<commit_message>
Resolve sponsor deck review findings
</commit_message>
<xml_diff>
--- a/paper/presentations/storage_embedded_ransomware_sponsor_brief.pptx
+++ b/paper/presentations/storage_embedded_ransomware_sponsor_brief.pptx
@@ -2,17 +2,17 @@
 <file path=ppt/presentation.xml><?xml version="1.0" encoding="utf-8"?>
 <p:presentation xmlns:p="http://schemas.openxmlformats.org/presentationml/2006/main">
   <p:sldMasterIdLst>
-    <p:sldMasterId xmlns:r="http://schemas.openxmlformats.org/officeDocument/2006/relationships" id="2147483648" r:id="Rc991896af4b64c27"/>
+    <p:sldMasterId xmlns:r="http://schemas.openxmlformats.org/officeDocument/2006/relationships" id="2147483648" r:id="R5cc96b96c26642f0"/>
   </p:sldMasterIdLst>
   <p:notesMasterIdLst>
-    <p:notesMasterId xmlns:r="http://schemas.openxmlformats.org/officeDocument/2006/relationships" r:id="R24debe337f8f40ae"/>
+    <p:notesMasterId xmlns:r="http://schemas.openxmlformats.org/officeDocument/2006/relationships" r:id="R3c4f3fe797934daf"/>
   </p:notesMasterIdLst>
   <p:sldIdLst>
-    <p:sldId xmlns:r="http://schemas.openxmlformats.org/officeDocument/2006/relationships" id="256" r:id="R5e42a85df4584026"/>
-    <p:sldId xmlns:r="http://schemas.openxmlformats.org/officeDocument/2006/relationships" id="257" r:id="R69a3def6125249fe"/>
-    <p:sldId xmlns:r="http://schemas.openxmlformats.org/officeDocument/2006/relationships" id="258" r:id="R0dc85a83df684185"/>
-    <p:sldId xmlns:r="http://schemas.openxmlformats.org/officeDocument/2006/relationships" id="259" r:id="R240eec863076448d"/>
-    <p:sldId xmlns:r="http://schemas.openxmlformats.org/officeDocument/2006/relationships" id="260" r:id="R8a3965f28c1c4c16"/>
+    <p:sldId xmlns:r="http://schemas.openxmlformats.org/officeDocument/2006/relationships" id="256" r:id="Rf2869630553e45f1"/>
+    <p:sldId xmlns:r="http://schemas.openxmlformats.org/officeDocument/2006/relationships" id="257" r:id="Rdd146b5f8c5c4e28"/>
+    <p:sldId xmlns:r="http://schemas.openxmlformats.org/officeDocument/2006/relationships" id="258" r:id="R29bd1c98d999413b"/>
+    <p:sldId xmlns:r="http://schemas.openxmlformats.org/officeDocument/2006/relationships" id="259" r:id="Ra25d3d61687c472e"/>
+    <p:sldId xmlns:r="http://schemas.openxmlformats.org/officeDocument/2006/relationships" id="260" r:id="R9ffd79c1140843ea"/>
   </p:sldIdLst>
   <p:sldSz cx="12192000" cy="6858000"/>
   <p:notesSz cx="6858000" cy="9144000"/>
@@ -823,7 +823,7 @@
   </p:cSld>
   <p:clrMap bg1="lt1" tx1="dk1" bg2="lt2" tx2="dk2" accent1="accent1" accent2="accent2" accent3="accent3" accent4="accent4" accent5="accent5" accent6="accent6" hlink="hlink" folHlink="folHlink"/>
   <p:sldLayoutIdLst>
-    <p:sldLayoutId xmlns:r="http://schemas.openxmlformats.org/officeDocument/2006/relationships" id="2147483649" r:id="R5a772447ec5043bf"/>
+    <p:sldLayoutId xmlns:r="http://schemas.openxmlformats.org/officeDocument/2006/relationships" id="2147483649" r:id="R19fcef3e8eaf4f1e"/>
   </p:sldLayoutIdLst>
   <p:txStyles>
     <p:titleStyle>
@@ -1122,7 +1122,7 @@
           <p:cNvPr id="1" name="">
             <a:extLst xmlns:a="http://schemas.openxmlformats.org/drawingml/2006/main">
               <a:ext uri="{FF2B5EF4-FFF2-40B4-BE49-F238E27FC236}">
-                <a16:creationId xmlns:a16="http://schemas.microsoft.com/office/drawing/2014/main" id="{CA6FFA25-8416-45DC-9D71-3CE72599AFF1}"/>
+                <a16:creationId xmlns:a16="http://schemas.microsoft.com/office/drawing/2014/main" id="{B5C75729-5D07-4696-8550-96189F4B9B03}"/>
               </a:ext>
             </a:extLst>
           </p:cNvPr>
@@ -1157,7 +1157,7 @@
           <p:cNvPr id="2" name="">
             <a:extLst xmlns:a="http://schemas.openxmlformats.org/drawingml/2006/main">
               <a:ext uri="{FF2B5EF4-FFF2-40B4-BE49-F238E27FC236}">
-                <a16:creationId xmlns:a16="http://schemas.microsoft.com/office/drawing/2014/main" id="{B187085A-BA83-43EA-A8FA-C271E65C5057}"/>
+                <a16:creationId xmlns:a16="http://schemas.microsoft.com/office/drawing/2014/main" id="{E0B00BF8-7286-45DB-B30A-2C7B3F728895}"/>
               </a:ext>
             </a:extLst>
           </p:cNvPr>
@@ -1192,7 +1192,7 @@
           <p:cNvPr id="3" name="kicker-marker">
             <a:extLst xmlns:a="http://schemas.openxmlformats.org/drawingml/2006/main">
               <a:ext uri="{FF2B5EF4-FFF2-40B4-BE49-F238E27FC236}">
-                <a16:creationId xmlns:a16="http://schemas.microsoft.com/office/drawing/2014/main" id="{D1AEF705-65F3-443E-83A1-2F6F43541C07}"/>
+                <a16:creationId xmlns:a16="http://schemas.microsoft.com/office/drawing/2014/main" id="{6B154921-C8CC-428D-B87A-7751B6150434}"/>
               </a:ext>
             </a:extLst>
           </p:cNvPr>
@@ -1227,7 +1227,7 @@
           <p:cNvPr id="4" name="kicker-label">
             <a:extLst xmlns:a="http://schemas.openxmlformats.org/drawingml/2006/main">
               <a:ext uri="{FF2B5EF4-FFF2-40B4-BE49-F238E27FC236}">
-                <a16:creationId xmlns:a16="http://schemas.microsoft.com/office/drawing/2014/main" id="{E1878492-09DB-48DD-A604-6F5D441AAC61}"/>
+                <a16:creationId xmlns:a16="http://schemas.microsoft.com/office/drawing/2014/main" id="{E48C4618-242A-4611-B039-EDE9021BBBAD}"/>
               </a:ext>
             </a:extLst>
           </p:cNvPr>
@@ -1291,7 +1291,7 @@
           <p:cNvPr id="5" name="">
             <a:extLst xmlns:a="http://schemas.openxmlformats.org/drawingml/2006/main">
               <a:ext uri="{FF2B5EF4-FFF2-40B4-BE49-F238E27FC236}">
-                <a16:creationId xmlns:a16="http://schemas.microsoft.com/office/drawing/2014/main" id="{F69830CB-E3E2-422C-BAB9-E5552393560A}"/>
+                <a16:creationId xmlns:a16="http://schemas.microsoft.com/office/drawing/2014/main" id="{7479CCFD-38CC-4B6D-99E2-5480CA31778B}"/>
               </a:ext>
             </a:extLst>
           </p:cNvPr>
@@ -1303,7 +1303,7 @@
         <p:spPr>
           <a:xfrm xmlns:a="http://schemas.openxmlformats.org/drawingml/2006/main">
             <a:off x="552450" y="876300"/>
-            <a:ext cx="6096000" cy="971550"/>
+            <a:ext cx="6191250" cy="971550"/>
           </a:xfrm>
           <a:prstGeom xmlns:a="http://schemas.openxmlformats.org/drawingml/2006/main" prst="rect">
             <a:avLst/>
@@ -1327,7 +1327,7 @@
           <a:lstStyle xmlns:a="http://schemas.openxmlformats.org/drawingml/2006/main"/>
           <a:p xmlns:a="http://schemas.openxmlformats.org/drawingml/2006/main">
             <a:pPr algn="l">
-              <a:defRPr sz="2850" b="1">
+              <a:defRPr sz="2700" b="1">
                 <a:solidFill>
                   <a:srgbClr val="111827"/>
                 </a:solidFill>
@@ -1337,7 +1337,7 @@
               </a:defRPr>
             </a:pPr>
             <a:r>
-              <a:rPr sz="2850" b="1">
+              <a:rPr sz="2700" b="1">
                 <a:solidFill>
                   <a:srgbClr val="111827"/>
                 </a:solidFill>
@@ -1345,7 +1345,7 @@
                 <a:ea typeface="Hiragino Mincho ProN"/>
                 <a:cs typeface="Hiragino Mincho ProN"/>
               </a:rPr>
-              <a:t>ホストが倒れても、ストレージには最後の信号が残る。</a:t>
+              <a:t>ホスト側が見えにくくなっても、ストレージには観測点が残る。</a:t>
             </a:r>
           </a:p>
         </p:txBody>
@@ -1355,7 +1355,7 @@
           <p:cNvPr id="6" name="">
             <a:extLst xmlns:a="http://schemas.openxmlformats.org/drawingml/2006/main">
               <a:ext uri="{FF2B5EF4-FFF2-40B4-BE49-F238E27FC236}">
-                <a16:creationId xmlns:a16="http://schemas.microsoft.com/office/drawing/2014/main" id="{825C160C-F43B-45DA-9694-2A7A4E212291}"/>
+                <a16:creationId xmlns:a16="http://schemas.microsoft.com/office/drawing/2014/main" id="{E10486BD-6280-480E-9235-C65806C5D030}"/>
               </a:ext>
             </a:extLst>
           </p:cNvPr>
@@ -1419,7 +1419,7 @@
           <p:cNvPr id="7" name="">
             <a:extLst xmlns:a="http://schemas.openxmlformats.org/drawingml/2006/main">
               <a:ext uri="{FF2B5EF4-FFF2-40B4-BE49-F238E27FC236}">
-                <a16:creationId xmlns:a16="http://schemas.microsoft.com/office/drawing/2014/main" id="{38EE7467-A9CE-49E6-AA23-A9289E1F6CB9}"/>
+                <a16:creationId xmlns:a16="http://schemas.microsoft.com/office/drawing/2014/main" id="{494CB6EB-0EB0-4A21-A634-0DE479A17000}"/>
               </a:ext>
             </a:extLst>
           </p:cNvPr>
@@ -1473,7 +1473,7 @@
                 <a:ea typeface="Hiragino Mincho ProN"/>
                 <a:cs typeface="Hiragino Mincho ProN"/>
               </a:rPr>
-              <a:t>この研究は、社会インフラ・医療・企業活動の停止を短くするために、ストレージ装置内で早く気づく方法を検証します。</a:t>
+              <a:t>この研究は、社会インフラ・医療・企業活動の停止を短くするために、ストレージ装置内で早く気づける条件を検証します。</a:t>
             </a:r>
           </a:p>
         </p:txBody>
@@ -1483,7 +1483,7 @@
           <p:cNvPr id="8" name="">
             <a:extLst xmlns:a="http://schemas.openxmlformats.org/drawingml/2006/main">
               <a:ext uri="{FF2B5EF4-FFF2-40B4-BE49-F238E27FC236}">
-                <a16:creationId xmlns:a16="http://schemas.microsoft.com/office/drawing/2014/main" id="{5FE32C65-43B3-4E51-BCD7-E0B47C18BFBC}"/>
+                <a16:creationId xmlns:a16="http://schemas.microsoft.com/office/drawing/2014/main" id="{F8E7BB21-87A3-41C3-92C3-FA609899D1C0}"/>
               </a:ext>
             </a:extLst>
           </p:cNvPr>
@@ -1516,7 +1516,7 @@
           <p:cNvPr id="9" name="">
             <a:extLst xmlns:a="http://schemas.openxmlformats.org/drawingml/2006/main">
               <a:ext uri="{FF2B5EF4-FFF2-40B4-BE49-F238E27FC236}">
-                <a16:creationId xmlns:a16="http://schemas.microsoft.com/office/drawing/2014/main" id="{3162BCA0-CAA7-46D8-83A8-CD3A4061FB90}"/>
+                <a16:creationId xmlns:a16="http://schemas.microsoft.com/office/drawing/2014/main" id="{3165B0F5-0AF5-4632-B2EE-E4D1462461C1}"/>
               </a:ext>
             </a:extLst>
           </p:cNvPr>
@@ -1570,7 +1570,7 @@
                 <a:ea typeface="Hiragino Sans"/>
                 <a:cs typeface="Hiragino Sans"/>
               </a:rPr>
-              <a:t>最後の防衛線としての観測点</a:t>
+              <a:t>最後に近い観測点の候補</a:t>
             </a:r>
           </a:p>
         </p:txBody>
@@ -1580,7 +1580,7 @@
           <p:cNvPr id="10" name="">
             <a:extLst xmlns:a="http://schemas.openxmlformats.org/drawingml/2006/main">
               <a:ext uri="{FF2B5EF4-FFF2-40B4-BE49-F238E27FC236}">
-                <a16:creationId xmlns:a16="http://schemas.microsoft.com/office/drawing/2014/main" id="{6F093D2C-0770-4AF2-B9FA-03FE27DBA0D2}"/>
+                <a16:creationId xmlns:a16="http://schemas.microsoft.com/office/drawing/2014/main" id="{D71E2AED-A593-4E0B-8D07-81E06B37C6E3}"/>
               </a:ext>
             </a:extLst>
           </p:cNvPr>
@@ -1613,7 +1613,7 @@
           <p:cNvPr id="11" name="">
             <a:extLst xmlns:a="http://schemas.openxmlformats.org/drawingml/2006/main">
               <a:ext uri="{FF2B5EF4-FFF2-40B4-BE49-F238E27FC236}">
-                <a16:creationId xmlns:a16="http://schemas.microsoft.com/office/drawing/2014/main" id="{6CA56E30-1E52-4B2A-83DB-9866CACED8A7}"/>
+                <a16:creationId xmlns:a16="http://schemas.microsoft.com/office/drawing/2014/main" id="{4425AF7F-8F64-450F-ACD5-A0A54406BC8F}"/>
               </a:ext>
             </a:extLst>
           </p:cNvPr>
@@ -1677,7 +1677,7 @@
           <p:cNvPr id="12" name="">
             <a:extLst xmlns:a="http://schemas.openxmlformats.org/drawingml/2006/main">
               <a:ext uri="{FF2B5EF4-FFF2-40B4-BE49-F238E27FC236}">
-                <a16:creationId xmlns:a16="http://schemas.microsoft.com/office/drawing/2014/main" id="{B6D1B6E2-293B-4EF5-AB2A-8492A9FB1645}"/>
+                <a16:creationId xmlns:a16="http://schemas.microsoft.com/office/drawing/2014/main" id="{2BE62EE0-4A56-4C6D-A562-9F5E03EF55B6}"/>
               </a:ext>
             </a:extLst>
           </p:cNvPr>
@@ -1741,7 +1741,7 @@
           <p:cNvPr id="13" name="">
             <a:extLst xmlns:a="http://schemas.openxmlformats.org/drawingml/2006/main">
               <a:ext uri="{FF2B5EF4-FFF2-40B4-BE49-F238E27FC236}">
-                <a16:creationId xmlns:a16="http://schemas.microsoft.com/office/drawing/2014/main" id="{6F71DEFF-8897-44A1-A051-12A4305FF046}"/>
+                <a16:creationId xmlns:a16="http://schemas.microsoft.com/office/drawing/2014/main" id="{9B20AD40-86D1-4A77-894D-1B4A16ECFBD9}"/>
               </a:ext>
             </a:extLst>
           </p:cNvPr>
@@ -1774,7 +1774,7 @@
           <p:cNvPr id="14" name="">
             <a:extLst xmlns:a="http://schemas.openxmlformats.org/drawingml/2006/main">
               <a:ext uri="{FF2B5EF4-FFF2-40B4-BE49-F238E27FC236}">
-                <a16:creationId xmlns:a16="http://schemas.microsoft.com/office/drawing/2014/main" id="{25A4D745-89F2-46C3-9F24-CF49692CB575}"/>
+                <a16:creationId xmlns:a16="http://schemas.microsoft.com/office/drawing/2014/main" id="{284AB901-6DC2-40C3-886A-8412C9322290}"/>
               </a:ext>
             </a:extLst>
           </p:cNvPr>
@@ -1838,7 +1838,7 @@
           <p:cNvPr id="15" name="">
             <a:extLst xmlns:a="http://schemas.openxmlformats.org/drawingml/2006/main">
               <a:ext uri="{FF2B5EF4-FFF2-40B4-BE49-F238E27FC236}">
-                <a16:creationId xmlns:a16="http://schemas.microsoft.com/office/drawing/2014/main" id="{904B2682-67B8-4B8F-B16D-EB4A1C64A0FC}"/>
+                <a16:creationId xmlns:a16="http://schemas.microsoft.com/office/drawing/2014/main" id="{CE3A0BF0-3155-4321-8BC0-58E30D7A3EFF}"/>
               </a:ext>
             </a:extLst>
           </p:cNvPr>
@@ -1902,7 +1902,7 @@
           <p:cNvPr id="16" name="">
             <a:extLst xmlns:a="http://schemas.openxmlformats.org/drawingml/2006/main">
               <a:ext uri="{FF2B5EF4-FFF2-40B4-BE49-F238E27FC236}">
-                <a16:creationId xmlns:a16="http://schemas.microsoft.com/office/drawing/2014/main" id="{D82EC4AE-A941-417A-865D-D07E28208E28}"/>
+                <a16:creationId xmlns:a16="http://schemas.microsoft.com/office/drawing/2014/main" id="{DE5C2EFD-C643-485C-8D7F-08C355405D1F}"/>
               </a:ext>
             </a:extLst>
           </p:cNvPr>
@@ -1966,7 +1966,7 @@
           <p:cNvPr id="17" name="">
             <a:extLst xmlns:a="http://schemas.openxmlformats.org/drawingml/2006/main">
               <a:ext uri="{FF2B5EF4-FFF2-40B4-BE49-F238E27FC236}">
-                <a16:creationId xmlns:a16="http://schemas.microsoft.com/office/drawing/2014/main" id="{73801507-0435-4A7D-A74A-46A61D0ED11A}"/>
+                <a16:creationId xmlns:a16="http://schemas.microsoft.com/office/drawing/2014/main" id="{78AD4FF6-4B04-4986-991C-0B7C76C18D18}"/>
               </a:ext>
             </a:extLst>
           </p:cNvPr>
@@ -2001,7 +2001,7 @@
           <p:cNvPr id="18" name="">
             <a:extLst xmlns:a="http://schemas.openxmlformats.org/drawingml/2006/main">
               <a:ext uri="{FF2B5EF4-FFF2-40B4-BE49-F238E27FC236}">
-                <a16:creationId xmlns:a16="http://schemas.microsoft.com/office/drawing/2014/main" id="{1B50CEEE-80BB-4C6D-B212-DE7B5D432A4D}"/>
+                <a16:creationId xmlns:a16="http://schemas.microsoft.com/office/drawing/2014/main" id="{A85AC688-1C66-4A75-B6B1-59DC6EE8B485}"/>
               </a:ext>
             </a:extLst>
           </p:cNvPr>
@@ -2055,7 +2055,7 @@
                 <a:ea typeface="Hiragino Sans"/>
                 <a:cs typeface="Hiragino Sans"/>
               </a:rPr>
-              <a:t>ストレージ装置内の小型検出器</a:t>
+              <a:t>ストレージ装置内の小型検出器候補</a:t>
             </a:r>
           </a:p>
         </p:txBody>
@@ -2065,7 +2065,7 @@
           <p:cNvPr id="19" name="">
             <a:extLst xmlns:a="http://schemas.openxmlformats.org/drawingml/2006/main">
               <a:ext uri="{FF2B5EF4-FFF2-40B4-BE49-F238E27FC236}">
-                <a16:creationId xmlns:a16="http://schemas.microsoft.com/office/drawing/2014/main" id="{821D63B9-3680-4BDE-AE7E-AB01CCA72C95}"/>
+                <a16:creationId xmlns:a16="http://schemas.microsoft.com/office/drawing/2014/main" id="{518E3F92-EC09-4646-AF19-903A4038AD37}"/>
               </a:ext>
             </a:extLst>
           </p:cNvPr>
@@ -2129,7 +2129,7 @@
           <p:cNvPr id="20" name="">
             <a:extLst xmlns:a="http://schemas.openxmlformats.org/drawingml/2006/main">
               <a:ext uri="{FF2B5EF4-FFF2-40B4-BE49-F238E27FC236}">
-                <a16:creationId xmlns:a16="http://schemas.microsoft.com/office/drawing/2014/main" id="{83165D41-53A6-484E-A52A-F34C2BDC2346}"/>
+                <a16:creationId xmlns:a16="http://schemas.microsoft.com/office/drawing/2014/main" id="{52B30B8D-4B17-4395-BA57-6EFFA0E85BB3}"/>
               </a:ext>
             </a:extLst>
           </p:cNvPr>
@@ -2164,7 +2164,7 @@
           <p:cNvPr id="21" name="">
             <a:extLst xmlns:a="http://schemas.openxmlformats.org/drawingml/2006/main">
               <a:ext uri="{FF2B5EF4-FFF2-40B4-BE49-F238E27FC236}">
-                <a16:creationId xmlns:a16="http://schemas.microsoft.com/office/drawing/2014/main" id="{23472650-3E32-4FD5-B5CE-F04CE69C41F4}"/>
+                <a16:creationId xmlns:a16="http://schemas.microsoft.com/office/drawing/2014/main" id="{D05E9827-918D-468F-BC5C-9F89E933D2D9}"/>
               </a:ext>
             </a:extLst>
           </p:cNvPr>
@@ -2228,7 +2228,7 @@
           <p:cNvPr id="22" name="">
             <a:extLst xmlns:a="http://schemas.openxmlformats.org/drawingml/2006/main">
               <a:ext uri="{FF2B5EF4-FFF2-40B4-BE49-F238E27FC236}">
-                <a16:creationId xmlns:a16="http://schemas.microsoft.com/office/drawing/2014/main" id="{83C250AB-9F78-465D-BF7F-40A27BC683D0}"/>
+                <a16:creationId xmlns:a16="http://schemas.microsoft.com/office/drawing/2014/main" id="{A3550F0D-7ADC-47C3-983B-1DF132078C06}"/>
               </a:ext>
             </a:extLst>
           </p:cNvPr>
@@ -2263,7 +2263,7 @@
           <p:cNvPr id="23" name="">
             <a:extLst xmlns:a="http://schemas.openxmlformats.org/drawingml/2006/main">
               <a:ext uri="{FF2B5EF4-FFF2-40B4-BE49-F238E27FC236}">
-                <a16:creationId xmlns:a16="http://schemas.microsoft.com/office/drawing/2014/main" id="{EF411E7C-E9C1-4F7E-A8E2-711F9922BA9E}"/>
+                <a16:creationId xmlns:a16="http://schemas.microsoft.com/office/drawing/2014/main" id="{748B7489-AD5C-4059-A417-784B98C2348D}"/>
               </a:ext>
             </a:extLst>
           </p:cNvPr>
@@ -2327,7 +2327,7 @@
           <p:cNvPr id="24" name="">
             <a:extLst xmlns:a="http://schemas.openxmlformats.org/drawingml/2006/main">
               <a:ext uri="{FF2B5EF4-FFF2-40B4-BE49-F238E27FC236}">
-                <a16:creationId xmlns:a16="http://schemas.microsoft.com/office/drawing/2014/main" id="{1F087AC1-4BCF-4CD4-8985-DB33A74A34B0}"/>
+                <a16:creationId xmlns:a16="http://schemas.microsoft.com/office/drawing/2014/main" id="{EC20B8D4-4B84-4210-A272-D2B338ADEC91}"/>
               </a:ext>
             </a:extLst>
           </p:cNvPr>
@@ -2391,7 +2391,7 @@
           <p:cNvPr id="25" name="">
             <a:extLst xmlns:a="http://schemas.openxmlformats.org/drawingml/2006/main">
               <a:ext uri="{FF2B5EF4-FFF2-40B4-BE49-F238E27FC236}">
-                <a16:creationId xmlns:a16="http://schemas.microsoft.com/office/drawing/2014/main" id="{86BE75CF-D9A4-44ED-9701-AAD070021EEE}"/>
+                <a16:creationId xmlns:a16="http://schemas.microsoft.com/office/drawing/2014/main" id="{E96CD149-A38E-4995-9B9A-0283EB63B5EF}"/>
               </a:ext>
             </a:extLst>
           </p:cNvPr>
@@ -2426,7 +2426,7 @@
           <p:cNvPr id="26" name="">
             <a:extLst xmlns:a="http://schemas.openxmlformats.org/drawingml/2006/main">
               <a:ext uri="{FF2B5EF4-FFF2-40B4-BE49-F238E27FC236}">
-                <a16:creationId xmlns:a16="http://schemas.microsoft.com/office/drawing/2014/main" id="{B0D97257-ADDE-472B-B2DB-33F53E64FBCF}"/>
+                <a16:creationId xmlns:a16="http://schemas.microsoft.com/office/drawing/2014/main" id="{764849D4-292A-4D9F-9515-84F6B3E703BB}"/>
               </a:ext>
             </a:extLst>
           </p:cNvPr>
@@ -2490,7 +2490,7 @@
           <p:cNvPr id="27" name="">
             <a:extLst xmlns:a="http://schemas.openxmlformats.org/drawingml/2006/main">
               <a:ext uri="{FF2B5EF4-FFF2-40B4-BE49-F238E27FC236}">
-                <a16:creationId xmlns:a16="http://schemas.microsoft.com/office/drawing/2014/main" id="{A50C0FB5-89A0-41DB-B541-05F2062066D0}"/>
+                <a16:creationId xmlns:a16="http://schemas.microsoft.com/office/drawing/2014/main" id="{B7886423-97A2-4480-94A7-9FDE4CBDD703}"/>
               </a:ext>
             </a:extLst>
           </p:cNvPr>
@@ -2554,7 +2554,7 @@
           <p:cNvPr id="28" name="">
             <a:extLst xmlns:a="http://schemas.openxmlformats.org/drawingml/2006/main">
               <a:ext uri="{FF2B5EF4-FFF2-40B4-BE49-F238E27FC236}">
-                <a16:creationId xmlns:a16="http://schemas.microsoft.com/office/drawing/2014/main" id="{B4F4E79F-BEB7-4B42-9002-A0B7740B7514}"/>
+                <a16:creationId xmlns:a16="http://schemas.microsoft.com/office/drawing/2014/main" id="{840A7AF9-FBC7-4A3A-9697-CD675AFCCB6C}"/>
               </a:ext>
             </a:extLst>
           </p:cNvPr>
@@ -2589,7 +2589,7 @@
           <p:cNvPr id="29" name="">
             <a:extLst xmlns:a="http://schemas.openxmlformats.org/drawingml/2006/main">
               <a:ext uri="{FF2B5EF4-FFF2-40B4-BE49-F238E27FC236}">
-                <a16:creationId xmlns:a16="http://schemas.microsoft.com/office/drawing/2014/main" id="{AF009239-CC34-4B33-92D9-88AC4C930F54}"/>
+                <a16:creationId xmlns:a16="http://schemas.microsoft.com/office/drawing/2014/main" id="{E03E846A-A121-49EC-91C8-151CA0F03059}"/>
               </a:ext>
             </a:extLst>
           </p:cNvPr>
@@ -2653,7 +2653,7 @@
           <p:cNvPr id="30" name="">
             <a:extLst xmlns:a="http://schemas.openxmlformats.org/drawingml/2006/main">
               <a:ext uri="{FF2B5EF4-FFF2-40B4-BE49-F238E27FC236}">
-                <a16:creationId xmlns:a16="http://schemas.microsoft.com/office/drawing/2014/main" id="{581EBBE7-8439-4440-AA01-E36C6ED084BE}"/>
+                <a16:creationId xmlns:a16="http://schemas.microsoft.com/office/drawing/2014/main" id="{5FF5D143-D1E6-4128-8B5F-4966223B4064}"/>
               </a:ext>
             </a:extLst>
           </p:cNvPr>
@@ -2717,7 +2717,7 @@
           <p:cNvPr id="31" name="">
             <a:extLst xmlns:a="http://schemas.openxmlformats.org/drawingml/2006/main">
               <a:ext uri="{FF2B5EF4-FFF2-40B4-BE49-F238E27FC236}">
-                <a16:creationId xmlns:a16="http://schemas.microsoft.com/office/drawing/2014/main" id="{AFA94789-FD44-4F4C-90DD-93D4FA5CE787}"/>
+                <a16:creationId xmlns:a16="http://schemas.microsoft.com/office/drawing/2014/main" id="{FB4BF818-18AE-488B-9BCB-DBD8871C7869}"/>
               </a:ext>
             </a:extLst>
           </p:cNvPr>
@@ -2752,7 +2752,7 @@
           <p:cNvPr id="32" name="">
             <a:extLst xmlns:a="http://schemas.openxmlformats.org/drawingml/2006/main">
               <a:ext uri="{FF2B5EF4-FFF2-40B4-BE49-F238E27FC236}">
-                <a16:creationId xmlns:a16="http://schemas.microsoft.com/office/drawing/2014/main" id="{1AB02952-01D2-4647-91EB-F4B005A94A15}"/>
+                <a16:creationId xmlns:a16="http://schemas.microsoft.com/office/drawing/2014/main" id="{53640365-8CBA-4EC0-AF37-26CEC9A12E91}"/>
               </a:ext>
             </a:extLst>
           </p:cNvPr>
@@ -2816,7 +2816,7 @@
           <p:cNvPr id="33" name="">
             <a:extLst xmlns:a="http://schemas.openxmlformats.org/drawingml/2006/main">
               <a:ext uri="{FF2B5EF4-FFF2-40B4-BE49-F238E27FC236}">
-                <a16:creationId xmlns:a16="http://schemas.microsoft.com/office/drawing/2014/main" id="{4E4CBE3C-2580-4F9B-B28D-E65FA59DE4FD}"/>
+                <a16:creationId xmlns:a16="http://schemas.microsoft.com/office/drawing/2014/main" id="{90392AF7-FA38-455E-8A23-CF0A6353444D}"/>
               </a:ext>
             </a:extLst>
           </p:cNvPr>
@@ -2878,7 +2878,7 @@
     </p:spTree>
     <p:extLst>
       <p:ext uri="{BB962C8B-B14F-4D97-AF65-F5344CB8AC3E}">
-        <p14:creationId xmlns:p14="http://schemas.microsoft.com/office/powerpoint/2010/main" val="1794293689"/>
+        <p14:creationId xmlns:p14="http://schemas.microsoft.com/office/powerpoint/2010/main" val="1772430670"/>
       </p:ext>
     </p:extLst>
   </p:cSld>
@@ -2902,7 +2902,7 @@
           <p:cNvPr id="1" name="">
             <a:extLst xmlns:a="http://schemas.openxmlformats.org/drawingml/2006/main">
               <a:ext uri="{FF2B5EF4-FFF2-40B4-BE49-F238E27FC236}">
-                <a16:creationId xmlns:a16="http://schemas.microsoft.com/office/drawing/2014/main" id="{97C29B16-8046-48A0-BFF6-F5E5E005C0BA}"/>
+                <a16:creationId xmlns:a16="http://schemas.microsoft.com/office/drawing/2014/main" id="{F50E9661-917B-4B43-995E-439D7AD75733}"/>
               </a:ext>
             </a:extLst>
           </p:cNvPr>
@@ -2937,7 +2937,7 @@
           <p:cNvPr id="2" name="">
             <a:extLst xmlns:a="http://schemas.openxmlformats.org/drawingml/2006/main">
               <a:ext uri="{FF2B5EF4-FFF2-40B4-BE49-F238E27FC236}">
-                <a16:creationId xmlns:a16="http://schemas.microsoft.com/office/drawing/2014/main" id="{D0EDF626-4BB6-4E4B-A16A-B7D6FA4D3D98}"/>
+                <a16:creationId xmlns:a16="http://schemas.microsoft.com/office/drawing/2014/main" id="{B8851B89-B9B6-4D2A-ACF0-B89F1CCEA9C3}"/>
               </a:ext>
             </a:extLst>
           </p:cNvPr>
@@ -2972,7 +2972,7 @@
           <p:cNvPr id="3" name="kicker-marker">
             <a:extLst xmlns:a="http://schemas.openxmlformats.org/drawingml/2006/main">
               <a:ext uri="{FF2B5EF4-FFF2-40B4-BE49-F238E27FC236}">
-                <a16:creationId xmlns:a16="http://schemas.microsoft.com/office/drawing/2014/main" id="{2B248E8D-AAA1-41FD-BBB2-7A8A2F9A1C55}"/>
+                <a16:creationId xmlns:a16="http://schemas.microsoft.com/office/drawing/2014/main" id="{ACDC87FB-0E0E-4068-9DCE-3ADD71B31E23}"/>
               </a:ext>
             </a:extLst>
           </p:cNvPr>
@@ -3007,7 +3007,7 @@
           <p:cNvPr id="4" name="kicker-label">
             <a:extLst xmlns:a="http://schemas.openxmlformats.org/drawingml/2006/main">
               <a:ext uri="{FF2B5EF4-FFF2-40B4-BE49-F238E27FC236}">
-                <a16:creationId xmlns:a16="http://schemas.microsoft.com/office/drawing/2014/main" id="{E153D5DF-A94E-4833-810E-C06EC6E0F5BF}"/>
+                <a16:creationId xmlns:a16="http://schemas.microsoft.com/office/drawing/2014/main" id="{F77D70EC-7E39-4304-8796-5837488C4214}"/>
               </a:ext>
             </a:extLst>
           </p:cNvPr>
@@ -3071,7 +3071,7 @@
           <p:cNvPr id="5" name="">
             <a:extLst xmlns:a="http://schemas.openxmlformats.org/drawingml/2006/main">
               <a:ext uri="{FF2B5EF4-FFF2-40B4-BE49-F238E27FC236}">
-                <a16:creationId xmlns:a16="http://schemas.microsoft.com/office/drawing/2014/main" id="{381D2B1F-B06A-4A6C-AD08-DC0B5AA7AAC5}"/>
+                <a16:creationId xmlns:a16="http://schemas.microsoft.com/office/drawing/2014/main" id="{8521DC6C-F412-43FF-A432-0F6AF2BFF795}"/>
               </a:ext>
             </a:extLst>
           </p:cNvPr>
@@ -3135,7 +3135,7 @@
           <p:cNvPr id="6" name="">
             <a:extLst xmlns:a="http://schemas.openxmlformats.org/drawingml/2006/main">
               <a:ext uri="{FF2B5EF4-FFF2-40B4-BE49-F238E27FC236}">
-                <a16:creationId xmlns:a16="http://schemas.microsoft.com/office/drawing/2014/main" id="{41AA8F43-31C8-4462-BF1E-BEA9AFA011E3}"/>
+                <a16:creationId xmlns:a16="http://schemas.microsoft.com/office/drawing/2014/main" id="{67DBC1BE-7E5B-4F5C-AF50-6DFE1DEF19A5}"/>
               </a:ext>
             </a:extLst>
           </p:cNvPr>
@@ -3199,7 +3199,7 @@
           <p:cNvPr id="7" name="">
             <a:extLst xmlns:a="http://schemas.openxmlformats.org/drawingml/2006/main">
               <a:ext uri="{FF2B5EF4-FFF2-40B4-BE49-F238E27FC236}">
-                <a16:creationId xmlns:a16="http://schemas.microsoft.com/office/drawing/2014/main" id="{529C741A-26A9-41B9-B4BE-8340BC25B6A0}"/>
+                <a16:creationId xmlns:a16="http://schemas.microsoft.com/office/drawing/2014/main" id="{DC6DE9A3-3157-43E5-9539-E627D8CFF623}"/>
               </a:ext>
             </a:extLst>
           </p:cNvPr>
@@ -3232,7 +3232,7 @@
           <p:cNvPr id="8" name="">
             <a:extLst xmlns:a="http://schemas.openxmlformats.org/drawingml/2006/main">
               <a:ext uri="{FF2B5EF4-FFF2-40B4-BE49-F238E27FC236}">
-                <a16:creationId xmlns:a16="http://schemas.microsoft.com/office/drawing/2014/main" id="{413416E0-0F37-4B64-B074-9ED24750E08B}"/>
+                <a16:creationId xmlns:a16="http://schemas.microsoft.com/office/drawing/2014/main" id="{746D577D-D4CF-48AA-B9CC-816375C8760E}"/>
               </a:ext>
             </a:extLst>
           </p:cNvPr>
@@ -3296,7 +3296,7 @@
           <p:cNvPr id="9" name="">
             <a:extLst xmlns:a="http://schemas.openxmlformats.org/drawingml/2006/main">
               <a:ext uri="{FF2B5EF4-FFF2-40B4-BE49-F238E27FC236}">
-                <a16:creationId xmlns:a16="http://schemas.microsoft.com/office/drawing/2014/main" id="{A3EAA9C5-C0DF-4068-8709-05AFD7F69537}"/>
+                <a16:creationId xmlns:a16="http://schemas.microsoft.com/office/drawing/2014/main" id="{A7EC07F0-E697-4844-B9AE-749BC4F06475}"/>
               </a:ext>
             </a:extLst>
           </p:cNvPr>
@@ -3360,7 +3360,7 @@
           <p:cNvPr id="10" name="">
             <a:extLst xmlns:a="http://schemas.openxmlformats.org/drawingml/2006/main">
               <a:ext uri="{FF2B5EF4-FFF2-40B4-BE49-F238E27FC236}">
-                <a16:creationId xmlns:a16="http://schemas.microsoft.com/office/drawing/2014/main" id="{4994FE1E-A3F5-4D34-A77A-E91FDAF477CB}"/>
+                <a16:creationId xmlns:a16="http://schemas.microsoft.com/office/drawing/2014/main" id="{563DB2AF-91F3-448E-A5DD-544E1435B893}"/>
               </a:ext>
             </a:extLst>
           </p:cNvPr>
@@ -3395,7 +3395,7 @@
           <p:cNvPr id="11" name="">
             <a:extLst xmlns:a="http://schemas.openxmlformats.org/drawingml/2006/main">
               <a:ext uri="{FF2B5EF4-FFF2-40B4-BE49-F238E27FC236}">
-                <a16:creationId xmlns:a16="http://schemas.microsoft.com/office/drawing/2014/main" id="{5CE3636E-327B-49C5-B62C-3F8DC193216E}"/>
+                <a16:creationId xmlns:a16="http://schemas.microsoft.com/office/drawing/2014/main" id="{0EA25F7F-7545-4E30-8E7B-318F8022FFAE}"/>
               </a:ext>
             </a:extLst>
           </p:cNvPr>
@@ -3459,7 +3459,7 @@
           <p:cNvPr id="12" name="">
             <a:extLst xmlns:a="http://schemas.openxmlformats.org/drawingml/2006/main">
               <a:ext uri="{FF2B5EF4-FFF2-40B4-BE49-F238E27FC236}">
-                <a16:creationId xmlns:a16="http://schemas.microsoft.com/office/drawing/2014/main" id="{F0BC45F8-24A0-45DA-AB8C-47C209EA81FE}"/>
+                <a16:creationId xmlns:a16="http://schemas.microsoft.com/office/drawing/2014/main" id="{A08ED46A-A003-4178-8F4E-A4487389153E}"/>
               </a:ext>
             </a:extLst>
           </p:cNvPr>
@@ -3492,7 +3492,7 @@
           <p:cNvPr id="13" name="">
             <a:extLst xmlns:a="http://schemas.openxmlformats.org/drawingml/2006/main">
               <a:ext uri="{FF2B5EF4-FFF2-40B4-BE49-F238E27FC236}">
-                <a16:creationId xmlns:a16="http://schemas.microsoft.com/office/drawing/2014/main" id="{E86AADF8-70A2-4B96-A9FF-C54DAE72BA08}"/>
+                <a16:creationId xmlns:a16="http://schemas.microsoft.com/office/drawing/2014/main" id="{54FA07B9-93FD-4A6A-B157-9BF96579C7EB}"/>
               </a:ext>
             </a:extLst>
           </p:cNvPr>
@@ -3546,7 +3546,7 @@
                 <a:ea typeface="Hiragino Sans"/>
                 <a:cs typeface="Hiragino Sans"/>
               </a:rPr>
-              <a:t>10秒フレーム</a:t>
+              <a:t>1枚の10秒フレーム</a:t>
             </a:r>
           </a:p>
         </p:txBody>
@@ -3556,7 +3556,7 @@
           <p:cNvPr id="14" name="">
             <a:extLst xmlns:a="http://schemas.openxmlformats.org/drawingml/2006/main">
               <a:ext uri="{FF2B5EF4-FFF2-40B4-BE49-F238E27FC236}">
-                <a16:creationId xmlns:a16="http://schemas.microsoft.com/office/drawing/2014/main" id="{6C364B06-C92B-46E3-8D28-151A3C9B7B09}"/>
+                <a16:creationId xmlns:a16="http://schemas.microsoft.com/office/drawing/2014/main" id="{668F836C-1F12-49E0-9FD1-89BF3A5865CA}"/>
               </a:ext>
             </a:extLst>
           </p:cNvPr>
@@ -3592,7 +3592,7 @@
           <a:lstStyle xmlns:a="http://schemas.openxmlformats.org/drawingml/2006/main"/>
           <a:p xmlns:a="http://schemas.openxmlformats.org/drawingml/2006/main">
             <a:pPr algn="l">
-              <a:defRPr sz="863" b="0">
+              <a:defRPr sz="900" b="0">
                 <a:solidFill>
                   <a:srgbClr val="64748B"/>
                 </a:solidFill>
@@ -3602,7 +3602,7 @@
               </a:defRPr>
             </a:pPr>
             <a:r>
-              <a:rPr sz="863" b="0">
+              <a:rPr sz="900" b="0">
                 <a:solidFill>
                   <a:srgbClr val="64748B"/>
                 </a:solidFill>
@@ -3610,7 +3610,7 @@
                 <a:ea typeface="Hiragino Sans"/>
                 <a:cs typeface="Hiragino Sans"/>
               </a:rPr>
-              <a:t>count・bytes・write ratio・平均LBA・平均長</a:t>
+              <a:t>最大12個の統計欄。使えない欄は空扱い</a:t>
             </a:r>
           </a:p>
         </p:txBody>
@@ -3620,7 +3620,7 @@
           <p:cNvPr id="15" name="">
             <a:extLst xmlns:a="http://schemas.openxmlformats.org/drawingml/2006/main">
               <a:ext uri="{FF2B5EF4-FFF2-40B4-BE49-F238E27FC236}">
-                <a16:creationId xmlns:a16="http://schemas.microsoft.com/office/drawing/2014/main" id="{98DD8563-BA52-4A49-91F7-11AC8A9B243F}"/>
+                <a16:creationId xmlns:a16="http://schemas.microsoft.com/office/drawing/2014/main" id="{BAEBC248-63EC-4097-895D-07378B850EB5}"/>
               </a:ext>
             </a:extLst>
           </p:cNvPr>
@@ -3655,7 +3655,7 @@
           <p:cNvPr id="16" name="">
             <a:extLst xmlns:a="http://schemas.openxmlformats.org/drawingml/2006/main">
               <a:ext uri="{FF2B5EF4-FFF2-40B4-BE49-F238E27FC236}">
-                <a16:creationId xmlns:a16="http://schemas.microsoft.com/office/drawing/2014/main" id="{DE2646AB-A336-473E-82DE-A32ABC98C092}"/>
+                <a16:creationId xmlns:a16="http://schemas.microsoft.com/office/drawing/2014/main" id="{69344AE5-7B50-41F9-BC96-3011563D8E51}"/>
               </a:ext>
             </a:extLst>
           </p:cNvPr>
@@ -3719,7 +3719,7 @@
           <p:cNvPr id="17" name="">
             <a:extLst xmlns:a="http://schemas.openxmlformats.org/drawingml/2006/main">
               <a:ext uri="{FF2B5EF4-FFF2-40B4-BE49-F238E27FC236}">
-                <a16:creationId xmlns:a16="http://schemas.microsoft.com/office/drawing/2014/main" id="{5316764C-079E-4D80-A017-8202C0BC8DDD}"/>
+                <a16:creationId xmlns:a16="http://schemas.microsoft.com/office/drawing/2014/main" id="{078559B0-4DF5-4DCF-92AD-0639698C62D1}"/>
               </a:ext>
             </a:extLst>
           </p:cNvPr>
@@ -3752,7 +3752,7 @@
           <p:cNvPr id="18" name="">
             <a:extLst xmlns:a="http://schemas.openxmlformats.org/drawingml/2006/main">
               <a:ext uri="{FF2B5EF4-FFF2-40B4-BE49-F238E27FC236}">
-                <a16:creationId xmlns:a16="http://schemas.microsoft.com/office/drawing/2014/main" id="{1831EC29-B995-4A3C-A0C0-40681105812C}"/>
+                <a16:creationId xmlns:a16="http://schemas.microsoft.com/office/drawing/2014/main" id="{71CFD99D-0F4F-4A37-A748-17327D34A054}"/>
               </a:ext>
             </a:extLst>
           </p:cNvPr>
@@ -3806,7 +3806,7 @@
                 <a:ea typeface="Hiragino Sans"/>
                 <a:cs typeface="Hiragino Sans"/>
               </a:rPr>
-              <a:t>N個を束ねる</a:t>
+              <a:t>時間文脈を作る</a:t>
             </a:r>
           </a:p>
         </p:txBody>
@@ -3816,7 +3816,7 @@
           <p:cNvPr id="19" name="">
             <a:extLst xmlns:a="http://schemas.openxmlformats.org/drawingml/2006/main">
               <a:ext uri="{FF2B5EF4-FFF2-40B4-BE49-F238E27FC236}">
-                <a16:creationId xmlns:a16="http://schemas.microsoft.com/office/drawing/2014/main" id="{BE2399E3-A154-4BA1-8ACD-747486343467}"/>
+                <a16:creationId xmlns:a16="http://schemas.microsoft.com/office/drawing/2014/main" id="{A9984CBB-BEEA-49F3-AEB7-3230009AFBE4}"/>
               </a:ext>
             </a:extLst>
           </p:cNvPr>
@@ -3852,7 +3852,7 @@
           <a:lstStyle xmlns:a="http://schemas.openxmlformats.org/drawingml/2006/main"/>
           <a:p xmlns:a="http://schemas.openxmlformats.org/drawingml/2006/main">
             <a:pPr algn="l">
-              <a:defRPr sz="863" b="0">
+              <a:defRPr sz="900" b="0">
                 <a:solidFill>
                   <a:srgbClr val="64748B"/>
                 </a:solidFill>
@@ -3862,7 +3862,7 @@
               </a:defRPr>
             </a:pPr>
             <a:r>
-              <a:rPr sz="863" b="0">
+              <a:rPr sz="900" b="0">
                 <a:solidFill>
                   <a:srgbClr val="64748B"/>
                 </a:solidFill>
@@ -3870,7 +3870,7 @@
                 <a:ea typeface="Hiragino Sans"/>
                 <a:cs typeface="Hiragino Sans"/>
               </a:rPr>
-              <a:t>N x 10秒の文脈。初期候補は N=12</a:t>
+              <a:t>初期候補は12フレーム、つまり約2分</a:t>
             </a:r>
           </a:p>
         </p:txBody>
@@ -3880,7 +3880,7 @@
           <p:cNvPr id="20" name="">
             <a:extLst xmlns:a="http://schemas.openxmlformats.org/drawingml/2006/main">
               <a:ext uri="{FF2B5EF4-FFF2-40B4-BE49-F238E27FC236}">
-                <a16:creationId xmlns:a16="http://schemas.microsoft.com/office/drawing/2014/main" id="{74E51E24-BD71-41B4-BD92-910525EE3572}"/>
+                <a16:creationId xmlns:a16="http://schemas.microsoft.com/office/drawing/2014/main" id="{B0E86921-783A-4F7C-B2DB-FE3007D4F318}"/>
               </a:ext>
             </a:extLst>
           </p:cNvPr>
@@ -3915,7 +3915,7 @@
           <p:cNvPr id="21" name="">
             <a:extLst xmlns:a="http://schemas.openxmlformats.org/drawingml/2006/main">
               <a:ext uri="{FF2B5EF4-FFF2-40B4-BE49-F238E27FC236}">
-                <a16:creationId xmlns:a16="http://schemas.microsoft.com/office/drawing/2014/main" id="{E1935709-4568-4ABF-8914-FBB2E4E40CD2}"/>
+                <a16:creationId xmlns:a16="http://schemas.microsoft.com/office/drawing/2014/main" id="{CB1C0D36-1EB0-4BC5-B501-11BCC6972062}"/>
               </a:ext>
             </a:extLst>
           </p:cNvPr>
@@ -3979,7 +3979,7 @@
           <p:cNvPr id="22" name="">
             <a:extLst xmlns:a="http://schemas.openxmlformats.org/drawingml/2006/main">
               <a:ext uri="{FF2B5EF4-FFF2-40B4-BE49-F238E27FC236}">
-                <a16:creationId xmlns:a16="http://schemas.microsoft.com/office/drawing/2014/main" id="{E542EC82-A1B6-4F74-830E-23F6A3432271}"/>
+                <a16:creationId xmlns:a16="http://schemas.microsoft.com/office/drawing/2014/main" id="{09885712-ED24-4543-BE90-3BF4833B227A}"/>
               </a:ext>
             </a:extLst>
           </p:cNvPr>
@@ -4012,7 +4012,7 @@
           <p:cNvPr id="23" name="">
             <a:extLst xmlns:a="http://schemas.openxmlformats.org/drawingml/2006/main">
               <a:ext uri="{FF2B5EF4-FFF2-40B4-BE49-F238E27FC236}">
-                <a16:creationId xmlns:a16="http://schemas.microsoft.com/office/drawing/2014/main" id="{8AEA7336-658C-4CAA-B3B9-96C9535B3069}"/>
+                <a16:creationId xmlns:a16="http://schemas.microsoft.com/office/drawing/2014/main" id="{86BD5113-FED6-4878-88E1-AE2D38696819}"/>
               </a:ext>
             </a:extLst>
           </p:cNvPr>
@@ -4066,7 +4066,7 @@
                 <a:ea typeface="Hiragino Sans"/>
                 <a:cs typeface="Hiragino Sans"/>
               </a:rPr>
-              <a:t>固定D=12入力</a:t>
+              <a:t>固定入力にする</a:t>
             </a:r>
           </a:p>
         </p:txBody>
@@ -4076,7 +4076,7 @@
           <p:cNvPr id="24" name="">
             <a:extLst xmlns:a="http://schemas.openxmlformats.org/drawingml/2006/main">
               <a:ext uri="{FF2B5EF4-FFF2-40B4-BE49-F238E27FC236}">
-                <a16:creationId xmlns:a16="http://schemas.microsoft.com/office/drawing/2014/main" id="{B5FA075B-796C-425F-AE2D-92AA08CFB689}"/>
+                <a16:creationId xmlns:a16="http://schemas.microsoft.com/office/drawing/2014/main" id="{883BF007-AC5B-4D57-9201-6BDFA395FA70}"/>
               </a:ext>
             </a:extLst>
           </p:cNvPr>
@@ -4112,7 +4112,7 @@
           <a:lstStyle xmlns:a="http://schemas.openxmlformats.org/drawingml/2006/main"/>
           <a:p xmlns:a="http://schemas.openxmlformats.org/drawingml/2006/main">
             <a:pPr algn="l">
-              <a:defRPr sz="863" b="0">
+              <a:defRPr sz="900" b="0">
                 <a:solidFill>
                   <a:srgbClr val="64748B"/>
                 </a:solidFill>
@@ -4122,7 +4122,7 @@
               </a:defRPr>
             </a:pPr>
             <a:r>
-              <a:rPr sz="863" b="0">
+              <a:rPr sz="900" b="0">
                 <a:solidFill>
                   <a:srgbClr val="64748B"/>
                 </a:solidFill>
@@ -4130,7 +4130,7 @@
                 <a:ea typeface="Hiragino Sans"/>
                 <a:cs typeface="Hiragino Sans"/>
               </a:rPr>
-              <a:t>optional slot と padding は mask で扱う</a:t>
+              <a:t>統計欄と時間幅をそろえ、maskで除外</a:t>
             </a:r>
           </a:p>
         </p:txBody>
@@ -4140,7 +4140,7 @@
           <p:cNvPr id="25" name="">
             <a:extLst xmlns:a="http://schemas.openxmlformats.org/drawingml/2006/main">
               <a:ext uri="{FF2B5EF4-FFF2-40B4-BE49-F238E27FC236}">
-                <a16:creationId xmlns:a16="http://schemas.microsoft.com/office/drawing/2014/main" id="{61C60140-FD85-4C7A-9549-F665F105B208}"/>
+                <a16:creationId xmlns:a16="http://schemas.microsoft.com/office/drawing/2014/main" id="{3A60A606-7B3F-4308-B081-DCD520A72535}"/>
               </a:ext>
             </a:extLst>
           </p:cNvPr>
@@ -4175,7 +4175,7 @@
           <p:cNvPr id="26" name="">
             <a:extLst xmlns:a="http://schemas.openxmlformats.org/drawingml/2006/main">
               <a:ext uri="{FF2B5EF4-FFF2-40B4-BE49-F238E27FC236}">
-                <a16:creationId xmlns:a16="http://schemas.microsoft.com/office/drawing/2014/main" id="{3C6C8A7A-E2EA-41C9-8054-23C957FEF384}"/>
+                <a16:creationId xmlns:a16="http://schemas.microsoft.com/office/drawing/2014/main" id="{056946BB-2BF5-4465-9982-A94BCA007EC9}"/>
               </a:ext>
             </a:extLst>
           </p:cNvPr>
@@ -4239,7 +4239,7 @@
           <p:cNvPr id="27" name="">
             <a:extLst xmlns:a="http://schemas.openxmlformats.org/drawingml/2006/main">
               <a:ext uri="{FF2B5EF4-FFF2-40B4-BE49-F238E27FC236}">
-                <a16:creationId xmlns:a16="http://schemas.microsoft.com/office/drawing/2014/main" id="{1FACD49E-4FD9-4553-A0A8-FDD70124DBF8}"/>
+                <a16:creationId xmlns:a16="http://schemas.microsoft.com/office/drawing/2014/main" id="{711F5735-40A5-48CA-ABA9-316B0CFB1536}"/>
               </a:ext>
             </a:extLst>
           </p:cNvPr>
@@ -4272,7 +4272,7 @@
           <p:cNvPr id="28" name="">
             <a:extLst xmlns:a="http://schemas.openxmlformats.org/drawingml/2006/main">
               <a:ext uri="{FF2B5EF4-FFF2-40B4-BE49-F238E27FC236}">
-                <a16:creationId xmlns:a16="http://schemas.microsoft.com/office/drawing/2014/main" id="{AB5961E6-E898-49F3-8A2F-6E2ACBAEF14A}"/>
+                <a16:creationId xmlns:a16="http://schemas.microsoft.com/office/drawing/2014/main" id="{3442F278-201C-4447-AB97-4465562AD242}"/>
               </a:ext>
             </a:extLst>
           </p:cNvPr>
@@ -4336,7 +4336,7 @@
           <p:cNvPr id="29" name="">
             <a:extLst xmlns:a="http://schemas.openxmlformats.org/drawingml/2006/main">
               <a:ext uri="{FF2B5EF4-FFF2-40B4-BE49-F238E27FC236}">
-                <a16:creationId xmlns:a16="http://schemas.microsoft.com/office/drawing/2014/main" id="{5AC5F686-49D5-42CE-909C-DF5A8322B707}"/>
+                <a16:creationId xmlns:a16="http://schemas.microsoft.com/office/drawing/2014/main" id="{C3DB614A-A343-4356-89B1-BD3C532BBAA6}"/>
               </a:ext>
             </a:extLst>
           </p:cNvPr>
@@ -4369,7 +4369,7 @@
           <p:cNvPr id="30" name="">
             <a:extLst xmlns:a="http://schemas.openxmlformats.org/drawingml/2006/main">
               <a:ext uri="{FF2B5EF4-FFF2-40B4-BE49-F238E27FC236}">
-                <a16:creationId xmlns:a16="http://schemas.microsoft.com/office/drawing/2014/main" id="{814B700D-266A-426D-8C3E-7D200DFA392E}"/>
+                <a16:creationId xmlns:a16="http://schemas.microsoft.com/office/drawing/2014/main" id="{C5E79522-1D13-496D-8BD7-BE012288D0B2}"/>
               </a:ext>
             </a:extLst>
           </p:cNvPr>
@@ -4433,7 +4433,7 @@
           <p:cNvPr id="31" name="">
             <a:extLst xmlns:a="http://schemas.openxmlformats.org/drawingml/2006/main">
               <a:ext uri="{FF2B5EF4-FFF2-40B4-BE49-F238E27FC236}">
-                <a16:creationId xmlns:a16="http://schemas.microsoft.com/office/drawing/2014/main" id="{A8737FC4-26D0-4236-9C92-695392C55F89}"/>
+                <a16:creationId xmlns:a16="http://schemas.microsoft.com/office/drawing/2014/main" id="{57970CD9-3D2C-463A-AE48-1864CB9F899F}"/>
               </a:ext>
             </a:extLst>
           </p:cNvPr>
@@ -4466,7 +4466,7 @@
           <p:cNvPr id="32" name="">
             <a:extLst xmlns:a="http://schemas.openxmlformats.org/drawingml/2006/main">
               <a:ext uri="{FF2B5EF4-FFF2-40B4-BE49-F238E27FC236}">
-                <a16:creationId xmlns:a16="http://schemas.microsoft.com/office/drawing/2014/main" id="{154D6E5B-376C-4581-881A-8B1F9C5117A3}"/>
+                <a16:creationId xmlns:a16="http://schemas.microsoft.com/office/drawing/2014/main" id="{953DD1B4-2308-4DA1-BE96-3A16E6E4AD9A}"/>
               </a:ext>
             </a:extLst>
           </p:cNvPr>
@@ -4530,7 +4530,7 @@
           <p:cNvPr id="33" name="">
             <a:extLst xmlns:a="http://schemas.openxmlformats.org/drawingml/2006/main">
               <a:ext uri="{FF2B5EF4-FFF2-40B4-BE49-F238E27FC236}">
-                <a16:creationId xmlns:a16="http://schemas.microsoft.com/office/drawing/2014/main" id="{D7BF2113-7DB0-4FAB-85D1-99074A5ADBE7}"/>
+                <a16:creationId xmlns:a16="http://schemas.microsoft.com/office/drawing/2014/main" id="{8B866D98-FE70-4140-8F43-0355C7391B20}"/>
               </a:ext>
             </a:extLst>
           </p:cNvPr>
@@ -4563,7 +4563,7 @@
           <p:cNvPr id="34" name="">
             <a:extLst xmlns:a="http://schemas.openxmlformats.org/drawingml/2006/main">
               <a:ext uri="{FF2B5EF4-FFF2-40B4-BE49-F238E27FC236}">
-                <a16:creationId xmlns:a16="http://schemas.microsoft.com/office/drawing/2014/main" id="{20A44AF9-9843-4DFE-98C8-A172AD1746F1}"/>
+                <a16:creationId xmlns:a16="http://schemas.microsoft.com/office/drawing/2014/main" id="{E1B86EA3-9CA5-4FB0-B37D-5D527E0A444F}"/>
               </a:ext>
             </a:extLst>
           </p:cNvPr>
@@ -4627,19 +4627,19 @@
           <p:cNvPr id="35" name="">
             <a:extLst xmlns:a="http://schemas.openxmlformats.org/drawingml/2006/main">
               <a:ext uri="{FF2B5EF4-FFF2-40B4-BE49-F238E27FC236}">
-                <a16:creationId xmlns:a16="http://schemas.microsoft.com/office/drawing/2014/main" id="{28C2A1A0-FCBC-479A-BF4D-91DF7B8654F0}"/>
-              </a:ext>
-            </a:extLst>
-          </p:cNvPr>
-          <p:cNvSpPr>
-            <a:spLocks xmlns:a="http://schemas.openxmlformats.org/drawingml/2006/main" noGrp="1"/>
-          </p:cNvSpPr>
-          <p:nvPr/>
-        </p:nvSpPr>
-        <p:spPr>
-          <a:xfrm xmlns:a="http://schemas.openxmlformats.org/drawingml/2006/main">
-            <a:off x="8096250" y="4514850"/>
-            <a:ext cx="1066800" cy="257175"/>
+                <a16:creationId xmlns:a16="http://schemas.microsoft.com/office/drawing/2014/main" id="{10C19B12-3C5B-47A1-9E9A-9471B3A6721E}"/>
+              </a:ext>
+            </a:extLst>
+          </p:cNvPr>
+          <p:cNvSpPr>
+            <a:spLocks xmlns:a="http://schemas.openxmlformats.org/drawingml/2006/main" noGrp="1"/>
+          </p:cNvSpPr>
+          <p:nvPr/>
+        </p:nvSpPr>
+        <p:spPr>
+          <a:xfrm xmlns:a="http://schemas.openxmlformats.org/drawingml/2006/main">
+            <a:off x="7905750" y="4514850"/>
+            <a:ext cx="1447800" cy="257175"/>
           </a:xfrm>
           <a:prstGeom xmlns:a="http://schemas.openxmlformats.org/drawingml/2006/main" prst="rect">
             <a:avLst/>
@@ -4660,19 +4660,19 @@
           <p:cNvPr id="36" name="">
             <a:extLst xmlns:a="http://schemas.openxmlformats.org/drawingml/2006/main">
               <a:ext uri="{FF2B5EF4-FFF2-40B4-BE49-F238E27FC236}">
-                <a16:creationId xmlns:a16="http://schemas.microsoft.com/office/drawing/2014/main" id="{C586E605-39AC-47C9-8656-557B85975E17}"/>
-              </a:ext>
-            </a:extLst>
-          </p:cNvPr>
-          <p:cNvSpPr>
-            <a:spLocks xmlns:a="http://schemas.openxmlformats.org/drawingml/2006/main" noGrp="1"/>
-          </p:cNvSpPr>
-          <p:nvPr/>
-        </p:nvSpPr>
-        <p:spPr>
-          <a:xfrm xmlns:a="http://schemas.openxmlformats.org/drawingml/2006/main">
-            <a:off x="8172450" y="4533900"/>
-            <a:ext cx="914400" cy="200025"/>
+                <a16:creationId xmlns:a16="http://schemas.microsoft.com/office/drawing/2014/main" id="{00AE17CE-4687-4EB7-8F79-C36F03EDB675}"/>
+              </a:ext>
+            </a:extLst>
+          </p:cNvPr>
+          <p:cNvSpPr>
+            <a:spLocks xmlns:a="http://schemas.openxmlformats.org/drawingml/2006/main" noGrp="1"/>
+          </p:cNvSpPr>
+          <p:nvPr/>
+        </p:nvSpPr>
+        <p:spPr>
+          <a:xfrm xmlns:a="http://schemas.openxmlformats.org/drawingml/2006/main">
+            <a:off x="7981950" y="4533900"/>
+            <a:ext cx="1295400" cy="200025"/>
           </a:xfrm>
           <a:prstGeom xmlns:a="http://schemas.openxmlformats.org/drawingml/2006/main" prst="rect">
             <a:avLst/>
@@ -4714,7 +4714,7 @@
                 <a:ea typeface="Hiragino Sans"/>
                 <a:cs typeface="Hiragino Sans"/>
               </a:rPr>
-              <a:t>重いentropy計算</a:t>
+              <a:t>重いエントロピー計算</a:t>
             </a:r>
           </a:p>
         </p:txBody>
@@ -4724,7 +4724,7 @@
           <p:cNvPr id="37" name="">
             <a:extLst xmlns:a="http://schemas.openxmlformats.org/drawingml/2006/main">
               <a:ext uri="{FF2B5EF4-FFF2-40B4-BE49-F238E27FC236}">
-                <a16:creationId xmlns:a16="http://schemas.microsoft.com/office/drawing/2014/main" id="{44E05F35-838D-40EB-BF30-54ECC5943A49}"/>
+                <a16:creationId xmlns:a16="http://schemas.microsoft.com/office/drawing/2014/main" id="{10E96015-4804-46D2-B14E-81AC41BAB906}"/>
               </a:ext>
             </a:extLst>
           </p:cNvPr>
@@ -4760,7 +4760,7 @@
           <a:lstStyle xmlns:a="http://schemas.openxmlformats.org/drawingml/2006/main"/>
           <a:p xmlns:a="http://schemas.openxmlformats.org/drawingml/2006/main">
             <a:pPr algn="l">
-              <a:defRPr sz="863" b="0">
+              <a:defRPr sz="915" b="0">
                 <a:solidFill>
                   <a:srgbClr val="E5E7EB"/>
                 </a:solidFill>
@@ -4770,7 +4770,7 @@
               </a:defRPr>
             </a:pPr>
             <a:r>
-              <a:rPr sz="863" b="0">
+              <a:rPr sz="915" b="0">
                 <a:solidFill>
                   <a:srgbClr val="E5E7EB"/>
                 </a:solidFill>
@@ -4788,7 +4788,7 @@
           <p:cNvPr id="38" name="">
             <a:extLst xmlns:a="http://schemas.openxmlformats.org/drawingml/2006/main">
               <a:ext uri="{FF2B5EF4-FFF2-40B4-BE49-F238E27FC236}">
-                <a16:creationId xmlns:a16="http://schemas.microsoft.com/office/drawing/2014/main" id="{BD8DB3A5-8EA4-42D6-A8F0-BA2566456D80}"/>
+                <a16:creationId xmlns:a16="http://schemas.microsoft.com/office/drawing/2014/main" id="{52F0B48B-A7E3-46A9-BF80-3605AFB90F9C}"/>
               </a:ext>
             </a:extLst>
           </p:cNvPr>
@@ -4823,7 +4823,7 @@
           <p:cNvPr id="39" name="">
             <a:extLst xmlns:a="http://schemas.openxmlformats.org/drawingml/2006/main">
               <a:ext uri="{FF2B5EF4-FFF2-40B4-BE49-F238E27FC236}">
-                <a16:creationId xmlns:a16="http://schemas.microsoft.com/office/drawing/2014/main" id="{4BFBBCD7-6D59-4628-B2E5-30732085BF6A}"/>
+                <a16:creationId xmlns:a16="http://schemas.microsoft.com/office/drawing/2014/main" id="{41CC4D81-1DCE-4834-AC82-83B455777EF1}"/>
               </a:ext>
             </a:extLst>
           </p:cNvPr>
@@ -4887,7 +4887,7 @@
           <p:cNvPr id="40" name="">
             <a:extLst xmlns:a="http://schemas.openxmlformats.org/drawingml/2006/main">
               <a:ext uri="{FF2B5EF4-FFF2-40B4-BE49-F238E27FC236}">
-                <a16:creationId xmlns:a16="http://schemas.microsoft.com/office/drawing/2014/main" id="{40E4B7A0-ABF7-4D42-9345-E5DE8461005C}"/>
+                <a16:creationId xmlns:a16="http://schemas.microsoft.com/office/drawing/2014/main" id="{6E05F4EA-6159-4723-8C4E-00CDA165A2FE}"/>
               </a:ext>
             </a:extLst>
           </p:cNvPr>
@@ -4922,7 +4922,7 @@
           <p:cNvPr id="41" name="">
             <a:extLst xmlns:a="http://schemas.openxmlformats.org/drawingml/2006/main">
               <a:ext uri="{FF2B5EF4-FFF2-40B4-BE49-F238E27FC236}">
-                <a16:creationId xmlns:a16="http://schemas.microsoft.com/office/drawing/2014/main" id="{058EE652-EA5C-4E8C-90B0-F30660FFFAB2}"/>
+                <a16:creationId xmlns:a16="http://schemas.microsoft.com/office/drawing/2014/main" id="{074421CF-9E2D-431A-ABCD-402CE7CC9C8C}"/>
               </a:ext>
             </a:extLst>
           </p:cNvPr>
@@ -4986,7 +4986,7 @@
           <p:cNvPr id="42" name="">
             <a:extLst xmlns:a="http://schemas.openxmlformats.org/drawingml/2006/main">
               <a:ext uri="{FF2B5EF4-FFF2-40B4-BE49-F238E27FC236}">
-                <a16:creationId xmlns:a16="http://schemas.microsoft.com/office/drawing/2014/main" id="{BE87DA00-2C68-4650-8588-F831CA7F9F88}"/>
+                <a16:creationId xmlns:a16="http://schemas.microsoft.com/office/drawing/2014/main" id="{C29B342D-A19A-4610-B0A5-0378A95873B6}"/>
               </a:ext>
             </a:extLst>
           </p:cNvPr>
@@ -5048,7 +5048,7 @@
     </p:spTree>
     <p:extLst>
       <p:ext uri="{BB962C8B-B14F-4D97-AF65-F5344CB8AC3E}">
-        <p14:creationId xmlns:p14="http://schemas.microsoft.com/office/powerpoint/2010/main" val="277740667"/>
+        <p14:creationId xmlns:p14="http://schemas.microsoft.com/office/powerpoint/2010/main" val="1728945711"/>
       </p:ext>
     </p:extLst>
   </p:cSld>
@@ -5072,7 +5072,7 @@
           <p:cNvPr id="1" name="">
             <a:extLst xmlns:a="http://schemas.openxmlformats.org/drawingml/2006/main">
               <a:ext uri="{FF2B5EF4-FFF2-40B4-BE49-F238E27FC236}">
-                <a16:creationId xmlns:a16="http://schemas.microsoft.com/office/drawing/2014/main" id="{3E9718EA-8083-4E1A-A52C-3C5275ECA5AC}"/>
+                <a16:creationId xmlns:a16="http://schemas.microsoft.com/office/drawing/2014/main" id="{EC40C2C1-3D00-463A-9115-3D6834F37DDF}"/>
               </a:ext>
             </a:extLst>
           </p:cNvPr>
@@ -5107,7 +5107,7 @@
           <p:cNvPr id="2" name="">
             <a:extLst xmlns:a="http://schemas.openxmlformats.org/drawingml/2006/main">
               <a:ext uri="{FF2B5EF4-FFF2-40B4-BE49-F238E27FC236}">
-                <a16:creationId xmlns:a16="http://schemas.microsoft.com/office/drawing/2014/main" id="{AE9F681B-413E-42BF-9F72-E20EE09C0E8A}"/>
+                <a16:creationId xmlns:a16="http://schemas.microsoft.com/office/drawing/2014/main" id="{7606666A-9A4A-47B6-A41B-BA3739AFC7D9}"/>
               </a:ext>
             </a:extLst>
           </p:cNvPr>
@@ -5142,7 +5142,7 @@
           <p:cNvPr id="3" name="kicker-marker">
             <a:extLst xmlns:a="http://schemas.openxmlformats.org/drawingml/2006/main">
               <a:ext uri="{FF2B5EF4-FFF2-40B4-BE49-F238E27FC236}">
-                <a16:creationId xmlns:a16="http://schemas.microsoft.com/office/drawing/2014/main" id="{C43F5712-F9C4-4981-8127-B61C2891C134}"/>
+                <a16:creationId xmlns:a16="http://schemas.microsoft.com/office/drawing/2014/main" id="{4BDD9E3C-AE7C-4894-B78F-C56161A773D3}"/>
               </a:ext>
             </a:extLst>
           </p:cNvPr>
@@ -5177,7 +5177,7 @@
           <p:cNvPr id="4" name="kicker-label">
             <a:extLst xmlns:a="http://schemas.openxmlformats.org/drawingml/2006/main">
               <a:ext uri="{FF2B5EF4-FFF2-40B4-BE49-F238E27FC236}">
-                <a16:creationId xmlns:a16="http://schemas.microsoft.com/office/drawing/2014/main" id="{FA34C003-823F-4FEA-8D3E-E5DC55DE872E}"/>
+                <a16:creationId xmlns:a16="http://schemas.microsoft.com/office/drawing/2014/main" id="{34D17074-1C52-4482-BD8C-9F3B53CF4032}"/>
               </a:ext>
             </a:extLst>
           </p:cNvPr>
@@ -5241,7 +5241,7 @@
           <p:cNvPr id="5" name="">
             <a:extLst xmlns:a="http://schemas.openxmlformats.org/drawingml/2006/main">
               <a:ext uri="{FF2B5EF4-FFF2-40B4-BE49-F238E27FC236}">
-                <a16:creationId xmlns:a16="http://schemas.microsoft.com/office/drawing/2014/main" id="{06504E71-B4D3-4BF1-949A-FE73A33E92EB}"/>
+                <a16:creationId xmlns:a16="http://schemas.microsoft.com/office/drawing/2014/main" id="{1B6D0CE5-16CE-4BD2-A5DE-DAFEC4B963B7}"/>
               </a:ext>
             </a:extLst>
           </p:cNvPr>
@@ -5305,7 +5305,7 @@
           <p:cNvPr id="6" name="">
             <a:extLst xmlns:a="http://schemas.openxmlformats.org/drawingml/2006/main">
               <a:ext uri="{FF2B5EF4-FFF2-40B4-BE49-F238E27FC236}">
-                <a16:creationId xmlns:a16="http://schemas.microsoft.com/office/drawing/2014/main" id="{702CBCC1-4B44-4B52-BF00-69807DF04C39}"/>
+                <a16:creationId xmlns:a16="http://schemas.microsoft.com/office/drawing/2014/main" id="{EE6BEB11-F081-488A-85A5-F290C3E8FDA3}"/>
               </a:ext>
             </a:extLst>
           </p:cNvPr>
@@ -5369,7 +5369,7 @@
           <p:cNvPr id="7" name="">
             <a:extLst xmlns:a="http://schemas.openxmlformats.org/drawingml/2006/main">
               <a:ext uri="{FF2B5EF4-FFF2-40B4-BE49-F238E27FC236}">
-                <a16:creationId xmlns:a16="http://schemas.microsoft.com/office/drawing/2014/main" id="{37BF2AF0-8822-4BB4-9E5A-FADDD3D684D0}"/>
+                <a16:creationId xmlns:a16="http://schemas.microsoft.com/office/drawing/2014/main" id="{44007FBB-CA5D-4D46-8E10-9DB9E1CF3D49}"/>
               </a:ext>
             </a:extLst>
           </p:cNvPr>
@@ -5402,7 +5402,7 @@
           <p:cNvPr id="8" name="">
             <a:extLst xmlns:a="http://schemas.openxmlformats.org/drawingml/2006/main">
               <a:ext uri="{FF2B5EF4-FFF2-40B4-BE49-F238E27FC236}">
-                <a16:creationId xmlns:a16="http://schemas.microsoft.com/office/drawing/2014/main" id="{9C01541D-1FE7-46C7-9325-FAC6BF963FC6}"/>
+                <a16:creationId xmlns:a16="http://schemas.microsoft.com/office/drawing/2014/main" id="{7B326F0A-D1F4-4000-9519-C9429F5DBBD1}"/>
               </a:ext>
             </a:extLst>
           </p:cNvPr>
@@ -5466,7 +5466,7 @@
           <p:cNvPr id="9" name="">
             <a:extLst xmlns:a="http://schemas.openxmlformats.org/drawingml/2006/main">
               <a:ext uri="{FF2B5EF4-FFF2-40B4-BE49-F238E27FC236}">
-                <a16:creationId xmlns:a16="http://schemas.microsoft.com/office/drawing/2014/main" id="{90369B71-3142-488A-A3CA-C03F823EF97D}"/>
+                <a16:creationId xmlns:a16="http://schemas.microsoft.com/office/drawing/2014/main" id="{24E84D39-897E-4AC7-9997-2AFB4F9A7541}"/>
               </a:ext>
             </a:extLst>
           </p:cNvPr>
@@ -5530,7 +5530,7 @@
           <p:cNvPr id="10" name="">
             <a:extLst xmlns:a="http://schemas.openxmlformats.org/drawingml/2006/main">
               <a:ext uri="{FF2B5EF4-FFF2-40B4-BE49-F238E27FC236}">
-                <a16:creationId xmlns:a16="http://schemas.microsoft.com/office/drawing/2014/main" id="{A1B9EF7D-771F-4555-A2DF-982F81A1EDFD}"/>
+                <a16:creationId xmlns:a16="http://schemas.microsoft.com/office/drawing/2014/main" id="{FACA6CA9-FA60-47B3-A2E0-BC84A6527B5B}"/>
               </a:ext>
             </a:extLst>
           </p:cNvPr>
@@ -5565,7 +5565,7 @@
           <p:cNvPr id="11" name="">
             <a:extLst xmlns:a="http://schemas.openxmlformats.org/drawingml/2006/main">
               <a:ext uri="{FF2B5EF4-FFF2-40B4-BE49-F238E27FC236}">
-                <a16:creationId xmlns:a16="http://schemas.microsoft.com/office/drawing/2014/main" id="{5A3982CD-D2D9-4268-9559-16B33096C37D}"/>
+                <a16:creationId xmlns:a16="http://schemas.microsoft.com/office/drawing/2014/main" id="{1558A990-C61A-492D-9272-ED0F88CAE6CB}"/>
               </a:ext>
             </a:extLst>
           </p:cNvPr>
@@ -5629,7 +5629,7 @@
           <p:cNvPr id="12" name="">
             <a:extLst xmlns:a="http://schemas.openxmlformats.org/drawingml/2006/main">
               <a:ext uri="{FF2B5EF4-FFF2-40B4-BE49-F238E27FC236}">
-                <a16:creationId xmlns:a16="http://schemas.microsoft.com/office/drawing/2014/main" id="{FFBA9E89-3503-408C-A5C7-ED49B4166C15}"/>
+                <a16:creationId xmlns:a16="http://schemas.microsoft.com/office/drawing/2014/main" id="{72714927-1D72-4E25-991C-20E90739BC09}"/>
               </a:ext>
             </a:extLst>
           </p:cNvPr>
@@ -5662,7 +5662,7 @@
           <p:cNvPr id="13" name="">
             <a:extLst xmlns:a="http://schemas.openxmlformats.org/drawingml/2006/main">
               <a:ext uri="{FF2B5EF4-FFF2-40B4-BE49-F238E27FC236}">
-                <a16:creationId xmlns:a16="http://schemas.microsoft.com/office/drawing/2014/main" id="{71A63E40-08F2-44B9-919F-A672729EC033}"/>
+                <a16:creationId xmlns:a16="http://schemas.microsoft.com/office/drawing/2014/main" id="{FD8A0625-DB55-45F6-8C16-D5D413C647FB}"/>
               </a:ext>
             </a:extLst>
           </p:cNvPr>
@@ -5726,7 +5726,7 @@
           <p:cNvPr id="14" name="">
             <a:extLst xmlns:a="http://schemas.openxmlformats.org/drawingml/2006/main">
               <a:ext uri="{FF2B5EF4-FFF2-40B4-BE49-F238E27FC236}">
-                <a16:creationId xmlns:a16="http://schemas.microsoft.com/office/drawing/2014/main" id="{E3CB170F-F15C-4FC9-844F-969343E30E52}"/>
+                <a16:creationId xmlns:a16="http://schemas.microsoft.com/office/drawing/2014/main" id="{50634273-142F-4C89-AD82-D3E4DB25A040}"/>
               </a:ext>
             </a:extLst>
           </p:cNvPr>
@@ -5790,7 +5790,7 @@
           <p:cNvPr id="15" name="">
             <a:extLst xmlns:a="http://schemas.openxmlformats.org/drawingml/2006/main">
               <a:ext uri="{FF2B5EF4-FFF2-40B4-BE49-F238E27FC236}">
-                <a16:creationId xmlns:a16="http://schemas.microsoft.com/office/drawing/2014/main" id="{04151C0C-597A-4E83-952A-B72F11A02DB3}"/>
+                <a16:creationId xmlns:a16="http://schemas.microsoft.com/office/drawing/2014/main" id="{39E61C9F-3E88-4D06-BDB5-B9FCF1D552A8}"/>
               </a:ext>
             </a:extLst>
           </p:cNvPr>
@@ -5825,7 +5825,7 @@
           <p:cNvPr id="16" name="">
             <a:extLst xmlns:a="http://schemas.openxmlformats.org/drawingml/2006/main">
               <a:ext uri="{FF2B5EF4-FFF2-40B4-BE49-F238E27FC236}">
-                <a16:creationId xmlns:a16="http://schemas.microsoft.com/office/drawing/2014/main" id="{D16ACED8-1A8B-4E6A-9398-D6BE397E973A}"/>
+                <a16:creationId xmlns:a16="http://schemas.microsoft.com/office/drawing/2014/main" id="{FC3DC446-A8CB-42C4-AE91-4C4569748365}"/>
               </a:ext>
             </a:extLst>
           </p:cNvPr>
@@ -5889,7 +5889,7 @@
           <p:cNvPr id="17" name="">
             <a:extLst xmlns:a="http://schemas.openxmlformats.org/drawingml/2006/main">
               <a:ext uri="{FF2B5EF4-FFF2-40B4-BE49-F238E27FC236}">
-                <a16:creationId xmlns:a16="http://schemas.microsoft.com/office/drawing/2014/main" id="{B7B93E40-6297-47D9-9622-D30B7F41AC8E}"/>
+                <a16:creationId xmlns:a16="http://schemas.microsoft.com/office/drawing/2014/main" id="{0356A017-D960-404D-A080-CC409421A566}"/>
               </a:ext>
             </a:extLst>
           </p:cNvPr>
@@ -5922,7 +5922,7 @@
           <p:cNvPr id="18" name="">
             <a:extLst xmlns:a="http://schemas.openxmlformats.org/drawingml/2006/main">
               <a:ext uri="{FF2B5EF4-FFF2-40B4-BE49-F238E27FC236}">
-                <a16:creationId xmlns:a16="http://schemas.microsoft.com/office/drawing/2014/main" id="{E001156F-05D3-43AD-8B20-809C59E06E4B}"/>
+                <a16:creationId xmlns:a16="http://schemas.microsoft.com/office/drawing/2014/main" id="{4E8FCA07-3025-4FB6-9CC3-57D4F70493EA}"/>
               </a:ext>
             </a:extLst>
           </p:cNvPr>
@@ -5986,7 +5986,7 @@
           <p:cNvPr id="19" name="">
             <a:extLst xmlns:a="http://schemas.openxmlformats.org/drawingml/2006/main">
               <a:ext uri="{FF2B5EF4-FFF2-40B4-BE49-F238E27FC236}">
-                <a16:creationId xmlns:a16="http://schemas.microsoft.com/office/drawing/2014/main" id="{668B8C4E-C80B-442F-8932-8944DD391591}"/>
+                <a16:creationId xmlns:a16="http://schemas.microsoft.com/office/drawing/2014/main" id="{B12228C0-D1DE-4152-8FF8-E36B4F96B022}"/>
               </a:ext>
             </a:extLst>
           </p:cNvPr>
@@ -6040,7 +6040,7 @@
                 <a:ea typeface="Hiragino Sans"/>
                 <a:cs typeface="Hiragino Sans"/>
               </a:rPr>
-              <a:t>どの統計が外れたかも管理者に返す</a:t>
+              <a:t>検証中の仮説として、外れた統計を返す</a:t>
             </a:r>
           </a:p>
         </p:txBody>
@@ -6050,7 +6050,7 @@
           <p:cNvPr id="20" name="">
             <a:extLst xmlns:a="http://schemas.openxmlformats.org/drawingml/2006/main">
               <a:ext uri="{FF2B5EF4-FFF2-40B4-BE49-F238E27FC236}">
-                <a16:creationId xmlns:a16="http://schemas.microsoft.com/office/drawing/2014/main" id="{3806D45D-8D15-4337-9480-15C22A221CF9}"/>
+                <a16:creationId xmlns:a16="http://schemas.microsoft.com/office/drawing/2014/main" id="{6B20F13F-707B-4779-9E73-F128382B79D1}"/>
               </a:ext>
             </a:extLst>
           </p:cNvPr>
@@ -6083,7 +6083,7 @@
           <p:cNvPr id="21" name="">
             <a:extLst xmlns:a="http://schemas.openxmlformats.org/drawingml/2006/main">
               <a:ext uri="{FF2B5EF4-FFF2-40B4-BE49-F238E27FC236}">
-                <a16:creationId xmlns:a16="http://schemas.microsoft.com/office/drawing/2014/main" id="{36D363B5-3DDE-4F28-904A-1A9ECA0285EB}"/>
+                <a16:creationId xmlns:a16="http://schemas.microsoft.com/office/drawing/2014/main" id="{66F7F697-BA24-4112-BA64-2700147ECA7D}"/>
               </a:ext>
             </a:extLst>
           </p:cNvPr>
@@ -6095,7 +6095,7 @@
         <p:spPr>
           <a:xfrm xmlns:a="http://schemas.openxmlformats.org/drawingml/2006/main">
             <a:off x="1123950" y="4362450"/>
-            <a:ext cx="2476500" cy="228600"/>
+            <a:ext cx="3238500" cy="228600"/>
           </a:xfrm>
           <a:prstGeom xmlns:a="http://schemas.openxmlformats.org/drawingml/2006/main" prst="rect">
             <a:avLst/>
@@ -6137,7 +6137,7 @@
                 <a:ea typeface="Hiragino Sans"/>
                 <a:cs typeface="Hiragino Sans"/>
               </a:rPr>
-              <a:t>正常時は再構成誤差が小さい</a:t>
+              <a:t>概念図: 正常時は誤差が小さい想定</a:t>
             </a:r>
           </a:p>
         </p:txBody>
@@ -6147,7 +6147,7 @@
           <p:cNvPr id="22" name="">
             <a:extLst xmlns:a="http://schemas.openxmlformats.org/drawingml/2006/main">
               <a:ext uri="{FF2B5EF4-FFF2-40B4-BE49-F238E27FC236}">
-                <a16:creationId xmlns:a16="http://schemas.microsoft.com/office/drawing/2014/main" id="{973434AB-2402-438E-8CEB-3919F7A2E7B6}"/>
+                <a16:creationId xmlns:a16="http://schemas.microsoft.com/office/drawing/2014/main" id="{AECBA61C-45DB-4AAF-A2A8-1295C2C571CB}"/>
               </a:ext>
             </a:extLst>
           </p:cNvPr>
@@ -6182,7 +6182,7 @@
           <p:cNvPr id="23" name="">
             <a:extLst xmlns:a="http://schemas.openxmlformats.org/drawingml/2006/main">
               <a:ext uri="{FF2B5EF4-FFF2-40B4-BE49-F238E27FC236}">
-                <a16:creationId xmlns:a16="http://schemas.microsoft.com/office/drawing/2014/main" id="{68F22139-BEC3-4B58-BC38-4D40EC960C4C}"/>
+                <a16:creationId xmlns:a16="http://schemas.microsoft.com/office/drawing/2014/main" id="{8E713D5A-65D2-4D2B-BA46-A0CFB3618195}"/>
               </a:ext>
             </a:extLst>
           </p:cNvPr>
@@ -6246,7 +6246,7 @@
           <p:cNvPr id="24" name="">
             <a:extLst xmlns:a="http://schemas.openxmlformats.org/drawingml/2006/main">
               <a:ext uri="{FF2B5EF4-FFF2-40B4-BE49-F238E27FC236}">
-                <a16:creationId xmlns:a16="http://schemas.microsoft.com/office/drawing/2014/main" id="{8A6D35A7-11E9-42C6-BEE9-F50B3CE34879}"/>
+                <a16:creationId xmlns:a16="http://schemas.microsoft.com/office/drawing/2014/main" id="{C290C7D3-B3D4-42A6-81D5-720B9C417DB7}"/>
               </a:ext>
             </a:extLst>
           </p:cNvPr>
@@ -6281,7 +6281,7 @@
           <p:cNvPr id="25" name="">
             <a:extLst xmlns:a="http://schemas.openxmlformats.org/drawingml/2006/main">
               <a:ext uri="{FF2B5EF4-FFF2-40B4-BE49-F238E27FC236}">
-                <a16:creationId xmlns:a16="http://schemas.microsoft.com/office/drawing/2014/main" id="{F91DE021-EC46-4C3F-8FF1-3ABDD8D6900E}"/>
+                <a16:creationId xmlns:a16="http://schemas.microsoft.com/office/drawing/2014/main" id="{2A0B4B83-2DE7-4FFE-9CAD-48C0D15C06C8}"/>
               </a:ext>
             </a:extLst>
           </p:cNvPr>
@@ -6345,7 +6345,7 @@
           <p:cNvPr id="26" name="">
             <a:extLst xmlns:a="http://schemas.openxmlformats.org/drawingml/2006/main">
               <a:ext uri="{FF2B5EF4-FFF2-40B4-BE49-F238E27FC236}">
-                <a16:creationId xmlns:a16="http://schemas.microsoft.com/office/drawing/2014/main" id="{CA059C78-6735-41C5-B9A6-6D1ED02B55D0}"/>
+                <a16:creationId xmlns:a16="http://schemas.microsoft.com/office/drawing/2014/main" id="{EE4D62C8-E0A7-48FA-B58D-BAAAD2021F8B}"/>
               </a:ext>
             </a:extLst>
           </p:cNvPr>
@@ -6380,7 +6380,7 @@
           <p:cNvPr id="27" name="">
             <a:extLst xmlns:a="http://schemas.openxmlformats.org/drawingml/2006/main">
               <a:ext uri="{FF2B5EF4-FFF2-40B4-BE49-F238E27FC236}">
-                <a16:creationId xmlns:a16="http://schemas.microsoft.com/office/drawing/2014/main" id="{45B77F13-87BD-4DDE-A203-869B4D39FE51}"/>
+                <a16:creationId xmlns:a16="http://schemas.microsoft.com/office/drawing/2014/main" id="{08D91DC9-1E22-4564-8C9E-A956EB08006D}"/>
               </a:ext>
             </a:extLst>
           </p:cNvPr>
@@ -6444,7 +6444,7 @@
           <p:cNvPr id="28" name="">
             <a:extLst xmlns:a="http://schemas.openxmlformats.org/drawingml/2006/main">
               <a:ext uri="{FF2B5EF4-FFF2-40B4-BE49-F238E27FC236}">
-                <a16:creationId xmlns:a16="http://schemas.microsoft.com/office/drawing/2014/main" id="{20230714-1F53-4177-8A49-D1B716102525}"/>
+                <a16:creationId xmlns:a16="http://schemas.microsoft.com/office/drawing/2014/main" id="{0F244566-1C35-43C9-B711-FCA60169A945}"/>
               </a:ext>
             </a:extLst>
           </p:cNvPr>
@@ -6479,7 +6479,7 @@
           <p:cNvPr id="29" name="">
             <a:extLst xmlns:a="http://schemas.openxmlformats.org/drawingml/2006/main">
               <a:ext uri="{FF2B5EF4-FFF2-40B4-BE49-F238E27FC236}">
-                <a16:creationId xmlns:a16="http://schemas.microsoft.com/office/drawing/2014/main" id="{C6AADD86-BA87-4EEA-9403-A1BF75910160}"/>
+                <a16:creationId xmlns:a16="http://schemas.microsoft.com/office/drawing/2014/main" id="{0F4A6F7A-E4C6-4CCE-8C14-083C7B7787FB}"/>
               </a:ext>
             </a:extLst>
           </p:cNvPr>
@@ -6543,7 +6543,7 @@
           <p:cNvPr id="30" name="">
             <a:extLst xmlns:a="http://schemas.openxmlformats.org/drawingml/2006/main">
               <a:ext uri="{FF2B5EF4-FFF2-40B4-BE49-F238E27FC236}">
-                <a16:creationId xmlns:a16="http://schemas.microsoft.com/office/drawing/2014/main" id="{5DD73C6B-BB09-4F47-AA44-42EB8F767C06}"/>
+                <a16:creationId xmlns:a16="http://schemas.microsoft.com/office/drawing/2014/main" id="{7E7789D3-C5CD-420F-9B6F-1736A23B3C00}"/>
               </a:ext>
             </a:extLst>
           </p:cNvPr>
@@ -6578,7 +6578,7 @@
           <p:cNvPr id="31" name="">
             <a:extLst xmlns:a="http://schemas.openxmlformats.org/drawingml/2006/main">
               <a:ext uri="{FF2B5EF4-FFF2-40B4-BE49-F238E27FC236}">
-                <a16:creationId xmlns:a16="http://schemas.microsoft.com/office/drawing/2014/main" id="{0CDB11B0-F3BF-4D19-B40B-D2903AC8E8A7}"/>
+                <a16:creationId xmlns:a16="http://schemas.microsoft.com/office/drawing/2014/main" id="{0CD7291E-6B9B-4B4E-BADB-548839D2230D}"/>
               </a:ext>
             </a:extLst>
           </p:cNvPr>
@@ -6642,7 +6642,7 @@
           <p:cNvPr id="32" name="">
             <a:extLst xmlns:a="http://schemas.openxmlformats.org/drawingml/2006/main">
               <a:ext uri="{FF2B5EF4-FFF2-40B4-BE49-F238E27FC236}">
-                <a16:creationId xmlns:a16="http://schemas.microsoft.com/office/drawing/2014/main" id="{C56EB01F-CC9C-40CF-A5BA-A42F39C1889F}"/>
+                <a16:creationId xmlns:a16="http://schemas.microsoft.com/office/drawing/2014/main" id="{51C17DA7-E296-4E2E-9AE5-4381FD69FE43}"/>
               </a:ext>
             </a:extLst>
           </p:cNvPr>
@@ -6677,7 +6677,7 @@
           <p:cNvPr id="33" name="">
             <a:extLst xmlns:a="http://schemas.openxmlformats.org/drawingml/2006/main">
               <a:ext uri="{FF2B5EF4-FFF2-40B4-BE49-F238E27FC236}">
-                <a16:creationId xmlns:a16="http://schemas.microsoft.com/office/drawing/2014/main" id="{C0B137B8-A607-4C2C-8072-37E3D28A729F}"/>
+                <a16:creationId xmlns:a16="http://schemas.microsoft.com/office/drawing/2014/main" id="{6FBD6B44-2008-4C01-A8DD-35E60A879030}"/>
               </a:ext>
             </a:extLst>
           </p:cNvPr>
@@ -6741,7 +6741,7 @@
           <p:cNvPr id="34" name="">
             <a:extLst xmlns:a="http://schemas.openxmlformats.org/drawingml/2006/main">
               <a:ext uri="{FF2B5EF4-FFF2-40B4-BE49-F238E27FC236}">
-                <a16:creationId xmlns:a16="http://schemas.microsoft.com/office/drawing/2014/main" id="{8F72A01D-CEA7-49AF-A7F6-BCB7EDBFD2F2}"/>
+                <a16:creationId xmlns:a16="http://schemas.microsoft.com/office/drawing/2014/main" id="{D749819B-DE45-4DF5-BCFC-6BECE2FF96DA}"/>
               </a:ext>
             </a:extLst>
           </p:cNvPr>
@@ -6776,7 +6776,7 @@
           <p:cNvPr id="35" name="">
             <a:extLst xmlns:a="http://schemas.openxmlformats.org/drawingml/2006/main">
               <a:ext uri="{FF2B5EF4-FFF2-40B4-BE49-F238E27FC236}">
-                <a16:creationId xmlns:a16="http://schemas.microsoft.com/office/drawing/2014/main" id="{25CC892E-67A0-495A-A547-47BAB223C9D9}"/>
+                <a16:creationId xmlns:a16="http://schemas.microsoft.com/office/drawing/2014/main" id="{FD80465A-69EB-4498-A19B-0A7C8523428D}"/>
               </a:ext>
             </a:extLst>
           </p:cNvPr>
@@ -6809,7 +6809,7 @@
           <p:cNvPr id="36" name="">
             <a:extLst xmlns:a="http://schemas.openxmlformats.org/drawingml/2006/main">
               <a:ext uri="{FF2B5EF4-FFF2-40B4-BE49-F238E27FC236}">
-                <a16:creationId xmlns:a16="http://schemas.microsoft.com/office/drawing/2014/main" id="{985F8672-243D-4BA8-AE5A-31F2E8C0E299}"/>
+                <a16:creationId xmlns:a16="http://schemas.microsoft.com/office/drawing/2014/main" id="{B65DB1C6-E358-4C6B-B540-DFBABB65AFC4}"/>
               </a:ext>
             </a:extLst>
           </p:cNvPr>
@@ -6821,7 +6821,7 @@
         <p:spPr>
           <a:xfrm xmlns:a="http://schemas.openxmlformats.org/drawingml/2006/main">
             <a:off x="6610350" y="4362450"/>
-            <a:ext cx="3048000" cy="228600"/>
+            <a:ext cx="3238500" cy="228600"/>
           </a:xfrm>
           <a:prstGeom xmlns:a="http://schemas.openxmlformats.org/drawingml/2006/main" prst="rect">
             <a:avLst/>
@@ -6863,7 +6863,7 @@
                 <a:ea typeface="Hiragino Sans"/>
                 <a:cs typeface="Hiragino Sans"/>
               </a:rPr>
-              <a:t>攻撃らしい窓は一部チャネルが跳ねる</a:t>
+              <a:t>概念図: 検証する仮説上の異常窓</a:t>
             </a:r>
           </a:p>
         </p:txBody>
@@ -6873,7 +6873,7 @@
           <p:cNvPr id="37" name="">
             <a:extLst xmlns:a="http://schemas.openxmlformats.org/drawingml/2006/main">
               <a:ext uri="{FF2B5EF4-FFF2-40B4-BE49-F238E27FC236}">
-                <a16:creationId xmlns:a16="http://schemas.microsoft.com/office/drawing/2014/main" id="{99F99A65-FB36-4955-AA82-D52D3A3B0F60}"/>
+                <a16:creationId xmlns:a16="http://schemas.microsoft.com/office/drawing/2014/main" id="{417401B0-7A99-4504-9A05-B16C4F57FF06}"/>
               </a:ext>
             </a:extLst>
           </p:cNvPr>
@@ -6891,7 +6891,7 @@
             <a:avLst/>
           </a:prstGeom>
           <a:solidFill xmlns:a="http://schemas.openxmlformats.org/drawingml/2006/main">
-            <a:srgbClr val="2563EB"/>
+            <a:srgbClr val="60A5FA"/>
           </a:solidFill>
           <a:ln xmlns:a="http://schemas.openxmlformats.org/drawingml/2006/main" w="0">
             <a:solidFill>
@@ -6908,7 +6908,7 @@
           <p:cNvPr id="38" name="">
             <a:extLst xmlns:a="http://schemas.openxmlformats.org/drawingml/2006/main">
               <a:ext uri="{FF2B5EF4-FFF2-40B4-BE49-F238E27FC236}">
-                <a16:creationId xmlns:a16="http://schemas.microsoft.com/office/drawing/2014/main" id="{D1C74331-A0F7-4092-9F5B-FC3BF4102057}"/>
+                <a16:creationId xmlns:a16="http://schemas.microsoft.com/office/drawing/2014/main" id="{DB792939-74A8-43D4-8C7D-0ABC3C8E1E2B}"/>
               </a:ext>
             </a:extLst>
           </p:cNvPr>
@@ -6972,7 +6972,7 @@
           <p:cNvPr id="39" name="">
             <a:extLst xmlns:a="http://schemas.openxmlformats.org/drawingml/2006/main">
               <a:ext uri="{FF2B5EF4-FFF2-40B4-BE49-F238E27FC236}">
-                <a16:creationId xmlns:a16="http://schemas.microsoft.com/office/drawing/2014/main" id="{7878C33A-8A78-4434-8C93-023FB55AEDEC}"/>
+                <a16:creationId xmlns:a16="http://schemas.microsoft.com/office/drawing/2014/main" id="{7ADA3004-68C8-4CB5-82F2-FEA305FACBF8}"/>
               </a:ext>
             </a:extLst>
           </p:cNvPr>
@@ -6990,7 +6990,7 @@
             <a:avLst/>
           </a:prstGeom>
           <a:solidFill xmlns:a="http://schemas.openxmlformats.org/drawingml/2006/main">
-            <a:srgbClr val="B91C1C"/>
+            <a:srgbClr val="DC2626"/>
           </a:solidFill>
           <a:ln xmlns:a="http://schemas.openxmlformats.org/drawingml/2006/main" w="0">
             <a:solidFill>
@@ -7007,7 +7007,7 @@
           <p:cNvPr id="40" name="">
             <a:extLst xmlns:a="http://schemas.openxmlformats.org/drawingml/2006/main">
               <a:ext uri="{FF2B5EF4-FFF2-40B4-BE49-F238E27FC236}">
-                <a16:creationId xmlns:a16="http://schemas.microsoft.com/office/drawing/2014/main" id="{0586447F-B862-488F-96F9-F4F262BDBCA4}"/>
+                <a16:creationId xmlns:a16="http://schemas.microsoft.com/office/drawing/2014/main" id="{A29F5791-6A9D-4010-89FB-DF38F9001E90}"/>
               </a:ext>
             </a:extLst>
           </p:cNvPr>
@@ -7071,7 +7071,7 @@
           <p:cNvPr id="41" name="">
             <a:extLst xmlns:a="http://schemas.openxmlformats.org/drawingml/2006/main">
               <a:ext uri="{FF2B5EF4-FFF2-40B4-BE49-F238E27FC236}">
-                <a16:creationId xmlns:a16="http://schemas.microsoft.com/office/drawing/2014/main" id="{B13B65A4-EE38-4382-A9D8-8BE28F0BDC27}"/>
+                <a16:creationId xmlns:a16="http://schemas.microsoft.com/office/drawing/2014/main" id="{33BE373F-54B4-41E4-A8F2-98CD9582637E}"/>
               </a:ext>
             </a:extLst>
           </p:cNvPr>
@@ -7089,7 +7089,7 @@
             <a:avLst/>
           </a:prstGeom>
           <a:solidFill xmlns:a="http://schemas.openxmlformats.org/drawingml/2006/main">
-            <a:srgbClr val="B91C1C"/>
+            <a:srgbClr val="DC2626"/>
           </a:solidFill>
           <a:ln xmlns:a="http://schemas.openxmlformats.org/drawingml/2006/main" w="0">
             <a:solidFill>
@@ -7106,7 +7106,7 @@
           <p:cNvPr id="42" name="">
             <a:extLst xmlns:a="http://schemas.openxmlformats.org/drawingml/2006/main">
               <a:ext uri="{FF2B5EF4-FFF2-40B4-BE49-F238E27FC236}">
-                <a16:creationId xmlns:a16="http://schemas.microsoft.com/office/drawing/2014/main" id="{99C2BBED-FC7B-44AD-AA3E-AE4A3A4E67B8}"/>
+                <a16:creationId xmlns:a16="http://schemas.microsoft.com/office/drawing/2014/main" id="{3F945DEA-F276-476D-804A-F4AD4254570B}"/>
               </a:ext>
             </a:extLst>
           </p:cNvPr>
@@ -7170,7 +7170,7 @@
           <p:cNvPr id="43" name="">
             <a:extLst xmlns:a="http://schemas.openxmlformats.org/drawingml/2006/main">
               <a:ext uri="{FF2B5EF4-FFF2-40B4-BE49-F238E27FC236}">
-                <a16:creationId xmlns:a16="http://schemas.microsoft.com/office/drawing/2014/main" id="{50F70B78-F390-4524-ADA5-A6B9633927E2}"/>
+                <a16:creationId xmlns:a16="http://schemas.microsoft.com/office/drawing/2014/main" id="{17C7A602-4558-4F06-8B16-8C9A8E16AE8A}"/>
               </a:ext>
             </a:extLst>
           </p:cNvPr>
@@ -7188,7 +7188,7 @@
             <a:avLst/>
           </a:prstGeom>
           <a:solidFill xmlns:a="http://schemas.openxmlformats.org/drawingml/2006/main">
-            <a:srgbClr val="2563EB"/>
+            <a:srgbClr val="60A5FA"/>
           </a:solidFill>
           <a:ln xmlns:a="http://schemas.openxmlformats.org/drawingml/2006/main" w="0">
             <a:solidFill>
@@ -7205,7 +7205,7 @@
           <p:cNvPr id="44" name="">
             <a:extLst xmlns:a="http://schemas.openxmlformats.org/drawingml/2006/main">
               <a:ext uri="{FF2B5EF4-FFF2-40B4-BE49-F238E27FC236}">
-                <a16:creationId xmlns:a16="http://schemas.microsoft.com/office/drawing/2014/main" id="{461AF5CF-0B74-46D0-BA58-77F96CB0CCD9}"/>
+                <a16:creationId xmlns:a16="http://schemas.microsoft.com/office/drawing/2014/main" id="{005FF63E-1D02-499D-A4EA-0F2C41CA05D6}"/>
               </a:ext>
             </a:extLst>
           </p:cNvPr>
@@ -7269,7 +7269,7 @@
           <p:cNvPr id="45" name="">
             <a:extLst xmlns:a="http://schemas.openxmlformats.org/drawingml/2006/main">
               <a:ext uri="{FF2B5EF4-FFF2-40B4-BE49-F238E27FC236}">
-                <a16:creationId xmlns:a16="http://schemas.microsoft.com/office/drawing/2014/main" id="{520E68E6-030E-4B5C-AD62-16E2E05FFA5B}"/>
+                <a16:creationId xmlns:a16="http://schemas.microsoft.com/office/drawing/2014/main" id="{F9AF461D-9F4A-4DEF-A38D-80E8E5005C2C}"/>
               </a:ext>
             </a:extLst>
           </p:cNvPr>
@@ -7287,7 +7287,7 @@
             <a:avLst/>
           </a:prstGeom>
           <a:solidFill xmlns:a="http://schemas.openxmlformats.org/drawingml/2006/main">
-            <a:srgbClr val="2563EB"/>
+            <a:srgbClr val="60A5FA"/>
           </a:solidFill>
           <a:ln xmlns:a="http://schemas.openxmlformats.org/drawingml/2006/main" w="0">
             <a:solidFill>
@@ -7304,7 +7304,7 @@
           <p:cNvPr id="46" name="">
             <a:extLst xmlns:a="http://schemas.openxmlformats.org/drawingml/2006/main">
               <a:ext uri="{FF2B5EF4-FFF2-40B4-BE49-F238E27FC236}">
-                <a16:creationId xmlns:a16="http://schemas.microsoft.com/office/drawing/2014/main" id="{2D6C9C19-9A77-455F-B2B0-170AFC979AA4}"/>
+                <a16:creationId xmlns:a16="http://schemas.microsoft.com/office/drawing/2014/main" id="{3A0DF5D6-8F9F-4504-8AFD-EB2FFA70F4EA}"/>
               </a:ext>
             </a:extLst>
           </p:cNvPr>
@@ -7368,7 +7368,7 @@
           <p:cNvPr id="47" name="">
             <a:extLst xmlns:a="http://schemas.openxmlformats.org/drawingml/2006/main">
               <a:ext uri="{FF2B5EF4-FFF2-40B4-BE49-F238E27FC236}">
-                <a16:creationId xmlns:a16="http://schemas.microsoft.com/office/drawing/2014/main" id="{7D1E2F66-B093-4448-88EC-7B8AAB554F0B}"/>
+                <a16:creationId xmlns:a16="http://schemas.microsoft.com/office/drawing/2014/main" id="{30BB71BD-E67F-4E44-ACC1-29AA4239CFA3}"/>
               </a:ext>
             </a:extLst>
           </p:cNvPr>
@@ -7386,7 +7386,7 @@
             <a:avLst/>
           </a:prstGeom>
           <a:solidFill xmlns:a="http://schemas.openxmlformats.org/drawingml/2006/main">
-            <a:srgbClr val="B91C1C"/>
+            <a:srgbClr val="DC2626"/>
           </a:solidFill>
           <a:ln xmlns:a="http://schemas.openxmlformats.org/drawingml/2006/main" w="0">
             <a:solidFill>
@@ -7403,7 +7403,7 @@
           <p:cNvPr id="48" name="">
             <a:extLst xmlns:a="http://schemas.openxmlformats.org/drawingml/2006/main">
               <a:ext uri="{FF2B5EF4-FFF2-40B4-BE49-F238E27FC236}">
-                <a16:creationId xmlns:a16="http://schemas.microsoft.com/office/drawing/2014/main" id="{20B97642-2EE4-48B6-AC39-AD7F13FB1D46}"/>
+                <a16:creationId xmlns:a16="http://schemas.microsoft.com/office/drawing/2014/main" id="{A3B6E3A5-D527-41CE-B4FE-3715F03E87DE}"/>
               </a:ext>
             </a:extLst>
           </p:cNvPr>
@@ -7467,7 +7467,7 @@
           <p:cNvPr id="49" name="">
             <a:extLst xmlns:a="http://schemas.openxmlformats.org/drawingml/2006/main">
               <a:ext uri="{FF2B5EF4-FFF2-40B4-BE49-F238E27FC236}">
-                <a16:creationId xmlns:a16="http://schemas.microsoft.com/office/drawing/2014/main" id="{8542165D-B4B2-47D7-A4CE-9FA8ABD5F2F0}"/>
+                <a16:creationId xmlns:a16="http://schemas.microsoft.com/office/drawing/2014/main" id="{6F36440F-46EC-4D10-86CB-6B8440CD96A6}"/>
               </a:ext>
             </a:extLst>
           </p:cNvPr>
@@ -7502,19 +7502,19 @@
           <p:cNvPr id="50" name="">
             <a:extLst xmlns:a="http://schemas.openxmlformats.org/drawingml/2006/main">
               <a:ext uri="{FF2B5EF4-FFF2-40B4-BE49-F238E27FC236}">
-                <a16:creationId xmlns:a16="http://schemas.microsoft.com/office/drawing/2014/main" id="{4757CCE5-1F63-4B9F-BCB2-BEA04DE2C3E8}"/>
-              </a:ext>
-            </a:extLst>
-          </p:cNvPr>
-          <p:cNvSpPr>
-            <a:spLocks xmlns:a="http://schemas.openxmlformats.org/drawingml/2006/main" noGrp="1"/>
-          </p:cNvSpPr>
-          <p:nvPr/>
-        </p:nvSpPr>
-        <p:spPr>
-          <a:xfrm xmlns:a="http://schemas.openxmlformats.org/drawingml/2006/main">
-            <a:off x="8724900" y="5676900"/>
-            <a:ext cx="1638300" cy="257175"/>
+                <a16:creationId xmlns:a16="http://schemas.microsoft.com/office/drawing/2014/main" id="{645B96F9-FD58-4D13-BE63-0C30CD9AA89C}"/>
+              </a:ext>
+            </a:extLst>
+          </p:cNvPr>
+          <p:cNvSpPr>
+            <a:spLocks xmlns:a="http://schemas.openxmlformats.org/drawingml/2006/main" noGrp="1"/>
+          </p:cNvSpPr>
+          <p:nvPr/>
+        </p:nvSpPr>
+        <p:spPr>
+          <a:xfrm xmlns:a="http://schemas.openxmlformats.org/drawingml/2006/main">
+            <a:off x="8401050" y="5676900"/>
+            <a:ext cx="2266950" cy="257175"/>
           </a:xfrm>
           <a:prstGeom xmlns:a="http://schemas.openxmlformats.org/drawingml/2006/main" prst="rect">
             <a:avLst/>
@@ -7535,19 +7535,19 @@
           <p:cNvPr id="51" name="">
             <a:extLst xmlns:a="http://schemas.openxmlformats.org/drawingml/2006/main">
               <a:ext uri="{FF2B5EF4-FFF2-40B4-BE49-F238E27FC236}">
-                <a16:creationId xmlns:a16="http://schemas.microsoft.com/office/drawing/2014/main" id="{71AB1CAD-67A3-4502-AD00-323D876AD82A}"/>
-              </a:ext>
-            </a:extLst>
-          </p:cNvPr>
-          <p:cNvSpPr>
-            <a:spLocks xmlns:a="http://schemas.openxmlformats.org/drawingml/2006/main" noGrp="1"/>
-          </p:cNvSpPr>
-          <p:nvPr/>
-        </p:nvSpPr>
-        <p:spPr>
-          <a:xfrm xmlns:a="http://schemas.openxmlformats.org/drawingml/2006/main">
-            <a:off x="8801100" y="5695950"/>
-            <a:ext cx="1485900" cy="200025"/>
+                <a16:creationId xmlns:a16="http://schemas.microsoft.com/office/drawing/2014/main" id="{0FE55D15-2F48-4069-ACDC-83C7429AA435}"/>
+              </a:ext>
+            </a:extLst>
+          </p:cNvPr>
+          <p:cNvSpPr>
+            <a:spLocks xmlns:a="http://schemas.openxmlformats.org/drawingml/2006/main" noGrp="1"/>
+          </p:cNvSpPr>
+          <p:nvPr/>
+        </p:nvSpPr>
+        <p:spPr>
+          <a:xfrm xmlns:a="http://schemas.openxmlformats.org/drawingml/2006/main">
+            <a:off x="8477250" y="5695950"/>
+            <a:ext cx="2114550" cy="200025"/>
           </a:xfrm>
           <a:prstGeom xmlns:a="http://schemas.openxmlformats.org/drawingml/2006/main" prst="rect">
             <a:avLst/>
@@ -7589,7 +7589,7 @@
                 <a:ea typeface="Hiragino Sans"/>
                 <a:cs typeface="Hiragino Sans"/>
               </a:rPr>
-              <a:t>性能値はまだ非主張</a:t>
+              <a:t>模式図。性能値は非主張</a:t>
             </a:r>
           </a:p>
         </p:txBody>
@@ -7599,7 +7599,7 @@
           <p:cNvPr id="52" name="">
             <a:extLst xmlns:a="http://schemas.openxmlformats.org/drawingml/2006/main">
               <a:ext uri="{FF2B5EF4-FFF2-40B4-BE49-F238E27FC236}">
-                <a16:creationId xmlns:a16="http://schemas.microsoft.com/office/drawing/2014/main" id="{2BC689D9-6F26-4B6B-AFCB-116318D6012F}"/>
+                <a16:creationId xmlns:a16="http://schemas.microsoft.com/office/drawing/2014/main" id="{A17E61EC-7F27-483A-BEFD-3D130D1D9895}"/>
               </a:ext>
             </a:extLst>
           </p:cNvPr>
@@ -7634,7 +7634,7 @@
           <p:cNvPr id="53" name="">
             <a:extLst xmlns:a="http://schemas.openxmlformats.org/drawingml/2006/main">
               <a:ext uri="{FF2B5EF4-FFF2-40B4-BE49-F238E27FC236}">
-                <a16:creationId xmlns:a16="http://schemas.microsoft.com/office/drawing/2014/main" id="{413C7F36-65A0-4D3B-B9A2-9CF27873A1CE}"/>
+                <a16:creationId xmlns:a16="http://schemas.microsoft.com/office/drawing/2014/main" id="{D739A948-1528-464A-AFF3-1CE29F3CCEDF}"/>
               </a:ext>
             </a:extLst>
           </p:cNvPr>
@@ -7698,7 +7698,7 @@
           <p:cNvPr id="54" name="">
             <a:extLst xmlns:a="http://schemas.openxmlformats.org/drawingml/2006/main">
               <a:ext uri="{FF2B5EF4-FFF2-40B4-BE49-F238E27FC236}">
-                <a16:creationId xmlns:a16="http://schemas.microsoft.com/office/drawing/2014/main" id="{42571C05-EC01-4097-A348-E392D082E81A}"/>
+                <a16:creationId xmlns:a16="http://schemas.microsoft.com/office/drawing/2014/main" id="{D0C80876-45BD-43E3-A551-420627996B6E}"/>
               </a:ext>
             </a:extLst>
           </p:cNvPr>
@@ -7760,7 +7760,7 @@
     </p:spTree>
     <p:extLst>
       <p:ext uri="{BB962C8B-B14F-4D97-AF65-F5344CB8AC3E}">
-        <p14:creationId xmlns:p14="http://schemas.microsoft.com/office/powerpoint/2010/main" val="1109917296"/>
+        <p14:creationId xmlns:p14="http://schemas.microsoft.com/office/powerpoint/2010/main" val="121656083"/>
       </p:ext>
     </p:extLst>
   </p:cSld>
@@ -7784,7 +7784,7 @@
           <p:cNvPr id="1" name="">
             <a:extLst xmlns:a="http://schemas.openxmlformats.org/drawingml/2006/main">
               <a:ext uri="{FF2B5EF4-FFF2-40B4-BE49-F238E27FC236}">
-                <a16:creationId xmlns:a16="http://schemas.microsoft.com/office/drawing/2014/main" id="{2C6BE0A6-7D45-4F37-9D55-9D5974FEEDFC}"/>
+                <a16:creationId xmlns:a16="http://schemas.microsoft.com/office/drawing/2014/main" id="{89D374C6-0B5E-4A64-B8F3-A4C8EF2DEC35}"/>
               </a:ext>
             </a:extLst>
           </p:cNvPr>
@@ -7819,7 +7819,7 @@
           <p:cNvPr id="2" name="">
             <a:extLst xmlns:a="http://schemas.openxmlformats.org/drawingml/2006/main">
               <a:ext uri="{FF2B5EF4-FFF2-40B4-BE49-F238E27FC236}">
-                <a16:creationId xmlns:a16="http://schemas.microsoft.com/office/drawing/2014/main" id="{A86BA6A9-21B4-417D-9DFD-2EAF1C498122}"/>
+                <a16:creationId xmlns:a16="http://schemas.microsoft.com/office/drawing/2014/main" id="{F2E1BDDA-6D9F-42A4-8B45-F68A4959799A}"/>
               </a:ext>
             </a:extLst>
           </p:cNvPr>
@@ -7854,7 +7854,7 @@
           <p:cNvPr id="3" name="kicker-marker">
             <a:extLst xmlns:a="http://schemas.openxmlformats.org/drawingml/2006/main">
               <a:ext uri="{FF2B5EF4-FFF2-40B4-BE49-F238E27FC236}">
-                <a16:creationId xmlns:a16="http://schemas.microsoft.com/office/drawing/2014/main" id="{4CD745AE-AC73-425A-B423-E9C54D576F45}"/>
+                <a16:creationId xmlns:a16="http://schemas.microsoft.com/office/drawing/2014/main" id="{700FA4A1-BA50-416C-A0A8-50CCE74AB6D8}"/>
               </a:ext>
             </a:extLst>
           </p:cNvPr>
@@ -7889,7 +7889,7 @@
           <p:cNvPr id="4" name="kicker-label">
             <a:extLst xmlns:a="http://schemas.openxmlformats.org/drawingml/2006/main">
               <a:ext uri="{FF2B5EF4-FFF2-40B4-BE49-F238E27FC236}">
-                <a16:creationId xmlns:a16="http://schemas.microsoft.com/office/drawing/2014/main" id="{770427C6-75A9-4E38-B91D-B1BAF7C0FB3B}"/>
+                <a16:creationId xmlns:a16="http://schemas.microsoft.com/office/drawing/2014/main" id="{E0B997F6-7BD7-4A9B-998B-5340C48562CA}"/>
               </a:ext>
             </a:extLst>
           </p:cNvPr>
@@ -7953,7 +7953,7 @@
           <p:cNvPr id="5" name="">
             <a:extLst xmlns:a="http://schemas.openxmlformats.org/drawingml/2006/main">
               <a:ext uri="{FF2B5EF4-FFF2-40B4-BE49-F238E27FC236}">
-                <a16:creationId xmlns:a16="http://schemas.microsoft.com/office/drawing/2014/main" id="{7E09FE66-7335-4430-B5B7-1E85CA38FA2F}"/>
+                <a16:creationId xmlns:a16="http://schemas.microsoft.com/office/drawing/2014/main" id="{07748F93-63A9-44EF-8192-7589E28C9F60}"/>
               </a:ext>
             </a:extLst>
           </p:cNvPr>
@@ -8017,7 +8017,7 @@
           <p:cNvPr id="6" name="">
             <a:extLst xmlns:a="http://schemas.openxmlformats.org/drawingml/2006/main">
               <a:ext uri="{FF2B5EF4-FFF2-40B4-BE49-F238E27FC236}">
-                <a16:creationId xmlns:a16="http://schemas.microsoft.com/office/drawing/2014/main" id="{C45370ED-778E-4C21-9CD9-E4BE8FA21C4F}"/>
+                <a16:creationId xmlns:a16="http://schemas.microsoft.com/office/drawing/2014/main" id="{1D4B4893-B05E-43A6-9E0B-87550C5A80AF}"/>
               </a:ext>
             </a:extLst>
           </p:cNvPr>
@@ -8081,7 +8081,7 @@
           <p:cNvPr id="7" name="">
             <a:extLst xmlns:a="http://schemas.openxmlformats.org/drawingml/2006/main">
               <a:ext uri="{FF2B5EF4-FFF2-40B4-BE49-F238E27FC236}">
-                <a16:creationId xmlns:a16="http://schemas.microsoft.com/office/drawing/2014/main" id="{4D68A3DF-2846-4549-BCD3-FB5EAE20B904}"/>
+                <a16:creationId xmlns:a16="http://schemas.microsoft.com/office/drawing/2014/main" id="{3A4F316C-A644-4EBA-9119-633AAD3925AE}"/>
               </a:ext>
             </a:extLst>
           </p:cNvPr>
@@ -8116,7 +8116,7 @@
           <p:cNvPr id="8" name="">
             <a:extLst xmlns:a="http://schemas.openxmlformats.org/drawingml/2006/main">
               <a:ext uri="{FF2B5EF4-FFF2-40B4-BE49-F238E27FC236}">
-                <a16:creationId xmlns:a16="http://schemas.microsoft.com/office/drawing/2014/main" id="{4A4DD1DA-8177-40DF-B25B-D1C4367916BB}"/>
+                <a16:creationId xmlns:a16="http://schemas.microsoft.com/office/drawing/2014/main" id="{C5BFE6EF-9AE4-4D6B-8641-63D21B9175C1}"/>
               </a:ext>
             </a:extLst>
           </p:cNvPr>
@@ -8180,7 +8180,7 @@
           <p:cNvPr id="9" name="">
             <a:extLst xmlns:a="http://schemas.openxmlformats.org/drawingml/2006/main">
               <a:ext uri="{FF2B5EF4-FFF2-40B4-BE49-F238E27FC236}">
-                <a16:creationId xmlns:a16="http://schemas.microsoft.com/office/drawing/2014/main" id="{E592C28D-8227-4EF9-A531-7BF026A71230}"/>
+                <a16:creationId xmlns:a16="http://schemas.microsoft.com/office/drawing/2014/main" id="{BA5DB431-FF9C-40D2-9716-00E195C38C12}"/>
               </a:ext>
             </a:extLst>
           </p:cNvPr>
@@ -8244,7 +8244,7 @@
           <p:cNvPr id="10" name="">
             <a:extLst xmlns:a="http://schemas.openxmlformats.org/drawingml/2006/main">
               <a:ext uri="{FF2B5EF4-FFF2-40B4-BE49-F238E27FC236}">
-                <a16:creationId xmlns:a16="http://schemas.microsoft.com/office/drawing/2014/main" id="{C065E7D0-C621-419F-86DA-3BCAD2B79699}"/>
+                <a16:creationId xmlns:a16="http://schemas.microsoft.com/office/drawing/2014/main" id="{DECA4E64-16FE-43E5-8E02-63C669E2EBC0}"/>
               </a:ext>
             </a:extLst>
           </p:cNvPr>
@@ -8308,7 +8308,7 @@
           <p:cNvPr id="11" name="">
             <a:extLst xmlns:a="http://schemas.openxmlformats.org/drawingml/2006/main">
               <a:ext uri="{FF2B5EF4-FFF2-40B4-BE49-F238E27FC236}">
-                <a16:creationId xmlns:a16="http://schemas.microsoft.com/office/drawing/2014/main" id="{C11D8A68-07F6-40FF-AB6C-E2E2D9D4A85F}"/>
+                <a16:creationId xmlns:a16="http://schemas.microsoft.com/office/drawing/2014/main" id="{6453DBDF-E9BC-4343-AD89-28DFE3C941A2}"/>
               </a:ext>
             </a:extLst>
           </p:cNvPr>
@@ -8341,7 +8341,7 @@
           <p:cNvPr id="12" name="">
             <a:extLst xmlns:a="http://schemas.openxmlformats.org/drawingml/2006/main">
               <a:ext uri="{FF2B5EF4-FFF2-40B4-BE49-F238E27FC236}">
-                <a16:creationId xmlns:a16="http://schemas.microsoft.com/office/drawing/2014/main" id="{22D54EDF-AB93-4DB7-9A05-77F5382043A2}"/>
+                <a16:creationId xmlns:a16="http://schemas.microsoft.com/office/drawing/2014/main" id="{2220748A-4EEE-4599-8B21-A58A8BF0B853}"/>
               </a:ext>
             </a:extLst>
           </p:cNvPr>
@@ -8405,7 +8405,7 @@
           <p:cNvPr id="13" name="">
             <a:extLst xmlns:a="http://schemas.openxmlformats.org/drawingml/2006/main">
               <a:ext uri="{FF2B5EF4-FFF2-40B4-BE49-F238E27FC236}">
-                <a16:creationId xmlns:a16="http://schemas.microsoft.com/office/drawing/2014/main" id="{06F801D2-4EAD-4730-85E5-21C353A6F5C4}"/>
+                <a16:creationId xmlns:a16="http://schemas.microsoft.com/office/drawing/2014/main" id="{C705ABE4-FC24-49CF-8A23-5FFDA2E78B07}"/>
               </a:ext>
             </a:extLst>
           </p:cNvPr>
@@ -8438,7 +8438,7 @@
           <p:cNvPr id="14" name="">
             <a:extLst xmlns:a="http://schemas.openxmlformats.org/drawingml/2006/main">
               <a:ext uri="{FF2B5EF4-FFF2-40B4-BE49-F238E27FC236}">
-                <a16:creationId xmlns:a16="http://schemas.microsoft.com/office/drawing/2014/main" id="{55559FAE-274A-4845-981C-A26C58F7EA9E}"/>
+                <a16:creationId xmlns:a16="http://schemas.microsoft.com/office/drawing/2014/main" id="{2A267CD4-EFA0-4C65-9749-8929C13841A5}"/>
               </a:ext>
             </a:extLst>
           </p:cNvPr>
@@ -8502,7 +8502,7 @@
           <p:cNvPr id="15" name="">
             <a:extLst xmlns:a="http://schemas.openxmlformats.org/drawingml/2006/main">
               <a:ext uri="{FF2B5EF4-FFF2-40B4-BE49-F238E27FC236}">
-                <a16:creationId xmlns:a16="http://schemas.microsoft.com/office/drawing/2014/main" id="{3AD7930F-BD61-4A6C-8A91-0989FBE5C5BD}"/>
+                <a16:creationId xmlns:a16="http://schemas.microsoft.com/office/drawing/2014/main" id="{A276FBFB-2469-43F5-B12E-4F63E6374E3B}"/>
               </a:ext>
             </a:extLst>
           </p:cNvPr>
@@ -8556,7 +8556,7 @@
                 <a:ea typeface="Hiragino Sans"/>
                 <a:cs typeface="Hiragino Sans"/>
               </a:rPr>
-              <a:t>schema・license・run単位・split可能性を source audit で確認</a:t>
+              <a:t>出典、利用条件、実験の分け方を確認してから使う</a:t>
             </a:r>
           </a:p>
         </p:txBody>
@@ -8566,7 +8566,7 @@
           <p:cNvPr id="16" name="">
             <a:extLst xmlns:a="http://schemas.openxmlformats.org/drawingml/2006/main">
               <a:ext uri="{FF2B5EF4-FFF2-40B4-BE49-F238E27FC236}">
-                <a16:creationId xmlns:a16="http://schemas.microsoft.com/office/drawing/2014/main" id="{6B98FB1A-F299-4A23-B7C6-69F6BEC91511}"/>
+                <a16:creationId xmlns:a16="http://schemas.microsoft.com/office/drawing/2014/main" id="{F9384E6B-95E1-4DD2-A1D9-2E50D60EC960}"/>
               </a:ext>
             </a:extLst>
           </p:cNvPr>
@@ -8599,7 +8599,7 @@
           <p:cNvPr id="17" name="">
             <a:extLst xmlns:a="http://schemas.openxmlformats.org/drawingml/2006/main">
               <a:ext uri="{FF2B5EF4-FFF2-40B4-BE49-F238E27FC236}">
-                <a16:creationId xmlns:a16="http://schemas.microsoft.com/office/drawing/2014/main" id="{7BECF188-EF2C-46C9-B752-EB616438E83E}"/>
+                <a16:creationId xmlns:a16="http://schemas.microsoft.com/office/drawing/2014/main" id="{B485649B-C58C-47AC-9939-3307374014F6}"/>
               </a:ext>
             </a:extLst>
           </p:cNvPr>
@@ -8663,7 +8663,7 @@
           <p:cNvPr id="18" name="">
             <a:extLst xmlns:a="http://schemas.openxmlformats.org/drawingml/2006/main">
               <a:ext uri="{FF2B5EF4-FFF2-40B4-BE49-F238E27FC236}">
-                <a16:creationId xmlns:a16="http://schemas.microsoft.com/office/drawing/2014/main" id="{E0B4A1BC-28B7-4438-8171-AE4FF8BE6312}"/>
+                <a16:creationId xmlns:a16="http://schemas.microsoft.com/office/drawing/2014/main" id="{1DE755C2-70DB-473E-B28A-74B7F73A06E2}"/>
               </a:ext>
             </a:extLst>
           </p:cNvPr>
@@ -8696,7 +8696,7 @@
           <p:cNvPr id="19" name="">
             <a:extLst xmlns:a="http://schemas.openxmlformats.org/drawingml/2006/main">
               <a:ext uri="{FF2B5EF4-FFF2-40B4-BE49-F238E27FC236}">
-                <a16:creationId xmlns:a16="http://schemas.microsoft.com/office/drawing/2014/main" id="{3C5646DF-31C8-41FD-BF5A-CDCEFAA1498F}"/>
+                <a16:creationId xmlns:a16="http://schemas.microsoft.com/office/drawing/2014/main" id="{86A7D692-E8AA-4396-A5A9-F0C396E8FB07}"/>
               </a:ext>
             </a:extLst>
           </p:cNvPr>
@@ -8760,7 +8760,7 @@
           <p:cNvPr id="20" name="">
             <a:extLst xmlns:a="http://schemas.openxmlformats.org/drawingml/2006/main">
               <a:ext uri="{FF2B5EF4-FFF2-40B4-BE49-F238E27FC236}">
-                <a16:creationId xmlns:a16="http://schemas.microsoft.com/office/drawing/2014/main" id="{AF4BB64E-1BA3-4A13-9A3A-3B7C0A8358DC}"/>
+                <a16:creationId xmlns:a16="http://schemas.microsoft.com/office/drawing/2014/main" id="{5AC9D8C1-B0B4-4DF3-9ADB-3A5DBF16DCD6}"/>
               </a:ext>
             </a:extLst>
           </p:cNvPr>
@@ -8814,7 +8814,7 @@
                 <a:ea typeface="Hiragino Sans"/>
                 <a:cs typeface="Hiragino Sans"/>
               </a:rPr>
-              <a:t>manifest付き実験、固定split、seed、metrics、verdict</a:t>
+              <a:t>同じ条件で再実行できる実験記録と結果が必要</a:t>
             </a:r>
           </a:p>
         </p:txBody>
@@ -8824,7 +8824,7 @@
           <p:cNvPr id="21" name="">
             <a:extLst xmlns:a="http://schemas.openxmlformats.org/drawingml/2006/main">
               <a:ext uri="{FF2B5EF4-FFF2-40B4-BE49-F238E27FC236}">
-                <a16:creationId xmlns:a16="http://schemas.microsoft.com/office/drawing/2014/main" id="{2D656741-BF9F-46C9-A00A-0A797CD0589C}"/>
+                <a16:creationId xmlns:a16="http://schemas.microsoft.com/office/drawing/2014/main" id="{A545395C-B7D7-4B7F-8367-27BD9FEEBF76}"/>
               </a:ext>
             </a:extLst>
           </p:cNvPr>
@@ -8857,7 +8857,7 @@
           <p:cNvPr id="22" name="">
             <a:extLst xmlns:a="http://schemas.openxmlformats.org/drawingml/2006/main">
               <a:ext uri="{FF2B5EF4-FFF2-40B4-BE49-F238E27FC236}">
-                <a16:creationId xmlns:a16="http://schemas.microsoft.com/office/drawing/2014/main" id="{00F6D72A-F1A6-478C-8A1F-FEA2554C527A}"/>
+                <a16:creationId xmlns:a16="http://schemas.microsoft.com/office/drawing/2014/main" id="{6DA93A08-2372-4B67-8445-78F86B33DF27}"/>
               </a:ext>
             </a:extLst>
           </p:cNvPr>
@@ -8921,7 +8921,7 @@
           <p:cNvPr id="23" name="">
             <a:extLst xmlns:a="http://schemas.openxmlformats.org/drawingml/2006/main">
               <a:ext uri="{FF2B5EF4-FFF2-40B4-BE49-F238E27FC236}">
-                <a16:creationId xmlns:a16="http://schemas.microsoft.com/office/drawing/2014/main" id="{959B418E-83C9-41CD-B1D2-9A0891CCEFF8}"/>
+                <a16:creationId xmlns:a16="http://schemas.microsoft.com/office/drawing/2014/main" id="{2510E1CB-D34D-4FC7-A3A0-A6258E23D8E5}"/>
               </a:ext>
             </a:extLst>
           </p:cNvPr>
@@ -8954,7 +8954,7 @@
           <p:cNvPr id="24" name="">
             <a:extLst xmlns:a="http://schemas.openxmlformats.org/drawingml/2006/main">
               <a:ext uri="{FF2B5EF4-FFF2-40B4-BE49-F238E27FC236}">
-                <a16:creationId xmlns:a16="http://schemas.microsoft.com/office/drawing/2014/main" id="{077535ED-757D-4123-B2A3-11F9BB9A4394}"/>
+                <a16:creationId xmlns:a16="http://schemas.microsoft.com/office/drawing/2014/main" id="{C2EE697E-4655-4DC2-ADD4-B8E36D1519D4}"/>
               </a:ext>
             </a:extLst>
           </p:cNvPr>
@@ -9018,7 +9018,7 @@
           <p:cNvPr id="25" name="">
             <a:extLst xmlns:a="http://schemas.openxmlformats.org/drawingml/2006/main">
               <a:ext uri="{FF2B5EF4-FFF2-40B4-BE49-F238E27FC236}">
-                <a16:creationId xmlns:a16="http://schemas.microsoft.com/office/drawing/2014/main" id="{50499566-41B1-4B8F-947D-943193C0AA17}"/>
+                <a16:creationId xmlns:a16="http://schemas.microsoft.com/office/drawing/2014/main" id="{449C12E3-03F3-4AAC-9E52-AA2FFF72E5DA}"/>
               </a:ext>
             </a:extLst>
           </p:cNvPr>
@@ -9072,7 +9072,7 @@
                 <a:ea typeface="Hiragino Sans"/>
                 <a:cs typeface="Hiragino Sans"/>
               </a:rPr>
-              <a:t>benign workload holdout と false alarms per volume per day</a:t>
+              <a:t>正常業務だけのテストで、1日あたり何回鳴るかを測る</a:t>
             </a:r>
           </a:p>
         </p:txBody>
@@ -9082,7 +9082,7 @@
           <p:cNvPr id="26" name="">
             <a:extLst xmlns:a="http://schemas.openxmlformats.org/drawingml/2006/main">
               <a:ext uri="{FF2B5EF4-FFF2-40B4-BE49-F238E27FC236}">
-                <a16:creationId xmlns:a16="http://schemas.microsoft.com/office/drawing/2014/main" id="{FF9D3276-16BC-4525-8CD3-80590153C7A7}"/>
+                <a16:creationId xmlns:a16="http://schemas.microsoft.com/office/drawing/2014/main" id="{1035ABED-A1D8-4412-8A9C-A5623614DAD7}"/>
               </a:ext>
             </a:extLst>
           </p:cNvPr>
@@ -9115,7 +9115,7 @@
           <p:cNvPr id="27" name="">
             <a:extLst xmlns:a="http://schemas.openxmlformats.org/drawingml/2006/main">
               <a:ext uri="{FF2B5EF4-FFF2-40B4-BE49-F238E27FC236}">
-                <a16:creationId xmlns:a16="http://schemas.microsoft.com/office/drawing/2014/main" id="{2B931587-33E8-4E36-AF85-9C548C458B8D}"/>
+                <a16:creationId xmlns:a16="http://schemas.microsoft.com/office/drawing/2014/main" id="{0ED47D56-9066-4BA6-8600-B0ED0777B3A3}"/>
               </a:ext>
             </a:extLst>
           </p:cNvPr>
@@ -9179,7 +9179,7 @@
           <p:cNvPr id="28" name="">
             <a:extLst xmlns:a="http://schemas.openxmlformats.org/drawingml/2006/main">
               <a:ext uri="{FF2B5EF4-FFF2-40B4-BE49-F238E27FC236}">
-                <a16:creationId xmlns:a16="http://schemas.microsoft.com/office/drawing/2014/main" id="{481A4C2E-1055-471F-B8BD-63678E5CA42C}"/>
+                <a16:creationId xmlns:a16="http://schemas.microsoft.com/office/drawing/2014/main" id="{25956457-17FD-4AA9-A091-0A6FBBD2CF2C}"/>
               </a:ext>
             </a:extLst>
           </p:cNvPr>
@@ -9212,7 +9212,7 @@
           <p:cNvPr id="29" name="">
             <a:extLst xmlns:a="http://schemas.openxmlformats.org/drawingml/2006/main">
               <a:ext uri="{FF2B5EF4-FFF2-40B4-BE49-F238E27FC236}">
-                <a16:creationId xmlns:a16="http://schemas.microsoft.com/office/drawing/2014/main" id="{6BDCC480-FA27-4568-8290-2DCEFC45B726}"/>
+                <a16:creationId xmlns:a16="http://schemas.microsoft.com/office/drawing/2014/main" id="{AB91B950-A4F9-4DF6-BEB7-50BC5A20652B}"/>
               </a:ext>
             </a:extLst>
           </p:cNvPr>
@@ -9276,7 +9276,7 @@
           <p:cNvPr id="30" name="">
             <a:extLst xmlns:a="http://schemas.openxmlformats.org/drawingml/2006/main">
               <a:ext uri="{FF2B5EF4-FFF2-40B4-BE49-F238E27FC236}">
-                <a16:creationId xmlns:a16="http://schemas.microsoft.com/office/drawing/2014/main" id="{AA0A32A7-941E-4202-8C75-9B3195937649}"/>
+                <a16:creationId xmlns:a16="http://schemas.microsoft.com/office/drawing/2014/main" id="{DA1FA5DF-F7A0-480F-89C6-A941C19C4B75}"/>
               </a:ext>
             </a:extLst>
           </p:cNvPr>
@@ -9330,7 +9330,7 @@
                 <a:ea typeface="Hiragino Sans"/>
                 <a:cs typeface="Hiragino Sans"/>
               </a:rPr>
-              <a:t>変換、score parity、detector-data、scratch、2000 volume級CPU/メモリ</a:t>
+              <a:t>変換後の点数一致、1volumeの保存データ、作業メモリ、約2000volumeの処理時間</a:t>
             </a:r>
           </a:p>
         </p:txBody>
@@ -9340,7 +9340,7 @@
           <p:cNvPr id="31" name="">
             <a:extLst xmlns:a="http://schemas.openxmlformats.org/drawingml/2006/main">
               <a:ext uri="{FF2B5EF4-FFF2-40B4-BE49-F238E27FC236}">
-                <a16:creationId xmlns:a16="http://schemas.microsoft.com/office/drawing/2014/main" id="{BA4BA86B-E7E9-49F1-9056-3E2B41A5976F}"/>
+                <a16:creationId xmlns:a16="http://schemas.microsoft.com/office/drawing/2014/main" id="{4D9ACBB4-219C-4A25-976B-4F5E5B5FEC73}"/>
               </a:ext>
             </a:extLst>
           </p:cNvPr>
@@ -9373,7 +9373,7 @@
           <p:cNvPr id="32" name="">
             <a:extLst xmlns:a="http://schemas.openxmlformats.org/drawingml/2006/main">
               <a:ext uri="{FF2B5EF4-FFF2-40B4-BE49-F238E27FC236}">
-                <a16:creationId xmlns:a16="http://schemas.microsoft.com/office/drawing/2014/main" id="{876AE70B-A7A4-4D9E-8244-28983A4C42F0}"/>
+                <a16:creationId xmlns:a16="http://schemas.microsoft.com/office/drawing/2014/main" id="{CB325152-6F2D-4C3C-80CD-4DB8DE5AD4D7}"/>
               </a:ext>
             </a:extLst>
           </p:cNvPr>
@@ -9437,7 +9437,7 @@
           <p:cNvPr id="33" name="">
             <a:extLst xmlns:a="http://schemas.openxmlformats.org/drawingml/2006/main">
               <a:ext uri="{FF2B5EF4-FFF2-40B4-BE49-F238E27FC236}">
-                <a16:creationId xmlns:a16="http://schemas.microsoft.com/office/drawing/2014/main" id="{1028E256-D1D5-411A-B2F2-69352E852B70}"/>
+                <a16:creationId xmlns:a16="http://schemas.microsoft.com/office/drawing/2014/main" id="{D494859B-EDE9-4382-A0E4-5B64C013B899}"/>
               </a:ext>
             </a:extLst>
           </p:cNvPr>
@@ -9472,7 +9472,7 @@
           <p:cNvPr id="34" name="">
             <a:extLst xmlns:a="http://schemas.openxmlformats.org/drawingml/2006/main">
               <a:ext uri="{FF2B5EF4-FFF2-40B4-BE49-F238E27FC236}">
-                <a16:creationId xmlns:a16="http://schemas.microsoft.com/office/drawing/2014/main" id="{1A5C1E70-179B-432D-9A67-2AD588CEEE4C}"/>
+                <a16:creationId xmlns:a16="http://schemas.microsoft.com/office/drawing/2014/main" id="{4F112553-0AC6-4572-838B-E0365DD8DCB6}"/>
               </a:ext>
             </a:extLst>
           </p:cNvPr>
@@ -9536,7 +9536,7 @@
           <p:cNvPr id="35" name="">
             <a:extLst xmlns:a="http://schemas.openxmlformats.org/drawingml/2006/main">
               <a:ext uri="{FF2B5EF4-FFF2-40B4-BE49-F238E27FC236}">
-                <a16:creationId xmlns:a16="http://schemas.microsoft.com/office/drawing/2014/main" id="{0B4344B4-E3CD-4007-A377-7EE2536214AD}"/>
+                <a16:creationId xmlns:a16="http://schemas.microsoft.com/office/drawing/2014/main" id="{7BE70DD4-EEFA-4AD3-B3D0-B03BFF806504}"/>
               </a:ext>
             </a:extLst>
           </p:cNvPr>
@@ -9598,7 +9598,7 @@
     </p:spTree>
     <p:extLst>
       <p:ext uri="{BB962C8B-B14F-4D97-AF65-F5344CB8AC3E}">
-        <p14:creationId xmlns:p14="http://schemas.microsoft.com/office/powerpoint/2010/main" val="444362897"/>
+        <p14:creationId xmlns:p14="http://schemas.microsoft.com/office/powerpoint/2010/main" val="22110402"/>
       </p:ext>
     </p:extLst>
   </p:cSld>
@@ -9622,7 +9622,7 @@
           <p:cNvPr id="1" name="">
             <a:extLst xmlns:a="http://schemas.openxmlformats.org/drawingml/2006/main">
               <a:ext uri="{FF2B5EF4-FFF2-40B4-BE49-F238E27FC236}">
-                <a16:creationId xmlns:a16="http://schemas.microsoft.com/office/drawing/2014/main" id="{A59D3164-7D0C-4044-9DF3-A38F93DDC128}"/>
+                <a16:creationId xmlns:a16="http://schemas.microsoft.com/office/drawing/2014/main" id="{77D012B8-1CFF-4D86-93B3-E9F5E03D19D6}"/>
               </a:ext>
             </a:extLst>
           </p:cNvPr>
@@ -9657,7 +9657,7 @@
           <p:cNvPr id="2" name="">
             <a:extLst xmlns:a="http://schemas.openxmlformats.org/drawingml/2006/main">
               <a:ext uri="{FF2B5EF4-FFF2-40B4-BE49-F238E27FC236}">
-                <a16:creationId xmlns:a16="http://schemas.microsoft.com/office/drawing/2014/main" id="{EEDC8BC4-35AD-4EF5-BC55-DFE6F6AC92B8}"/>
+                <a16:creationId xmlns:a16="http://schemas.microsoft.com/office/drawing/2014/main" id="{53EA35EF-9850-4A81-96BB-FAA17EAEEA5C}"/>
               </a:ext>
             </a:extLst>
           </p:cNvPr>
@@ -9692,7 +9692,7 @@
           <p:cNvPr id="3" name="kicker-marker">
             <a:extLst xmlns:a="http://schemas.openxmlformats.org/drawingml/2006/main">
               <a:ext uri="{FF2B5EF4-FFF2-40B4-BE49-F238E27FC236}">
-                <a16:creationId xmlns:a16="http://schemas.microsoft.com/office/drawing/2014/main" id="{21FA04E1-8875-43A5-94D0-19A746D5E898}"/>
+                <a16:creationId xmlns:a16="http://schemas.microsoft.com/office/drawing/2014/main" id="{C7D4E2AF-7BF7-414E-9C6C-0D7DD3F7BB3E}"/>
               </a:ext>
             </a:extLst>
           </p:cNvPr>
@@ -9727,7 +9727,7 @@
           <p:cNvPr id="4" name="kicker-label">
             <a:extLst xmlns:a="http://schemas.openxmlformats.org/drawingml/2006/main">
               <a:ext uri="{FF2B5EF4-FFF2-40B4-BE49-F238E27FC236}">
-                <a16:creationId xmlns:a16="http://schemas.microsoft.com/office/drawing/2014/main" id="{1721E27A-DE09-4DFD-8EC7-E8EBB401A121}"/>
+                <a16:creationId xmlns:a16="http://schemas.microsoft.com/office/drawing/2014/main" id="{531281DB-497D-4E46-9B03-035BE2E7A8A5}"/>
               </a:ext>
             </a:extLst>
           </p:cNvPr>
@@ -9791,7 +9791,7 @@
           <p:cNvPr id="5" name="">
             <a:extLst xmlns:a="http://schemas.openxmlformats.org/drawingml/2006/main">
               <a:ext uri="{FF2B5EF4-FFF2-40B4-BE49-F238E27FC236}">
-                <a16:creationId xmlns:a16="http://schemas.microsoft.com/office/drawing/2014/main" id="{E88AB755-0838-4112-86A6-E962C6396DA6}"/>
+                <a16:creationId xmlns:a16="http://schemas.microsoft.com/office/drawing/2014/main" id="{680CE566-1099-4E96-BDFF-8E2AE77F985E}"/>
               </a:ext>
             </a:extLst>
           </p:cNvPr>
@@ -9855,7 +9855,7 @@
           <p:cNvPr id="6" name="">
             <a:extLst xmlns:a="http://schemas.openxmlformats.org/drawingml/2006/main">
               <a:ext uri="{FF2B5EF4-FFF2-40B4-BE49-F238E27FC236}">
-                <a16:creationId xmlns:a16="http://schemas.microsoft.com/office/drawing/2014/main" id="{1163389A-8E4F-4646-98BB-6FDE4A26DB6A}"/>
+                <a16:creationId xmlns:a16="http://schemas.microsoft.com/office/drawing/2014/main" id="{82477A23-8449-49D8-AF28-F66762428FE1}"/>
               </a:ext>
             </a:extLst>
           </p:cNvPr>
@@ -9919,7 +9919,7 @@
           <p:cNvPr id="7" name="">
             <a:extLst xmlns:a="http://schemas.openxmlformats.org/drawingml/2006/main">
               <a:ext uri="{FF2B5EF4-FFF2-40B4-BE49-F238E27FC236}">
-                <a16:creationId xmlns:a16="http://schemas.microsoft.com/office/drawing/2014/main" id="{4B7969AD-B7D0-40CA-85A7-27B3D9697D1C}"/>
+                <a16:creationId xmlns:a16="http://schemas.microsoft.com/office/drawing/2014/main" id="{F8995E91-D026-43EA-BF34-AD97EFF5BB37}"/>
               </a:ext>
             </a:extLst>
           </p:cNvPr>
@@ -9952,7 +9952,7 @@
           <p:cNvPr id="8" name="">
             <a:extLst xmlns:a="http://schemas.openxmlformats.org/drawingml/2006/main">
               <a:ext uri="{FF2B5EF4-FFF2-40B4-BE49-F238E27FC236}">
-                <a16:creationId xmlns:a16="http://schemas.microsoft.com/office/drawing/2014/main" id="{81296018-2E01-4775-904A-53C940A72446}"/>
+                <a16:creationId xmlns:a16="http://schemas.microsoft.com/office/drawing/2014/main" id="{AF336D4A-10B6-43B6-A2F3-05381EBC19E4}"/>
               </a:ext>
             </a:extLst>
           </p:cNvPr>
@@ -10029,7 +10029,7 @@
                 <a:ea typeface="Hiragino Sans"/>
                 <a:cs typeface="Hiragino Sans"/>
               </a:rPr>
-              <a:t>データ監査と抽出器</a:t>
+              <a:t>データは使えるか</a:t>
             </a:r>
           </a:p>
         </p:txBody>
@@ -10039,7 +10039,7 @@
           <p:cNvPr id="9" name="">
             <a:extLst xmlns:a="http://schemas.openxmlformats.org/drawingml/2006/main">
               <a:ext uri="{FF2B5EF4-FFF2-40B4-BE49-F238E27FC236}">
-                <a16:creationId xmlns:a16="http://schemas.microsoft.com/office/drawing/2014/main" id="{928A190D-6309-4C5E-AC55-7AFC37F15DAA}"/>
+                <a16:creationId xmlns:a16="http://schemas.microsoft.com/office/drawing/2014/main" id="{98BF00C3-32A5-4019-BA92-6EAD5B780943}"/>
               </a:ext>
             </a:extLst>
           </p:cNvPr>
@@ -10075,7 +10075,7 @@
           <a:lstStyle xmlns:a="http://schemas.openxmlformats.org/drawingml/2006/main"/>
           <a:p xmlns:a="http://schemas.openxmlformats.org/drawingml/2006/main">
             <a:pPr algn="l">
-              <a:defRPr sz="863" b="0">
+              <a:defRPr sz="900" b="0">
                 <a:solidFill>
                   <a:srgbClr val="64748B"/>
                 </a:solidFill>
@@ -10085,7 +10085,7 @@
               </a:defRPr>
             </a:pPr>
             <a:r>
-              <a:rPr sz="863" b="0">
+              <a:rPr sz="900" b="0">
                 <a:solidFill>
                   <a:srgbClr val="64748B"/>
                 </a:solidFill>
@@ -10093,7 +10093,7 @@
                 <a:ea typeface="Hiragino Sans"/>
                 <a:cs typeface="Hiragino Sans"/>
               </a:rPr>
-              <a:t>RanSAP/RanSMAP のschemaとlicenseを確認し、10秒統計を固定</a:t>
+              <a:t>schema・license・split単位を確認し、10秒統計を固定</a:t>
             </a:r>
           </a:p>
         </p:txBody>
@@ -10103,7 +10103,7 @@
           <p:cNvPr id="10" name="">
             <a:extLst xmlns:a="http://schemas.openxmlformats.org/drawingml/2006/main">
               <a:ext uri="{FF2B5EF4-FFF2-40B4-BE49-F238E27FC236}">
-                <a16:creationId xmlns:a16="http://schemas.microsoft.com/office/drawing/2014/main" id="{D8C0CF74-EA45-4F1D-A920-13F8A3F6A201}"/>
+                <a16:creationId xmlns:a16="http://schemas.microsoft.com/office/drawing/2014/main" id="{3119D6DD-2FBF-49F7-A608-88011DF5869A}"/>
               </a:ext>
             </a:extLst>
           </p:cNvPr>
@@ -10138,7 +10138,7 @@
           <p:cNvPr id="11" name="">
             <a:extLst xmlns:a="http://schemas.openxmlformats.org/drawingml/2006/main">
               <a:ext uri="{FF2B5EF4-FFF2-40B4-BE49-F238E27FC236}">
-                <a16:creationId xmlns:a16="http://schemas.microsoft.com/office/drawing/2014/main" id="{62A12E5C-C123-4617-B2E3-2BC708B14CF1}"/>
+                <a16:creationId xmlns:a16="http://schemas.microsoft.com/office/drawing/2014/main" id="{4869C647-6391-48F7-AEE3-FBF710F70DE9}"/>
               </a:ext>
             </a:extLst>
           </p:cNvPr>
@@ -10202,7 +10202,7 @@
           <p:cNvPr id="12" name="">
             <a:extLst xmlns:a="http://schemas.openxmlformats.org/drawingml/2006/main">
               <a:ext uri="{FF2B5EF4-FFF2-40B4-BE49-F238E27FC236}">
-                <a16:creationId xmlns:a16="http://schemas.microsoft.com/office/drawing/2014/main" id="{2EC101C9-DA64-4049-B163-ADACC327CD85}"/>
+                <a16:creationId xmlns:a16="http://schemas.microsoft.com/office/drawing/2014/main" id="{EA724E42-8FE2-436D-AAC1-AF457EF182FA}"/>
               </a:ext>
             </a:extLst>
           </p:cNvPr>
@@ -10235,7 +10235,7 @@
           <p:cNvPr id="13" name="">
             <a:extLst xmlns:a="http://schemas.openxmlformats.org/drawingml/2006/main">
               <a:ext uri="{FF2B5EF4-FFF2-40B4-BE49-F238E27FC236}">
-                <a16:creationId xmlns:a16="http://schemas.microsoft.com/office/drawing/2014/main" id="{616AEB0D-22D0-4839-97F4-C11E47F341A0}"/>
+                <a16:creationId xmlns:a16="http://schemas.microsoft.com/office/drawing/2014/main" id="{922CA793-2183-4DEF-AD35-9C489BA99F5C}"/>
               </a:ext>
             </a:extLst>
           </p:cNvPr>
@@ -10312,7 +10312,7 @@
                 <a:ea typeface="Hiragino Sans"/>
                 <a:cs typeface="Hiragino Sans"/>
               </a:rPr>
-              <a:t>baselineとAE比較</a:t>
+              <a:t>早期警告は有望か</a:t>
             </a:r>
           </a:p>
         </p:txBody>
@@ -10322,7 +10322,7 @@
           <p:cNvPr id="14" name="">
             <a:extLst xmlns:a="http://schemas.openxmlformats.org/drawingml/2006/main">
               <a:ext uri="{FF2B5EF4-FFF2-40B4-BE49-F238E27FC236}">
-                <a16:creationId xmlns:a16="http://schemas.microsoft.com/office/drawing/2014/main" id="{C3A5185F-3552-4676-8D70-616185C0F65A}"/>
+                <a16:creationId xmlns:a16="http://schemas.microsoft.com/office/drawing/2014/main" id="{7510AF0E-3D65-454C-A349-0C09AF152ADA}"/>
               </a:ext>
             </a:extLst>
           </p:cNvPr>
@@ -10358,7 +10358,7 @@
           <a:lstStyle xmlns:a="http://schemas.openxmlformats.org/drawingml/2006/main"/>
           <a:p xmlns:a="http://schemas.openxmlformats.org/drawingml/2006/main">
             <a:pPr algn="l">
-              <a:defRPr sz="863" b="0">
+              <a:defRPr sz="900" b="0">
                 <a:solidFill>
                   <a:srgbClr val="64748B"/>
                 </a:solidFill>
@@ -10368,7 +10368,7 @@
               </a:defRPr>
             </a:pPr>
             <a:r>
-              <a:rPr sz="863" b="0">
+              <a:rPr sz="900" b="0">
                 <a:solidFill>
                   <a:srgbClr val="64748B"/>
                 </a:solidFill>
@@ -10376,7 +10376,7 @@
                 <a:ea typeface="Hiragino Sans"/>
                 <a:cs typeface="Hiragino Sans"/>
               </a:rPr>
-              <a:t>単純write/entropy規則、古典的異常検出、小型AEを同じsplitで比較</a:t>
+              <a:t>単純規則・古典的異常検出・小型AEを同じ分け方で比較</a:t>
             </a:r>
           </a:p>
         </p:txBody>
@@ -10386,7 +10386,7 @@
           <p:cNvPr id="15" name="">
             <a:extLst xmlns:a="http://schemas.openxmlformats.org/drawingml/2006/main">
               <a:ext uri="{FF2B5EF4-FFF2-40B4-BE49-F238E27FC236}">
-                <a16:creationId xmlns:a16="http://schemas.microsoft.com/office/drawing/2014/main" id="{0F8D8E19-CA30-4C0C-BD77-D96EABD8A016}"/>
+                <a16:creationId xmlns:a16="http://schemas.microsoft.com/office/drawing/2014/main" id="{EE468758-E643-4930-BAF6-2C5AAF082440}"/>
               </a:ext>
             </a:extLst>
           </p:cNvPr>
@@ -10421,7 +10421,7 @@
           <p:cNvPr id="16" name="">
             <a:extLst xmlns:a="http://schemas.openxmlformats.org/drawingml/2006/main">
               <a:ext uri="{FF2B5EF4-FFF2-40B4-BE49-F238E27FC236}">
-                <a16:creationId xmlns:a16="http://schemas.microsoft.com/office/drawing/2014/main" id="{F15D540E-4DE4-48E2-B4E6-4623062F7C86}"/>
+                <a16:creationId xmlns:a16="http://schemas.microsoft.com/office/drawing/2014/main" id="{A1B77EDD-7B8F-4D6C-81B0-EBE0D50FD503}"/>
               </a:ext>
             </a:extLst>
           </p:cNvPr>
@@ -10485,7 +10485,7 @@
           <p:cNvPr id="17" name="">
             <a:extLst xmlns:a="http://schemas.openxmlformats.org/drawingml/2006/main">
               <a:ext uri="{FF2B5EF4-FFF2-40B4-BE49-F238E27FC236}">
-                <a16:creationId xmlns:a16="http://schemas.microsoft.com/office/drawing/2014/main" id="{EED67CA8-3614-42D0-9992-CFB9EDD1ABDA}"/>
+                <a16:creationId xmlns:a16="http://schemas.microsoft.com/office/drawing/2014/main" id="{72C5849A-8C00-4E00-AA25-CE0E3ED3CFE9}"/>
               </a:ext>
             </a:extLst>
           </p:cNvPr>
@@ -10518,7 +10518,7 @@
           <p:cNvPr id="18" name="">
             <a:extLst xmlns:a="http://schemas.openxmlformats.org/drawingml/2006/main">
               <a:ext uri="{FF2B5EF4-FFF2-40B4-BE49-F238E27FC236}">
-                <a16:creationId xmlns:a16="http://schemas.microsoft.com/office/drawing/2014/main" id="{F0C2B5A1-425A-4523-B40A-DA286F0B3E68}"/>
+                <a16:creationId xmlns:a16="http://schemas.microsoft.com/office/drawing/2014/main" id="{044B2F90-9816-4083-9342-873C4D52B553}"/>
               </a:ext>
             </a:extLst>
           </p:cNvPr>
@@ -10595,7 +10595,7 @@
                 <a:ea typeface="Hiragino Sans"/>
                 <a:cs typeface="Hiragino Sans"/>
               </a:rPr>
-              <a:t>MNNと多数volume</a:t>
+              <a:t>装置に載る見込みはあるか</a:t>
             </a:r>
           </a:p>
         </p:txBody>
@@ -10605,7 +10605,7 @@
           <p:cNvPr id="19" name="">
             <a:extLst xmlns:a="http://schemas.openxmlformats.org/drawingml/2006/main">
               <a:ext uri="{FF2B5EF4-FFF2-40B4-BE49-F238E27FC236}">
-                <a16:creationId xmlns:a16="http://schemas.microsoft.com/office/drawing/2014/main" id="{49DDD6D2-BEE9-45F0-A777-557C6CFEC9C5}"/>
+                <a16:creationId xmlns:a16="http://schemas.microsoft.com/office/drawing/2014/main" id="{929E7713-C4D7-42D3-84DB-6368E0068C1C}"/>
               </a:ext>
             </a:extLst>
           </p:cNvPr>
@@ -10641,9 +10641,271 @@
           <a:lstStyle xmlns:a="http://schemas.openxmlformats.org/drawingml/2006/main"/>
           <a:p xmlns:a="http://schemas.openxmlformats.org/drawingml/2006/main">
             <a:pPr algn="l">
+              <a:defRPr sz="900" b="0">
+                <a:solidFill>
+                  <a:srgbClr val="64748B"/>
+                </a:solidFill>
+                <a:latin typeface="Hiragino Sans"/>
+                <a:ea typeface="Hiragino Sans"/>
+                <a:cs typeface="Hiragino Sans"/>
+              </a:defRPr>
+            </a:pPr>
+            <a:r>
+              <a:rPr sz="900" b="0">
+                <a:solidFill>
+                  <a:srgbClr val="64748B"/>
+                </a:solidFill>
+                <a:latin typeface="Hiragino Sans"/>
+                <a:ea typeface="Hiragino Sans"/>
+                <a:cs typeface="Hiragino Sans"/>
+              </a:rPr>
+              <a:t>MNN・500 KB・多数volumeのfeasibility audit。失敗も結論</a:t>
+            </a:r>
+          </a:p>
+        </p:txBody>
+      </p:sp>
+      <p:sp>
+        <p:nvSpPr>
+          <p:cNvPr id="20" name="">
+            <a:extLst xmlns:a="http://schemas.openxmlformats.org/drawingml/2006/main">
+              <a:ext uri="{FF2B5EF4-FFF2-40B4-BE49-F238E27FC236}">
+                <a16:creationId xmlns:a16="http://schemas.microsoft.com/office/drawing/2014/main" id="{F9D02B84-CBC6-4544-9F7D-52D461B629DD}"/>
+              </a:ext>
+            </a:extLst>
+          </p:cNvPr>
+          <p:cNvSpPr>
+            <a:spLocks xmlns:a="http://schemas.openxmlformats.org/drawingml/2006/main" noGrp="1"/>
+          </p:cNvSpPr>
+          <p:nvPr/>
+        </p:nvSpPr>
+        <p:spPr>
+          <a:xfrm xmlns:a="http://schemas.openxmlformats.org/drawingml/2006/main">
+            <a:off x="685800" y="4591050"/>
+            <a:ext cx="10248900" cy="952500"/>
+          </a:xfrm>
+          <a:prstGeom xmlns:a="http://schemas.openxmlformats.org/drawingml/2006/main" prst="rect">
+            <a:avLst/>
+          </a:prstGeom>
+          <a:solidFill xmlns:a="http://schemas.openxmlformats.org/drawingml/2006/main">
+            <a:srgbClr val="1F2937"/>
+          </a:solidFill>
+          <a:ln xmlns:a="http://schemas.openxmlformats.org/drawingml/2006/main" w="0">
+            <a:solidFill>
+              <a:srgbClr val="000000">
+                <a:alpha val="0"/>
+              </a:srgbClr>
+            </a:solidFill>
+            <a:prstDash val="solid"/>
+          </a:ln>
+        </p:spPr>
+      </p:sp>
+      <p:sp>
+        <p:nvSpPr>
+          <p:cNvPr id="21" name="">
+            <a:extLst xmlns:a="http://schemas.openxmlformats.org/drawingml/2006/main">
+              <a:ext uri="{FF2B5EF4-FFF2-40B4-BE49-F238E27FC236}">
+                <a16:creationId xmlns:a16="http://schemas.microsoft.com/office/drawing/2014/main" id="{22A5160D-3470-4863-89B3-D6866ADA5B62}"/>
+              </a:ext>
+            </a:extLst>
+          </p:cNvPr>
+          <p:cNvSpPr>
+            <a:spLocks xmlns:a="http://schemas.openxmlformats.org/drawingml/2006/main" noGrp="1"/>
+          </p:cNvSpPr>
+          <p:nvPr/>
+        </p:nvSpPr>
+        <p:spPr>
+          <a:xfrm xmlns:a="http://schemas.openxmlformats.org/drawingml/2006/main">
+            <a:off x="971550" y="4791075"/>
+            <a:ext cx="1333500" cy="228600"/>
+          </a:xfrm>
+          <a:prstGeom xmlns:a="http://schemas.openxmlformats.org/drawingml/2006/main" prst="rect">
+            <a:avLst/>
+          </a:prstGeom>
+          <a:solidFill xmlns:a="http://schemas.openxmlformats.org/drawingml/2006/main">
+            <a:srgbClr val="000000">
+              <a:alpha val="0"/>
+            </a:srgbClr>
+          </a:solidFill>
+          <a:ln xmlns:a="http://schemas.openxmlformats.org/drawingml/2006/main" w="0">
+            <a:solidFill>
+              <a:srgbClr val="000000">
+                <a:alpha val="0"/>
+              </a:srgbClr>
+            </a:solidFill>
+            <a:prstDash val="solid"/>
+          </a:ln>
+        </p:spPr>
+        <p:txBody>
+          <a:bodyPr xmlns:a="http://schemas.openxmlformats.org/drawingml/2006/main" lIns="0" tIns="0" rIns="0" bIns="0" anchor="t"/>
+          <a:lstStyle xmlns:a="http://schemas.openxmlformats.org/drawingml/2006/main"/>
+          <a:p xmlns:a="http://schemas.openxmlformats.org/drawingml/2006/main">
+            <a:pPr algn="l">
+              <a:defRPr sz="1275" b="1">
+                <a:solidFill>
+                  <a:srgbClr val="FFFFFF"/>
+                </a:solidFill>
+                <a:latin typeface="Hiragino Sans"/>
+                <a:ea typeface="Hiragino Sans"/>
+                <a:cs typeface="Hiragino Sans"/>
+              </a:defRPr>
+            </a:pPr>
+            <a:r>
+              <a:rPr sz="1275" b="1">
+                <a:solidFill>
+                  <a:srgbClr val="FFFFFF"/>
+                </a:solidFill>
+                <a:latin typeface="Hiragino Sans"/>
+                <a:ea typeface="Hiragino Sans"/>
+                <a:cs typeface="Hiragino Sans"/>
+              </a:rPr>
+              <a:t>社会的意義</a:t>
+            </a:r>
+          </a:p>
+        </p:txBody>
+      </p:sp>
+      <p:sp>
+        <p:nvSpPr>
+          <p:cNvPr id="22" name="">
+            <a:extLst xmlns:a="http://schemas.openxmlformats.org/drawingml/2006/main">
+              <a:ext uri="{FF2B5EF4-FFF2-40B4-BE49-F238E27FC236}">
+                <a16:creationId xmlns:a16="http://schemas.microsoft.com/office/drawing/2014/main" id="{C568F1F2-14F8-41A6-B08F-F96FB7CC9064}"/>
+              </a:ext>
+            </a:extLst>
+          </p:cNvPr>
+          <p:cNvSpPr>
+            <a:spLocks xmlns:a="http://schemas.openxmlformats.org/drawingml/2006/main" noGrp="1"/>
+          </p:cNvSpPr>
+          <p:nvPr/>
+        </p:nvSpPr>
+        <p:spPr>
+          <a:xfrm xmlns:a="http://schemas.openxmlformats.org/drawingml/2006/main">
+            <a:off x="2362200" y="4781550"/>
+            <a:ext cx="7810500" cy="247650"/>
+          </a:xfrm>
+          <a:prstGeom xmlns:a="http://schemas.openxmlformats.org/drawingml/2006/main" prst="rect">
+            <a:avLst/>
+          </a:prstGeom>
+          <a:solidFill xmlns:a="http://schemas.openxmlformats.org/drawingml/2006/main">
+            <a:srgbClr val="000000">
+              <a:alpha val="0"/>
+            </a:srgbClr>
+          </a:solidFill>
+          <a:ln xmlns:a="http://schemas.openxmlformats.org/drawingml/2006/main" w="0">
+            <a:solidFill>
+              <a:srgbClr val="000000">
+                <a:alpha val="0"/>
+              </a:srgbClr>
+            </a:solidFill>
+            <a:prstDash val="solid"/>
+          </a:ln>
+        </p:spPr>
+        <p:txBody>
+          <a:bodyPr xmlns:a="http://schemas.openxmlformats.org/drawingml/2006/main" lIns="0" tIns="0" rIns="0" bIns="0" anchor="t"/>
+          <a:lstStyle xmlns:a="http://schemas.openxmlformats.org/drawingml/2006/main"/>
+          <a:p xmlns:a="http://schemas.openxmlformats.org/drawingml/2006/main">
+            <a:pPr algn="l">
+              <a:defRPr sz="1238" b="1">
+                <a:solidFill>
+                  <a:srgbClr val="FFFFFF"/>
+                </a:solidFill>
+                <a:latin typeface="Hiragino Sans"/>
+                <a:ea typeface="Hiragino Sans"/>
+                <a:cs typeface="Hiragino Sans"/>
+              </a:defRPr>
+            </a:pPr>
+            <a:r>
+              <a:rPr sz="1238" b="1">
+                <a:solidFill>
+                  <a:srgbClr val="FFFFFF"/>
+                </a:solidFill>
+                <a:latin typeface="Hiragino Sans"/>
+                <a:ea typeface="Hiragino Sans"/>
+                <a:cs typeface="Hiragino Sans"/>
+              </a:rPr>
+              <a:t>早期に気づける可能性を、病院・行政・企業の停止時間短縮につながる「実装条件付きの証拠」に変える。</a:t>
+            </a:r>
+          </a:p>
+        </p:txBody>
+      </p:sp>
+      <p:sp>
+        <p:nvSpPr>
+          <p:cNvPr id="23" name="">
+            <a:extLst xmlns:a="http://schemas.openxmlformats.org/drawingml/2006/main">
+              <a:ext uri="{FF2B5EF4-FFF2-40B4-BE49-F238E27FC236}">
+                <a16:creationId xmlns:a16="http://schemas.microsoft.com/office/drawing/2014/main" id="{E4590B46-42C2-41E3-AA2E-C7BEC509C43F}"/>
+              </a:ext>
+            </a:extLst>
+          </p:cNvPr>
+          <p:cNvSpPr>
+            <a:spLocks xmlns:a="http://schemas.openxmlformats.org/drawingml/2006/main" noGrp="1"/>
+          </p:cNvSpPr>
+          <p:nvPr/>
+        </p:nvSpPr>
+        <p:spPr>
+          <a:xfrm xmlns:a="http://schemas.openxmlformats.org/drawingml/2006/main">
+            <a:off x="2362200" y="5162550"/>
+            <a:ext cx="7524750" cy="9525"/>
+          </a:xfrm>
+          <a:prstGeom xmlns:a="http://schemas.openxmlformats.org/drawingml/2006/main" prst="rect">
+            <a:avLst/>
+          </a:prstGeom>
+          <a:solidFill xmlns:a="http://schemas.openxmlformats.org/drawingml/2006/main">
+            <a:srgbClr val="94A3B8"/>
+          </a:solidFill>
+          <a:ln xmlns:a="http://schemas.openxmlformats.org/drawingml/2006/main" w="0">
+            <a:solidFill>
+              <a:srgbClr val="000000">
+                <a:alpha val="0"/>
+              </a:srgbClr>
+            </a:solidFill>
+            <a:prstDash val="solid"/>
+          </a:ln>
+        </p:spPr>
+      </p:sp>
+      <p:sp>
+        <p:nvSpPr>
+          <p:cNvPr id="24" name="">
+            <a:extLst xmlns:a="http://schemas.openxmlformats.org/drawingml/2006/main">
+              <a:ext uri="{FF2B5EF4-FFF2-40B4-BE49-F238E27FC236}">
+                <a16:creationId xmlns:a16="http://schemas.microsoft.com/office/drawing/2014/main" id="{49EA9A6E-2798-4997-9972-F224E95C5FEB}"/>
+              </a:ext>
+            </a:extLst>
+          </p:cNvPr>
+          <p:cNvSpPr>
+            <a:spLocks xmlns:a="http://schemas.openxmlformats.org/drawingml/2006/main" noGrp="1"/>
+          </p:cNvSpPr>
+          <p:nvPr/>
+        </p:nvSpPr>
+        <p:spPr>
+          <a:xfrm xmlns:a="http://schemas.openxmlformats.org/drawingml/2006/main">
+            <a:off x="2362200" y="5200650"/>
+            <a:ext cx="7810500" cy="171450"/>
+          </a:xfrm>
+          <a:prstGeom xmlns:a="http://schemas.openxmlformats.org/drawingml/2006/main" prst="rect">
+            <a:avLst/>
+          </a:prstGeom>
+          <a:solidFill xmlns:a="http://schemas.openxmlformats.org/drawingml/2006/main">
+            <a:srgbClr val="000000">
+              <a:alpha val="0"/>
+            </a:srgbClr>
+          </a:solidFill>
+          <a:ln xmlns:a="http://schemas.openxmlformats.org/drawingml/2006/main" w="0">
+            <a:solidFill>
+              <a:srgbClr val="000000">
+                <a:alpha val="0"/>
+              </a:srgbClr>
+            </a:solidFill>
+            <a:prstDash val="solid"/>
+          </a:ln>
+        </p:spPr>
+        <p:txBody>
+          <a:bodyPr xmlns:a="http://schemas.openxmlformats.org/drawingml/2006/main" lIns="0" tIns="0" rIns="0" bIns="0" anchor="t"/>
+          <a:lstStyle xmlns:a="http://schemas.openxmlformats.org/drawingml/2006/main"/>
+          <a:p xmlns:a="http://schemas.openxmlformats.org/drawingml/2006/main">
+            <a:pPr algn="l">
               <a:defRPr sz="863" b="0">
                 <a:solidFill>
-                  <a:srgbClr val="64748B"/>
+                  <a:srgbClr val="E5E7EB"/>
                 </a:solidFill>
                 <a:latin typeface="Hiragino Sans"/>
                 <a:ea typeface="Hiragino Sans"/>
@@ -10653,268 +10915,6 @@
             <a:r>
               <a:rPr sz="863" b="0">
                 <a:solidFill>
-                  <a:srgbClr val="64748B"/>
-                </a:solidFill>
-                <a:latin typeface="Hiragino Sans"/>
-                <a:ea typeface="Hiragino Sans"/>
-                <a:cs typeface="Hiragino Sans"/>
-              </a:rPr>
-              <a:t>score parity、500 KB/volume、scratch、約2000 volumeのCPU/メモリ</a:t>
-            </a:r>
-          </a:p>
-        </p:txBody>
-      </p:sp>
-      <p:sp>
-        <p:nvSpPr>
-          <p:cNvPr id="20" name="">
-            <a:extLst xmlns:a="http://schemas.openxmlformats.org/drawingml/2006/main">
-              <a:ext uri="{FF2B5EF4-FFF2-40B4-BE49-F238E27FC236}">
-                <a16:creationId xmlns:a16="http://schemas.microsoft.com/office/drawing/2014/main" id="{D022FFE4-D44C-46A2-BB3D-61C77DE07247}"/>
-              </a:ext>
-            </a:extLst>
-          </p:cNvPr>
-          <p:cNvSpPr>
-            <a:spLocks xmlns:a="http://schemas.openxmlformats.org/drawingml/2006/main" noGrp="1"/>
-          </p:cNvSpPr>
-          <p:nvPr/>
-        </p:nvSpPr>
-        <p:spPr>
-          <a:xfrm xmlns:a="http://schemas.openxmlformats.org/drawingml/2006/main">
-            <a:off x="685800" y="4591050"/>
-            <a:ext cx="10248900" cy="952500"/>
-          </a:xfrm>
-          <a:prstGeom xmlns:a="http://schemas.openxmlformats.org/drawingml/2006/main" prst="rect">
-            <a:avLst/>
-          </a:prstGeom>
-          <a:solidFill xmlns:a="http://schemas.openxmlformats.org/drawingml/2006/main">
-            <a:srgbClr val="1F2937"/>
-          </a:solidFill>
-          <a:ln xmlns:a="http://schemas.openxmlformats.org/drawingml/2006/main" w="0">
-            <a:solidFill>
-              <a:srgbClr val="000000">
-                <a:alpha val="0"/>
-              </a:srgbClr>
-            </a:solidFill>
-            <a:prstDash val="solid"/>
-          </a:ln>
-        </p:spPr>
-      </p:sp>
-      <p:sp>
-        <p:nvSpPr>
-          <p:cNvPr id="21" name="">
-            <a:extLst xmlns:a="http://schemas.openxmlformats.org/drawingml/2006/main">
-              <a:ext uri="{FF2B5EF4-FFF2-40B4-BE49-F238E27FC236}">
-                <a16:creationId xmlns:a16="http://schemas.microsoft.com/office/drawing/2014/main" id="{F0E36831-88D4-4C00-8D68-2C0DD4D118DF}"/>
-              </a:ext>
-            </a:extLst>
-          </p:cNvPr>
-          <p:cNvSpPr>
-            <a:spLocks xmlns:a="http://schemas.openxmlformats.org/drawingml/2006/main" noGrp="1"/>
-          </p:cNvSpPr>
-          <p:nvPr/>
-        </p:nvSpPr>
-        <p:spPr>
-          <a:xfrm xmlns:a="http://schemas.openxmlformats.org/drawingml/2006/main">
-            <a:off x="971550" y="4791075"/>
-            <a:ext cx="1333500" cy="228600"/>
-          </a:xfrm>
-          <a:prstGeom xmlns:a="http://schemas.openxmlformats.org/drawingml/2006/main" prst="rect">
-            <a:avLst/>
-          </a:prstGeom>
-          <a:solidFill xmlns:a="http://schemas.openxmlformats.org/drawingml/2006/main">
-            <a:srgbClr val="000000">
-              <a:alpha val="0"/>
-            </a:srgbClr>
-          </a:solidFill>
-          <a:ln xmlns:a="http://schemas.openxmlformats.org/drawingml/2006/main" w="0">
-            <a:solidFill>
-              <a:srgbClr val="000000">
-                <a:alpha val="0"/>
-              </a:srgbClr>
-            </a:solidFill>
-            <a:prstDash val="solid"/>
-          </a:ln>
-        </p:spPr>
-        <p:txBody>
-          <a:bodyPr xmlns:a="http://schemas.openxmlformats.org/drawingml/2006/main" lIns="0" tIns="0" rIns="0" bIns="0" anchor="t"/>
-          <a:lstStyle xmlns:a="http://schemas.openxmlformats.org/drawingml/2006/main"/>
-          <a:p xmlns:a="http://schemas.openxmlformats.org/drawingml/2006/main">
-            <a:pPr algn="l">
-              <a:defRPr sz="1275" b="1">
-                <a:solidFill>
-                  <a:srgbClr val="FFFFFF"/>
-                </a:solidFill>
-                <a:latin typeface="Hiragino Sans"/>
-                <a:ea typeface="Hiragino Sans"/>
-                <a:cs typeface="Hiragino Sans"/>
-              </a:defRPr>
-            </a:pPr>
-            <a:r>
-              <a:rPr sz="1275" b="1">
-                <a:solidFill>
-                  <a:srgbClr val="FFFFFF"/>
-                </a:solidFill>
-                <a:latin typeface="Hiragino Sans"/>
-                <a:ea typeface="Hiragino Sans"/>
-                <a:cs typeface="Hiragino Sans"/>
-              </a:rPr>
-              <a:t>社会的意義</a:t>
-            </a:r>
-          </a:p>
-        </p:txBody>
-      </p:sp>
-      <p:sp>
-        <p:nvSpPr>
-          <p:cNvPr id="22" name="">
-            <a:extLst xmlns:a="http://schemas.openxmlformats.org/drawingml/2006/main">
-              <a:ext uri="{FF2B5EF4-FFF2-40B4-BE49-F238E27FC236}">
-                <a16:creationId xmlns:a16="http://schemas.microsoft.com/office/drawing/2014/main" id="{1CA72ED1-08ED-479A-A51F-A3FA49BE24B5}"/>
-              </a:ext>
-            </a:extLst>
-          </p:cNvPr>
-          <p:cNvSpPr>
-            <a:spLocks xmlns:a="http://schemas.openxmlformats.org/drawingml/2006/main" noGrp="1"/>
-          </p:cNvSpPr>
-          <p:nvPr/>
-        </p:nvSpPr>
-        <p:spPr>
-          <a:xfrm xmlns:a="http://schemas.openxmlformats.org/drawingml/2006/main">
-            <a:off x="2362200" y="4781550"/>
-            <a:ext cx="7810500" cy="247650"/>
-          </a:xfrm>
-          <a:prstGeom xmlns:a="http://schemas.openxmlformats.org/drawingml/2006/main" prst="rect">
-            <a:avLst/>
-          </a:prstGeom>
-          <a:solidFill xmlns:a="http://schemas.openxmlformats.org/drawingml/2006/main">
-            <a:srgbClr val="000000">
-              <a:alpha val="0"/>
-            </a:srgbClr>
-          </a:solidFill>
-          <a:ln xmlns:a="http://schemas.openxmlformats.org/drawingml/2006/main" w="0">
-            <a:solidFill>
-              <a:srgbClr val="000000">
-                <a:alpha val="0"/>
-              </a:srgbClr>
-            </a:solidFill>
-            <a:prstDash val="solid"/>
-          </a:ln>
-        </p:spPr>
-        <p:txBody>
-          <a:bodyPr xmlns:a="http://schemas.openxmlformats.org/drawingml/2006/main" lIns="0" tIns="0" rIns="0" bIns="0" anchor="t"/>
-          <a:lstStyle xmlns:a="http://schemas.openxmlformats.org/drawingml/2006/main"/>
-          <a:p xmlns:a="http://schemas.openxmlformats.org/drawingml/2006/main">
-            <a:pPr algn="l">
-              <a:defRPr sz="1238" b="1">
-                <a:solidFill>
-                  <a:srgbClr val="FFFFFF"/>
-                </a:solidFill>
-                <a:latin typeface="Hiragino Sans"/>
-                <a:ea typeface="Hiragino Sans"/>
-                <a:cs typeface="Hiragino Sans"/>
-              </a:defRPr>
-            </a:pPr>
-            <a:r>
-              <a:rPr sz="1238" b="1">
-                <a:solidFill>
-                  <a:srgbClr val="FFFFFF"/>
-                </a:solidFill>
-                <a:latin typeface="Hiragino Sans"/>
-                <a:ea typeface="Hiragino Sans"/>
-                <a:cs typeface="Hiragino Sans"/>
-              </a:rPr>
-              <a:t>早期に気づける可能性を、病院・行政・企業の停止時間短縮につながる「実装条件付きの証拠」に変える。</a:t>
-            </a:r>
-          </a:p>
-        </p:txBody>
-      </p:sp>
-      <p:sp>
-        <p:nvSpPr>
-          <p:cNvPr id="23" name="">
-            <a:extLst xmlns:a="http://schemas.openxmlformats.org/drawingml/2006/main">
-              <a:ext uri="{FF2B5EF4-FFF2-40B4-BE49-F238E27FC236}">
-                <a16:creationId xmlns:a16="http://schemas.microsoft.com/office/drawing/2014/main" id="{9EF7051D-C12A-412C-98A1-4EA54062777C}"/>
-              </a:ext>
-            </a:extLst>
-          </p:cNvPr>
-          <p:cNvSpPr>
-            <a:spLocks xmlns:a="http://schemas.openxmlformats.org/drawingml/2006/main" noGrp="1"/>
-          </p:cNvSpPr>
-          <p:nvPr/>
-        </p:nvSpPr>
-        <p:spPr>
-          <a:xfrm xmlns:a="http://schemas.openxmlformats.org/drawingml/2006/main">
-            <a:off x="2362200" y="5162550"/>
-            <a:ext cx="7524750" cy="9525"/>
-          </a:xfrm>
-          <a:prstGeom xmlns:a="http://schemas.openxmlformats.org/drawingml/2006/main" prst="rect">
-            <a:avLst/>
-          </a:prstGeom>
-          <a:solidFill xmlns:a="http://schemas.openxmlformats.org/drawingml/2006/main">
-            <a:srgbClr val="94A3B8"/>
-          </a:solidFill>
-          <a:ln xmlns:a="http://schemas.openxmlformats.org/drawingml/2006/main" w="0">
-            <a:solidFill>
-              <a:srgbClr val="000000">
-                <a:alpha val="0"/>
-              </a:srgbClr>
-            </a:solidFill>
-            <a:prstDash val="solid"/>
-          </a:ln>
-        </p:spPr>
-      </p:sp>
-      <p:sp>
-        <p:nvSpPr>
-          <p:cNvPr id="24" name="">
-            <a:extLst xmlns:a="http://schemas.openxmlformats.org/drawingml/2006/main">
-              <a:ext uri="{FF2B5EF4-FFF2-40B4-BE49-F238E27FC236}">
-                <a16:creationId xmlns:a16="http://schemas.microsoft.com/office/drawing/2014/main" id="{27D7AC36-47F1-4356-BA20-26D548958640}"/>
-              </a:ext>
-            </a:extLst>
-          </p:cNvPr>
-          <p:cNvSpPr>
-            <a:spLocks xmlns:a="http://schemas.openxmlformats.org/drawingml/2006/main" noGrp="1"/>
-          </p:cNvSpPr>
-          <p:nvPr/>
-        </p:nvSpPr>
-        <p:spPr>
-          <a:xfrm xmlns:a="http://schemas.openxmlformats.org/drawingml/2006/main">
-            <a:off x="2362200" y="5200650"/>
-            <a:ext cx="7810500" cy="171450"/>
-          </a:xfrm>
-          <a:prstGeom xmlns:a="http://schemas.openxmlformats.org/drawingml/2006/main" prst="rect">
-            <a:avLst/>
-          </a:prstGeom>
-          <a:solidFill xmlns:a="http://schemas.openxmlformats.org/drawingml/2006/main">
-            <a:srgbClr val="000000">
-              <a:alpha val="0"/>
-            </a:srgbClr>
-          </a:solidFill>
-          <a:ln xmlns:a="http://schemas.openxmlformats.org/drawingml/2006/main" w="0">
-            <a:solidFill>
-              <a:srgbClr val="000000">
-                <a:alpha val="0"/>
-              </a:srgbClr>
-            </a:solidFill>
-            <a:prstDash val="solid"/>
-          </a:ln>
-        </p:spPr>
-        <p:txBody>
-          <a:bodyPr xmlns:a="http://schemas.openxmlformats.org/drawingml/2006/main" lIns="0" tIns="0" rIns="0" bIns="0" anchor="t"/>
-          <a:lstStyle xmlns:a="http://schemas.openxmlformats.org/drawingml/2006/main"/>
-          <a:p xmlns:a="http://schemas.openxmlformats.org/drawingml/2006/main">
-            <a:pPr algn="l">
-              <a:defRPr sz="863" b="0">
-                <a:solidFill>
-                  <a:srgbClr val="E5E7EB"/>
-                </a:solidFill>
-                <a:latin typeface="Hiragino Sans"/>
-                <a:ea typeface="Hiragino Sans"/>
-                <a:cs typeface="Hiragino Sans"/>
-              </a:defRPr>
-            </a:pPr>
-            <a:r>
-              <a:rPr sz="863" b="0">
-                <a:solidFill>
                   <a:srgbClr val="E5E7EB"/>
                 </a:solidFill>
                 <a:latin typeface="Hiragino Sans"/>
@@ -10931,7 +10931,7 @@
           <p:cNvPr id="25" name="">
             <a:extLst xmlns:a="http://schemas.openxmlformats.org/drawingml/2006/main">
               <a:ext uri="{FF2B5EF4-FFF2-40B4-BE49-F238E27FC236}">
-                <a16:creationId xmlns:a16="http://schemas.microsoft.com/office/drawing/2014/main" id="{5065DDC4-4078-423F-B175-7C0ECBE21927}"/>
+                <a16:creationId xmlns:a16="http://schemas.microsoft.com/office/drawing/2014/main" id="{D140EEAD-BDFC-4F00-88DA-D6EDF1633E18}"/>
               </a:ext>
             </a:extLst>
           </p:cNvPr>
@@ -10966,7 +10966,7 @@
           <p:cNvPr id="26" name="">
             <a:extLst xmlns:a="http://schemas.openxmlformats.org/drawingml/2006/main">
               <a:ext uri="{FF2B5EF4-FFF2-40B4-BE49-F238E27FC236}">
-                <a16:creationId xmlns:a16="http://schemas.microsoft.com/office/drawing/2014/main" id="{3ACE571C-161D-4357-BA50-3EE7839C5999}"/>
+                <a16:creationId xmlns:a16="http://schemas.microsoft.com/office/drawing/2014/main" id="{9E151F39-60A5-49C2-93EB-ADC4F35F2FEA}"/>
               </a:ext>
             </a:extLst>
           </p:cNvPr>
@@ -11030,7 +11030,7 @@
           <p:cNvPr id="27" name="">
             <a:extLst xmlns:a="http://schemas.openxmlformats.org/drawingml/2006/main">
               <a:ext uri="{FF2B5EF4-FFF2-40B4-BE49-F238E27FC236}">
-                <a16:creationId xmlns:a16="http://schemas.microsoft.com/office/drawing/2014/main" id="{2D94CAB3-C0D3-4F29-9427-0CE56A8D93F6}"/>
+                <a16:creationId xmlns:a16="http://schemas.microsoft.com/office/drawing/2014/main" id="{3B75A347-E900-48B7-8875-800F0F549048}"/>
               </a:ext>
             </a:extLst>
           </p:cNvPr>
@@ -11092,7 +11092,7 @@
     </p:spTree>
     <p:extLst>
       <p:ext uri="{BB962C8B-B14F-4D97-AF65-F5344CB8AC3E}">
-        <p14:creationId xmlns:p14="http://schemas.microsoft.com/office/powerpoint/2010/main" val="1424450840"/>
+        <p14:creationId xmlns:p14="http://schemas.microsoft.com/office/powerpoint/2010/main" val="822540397"/>
       </p:ext>
     </p:extLst>
   </p:cSld>

</xml_diff>

<commit_message>
Address sponsor deck review comments
</commit_message>
<xml_diff>
--- a/paper/presentations/storage_embedded_ransomware_sponsor_brief.pptx
+++ b/paper/presentations/storage_embedded_ransomware_sponsor_brief.pptx
@@ -2,17 +2,17 @@
 <file path=ppt/presentation.xml><?xml version="1.0" encoding="utf-8"?>
 <p:presentation xmlns:p="http://schemas.openxmlformats.org/presentationml/2006/main">
   <p:sldMasterIdLst>
-    <p:sldMasterId xmlns:r="http://schemas.openxmlformats.org/officeDocument/2006/relationships" id="2147483648" r:id="Rd1f76ec1908046c6"/>
+    <p:sldMasterId xmlns:r="http://schemas.openxmlformats.org/officeDocument/2006/relationships" id="2147483648" r:id="R169779323bcd424a"/>
   </p:sldMasterIdLst>
   <p:notesMasterIdLst>
-    <p:notesMasterId xmlns:r="http://schemas.openxmlformats.org/officeDocument/2006/relationships" r:id="Rccf1c3bf8cfe40ee"/>
+    <p:notesMasterId xmlns:r="http://schemas.openxmlformats.org/officeDocument/2006/relationships" r:id="R960f53a2e9b54eb2"/>
   </p:notesMasterIdLst>
   <p:sldIdLst>
-    <p:sldId xmlns:r="http://schemas.openxmlformats.org/officeDocument/2006/relationships" id="256" r:id="Rad1d8e7fccd44047"/>
-    <p:sldId xmlns:r="http://schemas.openxmlformats.org/officeDocument/2006/relationships" id="257" r:id="Rc3d60302887545e6"/>
-    <p:sldId xmlns:r="http://schemas.openxmlformats.org/officeDocument/2006/relationships" id="258" r:id="R1ac545b17d954bd5"/>
-    <p:sldId xmlns:r="http://schemas.openxmlformats.org/officeDocument/2006/relationships" id="259" r:id="R8f04462b006344c8"/>
-    <p:sldId xmlns:r="http://schemas.openxmlformats.org/officeDocument/2006/relationships" id="260" r:id="R6b13ed40b6b44417"/>
+    <p:sldId xmlns:r="http://schemas.openxmlformats.org/officeDocument/2006/relationships" id="256" r:id="Rf87464fc551b4b28"/>
+    <p:sldId xmlns:r="http://schemas.openxmlformats.org/officeDocument/2006/relationships" id="257" r:id="R6c20cbc22d57439f"/>
+    <p:sldId xmlns:r="http://schemas.openxmlformats.org/officeDocument/2006/relationships" id="258" r:id="Rd20a6f58ce32429b"/>
+    <p:sldId xmlns:r="http://schemas.openxmlformats.org/officeDocument/2006/relationships" id="259" r:id="Re2df99987a2a4afa"/>
+    <p:sldId xmlns:r="http://schemas.openxmlformats.org/officeDocument/2006/relationships" id="260" r:id="Read80e0b7b3b4214"/>
   </p:sldIdLst>
   <p:sldSz cx="12192000" cy="6858000"/>
   <p:notesSz cx="6858000" cy="9144000"/>
@@ -823,7 +823,7 @@
   </p:cSld>
   <p:clrMap bg1="lt1" tx1="dk1" bg2="lt2" tx2="dk2" accent1="accent1" accent2="accent2" accent3="accent3" accent4="accent4" accent5="accent5" accent6="accent6" hlink="hlink" folHlink="folHlink"/>
   <p:sldLayoutIdLst>
-    <p:sldLayoutId xmlns:r="http://schemas.openxmlformats.org/officeDocument/2006/relationships" id="2147483649" r:id="Rc39fd4bc8c42439f"/>
+    <p:sldLayoutId xmlns:r="http://schemas.openxmlformats.org/officeDocument/2006/relationships" id="2147483649" r:id="R9db29c8cd7f749d6"/>
   </p:sldLayoutIdLst>
   <p:txStyles>
     <p:titleStyle>
@@ -1122,7 +1122,7 @@
           <p:cNvPr id="1" name="">
             <a:extLst xmlns:a="http://schemas.openxmlformats.org/drawingml/2006/main">
               <a:ext uri="{FF2B5EF4-FFF2-40B4-BE49-F238E27FC236}">
-                <a16:creationId xmlns:a16="http://schemas.microsoft.com/office/drawing/2014/main" id="{BEB5C441-8DAE-4E02-9DE8-EA337472C069}"/>
+                <a16:creationId xmlns:a16="http://schemas.microsoft.com/office/drawing/2014/main" id="{EACE0DAB-4DAE-406E-83B0-AEE40D280E95}"/>
               </a:ext>
             </a:extLst>
           </p:cNvPr>
@@ -1157,7 +1157,7 @@
           <p:cNvPr id="2" name="">
             <a:extLst xmlns:a="http://schemas.openxmlformats.org/drawingml/2006/main">
               <a:ext uri="{FF2B5EF4-FFF2-40B4-BE49-F238E27FC236}">
-                <a16:creationId xmlns:a16="http://schemas.microsoft.com/office/drawing/2014/main" id="{820DF5B6-4BE5-4E46-AD40-1124612D3836}"/>
+                <a16:creationId xmlns:a16="http://schemas.microsoft.com/office/drawing/2014/main" id="{EEF65B93-C919-4E05-A95E-F0C650B45306}"/>
               </a:ext>
             </a:extLst>
           </p:cNvPr>
@@ -1192,7 +1192,7 @@
           <p:cNvPr id="3" name="kicker-marker">
             <a:extLst xmlns:a="http://schemas.openxmlformats.org/drawingml/2006/main">
               <a:ext uri="{FF2B5EF4-FFF2-40B4-BE49-F238E27FC236}">
-                <a16:creationId xmlns:a16="http://schemas.microsoft.com/office/drawing/2014/main" id="{326C0FA3-D1D2-42A4-8C5A-980C26566F47}"/>
+                <a16:creationId xmlns:a16="http://schemas.microsoft.com/office/drawing/2014/main" id="{4FF3F009-C1F1-4A53-ACB5-7333BD3D4161}"/>
               </a:ext>
             </a:extLst>
           </p:cNvPr>
@@ -1227,7 +1227,7 @@
           <p:cNvPr id="4" name="kicker-label">
             <a:extLst xmlns:a="http://schemas.openxmlformats.org/drawingml/2006/main">
               <a:ext uri="{FF2B5EF4-FFF2-40B4-BE49-F238E27FC236}">
-                <a16:creationId xmlns:a16="http://schemas.microsoft.com/office/drawing/2014/main" id="{89185034-D1EE-42F9-9463-4A6C8DADE636}"/>
+                <a16:creationId xmlns:a16="http://schemas.microsoft.com/office/drawing/2014/main" id="{10F8442C-7651-4497-80D5-CED8E231F062}"/>
               </a:ext>
             </a:extLst>
           </p:cNvPr>
@@ -1291,7 +1291,7 @@
           <p:cNvPr id="5" name="">
             <a:extLst xmlns:a="http://schemas.openxmlformats.org/drawingml/2006/main">
               <a:ext uri="{FF2B5EF4-FFF2-40B4-BE49-F238E27FC236}">
-                <a16:creationId xmlns:a16="http://schemas.microsoft.com/office/drawing/2014/main" id="{EA539C39-4444-490F-B670-649A7202AB99}"/>
+                <a16:creationId xmlns:a16="http://schemas.microsoft.com/office/drawing/2014/main" id="{42F99E1F-839B-4181-97BF-D46C9174B7D8}"/>
               </a:ext>
             </a:extLst>
           </p:cNvPr>
@@ -1355,7 +1355,7 @@
           <p:cNvPr id="6" name="">
             <a:extLst xmlns:a="http://schemas.openxmlformats.org/drawingml/2006/main">
               <a:ext uri="{FF2B5EF4-FFF2-40B4-BE49-F238E27FC236}">
-                <a16:creationId xmlns:a16="http://schemas.microsoft.com/office/drawing/2014/main" id="{78E84EF8-54EE-4B96-94C9-B5CDBE66DA42}"/>
+                <a16:creationId xmlns:a16="http://schemas.microsoft.com/office/drawing/2014/main" id="{226AACF5-7B3C-4E02-8C57-16C07D99C372}"/>
               </a:ext>
             </a:extLst>
           </p:cNvPr>
@@ -1419,7 +1419,7 @@
           <p:cNvPr id="7" name="">
             <a:extLst xmlns:a="http://schemas.openxmlformats.org/drawingml/2006/main">
               <a:ext uri="{FF2B5EF4-FFF2-40B4-BE49-F238E27FC236}">
-                <a16:creationId xmlns:a16="http://schemas.microsoft.com/office/drawing/2014/main" id="{985BC643-AC80-426F-ABB8-6F98AF9F0560}"/>
+                <a16:creationId xmlns:a16="http://schemas.microsoft.com/office/drawing/2014/main" id="{82AC67D0-251C-4BA8-B4AB-D9BC595DAAD3}"/>
               </a:ext>
             </a:extLst>
           </p:cNvPr>
@@ -1483,7 +1483,7 @@
           <p:cNvPr id="8" name="">
             <a:extLst xmlns:a="http://schemas.openxmlformats.org/drawingml/2006/main">
               <a:ext uri="{FF2B5EF4-FFF2-40B4-BE49-F238E27FC236}">
-                <a16:creationId xmlns:a16="http://schemas.microsoft.com/office/drawing/2014/main" id="{EC056401-2859-4456-AB1E-03642B842C8A}"/>
+                <a16:creationId xmlns:a16="http://schemas.microsoft.com/office/drawing/2014/main" id="{44E1C557-0788-4831-A2C6-2AAFB1E27616}"/>
               </a:ext>
             </a:extLst>
           </p:cNvPr>
@@ -1516,7 +1516,7 @@
           <p:cNvPr id="9" name="">
             <a:extLst xmlns:a="http://schemas.openxmlformats.org/drawingml/2006/main">
               <a:ext uri="{FF2B5EF4-FFF2-40B4-BE49-F238E27FC236}">
-                <a16:creationId xmlns:a16="http://schemas.microsoft.com/office/drawing/2014/main" id="{C334F410-F6E0-414D-9E2E-9BA6862D9AD2}"/>
+                <a16:creationId xmlns:a16="http://schemas.microsoft.com/office/drawing/2014/main" id="{42A8F5C5-AFCF-42D7-A1EC-81B6CEAC0372}"/>
               </a:ext>
             </a:extLst>
           </p:cNvPr>
@@ -1580,7 +1580,7 @@
           <p:cNvPr id="10" name="">
             <a:extLst xmlns:a="http://schemas.openxmlformats.org/drawingml/2006/main">
               <a:ext uri="{FF2B5EF4-FFF2-40B4-BE49-F238E27FC236}">
-                <a16:creationId xmlns:a16="http://schemas.microsoft.com/office/drawing/2014/main" id="{A51A68F5-AC5C-4245-B69D-FD0C0C69C9AC}"/>
+                <a16:creationId xmlns:a16="http://schemas.microsoft.com/office/drawing/2014/main" id="{F73BEE0F-0D0C-4CE5-AB1F-14239A6E9FDA}"/>
               </a:ext>
             </a:extLst>
           </p:cNvPr>
@@ -1613,7 +1613,7 @@
           <p:cNvPr id="11" name="">
             <a:extLst xmlns:a="http://schemas.openxmlformats.org/drawingml/2006/main">
               <a:ext uri="{FF2B5EF4-FFF2-40B4-BE49-F238E27FC236}">
-                <a16:creationId xmlns:a16="http://schemas.microsoft.com/office/drawing/2014/main" id="{6CE4B204-6D1A-4A86-89DB-59BEBF7FA7E4}"/>
+                <a16:creationId xmlns:a16="http://schemas.microsoft.com/office/drawing/2014/main" id="{EBAB498D-EF9B-4BF1-893C-484F370D33E2}"/>
               </a:ext>
             </a:extLst>
           </p:cNvPr>
@@ -1677,7 +1677,7 @@
           <p:cNvPr id="12" name="">
             <a:extLst xmlns:a="http://schemas.openxmlformats.org/drawingml/2006/main">
               <a:ext uri="{FF2B5EF4-FFF2-40B4-BE49-F238E27FC236}">
-                <a16:creationId xmlns:a16="http://schemas.microsoft.com/office/drawing/2014/main" id="{F4BABAFF-0C1A-45AC-A704-2BCC6499CE87}"/>
+                <a16:creationId xmlns:a16="http://schemas.microsoft.com/office/drawing/2014/main" id="{2B5AD098-3037-4A51-BA33-7733A7BCA206}"/>
               </a:ext>
             </a:extLst>
           </p:cNvPr>
@@ -1741,7 +1741,7 @@
           <p:cNvPr id="13" name="">
             <a:extLst xmlns:a="http://schemas.openxmlformats.org/drawingml/2006/main">
               <a:ext uri="{FF2B5EF4-FFF2-40B4-BE49-F238E27FC236}">
-                <a16:creationId xmlns:a16="http://schemas.microsoft.com/office/drawing/2014/main" id="{46FA3B9E-5C50-4AAC-A9DF-33C899AB047A}"/>
+                <a16:creationId xmlns:a16="http://schemas.microsoft.com/office/drawing/2014/main" id="{07458AF2-B6B2-44C4-9BE6-A76C928E3692}"/>
               </a:ext>
             </a:extLst>
           </p:cNvPr>
@@ -1776,7 +1776,7 @@
           <p:cNvPr id="14" name="">
             <a:extLst xmlns:a="http://schemas.openxmlformats.org/drawingml/2006/main">
               <a:ext uri="{FF2B5EF4-FFF2-40B4-BE49-F238E27FC236}">
-                <a16:creationId xmlns:a16="http://schemas.microsoft.com/office/drawing/2014/main" id="{66EDF19D-1FA4-4C76-BBDF-6CCE59D0C2D5}"/>
+                <a16:creationId xmlns:a16="http://schemas.microsoft.com/office/drawing/2014/main" id="{FAC4B1B6-C93C-4968-A1D9-A5096E1900D4}"/>
               </a:ext>
             </a:extLst>
           </p:cNvPr>
@@ -1840,7 +1840,7 @@
           <p:cNvPr id="15" name="">
             <a:extLst xmlns:a="http://schemas.openxmlformats.org/drawingml/2006/main">
               <a:ext uri="{FF2B5EF4-FFF2-40B4-BE49-F238E27FC236}">
-                <a16:creationId xmlns:a16="http://schemas.microsoft.com/office/drawing/2014/main" id="{9646C0C6-9451-422D-94EC-2B81226B59F6}"/>
+                <a16:creationId xmlns:a16="http://schemas.microsoft.com/office/drawing/2014/main" id="{F393EE5B-B7B2-4E81-9809-0B98A86595C6}"/>
               </a:ext>
             </a:extLst>
           </p:cNvPr>
@@ -1873,7 +1873,7 @@
           <p:cNvPr id="16" name="">
             <a:extLst xmlns:a="http://schemas.openxmlformats.org/drawingml/2006/main">
               <a:ext uri="{FF2B5EF4-FFF2-40B4-BE49-F238E27FC236}">
-                <a16:creationId xmlns:a16="http://schemas.microsoft.com/office/drawing/2014/main" id="{993B4DA5-2096-4185-ACF8-1DCF7AA9D3D0}"/>
+                <a16:creationId xmlns:a16="http://schemas.microsoft.com/office/drawing/2014/main" id="{B6B51311-0123-4855-B756-9BCD2A4D8AB8}"/>
               </a:ext>
             </a:extLst>
           </p:cNvPr>
@@ -1937,7 +1937,7 @@
           <p:cNvPr id="17" name="">
             <a:extLst xmlns:a="http://schemas.openxmlformats.org/drawingml/2006/main">
               <a:ext uri="{FF2B5EF4-FFF2-40B4-BE49-F238E27FC236}">
-                <a16:creationId xmlns:a16="http://schemas.microsoft.com/office/drawing/2014/main" id="{92422AA8-6AD4-491C-AB15-F7DA5173E270}"/>
+                <a16:creationId xmlns:a16="http://schemas.microsoft.com/office/drawing/2014/main" id="{8834FE05-3653-4EA7-BA72-C646E6E1906B}"/>
               </a:ext>
             </a:extLst>
           </p:cNvPr>
@@ -2001,7 +2001,7 @@
           <p:cNvPr id="18" name="">
             <a:extLst xmlns:a="http://schemas.openxmlformats.org/drawingml/2006/main">
               <a:ext uri="{FF2B5EF4-FFF2-40B4-BE49-F238E27FC236}">
-                <a16:creationId xmlns:a16="http://schemas.microsoft.com/office/drawing/2014/main" id="{653C0A96-306A-44DA-B3F9-56D59D1CF463}"/>
+                <a16:creationId xmlns:a16="http://schemas.microsoft.com/office/drawing/2014/main" id="{48B7F5F3-534A-47CA-8A2C-B7E6152D8813}"/>
               </a:ext>
             </a:extLst>
           </p:cNvPr>
@@ -2036,7 +2036,7 @@
           <p:cNvPr id="19" name="">
             <a:extLst xmlns:a="http://schemas.openxmlformats.org/drawingml/2006/main">
               <a:ext uri="{FF2B5EF4-FFF2-40B4-BE49-F238E27FC236}">
-                <a16:creationId xmlns:a16="http://schemas.microsoft.com/office/drawing/2014/main" id="{62153CF2-3B5D-497A-8CFC-C087F1644FDF}"/>
+                <a16:creationId xmlns:a16="http://schemas.microsoft.com/office/drawing/2014/main" id="{E4363D55-448D-4A37-83DF-8ED63ED241A0}"/>
               </a:ext>
             </a:extLst>
           </p:cNvPr>
@@ -2100,7 +2100,7 @@
           <p:cNvPr id="20" name="">
             <a:extLst xmlns:a="http://schemas.openxmlformats.org/drawingml/2006/main">
               <a:ext uri="{FF2B5EF4-FFF2-40B4-BE49-F238E27FC236}">
-                <a16:creationId xmlns:a16="http://schemas.microsoft.com/office/drawing/2014/main" id="{C505166C-42D4-49AE-9FAD-8080406E3FA2}"/>
+                <a16:creationId xmlns:a16="http://schemas.microsoft.com/office/drawing/2014/main" id="{BFDBABB8-AC62-418B-9DAA-62C3BE7B97D8}"/>
               </a:ext>
             </a:extLst>
           </p:cNvPr>
@@ -2135,7 +2135,7 @@
           <p:cNvPr id="21" name="">
             <a:extLst xmlns:a="http://schemas.openxmlformats.org/drawingml/2006/main">
               <a:ext uri="{FF2B5EF4-FFF2-40B4-BE49-F238E27FC236}">
-                <a16:creationId xmlns:a16="http://schemas.microsoft.com/office/drawing/2014/main" id="{57F48D7E-58FB-4F1A-8219-E628D3C95C14}"/>
+                <a16:creationId xmlns:a16="http://schemas.microsoft.com/office/drawing/2014/main" id="{1D10D8C4-3BED-4C09-9846-096FD69B9583}"/>
               </a:ext>
             </a:extLst>
           </p:cNvPr>
@@ -2199,7 +2199,7 @@
           <p:cNvPr id="22" name="">
             <a:extLst xmlns:a="http://schemas.openxmlformats.org/drawingml/2006/main">
               <a:ext uri="{FF2B5EF4-FFF2-40B4-BE49-F238E27FC236}">
-                <a16:creationId xmlns:a16="http://schemas.microsoft.com/office/drawing/2014/main" id="{949DE90E-03EA-4659-9CDA-819A9B46EB51}"/>
+                <a16:creationId xmlns:a16="http://schemas.microsoft.com/office/drawing/2014/main" id="{4EA3AC36-4563-4887-A6AC-263F11D5ED68}"/>
               </a:ext>
             </a:extLst>
           </p:cNvPr>
@@ -2263,7 +2263,7 @@
           <p:cNvPr id="23" name="">
             <a:extLst xmlns:a="http://schemas.openxmlformats.org/drawingml/2006/main">
               <a:ext uri="{FF2B5EF4-FFF2-40B4-BE49-F238E27FC236}">
-                <a16:creationId xmlns:a16="http://schemas.microsoft.com/office/drawing/2014/main" id="{396F9431-0699-4CC4-AFE6-86A08BF7E97D}"/>
+                <a16:creationId xmlns:a16="http://schemas.microsoft.com/office/drawing/2014/main" id="{98E0005C-D46C-4829-A4D3-6FD6715A4F99}"/>
               </a:ext>
             </a:extLst>
           </p:cNvPr>
@@ -2298,7 +2298,7 @@
           <p:cNvPr id="24" name="">
             <a:extLst xmlns:a="http://schemas.openxmlformats.org/drawingml/2006/main">
               <a:ext uri="{FF2B5EF4-FFF2-40B4-BE49-F238E27FC236}">
-                <a16:creationId xmlns:a16="http://schemas.microsoft.com/office/drawing/2014/main" id="{661DD8F8-897B-4BF2-8CB3-CE498C1694B8}"/>
+                <a16:creationId xmlns:a16="http://schemas.microsoft.com/office/drawing/2014/main" id="{B77785D9-74E1-485E-9A2F-81719F2E0353}"/>
               </a:ext>
             </a:extLst>
           </p:cNvPr>
@@ -2362,7 +2362,7 @@
           <p:cNvPr id="25" name="">
             <a:extLst xmlns:a="http://schemas.openxmlformats.org/drawingml/2006/main">
               <a:ext uri="{FF2B5EF4-FFF2-40B4-BE49-F238E27FC236}">
-                <a16:creationId xmlns:a16="http://schemas.microsoft.com/office/drawing/2014/main" id="{5E590CA9-2CFB-4558-99B8-6F3CCFA8D70B}"/>
+                <a16:creationId xmlns:a16="http://schemas.microsoft.com/office/drawing/2014/main" id="{39EBC418-2303-4058-874C-C7ECC98B4FF8}"/>
               </a:ext>
             </a:extLst>
           </p:cNvPr>
@@ -2426,7 +2426,7 @@
           <p:cNvPr id="26" name="">
             <a:extLst xmlns:a="http://schemas.openxmlformats.org/drawingml/2006/main">
               <a:ext uri="{FF2B5EF4-FFF2-40B4-BE49-F238E27FC236}">
-                <a16:creationId xmlns:a16="http://schemas.microsoft.com/office/drawing/2014/main" id="{5B112043-5B32-4DA4-AA09-1C4EE99F6C98}"/>
+                <a16:creationId xmlns:a16="http://schemas.microsoft.com/office/drawing/2014/main" id="{62EFB4E6-A0D8-490B-8261-83D9303A55E7}"/>
               </a:ext>
             </a:extLst>
           </p:cNvPr>
@@ -2461,7 +2461,7 @@
           <p:cNvPr id="27" name="">
             <a:extLst xmlns:a="http://schemas.openxmlformats.org/drawingml/2006/main">
               <a:ext uri="{FF2B5EF4-FFF2-40B4-BE49-F238E27FC236}">
-                <a16:creationId xmlns:a16="http://schemas.microsoft.com/office/drawing/2014/main" id="{3564B6DC-F5FE-4C5C-B76C-EF2943670DB9}"/>
+                <a16:creationId xmlns:a16="http://schemas.microsoft.com/office/drawing/2014/main" id="{6074CBA5-8E4D-4891-8D17-E7AFDF087026}"/>
               </a:ext>
             </a:extLst>
           </p:cNvPr>
@@ -2525,7 +2525,7 @@
           <p:cNvPr id="28" name="">
             <a:extLst xmlns:a="http://schemas.openxmlformats.org/drawingml/2006/main">
               <a:ext uri="{FF2B5EF4-FFF2-40B4-BE49-F238E27FC236}">
-                <a16:creationId xmlns:a16="http://schemas.microsoft.com/office/drawing/2014/main" id="{51281110-DA57-476D-81D4-F9618DC199F8}"/>
+                <a16:creationId xmlns:a16="http://schemas.microsoft.com/office/drawing/2014/main" id="{8E3079AC-5DE2-44EE-A1FE-3B85839C7EA1}"/>
               </a:ext>
             </a:extLst>
           </p:cNvPr>
@@ -2589,7 +2589,7 @@
           <p:cNvPr id="29" name="">
             <a:extLst xmlns:a="http://schemas.openxmlformats.org/drawingml/2006/main">
               <a:ext uri="{FF2B5EF4-FFF2-40B4-BE49-F238E27FC236}">
-                <a16:creationId xmlns:a16="http://schemas.microsoft.com/office/drawing/2014/main" id="{ADB6B143-0B2B-43AC-8BE2-5B51CADA6CA3}"/>
+                <a16:creationId xmlns:a16="http://schemas.microsoft.com/office/drawing/2014/main" id="{F1975902-2688-4DAE-B92A-18E345A134D8}"/>
               </a:ext>
             </a:extLst>
           </p:cNvPr>
@@ -2624,7 +2624,7 @@
           <p:cNvPr id="30" name="">
             <a:extLst xmlns:a="http://schemas.openxmlformats.org/drawingml/2006/main">
               <a:ext uri="{FF2B5EF4-FFF2-40B4-BE49-F238E27FC236}">
-                <a16:creationId xmlns:a16="http://schemas.microsoft.com/office/drawing/2014/main" id="{D02E39A5-2328-4735-BBEC-F079C6823BF5}"/>
+                <a16:creationId xmlns:a16="http://schemas.microsoft.com/office/drawing/2014/main" id="{2236FE6E-6F8E-4DF4-B1CC-E7F5FAAD9540}"/>
               </a:ext>
             </a:extLst>
           </p:cNvPr>
@@ -2688,7 +2688,7 @@
           <p:cNvPr id="31" name="">
             <a:extLst xmlns:a="http://schemas.openxmlformats.org/drawingml/2006/main">
               <a:ext uri="{FF2B5EF4-FFF2-40B4-BE49-F238E27FC236}">
-                <a16:creationId xmlns:a16="http://schemas.microsoft.com/office/drawing/2014/main" id="{A07C5EB9-732E-49C0-9EA2-2EEFD059FE2C}"/>
+                <a16:creationId xmlns:a16="http://schemas.microsoft.com/office/drawing/2014/main" id="{4E86BC88-57E4-4DB5-922B-8540962F98BA}"/>
               </a:ext>
             </a:extLst>
           </p:cNvPr>
@@ -2752,7 +2752,7 @@
           <p:cNvPr id="32" name="">
             <a:extLst xmlns:a="http://schemas.openxmlformats.org/drawingml/2006/main">
               <a:ext uri="{FF2B5EF4-FFF2-40B4-BE49-F238E27FC236}">
-                <a16:creationId xmlns:a16="http://schemas.microsoft.com/office/drawing/2014/main" id="{21717FFA-CC26-4590-9642-6D3AE1C52A87}"/>
+                <a16:creationId xmlns:a16="http://schemas.microsoft.com/office/drawing/2014/main" id="{BD215DD6-47DB-4E4B-9CD9-9323213595E9}"/>
               </a:ext>
             </a:extLst>
           </p:cNvPr>
@@ -2787,7 +2787,7 @@
           <p:cNvPr id="33" name="">
             <a:extLst xmlns:a="http://schemas.openxmlformats.org/drawingml/2006/main">
               <a:ext uri="{FF2B5EF4-FFF2-40B4-BE49-F238E27FC236}">
-                <a16:creationId xmlns:a16="http://schemas.microsoft.com/office/drawing/2014/main" id="{6EC8EA3B-C537-4326-8B52-8AED214ABDD5}"/>
+                <a16:creationId xmlns:a16="http://schemas.microsoft.com/office/drawing/2014/main" id="{96507BD2-A494-44CF-9E3A-0B8627014F4D}"/>
               </a:ext>
             </a:extLst>
           </p:cNvPr>
@@ -2851,7 +2851,7 @@
           <p:cNvPr id="34" name="">
             <a:extLst xmlns:a="http://schemas.openxmlformats.org/drawingml/2006/main">
               <a:ext uri="{FF2B5EF4-FFF2-40B4-BE49-F238E27FC236}">
-                <a16:creationId xmlns:a16="http://schemas.microsoft.com/office/drawing/2014/main" id="{8FF29DD3-2CD6-49CB-87B8-063574E6CF90}"/>
+                <a16:creationId xmlns:a16="http://schemas.microsoft.com/office/drawing/2014/main" id="{8095CE37-6C21-4DF8-8A31-34F26F548584}"/>
               </a:ext>
             </a:extLst>
           </p:cNvPr>
@@ -2913,7 +2913,7 @@
     </p:spTree>
     <p:extLst>
       <p:ext uri="{BB962C8B-B14F-4D97-AF65-F5344CB8AC3E}">
-        <p14:creationId xmlns:p14="http://schemas.microsoft.com/office/powerpoint/2010/main" val="558945092"/>
+        <p14:creationId xmlns:p14="http://schemas.microsoft.com/office/powerpoint/2010/main" val="248387621"/>
       </p:ext>
     </p:extLst>
   </p:cSld>
@@ -2937,7 +2937,7 @@
           <p:cNvPr id="1" name="">
             <a:extLst xmlns:a="http://schemas.openxmlformats.org/drawingml/2006/main">
               <a:ext uri="{FF2B5EF4-FFF2-40B4-BE49-F238E27FC236}">
-                <a16:creationId xmlns:a16="http://schemas.microsoft.com/office/drawing/2014/main" id="{CAA7695D-0630-4808-BCAD-DC2D94A5B7E3}"/>
+                <a16:creationId xmlns:a16="http://schemas.microsoft.com/office/drawing/2014/main" id="{D3D1570D-C82F-45CF-8447-E3D132379489}"/>
               </a:ext>
             </a:extLst>
           </p:cNvPr>
@@ -2972,7 +2972,7 @@
           <p:cNvPr id="2" name="">
             <a:extLst xmlns:a="http://schemas.openxmlformats.org/drawingml/2006/main">
               <a:ext uri="{FF2B5EF4-FFF2-40B4-BE49-F238E27FC236}">
-                <a16:creationId xmlns:a16="http://schemas.microsoft.com/office/drawing/2014/main" id="{63C1483B-F58C-4FBD-B806-2F6586827145}"/>
+                <a16:creationId xmlns:a16="http://schemas.microsoft.com/office/drawing/2014/main" id="{EDDA4186-9463-46BC-BB80-C43983BFECB8}"/>
               </a:ext>
             </a:extLst>
           </p:cNvPr>
@@ -3007,7 +3007,7 @@
           <p:cNvPr id="3" name="kicker-marker">
             <a:extLst xmlns:a="http://schemas.openxmlformats.org/drawingml/2006/main">
               <a:ext uri="{FF2B5EF4-FFF2-40B4-BE49-F238E27FC236}">
-                <a16:creationId xmlns:a16="http://schemas.microsoft.com/office/drawing/2014/main" id="{11501FE4-8AFF-4D6C-95FB-CCF0DA6972FA}"/>
+                <a16:creationId xmlns:a16="http://schemas.microsoft.com/office/drawing/2014/main" id="{98878EF3-1FB0-425E-BE1E-6762FA44439A}"/>
               </a:ext>
             </a:extLst>
           </p:cNvPr>
@@ -3042,7 +3042,7 @@
           <p:cNvPr id="4" name="kicker-label">
             <a:extLst xmlns:a="http://schemas.openxmlformats.org/drawingml/2006/main">
               <a:ext uri="{FF2B5EF4-FFF2-40B4-BE49-F238E27FC236}">
-                <a16:creationId xmlns:a16="http://schemas.microsoft.com/office/drawing/2014/main" id="{ED1A2497-9D21-4C3D-9C84-F3FCAB8DC754}"/>
+                <a16:creationId xmlns:a16="http://schemas.microsoft.com/office/drawing/2014/main" id="{673ACEAF-D66D-4B4B-A8C7-E45841B7B63D}"/>
               </a:ext>
             </a:extLst>
           </p:cNvPr>
@@ -3106,7 +3106,7 @@
           <p:cNvPr id="5" name="">
             <a:extLst xmlns:a="http://schemas.openxmlformats.org/drawingml/2006/main">
               <a:ext uri="{FF2B5EF4-FFF2-40B4-BE49-F238E27FC236}">
-                <a16:creationId xmlns:a16="http://schemas.microsoft.com/office/drawing/2014/main" id="{A9DD321B-E87D-47F3-B0FD-DCB6FF1D45AF}"/>
+                <a16:creationId xmlns:a16="http://schemas.microsoft.com/office/drawing/2014/main" id="{EBFB95DA-B37D-4FF4-9AC1-3D0D849CCC4B}"/>
               </a:ext>
             </a:extLst>
           </p:cNvPr>
@@ -3170,7 +3170,7 @@
           <p:cNvPr id="6" name="">
             <a:extLst xmlns:a="http://schemas.openxmlformats.org/drawingml/2006/main">
               <a:ext uri="{FF2B5EF4-FFF2-40B4-BE49-F238E27FC236}">
-                <a16:creationId xmlns:a16="http://schemas.microsoft.com/office/drawing/2014/main" id="{640A9504-0A24-4940-96F5-CA84A6985868}"/>
+                <a16:creationId xmlns:a16="http://schemas.microsoft.com/office/drawing/2014/main" id="{84029561-B074-40AC-AC21-01EFFF6A1C92}"/>
               </a:ext>
             </a:extLst>
           </p:cNvPr>
@@ -3234,7 +3234,7 @@
           <p:cNvPr id="7" name="">
             <a:extLst xmlns:a="http://schemas.openxmlformats.org/drawingml/2006/main">
               <a:ext uri="{FF2B5EF4-FFF2-40B4-BE49-F238E27FC236}">
-                <a16:creationId xmlns:a16="http://schemas.microsoft.com/office/drawing/2014/main" id="{090CA5B5-2692-4444-B1C7-54FDE26797EC}"/>
+                <a16:creationId xmlns:a16="http://schemas.microsoft.com/office/drawing/2014/main" id="{E5919CD4-0801-4DDE-98A3-488B64E97EDB}"/>
               </a:ext>
             </a:extLst>
           </p:cNvPr>
@@ -3267,7 +3267,7 @@
           <p:cNvPr id="8" name="">
             <a:extLst xmlns:a="http://schemas.openxmlformats.org/drawingml/2006/main">
               <a:ext uri="{FF2B5EF4-FFF2-40B4-BE49-F238E27FC236}">
-                <a16:creationId xmlns:a16="http://schemas.microsoft.com/office/drawing/2014/main" id="{BDB7496C-537A-41B5-8BBE-923C894438EC}"/>
+                <a16:creationId xmlns:a16="http://schemas.microsoft.com/office/drawing/2014/main" id="{73B56BCC-EE00-4B20-87CE-FE9AD349B1F5}"/>
               </a:ext>
             </a:extLst>
           </p:cNvPr>
@@ -3331,7 +3331,7 @@
           <p:cNvPr id="9" name="">
             <a:extLst xmlns:a="http://schemas.openxmlformats.org/drawingml/2006/main">
               <a:ext uri="{FF2B5EF4-FFF2-40B4-BE49-F238E27FC236}">
-                <a16:creationId xmlns:a16="http://schemas.microsoft.com/office/drawing/2014/main" id="{76FBF135-5B46-4CFA-A6F3-E4A7508E1A49}"/>
+                <a16:creationId xmlns:a16="http://schemas.microsoft.com/office/drawing/2014/main" id="{E65A1B5A-57B6-424E-8D62-B5382E52350E}"/>
               </a:ext>
             </a:extLst>
           </p:cNvPr>
@@ -3395,7 +3395,7 @@
           <p:cNvPr id="10" name="">
             <a:extLst xmlns:a="http://schemas.openxmlformats.org/drawingml/2006/main">
               <a:ext uri="{FF2B5EF4-FFF2-40B4-BE49-F238E27FC236}">
-                <a16:creationId xmlns:a16="http://schemas.microsoft.com/office/drawing/2014/main" id="{A2239086-9F00-4210-9BA5-48035DD36188}"/>
+                <a16:creationId xmlns:a16="http://schemas.microsoft.com/office/drawing/2014/main" id="{23CADD57-B287-47C6-A795-95A914F868EC}"/>
               </a:ext>
             </a:extLst>
           </p:cNvPr>
@@ -3430,7 +3430,7 @@
           <p:cNvPr id="11" name="">
             <a:extLst xmlns:a="http://schemas.openxmlformats.org/drawingml/2006/main">
               <a:ext uri="{FF2B5EF4-FFF2-40B4-BE49-F238E27FC236}">
-                <a16:creationId xmlns:a16="http://schemas.microsoft.com/office/drawing/2014/main" id="{7DAB7746-E979-4B12-A4B0-3A155FF9EE14}"/>
+                <a16:creationId xmlns:a16="http://schemas.microsoft.com/office/drawing/2014/main" id="{B7102EB1-B4D8-49EB-B950-1CCF3D4F6C3D}"/>
               </a:ext>
             </a:extLst>
           </p:cNvPr>
@@ -3494,7 +3494,7 @@
           <p:cNvPr id="12" name="">
             <a:extLst xmlns:a="http://schemas.openxmlformats.org/drawingml/2006/main">
               <a:ext uri="{FF2B5EF4-FFF2-40B4-BE49-F238E27FC236}">
-                <a16:creationId xmlns:a16="http://schemas.microsoft.com/office/drawing/2014/main" id="{C5B40A3F-2D05-48CC-81FD-E689CA6B98C4}"/>
+                <a16:creationId xmlns:a16="http://schemas.microsoft.com/office/drawing/2014/main" id="{D292302C-F056-46B2-8182-57943EFBA328}"/>
               </a:ext>
             </a:extLst>
           </p:cNvPr>
@@ -3527,7 +3527,7 @@
           <p:cNvPr id="13" name="">
             <a:extLst xmlns:a="http://schemas.openxmlformats.org/drawingml/2006/main">
               <a:ext uri="{FF2B5EF4-FFF2-40B4-BE49-F238E27FC236}">
-                <a16:creationId xmlns:a16="http://schemas.microsoft.com/office/drawing/2014/main" id="{EE0283EE-6592-4565-9F16-011657944197}"/>
+                <a16:creationId xmlns:a16="http://schemas.microsoft.com/office/drawing/2014/main" id="{419EE8A4-D6A5-4DB9-A08F-7AD9483E7877}"/>
               </a:ext>
             </a:extLst>
           </p:cNvPr>
@@ -3591,7 +3591,7 @@
           <p:cNvPr id="14" name="">
             <a:extLst xmlns:a="http://schemas.openxmlformats.org/drawingml/2006/main">
               <a:ext uri="{FF2B5EF4-FFF2-40B4-BE49-F238E27FC236}">
-                <a16:creationId xmlns:a16="http://schemas.microsoft.com/office/drawing/2014/main" id="{7AFF393B-7A21-488B-BBAA-DB0DC0603B58}"/>
+                <a16:creationId xmlns:a16="http://schemas.microsoft.com/office/drawing/2014/main" id="{DBDEF5CD-77D9-4E06-BF64-CC886658DE9C}"/>
               </a:ext>
             </a:extLst>
           </p:cNvPr>
@@ -3655,7 +3655,7 @@
           <p:cNvPr id="15" name="">
             <a:extLst xmlns:a="http://schemas.openxmlformats.org/drawingml/2006/main">
               <a:ext uri="{FF2B5EF4-FFF2-40B4-BE49-F238E27FC236}">
-                <a16:creationId xmlns:a16="http://schemas.microsoft.com/office/drawing/2014/main" id="{54C0AC7F-DE12-44FF-A57D-B63862B4A2BD}"/>
+                <a16:creationId xmlns:a16="http://schemas.microsoft.com/office/drawing/2014/main" id="{5F2F3ACB-2FB6-4B61-BA13-C9CD849FCAE2}"/>
               </a:ext>
             </a:extLst>
           </p:cNvPr>
@@ -3690,7 +3690,7 @@
           <p:cNvPr id="16" name="">
             <a:extLst xmlns:a="http://schemas.openxmlformats.org/drawingml/2006/main">
               <a:ext uri="{FF2B5EF4-FFF2-40B4-BE49-F238E27FC236}">
-                <a16:creationId xmlns:a16="http://schemas.microsoft.com/office/drawing/2014/main" id="{42DE338D-29BE-4AD9-AD06-FF16EA4E2B9E}"/>
+                <a16:creationId xmlns:a16="http://schemas.microsoft.com/office/drawing/2014/main" id="{D9FC617E-6811-4B8C-8057-21E8DAF22CF9}"/>
               </a:ext>
             </a:extLst>
           </p:cNvPr>
@@ -3754,7 +3754,7 @@
           <p:cNvPr id="17" name="">
             <a:extLst xmlns:a="http://schemas.openxmlformats.org/drawingml/2006/main">
               <a:ext uri="{FF2B5EF4-FFF2-40B4-BE49-F238E27FC236}">
-                <a16:creationId xmlns:a16="http://schemas.microsoft.com/office/drawing/2014/main" id="{E9256CF9-9AE0-488E-80E2-7E0C053B1A6D}"/>
+                <a16:creationId xmlns:a16="http://schemas.microsoft.com/office/drawing/2014/main" id="{EE50598D-E479-4B5C-96DF-0E2068C4285E}"/>
               </a:ext>
             </a:extLst>
           </p:cNvPr>
@@ -3787,7 +3787,7 @@
           <p:cNvPr id="18" name="">
             <a:extLst xmlns:a="http://schemas.openxmlformats.org/drawingml/2006/main">
               <a:ext uri="{FF2B5EF4-FFF2-40B4-BE49-F238E27FC236}">
-                <a16:creationId xmlns:a16="http://schemas.microsoft.com/office/drawing/2014/main" id="{449452F1-9181-46C1-9CBC-7EEB78684AA0}"/>
+                <a16:creationId xmlns:a16="http://schemas.microsoft.com/office/drawing/2014/main" id="{B23EDEF1-E76B-4D53-817D-4CB89A37AAED}"/>
               </a:ext>
             </a:extLst>
           </p:cNvPr>
@@ -3851,7 +3851,7 @@
           <p:cNvPr id="19" name="">
             <a:extLst xmlns:a="http://schemas.openxmlformats.org/drawingml/2006/main">
               <a:ext uri="{FF2B5EF4-FFF2-40B4-BE49-F238E27FC236}">
-                <a16:creationId xmlns:a16="http://schemas.microsoft.com/office/drawing/2014/main" id="{FE001C4D-B892-4992-BA30-B9D5C672C8CE}"/>
+                <a16:creationId xmlns:a16="http://schemas.microsoft.com/office/drawing/2014/main" id="{A57E48AA-2D42-4BD8-8CA1-F118AC2113B2}"/>
               </a:ext>
             </a:extLst>
           </p:cNvPr>
@@ -3915,7 +3915,7 @@
           <p:cNvPr id="20" name="">
             <a:extLst xmlns:a="http://schemas.openxmlformats.org/drawingml/2006/main">
               <a:ext uri="{FF2B5EF4-FFF2-40B4-BE49-F238E27FC236}">
-                <a16:creationId xmlns:a16="http://schemas.microsoft.com/office/drawing/2014/main" id="{7DC10325-BD30-4CF4-B450-03DEBB71F479}"/>
+                <a16:creationId xmlns:a16="http://schemas.microsoft.com/office/drawing/2014/main" id="{1A0BB29E-1E65-4523-BC5A-34504611D040}"/>
               </a:ext>
             </a:extLst>
           </p:cNvPr>
@@ -3950,7 +3950,7 @@
           <p:cNvPr id="21" name="">
             <a:extLst xmlns:a="http://schemas.openxmlformats.org/drawingml/2006/main">
               <a:ext uri="{FF2B5EF4-FFF2-40B4-BE49-F238E27FC236}">
-                <a16:creationId xmlns:a16="http://schemas.microsoft.com/office/drawing/2014/main" id="{E66DACE9-7548-4D28-A203-FD6C0A223855}"/>
+                <a16:creationId xmlns:a16="http://schemas.microsoft.com/office/drawing/2014/main" id="{CF50B69C-F374-4D8F-943E-1225064AFE91}"/>
               </a:ext>
             </a:extLst>
           </p:cNvPr>
@@ -4014,7 +4014,7 @@
           <p:cNvPr id="22" name="">
             <a:extLst xmlns:a="http://schemas.openxmlformats.org/drawingml/2006/main">
               <a:ext uri="{FF2B5EF4-FFF2-40B4-BE49-F238E27FC236}">
-                <a16:creationId xmlns:a16="http://schemas.microsoft.com/office/drawing/2014/main" id="{0776A52A-21C0-49C8-9CF3-C3F868F86A8A}"/>
+                <a16:creationId xmlns:a16="http://schemas.microsoft.com/office/drawing/2014/main" id="{3D622D75-7996-42AE-BBE3-D056CA6874B7}"/>
               </a:ext>
             </a:extLst>
           </p:cNvPr>
@@ -4047,7 +4047,7 @@
           <p:cNvPr id="23" name="">
             <a:extLst xmlns:a="http://schemas.openxmlformats.org/drawingml/2006/main">
               <a:ext uri="{FF2B5EF4-FFF2-40B4-BE49-F238E27FC236}">
-                <a16:creationId xmlns:a16="http://schemas.microsoft.com/office/drawing/2014/main" id="{C01F132C-29D8-4E98-AF95-A608E28D0BD7}"/>
+                <a16:creationId xmlns:a16="http://schemas.microsoft.com/office/drawing/2014/main" id="{2500C31C-AD09-4B80-A6C1-C1A29B0C4ECE}"/>
               </a:ext>
             </a:extLst>
           </p:cNvPr>
@@ -4111,7 +4111,7 @@
           <p:cNvPr id="24" name="">
             <a:extLst xmlns:a="http://schemas.openxmlformats.org/drawingml/2006/main">
               <a:ext uri="{FF2B5EF4-FFF2-40B4-BE49-F238E27FC236}">
-                <a16:creationId xmlns:a16="http://schemas.microsoft.com/office/drawing/2014/main" id="{9D6010D0-85A6-4758-89D8-25921F02439F}"/>
+                <a16:creationId xmlns:a16="http://schemas.microsoft.com/office/drawing/2014/main" id="{7F4D252D-07F9-44DE-83E1-B303587AFE40}"/>
               </a:ext>
             </a:extLst>
           </p:cNvPr>
@@ -4175,7 +4175,7 @@
           <p:cNvPr id="25" name="">
             <a:extLst xmlns:a="http://schemas.openxmlformats.org/drawingml/2006/main">
               <a:ext uri="{FF2B5EF4-FFF2-40B4-BE49-F238E27FC236}">
-                <a16:creationId xmlns:a16="http://schemas.microsoft.com/office/drawing/2014/main" id="{B386D5B5-E5E8-49B7-9861-8DF98750CD9D}"/>
+                <a16:creationId xmlns:a16="http://schemas.microsoft.com/office/drawing/2014/main" id="{099FEA78-BC4E-4E50-869C-69E5D5CACAD3}"/>
               </a:ext>
             </a:extLst>
           </p:cNvPr>
@@ -4210,7 +4210,7 @@
           <p:cNvPr id="26" name="">
             <a:extLst xmlns:a="http://schemas.openxmlformats.org/drawingml/2006/main">
               <a:ext uri="{FF2B5EF4-FFF2-40B4-BE49-F238E27FC236}">
-                <a16:creationId xmlns:a16="http://schemas.microsoft.com/office/drawing/2014/main" id="{FBDDC3EF-DA93-402B-92A9-F4EBA893596F}"/>
+                <a16:creationId xmlns:a16="http://schemas.microsoft.com/office/drawing/2014/main" id="{A869D078-6003-4DCC-BE4A-F06BFD2B6B89}"/>
               </a:ext>
             </a:extLst>
           </p:cNvPr>
@@ -4274,7 +4274,7 @@
           <p:cNvPr id="27" name="">
             <a:extLst xmlns:a="http://schemas.openxmlformats.org/drawingml/2006/main">
               <a:ext uri="{FF2B5EF4-FFF2-40B4-BE49-F238E27FC236}">
-                <a16:creationId xmlns:a16="http://schemas.microsoft.com/office/drawing/2014/main" id="{D7581A22-3F6D-4E66-A281-1423F77B1F9A}"/>
+                <a16:creationId xmlns:a16="http://schemas.microsoft.com/office/drawing/2014/main" id="{AEB545FC-884B-41CF-AF6B-E3C622A22639}"/>
               </a:ext>
             </a:extLst>
           </p:cNvPr>
@@ -4338,7 +4338,7 @@
           <p:cNvPr id="28" name="">
             <a:extLst xmlns:a="http://schemas.openxmlformats.org/drawingml/2006/main">
               <a:ext uri="{FF2B5EF4-FFF2-40B4-BE49-F238E27FC236}">
-                <a16:creationId xmlns:a16="http://schemas.microsoft.com/office/drawing/2014/main" id="{57F36A62-5AFB-4721-AFF1-2E6A6688884C}"/>
+                <a16:creationId xmlns:a16="http://schemas.microsoft.com/office/drawing/2014/main" id="{77323F81-15B7-4FBA-B0E2-2429CE754F46}"/>
               </a:ext>
             </a:extLst>
           </p:cNvPr>
@@ -4371,7 +4371,7 @@
           <p:cNvPr id="29" name="">
             <a:extLst xmlns:a="http://schemas.openxmlformats.org/drawingml/2006/main">
               <a:ext uri="{FF2B5EF4-FFF2-40B4-BE49-F238E27FC236}">
-                <a16:creationId xmlns:a16="http://schemas.microsoft.com/office/drawing/2014/main" id="{D0C32E2D-A372-41F3-B7C8-9F2B9C7D2245}"/>
+                <a16:creationId xmlns:a16="http://schemas.microsoft.com/office/drawing/2014/main" id="{97666BA7-28B4-498C-85DB-FC9CEE84D4AB}"/>
               </a:ext>
             </a:extLst>
           </p:cNvPr>
@@ -4435,7 +4435,7 @@
           <p:cNvPr id="30" name="">
             <a:extLst xmlns:a="http://schemas.openxmlformats.org/drawingml/2006/main">
               <a:ext uri="{FF2B5EF4-FFF2-40B4-BE49-F238E27FC236}">
-                <a16:creationId xmlns:a16="http://schemas.microsoft.com/office/drawing/2014/main" id="{38C18727-F2BE-4158-9C95-8A8EED13BB65}"/>
+                <a16:creationId xmlns:a16="http://schemas.microsoft.com/office/drawing/2014/main" id="{FA6A3768-4F7C-49B8-B07A-AD3522BD6F54}"/>
               </a:ext>
             </a:extLst>
           </p:cNvPr>
@@ -4468,7 +4468,7 @@
           <p:cNvPr id="31" name="">
             <a:extLst xmlns:a="http://schemas.openxmlformats.org/drawingml/2006/main">
               <a:ext uri="{FF2B5EF4-FFF2-40B4-BE49-F238E27FC236}">
-                <a16:creationId xmlns:a16="http://schemas.microsoft.com/office/drawing/2014/main" id="{65E1CA2A-9DFA-4ADA-9AEE-7AFC3BAD2A2A}"/>
+                <a16:creationId xmlns:a16="http://schemas.microsoft.com/office/drawing/2014/main" id="{3BE1D04C-0D85-4FDE-8021-3829CCBECEB5}"/>
               </a:ext>
             </a:extLst>
           </p:cNvPr>
@@ -4532,7 +4532,7 @@
           <p:cNvPr id="32" name="">
             <a:extLst xmlns:a="http://schemas.openxmlformats.org/drawingml/2006/main">
               <a:ext uri="{FF2B5EF4-FFF2-40B4-BE49-F238E27FC236}">
-                <a16:creationId xmlns:a16="http://schemas.microsoft.com/office/drawing/2014/main" id="{E4DEC468-6F65-4C83-975E-A9E2C03BA9B6}"/>
+                <a16:creationId xmlns:a16="http://schemas.microsoft.com/office/drawing/2014/main" id="{9FC0A95C-6C3E-4D7E-9322-4783AC4B2DC9}"/>
               </a:ext>
             </a:extLst>
           </p:cNvPr>
@@ -4565,7 +4565,7 @@
           <p:cNvPr id="33" name="">
             <a:extLst xmlns:a="http://schemas.openxmlformats.org/drawingml/2006/main">
               <a:ext uri="{FF2B5EF4-FFF2-40B4-BE49-F238E27FC236}">
-                <a16:creationId xmlns:a16="http://schemas.microsoft.com/office/drawing/2014/main" id="{0331EA34-4F12-4EBD-9BCA-59B695FFF9A3}"/>
+                <a16:creationId xmlns:a16="http://schemas.microsoft.com/office/drawing/2014/main" id="{65A66AE2-4706-4C25-B3AE-A92792189688}"/>
               </a:ext>
             </a:extLst>
           </p:cNvPr>
@@ -4629,7 +4629,7 @@
           <p:cNvPr id="34" name="">
             <a:extLst xmlns:a="http://schemas.openxmlformats.org/drawingml/2006/main">
               <a:ext uri="{FF2B5EF4-FFF2-40B4-BE49-F238E27FC236}">
-                <a16:creationId xmlns:a16="http://schemas.microsoft.com/office/drawing/2014/main" id="{5DAA4D4B-5FBA-434F-9185-FD7E2F2852B3}"/>
+                <a16:creationId xmlns:a16="http://schemas.microsoft.com/office/drawing/2014/main" id="{8D7B5AC9-B0B2-42BC-A4AF-465BF5B7FF27}"/>
               </a:ext>
             </a:extLst>
           </p:cNvPr>
@@ -4693,7 +4693,7 @@
           <p:cNvPr id="35" name="">
             <a:extLst xmlns:a="http://schemas.openxmlformats.org/drawingml/2006/main">
               <a:ext uri="{FF2B5EF4-FFF2-40B4-BE49-F238E27FC236}">
-                <a16:creationId xmlns:a16="http://schemas.microsoft.com/office/drawing/2014/main" id="{152EDAEB-2A99-45B6-AB0E-5842EA140005}"/>
+                <a16:creationId xmlns:a16="http://schemas.microsoft.com/office/drawing/2014/main" id="{A01059B5-087B-4B47-8342-66D63C918362}"/>
               </a:ext>
             </a:extLst>
           </p:cNvPr>
@@ -4728,7 +4728,7 @@
           <p:cNvPr id="36" name="">
             <a:extLst xmlns:a="http://schemas.openxmlformats.org/drawingml/2006/main">
               <a:ext uri="{FF2B5EF4-FFF2-40B4-BE49-F238E27FC236}">
-                <a16:creationId xmlns:a16="http://schemas.microsoft.com/office/drawing/2014/main" id="{F28241AE-1737-4205-9908-076342B0E66B}"/>
+                <a16:creationId xmlns:a16="http://schemas.microsoft.com/office/drawing/2014/main" id="{CA75E65B-82C3-478A-B88D-E761629F168B}"/>
               </a:ext>
             </a:extLst>
           </p:cNvPr>
@@ -4792,7 +4792,7 @@
           <p:cNvPr id="37" name="">
             <a:extLst xmlns:a="http://schemas.openxmlformats.org/drawingml/2006/main">
               <a:ext uri="{FF2B5EF4-FFF2-40B4-BE49-F238E27FC236}">
-                <a16:creationId xmlns:a16="http://schemas.microsoft.com/office/drawing/2014/main" id="{613397F4-6431-48D8-A241-21F08985816C}"/>
+                <a16:creationId xmlns:a16="http://schemas.microsoft.com/office/drawing/2014/main" id="{136121C8-92B0-42CA-BD52-7C736ABF58F7}"/>
               </a:ext>
             </a:extLst>
           </p:cNvPr>
@@ -4854,7 +4854,7 @@
     </p:spTree>
     <p:extLst>
       <p:ext uri="{BB962C8B-B14F-4D97-AF65-F5344CB8AC3E}">
-        <p14:creationId xmlns:p14="http://schemas.microsoft.com/office/powerpoint/2010/main" val="1993392140"/>
+        <p14:creationId xmlns:p14="http://schemas.microsoft.com/office/powerpoint/2010/main" val="637665610"/>
       </p:ext>
     </p:extLst>
   </p:cSld>
@@ -4878,7 +4878,7 @@
           <p:cNvPr id="1" name="">
             <a:extLst xmlns:a="http://schemas.openxmlformats.org/drawingml/2006/main">
               <a:ext uri="{FF2B5EF4-FFF2-40B4-BE49-F238E27FC236}">
-                <a16:creationId xmlns:a16="http://schemas.microsoft.com/office/drawing/2014/main" id="{F2FCAAAE-73B8-41BB-A8A3-C4B036C46D6D}"/>
+                <a16:creationId xmlns:a16="http://schemas.microsoft.com/office/drawing/2014/main" id="{40BF4023-DB3C-43CC-BB10-9D4FE987873A}"/>
               </a:ext>
             </a:extLst>
           </p:cNvPr>
@@ -4913,7 +4913,7 @@
           <p:cNvPr id="2" name="">
             <a:extLst xmlns:a="http://schemas.openxmlformats.org/drawingml/2006/main">
               <a:ext uri="{FF2B5EF4-FFF2-40B4-BE49-F238E27FC236}">
-                <a16:creationId xmlns:a16="http://schemas.microsoft.com/office/drawing/2014/main" id="{586E1AE0-9A85-4A3D-A45B-2B81C46DB005}"/>
+                <a16:creationId xmlns:a16="http://schemas.microsoft.com/office/drawing/2014/main" id="{15B52F8A-DA42-4DA2-8F57-E2E1456DCB34}"/>
               </a:ext>
             </a:extLst>
           </p:cNvPr>
@@ -4948,7 +4948,7 @@
           <p:cNvPr id="3" name="kicker-marker">
             <a:extLst xmlns:a="http://schemas.openxmlformats.org/drawingml/2006/main">
               <a:ext uri="{FF2B5EF4-FFF2-40B4-BE49-F238E27FC236}">
-                <a16:creationId xmlns:a16="http://schemas.microsoft.com/office/drawing/2014/main" id="{3293E6F9-9230-423E-A5D7-142D43C9A108}"/>
+                <a16:creationId xmlns:a16="http://schemas.microsoft.com/office/drawing/2014/main" id="{2685BEF7-F01E-4A39-AE8E-03DF04090F33}"/>
               </a:ext>
             </a:extLst>
           </p:cNvPr>
@@ -4983,7 +4983,7 @@
           <p:cNvPr id="4" name="kicker-label">
             <a:extLst xmlns:a="http://schemas.openxmlformats.org/drawingml/2006/main">
               <a:ext uri="{FF2B5EF4-FFF2-40B4-BE49-F238E27FC236}">
-                <a16:creationId xmlns:a16="http://schemas.microsoft.com/office/drawing/2014/main" id="{27178395-E070-439F-B404-951D9A1BBA77}"/>
+                <a16:creationId xmlns:a16="http://schemas.microsoft.com/office/drawing/2014/main" id="{E3E2DB66-9D1E-481D-9BFA-393B4DF6BD19}"/>
               </a:ext>
             </a:extLst>
           </p:cNvPr>
@@ -5047,7 +5047,7 @@
           <p:cNvPr id="5" name="">
             <a:extLst xmlns:a="http://schemas.openxmlformats.org/drawingml/2006/main">
               <a:ext uri="{FF2B5EF4-FFF2-40B4-BE49-F238E27FC236}">
-                <a16:creationId xmlns:a16="http://schemas.microsoft.com/office/drawing/2014/main" id="{0CD45C1B-0A67-4D0B-B070-DDFB8BE500B0}"/>
+                <a16:creationId xmlns:a16="http://schemas.microsoft.com/office/drawing/2014/main" id="{4A700A59-7B22-4FBB-BAE5-771C12D213D5}"/>
               </a:ext>
             </a:extLst>
           </p:cNvPr>
@@ -5111,7 +5111,7 @@
           <p:cNvPr id="6" name="">
             <a:extLst xmlns:a="http://schemas.openxmlformats.org/drawingml/2006/main">
               <a:ext uri="{FF2B5EF4-FFF2-40B4-BE49-F238E27FC236}">
-                <a16:creationId xmlns:a16="http://schemas.microsoft.com/office/drawing/2014/main" id="{C6E0F6E3-F318-4D74-A952-3DC693694E49}"/>
+                <a16:creationId xmlns:a16="http://schemas.microsoft.com/office/drawing/2014/main" id="{43929C1B-3527-4808-BCCE-BF5141DF5A9F}"/>
               </a:ext>
             </a:extLst>
           </p:cNvPr>
@@ -5175,7 +5175,7 @@
           <p:cNvPr id="7" name="">
             <a:extLst xmlns:a="http://schemas.openxmlformats.org/drawingml/2006/main">
               <a:ext uri="{FF2B5EF4-FFF2-40B4-BE49-F238E27FC236}">
-                <a16:creationId xmlns:a16="http://schemas.microsoft.com/office/drawing/2014/main" id="{9CFC3A57-38E9-4BBE-9ACF-E11E2ECDED51}"/>
+                <a16:creationId xmlns:a16="http://schemas.microsoft.com/office/drawing/2014/main" id="{A5067023-5223-4DC6-B70E-167034472899}"/>
               </a:ext>
             </a:extLst>
           </p:cNvPr>
@@ -5210,7 +5210,7 @@
           <p:cNvPr id="8" name="">
             <a:extLst xmlns:a="http://schemas.openxmlformats.org/drawingml/2006/main">
               <a:ext uri="{FF2B5EF4-FFF2-40B4-BE49-F238E27FC236}">
-                <a16:creationId xmlns:a16="http://schemas.microsoft.com/office/drawing/2014/main" id="{72D81E1E-7665-486A-AEE2-F2C141854FA3}"/>
+                <a16:creationId xmlns:a16="http://schemas.microsoft.com/office/drawing/2014/main" id="{0B2A445D-928A-43B2-AACB-06F1BB506DC5}"/>
               </a:ext>
             </a:extLst>
           </p:cNvPr>
@@ -5274,7 +5274,7 @@
           <p:cNvPr id="9" name="">
             <a:extLst xmlns:a="http://schemas.openxmlformats.org/drawingml/2006/main">
               <a:ext uri="{FF2B5EF4-FFF2-40B4-BE49-F238E27FC236}">
-                <a16:creationId xmlns:a16="http://schemas.microsoft.com/office/drawing/2014/main" id="{AA541E9C-62FF-4573-B648-38C3A005FD32}"/>
+                <a16:creationId xmlns:a16="http://schemas.microsoft.com/office/drawing/2014/main" id="{F0C8A477-B915-4F1A-B060-BC9F74BFA2EC}"/>
               </a:ext>
             </a:extLst>
           </p:cNvPr>
@@ -5338,7 +5338,7 @@
           <p:cNvPr id="10" name="">
             <a:extLst xmlns:a="http://schemas.openxmlformats.org/drawingml/2006/main">
               <a:ext uri="{FF2B5EF4-FFF2-40B4-BE49-F238E27FC236}">
-                <a16:creationId xmlns:a16="http://schemas.microsoft.com/office/drawing/2014/main" id="{5AD6E915-D6D9-40A8-9A45-835F3EED03E3}"/>
+                <a16:creationId xmlns:a16="http://schemas.microsoft.com/office/drawing/2014/main" id="{F8B056A7-5F37-4123-8A0C-4D64FE09E7FA}"/>
               </a:ext>
             </a:extLst>
           </p:cNvPr>
@@ -5402,7 +5402,7 @@
           <p:cNvPr id="11" name="">
             <a:extLst xmlns:a="http://schemas.openxmlformats.org/drawingml/2006/main">
               <a:ext uri="{FF2B5EF4-FFF2-40B4-BE49-F238E27FC236}">
-                <a16:creationId xmlns:a16="http://schemas.microsoft.com/office/drawing/2014/main" id="{CF75B645-4FA5-4C72-99BB-F9160672333F}"/>
+                <a16:creationId xmlns:a16="http://schemas.microsoft.com/office/drawing/2014/main" id="{E695861F-75AB-4061-9BE2-59847531FDD2}"/>
               </a:ext>
             </a:extLst>
           </p:cNvPr>
@@ -5466,7 +5466,7 @@
           <p:cNvPr id="12" name="">
             <a:extLst xmlns:a="http://schemas.openxmlformats.org/drawingml/2006/main">
               <a:ext uri="{FF2B5EF4-FFF2-40B4-BE49-F238E27FC236}">
-                <a16:creationId xmlns:a16="http://schemas.microsoft.com/office/drawing/2014/main" id="{6FBF428B-905F-4C88-B5EF-6B4D0503BE62}"/>
+                <a16:creationId xmlns:a16="http://schemas.microsoft.com/office/drawing/2014/main" id="{BDBD456B-9718-4B25-A8CE-446B6BC02220}"/>
               </a:ext>
             </a:extLst>
           </p:cNvPr>
@@ -5499,7 +5499,7 @@
           <p:cNvPr id="13" name="">
             <a:extLst xmlns:a="http://schemas.openxmlformats.org/drawingml/2006/main">
               <a:ext uri="{FF2B5EF4-FFF2-40B4-BE49-F238E27FC236}">
-                <a16:creationId xmlns:a16="http://schemas.microsoft.com/office/drawing/2014/main" id="{66F8B083-7C4F-4B19-B660-FCF6D7441471}"/>
+                <a16:creationId xmlns:a16="http://schemas.microsoft.com/office/drawing/2014/main" id="{1C4D6FFF-5248-4755-8F27-C4E4BAACBB94}"/>
               </a:ext>
             </a:extLst>
           </p:cNvPr>
@@ -5563,7 +5563,7 @@
           <p:cNvPr id="14" name="">
             <a:extLst xmlns:a="http://schemas.openxmlformats.org/drawingml/2006/main">
               <a:ext uri="{FF2B5EF4-FFF2-40B4-BE49-F238E27FC236}">
-                <a16:creationId xmlns:a16="http://schemas.microsoft.com/office/drawing/2014/main" id="{52285CA4-4851-4939-9E06-1F765B4C9BCE}"/>
+                <a16:creationId xmlns:a16="http://schemas.microsoft.com/office/drawing/2014/main" id="{B782686F-B345-403C-88A2-ACB331A999ED}"/>
               </a:ext>
             </a:extLst>
           </p:cNvPr>
@@ -5627,7 +5627,7 @@
           <p:cNvPr id="15" name="">
             <a:extLst xmlns:a="http://schemas.openxmlformats.org/drawingml/2006/main">
               <a:ext uri="{FF2B5EF4-FFF2-40B4-BE49-F238E27FC236}">
-                <a16:creationId xmlns:a16="http://schemas.microsoft.com/office/drawing/2014/main" id="{792C45A9-9EC9-454C-84F6-C83B9A1A6EF8}"/>
+                <a16:creationId xmlns:a16="http://schemas.microsoft.com/office/drawing/2014/main" id="{4919812F-718E-4F00-861C-5B484BD2BB7D}"/>
               </a:ext>
             </a:extLst>
           </p:cNvPr>
@@ -5691,7 +5691,7 @@
           <p:cNvPr id="16" name="">
             <a:extLst xmlns:a="http://schemas.openxmlformats.org/drawingml/2006/main">
               <a:ext uri="{FF2B5EF4-FFF2-40B4-BE49-F238E27FC236}">
-                <a16:creationId xmlns:a16="http://schemas.microsoft.com/office/drawing/2014/main" id="{A65C069A-E919-4D22-A107-6DB523697E5C}"/>
+                <a16:creationId xmlns:a16="http://schemas.microsoft.com/office/drawing/2014/main" id="{2B856E52-9F30-4C35-9313-CC0F9F84D982}"/>
               </a:ext>
             </a:extLst>
           </p:cNvPr>
@@ -5755,7 +5755,7 @@
           <p:cNvPr id="17" name="">
             <a:extLst xmlns:a="http://schemas.openxmlformats.org/drawingml/2006/main">
               <a:ext uri="{FF2B5EF4-FFF2-40B4-BE49-F238E27FC236}">
-                <a16:creationId xmlns:a16="http://schemas.microsoft.com/office/drawing/2014/main" id="{E6091592-2846-43B0-BB51-08E5C4F0DE56}"/>
+                <a16:creationId xmlns:a16="http://schemas.microsoft.com/office/drawing/2014/main" id="{BAB26800-57CD-4557-9067-99F187B39166}"/>
               </a:ext>
             </a:extLst>
           </p:cNvPr>
@@ -5788,7 +5788,7 @@
           <p:cNvPr id="18" name="">
             <a:extLst xmlns:a="http://schemas.openxmlformats.org/drawingml/2006/main">
               <a:ext uri="{FF2B5EF4-FFF2-40B4-BE49-F238E27FC236}">
-                <a16:creationId xmlns:a16="http://schemas.microsoft.com/office/drawing/2014/main" id="{C9B5E2DC-C0D4-454F-A87C-B4EE2F0A6BBB}"/>
+                <a16:creationId xmlns:a16="http://schemas.microsoft.com/office/drawing/2014/main" id="{F9541533-1AC9-4071-81C3-8665C29E764B}"/>
               </a:ext>
             </a:extLst>
           </p:cNvPr>
@@ -5852,7 +5852,7 @@
           <p:cNvPr id="19" name="">
             <a:extLst xmlns:a="http://schemas.openxmlformats.org/drawingml/2006/main">
               <a:ext uri="{FF2B5EF4-FFF2-40B4-BE49-F238E27FC236}">
-                <a16:creationId xmlns:a16="http://schemas.microsoft.com/office/drawing/2014/main" id="{5A6E13F6-BDE2-4605-AFA7-5E4C2481FEEB}"/>
+                <a16:creationId xmlns:a16="http://schemas.microsoft.com/office/drawing/2014/main" id="{24372401-CE83-45E8-92CF-A79A04626C1B}"/>
               </a:ext>
             </a:extLst>
           </p:cNvPr>
@@ -5916,7 +5916,7 @@
           <p:cNvPr id="20" name="">
             <a:extLst xmlns:a="http://schemas.openxmlformats.org/drawingml/2006/main">
               <a:ext uri="{FF2B5EF4-FFF2-40B4-BE49-F238E27FC236}">
-                <a16:creationId xmlns:a16="http://schemas.microsoft.com/office/drawing/2014/main" id="{C51F2CED-2A1A-49DB-B12A-D6E33F0BF74A}"/>
+                <a16:creationId xmlns:a16="http://schemas.microsoft.com/office/drawing/2014/main" id="{221CCD3A-F4FF-43C7-997D-FEECBC90D8EE}"/>
               </a:ext>
             </a:extLst>
           </p:cNvPr>
@@ -5980,7 +5980,7 @@
           <p:cNvPr id="21" name="">
             <a:extLst xmlns:a="http://schemas.openxmlformats.org/drawingml/2006/main">
               <a:ext uri="{FF2B5EF4-FFF2-40B4-BE49-F238E27FC236}">
-                <a16:creationId xmlns:a16="http://schemas.microsoft.com/office/drawing/2014/main" id="{0EE55DF5-02FD-4ECC-ABF3-54F902C95C76}"/>
+                <a16:creationId xmlns:a16="http://schemas.microsoft.com/office/drawing/2014/main" id="{29AF9B07-2214-4063-B261-4BBD03B8E88D}"/>
               </a:ext>
             </a:extLst>
           </p:cNvPr>
@@ -6044,7 +6044,7 @@
           <p:cNvPr id="22" name="">
             <a:extLst xmlns:a="http://schemas.openxmlformats.org/drawingml/2006/main">
               <a:ext uri="{FF2B5EF4-FFF2-40B4-BE49-F238E27FC236}">
-                <a16:creationId xmlns:a16="http://schemas.microsoft.com/office/drawing/2014/main" id="{080C7082-98C9-4048-9B50-4E9510794F60}"/>
+                <a16:creationId xmlns:a16="http://schemas.microsoft.com/office/drawing/2014/main" id="{06A91046-6B33-4A62-AAED-998674569E7E}"/>
               </a:ext>
             </a:extLst>
           </p:cNvPr>
@@ -6077,7 +6077,7 @@
           <p:cNvPr id="23" name="">
             <a:extLst xmlns:a="http://schemas.openxmlformats.org/drawingml/2006/main">
               <a:ext uri="{FF2B5EF4-FFF2-40B4-BE49-F238E27FC236}">
-                <a16:creationId xmlns:a16="http://schemas.microsoft.com/office/drawing/2014/main" id="{C4D6B81B-3DDA-4F65-89F3-F0E5857DCF84}"/>
+                <a16:creationId xmlns:a16="http://schemas.microsoft.com/office/drawing/2014/main" id="{A19CB6B8-76F1-4940-9F72-3E6DECAFE60D}"/>
               </a:ext>
             </a:extLst>
           </p:cNvPr>
@@ -6141,7 +6141,7 @@
           <p:cNvPr id="24" name="">
             <a:extLst xmlns:a="http://schemas.openxmlformats.org/drawingml/2006/main">
               <a:ext uri="{FF2B5EF4-FFF2-40B4-BE49-F238E27FC236}">
-                <a16:creationId xmlns:a16="http://schemas.microsoft.com/office/drawing/2014/main" id="{EF4C99C3-5BF3-40D6-9DC3-AF1B65DFF74A}"/>
+                <a16:creationId xmlns:a16="http://schemas.microsoft.com/office/drawing/2014/main" id="{BBE4E233-B7C4-4C1D-B17F-72B27B86B4CA}"/>
               </a:ext>
             </a:extLst>
           </p:cNvPr>
@@ -6205,7 +6205,7 @@
           <p:cNvPr id="25" name="">
             <a:extLst xmlns:a="http://schemas.openxmlformats.org/drawingml/2006/main">
               <a:ext uri="{FF2B5EF4-FFF2-40B4-BE49-F238E27FC236}">
-                <a16:creationId xmlns:a16="http://schemas.microsoft.com/office/drawing/2014/main" id="{BF7998BE-2544-4BA0-8E4B-06F59E79500C}"/>
+                <a16:creationId xmlns:a16="http://schemas.microsoft.com/office/drawing/2014/main" id="{BF8E4703-1C2A-4ABE-96EA-4F27D5DAA84A}"/>
               </a:ext>
             </a:extLst>
           </p:cNvPr>
@@ -6269,7 +6269,7 @@
           <p:cNvPr id="26" name="">
             <a:extLst xmlns:a="http://schemas.openxmlformats.org/drawingml/2006/main">
               <a:ext uri="{FF2B5EF4-FFF2-40B4-BE49-F238E27FC236}">
-                <a16:creationId xmlns:a16="http://schemas.microsoft.com/office/drawing/2014/main" id="{3FCE1558-EF77-4DFD-8D75-1CA0B0B0656E}"/>
+                <a16:creationId xmlns:a16="http://schemas.microsoft.com/office/drawing/2014/main" id="{4C7B55B7-D271-41DF-B6E8-C9ED2B424155}"/>
               </a:ext>
             </a:extLst>
           </p:cNvPr>
@@ -6333,7 +6333,7 @@
           <p:cNvPr id="27" name="">
             <a:extLst xmlns:a="http://schemas.openxmlformats.org/drawingml/2006/main">
               <a:ext uri="{FF2B5EF4-FFF2-40B4-BE49-F238E27FC236}">
-                <a16:creationId xmlns:a16="http://schemas.microsoft.com/office/drawing/2014/main" id="{8DC4427C-0CF1-4BB2-8F41-AACB472F1496}"/>
+                <a16:creationId xmlns:a16="http://schemas.microsoft.com/office/drawing/2014/main" id="{5BB60E7C-CFDF-493F-B727-265FC7C3DD61}"/>
               </a:ext>
             </a:extLst>
           </p:cNvPr>
@@ -6366,7 +6366,7 @@
           <p:cNvPr id="28" name="">
             <a:extLst xmlns:a="http://schemas.openxmlformats.org/drawingml/2006/main">
               <a:ext uri="{FF2B5EF4-FFF2-40B4-BE49-F238E27FC236}">
-                <a16:creationId xmlns:a16="http://schemas.microsoft.com/office/drawing/2014/main" id="{6DCC458E-AB5B-455B-B788-5F199E10C659}"/>
+                <a16:creationId xmlns:a16="http://schemas.microsoft.com/office/drawing/2014/main" id="{5A4B8CCE-F210-4B03-B4CE-538C59C4A548}"/>
               </a:ext>
             </a:extLst>
           </p:cNvPr>
@@ -6430,7 +6430,7 @@
           <p:cNvPr id="29" name="">
             <a:extLst xmlns:a="http://schemas.openxmlformats.org/drawingml/2006/main">
               <a:ext uri="{FF2B5EF4-FFF2-40B4-BE49-F238E27FC236}">
-                <a16:creationId xmlns:a16="http://schemas.microsoft.com/office/drawing/2014/main" id="{4CDA1422-C3DE-441B-A9A5-8785233E260B}"/>
+                <a16:creationId xmlns:a16="http://schemas.microsoft.com/office/drawing/2014/main" id="{E50E2DA1-7226-4B54-AA7D-468157D899CF}"/>
               </a:ext>
             </a:extLst>
           </p:cNvPr>
@@ -6494,7 +6494,7 @@
           <p:cNvPr id="30" name="">
             <a:extLst xmlns:a="http://schemas.openxmlformats.org/drawingml/2006/main">
               <a:ext uri="{FF2B5EF4-FFF2-40B4-BE49-F238E27FC236}">
-                <a16:creationId xmlns:a16="http://schemas.microsoft.com/office/drawing/2014/main" id="{04DA3784-F053-4F36-A601-8A2CDDFC3DB8}"/>
+                <a16:creationId xmlns:a16="http://schemas.microsoft.com/office/drawing/2014/main" id="{252EC752-8D3B-468D-AFC5-9510A304F92A}"/>
               </a:ext>
             </a:extLst>
           </p:cNvPr>
@@ -6558,7 +6558,7 @@
           <p:cNvPr id="31" name="">
             <a:extLst xmlns:a="http://schemas.openxmlformats.org/drawingml/2006/main">
               <a:ext uri="{FF2B5EF4-FFF2-40B4-BE49-F238E27FC236}">
-                <a16:creationId xmlns:a16="http://schemas.microsoft.com/office/drawing/2014/main" id="{C8D2A9BA-C9FA-4A16-9D49-4A3FD673E699}"/>
+                <a16:creationId xmlns:a16="http://schemas.microsoft.com/office/drawing/2014/main" id="{57D97DDC-1CFE-4C91-8848-F9844332BFAD}"/>
               </a:ext>
             </a:extLst>
           </p:cNvPr>
@@ -6622,7 +6622,7 @@
           <p:cNvPr id="32" name="">
             <a:extLst xmlns:a="http://schemas.openxmlformats.org/drawingml/2006/main">
               <a:ext uri="{FF2B5EF4-FFF2-40B4-BE49-F238E27FC236}">
-                <a16:creationId xmlns:a16="http://schemas.microsoft.com/office/drawing/2014/main" id="{65992ABB-FE18-4355-82E8-047E4AB7CC4F}"/>
+                <a16:creationId xmlns:a16="http://schemas.microsoft.com/office/drawing/2014/main" id="{DF2893D0-509F-40ED-ABDB-09F72028C6C5}"/>
               </a:ext>
             </a:extLst>
           </p:cNvPr>
@@ -6655,7 +6655,7 @@
           <p:cNvPr id="33" name="">
             <a:extLst xmlns:a="http://schemas.openxmlformats.org/drawingml/2006/main">
               <a:ext uri="{FF2B5EF4-FFF2-40B4-BE49-F238E27FC236}">
-                <a16:creationId xmlns:a16="http://schemas.microsoft.com/office/drawing/2014/main" id="{453E0B81-7BA0-4495-B3D7-097148EA1700}"/>
+                <a16:creationId xmlns:a16="http://schemas.microsoft.com/office/drawing/2014/main" id="{9B3C799F-1723-4D5A-B6C9-8304BB5C1274}"/>
               </a:ext>
             </a:extLst>
           </p:cNvPr>
@@ -6719,7 +6719,7 @@
           <p:cNvPr id="34" name="">
             <a:extLst xmlns:a="http://schemas.openxmlformats.org/drawingml/2006/main">
               <a:ext uri="{FF2B5EF4-FFF2-40B4-BE49-F238E27FC236}">
-                <a16:creationId xmlns:a16="http://schemas.microsoft.com/office/drawing/2014/main" id="{C1A3FD07-CBDD-4787-A68C-D8BDA112F192}"/>
+                <a16:creationId xmlns:a16="http://schemas.microsoft.com/office/drawing/2014/main" id="{5A3CFBC5-4ED9-4EFA-ADB6-1288F36EF256}"/>
               </a:ext>
             </a:extLst>
           </p:cNvPr>
@@ -6783,7 +6783,7 @@
           <p:cNvPr id="35" name="">
             <a:extLst xmlns:a="http://schemas.openxmlformats.org/drawingml/2006/main">
               <a:ext uri="{FF2B5EF4-FFF2-40B4-BE49-F238E27FC236}">
-                <a16:creationId xmlns:a16="http://schemas.microsoft.com/office/drawing/2014/main" id="{13F96B49-FC0B-4AEA-BB1F-1F30DBFF053A}"/>
+                <a16:creationId xmlns:a16="http://schemas.microsoft.com/office/drawing/2014/main" id="{0B5C102A-8A5B-4CF0-9A07-F08078C244EA}"/>
               </a:ext>
             </a:extLst>
           </p:cNvPr>
@@ -6847,7 +6847,7 @@
           <p:cNvPr id="36" name="">
             <a:extLst xmlns:a="http://schemas.openxmlformats.org/drawingml/2006/main">
               <a:ext uri="{FF2B5EF4-FFF2-40B4-BE49-F238E27FC236}">
-                <a16:creationId xmlns:a16="http://schemas.microsoft.com/office/drawing/2014/main" id="{9BE17F0B-3E8B-4060-81D2-9AC764F4AE55}"/>
+                <a16:creationId xmlns:a16="http://schemas.microsoft.com/office/drawing/2014/main" id="{2072C788-679A-4E97-AEED-ED575AFFFA96}"/>
               </a:ext>
             </a:extLst>
           </p:cNvPr>
@@ -6911,7 +6911,7 @@
           <p:cNvPr id="37" name="">
             <a:extLst xmlns:a="http://schemas.openxmlformats.org/drawingml/2006/main">
               <a:ext uri="{FF2B5EF4-FFF2-40B4-BE49-F238E27FC236}">
-                <a16:creationId xmlns:a16="http://schemas.microsoft.com/office/drawing/2014/main" id="{AD4ED72D-830C-4CAF-8BB2-A7CB9D6CEE40}"/>
+                <a16:creationId xmlns:a16="http://schemas.microsoft.com/office/drawing/2014/main" id="{BB96F4C3-F63F-4A60-BBF1-FC41B5EBEC26}"/>
               </a:ext>
             </a:extLst>
           </p:cNvPr>
@@ -6946,7 +6946,7 @@
           <p:cNvPr id="38" name="">
             <a:extLst xmlns:a="http://schemas.openxmlformats.org/drawingml/2006/main">
               <a:ext uri="{FF2B5EF4-FFF2-40B4-BE49-F238E27FC236}">
-                <a16:creationId xmlns:a16="http://schemas.microsoft.com/office/drawing/2014/main" id="{0D3D7635-19B8-4CD2-81EF-6DFA605CB3D2}"/>
+                <a16:creationId xmlns:a16="http://schemas.microsoft.com/office/drawing/2014/main" id="{22180C46-DF50-419A-BB0F-80A1B6859509}"/>
               </a:ext>
             </a:extLst>
           </p:cNvPr>
@@ -7010,7 +7010,7 @@
           <p:cNvPr id="39" name="">
             <a:extLst xmlns:a="http://schemas.openxmlformats.org/drawingml/2006/main">
               <a:ext uri="{FF2B5EF4-FFF2-40B4-BE49-F238E27FC236}">
-                <a16:creationId xmlns:a16="http://schemas.microsoft.com/office/drawing/2014/main" id="{22E52ECA-26AA-4D86-897F-17843E413036}"/>
+                <a16:creationId xmlns:a16="http://schemas.microsoft.com/office/drawing/2014/main" id="{73B73D06-65C8-4059-9DD6-3807C80C0DD3}"/>
               </a:ext>
             </a:extLst>
           </p:cNvPr>
@@ -7043,7 +7043,7 @@
           <p:cNvPr id="40" name="">
             <a:extLst xmlns:a="http://schemas.openxmlformats.org/drawingml/2006/main">
               <a:ext uri="{FF2B5EF4-FFF2-40B4-BE49-F238E27FC236}">
-                <a16:creationId xmlns:a16="http://schemas.microsoft.com/office/drawing/2014/main" id="{940C184F-FE48-41E8-ABDB-46AA5EFD65B4}"/>
+                <a16:creationId xmlns:a16="http://schemas.microsoft.com/office/drawing/2014/main" id="{46497D61-649F-4BFD-A620-A62082BD1260}"/>
               </a:ext>
             </a:extLst>
           </p:cNvPr>
@@ -7107,7 +7107,7 @@
           <p:cNvPr id="41" name="">
             <a:extLst xmlns:a="http://schemas.openxmlformats.org/drawingml/2006/main">
               <a:ext uri="{FF2B5EF4-FFF2-40B4-BE49-F238E27FC236}">
-                <a16:creationId xmlns:a16="http://schemas.microsoft.com/office/drawing/2014/main" id="{A0D0AD7F-7FB7-4446-8F5C-FEAA07F42731}"/>
+                <a16:creationId xmlns:a16="http://schemas.microsoft.com/office/drawing/2014/main" id="{8E0E73FF-6A6F-488D-9415-72E9CEC52578}"/>
               </a:ext>
             </a:extLst>
           </p:cNvPr>
@@ -7142,7 +7142,7 @@
           <p:cNvPr id="42" name="">
             <a:extLst xmlns:a="http://schemas.openxmlformats.org/drawingml/2006/main">
               <a:ext uri="{FF2B5EF4-FFF2-40B4-BE49-F238E27FC236}">
-                <a16:creationId xmlns:a16="http://schemas.microsoft.com/office/drawing/2014/main" id="{1CE10A96-1510-4894-95C9-FCFCB3F99CD9}"/>
+                <a16:creationId xmlns:a16="http://schemas.microsoft.com/office/drawing/2014/main" id="{E1299C49-092A-4A2B-B81E-19E02175676E}"/>
               </a:ext>
             </a:extLst>
           </p:cNvPr>
@@ -7206,7 +7206,7 @@
           <p:cNvPr id="43" name="">
             <a:extLst xmlns:a="http://schemas.openxmlformats.org/drawingml/2006/main">
               <a:ext uri="{FF2B5EF4-FFF2-40B4-BE49-F238E27FC236}">
-                <a16:creationId xmlns:a16="http://schemas.microsoft.com/office/drawing/2014/main" id="{07FB8BA0-C8CE-4F9F-A24C-E0D139B5B079}"/>
+                <a16:creationId xmlns:a16="http://schemas.microsoft.com/office/drawing/2014/main" id="{B53323F1-F3D5-467E-8E8B-51FCC28C5594}"/>
               </a:ext>
             </a:extLst>
           </p:cNvPr>
@@ -7268,7 +7268,7 @@
     </p:spTree>
     <p:extLst>
       <p:ext uri="{BB962C8B-B14F-4D97-AF65-F5344CB8AC3E}">
-        <p14:creationId xmlns:p14="http://schemas.microsoft.com/office/powerpoint/2010/main" val="2019477854"/>
+        <p14:creationId xmlns:p14="http://schemas.microsoft.com/office/powerpoint/2010/main" val="1376826869"/>
       </p:ext>
     </p:extLst>
   </p:cSld>
@@ -7292,7 +7292,7 @@
           <p:cNvPr id="1" name="">
             <a:extLst xmlns:a="http://schemas.openxmlformats.org/drawingml/2006/main">
               <a:ext uri="{FF2B5EF4-FFF2-40B4-BE49-F238E27FC236}">
-                <a16:creationId xmlns:a16="http://schemas.microsoft.com/office/drawing/2014/main" id="{7C747907-C424-47C3-BAA1-1A4990268AEC}"/>
+                <a16:creationId xmlns:a16="http://schemas.microsoft.com/office/drawing/2014/main" id="{374CCD62-1B92-45B6-BB26-3B532DDE76BB}"/>
               </a:ext>
             </a:extLst>
           </p:cNvPr>
@@ -7327,7 +7327,7 @@
           <p:cNvPr id="2" name="">
             <a:extLst xmlns:a="http://schemas.openxmlformats.org/drawingml/2006/main">
               <a:ext uri="{FF2B5EF4-FFF2-40B4-BE49-F238E27FC236}">
-                <a16:creationId xmlns:a16="http://schemas.microsoft.com/office/drawing/2014/main" id="{91286DEB-7905-4418-BF23-7AF314F3519E}"/>
+                <a16:creationId xmlns:a16="http://schemas.microsoft.com/office/drawing/2014/main" id="{A70E45D1-A142-47DC-B6E6-149C3BD54D97}"/>
               </a:ext>
             </a:extLst>
           </p:cNvPr>
@@ -7362,7 +7362,7 @@
           <p:cNvPr id="3" name="kicker-marker">
             <a:extLst xmlns:a="http://schemas.openxmlformats.org/drawingml/2006/main">
               <a:ext uri="{FF2B5EF4-FFF2-40B4-BE49-F238E27FC236}">
-                <a16:creationId xmlns:a16="http://schemas.microsoft.com/office/drawing/2014/main" id="{1910889E-AB15-4940-B35B-9BED2E1DC804}"/>
+                <a16:creationId xmlns:a16="http://schemas.microsoft.com/office/drawing/2014/main" id="{082EBEE8-D95C-43E3-9114-26CF93485186}"/>
               </a:ext>
             </a:extLst>
           </p:cNvPr>
@@ -7397,7 +7397,7 @@
           <p:cNvPr id="4" name="kicker-label">
             <a:extLst xmlns:a="http://schemas.openxmlformats.org/drawingml/2006/main">
               <a:ext uri="{FF2B5EF4-FFF2-40B4-BE49-F238E27FC236}">
-                <a16:creationId xmlns:a16="http://schemas.microsoft.com/office/drawing/2014/main" id="{D3FE54EA-E2EC-4BE0-9080-D1B75DCE5C4E}"/>
+                <a16:creationId xmlns:a16="http://schemas.microsoft.com/office/drawing/2014/main" id="{EE33BFF7-B4CA-44F8-AD4E-905BD2ECA42D}"/>
               </a:ext>
             </a:extLst>
           </p:cNvPr>
@@ -7461,7 +7461,7 @@
           <p:cNvPr id="5" name="">
             <a:extLst xmlns:a="http://schemas.openxmlformats.org/drawingml/2006/main">
               <a:ext uri="{FF2B5EF4-FFF2-40B4-BE49-F238E27FC236}">
-                <a16:creationId xmlns:a16="http://schemas.microsoft.com/office/drawing/2014/main" id="{F877D8BD-3351-4900-B013-1A27A0021F87}"/>
+                <a16:creationId xmlns:a16="http://schemas.microsoft.com/office/drawing/2014/main" id="{18D82B87-D919-4AFC-9642-6F70CE0642FC}"/>
               </a:ext>
             </a:extLst>
           </p:cNvPr>
@@ -7525,7 +7525,7 @@
           <p:cNvPr id="6" name="">
             <a:extLst xmlns:a="http://schemas.openxmlformats.org/drawingml/2006/main">
               <a:ext uri="{FF2B5EF4-FFF2-40B4-BE49-F238E27FC236}">
-                <a16:creationId xmlns:a16="http://schemas.microsoft.com/office/drawing/2014/main" id="{33DE0C73-1B82-46B6-835C-F14F91862CCC}"/>
+                <a16:creationId xmlns:a16="http://schemas.microsoft.com/office/drawing/2014/main" id="{391AD34C-06FC-41A9-8743-8ED866B50D16}"/>
               </a:ext>
             </a:extLst>
           </p:cNvPr>
@@ -7579,7 +7579,7 @@
                 <a:ea typeface="Hiragino Sans"/>
                 <a:cs typeface="Hiragino Sans"/>
               </a:rPr>
-              <a:t>単純なwrite規則や古典的異常検出に負けるなら、AEを主役にしない。それも重要な結論です。</a:t>
+              <a:t>単純な書き込み規則や古典的異常検出に負けるなら、AEを主役にしない。それも重要な結論です。</a:t>
             </a:r>
           </a:p>
         </p:txBody>
@@ -7589,7 +7589,7 @@
           <p:cNvPr id="7" name="">
             <a:extLst xmlns:a="http://schemas.openxmlformats.org/drawingml/2006/main">
               <a:ext uri="{FF2B5EF4-FFF2-40B4-BE49-F238E27FC236}">
-                <a16:creationId xmlns:a16="http://schemas.microsoft.com/office/drawing/2014/main" id="{4F395A89-0990-4BD7-8BB9-51C8704124D7}"/>
+                <a16:creationId xmlns:a16="http://schemas.microsoft.com/office/drawing/2014/main" id="{0917D08B-B2DB-47A0-A8B4-9F033252A1A5}"/>
               </a:ext>
             </a:extLst>
           </p:cNvPr>
@@ -7622,7 +7622,7 @@
           <p:cNvPr id="8" name="">
             <a:extLst xmlns:a="http://schemas.openxmlformats.org/drawingml/2006/main">
               <a:ext uri="{FF2B5EF4-FFF2-40B4-BE49-F238E27FC236}">
-                <a16:creationId xmlns:a16="http://schemas.microsoft.com/office/drawing/2014/main" id="{F93791D6-64A4-40FF-BD49-D63A68B991CA}"/>
+                <a16:creationId xmlns:a16="http://schemas.microsoft.com/office/drawing/2014/main" id="{4CBEBE31-2971-4661-9D80-2BEAB74CC3BE}"/>
               </a:ext>
             </a:extLst>
           </p:cNvPr>
@@ -7686,7 +7686,7 @@
           <p:cNvPr id="9" name="">
             <a:extLst xmlns:a="http://schemas.openxmlformats.org/drawingml/2006/main">
               <a:ext uri="{FF2B5EF4-FFF2-40B4-BE49-F238E27FC236}">
-                <a16:creationId xmlns:a16="http://schemas.microsoft.com/office/drawing/2014/main" id="{FD27D43F-56F7-4F45-95CD-DABC5D794139}"/>
+                <a16:creationId xmlns:a16="http://schemas.microsoft.com/office/drawing/2014/main" id="{FEE6C558-E543-4D46-A765-3DACB8D3C9EF}"/>
               </a:ext>
             </a:extLst>
           </p:cNvPr>
@@ -7740,7 +7740,7 @@
                 <a:ea typeface="Hiragino Sans"/>
                 <a:cs typeface="Hiragino Sans"/>
               </a:rPr>
-              <a:t>AEのtraining / calibrationに攻撃labelを使わない</a:t>
+              <a:t>AEの学習・しきい値決めに攻撃labelを使わない</a:t>
             </a:r>
           </a:p>
         </p:txBody>
@@ -7750,7 +7750,7 @@
           <p:cNvPr id="10" name="">
             <a:extLst xmlns:a="http://schemas.openxmlformats.org/drawingml/2006/main">
               <a:ext uri="{FF2B5EF4-FFF2-40B4-BE49-F238E27FC236}">
-                <a16:creationId xmlns:a16="http://schemas.microsoft.com/office/drawing/2014/main" id="{A90AFA86-A6FE-41D5-81A5-507F64E7B361}"/>
+                <a16:creationId xmlns:a16="http://schemas.microsoft.com/office/drawing/2014/main" id="{B33CF6E5-DD5D-40D8-89D5-9D0B74844AAC}"/>
               </a:ext>
             </a:extLst>
           </p:cNvPr>
@@ -7785,7 +7785,7 @@
           <p:cNvPr id="11" name="">
             <a:extLst xmlns:a="http://schemas.openxmlformats.org/drawingml/2006/main">
               <a:ext uri="{FF2B5EF4-FFF2-40B4-BE49-F238E27FC236}">
-                <a16:creationId xmlns:a16="http://schemas.microsoft.com/office/drawing/2014/main" id="{7084F484-A4D2-48F9-A6C8-88E58D1E6A74}"/>
+                <a16:creationId xmlns:a16="http://schemas.microsoft.com/office/drawing/2014/main" id="{CBB8E289-3440-457E-ADCF-EACEDFA0571E}"/>
               </a:ext>
             </a:extLst>
           </p:cNvPr>
@@ -7849,7 +7849,7 @@
           <p:cNvPr id="12" name="">
             <a:extLst xmlns:a="http://schemas.openxmlformats.org/drawingml/2006/main">
               <a:ext uri="{FF2B5EF4-FFF2-40B4-BE49-F238E27FC236}">
-                <a16:creationId xmlns:a16="http://schemas.microsoft.com/office/drawing/2014/main" id="{A02F1CF0-4D89-4B5D-A0EB-870D104DFE4A}"/>
+                <a16:creationId xmlns:a16="http://schemas.microsoft.com/office/drawing/2014/main" id="{30AA206D-03F0-482C-9742-EA29D40D09C5}"/>
               </a:ext>
             </a:extLst>
           </p:cNvPr>
@@ -7882,7 +7882,7 @@
           <p:cNvPr id="13" name="">
             <a:extLst xmlns:a="http://schemas.openxmlformats.org/drawingml/2006/main">
               <a:ext uri="{FF2B5EF4-FFF2-40B4-BE49-F238E27FC236}">
-                <a16:creationId xmlns:a16="http://schemas.microsoft.com/office/drawing/2014/main" id="{B5307BD2-4A27-486A-903C-8D43C33067E2}"/>
+                <a16:creationId xmlns:a16="http://schemas.microsoft.com/office/drawing/2014/main" id="{8E3E4D4E-9AF6-469E-A5FA-E3D274D65895}"/>
               </a:ext>
             </a:extLst>
           </p:cNvPr>
@@ -7936,7 +7936,7 @@
                 <a:ea typeface="Hiragino Sans"/>
                 <a:cs typeface="Hiragino Sans"/>
               </a:rPr>
-              <a:t>baselineと比較</a:t>
+              <a:t>単純比較</a:t>
             </a:r>
           </a:p>
         </p:txBody>
@@ -7946,7 +7946,7 @@
           <p:cNvPr id="14" name="">
             <a:extLst xmlns:a="http://schemas.openxmlformats.org/drawingml/2006/main">
               <a:ext uri="{FF2B5EF4-FFF2-40B4-BE49-F238E27FC236}">
-                <a16:creationId xmlns:a16="http://schemas.microsoft.com/office/drawing/2014/main" id="{DDB1749F-926A-4F8A-A948-78C88D4A58F1}"/>
+                <a16:creationId xmlns:a16="http://schemas.microsoft.com/office/drawing/2014/main" id="{CFE84710-309B-460D-9F84-A4A46EF61FC7}"/>
               </a:ext>
             </a:extLst>
           </p:cNvPr>
@@ -8000,7 +8000,7 @@
                 <a:ea typeface="Hiragino Sans"/>
                 <a:cs typeface="Hiragino Sans"/>
               </a:rPr>
-              <a:t>write比率、bytes、LBA/長さshift、Isolation Forest等</a:t>
+              <a:t>write比率、bytes、位置や長さの変化、古典的な異常検出</a:t>
             </a:r>
           </a:p>
         </p:txBody>
@@ -8010,7 +8010,7 @@
           <p:cNvPr id="15" name="">
             <a:extLst xmlns:a="http://schemas.openxmlformats.org/drawingml/2006/main">
               <a:ext uri="{FF2B5EF4-FFF2-40B4-BE49-F238E27FC236}">
-                <a16:creationId xmlns:a16="http://schemas.microsoft.com/office/drawing/2014/main" id="{ACB8A85C-C42F-412C-B9E7-5649ABC4E051}"/>
+                <a16:creationId xmlns:a16="http://schemas.microsoft.com/office/drawing/2014/main" id="{30809972-405A-4272-A3A1-857CF94D3DA2}"/>
               </a:ext>
             </a:extLst>
           </p:cNvPr>
@@ -8045,7 +8045,7 @@
           <p:cNvPr id="16" name="">
             <a:extLst xmlns:a="http://schemas.openxmlformats.org/drawingml/2006/main">
               <a:ext uri="{FF2B5EF4-FFF2-40B4-BE49-F238E27FC236}">
-                <a16:creationId xmlns:a16="http://schemas.microsoft.com/office/drawing/2014/main" id="{1AF082C7-4B23-445D-85C9-08A3B13EF359}"/>
+                <a16:creationId xmlns:a16="http://schemas.microsoft.com/office/drawing/2014/main" id="{86810280-1A96-46B4-96EF-EB1D7F6252CD}"/>
               </a:ext>
             </a:extLst>
           </p:cNvPr>
@@ -8109,7 +8109,7 @@
           <p:cNvPr id="17" name="">
             <a:extLst xmlns:a="http://schemas.openxmlformats.org/drawingml/2006/main">
               <a:ext uri="{FF2B5EF4-FFF2-40B4-BE49-F238E27FC236}">
-                <a16:creationId xmlns:a16="http://schemas.microsoft.com/office/drawing/2014/main" id="{ADCA97AB-FFBC-4EE9-8AF9-2330682F4BDB}"/>
+                <a16:creationId xmlns:a16="http://schemas.microsoft.com/office/drawing/2014/main" id="{019CC6CE-CBE7-4BE3-88E3-E0F696A7E361}"/>
               </a:ext>
             </a:extLst>
           </p:cNvPr>
@@ -8142,7 +8142,7 @@
           <p:cNvPr id="18" name="">
             <a:extLst xmlns:a="http://schemas.openxmlformats.org/drawingml/2006/main">
               <a:ext uri="{FF2B5EF4-FFF2-40B4-BE49-F238E27FC236}">
-                <a16:creationId xmlns:a16="http://schemas.microsoft.com/office/drawing/2014/main" id="{559F2CBC-C424-468B-9B41-383390E8782D}"/>
+                <a16:creationId xmlns:a16="http://schemas.microsoft.com/office/drawing/2014/main" id="{6D3DB84E-7FFF-45A9-8D1B-F7EF8ADF321D}"/>
               </a:ext>
             </a:extLst>
           </p:cNvPr>
@@ -8206,7 +8206,7 @@
           <p:cNvPr id="19" name="">
             <a:extLst xmlns:a="http://schemas.openxmlformats.org/drawingml/2006/main">
               <a:ext uri="{FF2B5EF4-FFF2-40B4-BE49-F238E27FC236}">
-                <a16:creationId xmlns:a16="http://schemas.microsoft.com/office/drawing/2014/main" id="{4C179424-F4BC-4D43-BB7A-B396884BD59F}"/>
+                <a16:creationId xmlns:a16="http://schemas.microsoft.com/office/drawing/2014/main" id="{DB31A80D-2CD5-492B-9B1C-4C298C377F10}"/>
               </a:ext>
             </a:extLst>
           </p:cNvPr>
@@ -8260,7 +8260,7 @@
                 <a:ea typeface="Hiragino Sans"/>
                 <a:cs typeface="Hiragino Sans"/>
               </a:rPr>
-              <a:t>追加operatorの価値とdevice costを切り分ける</a:t>
+              <a:t>追加する演算の価値と装置側の負担を切り分ける</a:t>
             </a:r>
           </a:p>
         </p:txBody>
@@ -8270,7 +8270,7 @@
           <p:cNvPr id="20" name="">
             <a:extLst xmlns:a="http://schemas.openxmlformats.org/drawingml/2006/main">
               <a:ext uri="{FF2B5EF4-FFF2-40B4-BE49-F238E27FC236}">
-                <a16:creationId xmlns:a16="http://schemas.microsoft.com/office/drawing/2014/main" id="{531DCF29-7C91-4E67-8F13-F7D4CFDFE792}"/>
+                <a16:creationId xmlns:a16="http://schemas.microsoft.com/office/drawing/2014/main" id="{B74819B1-C6E3-47DB-BA2F-7C1B4BBA7FE8}"/>
               </a:ext>
             </a:extLst>
           </p:cNvPr>
@@ -8305,7 +8305,7 @@
           <p:cNvPr id="21" name="">
             <a:extLst xmlns:a="http://schemas.openxmlformats.org/drawingml/2006/main">
               <a:ext uri="{FF2B5EF4-FFF2-40B4-BE49-F238E27FC236}">
-                <a16:creationId xmlns:a16="http://schemas.microsoft.com/office/drawing/2014/main" id="{0247741B-A883-48E2-868C-171305121A50}"/>
+                <a16:creationId xmlns:a16="http://schemas.microsoft.com/office/drawing/2014/main" id="{14B14D2A-6CF9-42A6-9B8B-EF1887F13D1B}"/>
               </a:ext>
             </a:extLst>
           </p:cNvPr>
@@ -8369,7 +8369,7 @@
           <p:cNvPr id="22" name="">
             <a:extLst xmlns:a="http://schemas.openxmlformats.org/drawingml/2006/main">
               <a:ext uri="{FF2B5EF4-FFF2-40B4-BE49-F238E27FC236}">
-                <a16:creationId xmlns:a16="http://schemas.microsoft.com/office/drawing/2014/main" id="{2B27EF77-DA29-46C9-BE4A-A288D4A8465D}"/>
+                <a16:creationId xmlns:a16="http://schemas.microsoft.com/office/drawing/2014/main" id="{E5A6C94D-F823-4D9D-89F3-3004A8C79F0A}"/>
               </a:ext>
             </a:extLst>
           </p:cNvPr>
@@ -8402,7 +8402,7 @@
           <p:cNvPr id="23" name="">
             <a:extLst xmlns:a="http://schemas.openxmlformats.org/drawingml/2006/main">
               <a:ext uri="{FF2B5EF4-FFF2-40B4-BE49-F238E27FC236}">
-                <a16:creationId xmlns:a16="http://schemas.microsoft.com/office/drawing/2014/main" id="{FB8752CF-F05F-4463-B0EC-A0191387F8E2}"/>
+                <a16:creationId xmlns:a16="http://schemas.microsoft.com/office/drawing/2014/main" id="{B33D5F43-4EC2-4CCF-8332-21361BDC94A6}"/>
               </a:ext>
             </a:extLst>
           </p:cNvPr>
@@ -8466,7 +8466,7 @@
           <p:cNvPr id="24" name="">
             <a:extLst xmlns:a="http://schemas.openxmlformats.org/drawingml/2006/main">
               <a:ext uri="{FF2B5EF4-FFF2-40B4-BE49-F238E27FC236}">
-                <a16:creationId xmlns:a16="http://schemas.microsoft.com/office/drawing/2014/main" id="{06F6D5AB-0F0B-49DD-8985-B5488DD216F7}"/>
+                <a16:creationId xmlns:a16="http://schemas.microsoft.com/office/drawing/2014/main" id="{22CC0057-155B-40BF-AD4E-C75194D22F0E}"/>
               </a:ext>
             </a:extLst>
           </p:cNvPr>
@@ -8520,7 +8520,7 @@
                 <a:ea typeface="Hiragino Sans"/>
                 <a:cs typeface="Hiragino Sans"/>
               </a:rPr>
-              <a:t>低false alarm、早期性、MNN parity、500KB制約</a:t>
+              <a:t>誤警報の少なさ、早期性、装置用変換後の一致、500KB制約</a:t>
             </a:r>
           </a:p>
         </p:txBody>
@@ -8530,7 +8530,7 @@
           <p:cNvPr id="25" name="">
             <a:extLst xmlns:a="http://schemas.openxmlformats.org/drawingml/2006/main">
               <a:ext uri="{FF2B5EF4-FFF2-40B4-BE49-F238E27FC236}">
-                <a16:creationId xmlns:a16="http://schemas.microsoft.com/office/drawing/2014/main" id="{F250FA90-8476-435C-BBBC-E07CC10C2905}"/>
+                <a16:creationId xmlns:a16="http://schemas.microsoft.com/office/drawing/2014/main" id="{8DED4A28-A203-40AE-A7EF-1D5293C7EFE3}"/>
               </a:ext>
             </a:extLst>
           </p:cNvPr>
@@ -8563,7 +8563,7 @@
           <p:cNvPr id="26" name="">
             <a:extLst xmlns:a="http://schemas.openxmlformats.org/drawingml/2006/main">
               <a:ext uri="{FF2B5EF4-FFF2-40B4-BE49-F238E27FC236}">
-                <a16:creationId xmlns:a16="http://schemas.microsoft.com/office/drawing/2014/main" id="{F41F253D-F25E-421A-9FEF-509676EA0EC8}"/>
+                <a16:creationId xmlns:a16="http://schemas.microsoft.com/office/drawing/2014/main" id="{386F9ED1-F830-4AEE-9D79-5AA74A8D6797}"/>
               </a:ext>
             </a:extLst>
           </p:cNvPr>
@@ -8627,7 +8627,7 @@
           <p:cNvPr id="27" name="">
             <a:extLst xmlns:a="http://schemas.openxmlformats.org/drawingml/2006/main">
               <a:ext uri="{FF2B5EF4-FFF2-40B4-BE49-F238E27FC236}">
-                <a16:creationId xmlns:a16="http://schemas.microsoft.com/office/drawing/2014/main" id="{1F1978E0-1F28-48B9-B610-59A04C6B5D87}"/>
+                <a16:creationId xmlns:a16="http://schemas.microsoft.com/office/drawing/2014/main" id="{AFEE0713-F538-428C-9D0B-C0A2BDC389C4}"/>
               </a:ext>
             </a:extLst>
           </p:cNvPr>
@@ -8681,7 +8681,7 @@
                 <a:ea typeface="Hiragino Sans"/>
                 <a:cs typeface="Hiragino Sans"/>
               </a:rPr>
-              <a:t>false alarms / volume / day</a:t>
+              <a:t>誤警報の少なさ</a:t>
             </a:r>
           </a:p>
         </p:txBody>
@@ -8691,7 +8691,7 @@
           <p:cNvPr id="28" name="">
             <a:extLst xmlns:a="http://schemas.openxmlformats.org/drawingml/2006/main">
               <a:ext uri="{FF2B5EF4-FFF2-40B4-BE49-F238E27FC236}">
-                <a16:creationId xmlns:a16="http://schemas.microsoft.com/office/drawing/2014/main" id="{FF14C726-0A8A-4FFC-BE97-A86EEB7D3A54}"/>
+                <a16:creationId xmlns:a16="http://schemas.microsoft.com/office/drawing/2014/main" id="{5B0EC6E8-F0B0-4E5F-A419-09BCB882A63D}"/>
               </a:ext>
             </a:extLst>
           </p:cNvPr>
@@ -8745,7 +8745,7 @@
                 <a:ea typeface="Hiragino Sans"/>
                 <a:cs typeface="Hiragino Sans"/>
               </a:rPr>
-              <a:t>time to detect</a:t>
+              <a:t>検知までの時間</a:t>
             </a:r>
           </a:p>
         </p:txBody>
@@ -8755,7 +8755,7 @@
           <p:cNvPr id="29" name="">
             <a:extLst xmlns:a="http://schemas.openxmlformats.org/drawingml/2006/main">
               <a:ext uri="{FF2B5EF4-FFF2-40B4-BE49-F238E27FC236}">
-                <a16:creationId xmlns:a16="http://schemas.microsoft.com/office/drawing/2014/main" id="{F517D275-21D9-4D27-BDC4-96BF6ABDEDA5}"/>
+                <a16:creationId xmlns:a16="http://schemas.microsoft.com/office/drawing/2014/main" id="{BB162E76-9BE0-48F2-9C7B-E3506F8B3408}"/>
               </a:ext>
             </a:extLst>
           </p:cNvPr>
@@ -8819,7 +8819,7 @@
           <p:cNvPr id="30" name="">
             <a:extLst xmlns:a="http://schemas.openxmlformats.org/drawingml/2006/main">
               <a:ext uri="{FF2B5EF4-FFF2-40B4-BE49-F238E27FC236}">
-                <a16:creationId xmlns:a16="http://schemas.microsoft.com/office/drawing/2014/main" id="{DF9CB868-88BE-4289-87E9-A5BC2D371BCB}"/>
+                <a16:creationId xmlns:a16="http://schemas.microsoft.com/office/drawing/2014/main" id="{FE84FC29-9211-4521-8232-0EF1F7B7C4D4}"/>
               </a:ext>
             </a:extLst>
           </p:cNvPr>
@@ -8873,7 +8873,7 @@
                 <a:ea typeface="Hiragino Sans"/>
                 <a:cs typeface="Hiragino Sans"/>
               </a:rPr>
-              <a:t>channel-wise error</a:t>
+              <a:t>どの特徴がズレたか</a:t>
             </a:r>
           </a:p>
         </p:txBody>
@@ -8883,7 +8883,7 @@
           <p:cNvPr id="31" name="">
             <a:extLst xmlns:a="http://schemas.openxmlformats.org/drawingml/2006/main">
               <a:ext uri="{FF2B5EF4-FFF2-40B4-BE49-F238E27FC236}">
-                <a16:creationId xmlns:a16="http://schemas.microsoft.com/office/drawing/2014/main" id="{E42CFEEE-122D-4DD1-A6B8-3387D436427F}"/>
+                <a16:creationId xmlns:a16="http://schemas.microsoft.com/office/drawing/2014/main" id="{26BB6752-4ED7-4436-9277-EC927DE7B3D1}"/>
               </a:ext>
             </a:extLst>
           </p:cNvPr>
@@ -8916,7 +8916,7 @@
           <p:cNvPr id="32" name="">
             <a:extLst xmlns:a="http://schemas.openxmlformats.org/drawingml/2006/main">
               <a:ext uri="{FF2B5EF4-FFF2-40B4-BE49-F238E27FC236}">
-                <a16:creationId xmlns:a16="http://schemas.microsoft.com/office/drawing/2014/main" id="{72DBB869-5D41-4FA6-BE02-70FCBB974140}"/>
+                <a16:creationId xmlns:a16="http://schemas.microsoft.com/office/drawing/2014/main" id="{D28FB1AD-813E-40F6-9CD6-0733B44FCB7A}"/>
               </a:ext>
             </a:extLst>
           </p:cNvPr>
@@ -8980,7 +8980,7 @@
           <p:cNvPr id="33" name="">
             <a:extLst xmlns:a="http://schemas.openxmlformats.org/drawingml/2006/main">
               <a:ext uri="{FF2B5EF4-FFF2-40B4-BE49-F238E27FC236}">
-                <a16:creationId xmlns:a16="http://schemas.microsoft.com/office/drawing/2014/main" id="{E9F565D4-9E51-45B1-9C57-03D8577272EF}"/>
+                <a16:creationId xmlns:a16="http://schemas.microsoft.com/office/drawing/2014/main" id="{D3F55576-D77D-4DAC-AED4-059FE672C3A8}"/>
               </a:ext>
             </a:extLst>
           </p:cNvPr>
@@ -9013,7 +9013,7 @@
           <p:cNvPr id="34" name="">
             <a:extLst xmlns:a="http://schemas.openxmlformats.org/drawingml/2006/main">
               <a:ext uri="{FF2B5EF4-FFF2-40B4-BE49-F238E27FC236}">
-                <a16:creationId xmlns:a16="http://schemas.microsoft.com/office/drawing/2014/main" id="{CCFF6E22-A746-4FC5-87BD-5B60B1B16318}"/>
+                <a16:creationId xmlns:a16="http://schemas.microsoft.com/office/drawing/2014/main" id="{9A4A063A-0C0E-4361-9364-8BA8BB9CE20D}"/>
               </a:ext>
             </a:extLst>
           </p:cNvPr>
@@ -9077,7 +9077,7 @@
           <p:cNvPr id="35" name="">
             <a:extLst xmlns:a="http://schemas.openxmlformats.org/drawingml/2006/main">
               <a:ext uri="{FF2B5EF4-FFF2-40B4-BE49-F238E27FC236}">
-                <a16:creationId xmlns:a16="http://schemas.microsoft.com/office/drawing/2014/main" id="{2F09EADB-593F-4EBB-9F74-FA975959159F}"/>
+                <a16:creationId xmlns:a16="http://schemas.microsoft.com/office/drawing/2014/main" id="{DD5EEF55-F8E9-4A3E-A059-2E0AE8B56D13}"/>
               </a:ext>
             </a:extLst>
           </p:cNvPr>
@@ -9110,7 +9110,7 @@
           <p:cNvPr id="36" name="">
             <a:extLst xmlns:a="http://schemas.openxmlformats.org/drawingml/2006/main">
               <a:ext uri="{FF2B5EF4-FFF2-40B4-BE49-F238E27FC236}">
-                <a16:creationId xmlns:a16="http://schemas.microsoft.com/office/drawing/2014/main" id="{419B661B-1A8E-40D5-B5D7-C40EC6DD1566}"/>
+                <a16:creationId xmlns:a16="http://schemas.microsoft.com/office/drawing/2014/main" id="{75D9F38B-1CBD-4AD2-AEBD-07D09C878DE1}"/>
               </a:ext>
             </a:extLst>
           </p:cNvPr>
@@ -9174,7 +9174,7 @@
           <p:cNvPr id="37" name="">
             <a:extLst xmlns:a="http://schemas.openxmlformats.org/drawingml/2006/main">
               <a:ext uri="{FF2B5EF4-FFF2-40B4-BE49-F238E27FC236}">
-                <a16:creationId xmlns:a16="http://schemas.microsoft.com/office/drawing/2014/main" id="{1EE76907-C91A-4852-BA98-F7AC0E59CAB3}"/>
+                <a16:creationId xmlns:a16="http://schemas.microsoft.com/office/drawing/2014/main" id="{FB62C2C2-97C4-4E6A-98D6-ED2BDBDC9C32}"/>
               </a:ext>
             </a:extLst>
           </p:cNvPr>
@@ -9207,7 +9207,7 @@
           <p:cNvPr id="38" name="">
             <a:extLst xmlns:a="http://schemas.openxmlformats.org/drawingml/2006/main">
               <a:ext uri="{FF2B5EF4-FFF2-40B4-BE49-F238E27FC236}">
-                <a16:creationId xmlns:a16="http://schemas.microsoft.com/office/drawing/2014/main" id="{0197B2F4-0257-40A9-9BDD-CEDA311B965D}"/>
+                <a16:creationId xmlns:a16="http://schemas.microsoft.com/office/drawing/2014/main" id="{CEF03734-CE29-470A-B9CA-204B03C54114}"/>
               </a:ext>
             </a:extLst>
           </p:cNvPr>
@@ -9271,7 +9271,7 @@
           <p:cNvPr id="39" name="">
             <a:extLst xmlns:a="http://schemas.openxmlformats.org/drawingml/2006/main">
               <a:ext uri="{FF2B5EF4-FFF2-40B4-BE49-F238E27FC236}">
-                <a16:creationId xmlns:a16="http://schemas.microsoft.com/office/drawing/2014/main" id="{9F6CF5DC-3CE0-457B-8FF1-A0EED54A62D3}"/>
+                <a16:creationId xmlns:a16="http://schemas.microsoft.com/office/drawing/2014/main" id="{C7944872-CC24-440E-BE5B-795694EC1999}"/>
               </a:ext>
             </a:extLst>
           </p:cNvPr>
@@ -9304,7 +9304,7 @@
           <p:cNvPr id="40" name="">
             <a:extLst xmlns:a="http://schemas.openxmlformats.org/drawingml/2006/main">
               <a:ext uri="{FF2B5EF4-FFF2-40B4-BE49-F238E27FC236}">
-                <a16:creationId xmlns:a16="http://schemas.microsoft.com/office/drawing/2014/main" id="{DC3A4EDE-4FC0-4A02-B303-A42F42678EBB}"/>
+                <a16:creationId xmlns:a16="http://schemas.microsoft.com/office/drawing/2014/main" id="{4E4F5277-0A87-4C10-9E8E-127F6D8ADB80}"/>
               </a:ext>
             </a:extLst>
           </p:cNvPr>
@@ -9358,7 +9358,7 @@
                 <a:ea typeface="Hiragino Sans"/>
                 <a:cs typeface="Hiragino Sans"/>
               </a:rPr>
-              <a:t>N=6/12/24</a:t>
+              <a:t>入力長を変更</a:t>
             </a:r>
           </a:p>
         </p:txBody>
@@ -9368,7 +9368,7 @@
           <p:cNvPr id="41" name="">
             <a:extLst xmlns:a="http://schemas.openxmlformats.org/drawingml/2006/main">
               <a:ext uri="{FF2B5EF4-FFF2-40B4-BE49-F238E27FC236}">
-                <a16:creationId xmlns:a16="http://schemas.microsoft.com/office/drawing/2014/main" id="{C4563818-BAF0-4AB6-9B90-4348972807AE}"/>
+                <a16:creationId xmlns:a16="http://schemas.microsoft.com/office/drawing/2014/main" id="{9C0604FC-271E-4A9A-9BC5-D6A84D271EA0}"/>
               </a:ext>
             </a:extLst>
           </p:cNvPr>
@@ -9401,7 +9401,7 @@
           <p:cNvPr id="42" name="">
             <a:extLst xmlns:a="http://schemas.openxmlformats.org/drawingml/2006/main">
               <a:ext uri="{FF2B5EF4-FFF2-40B4-BE49-F238E27FC236}">
-                <a16:creationId xmlns:a16="http://schemas.microsoft.com/office/drawing/2014/main" id="{33E67CE4-2622-4BEF-8712-633226EE6E96}"/>
+                <a16:creationId xmlns:a16="http://schemas.microsoft.com/office/drawing/2014/main" id="{14449698-E726-4ED4-986E-FCFEA9C5E000}"/>
               </a:ext>
             </a:extLst>
           </p:cNvPr>
@@ -9455,7 +9455,7 @@
                 <a:ea typeface="Hiragino Sans"/>
                 <a:cs typeface="Hiragino Sans"/>
               </a:rPr>
-              <a:t>MNN変換後score</a:t>
+              <a:t>装置用変換後も同じ点数</a:t>
             </a:r>
           </a:p>
         </p:txBody>
@@ -9465,7 +9465,7 @@
           <p:cNvPr id="43" name="">
             <a:extLst xmlns:a="http://schemas.openxmlformats.org/drawingml/2006/main">
               <a:ext uri="{FF2B5EF4-FFF2-40B4-BE49-F238E27FC236}">
-                <a16:creationId xmlns:a16="http://schemas.microsoft.com/office/drawing/2014/main" id="{58B57ACC-3F70-40EC-8224-F90ED2E0E72F}"/>
+                <a16:creationId xmlns:a16="http://schemas.microsoft.com/office/drawing/2014/main" id="{06EBA5B9-60DB-4AC1-A0C2-C264AFEF6151}"/>
               </a:ext>
             </a:extLst>
           </p:cNvPr>
@@ -9498,7 +9498,7 @@
           <p:cNvPr id="44" name="">
             <a:extLst xmlns:a="http://schemas.openxmlformats.org/drawingml/2006/main">
               <a:ext uri="{FF2B5EF4-FFF2-40B4-BE49-F238E27FC236}">
-                <a16:creationId xmlns:a16="http://schemas.microsoft.com/office/drawing/2014/main" id="{B7311D6F-1375-4739-8DCD-F3626CCB6C65}"/>
+                <a16:creationId xmlns:a16="http://schemas.microsoft.com/office/drawing/2014/main" id="{A460FE17-5E91-4268-AF35-B64EB0D454F5}"/>
               </a:ext>
             </a:extLst>
           </p:cNvPr>
@@ -9562,7 +9562,7 @@
           <p:cNvPr id="45" name="">
             <a:extLst xmlns:a="http://schemas.openxmlformats.org/drawingml/2006/main">
               <a:ext uri="{FF2B5EF4-FFF2-40B4-BE49-F238E27FC236}">
-                <a16:creationId xmlns:a16="http://schemas.microsoft.com/office/drawing/2014/main" id="{EE158A68-B1C9-4603-A90A-C4D8FBBC908C}"/>
+                <a16:creationId xmlns:a16="http://schemas.microsoft.com/office/drawing/2014/main" id="{5228FA3F-DB9D-4B30-ABA1-1649DCCD5FCC}"/>
               </a:ext>
             </a:extLst>
           </p:cNvPr>
@@ -9597,7 +9597,7 @@
           <p:cNvPr id="46" name="">
             <a:extLst xmlns:a="http://schemas.openxmlformats.org/drawingml/2006/main">
               <a:ext uri="{FF2B5EF4-FFF2-40B4-BE49-F238E27FC236}">
-                <a16:creationId xmlns:a16="http://schemas.microsoft.com/office/drawing/2014/main" id="{1500BE16-F9CD-4CDA-B1F9-BDE8D222ABE4}"/>
+                <a16:creationId xmlns:a16="http://schemas.microsoft.com/office/drawing/2014/main" id="{734278C2-4F1B-4FC9-A679-A38A8737EC26}"/>
               </a:ext>
             </a:extLst>
           </p:cNvPr>
@@ -9661,7 +9661,7 @@
           <p:cNvPr id="47" name="">
             <a:extLst xmlns:a="http://schemas.openxmlformats.org/drawingml/2006/main">
               <a:ext uri="{FF2B5EF4-FFF2-40B4-BE49-F238E27FC236}">
-                <a16:creationId xmlns:a16="http://schemas.microsoft.com/office/drawing/2014/main" id="{B6B5D649-E36A-43CE-A577-87B2EAA7614B}"/>
+                <a16:creationId xmlns:a16="http://schemas.microsoft.com/office/drawing/2014/main" id="{0355152E-90AB-4D73-982A-2702E87E7F65}"/>
               </a:ext>
             </a:extLst>
           </p:cNvPr>
@@ -9723,7 +9723,7 @@
     </p:spTree>
     <p:extLst>
       <p:ext uri="{BB962C8B-B14F-4D97-AF65-F5344CB8AC3E}">
-        <p14:creationId xmlns:p14="http://schemas.microsoft.com/office/powerpoint/2010/main" val="1611577052"/>
+        <p14:creationId xmlns:p14="http://schemas.microsoft.com/office/powerpoint/2010/main" val="1044288403"/>
       </p:ext>
     </p:extLst>
   </p:cSld>
@@ -9747,7 +9747,7 @@
           <p:cNvPr id="1" name="">
             <a:extLst xmlns:a="http://schemas.openxmlformats.org/drawingml/2006/main">
               <a:ext uri="{FF2B5EF4-FFF2-40B4-BE49-F238E27FC236}">
-                <a16:creationId xmlns:a16="http://schemas.microsoft.com/office/drawing/2014/main" id="{D0A170B3-A2FF-4DD5-9F6F-FFFD2FD676A1}"/>
+                <a16:creationId xmlns:a16="http://schemas.microsoft.com/office/drawing/2014/main" id="{6AC17883-75AF-4576-8009-3BFAA1EE45C6}"/>
               </a:ext>
             </a:extLst>
           </p:cNvPr>
@@ -9782,7 +9782,7 @@
           <p:cNvPr id="2" name="">
             <a:extLst xmlns:a="http://schemas.openxmlformats.org/drawingml/2006/main">
               <a:ext uri="{FF2B5EF4-FFF2-40B4-BE49-F238E27FC236}">
-                <a16:creationId xmlns:a16="http://schemas.microsoft.com/office/drawing/2014/main" id="{07B19260-A713-4FF1-8DCB-811968FC4119}"/>
+                <a16:creationId xmlns:a16="http://schemas.microsoft.com/office/drawing/2014/main" id="{059CF62A-13C5-45BC-9EAA-05F4D08FB0E9}"/>
               </a:ext>
             </a:extLst>
           </p:cNvPr>
@@ -9817,7 +9817,7 @@
           <p:cNvPr id="3" name="kicker-marker">
             <a:extLst xmlns:a="http://schemas.openxmlformats.org/drawingml/2006/main">
               <a:ext uri="{FF2B5EF4-FFF2-40B4-BE49-F238E27FC236}">
-                <a16:creationId xmlns:a16="http://schemas.microsoft.com/office/drawing/2014/main" id="{2F4ADEC9-169E-4FAF-867E-D1409D70121A}"/>
+                <a16:creationId xmlns:a16="http://schemas.microsoft.com/office/drawing/2014/main" id="{00999874-80F3-455E-82CC-48C696D09BA5}"/>
               </a:ext>
             </a:extLst>
           </p:cNvPr>
@@ -9852,7 +9852,7 @@
           <p:cNvPr id="4" name="kicker-label">
             <a:extLst xmlns:a="http://schemas.openxmlformats.org/drawingml/2006/main">
               <a:ext uri="{FF2B5EF4-FFF2-40B4-BE49-F238E27FC236}">
-                <a16:creationId xmlns:a16="http://schemas.microsoft.com/office/drawing/2014/main" id="{4E055727-D118-4354-87AE-383473A1171F}"/>
+                <a16:creationId xmlns:a16="http://schemas.microsoft.com/office/drawing/2014/main" id="{71845A79-0A8A-491E-9C12-244C6A0F990C}"/>
               </a:ext>
             </a:extLst>
           </p:cNvPr>
@@ -9916,7 +9916,7 @@
           <p:cNvPr id="5" name="">
             <a:extLst xmlns:a="http://schemas.openxmlformats.org/drawingml/2006/main">
               <a:ext uri="{FF2B5EF4-FFF2-40B4-BE49-F238E27FC236}">
-                <a16:creationId xmlns:a16="http://schemas.microsoft.com/office/drawing/2014/main" id="{59B330B0-FF7B-4E8A-8C94-DB9120A13856}"/>
+                <a16:creationId xmlns:a16="http://schemas.microsoft.com/office/drawing/2014/main" id="{1D0E7318-3971-4B6A-AE44-A7ADCAC6B17E}"/>
               </a:ext>
             </a:extLst>
           </p:cNvPr>
@@ -9980,7 +9980,7 @@
           <p:cNvPr id="6" name="">
             <a:extLst xmlns:a="http://schemas.openxmlformats.org/drawingml/2006/main">
               <a:ext uri="{FF2B5EF4-FFF2-40B4-BE49-F238E27FC236}">
-                <a16:creationId xmlns:a16="http://schemas.microsoft.com/office/drawing/2014/main" id="{4BCA4DFC-2CE6-43BC-AC76-8899EB59871A}"/>
+                <a16:creationId xmlns:a16="http://schemas.microsoft.com/office/drawing/2014/main" id="{B2B6B8AE-3D9F-4D25-A55B-32EC08B8F49F}"/>
               </a:ext>
             </a:extLst>
           </p:cNvPr>
@@ -10044,7 +10044,7 @@
           <p:cNvPr id="7" name="">
             <a:extLst xmlns:a="http://schemas.openxmlformats.org/drawingml/2006/main">
               <a:ext uri="{FF2B5EF4-FFF2-40B4-BE49-F238E27FC236}">
-                <a16:creationId xmlns:a16="http://schemas.microsoft.com/office/drawing/2014/main" id="{FDADD86B-C323-4A04-9C3F-50753010FA77}"/>
+                <a16:creationId xmlns:a16="http://schemas.microsoft.com/office/drawing/2014/main" id="{AC9A08A0-1116-4FD5-B20C-2E6C4A355252}"/>
               </a:ext>
             </a:extLst>
           </p:cNvPr>
@@ -10079,7 +10079,7 @@
           <p:cNvPr id="8" name="">
             <a:extLst xmlns:a="http://schemas.openxmlformats.org/drawingml/2006/main">
               <a:ext uri="{FF2B5EF4-FFF2-40B4-BE49-F238E27FC236}">
-                <a16:creationId xmlns:a16="http://schemas.microsoft.com/office/drawing/2014/main" id="{803D6B3B-2535-4771-AFF6-A202E62997EC}"/>
+                <a16:creationId xmlns:a16="http://schemas.microsoft.com/office/drawing/2014/main" id="{978C2F57-13C6-4AFD-B8EE-A620DD122E04}"/>
               </a:ext>
             </a:extLst>
           </p:cNvPr>
@@ -10143,7 +10143,7 @@
           <p:cNvPr id="9" name="">
             <a:extLst xmlns:a="http://schemas.openxmlformats.org/drawingml/2006/main">
               <a:ext uri="{FF2B5EF4-FFF2-40B4-BE49-F238E27FC236}">
-                <a16:creationId xmlns:a16="http://schemas.microsoft.com/office/drawing/2014/main" id="{D30F2D6C-6322-4DB6-BB67-2C3626F13A69}"/>
+                <a16:creationId xmlns:a16="http://schemas.microsoft.com/office/drawing/2014/main" id="{86F6069C-A616-4132-90EE-B5E6E8C4D5D7}"/>
               </a:ext>
             </a:extLst>
           </p:cNvPr>
@@ -10207,7 +10207,7 @@
           <p:cNvPr id="10" name="">
             <a:extLst xmlns:a="http://schemas.openxmlformats.org/drawingml/2006/main">
               <a:ext uri="{FF2B5EF4-FFF2-40B4-BE49-F238E27FC236}">
-                <a16:creationId xmlns:a16="http://schemas.microsoft.com/office/drawing/2014/main" id="{A0C69FBA-AEC6-4A8C-B0CD-7EB378D7A492}"/>
+                <a16:creationId xmlns:a16="http://schemas.microsoft.com/office/drawing/2014/main" id="{4D6312CC-ED99-46DD-AEE1-B9B84C914A72}"/>
               </a:ext>
             </a:extLst>
           </p:cNvPr>
@@ -10240,7 +10240,7 @@
           <p:cNvPr id="11" name="">
             <a:extLst xmlns:a="http://schemas.openxmlformats.org/drawingml/2006/main">
               <a:ext uri="{FF2B5EF4-FFF2-40B4-BE49-F238E27FC236}">
-                <a16:creationId xmlns:a16="http://schemas.microsoft.com/office/drawing/2014/main" id="{3D2957D7-8D68-473D-8A07-7EABFB224DBE}"/>
+                <a16:creationId xmlns:a16="http://schemas.microsoft.com/office/drawing/2014/main" id="{F14177F0-B192-44F8-B117-03020EEBB7EC}"/>
               </a:ext>
             </a:extLst>
           </p:cNvPr>
@@ -10294,7 +10294,7 @@
                 <a:ea typeface="Hiragino Sans"/>
                 <a:cs typeface="Hiragino Sans"/>
               </a:rPr>
-              <a:t>観測境界: block I/O metadata</a:t>
+              <a:t>観測境界: 装置に見えるI/O情報</a:t>
             </a:r>
           </a:p>
         </p:txBody>
@@ -10304,7 +10304,7 @@
           <p:cNvPr id="12" name="">
             <a:extLst xmlns:a="http://schemas.openxmlformats.org/drawingml/2006/main">
               <a:ext uri="{FF2B5EF4-FFF2-40B4-BE49-F238E27FC236}">
-                <a16:creationId xmlns:a16="http://schemas.microsoft.com/office/drawing/2014/main" id="{DABBA5C1-A252-47D3-B782-6881CF1E79AA}"/>
+                <a16:creationId xmlns:a16="http://schemas.microsoft.com/office/drawing/2014/main" id="{D3F2516F-2F3E-4DC0-AFA9-9EC8D79F7280}"/>
               </a:ext>
             </a:extLst>
           </p:cNvPr>
@@ -10337,7 +10337,7 @@
           <p:cNvPr id="13" name="">
             <a:extLst xmlns:a="http://schemas.openxmlformats.org/drawingml/2006/main">
               <a:ext uri="{FF2B5EF4-FFF2-40B4-BE49-F238E27FC236}">
-                <a16:creationId xmlns:a16="http://schemas.microsoft.com/office/drawing/2014/main" id="{0EA29122-8BAC-4AD9-8905-3744AD4A42F4}"/>
+                <a16:creationId xmlns:a16="http://schemas.microsoft.com/office/drawing/2014/main" id="{8B8C683B-A5FE-42D9-AA66-95CFDC3F3FDC}"/>
               </a:ext>
             </a:extLst>
           </p:cNvPr>
@@ -10401,7 +10401,7 @@
           <p:cNvPr id="14" name="">
             <a:extLst xmlns:a="http://schemas.openxmlformats.org/drawingml/2006/main">
               <a:ext uri="{FF2B5EF4-FFF2-40B4-BE49-F238E27FC236}">
-                <a16:creationId xmlns:a16="http://schemas.microsoft.com/office/drawing/2014/main" id="{2C5468FF-26AE-4EC0-807C-E3D71D44FE03}"/>
+                <a16:creationId xmlns:a16="http://schemas.microsoft.com/office/drawing/2014/main" id="{A85A945B-858E-4BA1-A016-924C81ED848B}"/>
               </a:ext>
             </a:extLst>
           </p:cNvPr>
@@ -10434,7 +10434,7 @@
           <p:cNvPr id="15" name="">
             <a:extLst xmlns:a="http://schemas.openxmlformats.org/drawingml/2006/main">
               <a:ext uri="{FF2B5EF4-FFF2-40B4-BE49-F238E27FC236}">
-                <a16:creationId xmlns:a16="http://schemas.microsoft.com/office/drawing/2014/main" id="{9AF7E99B-A0D7-4E47-AE46-757A2D8C61F5}"/>
+                <a16:creationId xmlns:a16="http://schemas.microsoft.com/office/drawing/2014/main" id="{F998A616-DCFE-43D4-9974-CC1E3A4DA8C2}"/>
               </a:ext>
             </a:extLst>
           </p:cNvPr>
@@ -10498,7 +10498,7 @@
           <p:cNvPr id="16" name="">
             <a:extLst xmlns:a="http://schemas.openxmlformats.org/drawingml/2006/main">
               <a:ext uri="{FF2B5EF4-FFF2-40B4-BE49-F238E27FC236}">
-                <a16:creationId xmlns:a16="http://schemas.microsoft.com/office/drawing/2014/main" id="{288B4569-ACE1-41E9-97DF-EA747D9CDEC2}"/>
+                <a16:creationId xmlns:a16="http://schemas.microsoft.com/office/drawing/2014/main" id="{133C7B5A-4267-40D1-96E6-690D8535919B}"/>
               </a:ext>
             </a:extLst>
           </p:cNvPr>
@@ -10531,7 +10531,7 @@
           <p:cNvPr id="17" name="">
             <a:extLst xmlns:a="http://schemas.openxmlformats.org/drawingml/2006/main">
               <a:ext uri="{FF2B5EF4-FFF2-40B4-BE49-F238E27FC236}">
-                <a16:creationId xmlns:a16="http://schemas.microsoft.com/office/drawing/2014/main" id="{7901D5B7-D634-4A43-B57A-D88DC9BC4C0F}"/>
+                <a16:creationId xmlns:a16="http://schemas.microsoft.com/office/drawing/2014/main" id="{943FEB55-3C61-4784-AE30-404E6A66AF0C}"/>
               </a:ext>
             </a:extLst>
           </p:cNvPr>
@@ -10585,7 +10585,7 @@
                 <a:ea typeface="Hiragino Sans"/>
                 <a:cs typeface="Hiragino Sans"/>
               </a:rPr>
-              <a:t>baseline / ablation / claim gate</a:t>
+              <a:t>単純比較・外して試す項目・主張の証拠条件</a:t>
             </a:r>
           </a:p>
         </p:txBody>
@@ -10595,7 +10595,7 @@
           <p:cNvPr id="18" name="">
             <a:extLst xmlns:a="http://schemas.openxmlformats.org/drawingml/2006/main">
               <a:ext uri="{FF2B5EF4-FFF2-40B4-BE49-F238E27FC236}">
-                <a16:creationId xmlns:a16="http://schemas.microsoft.com/office/drawing/2014/main" id="{0BE4B6AE-3C27-4D1D-A025-4032A55B7C96}"/>
+                <a16:creationId xmlns:a16="http://schemas.microsoft.com/office/drawing/2014/main" id="{5B23E311-0588-42E5-BB20-522C95E412E8}"/>
               </a:ext>
             </a:extLst>
           </p:cNvPr>
@@ -10628,7 +10628,7 @@
           <p:cNvPr id="19" name="">
             <a:extLst xmlns:a="http://schemas.openxmlformats.org/drawingml/2006/main">
               <a:ext uri="{FF2B5EF4-FFF2-40B4-BE49-F238E27FC236}">
-                <a16:creationId xmlns:a16="http://schemas.microsoft.com/office/drawing/2014/main" id="{6C66351D-0331-424F-915A-FF0D87930784}"/>
+                <a16:creationId xmlns:a16="http://schemas.microsoft.com/office/drawing/2014/main" id="{25A6CAF1-8C61-49BD-8271-44FC0B5FAFB9}"/>
               </a:ext>
             </a:extLst>
           </p:cNvPr>
@@ -10682,7 +10682,7 @@
                 <a:ea typeface="Hiragino Sans"/>
                 <a:cs typeface="Hiragino Sans"/>
               </a:rPr>
-              <a:t>RanSAP/RanSMAP source audit</a:t>
+              <a:t>候補データの出典確認</a:t>
             </a:r>
           </a:p>
         </p:txBody>
@@ -10692,7 +10692,7 @@
           <p:cNvPr id="20" name="">
             <a:extLst xmlns:a="http://schemas.openxmlformats.org/drawingml/2006/main">
               <a:ext uri="{FF2B5EF4-FFF2-40B4-BE49-F238E27FC236}">
-                <a16:creationId xmlns:a16="http://schemas.microsoft.com/office/drawing/2014/main" id="{F445EE2F-2B2D-474C-8B63-64B831408067}"/>
+                <a16:creationId xmlns:a16="http://schemas.microsoft.com/office/drawing/2014/main" id="{1CC07B45-2362-4F74-A84B-0FE52F44C549}"/>
               </a:ext>
             </a:extLst>
           </p:cNvPr>
@@ -10725,7 +10725,7 @@
           <p:cNvPr id="21" name="">
             <a:extLst xmlns:a="http://schemas.openxmlformats.org/drawingml/2006/main">
               <a:ext uri="{FF2B5EF4-FFF2-40B4-BE49-F238E27FC236}">
-                <a16:creationId xmlns:a16="http://schemas.microsoft.com/office/drawing/2014/main" id="{BEE568D8-96C9-49CF-B5E1-F575B0B2BAFF}"/>
+                <a16:creationId xmlns:a16="http://schemas.microsoft.com/office/drawing/2014/main" id="{2DCCCE4E-DDA5-49B8-A3AA-AC64A579A7DD}"/>
               </a:ext>
             </a:extLst>
           </p:cNvPr>
@@ -10789,7 +10789,7 @@
           <p:cNvPr id="22" name="">
             <a:extLst xmlns:a="http://schemas.openxmlformats.org/drawingml/2006/main">
               <a:ext uri="{FF2B5EF4-FFF2-40B4-BE49-F238E27FC236}">
-                <a16:creationId xmlns:a16="http://schemas.microsoft.com/office/drawing/2014/main" id="{95FD2E29-436A-4FA4-89A9-1F4D99641E0C}"/>
+                <a16:creationId xmlns:a16="http://schemas.microsoft.com/office/drawing/2014/main" id="{D98355B3-22CA-4A15-9637-426A634A017E}"/>
               </a:ext>
             </a:extLst>
           </p:cNvPr>
@@ -10822,7 +10822,7 @@
           <p:cNvPr id="23" name="">
             <a:extLst xmlns:a="http://schemas.openxmlformats.org/drawingml/2006/main">
               <a:ext uri="{FF2B5EF4-FFF2-40B4-BE49-F238E27FC236}">
-                <a16:creationId xmlns:a16="http://schemas.microsoft.com/office/drawing/2014/main" id="{73119E5C-27C6-484E-9D08-10487D65A140}"/>
+                <a16:creationId xmlns:a16="http://schemas.microsoft.com/office/drawing/2014/main" id="{3D858131-265A-483E-80E1-F9DCF519C229}"/>
               </a:ext>
             </a:extLst>
           </p:cNvPr>
@@ -10886,7 +10886,7 @@
           <p:cNvPr id="24" name="">
             <a:extLst xmlns:a="http://schemas.openxmlformats.org/drawingml/2006/main">
               <a:ext uri="{FF2B5EF4-FFF2-40B4-BE49-F238E27FC236}">
-                <a16:creationId xmlns:a16="http://schemas.microsoft.com/office/drawing/2014/main" id="{FA38AA31-54AE-4098-B6F0-C20A04CEC8B5}"/>
+                <a16:creationId xmlns:a16="http://schemas.microsoft.com/office/drawing/2014/main" id="{477F8DE3-3900-48D1-A725-177CA854401C}"/>
               </a:ext>
             </a:extLst>
           </p:cNvPr>
@@ -10919,7 +10919,7 @@
           <p:cNvPr id="25" name="">
             <a:extLst xmlns:a="http://schemas.openxmlformats.org/drawingml/2006/main">
               <a:ext uri="{FF2B5EF4-FFF2-40B4-BE49-F238E27FC236}">
-                <a16:creationId xmlns:a16="http://schemas.microsoft.com/office/drawing/2014/main" id="{ADB4EB5D-0102-46D8-A4E2-E48FE43F83D3}"/>
+                <a16:creationId xmlns:a16="http://schemas.microsoft.com/office/drawing/2014/main" id="{036D1ECE-7359-4402-8A02-BADE0970E4AF}"/>
               </a:ext>
             </a:extLst>
           </p:cNvPr>
@@ -10983,7 +10983,7 @@
           <p:cNvPr id="26" name="">
             <a:extLst xmlns:a="http://schemas.openxmlformats.org/drawingml/2006/main">
               <a:ext uri="{FF2B5EF4-FFF2-40B4-BE49-F238E27FC236}">
-                <a16:creationId xmlns:a16="http://schemas.microsoft.com/office/drawing/2014/main" id="{3D08AAD9-26C7-4F54-B72B-A31BDF47AA10}"/>
+                <a16:creationId xmlns:a16="http://schemas.microsoft.com/office/drawing/2014/main" id="{4241ED9D-7194-4946-ADB9-EC29E75CC6A2}"/>
               </a:ext>
             </a:extLst>
           </p:cNvPr>
@@ -11016,7 +11016,7 @@
           <p:cNvPr id="27" name="">
             <a:extLst xmlns:a="http://schemas.openxmlformats.org/drawingml/2006/main">
               <a:ext uri="{FF2B5EF4-FFF2-40B4-BE49-F238E27FC236}">
-                <a16:creationId xmlns:a16="http://schemas.microsoft.com/office/drawing/2014/main" id="{5453F24D-E15E-4DA5-B76A-361C528A19B2}"/>
+                <a16:creationId xmlns:a16="http://schemas.microsoft.com/office/drawing/2014/main" id="{6F20FC95-24D7-4CE1-A2F1-8411785BEAF4}"/>
               </a:ext>
             </a:extLst>
           </p:cNvPr>
@@ -11080,7 +11080,7 @@
           <p:cNvPr id="28" name="">
             <a:extLst xmlns:a="http://schemas.openxmlformats.org/drawingml/2006/main">
               <a:ext uri="{FF2B5EF4-FFF2-40B4-BE49-F238E27FC236}">
-                <a16:creationId xmlns:a16="http://schemas.microsoft.com/office/drawing/2014/main" id="{33CD32D0-F7B9-49CD-A9A9-97F1C332B385}"/>
+                <a16:creationId xmlns:a16="http://schemas.microsoft.com/office/drawing/2014/main" id="{E2070835-F46B-4F78-9696-C92EDDDD7D22}"/>
               </a:ext>
             </a:extLst>
           </p:cNvPr>
@@ -11113,7 +11113,7 @@
           <p:cNvPr id="29" name="">
             <a:extLst xmlns:a="http://schemas.openxmlformats.org/drawingml/2006/main">
               <a:ext uri="{FF2B5EF4-FFF2-40B4-BE49-F238E27FC236}">
-                <a16:creationId xmlns:a16="http://schemas.microsoft.com/office/drawing/2014/main" id="{EC57F9CA-9BC6-4722-BA95-CF9CF0F569A7}"/>
+                <a16:creationId xmlns:a16="http://schemas.microsoft.com/office/drawing/2014/main" id="{9676E9EC-1845-484A-8B13-EC47CCD2E50B}"/>
               </a:ext>
             </a:extLst>
           </p:cNvPr>
@@ -11177,7 +11177,7 @@
           <p:cNvPr id="30" name="">
             <a:extLst xmlns:a="http://schemas.openxmlformats.org/drawingml/2006/main">
               <a:ext uri="{FF2B5EF4-FFF2-40B4-BE49-F238E27FC236}">
-                <a16:creationId xmlns:a16="http://schemas.microsoft.com/office/drawing/2014/main" id="{0AF143C5-1392-47E9-A480-D9D76729EDE0}"/>
+                <a16:creationId xmlns:a16="http://schemas.microsoft.com/office/drawing/2014/main" id="{8822EF3D-0913-4468-8479-3BBEA7EC6AE4}"/>
               </a:ext>
             </a:extLst>
           </p:cNvPr>
@@ -11210,7 +11210,7 @@
           <p:cNvPr id="31" name="">
             <a:extLst xmlns:a="http://schemas.openxmlformats.org/drawingml/2006/main">
               <a:ext uri="{FF2B5EF4-FFF2-40B4-BE49-F238E27FC236}">
-                <a16:creationId xmlns:a16="http://schemas.microsoft.com/office/drawing/2014/main" id="{26156CFA-42B8-40B2-8A21-5311B47267D0}"/>
+                <a16:creationId xmlns:a16="http://schemas.microsoft.com/office/drawing/2014/main" id="{E7D63610-7DCC-454E-837C-143F85B861D8}"/>
               </a:ext>
             </a:extLst>
           </p:cNvPr>
@@ -11264,7 +11264,7 @@
                 <a:ea typeface="Hiragino Sans"/>
                 <a:cs typeface="Hiragino Sans"/>
               </a:rPr>
-              <a:t>MNN parityと500KB/device-fit</a:t>
+              <a:t>装置制約への収まり</a:t>
             </a:r>
           </a:p>
         </p:txBody>
@@ -11274,7 +11274,7 @@
           <p:cNvPr id="32" name="">
             <a:extLst xmlns:a="http://schemas.openxmlformats.org/drawingml/2006/main">
               <a:ext uri="{FF2B5EF4-FFF2-40B4-BE49-F238E27FC236}">
-                <a16:creationId xmlns:a16="http://schemas.microsoft.com/office/drawing/2014/main" id="{BFE06E74-76BB-4F5F-857A-FBE9D5476F31}"/>
+                <a16:creationId xmlns:a16="http://schemas.microsoft.com/office/drawing/2014/main" id="{B6EC2944-0F67-44DB-B833-C7ACF3E19141}"/>
               </a:ext>
             </a:extLst>
           </p:cNvPr>
@@ -11307,7 +11307,7 @@
           <p:cNvPr id="33" name="">
             <a:extLst xmlns:a="http://schemas.openxmlformats.org/drawingml/2006/main">
               <a:ext uri="{FF2B5EF4-FFF2-40B4-BE49-F238E27FC236}">
-                <a16:creationId xmlns:a16="http://schemas.microsoft.com/office/drawing/2014/main" id="{7D156918-9812-40F1-8478-1708E06A3BDB}"/>
+                <a16:creationId xmlns:a16="http://schemas.microsoft.com/office/drawing/2014/main" id="{EE11B4F0-C92D-48E7-A768-E11D12F0CB4B}"/>
               </a:ext>
             </a:extLst>
           </p:cNvPr>
@@ -11371,7 +11371,7 @@
           <p:cNvPr id="34" name="">
             <a:extLst xmlns:a="http://schemas.openxmlformats.org/drawingml/2006/main">
               <a:ext uri="{FF2B5EF4-FFF2-40B4-BE49-F238E27FC236}">
-                <a16:creationId xmlns:a16="http://schemas.microsoft.com/office/drawing/2014/main" id="{AA66A6FE-4A55-4379-9320-3D518EC94DD0}"/>
+                <a16:creationId xmlns:a16="http://schemas.microsoft.com/office/drawing/2014/main" id="{562A191C-D8C9-48CC-A899-D4591DD626C7}"/>
               </a:ext>
             </a:extLst>
           </p:cNvPr>
@@ -11404,7 +11404,7 @@
           <p:cNvPr id="35" name="">
             <a:extLst xmlns:a="http://schemas.openxmlformats.org/drawingml/2006/main">
               <a:ext uri="{FF2B5EF4-FFF2-40B4-BE49-F238E27FC236}">
-                <a16:creationId xmlns:a16="http://schemas.microsoft.com/office/drawing/2014/main" id="{1ED7C5BE-18C5-498F-A106-C4C1251CCDB7}"/>
+                <a16:creationId xmlns:a16="http://schemas.microsoft.com/office/drawing/2014/main" id="{E3F7D831-5486-4B66-AFF1-7A429DB000C2}"/>
               </a:ext>
             </a:extLst>
           </p:cNvPr>
@@ -11468,7 +11468,7 @@
           <p:cNvPr id="36" name="">
             <a:extLst xmlns:a="http://schemas.openxmlformats.org/drawingml/2006/main">
               <a:ext uri="{FF2B5EF4-FFF2-40B4-BE49-F238E27FC236}">
-                <a16:creationId xmlns:a16="http://schemas.microsoft.com/office/drawing/2014/main" id="{9BBB6D1A-9BCE-4BE4-B34D-95A06079B6A0}"/>
+                <a16:creationId xmlns:a16="http://schemas.microsoft.com/office/drawing/2014/main" id="{1BDB7081-B50B-4D0C-9FBD-5AE907C4A642}"/>
               </a:ext>
             </a:extLst>
           </p:cNvPr>
@@ -11503,7 +11503,7 @@
           <p:cNvPr id="37" name="">
             <a:extLst xmlns:a="http://schemas.openxmlformats.org/drawingml/2006/main">
               <a:ext uri="{FF2B5EF4-FFF2-40B4-BE49-F238E27FC236}">
-                <a16:creationId xmlns:a16="http://schemas.microsoft.com/office/drawing/2014/main" id="{B6A02B86-B2D6-4C83-AD9E-79FADE5FD1D2}"/>
+                <a16:creationId xmlns:a16="http://schemas.microsoft.com/office/drawing/2014/main" id="{410EC6DC-735A-446C-AB01-04FC37E606A9}"/>
               </a:ext>
             </a:extLst>
           </p:cNvPr>
@@ -11567,7 +11567,7 @@
           <p:cNvPr id="38" name="">
             <a:extLst xmlns:a="http://schemas.openxmlformats.org/drawingml/2006/main">
               <a:ext uri="{FF2B5EF4-FFF2-40B4-BE49-F238E27FC236}">
-                <a16:creationId xmlns:a16="http://schemas.microsoft.com/office/drawing/2014/main" id="{581D6A36-5112-4C5F-83AC-3E830FBD6878}"/>
+                <a16:creationId xmlns:a16="http://schemas.microsoft.com/office/drawing/2014/main" id="{E8761070-6409-40A5-8AC4-82E5C85A5CF0}"/>
               </a:ext>
             </a:extLst>
           </p:cNvPr>
@@ -11629,7 +11629,7 @@
     </p:spTree>
     <p:extLst>
       <p:ext uri="{BB962C8B-B14F-4D97-AF65-F5344CB8AC3E}">
-        <p14:creationId xmlns:p14="http://schemas.microsoft.com/office/powerpoint/2010/main" val="1918320851"/>
+        <p14:creationId xmlns:p14="http://schemas.microsoft.com/office/powerpoint/2010/main" val="620296593"/>
       </p:ext>
     </p:extLst>
   </p:cSld>

</xml_diff>

<commit_message>
Tighten sponsor deck Japanese copy
</commit_message>
<xml_diff>
--- a/paper/presentations/storage_embedded_ransomware_sponsor_brief.pptx
+++ b/paper/presentations/storage_embedded_ransomware_sponsor_brief.pptx
@@ -2,18 +2,18 @@
 <file path=ppt/presentation.xml><?xml version="1.0" encoding="utf-8"?>
 <p:presentation xmlns:p="http://schemas.openxmlformats.org/presentationml/2006/main">
   <p:sldMasterIdLst>
-    <p:sldMasterId xmlns:r="http://schemas.openxmlformats.org/officeDocument/2006/relationships" id="2147483648" r:id="R78016d5d90d447e1"/>
+    <p:sldMasterId xmlns:r="http://schemas.openxmlformats.org/officeDocument/2006/relationships" id="2147483648" r:id="Rcb2a0d22a58d4f32"/>
   </p:sldMasterIdLst>
   <p:notesMasterIdLst>
-    <p:notesMasterId xmlns:r="http://schemas.openxmlformats.org/officeDocument/2006/relationships" r:id="Rbba5c52376814b20"/>
+    <p:notesMasterId xmlns:r="http://schemas.openxmlformats.org/officeDocument/2006/relationships" r:id="R8dd23756957546a0"/>
   </p:notesMasterIdLst>
   <p:sldIdLst>
-    <p:sldId xmlns:r="http://schemas.openxmlformats.org/officeDocument/2006/relationships" id="256" r:id="R3c71797adda145c4"/>
-    <p:sldId xmlns:r="http://schemas.openxmlformats.org/officeDocument/2006/relationships" id="257" r:id="Re978c8396e4f4196"/>
-    <p:sldId xmlns:r="http://schemas.openxmlformats.org/officeDocument/2006/relationships" id="258" r:id="Rb72971dec26d4797"/>
-    <p:sldId xmlns:r="http://schemas.openxmlformats.org/officeDocument/2006/relationships" id="259" r:id="Re9aa8a6251d84c6d"/>
-    <p:sldId xmlns:r="http://schemas.openxmlformats.org/officeDocument/2006/relationships" id="260" r:id="Rca979d294e124b33"/>
-    <p:sldId xmlns:r="http://schemas.openxmlformats.org/officeDocument/2006/relationships" id="261" r:id="Rc962a760b1d64d04"/>
+    <p:sldId xmlns:r="http://schemas.openxmlformats.org/officeDocument/2006/relationships" id="256" r:id="Rd6c62c6c98664170"/>
+    <p:sldId xmlns:r="http://schemas.openxmlformats.org/officeDocument/2006/relationships" id="257" r:id="Rbb2331d491024646"/>
+    <p:sldId xmlns:r="http://schemas.openxmlformats.org/officeDocument/2006/relationships" id="258" r:id="R9e0e869f9bcc48dd"/>
+    <p:sldId xmlns:r="http://schemas.openxmlformats.org/officeDocument/2006/relationships" id="259" r:id="R9a8d79fbd2aa4f29"/>
+    <p:sldId xmlns:r="http://schemas.openxmlformats.org/officeDocument/2006/relationships" id="260" r:id="R29dee7d4c15a44c8"/>
+    <p:sldId xmlns:r="http://schemas.openxmlformats.org/officeDocument/2006/relationships" id="261" r:id="R8738d942bfeb4b45"/>
   </p:sldIdLst>
   <p:sldSz cx="12192000" cy="6858000"/>
   <p:notesSz cx="6858000" cy="9144000"/>
@@ -890,7 +890,7 @@
   </p:cSld>
   <p:clrMap bg1="lt1" tx1="dk1" bg2="lt2" tx2="dk2" accent1="accent1" accent2="accent2" accent3="accent3" accent4="accent4" accent5="accent5" accent6="accent6" hlink="hlink" folHlink="folHlink"/>
   <p:sldLayoutIdLst>
-    <p:sldLayoutId xmlns:r="http://schemas.openxmlformats.org/officeDocument/2006/relationships" id="2147483649" r:id="R71cfd1f298584f39"/>
+    <p:sldLayoutId xmlns:r="http://schemas.openxmlformats.org/officeDocument/2006/relationships" id="2147483649" r:id="R5ecc10da0be948f6"/>
   </p:sldLayoutIdLst>
   <p:txStyles>
     <p:titleStyle>
@@ -1189,7 +1189,7 @@
           <p:cNvPr id="1" name="">
             <a:extLst xmlns:a="http://schemas.openxmlformats.org/drawingml/2006/main">
               <a:ext uri="{FF2B5EF4-FFF2-40B4-BE49-F238E27FC236}">
-                <a16:creationId xmlns:a16="http://schemas.microsoft.com/office/drawing/2014/main" id="{4E38E47B-E08E-4480-85C5-E47273DA1283}"/>
+                <a16:creationId xmlns:a16="http://schemas.microsoft.com/office/drawing/2014/main" id="{800C9D7C-CA41-4088-833E-1FCFB91EC430}"/>
               </a:ext>
             </a:extLst>
           </p:cNvPr>
@@ -1224,7 +1224,7 @@
           <p:cNvPr id="2" name="">
             <a:extLst xmlns:a="http://schemas.openxmlformats.org/drawingml/2006/main">
               <a:ext uri="{FF2B5EF4-FFF2-40B4-BE49-F238E27FC236}">
-                <a16:creationId xmlns:a16="http://schemas.microsoft.com/office/drawing/2014/main" id="{68B01F8D-959B-4B0A-A7BC-D55E42B6588B}"/>
+                <a16:creationId xmlns:a16="http://schemas.microsoft.com/office/drawing/2014/main" id="{D0BCB888-07C8-4E23-BE30-959A2B45F0F5}"/>
               </a:ext>
             </a:extLst>
           </p:cNvPr>
@@ -1259,7 +1259,7 @@
           <p:cNvPr id="3" name="">
             <a:extLst xmlns:a="http://schemas.openxmlformats.org/drawingml/2006/main">
               <a:ext uri="{FF2B5EF4-FFF2-40B4-BE49-F238E27FC236}">
-                <a16:creationId xmlns:a16="http://schemas.microsoft.com/office/drawing/2014/main" id="{41334C50-47C6-4AF9-B912-F29ED87FE4A9}"/>
+                <a16:creationId xmlns:a16="http://schemas.microsoft.com/office/drawing/2014/main" id="{DFDAB935-DEEF-4BFB-96A7-2A2644B37F4A}"/>
               </a:ext>
             </a:extLst>
           </p:cNvPr>
@@ -1294,7 +1294,7 @@
           <p:cNvPr id="4" name="">
             <a:extLst xmlns:a="http://schemas.openxmlformats.org/drawingml/2006/main">
               <a:ext uri="{FF2B5EF4-FFF2-40B4-BE49-F238E27FC236}">
-                <a16:creationId xmlns:a16="http://schemas.microsoft.com/office/drawing/2014/main" id="{BBA6B132-7EC3-4449-9F31-92F4EBC388A6}"/>
+                <a16:creationId xmlns:a16="http://schemas.microsoft.com/office/drawing/2014/main" id="{542808FA-0D11-467C-B8DE-3CC4CF155132}"/>
               </a:ext>
             </a:extLst>
           </p:cNvPr>
@@ -1358,7 +1358,7 @@
           <p:cNvPr id="5" name="">
             <a:extLst xmlns:a="http://schemas.openxmlformats.org/drawingml/2006/main">
               <a:ext uri="{FF2B5EF4-FFF2-40B4-BE49-F238E27FC236}">
-                <a16:creationId xmlns:a16="http://schemas.microsoft.com/office/drawing/2014/main" id="{B657D77B-3F1C-4C4D-90B9-AC022E1502C9}"/>
+                <a16:creationId xmlns:a16="http://schemas.microsoft.com/office/drawing/2014/main" id="{5F6399FD-F136-4036-8344-91668FF64B6F}"/>
               </a:ext>
             </a:extLst>
           </p:cNvPr>
@@ -1422,7 +1422,7 @@
           <p:cNvPr id="6" name="">
             <a:extLst xmlns:a="http://schemas.openxmlformats.org/drawingml/2006/main">
               <a:ext uri="{FF2B5EF4-FFF2-40B4-BE49-F238E27FC236}">
-                <a16:creationId xmlns:a16="http://schemas.microsoft.com/office/drawing/2014/main" id="{03D5ACE0-F5F5-4F5A-B4C4-A950E421E24D}"/>
+                <a16:creationId xmlns:a16="http://schemas.microsoft.com/office/drawing/2014/main" id="{C6FA4DBD-D97D-450A-B4BF-D9A5CC257440}"/>
               </a:ext>
             </a:extLst>
           </p:cNvPr>
@@ -1458,7 +1458,7 @@
           <a:lstStyle xmlns:a="http://schemas.openxmlformats.org/drawingml/2006/main"/>
           <a:p xmlns:a="http://schemas.openxmlformats.org/drawingml/2006/main">
             <a:pPr algn="l">
-              <a:defRPr sz="2325" b="1">
+              <a:defRPr sz="2175" b="1">
                 <a:solidFill>
                   <a:srgbClr val="111827"/>
                 </a:solidFill>
@@ -1468,7 +1468,7 @@
               </a:defRPr>
             </a:pPr>
             <a:r>
-              <a:rPr sz="2325" b="1">
+              <a:rPr sz="2175" b="1">
                 <a:solidFill>
                   <a:srgbClr val="111827"/>
                 </a:solidFill>
@@ -1476,7 +1476,7 @@
                 <a:ea typeface="Hiragino Mincho ProN"/>
                 <a:cs typeface="Hiragino Mincho ProN"/>
               </a:rPr>
-              <a:t>ブロックI/Oだけを観測し、軽いAE候補に絞る</a:t>
+              <a:t>観測範囲をブロックI/Oに絞り、入力として足りるかを測る</a:t>
             </a:r>
           </a:p>
         </p:txBody>
@@ -1486,7 +1486,7 @@
           <p:cNvPr id="7" name="">
             <a:extLst xmlns:a="http://schemas.openxmlformats.org/drawingml/2006/main">
               <a:ext uri="{FF2B5EF4-FFF2-40B4-BE49-F238E27FC236}">
-                <a16:creationId xmlns:a16="http://schemas.microsoft.com/office/drawing/2014/main" id="{C77EF9E5-E5A8-4F71-9768-DEA8173E897D}"/>
+                <a16:creationId xmlns:a16="http://schemas.microsoft.com/office/drawing/2014/main" id="{0BE69A05-30D9-4446-9CDD-7674619AA878}"/>
               </a:ext>
             </a:extLst>
           </p:cNvPr>
@@ -1519,7 +1519,7 @@
           <p:cNvPr id="8" name="">
             <a:extLst xmlns:a="http://schemas.openxmlformats.org/drawingml/2006/main">
               <a:ext uri="{FF2B5EF4-FFF2-40B4-BE49-F238E27FC236}">
-                <a16:creationId xmlns:a16="http://schemas.microsoft.com/office/drawing/2014/main" id="{B6F4E355-DF87-4CD3-8F87-723048256F8A}"/>
+                <a16:creationId xmlns:a16="http://schemas.microsoft.com/office/drawing/2014/main" id="{93BC5E10-97F5-462D-8B3D-D4B6DDD4C87D}"/>
               </a:ext>
             </a:extLst>
           </p:cNvPr>
@@ -1554,7 +1554,7 @@
           <p:cNvPr id="9" name="">
             <a:extLst xmlns:a="http://schemas.openxmlformats.org/drawingml/2006/main">
               <a:ext uri="{FF2B5EF4-FFF2-40B4-BE49-F238E27FC236}">
-                <a16:creationId xmlns:a16="http://schemas.microsoft.com/office/drawing/2014/main" id="{20CEC8D3-E8F8-40D0-B471-5E4D98987080}"/>
+                <a16:creationId xmlns:a16="http://schemas.microsoft.com/office/drawing/2014/main" id="{CF7E9209-C83E-4201-97E3-DB26B96F4F63}"/>
               </a:ext>
             </a:extLst>
           </p:cNvPr>
@@ -1608,7 +1608,7 @@
                 <a:ea typeface="Hiragino Sans"/>
                 <a:cs typeface="Hiragino Sans"/>
               </a:rPr>
-              <a:t>主張 | ホストのプロセス名やファイルパスに頼らず、安い要求メタデータだけをAE候補の入力価値として検証する。</a:t>
+              <a:t>主張 | プロセス名やファイルパスを使わず、要求メタデータだけでAE候補に渡す統計列を作れるかを検証する。</a:t>
             </a:r>
           </a:p>
         </p:txBody>
@@ -1618,7 +1618,7 @@
           <p:cNvPr id="10" name="">
             <a:extLst xmlns:a="http://schemas.openxmlformats.org/drawingml/2006/main">
               <a:ext uri="{FF2B5EF4-FFF2-40B4-BE49-F238E27FC236}">
-                <a16:creationId xmlns:a16="http://schemas.microsoft.com/office/drawing/2014/main" id="{A45AB7D3-4EC8-448E-9EFB-32C6CA50D574}"/>
+                <a16:creationId xmlns:a16="http://schemas.microsoft.com/office/drawing/2014/main" id="{2AEA9F35-A8A3-457D-A041-949728628C73}"/>
               </a:ext>
             </a:extLst>
           </p:cNvPr>
@@ -1651,7 +1651,7 @@
           <p:cNvPr id="11" name="">
             <a:extLst xmlns:a="http://schemas.openxmlformats.org/drawingml/2006/main">
               <a:ext uri="{FF2B5EF4-FFF2-40B4-BE49-F238E27FC236}">
-                <a16:creationId xmlns:a16="http://schemas.microsoft.com/office/drawing/2014/main" id="{82D9775C-A9A8-4C1E-B6E2-A5159E98D5DE}"/>
+                <a16:creationId xmlns:a16="http://schemas.microsoft.com/office/drawing/2014/main" id="{B52520F7-E786-482F-900C-C402B66DC0C8}"/>
               </a:ext>
             </a:extLst>
           </p:cNvPr>
@@ -1686,7 +1686,7 @@
           <p:cNvPr id="12" name="">
             <a:extLst xmlns:a="http://schemas.openxmlformats.org/drawingml/2006/main">
               <a:ext uri="{FF2B5EF4-FFF2-40B4-BE49-F238E27FC236}">
-                <a16:creationId xmlns:a16="http://schemas.microsoft.com/office/drawing/2014/main" id="{4C9DD300-CD96-44AA-9F95-CF26304CBF6A}"/>
+                <a16:creationId xmlns:a16="http://schemas.microsoft.com/office/drawing/2014/main" id="{975338CC-DF6C-4BB2-BF35-04A746661687}"/>
               </a:ext>
             </a:extLst>
           </p:cNvPr>
@@ -1721,7 +1721,7 @@
           <p:cNvPr id="13" name="">
             <a:extLst xmlns:a="http://schemas.openxmlformats.org/drawingml/2006/main">
               <a:ext uri="{FF2B5EF4-FFF2-40B4-BE49-F238E27FC236}">
-                <a16:creationId xmlns:a16="http://schemas.microsoft.com/office/drawing/2014/main" id="{8670B0D8-C65A-4F66-B850-FCEEBDEBCAD5}"/>
+                <a16:creationId xmlns:a16="http://schemas.microsoft.com/office/drawing/2014/main" id="{2A905709-DEAE-49F5-84B9-38440980D6D5}"/>
               </a:ext>
             </a:extLst>
           </p:cNvPr>
@@ -1756,7 +1756,7 @@
           <p:cNvPr id="14" name="">
             <a:extLst xmlns:a="http://schemas.openxmlformats.org/drawingml/2006/main">
               <a:ext uri="{FF2B5EF4-FFF2-40B4-BE49-F238E27FC236}">
-                <a16:creationId xmlns:a16="http://schemas.microsoft.com/office/drawing/2014/main" id="{CECCEEDE-5C5E-48ED-A8EF-FCDD208C01CD}"/>
+                <a16:creationId xmlns:a16="http://schemas.microsoft.com/office/drawing/2014/main" id="{54686577-3B1E-4016-83C4-87516DC10F30}"/>
               </a:ext>
             </a:extLst>
           </p:cNvPr>
@@ -1791,7 +1791,7 @@
           <p:cNvPr id="15" name="">
             <a:extLst xmlns:a="http://schemas.openxmlformats.org/drawingml/2006/main">
               <a:ext uri="{FF2B5EF4-FFF2-40B4-BE49-F238E27FC236}">
-                <a16:creationId xmlns:a16="http://schemas.microsoft.com/office/drawing/2014/main" id="{AF2D76BC-EBBB-4D03-B5C8-80D84F881933}"/>
+                <a16:creationId xmlns:a16="http://schemas.microsoft.com/office/drawing/2014/main" id="{1C75B3E6-EE87-4853-94D5-4B3B7C0AD260}"/>
               </a:ext>
             </a:extLst>
           </p:cNvPr>
@@ -1826,7 +1826,7 @@
           <p:cNvPr id="16" name="">
             <a:extLst xmlns:a="http://schemas.openxmlformats.org/drawingml/2006/main">
               <a:ext uri="{FF2B5EF4-FFF2-40B4-BE49-F238E27FC236}">
-                <a16:creationId xmlns:a16="http://schemas.microsoft.com/office/drawing/2014/main" id="{A478FD8B-1FD8-4FE3-B473-6E52670BB8DC}"/>
+                <a16:creationId xmlns:a16="http://schemas.microsoft.com/office/drawing/2014/main" id="{EAA41593-1F9E-4D17-ACF5-FCC2AB098FAB}"/>
               </a:ext>
             </a:extLst>
           </p:cNvPr>
@@ -1861,7 +1861,7 @@
           <p:cNvPr id="17" name="">
             <a:extLst xmlns:a="http://schemas.openxmlformats.org/drawingml/2006/main">
               <a:ext uri="{FF2B5EF4-FFF2-40B4-BE49-F238E27FC236}">
-                <a16:creationId xmlns:a16="http://schemas.microsoft.com/office/drawing/2014/main" id="{633912B8-1ACE-4C59-B21E-A74F4725FC87}"/>
+                <a16:creationId xmlns:a16="http://schemas.microsoft.com/office/drawing/2014/main" id="{418B3833-787C-41DF-A76C-BDB21935C9A8}"/>
               </a:ext>
             </a:extLst>
           </p:cNvPr>
@@ -1896,7 +1896,7 @@
           <p:cNvPr id="18" name="">
             <a:extLst xmlns:a="http://schemas.openxmlformats.org/drawingml/2006/main">
               <a:ext uri="{FF2B5EF4-FFF2-40B4-BE49-F238E27FC236}">
-                <a16:creationId xmlns:a16="http://schemas.microsoft.com/office/drawing/2014/main" id="{B5BCE7EA-1975-418A-A8B9-80FC89D79569}"/>
+                <a16:creationId xmlns:a16="http://schemas.microsoft.com/office/drawing/2014/main" id="{2A770C9B-375A-4B6F-9E1A-F4EB96F90DB1}"/>
               </a:ext>
             </a:extLst>
           </p:cNvPr>
@@ -1931,7 +1931,7 @@
           <p:cNvPr id="19" name="">
             <a:extLst xmlns:a="http://schemas.openxmlformats.org/drawingml/2006/main">
               <a:ext uri="{FF2B5EF4-FFF2-40B4-BE49-F238E27FC236}">
-                <a16:creationId xmlns:a16="http://schemas.microsoft.com/office/drawing/2014/main" id="{DDA4BD32-2EF0-4659-B471-EDE354143BCD}"/>
+                <a16:creationId xmlns:a16="http://schemas.microsoft.com/office/drawing/2014/main" id="{39098D06-760B-4E1F-B6A1-0645449E9106}"/>
               </a:ext>
             </a:extLst>
           </p:cNvPr>
@@ -1966,7 +1966,7 @@
           <p:cNvPr id="20" name="">
             <a:extLst xmlns:a="http://schemas.openxmlformats.org/drawingml/2006/main">
               <a:ext uri="{FF2B5EF4-FFF2-40B4-BE49-F238E27FC236}">
-                <a16:creationId xmlns:a16="http://schemas.microsoft.com/office/drawing/2014/main" id="{932F1AD0-AD90-4095-B30B-3A3FB56B9C3F}"/>
+                <a16:creationId xmlns:a16="http://schemas.microsoft.com/office/drawing/2014/main" id="{18337938-EC15-41E9-B828-B377CC135E1E}"/>
               </a:ext>
             </a:extLst>
           </p:cNvPr>
@@ -2001,7 +2001,7 @@
           <p:cNvPr id="21" name="">
             <a:extLst xmlns:a="http://schemas.openxmlformats.org/drawingml/2006/main">
               <a:ext uri="{FF2B5EF4-FFF2-40B4-BE49-F238E27FC236}">
-                <a16:creationId xmlns:a16="http://schemas.microsoft.com/office/drawing/2014/main" id="{AC7465DC-BFB8-4867-A958-14B398D7864E}"/>
+                <a16:creationId xmlns:a16="http://schemas.microsoft.com/office/drawing/2014/main" id="{A9797695-55D0-45B6-9991-4B403F694271}"/>
               </a:ext>
             </a:extLst>
           </p:cNvPr>
@@ -2036,7 +2036,7 @@
           <p:cNvPr id="22" name="">
             <a:extLst xmlns:a="http://schemas.openxmlformats.org/drawingml/2006/main">
               <a:ext uri="{FF2B5EF4-FFF2-40B4-BE49-F238E27FC236}">
-                <a16:creationId xmlns:a16="http://schemas.microsoft.com/office/drawing/2014/main" id="{AF1BF3BB-27A2-44A0-9B0D-A6577C1E797E}"/>
+                <a16:creationId xmlns:a16="http://schemas.microsoft.com/office/drawing/2014/main" id="{4418951B-B29C-4A26-A229-9883CD3E1D70}"/>
               </a:ext>
             </a:extLst>
           </p:cNvPr>
@@ -2071,7 +2071,7 @@
           <p:cNvPr id="23" name="">
             <a:extLst xmlns:a="http://schemas.openxmlformats.org/drawingml/2006/main">
               <a:ext uri="{FF2B5EF4-FFF2-40B4-BE49-F238E27FC236}">
-                <a16:creationId xmlns:a16="http://schemas.microsoft.com/office/drawing/2014/main" id="{924D79BF-E369-454B-932F-D1972E247089}"/>
+                <a16:creationId xmlns:a16="http://schemas.microsoft.com/office/drawing/2014/main" id="{6C34E2C6-6AE7-47BA-B0A1-AB1ADCB98839}"/>
               </a:ext>
             </a:extLst>
           </p:cNvPr>
@@ -2104,7 +2104,7 @@
           <p:cNvPr id="24" name="">
             <a:extLst xmlns:a="http://schemas.openxmlformats.org/drawingml/2006/main">
               <a:ext uri="{FF2B5EF4-FFF2-40B4-BE49-F238E27FC236}">
-                <a16:creationId xmlns:a16="http://schemas.microsoft.com/office/drawing/2014/main" id="{DDFB8E20-CA19-4CA6-BFAD-DDF26A373671}"/>
+                <a16:creationId xmlns:a16="http://schemas.microsoft.com/office/drawing/2014/main" id="{DF616FDF-2513-4883-8EDF-E3A2AE448536}"/>
               </a:ext>
             </a:extLst>
           </p:cNvPr>
@@ -2139,7 +2139,7 @@
           <p:cNvPr id="25" name="">
             <a:extLst xmlns:a="http://schemas.openxmlformats.org/drawingml/2006/main">
               <a:ext uri="{FF2B5EF4-FFF2-40B4-BE49-F238E27FC236}">
-                <a16:creationId xmlns:a16="http://schemas.microsoft.com/office/drawing/2014/main" id="{1CD935A2-3CED-4497-9724-7B0CED56086D}"/>
+                <a16:creationId xmlns:a16="http://schemas.microsoft.com/office/drawing/2014/main" id="{74D5DEA3-4136-45FA-814C-B7EC6A4774BA}"/>
               </a:ext>
             </a:extLst>
           </p:cNvPr>
@@ -2193,7 +2193,7 @@
                 <a:ea typeface="Hiragino Sans"/>
                 <a:cs typeface="Hiragino Sans"/>
               </a:rPr>
-              <a:t>見るのは装置境界で安く取れる情報だけ</a:t>
+              <a:t>観測は装置境界で安く取れる情報だけ</a:t>
             </a:r>
           </a:p>
         </p:txBody>
@@ -2203,7 +2203,7 @@
           <p:cNvPr id="26" name="">
             <a:extLst xmlns:a="http://schemas.openxmlformats.org/drawingml/2006/main">
               <a:ext uri="{FF2B5EF4-FFF2-40B4-BE49-F238E27FC236}">
-                <a16:creationId xmlns:a16="http://schemas.microsoft.com/office/drawing/2014/main" id="{08D93947-8618-4A03-9C4A-8053917661C9}"/>
+                <a16:creationId xmlns:a16="http://schemas.microsoft.com/office/drawing/2014/main" id="{BCC026DF-6B68-4613-B7C9-5862D5A5FF6A}"/>
               </a:ext>
             </a:extLst>
           </p:cNvPr>
@@ -2236,7 +2236,7 @@
           <p:cNvPr id="27" name="">
             <a:extLst xmlns:a="http://schemas.openxmlformats.org/drawingml/2006/main">
               <a:ext uri="{FF2B5EF4-FFF2-40B4-BE49-F238E27FC236}">
-                <a16:creationId xmlns:a16="http://schemas.microsoft.com/office/drawing/2014/main" id="{27FE9EE1-2CF6-4F3A-99FB-94849D1E39B6}"/>
+                <a16:creationId xmlns:a16="http://schemas.microsoft.com/office/drawing/2014/main" id="{C04A9E0E-5361-4BB0-AA8A-073C089CB108}"/>
               </a:ext>
             </a:extLst>
           </p:cNvPr>
@@ -2300,7 +2300,7 @@
           <p:cNvPr id="28" name="">
             <a:extLst xmlns:a="http://schemas.openxmlformats.org/drawingml/2006/main">
               <a:ext uri="{FF2B5EF4-FFF2-40B4-BE49-F238E27FC236}">
-                <a16:creationId xmlns:a16="http://schemas.microsoft.com/office/drawing/2014/main" id="{D9E8BA55-0F0C-4446-A928-83FB8D786D17}"/>
+                <a16:creationId xmlns:a16="http://schemas.microsoft.com/office/drawing/2014/main" id="{75915CDE-118F-438E-B321-0F497DFC27D2}"/>
               </a:ext>
             </a:extLst>
           </p:cNvPr>
@@ -2364,7 +2364,7 @@
           <p:cNvPr id="29" name="">
             <a:extLst xmlns:a="http://schemas.openxmlformats.org/drawingml/2006/main">
               <a:ext uri="{FF2B5EF4-FFF2-40B4-BE49-F238E27FC236}">
-                <a16:creationId xmlns:a16="http://schemas.microsoft.com/office/drawing/2014/main" id="{4FD30CEF-49F3-4530-9EF6-0D90EDBB73F9}"/>
+                <a16:creationId xmlns:a16="http://schemas.microsoft.com/office/drawing/2014/main" id="{425BAAA4-4CB3-47C4-A9E0-228E144376FA}"/>
               </a:ext>
             </a:extLst>
           </p:cNvPr>
@@ -2399,7 +2399,7 @@
           <p:cNvPr id="30" name="">
             <a:extLst xmlns:a="http://schemas.openxmlformats.org/drawingml/2006/main">
               <a:ext uri="{FF2B5EF4-FFF2-40B4-BE49-F238E27FC236}">
-                <a16:creationId xmlns:a16="http://schemas.microsoft.com/office/drawing/2014/main" id="{9AFE9A06-2B6E-4EA7-B1C9-88E49DA17223}"/>
+                <a16:creationId xmlns:a16="http://schemas.microsoft.com/office/drawing/2014/main" id="{FF0AD81F-0A82-484D-A95C-BCA3A157133A}"/>
               </a:ext>
             </a:extLst>
           </p:cNvPr>
@@ -2463,7 +2463,7 @@
           <p:cNvPr id="31" name="">
             <a:extLst xmlns:a="http://schemas.openxmlformats.org/drawingml/2006/main">
               <a:ext uri="{FF2B5EF4-FFF2-40B4-BE49-F238E27FC236}">
-                <a16:creationId xmlns:a16="http://schemas.microsoft.com/office/drawing/2014/main" id="{261EB39F-C7E2-4827-80B8-A76910F1B1AF}"/>
+                <a16:creationId xmlns:a16="http://schemas.microsoft.com/office/drawing/2014/main" id="{87956898-E625-4950-8050-2A2B11972FC6}"/>
               </a:ext>
             </a:extLst>
           </p:cNvPr>
@@ -2496,7 +2496,7 @@
           <p:cNvPr id="32" name="">
             <a:extLst xmlns:a="http://schemas.openxmlformats.org/drawingml/2006/main">
               <a:ext uri="{FF2B5EF4-FFF2-40B4-BE49-F238E27FC236}">
-                <a16:creationId xmlns:a16="http://schemas.microsoft.com/office/drawing/2014/main" id="{9F6404AE-4884-413C-9219-973349D21DC2}"/>
+                <a16:creationId xmlns:a16="http://schemas.microsoft.com/office/drawing/2014/main" id="{9F1D281C-9B03-444C-9A41-5A83E42C0FAB}"/>
               </a:ext>
             </a:extLst>
           </p:cNvPr>
@@ -2531,7 +2531,7 @@
           <p:cNvPr id="33" name="">
             <a:extLst xmlns:a="http://schemas.openxmlformats.org/drawingml/2006/main">
               <a:ext uri="{FF2B5EF4-FFF2-40B4-BE49-F238E27FC236}">
-                <a16:creationId xmlns:a16="http://schemas.microsoft.com/office/drawing/2014/main" id="{C0D2A592-C50A-49A8-A2EB-DECDB1CA4999}"/>
+                <a16:creationId xmlns:a16="http://schemas.microsoft.com/office/drawing/2014/main" id="{2B64E4D6-0369-42B3-84F5-FD0ECD2E57B9}"/>
               </a:ext>
             </a:extLst>
           </p:cNvPr>
@@ -2595,7 +2595,7 @@
           <p:cNvPr id="34" name="">
             <a:extLst xmlns:a="http://schemas.openxmlformats.org/drawingml/2006/main">
               <a:ext uri="{FF2B5EF4-FFF2-40B4-BE49-F238E27FC236}">
-                <a16:creationId xmlns:a16="http://schemas.microsoft.com/office/drawing/2014/main" id="{7C69FA1B-8A63-4255-9EA9-4D1999FBCE42}"/>
+                <a16:creationId xmlns:a16="http://schemas.microsoft.com/office/drawing/2014/main" id="{D3F622D2-AB9E-4F9D-99BC-5F4B76396262}"/>
               </a:ext>
             </a:extLst>
           </p:cNvPr>
@@ -2682,7 +2682,7 @@
           <p:cNvPr id="35" name="">
             <a:extLst xmlns:a="http://schemas.openxmlformats.org/drawingml/2006/main">
               <a:ext uri="{FF2B5EF4-FFF2-40B4-BE49-F238E27FC236}">
-                <a16:creationId xmlns:a16="http://schemas.microsoft.com/office/drawing/2014/main" id="{D885D69C-C7BC-4722-B70E-7921AA301374}"/>
+                <a16:creationId xmlns:a16="http://schemas.microsoft.com/office/drawing/2014/main" id="{D153C585-9D7D-4A9A-A365-3A8769E49148}"/>
               </a:ext>
             </a:extLst>
           </p:cNvPr>
@@ -2717,7 +2717,7 @@
           <p:cNvPr id="36" name="">
             <a:extLst xmlns:a="http://schemas.openxmlformats.org/drawingml/2006/main">
               <a:ext uri="{FF2B5EF4-FFF2-40B4-BE49-F238E27FC236}">
-                <a16:creationId xmlns:a16="http://schemas.microsoft.com/office/drawing/2014/main" id="{B3108A08-CAE8-4388-931D-F6887F96C33C}"/>
+                <a16:creationId xmlns:a16="http://schemas.microsoft.com/office/drawing/2014/main" id="{9D844828-8EE2-4007-8B27-5AA1848E6FCF}"/>
               </a:ext>
             </a:extLst>
           </p:cNvPr>
@@ -2781,7 +2781,7 @@
           <p:cNvPr id="37" name="">
             <a:extLst xmlns:a="http://schemas.openxmlformats.org/drawingml/2006/main">
               <a:ext uri="{FF2B5EF4-FFF2-40B4-BE49-F238E27FC236}">
-                <a16:creationId xmlns:a16="http://schemas.microsoft.com/office/drawing/2014/main" id="{9BFA53A1-002F-42D1-8E88-A0F1F3EF2368}"/>
+                <a16:creationId xmlns:a16="http://schemas.microsoft.com/office/drawing/2014/main" id="{3C4858C5-1376-408A-977E-47D33EFF8CE1}"/>
               </a:ext>
             </a:extLst>
           </p:cNvPr>
@@ -2814,7 +2814,7 @@
           <p:cNvPr id="38" name="">
             <a:extLst xmlns:a="http://schemas.openxmlformats.org/drawingml/2006/main">
               <a:ext uri="{FF2B5EF4-FFF2-40B4-BE49-F238E27FC236}">
-                <a16:creationId xmlns:a16="http://schemas.microsoft.com/office/drawing/2014/main" id="{6F52992B-8CCD-4816-B502-2FDBEE546E63}"/>
+                <a16:creationId xmlns:a16="http://schemas.microsoft.com/office/drawing/2014/main" id="{7F63C85C-557C-40EA-9F6D-3B4F20C4436C}"/>
               </a:ext>
             </a:extLst>
           </p:cNvPr>
@@ -2878,7 +2878,7 @@
           <p:cNvPr id="39" name="">
             <a:extLst xmlns:a="http://schemas.openxmlformats.org/drawingml/2006/main">
               <a:ext uri="{FF2B5EF4-FFF2-40B4-BE49-F238E27FC236}">
-                <a16:creationId xmlns:a16="http://schemas.microsoft.com/office/drawing/2014/main" id="{AB9CF17F-8A33-4951-A48B-26894104B02E}"/>
+                <a16:creationId xmlns:a16="http://schemas.microsoft.com/office/drawing/2014/main" id="{0E66A6DE-E480-4BBB-B772-137E72212C43}"/>
               </a:ext>
             </a:extLst>
           </p:cNvPr>
@@ -2942,7 +2942,7 @@
           <p:cNvPr id="40" name="">
             <a:extLst xmlns:a="http://schemas.openxmlformats.org/drawingml/2006/main">
               <a:ext uri="{FF2B5EF4-FFF2-40B4-BE49-F238E27FC236}">
-                <a16:creationId xmlns:a16="http://schemas.microsoft.com/office/drawing/2014/main" id="{7BB52583-71EB-4A4D-AC87-4FD36C51EB26}"/>
+                <a16:creationId xmlns:a16="http://schemas.microsoft.com/office/drawing/2014/main" id="{3EE0985A-8D36-4497-99C8-55DDDAEE520F}"/>
               </a:ext>
             </a:extLst>
           </p:cNvPr>
@@ -2975,7 +2975,7 @@
           <p:cNvPr id="41" name="">
             <a:extLst xmlns:a="http://schemas.openxmlformats.org/drawingml/2006/main">
               <a:ext uri="{FF2B5EF4-FFF2-40B4-BE49-F238E27FC236}">
-                <a16:creationId xmlns:a16="http://schemas.microsoft.com/office/drawing/2014/main" id="{4D9704FA-4E87-4950-AB4F-956F99619D74}"/>
+                <a16:creationId xmlns:a16="http://schemas.microsoft.com/office/drawing/2014/main" id="{7D7786E8-F478-49B1-AA0B-BE54CF7E8E32}"/>
               </a:ext>
             </a:extLst>
           </p:cNvPr>
@@ -3010,7 +3010,7 @@
           <p:cNvPr id="42" name="">
             <a:extLst xmlns:a="http://schemas.openxmlformats.org/drawingml/2006/main">
               <a:ext uri="{FF2B5EF4-FFF2-40B4-BE49-F238E27FC236}">
-                <a16:creationId xmlns:a16="http://schemas.microsoft.com/office/drawing/2014/main" id="{4DD2838E-6C9A-478C-A573-55555517490A}"/>
+                <a16:creationId xmlns:a16="http://schemas.microsoft.com/office/drawing/2014/main" id="{716D27DD-073B-4699-968F-B123E39BD44E}"/>
               </a:ext>
             </a:extLst>
           </p:cNvPr>
@@ -3074,7 +3074,7 @@
           <p:cNvPr id="43" name="">
             <a:extLst xmlns:a="http://schemas.openxmlformats.org/drawingml/2006/main">
               <a:ext uri="{FF2B5EF4-FFF2-40B4-BE49-F238E27FC236}">
-                <a16:creationId xmlns:a16="http://schemas.microsoft.com/office/drawing/2014/main" id="{86C13B46-EE83-4644-9629-6843F1C6D77E}"/>
+                <a16:creationId xmlns:a16="http://schemas.microsoft.com/office/drawing/2014/main" id="{A9F61BF5-63F3-4B63-8C20-9B951CDCF0E2}"/>
               </a:ext>
             </a:extLst>
           </p:cNvPr>
@@ -3107,7 +3107,7 @@
           <p:cNvPr id="44" name="">
             <a:extLst xmlns:a="http://schemas.openxmlformats.org/drawingml/2006/main">
               <a:ext uri="{FF2B5EF4-FFF2-40B4-BE49-F238E27FC236}">
-                <a16:creationId xmlns:a16="http://schemas.microsoft.com/office/drawing/2014/main" id="{DD2B6AD5-B5F5-44B3-92E6-84B4570DBD26}"/>
+                <a16:creationId xmlns:a16="http://schemas.microsoft.com/office/drawing/2014/main" id="{C2CEDD2F-64EB-41EC-AE7B-12E15351A02B}"/>
               </a:ext>
             </a:extLst>
           </p:cNvPr>
@@ -3194,7 +3194,7 @@
           <p:cNvPr id="45" name="">
             <a:extLst xmlns:a="http://schemas.openxmlformats.org/drawingml/2006/main">
               <a:ext uri="{FF2B5EF4-FFF2-40B4-BE49-F238E27FC236}">
-                <a16:creationId xmlns:a16="http://schemas.microsoft.com/office/drawing/2014/main" id="{CB38DE0E-313E-4713-8275-A6D27905153A}"/>
+                <a16:creationId xmlns:a16="http://schemas.microsoft.com/office/drawing/2014/main" id="{97C08E20-B5C6-416C-ADC1-3AF2C778ECBF}"/>
               </a:ext>
             </a:extLst>
           </p:cNvPr>
@@ -3227,7 +3227,7 @@
           <p:cNvPr id="46" name="">
             <a:extLst xmlns:a="http://schemas.openxmlformats.org/drawingml/2006/main">
               <a:ext uri="{FF2B5EF4-FFF2-40B4-BE49-F238E27FC236}">
-                <a16:creationId xmlns:a16="http://schemas.microsoft.com/office/drawing/2014/main" id="{DFBC36BB-CC39-478E-9D72-3D5038C33166}"/>
+                <a16:creationId xmlns:a16="http://schemas.microsoft.com/office/drawing/2014/main" id="{8109466E-DE48-4738-95E2-E54F691BDD9A}"/>
               </a:ext>
             </a:extLst>
           </p:cNvPr>
@@ -3314,7 +3314,7 @@
           <p:cNvPr id="47" name="">
             <a:extLst xmlns:a="http://schemas.openxmlformats.org/drawingml/2006/main">
               <a:ext uri="{FF2B5EF4-FFF2-40B4-BE49-F238E27FC236}">
-                <a16:creationId xmlns:a16="http://schemas.microsoft.com/office/drawing/2014/main" id="{CA2FEBE5-F7F0-4669-BCFE-AB05696DAAE7}"/>
+                <a16:creationId xmlns:a16="http://schemas.microsoft.com/office/drawing/2014/main" id="{1F5DE363-6356-4EC2-A065-C831528DFFC7}"/>
               </a:ext>
             </a:extLst>
           </p:cNvPr>
@@ -3347,7 +3347,7 @@
           <p:cNvPr id="48" name="">
             <a:extLst xmlns:a="http://schemas.openxmlformats.org/drawingml/2006/main">
               <a:ext uri="{FF2B5EF4-FFF2-40B4-BE49-F238E27FC236}">
-                <a16:creationId xmlns:a16="http://schemas.microsoft.com/office/drawing/2014/main" id="{35B2A058-6BCB-4B1C-A4EF-A2FFEA076C5A}"/>
+                <a16:creationId xmlns:a16="http://schemas.microsoft.com/office/drawing/2014/main" id="{2A1E42E5-507C-4E1B-870D-7896E6F8123D}"/>
               </a:ext>
             </a:extLst>
           </p:cNvPr>
@@ -3434,7 +3434,7 @@
           <p:cNvPr id="49" name="">
             <a:extLst xmlns:a="http://schemas.openxmlformats.org/drawingml/2006/main">
               <a:ext uri="{FF2B5EF4-FFF2-40B4-BE49-F238E27FC236}">
-                <a16:creationId xmlns:a16="http://schemas.microsoft.com/office/drawing/2014/main" id="{4253CF6A-F1C8-4164-883B-622D542AEE07}"/>
+                <a16:creationId xmlns:a16="http://schemas.microsoft.com/office/drawing/2014/main" id="{9BC9CC1E-55DD-4D37-8BE8-053A329C85DA}"/>
               </a:ext>
             </a:extLst>
           </p:cNvPr>
@@ -3467,7 +3467,7 @@
           <p:cNvPr id="50" name="">
             <a:extLst xmlns:a="http://schemas.openxmlformats.org/drawingml/2006/main">
               <a:ext uri="{FF2B5EF4-FFF2-40B4-BE49-F238E27FC236}">
-                <a16:creationId xmlns:a16="http://schemas.microsoft.com/office/drawing/2014/main" id="{982DFDF9-6350-4CFB-B952-B96332CDA646}"/>
+                <a16:creationId xmlns:a16="http://schemas.microsoft.com/office/drawing/2014/main" id="{3968304F-EFE4-479A-9F6C-27614F9FD3A0}"/>
               </a:ext>
             </a:extLst>
           </p:cNvPr>
@@ -3502,7 +3502,7 @@
           <p:cNvPr id="51" name="">
             <a:extLst xmlns:a="http://schemas.openxmlformats.org/drawingml/2006/main">
               <a:ext uri="{FF2B5EF4-FFF2-40B4-BE49-F238E27FC236}">
-                <a16:creationId xmlns:a16="http://schemas.microsoft.com/office/drawing/2014/main" id="{5FCADDBE-150D-43A7-BC74-1C28495065B4}"/>
+                <a16:creationId xmlns:a16="http://schemas.microsoft.com/office/drawing/2014/main" id="{298FCCEC-8874-44E8-BD26-144B6281D7BF}"/>
               </a:ext>
             </a:extLst>
           </p:cNvPr>
@@ -3566,7 +3566,7 @@
           <p:cNvPr id="52" name="">
             <a:extLst xmlns:a="http://schemas.openxmlformats.org/drawingml/2006/main">
               <a:ext uri="{FF2B5EF4-FFF2-40B4-BE49-F238E27FC236}">
-                <a16:creationId xmlns:a16="http://schemas.microsoft.com/office/drawing/2014/main" id="{72BCB722-7205-466C-B9CB-E1EEB61885DB}"/>
+                <a16:creationId xmlns:a16="http://schemas.microsoft.com/office/drawing/2014/main" id="{51F9699E-5385-48A3-BAB3-6871A7FE3678}"/>
               </a:ext>
             </a:extLst>
           </p:cNvPr>
@@ -3599,7 +3599,7 @@
           <p:cNvPr id="53" name="">
             <a:extLst xmlns:a="http://schemas.openxmlformats.org/drawingml/2006/main">
               <a:ext uri="{FF2B5EF4-FFF2-40B4-BE49-F238E27FC236}">
-                <a16:creationId xmlns:a16="http://schemas.microsoft.com/office/drawing/2014/main" id="{52DF0CD8-E111-4845-8620-D2678935DD9A}"/>
+                <a16:creationId xmlns:a16="http://schemas.microsoft.com/office/drawing/2014/main" id="{623761DB-1195-46E1-8631-A5FE0E23C067}"/>
               </a:ext>
             </a:extLst>
           </p:cNvPr>
@@ -3634,7 +3634,7 @@
           <p:cNvPr id="54" name="">
             <a:extLst xmlns:a="http://schemas.openxmlformats.org/drawingml/2006/main">
               <a:ext uri="{FF2B5EF4-FFF2-40B4-BE49-F238E27FC236}">
-                <a16:creationId xmlns:a16="http://schemas.microsoft.com/office/drawing/2014/main" id="{6FF5B164-9834-41CE-BB82-967EAEE5CA5B}"/>
+                <a16:creationId xmlns:a16="http://schemas.microsoft.com/office/drawing/2014/main" id="{66806566-856A-45C8-9CFB-0BDCAA435CDA}"/>
               </a:ext>
             </a:extLst>
           </p:cNvPr>
@@ -3698,7 +3698,7 @@
           <p:cNvPr id="55" name="">
             <a:extLst xmlns:a="http://schemas.openxmlformats.org/drawingml/2006/main">
               <a:ext uri="{FF2B5EF4-FFF2-40B4-BE49-F238E27FC236}">
-                <a16:creationId xmlns:a16="http://schemas.microsoft.com/office/drawing/2014/main" id="{20DA21E0-8134-4327-AC32-AF1E403D4701}"/>
+                <a16:creationId xmlns:a16="http://schemas.microsoft.com/office/drawing/2014/main" id="{15C91474-1D31-4BCC-964C-1716715F56FC}"/>
               </a:ext>
             </a:extLst>
           </p:cNvPr>
@@ -3731,7 +3731,7 @@
           <p:cNvPr id="56" name="">
             <a:extLst xmlns:a="http://schemas.openxmlformats.org/drawingml/2006/main">
               <a:ext uri="{FF2B5EF4-FFF2-40B4-BE49-F238E27FC236}">
-                <a16:creationId xmlns:a16="http://schemas.microsoft.com/office/drawing/2014/main" id="{3E601EFA-F96B-459E-82B5-3BA0F4A73E7F}"/>
+                <a16:creationId xmlns:a16="http://schemas.microsoft.com/office/drawing/2014/main" id="{C545111A-A53E-4C4D-A533-05C71079F97E}"/>
               </a:ext>
             </a:extLst>
           </p:cNvPr>
@@ -3766,7 +3766,7 @@
           <p:cNvPr id="57" name="">
             <a:extLst xmlns:a="http://schemas.openxmlformats.org/drawingml/2006/main">
               <a:ext uri="{FF2B5EF4-FFF2-40B4-BE49-F238E27FC236}">
-                <a16:creationId xmlns:a16="http://schemas.microsoft.com/office/drawing/2014/main" id="{B0494AF1-5C27-4B67-BD89-3A38DD1BE5F6}"/>
+                <a16:creationId xmlns:a16="http://schemas.microsoft.com/office/drawing/2014/main" id="{4E0F4CCF-C8B6-4747-912C-69A709C71E4F}"/>
               </a:ext>
             </a:extLst>
           </p:cNvPr>
@@ -3830,7 +3830,7 @@
           <p:cNvPr id="58" name="">
             <a:extLst xmlns:a="http://schemas.openxmlformats.org/drawingml/2006/main">
               <a:ext uri="{FF2B5EF4-FFF2-40B4-BE49-F238E27FC236}">
-                <a16:creationId xmlns:a16="http://schemas.microsoft.com/office/drawing/2014/main" id="{20DAA23D-0F6B-4B81-9998-CB6DA1118A27}"/>
+                <a16:creationId xmlns:a16="http://schemas.microsoft.com/office/drawing/2014/main" id="{5A4CF8FB-7CC5-4D32-921A-4AEFC5D9715B}"/>
               </a:ext>
             </a:extLst>
           </p:cNvPr>
@@ -3894,7 +3894,7 @@
           <p:cNvPr id="59" name="">
             <a:extLst xmlns:a="http://schemas.openxmlformats.org/drawingml/2006/main">
               <a:ext uri="{FF2B5EF4-FFF2-40B4-BE49-F238E27FC236}">
-                <a16:creationId xmlns:a16="http://schemas.microsoft.com/office/drawing/2014/main" id="{85BE2130-8D1A-4555-9872-CA1AB9BA8A02}"/>
+                <a16:creationId xmlns:a16="http://schemas.microsoft.com/office/drawing/2014/main" id="{78868278-720F-4121-AB43-630529009873}"/>
               </a:ext>
             </a:extLst>
           </p:cNvPr>
@@ -3958,7 +3958,7 @@
           <p:cNvPr id="60" name="">
             <a:extLst xmlns:a="http://schemas.openxmlformats.org/drawingml/2006/main">
               <a:ext uri="{FF2B5EF4-FFF2-40B4-BE49-F238E27FC236}">
-                <a16:creationId xmlns:a16="http://schemas.microsoft.com/office/drawing/2014/main" id="{E0BEDF08-FC52-4D1B-A462-21EF2917ABFF}"/>
+                <a16:creationId xmlns:a16="http://schemas.microsoft.com/office/drawing/2014/main" id="{32CAB53E-4C8C-4AE3-A02D-B8E2A45B7BAB}"/>
               </a:ext>
             </a:extLst>
           </p:cNvPr>
@@ -4022,7 +4022,7 @@
           <p:cNvPr id="61" name="">
             <a:extLst xmlns:a="http://schemas.openxmlformats.org/drawingml/2006/main">
               <a:ext uri="{FF2B5EF4-FFF2-40B4-BE49-F238E27FC236}">
-                <a16:creationId xmlns:a16="http://schemas.microsoft.com/office/drawing/2014/main" id="{D957DA86-DC8D-42B7-B9FD-37E6BBCA62E6}"/>
+                <a16:creationId xmlns:a16="http://schemas.microsoft.com/office/drawing/2014/main" id="{B55A99AA-56B7-407E-A88C-862F67A2BBCB}"/>
               </a:ext>
             </a:extLst>
           </p:cNvPr>
@@ -4057,7 +4057,7 @@
           <p:cNvPr id="62" name="">
             <a:extLst xmlns:a="http://schemas.openxmlformats.org/drawingml/2006/main">
               <a:ext uri="{FF2B5EF4-FFF2-40B4-BE49-F238E27FC236}">
-                <a16:creationId xmlns:a16="http://schemas.microsoft.com/office/drawing/2014/main" id="{7F0340B5-B98C-4426-B803-63629A227965}"/>
+                <a16:creationId xmlns:a16="http://schemas.microsoft.com/office/drawing/2014/main" id="{66ECB131-1154-4259-9923-45125C205F86}"/>
               </a:ext>
             </a:extLst>
           </p:cNvPr>
@@ -4119,7 +4119,7 @@
     </p:spTree>
     <p:extLst>
       <p:ext uri="{BB962C8B-B14F-4D97-AF65-F5344CB8AC3E}">
-        <p14:creationId xmlns:p14="http://schemas.microsoft.com/office/powerpoint/2010/main" val="1827670241"/>
+        <p14:creationId xmlns:p14="http://schemas.microsoft.com/office/powerpoint/2010/main" val="1258848881"/>
       </p:ext>
     </p:extLst>
   </p:cSld>
@@ -4143,7 +4143,7 @@
           <p:cNvPr id="1" name="">
             <a:extLst xmlns:a="http://schemas.openxmlformats.org/drawingml/2006/main">
               <a:ext uri="{FF2B5EF4-FFF2-40B4-BE49-F238E27FC236}">
-                <a16:creationId xmlns:a16="http://schemas.microsoft.com/office/drawing/2014/main" id="{2D1E5E7A-7530-4651-8A6A-8A3972734CB3}"/>
+                <a16:creationId xmlns:a16="http://schemas.microsoft.com/office/drawing/2014/main" id="{4B558799-374A-437B-8AB1-F0998CE0AA5A}"/>
               </a:ext>
             </a:extLst>
           </p:cNvPr>
@@ -4178,7 +4178,7 @@
           <p:cNvPr id="2" name="">
             <a:extLst xmlns:a="http://schemas.openxmlformats.org/drawingml/2006/main">
               <a:ext uri="{FF2B5EF4-FFF2-40B4-BE49-F238E27FC236}">
-                <a16:creationId xmlns:a16="http://schemas.microsoft.com/office/drawing/2014/main" id="{39052E3B-8D3E-4100-902D-C6D1B823B5B8}"/>
+                <a16:creationId xmlns:a16="http://schemas.microsoft.com/office/drawing/2014/main" id="{247D86A4-1AC5-4EA2-B29E-2DFAD322C90E}"/>
               </a:ext>
             </a:extLst>
           </p:cNvPr>
@@ -4213,7 +4213,7 @@
           <p:cNvPr id="3" name="">
             <a:extLst xmlns:a="http://schemas.openxmlformats.org/drawingml/2006/main">
               <a:ext uri="{FF2B5EF4-FFF2-40B4-BE49-F238E27FC236}">
-                <a16:creationId xmlns:a16="http://schemas.microsoft.com/office/drawing/2014/main" id="{8DE15640-DB1F-49F3-A985-097D330C4F63}"/>
+                <a16:creationId xmlns:a16="http://schemas.microsoft.com/office/drawing/2014/main" id="{C46FBB90-40D7-488B-8817-17B5C5284AA5}"/>
               </a:ext>
             </a:extLst>
           </p:cNvPr>
@@ -4248,7 +4248,7 @@
           <p:cNvPr id="4" name="">
             <a:extLst xmlns:a="http://schemas.openxmlformats.org/drawingml/2006/main">
               <a:ext uri="{FF2B5EF4-FFF2-40B4-BE49-F238E27FC236}">
-                <a16:creationId xmlns:a16="http://schemas.microsoft.com/office/drawing/2014/main" id="{A7470BDF-C7E0-4304-BCA1-6329AD0ED0FE}"/>
+                <a16:creationId xmlns:a16="http://schemas.microsoft.com/office/drawing/2014/main" id="{6BCC5FFE-8209-4870-93F0-EBD0F71E26CA}"/>
               </a:ext>
             </a:extLst>
           </p:cNvPr>
@@ -4312,7 +4312,7 @@
           <p:cNvPr id="5" name="">
             <a:extLst xmlns:a="http://schemas.openxmlformats.org/drawingml/2006/main">
               <a:ext uri="{FF2B5EF4-FFF2-40B4-BE49-F238E27FC236}">
-                <a16:creationId xmlns:a16="http://schemas.microsoft.com/office/drawing/2014/main" id="{14BFAF71-351F-4EB9-8F52-CB0E50838D2F}"/>
+                <a16:creationId xmlns:a16="http://schemas.microsoft.com/office/drawing/2014/main" id="{63B9A9E3-8453-4819-9ECD-25CBFBB78EE0}"/>
               </a:ext>
             </a:extLst>
           </p:cNvPr>
@@ -4376,7 +4376,7 @@
           <p:cNvPr id="6" name="">
             <a:extLst xmlns:a="http://schemas.openxmlformats.org/drawingml/2006/main">
               <a:ext uri="{FF2B5EF4-FFF2-40B4-BE49-F238E27FC236}">
-                <a16:creationId xmlns:a16="http://schemas.microsoft.com/office/drawing/2014/main" id="{F79EF586-FC09-49E1-B383-478FD1ADCFAD}"/>
+                <a16:creationId xmlns:a16="http://schemas.microsoft.com/office/drawing/2014/main" id="{CD2A98D9-AE1B-406C-92D4-3D8BD3967B1C}"/>
               </a:ext>
             </a:extLst>
           </p:cNvPr>
@@ -4430,7 +4430,7 @@
                 <a:ea typeface="Hiragino Mincho ProN"/>
                 <a:cs typeface="Hiragino Mincho ProN"/>
               </a:rPr>
-              <a:t>この資料は導入判断ではなく、棄却条件を決める</a:t>
+              <a:t>導入判断の前に、候補を落とす条件を決める</a:t>
             </a:r>
           </a:p>
         </p:txBody>
@@ -4440,7 +4440,7 @@
           <p:cNvPr id="7" name="">
             <a:extLst xmlns:a="http://schemas.openxmlformats.org/drawingml/2006/main">
               <a:ext uri="{FF2B5EF4-FFF2-40B4-BE49-F238E27FC236}">
-                <a16:creationId xmlns:a16="http://schemas.microsoft.com/office/drawing/2014/main" id="{7E24893C-94B2-4602-BD32-EAAD7FB93F5B}"/>
+                <a16:creationId xmlns:a16="http://schemas.microsoft.com/office/drawing/2014/main" id="{DDE3F6B7-D2DA-4A00-843B-E4B2F3792800}"/>
               </a:ext>
             </a:extLst>
           </p:cNvPr>
@@ -4473,7 +4473,7 @@
           <p:cNvPr id="8" name="">
             <a:extLst xmlns:a="http://schemas.openxmlformats.org/drawingml/2006/main">
               <a:ext uri="{FF2B5EF4-FFF2-40B4-BE49-F238E27FC236}">
-                <a16:creationId xmlns:a16="http://schemas.microsoft.com/office/drawing/2014/main" id="{B1E397B8-7C39-47FA-9C99-D145DAE11208}"/>
+                <a16:creationId xmlns:a16="http://schemas.microsoft.com/office/drawing/2014/main" id="{108CD3FF-B24B-4445-B079-51C343142735}"/>
               </a:ext>
             </a:extLst>
           </p:cNvPr>
@@ -4508,7 +4508,7 @@
           <p:cNvPr id="9" name="">
             <a:extLst xmlns:a="http://schemas.openxmlformats.org/drawingml/2006/main">
               <a:ext uri="{FF2B5EF4-FFF2-40B4-BE49-F238E27FC236}">
-                <a16:creationId xmlns:a16="http://schemas.microsoft.com/office/drawing/2014/main" id="{E194EC71-A58E-441D-A1E8-CA4021A83097}"/>
+                <a16:creationId xmlns:a16="http://schemas.microsoft.com/office/drawing/2014/main" id="{1A93F7D5-D83D-4D5C-BF78-17677DC0AEC0}"/>
               </a:ext>
             </a:extLst>
           </p:cNvPr>
@@ -4562,7 +4562,7 @@
                 <a:ea typeface="Hiragino Sans"/>
                 <a:cs typeface="Hiragino Sans"/>
               </a:rPr>
-              <a:t>主張 | 単純規則、AE候補、装置制約の順に削り、次に測る証拠を明確にするための資料である。</a:t>
+              <a:t>主張 | いま必要なのは採用可否の結論ではなく、次の実験で候補を採用・縮小・棄却する判定条件である。</a:t>
             </a:r>
           </a:p>
         </p:txBody>
@@ -4572,7 +4572,7 @@
           <p:cNvPr id="10" name="">
             <a:extLst xmlns:a="http://schemas.openxmlformats.org/drawingml/2006/main">
               <a:ext uri="{FF2B5EF4-FFF2-40B4-BE49-F238E27FC236}">
-                <a16:creationId xmlns:a16="http://schemas.microsoft.com/office/drawing/2014/main" id="{E255DA17-D158-4FD1-AD81-37500069084C}"/>
+                <a16:creationId xmlns:a16="http://schemas.microsoft.com/office/drawing/2014/main" id="{3475EB74-AED9-46DC-A386-84D83BE17408}"/>
               </a:ext>
             </a:extLst>
           </p:cNvPr>
@@ -4605,7 +4605,7 @@
           <p:cNvPr id="11" name="">
             <a:extLst xmlns:a="http://schemas.openxmlformats.org/drawingml/2006/main">
               <a:ext uri="{FF2B5EF4-FFF2-40B4-BE49-F238E27FC236}">
-                <a16:creationId xmlns:a16="http://schemas.microsoft.com/office/drawing/2014/main" id="{F602DF5E-2A93-492F-A754-439BF7139C82}"/>
+                <a16:creationId xmlns:a16="http://schemas.microsoft.com/office/drawing/2014/main" id="{48796FBC-905D-43C1-AF0C-8FB9814623E8}"/>
               </a:ext>
             </a:extLst>
           </p:cNvPr>
@@ -4640,7 +4640,7 @@
           <p:cNvPr id="12" name="">
             <a:extLst xmlns:a="http://schemas.openxmlformats.org/drawingml/2006/main">
               <a:ext uri="{FF2B5EF4-FFF2-40B4-BE49-F238E27FC236}">
-                <a16:creationId xmlns:a16="http://schemas.microsoft.com/office/drawing/2014/main" id="{510D6CDE-F47D-4568-9B7D-0466ED4D5231}"/>
+                <a16:creationId xmlns:a16="http://schemas.microsoft.com/office/drawing/2014/main" id="{D12F5583-40C4-4005-9081-B3BBC317D4CA}"/>
               </a:ext>
             </a:extLst>
           </p:cNvPr>
@@ -4704,7 +4704,7 @@
           <p:cNvPr id="13" name="">
             <a:extLst xmlns:a="http://schemas.openxmlformats.org/drawingml/2006/main">
               <a:ext uri="{FF2B5EF4-FFF2-40B4-BE49-F238E27FC236}">
-                <a16:creationId xmlns:a16="http://schemas.microsoft.com/office/drawing/2014/main" id="{03BA98EA-388F-43EB-9A23-7F550DF33BE8}"/>
+                <a16:creationId xmlns:a16="http://schemas.microsoft.com/office/drawing/2014/main" id="{B9451E6D-3DF4-4F3A-9ACA-68C2D52F2046}"/>
               </a:ext>
             </a:extLst>
           </p:cNvPr>
@@ -4737,7 +4737,7 @@
           <p:cNvPr id="14" name="">
             <a:extLst xmlns:a="http://schemas.openxmlformats.org/drawingml/2006/main">
               <a:ext uri="{FF2B5EF4-FFF2-40B4-BE49-F238E27FC236}">
-                <a16:creationId xmlns:a16="http://schemas.microsoft.com/office/drawing/2014/main" id="{5C3AB0F3-A6CA-445F-9487-A6C0950B5881}"/>
+                <a16:creationId xmlns:a16="http://schemas.microsoft.com/office/drawing/2014/main" id="{6C4E1DAB-AB50-4868-AA54-993918E2288A}"/>
               </a:ext>
             </a:extLst>
           </p:cNvPr>
@@ -4772,7 +4772,7 @@
           <p:cNvPr id="15" name="">
             <a:extLst xmlns:a="http://schemas.openxmlformats.org/drawingml/2006/main">
               <a:ext uri="{FF2B5EF4-FFF2-40B4-BE49-F238E27FC236}">
-                <a16:creationId xmlns:a16="http://schemas.microsoft.com/office/drawing/2014/main" id="{26D9A762-732E-45AD-AD65-7255CEEF3A62}"/>
+                <a16:creationId xmlns:a16="http://schemas.microsoft.com/office/drawing/2014/main" id="{542BAAD8-8B90-4D16-BC2F-66E2AB8FEC15}"/>
               </a:ext>
             </a:extLst>
           </p:cNvPr>
@@ -4836,7 +4836,7 @@
           <p:cNvPr id="16" name="">
             <a:extLst xmlns:a="http://schemas.openxmlformats.org/drawingml/2006/main">
               <a:ext uri="{FF2B5EF4-FFF2-40B4-BE49-F238E27FC236}">
-                <a16:creationId xmlns:a16="http://schemas.microsoft.com/office/drawing/2014/main" id="{A2C599BF-ABF3-4A6C-9470-8BAC8A3A8BF2}"/>
+                <a16:creationId xmlns:a16="http://schemas.microsoft.com/office/drawing/2014/main" id="{8C26DB6F-198D-4FED-931C-5712278ED822}"/>
               </a:ext>
             </a:extLst>
           </p:cNvPr>
@@ -4900,7 +4900,7 @@
           <p:cNvPr id="17" name="">
             <a:extLst xmlns:a="http://schemas.openxmlformats.org/drawingml/2006/main">
               <a:ext uri="{FF2B5EF4-FFF2-40B4-BE49-F238E27FC236}">
-                <a16:creationId xmlns:a16="http://schemas.microsoft.com/office/drawing/2014/main" id="{76493AED-653D-43E6-A85F-055FAFDBC394}"/>
+                <a16:creationId xmlns:a16="http://schemas.microsoft.com/office/drawing/2014/main" id="{60550AE4-229C-4BB3-A8A0-EFE63C4DC284}"/>
               </a:ext>
             </a:extLst>
           </p:cNvPr>
@@ -4935,7 +4935,7 @@
           <p:cNvPr id="18" name="">
             <a:extLst xmlns:a="http://schemas.openxmlformats.org/drawingml/2006/main">
               <a:ext uri="{FF2B5EF4-FFF2-40B4-BE49-F238E27FC236}">
-                <a16:creationId xmlns:a16="http://schemas.microsoft.com/office/drawing/2014/main" id="{54BC08C8-3CA0-4DE1-B780-A0E5C9FC8810}"/>
+                <a16:creationId xmlns:a16="http://schemas.microsoft.com/office/drawing/2014/main" id="{5C798196-2420-469B-94D1-FA21ACD89255}"/>
               </a:ext>
             </a:extLst>
           </p:cNvPr>
@@ -4999,7 +4999,7 @@
           <p:cNvPr id="19" name="">
             <a:extLst xmlns:a="http://schemas.openxmlformats.org/drawingml/2006/main">
               <a:ext uri="{FF2B5EF4-FFF2-40B4-BE49-F238E27FC236}">
-                <a16:creationId xmlns:a16="http://schemas.microsoft.com/office/drawing/2014/main" id="{68E06C81-A116-4B35-B74E-C82D8C06B2C3}"/>
+                <a16:creationId xmlns:a16="http://schemas.microsoft.com/office/drawing/2014/main" id="{15F4E05C-A74A-40E3-83E5-36F4FE451254}"/>
               </a:ext>
             </a:extLst>
           </p:cNvPr>
@@ -5032,7 +5032,7 @@
           <p:cNvPr id="20" name="">
             <a:extLst xmlns:a="http://schemas.openxmlformats.org/drawingml/2006/main">
               <a:ext uri="{FF2B5EF4-FFF2-40B4-BE49-F238E27FC236}">
-                <a16:creationId xmlns:a16="http://schemas.microsoft.com/office/drawing/2014/main" id="{371A9B87-E35A-406F-97B3-380BA8533C58}"/>
+                <a16:creationId xmlns:a16="http://schemas.microsoft.com/office/drawing/2014/main" id="{69928A4D-4AD1-41BF-88F8-CE4CF09DC263}"/>
               </a:ext>
             </a:extLst>
           </p:cNvPr>
@@ -5067,7 +5067,7 @@
           <p:cNvPr id="21" name="">
             <a:extLst xmlns:a="http://schemas.openxmlformats.org/drawingml/2006/main">
               <a:ext uri="{FF2B5EF4-FFF2-40B4-BE49-F238E27FC236}">
-                <a16:creationId xmlns:a16="http://schemas.microsoft.com/office/drawing/2014/main" id="{D7BE07FB-0A99-47B9-834A-638F1DE79E2B}"/>
+                <a16:creationId xmlns:a16="http://schemas.microsoft.com/office/drawing/2014/main" id="{8F1836D2-B01A-4B41-9C67-35C58CCBED0E}"/>
               </a:ext>
             </a:extLst>
           </p:cNvPr>
@@ -5131,7 +5131,7 @@
           <p:cNvPr id="22" name="">
             <a:extLst xmlns:a="http://schemas.openxmlformats.org/drawingml/2006/main">
               <a:ext uri="{FF2B5EF4-FFF2-40B4-BE49-F238E27FC236}">
-                <a16:creationId xmlns:a16="http://schemas.microsoft.com/office/drawing/2014/main" id="{CD2FE011-A054-4701-99F0-F71AE6893762}"/>
+                <a16:creationId xmlns:a16="http://schemas.microsoft.com/office/drawing/2014/main" id="{BC1607C9-9660-4EA4-B08E-33AB6E133C2E}"/>
               </a:ext>
             </a:extLst>
           </p:cNvPr>
@@ -5195,7 +5195,7 @@
           <p:cNvPr id="23" name="">
             <a:extLst xmlns:a="http://schemas.openxmlformats.org/drawingml/2006/main">
               <a:ext uri="{FF2B5EF4-FFF2-40B4-BE49-F238E27FC236}">
-                <a16:creationId xmlns:a16="http://schemas.microsoft.com/office/drawing/2014/main" id="{B0676859-67BE-4F24-8621-4E49C466F1C3}"/>
+                <a16:creationId xmlns:a16="http://schemas.microsoft.com/office/drawing/2014/main" id="{1DD906AD-F000-4B1E-87E2-F1A7E104ADB0}"/>
               </a:ext>
             </a:extLst>
           </p:cNvPr>
@@ -5230,7 +5230,7 @@
           <p:cNvPr id="24" name="">
             <a:extLst xmlns:a="http://schemas.openxmlformats.org/drawingml/2006/main">
               <a:ext uri="{FF2B5EF4-FFF2-40B4-BE49-F238E27FC236}">
-                <a16:creationId xmlns:a16="http://schemas.microsoft.com/office/drawing/2014/main" id="{B6B5A023-24F2-448A-BD7C-F20855231512}"/>
+                <a16:creationId xmlns:a16="http://schemas.microsoft.com/office/drawing/2014/main" id="{BDDEEEDF-400A-4D00-A1F3-C879AC42BA5C}"/>
               </a:ext>
             </a:extLst>
           </p:cNvPr>
@@ -5294,7 +5294,7 @@
           <p:cNvPr id="25" name="">
             <a:extLst xmlns:a="http://schemas.openxmlformats.org/drawingml/2006/main">
               <a:ext uri="{FF2B5EF4-FFF2-40B4-BE49-F238E27FC236}">
-                <a16:creationId xmlns:a16="http://schemas.microsoft.com/office/drawing/2014/main" id="{39B6FB5E-3976-490F-867F-EA4ED85AAB53}"/>
+                <a16:creationId xmlns:a16="http://schemas.microsoft.com/office/drawing/2014/main" id="{E025B094-E27D-48F5-9DB3-93701E9B537A}"/>
               </a:ext>
             </a:extLst>
           </p:cNvPr>
@@ -5327,7 +5327,7 @@
           <p:cNvPr id="26" name="">
             <a:extLst xmlns:a="http://schemas.openxmlformats.org/drawingml/2006/main">
               <a:ext uri="{FF2B5EF4-FFF2-40B4-BE49-F238E27FC236}">
-                <a16:creationId xmlns:a16="http://schemas.microsoft.com/office/drawing/2014/main" id="{D027C426-A6B4-4D35-9B11-A43312096E6E}"/>
+                <a16:creationId xmlns:a16="http://schemas.microsoft.com/office/drawing/2014/main" id="{DE212E0C-F254-4B96-95D1-BB032EAFF1BA}"/>
               </a:ext>
             </a:extLst>
           </p:cNvPr>
@@ -5362,7 +5362,7 @@
           <p:cNvPr id="27" name="">
             <a:extLst xmlns:a="http://schemas.openxmlformats.org/drawingml/2006/main">
               <a:ext uri="{FF2B5EF4-FFF2-40B4-BE49-F238E27FC236}">
-                <a16:creationId xmlns:a16="http://schemas.microsoft.com/office/drawing/2014/main" id="{4EEFE5AB-F68A-4952-BCBC-1A59BBBC59EC}"/>
+                <a16:creationId xmlns:a16="http://schemas.microsoft.com/office/drawing/2014/main" id="{1714C721-EC26-4851-BF60-CBB710069B55}"/>
               </a:ext>
             </a:extLst>
           </p:cNvPr>
@@ -5426,7 +5426,7 @@
           <p:cNvPr id="28" name="">
             <a:extLst xmlns:a="http://schemas.openxmlformats.org/drawingml/2006/main">
               <a:ext uri="{FF2B5EF4-FFF2-40B4-BE49-F238E27FC236}">
-                <a16:creationId xmlns:a16="http://schemas.microsoft.com/office/drawing/2014/main" id="{2254BA3A-0EFA-4771-903F-04FB4CCAA13E}"/>
+                <a16:creationId xmlns:a16="http://schemas.microsoft.com/office/drawing/2014/main" id="{DFF085FB-A372-4FB7-B997-ED998F9D2712}"/>
               </a:ext>
             </a:extLst>
           </p:cNvPr>
@@ -5490,7 +5490,7 @@
           <p:cNvPr id="29" name="">
             <a:extLst xmlns:a="http://schemas.openxmlformats.org/drawingml/2006/main">
               <a:ext uri="{FF2B5EF4-FFF2-40B4-BE49-F238E27FC236}">
-                <a16:creationId xmlns:a16="http://schemas.microsoft.com/office/drawing/2014/main" id="{40F4E71F-42F9-4BE1-B2B7-BEAEC46CFE2B}"/>
+                <a16:creationId xmlns:a16="http://schemas.microsoft.com/office/drawing/2014/main" id="{5DF3BF32-A6B3-4C15-9D45-AC82C78F760A}"/>
               </a:ext>
             </a:extLst>
           </p:cNvPr>
@@ -5525,7 +5525,7 @@
           <p:cNvPr id="30" name="">
             <a:extLst xmlns:a="http://schemas.openxmlformats.org/drawingml/2006/main">
               <a:ext uri="{FF2B5EF4-FFF2-40B4-BE49-F238E27FC236}">
-                <a16:creationId xmlns:a16="http://schemas.microsoft.com/office/drawing/2014/main" id="{EB56E077-9EDE-48F8-B448-FE7318D71E28}"/>
+                <a16:creationId xmlns:a16="http://schemas.microsoft.com/office/drawing/2014/main" id="{5B615AFD-B7A2-46C6-A2F2-B5A1E7306F03}"/>
               </a:ext>
             </a:extLst>
           </p:cNvPr>
@@ -5589,7 +5589,7 @@
           <p:cNvPr id="31" name="">
             <a:extLst xmlns:a="http://schemas.openxmlformats.org/drawingml/2006/main">
               <a:ext uri="{FF2B5EF4-FFF2-40B4-BE49-F238E27FC236}">
-                <a16:creationId xmlns:a16="http://schemas.microsoft.com/office/drawing/2014/main" id="{7B2B4C7F-F221-44EC-B2B1-EC8B15B28190}"/>
+                <a16:creationId xmlns:a16="http://schemas.microsoft.com/office/drawing/2014/main" id="{55EC90E3-E95A-4D5B-B22E-DE421708C0C3}"/>
               </a:ext>
             </a:extLst>
           </p:cNvPr>
@@ -5622,7 +5622,7 @@
           <p:cNvPr id="32" name="">
             <a:extLst xmlns:a="http://schemas.openxmlformats.org/drawingml/2006/main">
               <a:ext uri="{FF2B5EF4-FFF2-40B4-BE49-F238E27FC236}">
-                <a16:creationId xmlns:a16="http://schemas.microsoft.com/office/drawing/2014/main" id="{2741C9F1-46D3-4F60-A7E7-DBFD468B5DA8}"/>
+                <a16:creationId xmlns:a16="http://schemas.microsoft.com/office/drawing/2014/main" id="{CBACCF04-1422-4347-9114-0CDBE697BE73}"/>
               </a:ext>
             </a:extLst>
           </p:cNvPr>
@@ -5657,7 +5657,7 @@
           <p:cNvPr id="33" name="">
             <a:extLst xmlns:a="http://schemas.openxmlformats.org/drawingml/2006/main">
               <a:ext uri="{FF2B5EF4-FFF2-40B4-BE49-F238E27FC236}">
-                <a16:creationId xmlns:a16="http://schemas.microsoft.com/office/drawing/2014/main" id="{D1F0EBD9-42F8-4BBE-9633-E9661EB2B399}"/>
+                <a16:creationId xmlns:a16="http://schemas.microsoft.com/office/drawing/2014/main" id="{9245D2EE-C3A7-4667-A7A6-8EC70AADF3B6}"/>
               </a:ext>
             </a:extLst>
           </p:cNvPr>
@@ -5721,7 +5721,7 @@
           <p:cNvPr id="34" name="">
             <a:extLst xmlns:a="http://schemas.openxmlformats.org/drawingml/2006/main">
               <a:ext uri="{FF2B5EF4-FFF2-40B4-BE49-F238E27FC236}">
-                <a16:creationId xmlns:a16="http://schemas.microsoft.com/office/drawing/2014/main" id="{794026BC-B3C8-4A6E-B9F8-202BF79A2F54}"/>
+                <a16:creationId xmlns:a16="http://schemas.microsoft.com/office/drawing/2014/main" id="{2A300EFE-A684-4806-A13C-9B8504781078}"/>
               </a:ext>
             </a:extLst>
           </p:cNvPr>
@@ -5785,7 +5785,7 @@
           <p:cNvPr id="35" name="">
             <a:extLst xmlns:a="http://schemas.openxmlformats.org/drawingml/2006/main">
               <a:ext uri="{FF2B5EF4-FFF2-40B4-BE49-F238E27FC236}">
-                <a16:creationId xmlns:a16="http://schemas.microsoft.com/office/drawing/2014/main" id="{B0F0C386-ED06-465A-85A9-B6F6B181D936}"/>
+                <a16:creationId xmlns:a16="http://schemas.microsoft.com/office/drawing/2014/main" id="{C0B811CE-8084-4CBC-BB75-DBA10BB9B61E}"/>
               </a:ext>
             </a:extLst>
           </p:cNvPr>
@@ -5818,7 +5818,7 @@
           <p:cNvPr id="36" name="">
             <a:extLst xmlns:a="http://schemas.openxmlformats.org/drawingml/2006/main">
               <a:ext uri="{FF2B5EF4-FFF2-40B4-BE49-F238E27FC236}">
-                <a16:creationId xmlns:a16="http://schemas.microsoft.com/office/drawing/2014/main" id="{5C04F33F-ED22-4355-8DA2-50C7D958CF64}"/>
+                <a16:creationId xmlns:a16="http://schemas.microsoft.com/office/drawing/2014/main" id="{D58D5F3E-CF8B-4771-91C9-D2FD5CDF86AB}"/>
               </a:ext>
             </a:extLst>
           </p:cNvPr>
@@ -5853,7 +5853,7 @@
           <p:cNvPr id="37" name="">
             <a:extLst xmlns:a="http://schemas.openxmlformats.org/drawingml/2006/main">
               <a:ext uri="{FF2B5EF4-FFF2-40B4-BE49-F238E27FC236}">
-                <a16:creationId xmlns:a16="http://schemas.microsoft.com/office/drawing/2014/main" id="{27178FE6-16A1-4AB8-B762-C285F8E1B51A}"/>
+                <a16:creationId xmlns:a16="http://schemas.microsoft.com/office/drawing/2014/main" id="{E80BE486-AABD-4258-8F03-D307A1BC60C3}"/>
               </a:ext>
             </a:extLst>
           </p:cNvPr>
@@ -5917,7 +5917,7 @@
           <p:cNvPr id="38" name="">
             <a:extLst xmlns:a="http://schemas.openxmlformats.org/drawingml/2006/main">
               <a:ext uri="{FF2B5EF4-FFF2-40B4-BE49-F238E27FC236}">
-                <a16:creationId xmlns:a16="http://schemas.microsoft.com/office/drawing/2014/main" id="{C96EF432-B5A2-41C7-AA87-1668A4D1C7DA}"/>
+                <a16:creationId xmlns:a16="http://schemas.microsoft.com/office/drawing/2014/main" id="{2A037E01-8D17-44D9-90DD-4AB9A110FED3}"/>
               </a:ext>
             </a:extLst>
           </p:cNvPr>
@@ -5981,7 +5981,7 @@
           <p:cNvPr id="39" name="">
             <a:extLst xmlns:a="http://schemas.openxmlformats.org/drawingml/2006/main">
               <a:ext uri="{FF2B5EF4-FFF2-40B4-BE49-F238E27FC236}">
-                <a16:creationId xmlns:a16="http://schemas.microsoft.com/office/drawing/2014/main" id="{21FA2EB9-827F-4619-8773-80509B50BE10}"/>
+                <a16:creationId xmlns:a16="http://schemas.microsoft.com/office/drawing/2014/main" id="{098ED56D-8F99-4728-8CF8-5080E9E9269B}"/>
               </a:ext>
             </a:extLst>
           </p:cNvPr>
@@ -6014,7 +6014,7 @@
           <p:cNvPr id="40" name="">
             <a:extLst xmlns:a="http://schemas.openxmlformats.org/drawingml/2006/main">
               <a:ext uri="{FF2B5EF4-FFF2-40B4-BE49-F238E27FC236}">
-                <a16:creationId xmlns:a16="http://schemas.microsoft.com/office/drawing/2014/main" id="{8993ED33-8884-4610-9DB4-A910708E4DFB}"/>
+                <a16:creationId xmlns:a16="http://schemas.microsoft.com/office/drawing/2014/main" id="{DCB95A29-812A-4D63-A527-3DB215299967}"/>
               </a:ext>
             </a:extLst>
           </p:cNvPr>
@@ -6049,7 +6049,7 @@
           <p:cNvPr id="41" name="">
             <a:extLst xmlns:a="http://schemas.openxmlformats.org/drawingml/2006/main">
               <a:ext uri="{FF2B5EF4-FFF2-40B4-BE49-F238E27FC236}">
-                <a16:creationId xmlns:a16="http://schemas.microsoft.com/office/drawing/2014/main" id="{5BFBCA6D-50C1-4D9C-BCD9-2EF745E27F31}"/>
+                <a16:creationId xmlns:a16="http://schemas.microsoft.com/office/drawing/2014/main" id="{74F73287-00CD-4C66-9E47-7FB8DDE938E7}"/>
               </a:ext>
             </a:extLst>
           </p:cNvPr>
@@ -6113,7 +6113,7 @@
           <p:cNvPr id="42" name="">
             <a:extLst xmlns:a="http://schemas.openxmlformats.org/drawingml/2006/main">
               <a:ext uri="{FF2B5EF4-FFF2-40B4-BE49-F238E27FC236}">
-                <a16:creationId xmlns:a16="http://schemas.microsoft.com/office/drawing/2014/main" id="{85475411-AC5D-49AC-B036-DAE9705D7612}"/>
+                <a16:creationId xmlns:a16="http://schemas.microsoft.com/office/drawing/2014/main" id="{C521CF27-DBA3-4746-B6D4-15293EE5AB48}"/>
               </a:ext>
             </a:extLst>
           </p:cNvPr>
@@ -6177,7 +6177,7 @@
           <p:cNvPr id="43" name="">
             <a:extLst xmlns:a="http://schemas.openxmlformats.org/drawingml/2006/main">
               <a:ext uri="{FF2B5EF4-FFF2-40B4-BE49-F238E27FC236}">
-                <a16:creationId xmlns:a16="http://schemas.microsoft.com/office/drawing/2014/main" id="{F202FE57-FCCC-4768-ADA2-3132972EC24C}"/>
+                <a16:creationId xmlns:a16="http://schemas.microsoft.com/office/drawing/2014/main" id="{97724D09-5F31-4358-B81B-BE5B4198F32D}"/>
               </a:ext>
             </a:extLst>
           </p:cNvPr>
@@ -6212,7 +6212,7 @@
           <p:cNvPr id="44" name="">
             <a:extLst xmlns:a="http://schemas.openxmlformats.org/drawingml/2006/main">
               <a:ext uri="{FF2B5EF4-FFF2-40B4-BE49-F238E27FC236}">
-                <a16:creationId xmlns:a16="http://schemas.microsoft.com/office/drawing/2014/main" id="{2236F027-8E11-4B8F-9AF1-1F14155D9197}"/>
+                <a16:creationId xmlns:a16="http://schemas.microsoft.com/office/drawing/2014/main" id="{4CBB68E7-E40B-452D-8A27-DB9558ECA71B}"/>
               </a:ext>
             </a:extLst>
           </p:cNvPr>
@@ -6274,7 +6274,7 @@
     </p:spTree>
     <p:extLst>
       <p:ext uri="{BB962C8B-B14F-4D97-AF65-F5344CB8AC3E}">
-        <p14:creationId xmlns:p14="http://schemas.microsoft.com/office/powerpoint/2010/main" val="1440446054"/>
+        <p14:creationId xmlns:p14="http://schemas.microsoft.com/office/powerpoint/2010/main" val="956533939"/>
       </p:ext>
     </p:extLst>
   </p:cSld>
@@ -6298,7 +6298,7 @@
           <p:cNvPr id="1" name="">
             <a:extLst xmlns:a="http://schemas.openxmlformats.org/drawingml/2006/main">
               <a:ext uri="{FF2B5EF4-FFF2-40B4-BE49-F238E27FC236}">
-                <a16:creationId xmlns:a16="http://schemas.microsoft.com/office/drawing/2014/main" id="{8E718FB0-A05C-49A3-B3F9-BCAA9571E321}"/>
+                <a16:creationId xmlns:a16="http://schemas.microsoft.com/office/drawing/2014/main" id="{996A11F6-E56A-485C-BE24-26023FDEC7D7}"/>
               </a:ext>
             </a:extLst>
           </p:cNvPr>
@@ -6333,7 +6333,7 @@
           <p:cNvPr id="2" name="">
             <a:extLst xmlns:a="http://schemas.openxmlformats.org/drawingml/2006/main">
               <a:ext uri="{FF2B5EF4-FFF2-40B4-BE49-F238E27FC236}">
-                <a16:creationId xmlns:a16="http://schemas.microsoft.com/office/drawing/2014/main" id="{8761EC0F-26CA-46BB-BB69-5605005C33AE}"/>
+                <a16:creationId xmlns:a16="http://schemas.microsoft.com/office/drawing/2014/main" id="{6A3A3111-4397-4E24-8B69-3BB21BC6C214}"/>
               </a:ext>
             </a:extLst>
           </p:cNvPr>
@@ -6368,7 +6368,7 @@
           <p:cNvPr id="3" name="">
             <a:extLst xmlns:a="http://schemas.openxmlformats.org/drawingml/2006/main">
               <a:ext uri="{FF2B5EF4-FFF2-40B4-BE49-F238E27FC236}">
-                <a16:creationId xmlns:a16="http://schemas.microsoft.com/office/drawing/2014/main" id="{E0F1A78B-E68F-4BCA-BB1C-F0CC7DF32803}"/>
+                <a16:creationId xmlns:a16="http://schemas.microsoft.com/office/drawing/2014/main" id="{DD472F30-955A-441D-A338-4B7BE9178E3F}"/>
               </a:ext>
             </a:extLst>
           </p:cNvPr>
@@ -6403,7 +6403,7 @@
           <p:cNvPr id="4" name="">
             <a:extLst xmlns:a="http://schemas.openxmlformats.org/drawingml/2006/main">
               <a:ext uri="{FF2B5EF4-FFF2-40B4-BE49-F238E27FC236}">
-                <a16:creationId xmlns:a16="http://schemas.microsoft.com/office/drawing/2014/main" id="{9A861E4D-973C-45EE-8029-B0B8010AAEA6}"/>
+                <a16:creationId xmlns:a16="http://schemas.microsoft.com/office/drawing/2014/main" id="{726FC2D6-E6B9-426C-9B1B-220A2C5B5D6E}"/>
               </a:ext>
             </a:extLst>
           </p:cNvPr>
@@ -6467,7 +6467,7 @@
           <p:cNvPr id="5" name="">
             <a:extLst xmlns:a="http://schemas.openxmlformats.org/drawingml/2006/main">
               <a:ext uri="{FF2B5EF4-FFF2-40B4-BE49-F238E27FC236}">
-                <a16:creationId xmlns:a16="http://schemas.microsoft.com/office/drawing/2014/main" id="{D553A325-18AB-4C95-9D56-8445D5BF847F}"/>
+                <a16:creationId xmlns:a16="http://schemas.microsoft.com/office/drawing/2014/main" id="{95DF4668-6D66-42AB-829E-C6CA08F8FA0C}"/>
               </a:ext>
             </a:extLst>
           </p:cNvPr>
@@ -6531,7 +6531,7 @@
           <p:cNvPr id="6" name="">
             <a:extLst xmlns:a="http://schemas.openxmlformats.org/drawingml/2006/main">
               <a:ext uri="{FF2B5EF4-FFF2-40B4-BE49-F238E27FC236}">
-                <a16:creationId xmlns:a16="http://schemas.microsoft.com/office/drawing/2014/main" id="{C78449F7-2381-4C3C-B26F-0CFFC6552034}"/>
+                <a16:creationId xmlns:a16="http://schemas.microsoft.com/office/drawing/2014/main" id="{A42E6206-211E-46D3-8B21-61F74C2E2A39}"/>
               </a:ext>
             </a:extLst>
           </p:cNvPr>
@@ -6585,7 +6585,7 @@
                 <a:ea typeface="Hiragino Mincho ProN"/>
                 <a:cs typeface="Hiragino Mincho ProN"/>
               </a:rPr>
-              <a:t>入力はrawログではなく、10秒統計列に固定する</a:t>
+              <a:t>生イベントを残さず、10秒統計だけを残す</a:t>
             </a:r>
           </a:p>
         </p:txBody>
@@ -6595,7 +6595,7 @@
           <p:cNvPr id="7" name="">
             <a:extLst xmlns:a="http://schemas.openxmlformats.org/drawingml/2006/main">
               <a:ext uri="{FF2B5EF4-FFF2-40B4-BE49-F238E27FC236}">
-                <a16:creationId xmlns:a16="http://schemas.microsoft.com/office/drawing/2014/main" id="{7EB4515F-38E4-4C26-A366-FAA7AE291AE9}"/>
+                <a16:creationId xmlns:a16="http://schemas.microsoft.com/office/drawing/2014/main" id="{38DA55A6-EE1A-4DA0-9C78-D59F8145C414}"/>
               </a:ext>
             </a:extLst>
           </p:cNvPr>
@@ -6628,7 +6628,7 @@
           <p:cNvPr id="8" name="">
             <a:extLst xmlns:a="http://schemas.openxmlformats.org/drawingml/2006/main">
               <a:ext uri="{FF2B5EF4-FFF2-40B4-BE49-F238E27FC236}">
-                <a16:creationId xmlns:a16="http://schemas.microsoft.com/office/drawing/2014/main" id="{7415B5B2-5254-4F3C-B261-7E8F72BA6A0B}"/>
+                <a16:creationId xmlns:a16="http://schemas.microsoft.com/office/drawing/2014/main" id="{4F705DE1-9EE9-4C9E-9D6E-E3BB98B67BB1}"/>
               </a:ext>
             </a:extLst>
           </p:cNvPr>
@@ -6663,7 +6663,7 @@
           <p:cNvPr id="9" name="">
             <a:extLst xmlns:a="http://schemas.openxmlformats.org/drawingml/2006/main">
               <a:ext uri="{FF2B5EF4-FFF2-40B4-BE49-F238E27FC236}">
-                <a16:creationId xmlns:a16="http://schemas.microsoft.com/office/drawing/2014/main" id="{0CDFDB75-9DFD-4B0A-B64B-02BE9830F379}"/>
+                <a16:creationId xmlns:a16="http://schemas.microsoft.com/office/drawing/2014/main" id="{6DC4C0C8-99D5-4A62-8DE1-CF540AB4FE2D}"/>
               </a:ext>
             </a:extLst>
           </p:cNvPr>
@@ -6717,7 +6717,7 @@
                 <a:ea typeface="Hiragino Sans"/>
                 <a:cs typeface="Hiragino Sans"/>
               </a:rPr>
-              <a:t>主張 | 特徴抽出そのものが装置コストなので、MLへ渡す入力は安い集計から作る固定shapeの列に限定する。</a:t>
+              <a:t>主張 | 装置に残すのはraw event列ではなく、10秒ごとに集約した固定長の統計列である。</a:t>
             </a:r>
           </a:p>
         </p:txBody>
@@ -6727,7 +6727,7 @@
           <p:cNvPr id="10" name="">
             <a:extLst xmlns:a="http://schemas.openxmlformats.org/drawingml/2006/main">
               <a:ext uri="{FF2B5EF4-FFF2-40B4-BE49-F238E27FC236}">
-                <a16:creationId xmlns:a16="http://schemas.microsoft.com/office/drawing/2014/main" id="{8E6545BF-8520-40A5-8BA9-9B807B4E11EA}"/>
+                <a16:creationId xmlns:a16="http://schemas.microsoft.com/office/drawing/2014/main" id="{8A84E9D3-1BDD-462E-8A29-910E00CD4A50}"/>
               </a:ext>
             </a:extLst>
           </p:cNvPr>
@@ -6760,7 +6760,7 @@
           <p:cNvPr id="11" name="">
             <a:extLst xmlns:a="http://schemas.openxmlformats.org/drawingml/2006/main">
               <a:ext uri="{FF2B5EF4-FFF2-40B4-BE49-F238E27FC236}">
-                <a16:creationId xmlns:a16="http://schemas.microsoft.com/office/drawing/2014/main" id="{CBD3F9F9-251C-4459-BB6B-55D177F481C0}"/>
+                <a16:creationId xmlns:a16="http://schemas.microsoft.com/office/drawing/2014/main" id="{DB2A5320-ED0A-499F-BC2E-F7ECA176772F}"/>
               </a:ext>
             </a:extLst>
           </p:cNvPr>
@@ -6795,7 +6795,7 @@
           <p:cNvPr id="12" name="">
             <a:extLst xmlns:a="http://schemas.openxmlformats.org/drawingml/2006/main">
               <a:ext uri="{FF2B5EF4-FFF2-40B4-BE49-F238E27FC236}">
-                <a16:creationId xmlns:a16="http://schemas.microsoft.com/office/drawing/2014/main" id="{7A32C142-CA6C-4378-AD1F-3F98603FF99E}"/>
+                <a16:creationId xmlns:a16="http://schemas.microsoft.com/office/drawing/2014/main" id="{9B96AA88-EC5A-4DB9-83DB-5B4989571FEF}"/>
               </a:ext>
             </a:extLst>
           </p:cNvPr>
@@ -6859,7 +6859,7 @@
           <p:cNvPr id="13" name="">
             <a:extLst xmlns:a="http://schemas.openxmlformats.org/drawingml/2006/main">
               <a:ext uri="{FF2B5EF4-FFF2-40B4-BE49-F238E27FC236}">
-                <a16:creationId xmlns:a16="http://schemas.microsoft.com/office/drawing/2014/main" id="{E781031B-5742-463F-A201-97E4A110C6BB}"/>
+                <a16:creationId xmlns:a16="http://schemas.microsoft.com/office/drawing/2014/main" id="{5A168818-2AF7-47F4-9A06-61A2031691B5}"/>
               </a:ext>
             </a:extLst>
           </p:cNvPr>
@@ -6892,7 +6892,7 @@
           <p:cNvPr id="14" name="">
             <a:extLst xmlns:a="http://schemas.openxmlformats.org/drawingml/2006/main">
               <a:ext uri="{FF2B5EF4-FFF2-40B4-BE49-F238E27FC236}">
-                <a16:creationId xmlns:a16="http://schemas.microsoft.com/office/drawing/2014/main" id="{2C866FDA-0F0E-48B3-9D4C-E2053E5F5012}"/>
+                <a16:creationId xmlns:a16="http://schemas.microsoft.com/office/drawing/2014/main" id="{859719A6-6CA2-4EBE-8C06-4B15FB4174AF}"/>
               </a:ext>
             </a:extLst>
           </p:cNvPr>
@@ -6956,7 +6956,7 @@
           <p:cNvPr id="15" name="">
             <a:extLst xmlns:a="http://schemas.openxmlformats.org/drawingml/2006/main">
               <a:ext uri="{FF2B5EF4-FFF2-40B4-BE49-F238E27FC236}">
-                <a16:creationId xmlns:a16="http://schemas.microsoft.com/office/drawing/2014/main" id="{87C92D4D-C7E3-4C25-8D03-B15970758FAE}"/>
+                <a16:creationId xmlns:a16="http://schemas.microsoft.com/office/drawing/2014/main" id="{5BBA6879-D018-4771-801C-8C981C79E926}"/>
               </a:ext>
             </a:extLst>
           </p:cNvPr>
@@ -6991,7 +6991,7 @@
           <p:cNvPr id="16" name="">
             <a:extLst xmlns:a="http://schemas.openxmlformats.org/drawingml/2006/main">
               <a:ext uri="{FF2B5EF4-FFF2-40B4-BE49-F238E27FC236}">
-                <a16:creationId xmlns:a16="http://schemas.microsoft.com/office/drawing/2014/main" id="{8547DCCD-CC71-4B19-A5D8-B7C40899C818}"/>
+                <a16:creationId xmlns:a16="http://schemas.microsoft.com/office/drawing/2014/main" id="{9E0B394F-D62C-494B-ABB4-7C3746D1B7A1}"/>
               </a:ext>
             </a:extLst>
           </p:cNvPr>
@@ -7055,7 +7055,7 @@
           <p:cNvPr id="17" name="">
             <a:extLst xmlns:a="http://schemas.openxmlformats.org/drawingml/2006/main">
               <a:ext uri="{FF2B5EF4-FFF2-40B4-BE49-F238E27FC236}">
-                <a16:creationId xmlns:a16="http://schemas.microsoft.com/office/drawing/2014/main" id="{3684A314-F03C-49B6-A286-7E05FE15379B}"/>
+                <a16:creationId xmlns:a16="http://schemas.microsoft.com/office/drawing/2014/main" id="{F32A91F8-C1F8-4D88-8F1B-B34D2295B223}"/>
               </a:ext>
             </a:extLst>
           </p:cNvPr>
@@ -7088,7 +7088,7 @@
           <p:cNvPr id="18" name="">
             <a:extLst xmlns:a="http://schemas.openxmlformats.org/drawingml/2006/main">
               <a:ext uri="{FF2B5EF4-FFF2-40B4-BE49-F238E27FC236}">
-                <a16:creationId xmlns:a16="http://schemas.microsoft.com/office/drawing/2014/main" id="{6ACA863E-1DE0-42E8-86A0-6E05C3354FEA}"/>
+                <a16:creationId xmlns:a16="http://schemas.microsoft.com/office/drawing/2014/main" id="{8257DC21-237C-4996-B2D7-E64332230F28}"/>
               </a:ext>
             </a:extLst>
           </p:cNvPr>
@@ -7152,7 +7152,7 @@
           <p:cNvPr id="19" name="">
             <a:extLst xmlns:a="http://schemas.openxmlformats.org/drawingml/2006/main">
               <a:ext uri="{FF2B5EF4-FFF2-40B4-BE49-F238E27FC236}">
-                <a16:creationId xmlns:a16="http://schemas.microsoft.com/office/drawing/2014/main" id="{A3A6664B-0691-4059-8321-E7FADB0ED669}"/>
+                <a16:creationId xmlns:a16="http://schemas.microsoft.com/office/drawing/2014/main" id="{AC1AB28C-66B1-4517-B374-E92B20AEFFEE}"/>
               </a:ext>
             </a:extLst>
           </p:cNvPr>
@@ -7187,7 +7187,7 @@
           <p:cNvPr id="20" name="">
             <a:extLst xmlns:a="http://schemas.openxmlformats.org/drawingml/2006/main">
               <a:ext uri="{FF2B5EF4-FFF2-40B4-BE49-F238E27FC236}">
-                <a16:creationId xmlns:a16="http://schemas.microsoft.com/office/drawing/2014/main" id="{2BE6BA78-75DF-4DC3-B086-9D8B89F0C500}"/>
+                <a16:creationId xmlns:a16="http://schemas.microsoft.com/office/drawing/2014/main" id="{02EDB78F-658E-4A31-8653-E14FE365BABB}"/>
               </a:ext>
             </a:extLst>
           </p:cNvPr>
@@ -7251,7 +7251,7 @@
           <p:cNvPr id="21" name="">
             <a:extLst xmlns:a="http://schemas.openxmlformats.org/drawingml/2006/main">
               <a:ext uri="{FF2B5EF4-FFF2-40B4-BE49-F238E27FC236}">
-                <a16:creationId xmlns:a16="http://schemas.microsoft.com/office/drawing/2014/main" id="{D7DA7687-DD7F-45D0-8728-DA29BF492D51}"/>
+                <a16:creationId xmlns:a16="http://schemas.microsoft.com/office/drawing/2014/main" id="{223B010E-1428-455E-B48A-D7AB289A2AD4}"/>
               </a:ext>
             </a:extLst>
           </p:cNvPr>
@@ -7284,7 +7284,7 @@
           <p:cNvPr id="22" name="">
             <a:extLst xmlns:a="http://schemas.openxmlformats.org/drawingml/2006/main">
               <a:ext uri="{FF2B5EF4-FFF2-40B4-BE49-F238E27FC236}">
-                <a16:creationId xmlns:a16="http://schemas.microsoft.com/office/drawing/2014/main" id="{2B02099B-2988-4BFF-825C-45F50F62831F}"/>
+                <a16:creationId xmlns:a16="http://schemas.microsoft.com/office/drawing/2014/main" id="{6AC3F1E7-E9BF-4E27-9741-F9404C9AD85C}"/>
               </a:ext>
             </a:extLst>
           </p:cNvPr>
@@ -7348,7 +7348,7 @@
           <p:cNvPr id="23" name="">
             <a:extLst xmlns:a="http://schemas.openxmlformats.org/drawingml/2006/main">
               <a:ext uri="{FF2B5EF4-FFF2-40B4-BE49-F238E27FC236}">
-                <a16:creationId xmlns:a16="http://schemas.microsoft.com/office/drawing/2014/main" id="{63A4A07B-06D3-4158-8714-9A3AF856B7AC}"/>
+                <a16:creationId xmlns:a16="http://schemas.microsoft.com/office/drawing/2014/main" id="{C750E8DB-A3AA-479E-9A00-9DE0340756EC}"/>
               </a:ext>
             </a:extLst>
           </p:cNvPr>
@@ -7383,7 +7383,7 @@
           <p:cNvPr id="24" name="">
             <a:extLst xmlns:a="http://schemas.openxmlformats.org/drawingml/2006/main">
               <a:ext uri="{FF2B5EF4-FFF2-40B4-BE49-F238E27FC236}">
-                <a16:creationId xmlns:a16="http://schemas.microsoft.com/office/drawing/2014/main" id="{89E346CF-6985-43AF-BE35-511824ACBB76}"/>
+                <a16:creationId xmlns:a16="http://schemas.microsoft.com/office/drawing/2014/main" id="{5FEE3A4A-F592-4AE7-8D24-9A50BD6D3DCD}"/>
               </a:ext>
             </a:extLst>
           </p:cNvPr>
@@ -7447,7 +7447,7 @@
           <p:cNvPr id="25" name="">
             <a:extLst xmlns:a="http://schemas.openxmlformats.org/drawingml/2006/main">
               <a:ext uri="{FF2B5EF4-FFF2-40B4-BE49-F238E27FC236}">
-                <a16:creationId xmlns:a16="http://schemas.microsoft.com/office/drawing/2014/main" id="{C57BE945-B620-4334-8C6D-EB8E0DF88586}"/>
+                <a16:creationId xmlns:a16="http://schemas.microsoft.com/office/drawing/2014/main" id="{D584D574-AF0C-42EA-AEDC-81C459470882}"/>
               </a:ext>
             </a:extLst>
           </p:cNvPr>
@@ -7480,7 +7480,7 @@
           <p:cNvPr id="26" name="">
             <a:extLst xmlns:a="http://schemas.openxmlformats.org/drawingml/2006/main">
               <a:ext uri="{FF2B5EF4-FFF2-40B4-BE49-F238E27FC236}">
-                <a16:creationId xmlns:a16="http://schemas.microsoft.com/office/drawing/2014/main" id="{344E2322-F550-4384-A657-1D0A3F2149AB}"/>
+                <a16:creationId xmlns:a16="http://schemas.microsoft.com/office/drawing/2014/main" id="{C2096329-2095-4298-9AF4-49D23851D874}"/>
               </a:ext>
             </a:extLst>
           </p:cNvPr>
@@ -7544,7 +7544,7 @@
           <p:cNvPr id="27" name="">
             <a:extLst xmlns:a="http://schemas.openxmlformats.org/drawingml/2006/main">
               <a:ext uri="{FF2B5EF4-FFF2-40B4-BE49-F238E27FC236}">
-                <a16:creationId xmlns:a16="http://schemas.microsoft.com/office/drawing/2014/main" id="{E99C6449-8FC4-4FEE-8199-13B7D9986174}"/>
+                <a16:creationId xmlns:a16="http://schemas.microsoft.com/office/drawing/2014/main" id="{A428B0C2-1948-4F6C-BC34-23928759EF81}"/>
               </a:ext>
             </a:extLst>
           </p:cNvPr>
@@ -7579,7 +7579,7 @@
           <p:cNvPr id="28" name="">
             <a:extLst xmlns:a="http://schemas.openxmlformats.org/drawingml/2006/main">
               <a:ext uri="{FF2B5EF4-FFF2-40B4-BE49-F238E27FC236}">
-                <a16:creationId xmlns:a16="http://schemas.microsoft.com/office/drawing/2014/main" id="{148D6E3E-CA78-4BE4-AF1C-74C1DC79BED9}"/>
+                <a16:creationId xmlns:a16="http://schemas.microsoft.com/office/drawing/2014/main" id="{A2348508-0069-4B53-92FD-3A4BDE4012AC}"/>
               </a:ext>
             </a:extLst>
           </p:cNvPr>
@@ -7643,7 +7643,7 @@
           <p:cNvPr id="29" name="">
             <a:extLst xmlns:a="http://schemas.openxmlformats.org/drawingml/2006/main">
               <a:ext uri="{FF2B5EF4-FFF2-40B4-BE49-F238E27FC236}">
-                <a16:creationId xmlns:a16="http://schemas.microsoft.com/office/drawing/2014/main" id="{36F06694-D100-492A-BBE4-D96D4BCA6068}"/>
+                <a16:creationId xmlns:a16="http://schemas.microsoft.com/office/drawing/2014/main" id="{F382C06C-2D5D-4E04-AB89-5D5A7558E58F}"/>
               </a:ext>
             </a:extLst>
           </p:cNvPr>
@@ -7676,7 +7676,7 @@
           <p:cNvPr id="30" name="">
             <a:extLst xmlns:a="http://schemas.openxmlformats.org/drawingml/2006/main">
               <a:ext uri="{FF2B5EF4-FFF2-40B4-BE49-F238E27FC236}">
-                <a16:creationId xmlns:a16="http://schemas.microsoft.com/office/drawing/2014/main" id="{C1E2F196-2C90-4C69-8550-BC48FD71F7A0}"/>
+                <a16:creationId xmlns:a16="http://schemas.microsoft.com/office/drawing/2014/main" id="{F60AC65D-87BA-48F1-A598-E831309D1F2C}"/>
               </a:ext>
             </a:extLst>
           </p:cNvPr>
@@ -7740,7 +7740,7 @@
           <p:cNvPr id="31" name="">
             <a:extLst xmlns:a="http://schemas.openxmlformats.org/drawingml/2006/main">
               <a:ext uri="{FF2B5EF4-FFF2-40B4-BE49-F238E27FC236}">
-                <a16:creationId xmlns:a16="http://schemas.microsoft.com/office/drawing/2014/main" id="{4B913B3F-407A-48FC-BBF8-538A7FD96D3A}"/>
+                <a16:creationId xmlns:a16="http://schemas.microsoft.com/office/drawing/2014/main" id="{967245EA-B3EF-4AB0-B932-A3AFD5470F33}"/>
               </a:ext>
             </a:extLst>
           </p:cNvPr>
@@ -7775,7 +7775,7 @@
           <p:cNvPr id="32" name="">
             <a:extLst xmlns:a="http://schemas.openxmlformats.org/drawingml/2006/main">
               <a:ext uri="{FF2B5EF4-FFF2-40B4-BE49-F238E27FC236}">
-                <a16:creationId xmlns:a16="http://schemas.microsoft.com/office/drawing/2014/main" id="{EA5257AA-A83D-454B-BA65-E8C22BABE998}"/>
+                <a16:creationId xmlns:a16="http://schemas.microsoft.com/office/drawing/2014/main" id="{349993C5-B4CA-4C6C-8247-CEEBFE36EEED}"/>
               </a:ext>
             </a:extLst>
           </p:cNvPr>
@@ -7839,7 +7839,7 @@
           <p:cNvPr id="33" name="">
             <a:extLst xmlns:a="http://schemas.openxmlformats.org/drawingml/2006/main">
               <a:ext uri="{FF2B5EF4-FFF2-40B4-BE49-F238E27FC236}">
-                <a16:creationId xmlns:a16="http://schemas.microsoft.com/office/drawing/2014/main" id="{01970847-8C18-4B9F-B127-3D65816FCD96}"/>
+                <a16:creationId xmlns:a16="http://schemas.microsoft.com/office/drawing/2014/main" id="{D4764C61-285F-4D5C-8D1C-B9E431F48428}"/>
               </a:ext>
             </a:extLst>
           </p:cNvPr>
@@ -7872,7 +7872,7 @@
           <p:cNvPr id="34" name="">
             <a:extLst xmlns:a="http://schemas.openxmlformats.org/drawingml/2006/main">
               <a:ext uri="{FF2B5EF4-FFF2-40B4-BE49-F238E27FC236}">
-                <a16:creationId xmlns:a16="http://schemas.microsoft.com/office/drawing/2014/main" id="{F5A6BDED-37D6-43F3-8FC2-692C385FAF81}"/>
+                <a16:creationId xmlns:a16="http://schemas.microsoft.com/office/drawing/2014/main" id="{FEF44244-9EFB-4FE5-9618-5E12E753808C}"/>
               </a:ext>
             </a:extLst>
           </p:cNvPr>
@@ -7936,7 +7936,7 @@
           <p:cNvPr id="35" name="">
             <a:extLst xmlns:a="http://schemas.openxmlformats.org/drawingml/2006/main">
               <a:ext uri="{FF2B5EF4-FFF2-40B4-BE49-F238E27FC236}">
-                <a16:creationId xmlns:a16="http://schemas.microsoft.com/office/drawing/2014/main" id="{9FD3EC4B-15C0-4003-9F4F-6348DB824814}"/>
+                <a16:creationId xmlns:a16="http://schemas.microsoft.com/office/drawing/2014/main" id="{8AB5E9C1-01E8-4D18-ACFE-362743F7BF6E}"/>
               </a:ext>
             </a:extLst>
           </p:cNvPr>
@@ -7971,7 +7971,7 @@
           <p:cNvPr id="36" name="">
             <a:extLst xmlns:a="http://schemas.openxmlformats.org/drawingml/2006/main">
               <a:ext uri="{FF2B5EF4-FFF2-40B4-BE49-F238E27FC236}">
-                <a16:creationId xmlns:a16="http://schemas.microsoft.com/office/drawing/2014/main" id="{F4DD236F-4B1C-4EDB-8404-C4EAD05C4E44}"/>
+                <a16:creationId xmlns:a16="http://schemas.microsoft.com/office/drawing/2014/main" id="{24829FE2-723F-436A-9B91-DB1E4EA515BE}"/>
               </a:ext>
             </a:extLst>
           </p:cNvPr>
@@ -8035,7 +8035,7 @@
           <p:cNvPr id="37" name="">
             <a:extLst xmlns:a="http://schemas.openxmlformats.org/drawingml/2006/main">
               <a:ext uri="{FF2B5EF4-FFF2-40B4-BE49-F238E27FC236}">
-                <a16:creationId xmlns:a16="http://schemas.microsoft.com/office/drawing/2014/main" id="{5A66CCBC-F8AE-4E33-8398-AEBFD0567337}"/>
+                <a16:creationId xmlns:a16="http://schemas.microsoft.com/office/drawing/2014/main" id="{922259F5-4461-483F-A6E0-6118237796C6}"/>
               </a:ext>
             </a:extLst>
           </p:cNvPr>
@@ -8068,7 +8068,7 @@
           <p:cNvPr id="38" name="">
             <a:extLst xmlns:a="http://schemas.openxmlformats.org/drawingml/2006/main">
               <a:ext uri="{FF2B5EF4-FFF2-40B4-BE49-F238E27FC236}">
-                <a16:creationId xmlns:a16="http://schemas.microsoft.com/office/drawing/2014/main" id="{C5BBC312-9885-4201-BCBC-3D5E9507F493}"/>
+                <a16:creationId xmlns:a16="http://schemas.microsoft.com/office/drawing/2014/main" id="{811AE63F-3999-4E48-8BF0-4C94D016CE72}"/>
               </a:ext>
             </a:extLst>
           </p:cNvPr>
@@ -8132,7 +8132,7 @@
           <p:cNvPr id="39" name="">
             <a:extLst xmlns:a="http://schemas.openxmlformats.org/drawingml/2006/main">
               <a:ext uri="{FF2B5EF4-FFF2-40B4-BE49-F238E27FC236}">
-                <a16:creationId xmlns:a16="http://schemas.microsoft.com/office/drawing/2014/main" id="{AA643E59-9CFD-4B68-A097-8F742AA8CEFD}"/>
+                <a16:creationId xmlns:a16="http://schemas.microsoft.com/office/drawing/2014/main" id="{BF96E35D-D5AE-46E0-90B8-1CE0DD3DDE87}"/>
               </a:ext>
             </a:extLst>
           </p:cNvPr>
@@ -8167,7 +8167,7 @@
           <p:cNvPr id="40" name="">
             <a:extLst xmlns:a="http://schemas.openxmlformats.org/drawingml/2006/main">
               <a:ext uri="{FF2B5EF4-FFF2-40B4-BE49-F238E27FC236}">
-                <a16:creationId xmlns:a16="http://schemas.microsoft.com/office/drawing/2014/main" id="{9A727623-6AA7-4ED4-8CA1-F0F4A5D89EC0}"/>
+                <a16:creationId xmlns:a16="http://schemas.microsoft.com/office/drawing/2014/main" id="{0CD38D54-93EE-4FA3-AF56-0AAF74296A05}"/>
               </a:ext>
             </a:extLst>
           </p:cNvPr>
@@ -8231,7 +8231,7 @@
           <p:cNvPr id="41" name="">
             <a:extLst xmlns:a="http://schemas.openxmlformats.org/drawingml/2006/main">
               <a:ext uri="{FF2B5EF4-FFF2-40B4-BE49-F238E27FC236}">
-                <a16:creationId xmlns:a16="http://schemas.microsoft.com/office/drawing/2014/main" id="{7CDACAC1-255F-4B52-93A9-7564A91654BF}"/>
+                <a16:creationId xmlns:a16="http://schemas.microsoft.com/office/drawing/2014/main" id="{0CBEB4FB-44C4-427A-8CEB-D143A1665D84}"/>
               </a:ext>
             </a:extLst>
           </p:cNvPr>
@@ -8264,7 +8264,7 @@
           <p:cNvPr id="42" name="">
             <a:extLst xmlns:a="http://schemas.openxmlformats.org/drawingml/2006/main">
               <a:ext uri="{FF2B5EF4-FFF2-40B4-BE49-F238E27FC236}">
-                <a16:creationId xmlns:a16="http://schemas.microsoft.com/office/drawing/2014/main" id="{7DA3DC25-4247-4DD7-B672-B2DB15BA0AA7}"/>
+                <a16:creationId xmlns:a16="http://schemas.microsoft.com/office/drawing/2014/main" id="{8AD70181-A804-4FEC-8736-F6D4A615305F}"/>
               </a:ext>
             </a:extLst>
           </p:cNvPr>
@@ -8420,7 +8420,7 @@
           <p:cNvPr id="43" name="">
             <a:extLst xmlns:a="http://schemas.openxmlformats.org/drawingml/2006/main">
               <a:ext uri="{FF2B5EF4-FFF2-40B4-BE49-F238E27FC236}">
-                <a16:creationId xmlns:a16="http://schemas.microsoft.com/office/drawing/2014/main" id="{E363543C-B082-4507-AF13-4CF64F2F77C6}"/>
+                <a16:creationId xmlns:a16="http://schemas.microsoft.com/office/drawing/2014/main" id="{9AF95847-EFAA-442A-B60C-73A2174007AF}"/>
               </a:ext>
             </a:extLst>
           </p:cNvPr>
@@ -8453,7 +8453,7 @@
           <p:cNvPr id="44" name="">
             <a:extLst xmlns:a="http://schemas.openxmlformats.org/drawingml/2006/main">
               <a:ext uri="{FF2B5EF4-FFF2-40B4-BE49-F238E27FC236}">
-                <a16:creationId xmlns:a16="http://schemas.microsoft.com/office/drawing/2014/main" id="{54F99A48-67A8-4C57-8F1D-44077B1EAB00}"/>
+                <a16:creationId xmlns:a16="http://schemas.microsoft.com/office/drawing/2014/main" id="{5FB15FD3-A6AE-42F5-80BA-EE18EA5A4F6F}"/>
               </a:ext>
             </a:extLst>
           </p:cNvPr>
@@ -8488,7 +8488,7 @@
           <p:cNvPr id="45" name="">
             <a:extLst xmlns:a="http://schemas.openxmlformats.org/drawingml/2006/main">
               <a:ext uri="{FF2B5EF4-FFF2-40B4-BE49-F238E27FC236}">
-                <a16:creationId xmlns:a16="http://schemas.microsoft.com/office/drawing/2014/main" id="{49264D6B-DDDD-4E29-9A8E-79E7DA7421E0}"/>
+                <a16:creationId xmlns:a16="http://schemas.microsoft.com/office/drawing/2014/main" id="{191FFCDF-398E-4A0D-95EF-D3D4F8A9EF2A}"/>
               </a:ext>
             </a:extLst>
           </p:cNvPr>
@@ -8552,7 +8552,7 @@
           <p:cNvPr id="46" name="">
             <a:extLst xmlns:a="http://schemas.openxmlformats.org/drawingml/2006/main">
               <a:ext uri="{FF2B5EF4-FFF2-40B4-BE49-F238E27FC236}">
-                <a16:creationId xmlns:a16="http://schemas.microsoft.com/office/drawing/2014/main" id="{7B741681-0205-42A2-AF77-BA9D518928E7}"/>
+                <a16:creationId xmlns:a16="http://schemas.microsoft.com/office/drawing/2014/main" id="{396316D9-64ED-4B41-9B6E-505F54C8264A}"/>
               </a:ext>
             </a:extLst>
           </p:cNvPr>
@@ -8616,7 +8616,7 @@
           <p:cNvPr id="47" name="">
             <a:extLst xmlns:a="http://schemas.openxmlformats.org/drawingml/2006/main">
               <a:ext uri="{FF2B5EF4-FFF2-40B4-BE49-F238E27FC236}">
-                <a16:creationId xmlns:a16="http://schemas.microsoft.com/office/drawing/2014/main" id="{F33C198C-B7E3-402B-A06C-2BCF5B31F68C}"/>
+                <a16:creationId xmlns:a16="http://schemas.microsoft.com/office/drawing/2014/main" id="{A1808295-7B99-4DF5-934D-7843232C76F6}"/>
               </a:ext>
             </a:extLst>
           </p:cNvPr>
@@ -8649,7 +8649,7 @@
           <p:cNvPr id="48" name="">
             <a:extLst xmlns:a="http://schemas.openxmlformats.org/drawingml/2006/main">
               <a:ext uri="{FF2B5EF4-FFF2-40B4-BE49-F238E27FC236}">
-                <a16:creationId xmlns:a16="http://schemas.microsoft.com/office/drawing/2014/main" id="{092EE41B-1CE0-4655-9498-96646A484770}"/>
+                <a16:creationId xmlns:a16="http://schemas.microsoft.com/office/drawing/2014/main" id="{A429E99A-91B2-4A4A-9433-F3C2562FFBC2}"/>
               </a:ext>
             </a:extLst>
           </p:cNvPr>
@@ -8713,7 +8713,7 @@
           <p:cNvPr id="49" name="">
             <a:extLst xmlns:a="http://schemas.openxmlformats.org/drawingml/2006/main">
               <a:ext uri="{FF2B5EF4-FFF2-40B4-BE49-F238E27FC236}">
-                <a16:creationId xmlns:a16="http://schemas.microsoft.com/office/drawing/2014/main" id="{4F9E547D-9DD6-40EE-A82E-2BFE4CCD106F}"/>
+                <a16:creationId xmlns:a16="http://schemas.microsoft.com/office/drawing/2014/main" id="{F29A90C0-658E-4D9D-BDA4-42904E4D027E}"/>
               </a:ext>
             </a:extLst>
           </p:cNvPr>
@@ -8746,7 +8746,7 @@
           <p:cNvPr id="50" name="">
             <a:extLst xmlns:a="http://schemas.openxmlformats.org/drawingml/2006/main">
               <a:ext uri="{FF2B5EF4-FFF2-40B4-BE49-F238E27FC236}">
-                <a16:creationId xmlns:a16="http://schemas.microsoft.com/office/drawing/2014/main" id="{F8FF4695-1269-4021-8D48-4D5BA8D927AF}"/>
+                <a16:creationId xmlns:a16="http://schemas.microsoft.com/office/drawing/2014/main" id="{FC821039-40A7-4601-80E8-FA65C9783CB7}"/>
               </a:ext>
             </a:extLst>
           </p:cNvPr>
@@ -8810,7 +8810,7 @@
           <p:cNvPr id="51" name="">
             <a:extLst xmlns:a="http://schemas.openxmlformats.org/drawingml/2006/main">
               <a:ext uri="{FF2B5EF4-FFF2-40B4-BE49-F238E27FC236}">
-                <a16:creationId xmlns:a16="http://schemas.microsoft.com/office/drawing/2014/main" id="{05CD544C-0A38-4E3D-96E1-2D629B9BE1E4}"/>
+                <a16:creationId xmlns:a16="http://schemas.microsoft.com/office/drawing/2014/main" id="{3136CAE1-75B2-4BE7-8ACE-32770920C0C1}"/>
               </a:ext>
             </a:extLst>
           </p:cNvPr>
@@ -8845,7 +8845,7 @@
           <p:cNvPr id="52" name="">
             <a:extLst xmlns:a="http://schemas.openxmlformats.org/drawingml/2006/main">
               <a:ext uri="{FF2B5EF4-FFF2-40B4-BE49-F238E27FC236}">
-                <a16:creationId xmlns:a16="http://schemas.microsoft.com/office/drawing/2014/main" id="{0D1AAACB-895F-4533-BB14-E6F5067AB631}"/>
+                <a16:creationId xmlns:a16="http://schemas.microsoft.com/office/drawing/2014/main" id="{5875FE6D-7C10-4605-A503-F572BFDFBDCA}"/>
               </a:ext>
             </a:extLst>
           </p:cNvPr>
@@ -8907,7 +8907,7 @@
     </p:spTree>
     <p:extLst>
       <p:ext uri="{BB962C8B-B14F-4D97-AF65-F5344CB8AC3E}">
-        <p14:creationId xmlns:p14="http://schemas.microsoft.com/office/powerpoint/2010/main" val="831287568"/>
+        <p14:creationId xmlns:p14="http://schemas.microsoft.com/office/powerpoint/2010/main" val="1005806483"/>
       </p:ext>
     </p:extLst>
   </p:cSld>
@@ -8931,7 +8931,7 @@
           <p:cNvPr id="1" name="">
             <a:extLst xmlns:a="http://schemas.openxmlformats.org/drawingml/2006/main">
               <a:ext uri="{FF2B5EF4-FFF2-40B4-BE49-F238E27FC236}">
-                <a16:creationId xmlns:a16="http://schemas.microsoft.com/office/drawing/2014/main" id="{FE1CC4B8-DB47-42F8-A27C-81FCBFCA7C48}"/>
+                <a16:creationId xmlns:a16="http://schemas.microsoft.com/office/drawing/2014/main" id="{8C820FC6-DC63-4E4A-B867-45A55C528A15}"/>
               </a:ext>
             </a:extLst>
           </p:cNvPr>
@@ -8966,7 +8966,7 @@
           <p:cNvPr id="2" name="">
             <a:extLst xmlns:a="http://schemas.openxmlformats.org/drawingml/2006/main">
               <a:ext uri="{FF2B5EF4-FFF2-40B4-BE49-F238E27FC236}">
-                <a16:creationId xmlns:a16="http://schemas.microsoft.com/office/drawing/2014/main" id="{EC4DE90E-A757-4C8D-99A9-EC73D3662BD0}"/>
+                <a16:creationId xmlns:a16="http://schemas.microsoft.com/office/drawing/2014/main" id="{52EA2C59-6919-43C0-8515-71BF1F0FFB87}"/>
               </a:ext>
             </a:extLst>
           </p:cNvPr>
@@ -9001,7 +9001,7 @@
           <p:cNvPr id="3" name="">
             <a:extLst xmlns:a="http://schemas.openxmlformats.org/drawingml/2006/main">
               <a:ext uri="{FF2B5EF4-FFF2-40B4-BE49-F238E27FC236}">
-                <a16:creationId xmlns:a16="http://schemas.microsoft.com/office/drawing/2014/main" id="{E9B68861-390A-4C18-B350-51F8B2FF3758}"/>
+                <a16:creationId xmlns:a16="http://schemas.microsoft.com/office/drawing/2014/main" id="{CC46E333-1581-4998-8C25-00D91662C2C2}"/>
               </a:ext>
             </a:extLst>
           </p:cNvPr>
@@ -9036,7 +9036,7 @@
           <p:cNvPr id="4" name="">
             <a:extLst xmlns:a="http://schemas.openxmlformats.org/drawingml/2006/main">
               <a:ext uri="{FF2B5EF4-FFF2-40B4-BE49-F238E27FC236}">
-                <a16:creationId xmlns:a16="http://schemas.microsoft.com/office/drawing/2014/main" id="{9CC5EDE9-F915-4F2F-B290-603DF8CE8054}"/>
+                <a16:creationId xmlns:a16="http://schemas.microsoft.com/office/drawing/2014/main" id="{1B421EF9-1A8A-4A46-B987-C0CA86321E55}"/>
               </a:ext>
             </a:extLst>
           </p:cNvPr>
@@ -9100,7 +9100,7 @@
           <p:cNvPr id="5" name="">
             <a:extLst xmlns:a="http://schemas.openxmlformats.org/drawingml/2006/main">
               <a:ext uri="{FF2B5EF4-FFF2-40B4-BE49-F238E27FC236}">
-                <a16:creationId xmlns:a16="http://schemas.microsoft.com/office/drawing/2014/main" id="{FACAD8F9-DFA2-46C0-B258-63B84667085D}"/>
+                <a16:creationId xmlns:a16="http://schemas.microsoft.com/office/drawing/2014/main" id="{16A5FB4A-BBCF-41EF-B083-A532089B7205}"/>
               </a:ext>
             </a:extLst>
           </p:cNvPr>
@@ -9164,7 +9164,7 @@
           <p:cNvPr id="6" name="">
             <a:extLst xmlns:a="http://schemas.openxmlformats.org/drawingml/2006/main">
               <a:ext uri="{FF2B5EF4-FFF2-40B4-BE49-F238E27FC236}">
-                <a16:creationId xmlns:a16="http://schemas.microsoft.com/office/drawing/2014/main" id="{EF02739D-DFE7-4420-846B-633808D3FEF0}"/>
+                <a16:creationId xmlns:a16="http://schemas.microsoft.com/office/drawing/2014/main" id="{0862320B-2459-4546-B18F-DB3473966F8C}"/>
               </a:ext>
             </a:extLst>
           </p:cNvPr>
@@ -9218,7 +9218,7 @@
                 <a:ea typeface="Hiragino Mincho ProN"/>
                 <a:cs typeface="Hiragino Mincho ProN"/>
               </a:rPr>
-              <a:t>AE候補は、追加演算が必要かを測る階段である</a:t>
+              <a:t>AE候補は、追加演算の必要性を測る階段である</a:t>
             </a:r>
           </a:p>
         </p:txBody>
@@ -9228,7 +9228,7 @@
           <p:cNvPr id="7" name="">
             <a:extLst xmlns:a="http://schemas.openxmlformats.org/drawingml/2006/main">
               <a:ext uri="{FF2B5EF4-FFF2-40B4-BE49-F238E27FC236}">
-                <a16:creationId xmlns:a16="http://schemas.microsoft.com/office/drawing/2014/main" id="{AA542A5F-2849-4364-86B2-7114C15E2291}"/>
+                <a16:creationId xmlns:a16="http://schemas.microsoft.com/office/drawing/2014/main" id="{5650D0C0-5CEA-4D16-80FF-5949D7054C46}"/>
               </a:ext>
             </a:extLst>
           </p:cNvPr>
@@ -9261,7 +9261,7 @@
           <p:cNvPr id="8" name="">
             <a:extLst xmlns:a="http://schemas.openxmlformats.org/drawingml/2006/main">
               <a:ext uri="{FF2B5EF4-FFF2-40B4-BE49-F238E27FC236}">
-                <a16:creationId xmlns:a16="http://schemas.microsoft.com/office/drawing/2014/main" id="{FC638F08-2F3F-4F46-8F57-57D571FE7449}"/>
+                <a16:creationId xmlns:a16="http://schemas.microsoft.com/office/drawing/2014/main" id="{E8F7269D-87E4-4CBB-A288-75B977B04760}"/>
               </a:ext>
             </a:extLst>
           </p:cNvPr>
@@ -9296,7 +9296,7 @@
           <p:cNvPr id="9" name="">
             <a:extLst xmlns:a="http://schemas.openxmlformats.org/drawingml/2006/main">
               <a:ext uri="{FF2B5EF4-FFF2-40B4-BE49-F238E27FC236}">
-                <a16:creationId xmlns:a16="http://schemas.microsoft.com/office/drawing/2014/main" id="{BA995C75-D2EA-45B3-A317-01B8063BD31B}"/>
+                <a16:creationId xmlns:a16="http://schemas.microsoft.com/office/drawing/2014/main" id="{B29984AA-7C2F-40F0-901B-10098896A89B}"/>
               </a:ext>
             </a:extLst>
           </p:cNvPr>
@@ -9350,7 +9350,7 @@
                 <a:ea typeface="Hiragino Sans"/>
                 <a:cs typeface="Hiragino Sans"/>
               </a:rPr>
-              <a:t>主張 | 複雑なモデルを採用するためではなく、単純候補で説明できない差分だけを上位候補に渡す。</a:t>
+              <a:t>主張 | 単純候補で説明できるなら止め、説明できない差分だけをDense、GRU、Conv1D、CNN-GRUへ渡す。</a:t>
             </a:r>
           </a:p>
         </p:txBody>
@@ -9360,7 +9360,7 @@
           <p:cNvPr id="10" name="">
             <a:extLst xmlns:a="http://schemas.openxmlformats.org/drawingml/2006/main">
               <a:ext uri="{FF2B5EF4-FFF2-40B4-BE49-F238E27FC236}">
-                <a16:creationId xmlns:a16="http://schemas.microsoft.com/office/drawing/2014/main" id="{016D9B80-D192-4064-9B40-D6F54C8034BB}"/>
+                <a16:creationId xmlns:a16="http://schemas.microsoft.com/office/drawing/2014/main" id="{7B1D59E5-BF23-4420-AC41-2A86478DB94A}"/>
               </a:ext>
             </a:extLst>
           </p:cNvPr>
@@ -9393,7 +9393,7 @@
           <p:cNvPr id="11" name="">
             <a:extLst xmlns:a="http://schemas.openxmlformats.org/drawingml/2006/main">
               <a:ext uri="{FF2B5EF4-FFF2-40B4-BE49-F238E27FC236}">
-                <a16:creationId xmlns:a16="http://schemas.microsoft.com/office/drawing/2014/main" id="{F7ACED5C-C41C-4867-86CB-7CA3656EDA6E}"/>
+                <a16:creationId xmlns:a16="http://schemas.microsoft.com/office/drawing/2014/main" id="{506E7B6D-4D36-43EA-BAE2-AEE796A3B8B9}"/>
               </a:ext>
             </a:extLst>
           </p:cNvPr>
@@ -9457,7 +9457,7 @@
           <p:cNvPr id="12" name="">
             <a:extLst xmlns:a="http://schemas.openxmlformats.org/drawingml/2006/main">
               <a:ext uri="{FF2B5EF4-FFF2-40B4-BE49-F238E27FC236}">
-                <a16:creationId xmlns:a16="http://schemas.microsoft.com/office/drawing/2014/main" id="{6573A680-6F22-45A7-988D-693ED371A62D}"/>
+                <a16:creationId xmlns:a16="http://schemas.microsoft.com/office/drawing/2014/main" id="{024E6DA7-D2ED-4DAB-A117-B83F62010005}"/>
               </a:ext>
             </a:extLst>
           </p:cNvPr>
@@ -9492,7 +9492,7 @@
           <p:cNvPr id="13" name="">
             <a:extLst xmlns:a="http://schemas.openxmlformats.org/drawingml/2006/main">
               <a:ext uri="{FF2B5EF4-FFF2-40B4-BE49-F238E27FC236}">
-                <a16:creationId xmlns:a16="http://schemas.microsoft.com/office/drawing/2014/main" id="{701660D2-DB21-413F-A8DF-07B8768F943A}"/>
+                <a16:creationId xmlns:a16="http://schemas.microsoft.com/office/drawing/2014/main" id="{D422066A-B597-418D-82D8-39D04FB97AFA}"/>
               </a:ext>
             </a:extLst>
           </p:cNvPr>
@@ -9556,7 +9556,7 @@
           <p:cNvPr id="14" name="">
             <a:extLst xmlns:a="http://schemas.openxmlformats.org/drawingml/2006/main">
               <a:ext uri="{FF2B5EF4-FFF2-40B4-BE49-F238E27FC236}">
-                <a16:creationId xmlns:a16="http://schemas.microsoft.com/office/drawing/2014/main" id="{C28949D3-7611-4E43-8231-86DBB433364D}"/>
+                <a16:creationId xmlns:a16="http://schemas.microsoft.com/office/drawing/2014/main" id="{4B7C4B5C-CB27-4F93-B576-7FDB33EA8DDE}"/>
               </a:ext>
             </a:extLst>
           </p:cNvPr>
@@ -9591,7 +9591,7 @@
           <p:cNvPr id="15" name="">
             <a:extLst xmlns:a="http://schemas.openxmlformats.org/drawingml/2006/main">
               <a:ext uri="{FF2B5EF4-FFF2-40B4-BE49-F238E27FC236}">
-                <a16:creationId xmlns:a16="http://schemas.microsoft.com/office/drawing/2014/main" id="{42796144-0D93-4A2F-9E4E-B06B1C3133E6}"/>
+                <a16:creationId xmlns:a16="http://schemas.microsoft.com/office/drawing/2014/main" id="{72ADCF96-C4A8-4483-AB60-B8A773A43CB9}"/>
               </a:ext>
             </a:extLst>
           </p:cNvPr>
@@ -9655,7 +9655,7 @@
           <p:cNvPr id="16" name="">
             <a:extLst xmlns:a="http://schemas.openxmlformats.org/drawingml/2006/main">
               <a:ext uri="{FF2B5EF4-FFF2-40B4-BE49-F238E27FC236}">
-                <a16:creationId xmlns:a16="http://schemas.microsoft.com/office/drawing/2014/main" id="{06A84619-D093-4A25-BD64-DF68B1FBC1D1}"/>
+                <a16:creationId xmlns:a16="http://schemas.microsoft.com/office/drawing/2014/main" id="{CAFF39DF-76D4-4C91-950F-0AC0D9DC3B8F}"/>
               </a:ext>
             </a:extLst>
           </p:cNvPr>
@@ -9690,7 +9690,7 @@
           <p:cNvPr id="17" name="">
             <a:extLst xmlns:a="http://schemas.openxmlformats.org/drawingml/2006/main">
               <a:ext uri="{FF2B5EF4-FFF2-40B4-BE49-F238E27FC236}">
-                <a16:creationId xmlns:a16="http://schemas.microsoft.com/office/drawing/2014/main" id="{099C0FE3-B16E-4CA0-843D-0791494E1B79}"/>
+                <a16:creationId xmlns:a16="http://schemas.microsoft.com/office/drawing/2014/main" id="{3E99EEDC-3D0C-44B8-A836-F1343E744A54}"/>
               </a:ext>
             </a:extLst>
           </p:cNvPr>
@@ -9754,7 +9754,7 @@
           <p:cNvPr id="18" name="">
             <a:extLst xmlns:a="http://schemas.openxmlformats.org/drawingml/2006/main">
               <a:ext uri="{FF2B5EF4-FFF2-40B4-BE49-F238E27FC236}">
-                <a16:creationId xmlns:a16="http://schemas.microsoft.com/office/drawing/2014/main" id="{E37056B6-ACE5-4554-ABD6-70F95BC2E15C}"/>
+                <a16:creationId xmlns:a16="http://schemas.microsoft.com/office/drawing/2014/main" id="{F21BC5EF-2ADE-47D9-A864-D9A492C2CAFF}"/>
               </a:ext>
             </a:extLst>
           </p:cNvPr>
@@ -9789,7 +9789,7 @@
           <p:cNvPr id="19" name="">
             <a:extLst xmlns:a="http://schemas.openxmlformats.org/drawingml/2006/main">
               <a:ext uri="{FF2B5EF4-FFF2-40B4-BE49-F238E27FC236}">
-                <a16:creationId xmlns:a16="http://schemas.microsoft.com/office/drawing/2014/main" id="{57FB5CF4-40BD-4F05-8EE2-B04565E0EC2B}"/>
+                <a16:creationId xmlns:a16="http://schemas.microsoft.com/office/drawing/2014/main" id="{D33E7842-47B4-431C-9197-15CF7F3D60EF}"/>
               </a:ext>
             </a:extLst>
           </p:cNvPr>
@@ -9853,7 +9853,7 @@
           <p:cNvPr id="20" name="">
             <a:extLst xmlns:a="http://schemas.openxmlformats.org/drawingml/2006/main">
               <a:ext uri="{FF2B5EF4-FFF2-40B4-BE49-F238E27FC236}">
-                <a16:creationId xmlns:a16="http://schemas.microsoft.com/office/drawing/2014/main" id="{320D23C2-B0E5-4128-A546-CB8F15B10C2E}"/>
+                <a16:creationId xmlns:a16="http://schemas.microsoft.com/office/drawing/2014/main" id="{B59C0A66-202F-4D69-B213-FFB63F8A1CFC}"/>
               </a:ext>
             </a:extLst>
           </p:cNvPr>
@@ -9886,7 +9886,7 @@
           <p:cNvPr id="21" name="">
             <a:extLst xmlns:a="http://schemas.openxmlformats.org/drawingml/2006/main">
               <a:ext uri="{FF2B5EF4-FFF2-40B4-BE49-F238E27FC236}">
-                <a16:creationId xmlns:a16="http://schemas.microsoft.com/office/drawing/2014/main" id="{3C73049B-B460-46A2-A455-6B147A88AD4D}"/>
+                <a16:creationId xmlns:a16="http://schemas.microsoft.com/office/drawing/2014/main" id="{55A5CE80-70F5-44DB-A860-8137E2ED1CD8}"/>
               </a:ext>
             </a:extLst>
           </p:cNvPr>
@@ -9950,7 +9950,7 @@
           <p:cNvPr id="22" name="">
             <a:extLst xmlns:a="http://schemas.openxmlformats.org/drawingml/2006/main">
               <a:ext uri="{FF2B5EF4-FFF2-40B4-BE49-F238E27FC236}">
-                <a16:creationId xmlns:a16="http://schemas.microsoft.com/office/drawing/2014/main" id="{8B9FF28B-3CF8-4355-850E-622B5104624B}"/>
+                <a16:creationId xmlns:a16="http://schemas.microsoft.com/office/drawing/2014/main" id="{E57D1484-1D8A-455C-95A3-1C1D64E4470A}"/>
               </a:ext>
             </a:extLst>
           </p:cNvPr>
@@ -9985,7 +9985,7 @@
           <p:cNvPr id="23" name="">
             <a:extLst xmlns:a="http://schemas.openxmlformats.org/drawingml/2006/main">
               <a:ext uri="{FF2B5EF4-FFF2-40B4-BE49-F238E27FC236}">
-                <a16:creationId xmlns:a16="http://schemas.microsoft.com/office/drawing/2014/main" id="{456B9960-B75E-4AD4-9494-033E18FE500A}"/>
+                <a16:creationId xmlns:a16="http://schemas.microsoft.com/office/drawing/2014/main" id="{866AD5F3-44ED-4484-8837-2A86445C7319}"/>
               </a:ext>
             </a:extLst>
           </p:cNvPr>
@@ -10049,7 +10049,7 @@
           <p:cNvPr id="24" name="">
             <a:extLst xmlns:a="http://schemas.openxmlformats.org/drawingml/2006/main">
               <a:ext uri="{FF2B5EF4-FFF2-40B4-BE49-F238E27FC236}">
-                <a16:creationId xmlns:a16="http://schemas.microsoft.com/office/drawing/2014/main" id="{4EB1E587-5C18-4623-A1FC-68A696BAE927}"/>
+                <a16:creationId xmlns:a16="http://schemas.microsoft.com/office/drawing/2014/main" id="{A6370EA3-CCC8-4C6D-9C4E-347BEA5AD2A0}"/>
               </a:ext>
             </a:extLst>
           </p:cNvPr>
@@ -10084,7 +10084,7 @@
           <p:cNvPr id="25" name="">
             <a:extLst xmlns:a="http://schemas.openxmlformats.org/drawingml/2006/main">
               <a:ext uri="{FF2B5EF4-FFF2-40B4-BE49-F238E27FC236}">
-                <a16:creationId xmlns:a16="http://schemas.microsoft.com/office/drawing/2014/main" id="{1C15C68B-4080-4653-9F5D-843A22E27A01}"/>
+                <a16:creationId xmlns:a16="http://schemas.microsoft.com/office/drawing/2014/main" id="{06D420EE-0B6B-414F-B1BD-7D714D7A4DCD}"/>
               </a:ext>
             </a:extLst>
           </p:cNvPr>
@@ -10148,7 +10148,7 @@
           <p:cNvPr id="26" name="">
             <a:extLst xmlns:a="http://schemas.openxmlformats.org/drawingml/2006/main">
               <a:ext uri="{FF2B5EF4-FFF2-40B4-BE49-F238E27FC236}">
-                <a16:creationId xmlns:a16="http://schemas.microsoft.com/office/drawing/2014/main" id="{4E2C9D73-9EDC-42DE-AFDE-61411C4E8EFA}"/>
+                <a16:creationId xmlns:a16="http://schemas.microsoft.com/office/drawing/2014/main" id="{405C1E00-FB9A-43E4-AD2E-099941303DC4}"/>
               </a:ext>
             </a:extLst>
           </p:cNvPr>
@@ -10183,7 +10183,7 @@
           <p:cNvPr id="27" name="">
             <a:extLst xmlns:a="http://schemas.openxmlformats.org/drawingml/2006/main">
               <a:ext uri="{FF2B5EF4-FFF2-40B4-BE49-F238E27FC236}">
-                <a16:creationId xmlns:a16="http://schemas.microsoft.com/office/drawing/2014/main" id="{C1DB6318-086C-4235-A138-799A1FE80630}"/>
+                <a16:creationId xmlns:a16="http://schemas.microsoft.com/office/drawing/2014/main" id="{C76E0DAF-7987-474F-8CD9-7509810CEEB7}"/>
               </a:ext>
             </a:extLst>
           </p:cNvPr>
@@ -10247,7 +10247,7 @@
           <p:cNvPr id="28" name="">
             <a:extLst xmlns:a="http://schemas.openxmlformats.org/drawingml/2006/main">
               <a:ext uri="{FF2B5EF4-FFF2-40B4-BE49-F238E27FC236}">
-                <a16:creationId xmlns:a16="http://schemas.microsoft.com/office/drawing/2014/main" id="{45A52624-2850-4201-B81F-9111ECF83A2A}"/>
+                <a16:creationId xmlns:a16="http://schemas.microsoft.com/office/drawing/2014/main" id="{A25E5EFE-0180-4B4B-9E8A-F4B51CD1CC04}"/>
               </a:ext>
             </a:extLst>
           </p:cNvPr>
@@ -10282,7 +10282,7 @@
           <p:cNvPr id="29" name="">
             <a:extLst xmlns:a="http://schemas.openxmlformats.org/drawingml/2006/main">
               <a:ext uri="{FF2B5EF4-FFF2-40B4-BE49-F238E27FC236}">
-                <a16:creationId xmlns:a16="http://schemas.microsoft.com/office/drawing/2014/main" id="{F297845D-6893-40F2-B51D-DDEF52B8A385}"/>
+                <a16:creationId xmlns:a16="http://schemas.microsoft.com/office/drawing/2014/main" id="{44E921B2-F658-41AD-A15E-305132D9E0B0}"/>
               </a:ext>
             </a:extLst>
           </p:cNvPr>
@@ -10346,7 +10346,7 @@
           <p:cNvPr id="30" name="">
             <a:extLst xmlns:a="http://schemas.openxmlformats.org/drawingml/2006/main">
               <a:ext uri="{FF2B5EF4-FFF2-40B4-BE49-F238E27FC236}">
-                <a16:creationId xmlns:a16="http://schemas.microsoft.com/office/drawing/2014/main" id="{EF8F0734-AB50-4C1B-84A5-69C3A5E2488A}"/>
+                <a16:creationId xmlns:a16="http://schemas.microsoft.com/office/drawing/2014/main" id="{4CAB004F-4093-415D-9F47-2796CBBF31C5}"/>
               </a:ext>
             </a:extLst>
           </p:cNvPr>
@@ -10379,7 +10379,7 @@
           <p:cNvPr id="31" name="">
             <a:extLst xmlns:a="http://schemas.openxmlformats.org/drawingml/2006/main">
               <a:ext uri="{FF2B5EF4-FFF2-40B4-BE49-F238E27FC236}">
-                <a16:creationId xmlns:a16="http://schemas.microsoft.com/office/drawing/2014/main" id="{C8984D66-0CAF-43F6-B039-17C845144989}"/>
+                <a16:creationId xmlns:a16="http://schemas.microsoft.com/office/drawing/2014/main" id="{659AA732-4A78-4836-866D-A23776DEE569}"/>
               </a:ext>
             </a:extLst>
           </p:cNvPr>
@@ -10443,7 +10443,7 @@
           <p:cNvPr id="32" name="">
             <a:extLst xmlns:a="http://schemas.openxmlformats.org/drawingml/2006/main">
               <a:ext uri="{FF2B5EF4-FFF2-40B4-BE49-F238E27FC236}">
-                <a16:creationId xmlns:a16="http://schemas.microsoft.com/office/drawing/2014/main" id="{2B3FC2B7-9114-40B7-9995-B027CC479BC4}"/>
+                <a16:creationId xmlns:a16="http://schemas.microsoft.com/office/drawing/2014/main" id="{83AA0F38-2F86-44AA-9DBB-23950165A54E}"/>
               </a:ext>
             </a:extLst>
           </p:cNvPr>
@@ -10478,7 +10478,7 @@
           <p:cNvPr id="33" name="">
             <a:extLst xmlns:a="http://schemas.openxmlformats.org/drawingml/2006/main">
               <a:ext uri="{FF2B5EF4-FFF2-40B4-BE49-F238E27FC236}">
-                <a16:creationId xmlns:a16="http://schemas.microsoft.com/office/drawing/2014/main" id="{47072004-CC19-4488-9D29-C77BABBD77C5}"/>
+                <a16:creationId xmlns:a16="http://schemas.microsoft.com/office/drawing/2014/main" id="{6F14B1A9-644D-40F9-A43D-25DC0B949765}"/>
               </a:ext>
             </a:extLst>
           </p:cNvPr>
@@ -10542,7 +10542,7 @@
           <p:cNvPr id="34" name="">
             <a:extLst xmlns:a="http://schemas.openxmlformats.org/drawingml/2006/main">
               <a:ext uri="{FF2B5EF4-FFF2-40B4-BE49-F238E27FC236}">
-                <a16:creationId xmlns:a16="http://schemas.microsoft.com/office/drawing/2014/main" id="{B38D1C6E-02D3-45A5-B675-C1F97FD3E65F}"/>
+                <a16:creationId xmlns:a16="http://schemas.microsoft.com/office/drawing/2014/main" id="{98282C93-B91D-4A2E-86E9-C5A3D01B1293}"/>
               </a:ext>
             </a:extLst>
           </p:cNvPr>
@@ -10577,7 +10577,7 @@
           <p:cNvPr id="35" name="">
             <a:extLst xmlns:a="http://schemas.openxmlformats.org/drawingml/2006/main">
               <a:ext uri="{FF2B5EF4-FFF2-40B4-BE49-F238E27FC236}">
-                <a16:creationId xmlns:a16="http://schemas.microsoft.com/office/drawing/2014/main" id="{EF4581E8-C953-41DA-A6A0-97B332CEF2C8}"/>
+                <a16:creationId xmlns:a16="http://schemas.microsoft.com/office/drawing/2014/main" id="{04028776-35C0-45F8-95B1-1750AFE7F345}"/>
               </a:ext>
             </a:extLst>
           </p:cNvPr>
@@ -10641,7 +10641,7 @@
           <p:cNvPr id="36" name="">
             <a:extLst xmlns:a="http://schemas.openxmlformats.org/drawingml/2006/main">
               <a:ext uri="{FF2B5EF4-FFF2-40B4-BE49-F238E27FC236}">
-                <a16:creationId xmlns:a16="http://schemas.microsoft.com/office/drawing/2014/main" id="{C9A841A1-0ACD-4ABA-B606-A40A7D0C831F}"/>
+                <a16:creationId xmlns:a16="http://schemas.microsoft.com/office/drawing/2014/main" id="{5067013B-4A27-4601-A110-074810703C99}"/>
               </a:ext>
             </a:extLst>
           </p:cNvPr>
@@ -10676,7 +10676,7 @@
           <p:cNvPr id="37" name="">
             <a:extLst xmlns:a="http://schemas.openxmlformats.org/drawingml/2006/main">
               <a:ext uri="{FF2B5EF4-FFF2-40B4-BE49-F238E27FC236}">
-                <a16:creationId xmlns:a16="http://schemas.microsoft.com/office/drawing/2014/main" id="{C110DD05-46E8-4563-B336-6F45E07DF8B6}"/>
+                <a16:creationId xmlns:a16="http://schemas.microsoft.com/office/drawing/2014/main" id="{A088C6B0-EDBB-485B-9D2E-17890227EA82}"/>
               </a:ext>
             </a:extLst>
           </p:cNvPr>
@@ -10740,7 +10740,7 @@
           <p:cNvPr id="38" name="">
             <a:extLst xmlns:a="http://schemas.openxmlformats.org/drawingml/2006/main">
               <a:ext uri="{FF2B5EF4-FFF2-40B4-BE49-F238E27FC236}">
-                <a16:creationId xmlns:a16="http://schemas.microsoft.com/office/drawing/2014/main" id="{B2E954C2-5EB6-470E-8D3F-A9534E57BACF}"/>
+                <a16:creationId xmlns:a16="http://schemas.microsoft.com/office/drawing/2014/main" id="{24413BF0-C826-44E1-BC56-151C416E2695}"/>
               </a:ext>
             </a:extLst>
           </p:cNvPr>
@@ -10775,7 +10775,7 @@
           <p:cNvPr id="39" name="">
             <a:extLst xmlns:a="http://schemas.openxmlformats.org/drawingml/2006/main">
               <a:ext uri="{FF2B5EF4-FFF2-40B4-BE49-F238E27FC236}">
-                <a16:creationId xmlns:a16="http://schemas.microsoft.com/office/drawing/2014/main" id="{3EDB31C9-D05A-49FC-9442-30B56F634F2B}"/>
+                <a16:creationId xmlns:a16="http://schemas.microsoft.com/office/drawing/2014/main" id="{1D962138-7E1E-4061-B378-4135D92E30BB}"/>
               </a:ext>
             </a:extLst>
           </p:cNvPr>
@@ -10839,7 +10839,7 @@
           <p:cNvPr id="40" name="">
             <a:extLst xmlns:a="http://schemas.openxmlformats.org/drawingml/2006/main">
               <a:ext uri="{FF2B5EF4-FFF2-40B4-BE49-F238E27FC236}">
-                <a16:creationId xmlns:a16="http://schemas.microsoft.com/office/drawing/2014/main" id="{0EBE55BE-11DA-4DD2-8303-0FCA68FCEE69}"/>
+                <a16:creationId xmlns:a16="http://schemas.microsoft.com/office/drawing/2014/main" id="{159B46BA-C482-42E0-A74A-B384FFD9FA93}"/>
               </a:ext>
             </a:extLst>
           </p:cNvPr>
@@ -10872,7 +10872,7 @@
           <p:cNvPr id="41" name="">
             <a:extLst xmlns:a="http://schemas.openxmlformats.org/drawingml/2006/main">
               <a:ext uri="{FF2B5EF4-FFF2-40B4-BE49-F238E27FC236}">
-                <a16:creationId xmlns:a16="http://schemas.microsoft.com/office/drawing/2014/main" id="{48FD0BCD-B02A-48B9-BDCF-6E16066B0B6E}"/>
+                <a16:creationId xmlns:a16="http://schemas.microsoft.com/office/drawing/2014/main" id="{815143A8-9876-43D2-98E5-9D8967328805}"/>
               </a:ext>
             </a:extLst>
           </p:cNvPr>
@@ -10936,7 +10936,7 @@
           <p:cNvPr id="42" name="">
             <a:extLst xmlns:a="http://schemas.openxmlformats.org/drawingml/2006/main">
               <a:ext uri="{FF2B5EF4-FFF2-40B4-BE49-F238E27FC236}">
-                <a16:creationId xmlns:a16="http://schemas.microsoft.com/office/drawing/2014/main" id="{6C55D434-1C8A-4F26-82DC-49C0A0931269}"/>
+                <a16:creationId xmlns:a16="http://schemas.microsoft.com/office/drawing/2014/main" id="{C0F0EC58-C03E-40D7-8376-EFE263724400}"/>
               </a:ext>
             </a:extLst>
           </p:cNvPr>
@@ -10971,7 +10971,7 @@
           <p:cNvPr id="43" name="">
             <a:extLst xmlns:a="http://schemas.openxmlformats.org/drawingml/2006/main">
               <a:ext uri="{FF2B5EF4-FFF2-40B4-BE49-F238E27FC236}">
-                <a16:creationId xmlns:a16="http://schemas.microsoft.com/office/drawing/2014/main" id="{2D2C10B7-1EAD-4CEF-B664-BBC745BAE910}"/>
+                <a16:creationId xmlns:a16="http://schemas.microsoft.com/office/drawing/2014/main" id="{77E80F56-E7EA-455B-B400-E2B041192490}"/>
               </a:ext>
             </a:extLst>
           </p:cNvPr>
@@ -11035,7 +11035,7 @@
           <p:cNvPr id="44" name="">
             <a:extLst xmlns:a="http://schemas.openxmlformats.org/drawingml/2006/main">
               <a:ext uri="{FF2B5EF4-FFF2-40B4-BE49-F238E27FC236}">
-                <a16:creationId xmlns:a16="http://schemas.microsoft.com/office/drawing/2014/main" id="{24C99D6A-0C8F-4F87-8BC6-BC4A22D62FEC}"/>
+                <a16:creationId xmlns:a16="http://schemas.microsoft.com/office/drawing/2014/main" id="{93283D66-6D2C-47C5-AA92-A6FFF5BDA5A1}"/>
               </a:ext>
             </a:extLst>
           </p:cNvPr>
@@ -11070,7 +11070,7 @@
           <p:cNvPr id="45" name="">
             <a:extLst xmlns:a="http://schemas.openxmlformats.org/drawingml/2006/main">
               <a:ext uri="{FF2B5EF4-FFF2-40B4-BE49-F238E27FC236}">
-                <a16:creationId xmlns:a16="http://schemas.microsoft.com/office/drawing/2014/main" id="{C9E80DB2-7444-4865-A54B-A97E58E68DF8}"/>
+                <a16:creationId xmlns:a16="http://schemas.microsoft.com/office/drawing/2014/main" id="{2DEA2D13-2A00-4F5B-A02B-1FF3F763924A}"/>
               </a:ext>
             </a:extLst>
           </p:cNvPr>
@@ -11134,7 +11134,7 @@
           <p:cNvPr id="46" name="">
             <a:extLst xmlns:a="http://schemas.openxmlformats.org/drawingml/2006/main">
               <a:ext uri="{FF2B5EF4-FFF2-40B4-BE49-F238E27FC236}">
-                <a16:creationId xmlns:a16="http://schemas.microsoft.com/office/drawing/2014/main" id="{BF234117-628D-40B1-BB39-EF771BEECC17}"/>
+                <a16:creationId xmlns:a16="http://schemas.microsoft.com/office/drawing/2014/main" id="{1747CDB4-6A67-4220-832B-B03D6ECAA9CF}"/>
               </a:ext>
             </a:extLst>
           </p:cNvPr>
@@ -11169,7 +11169,7 @@
           <p:cNvPr id="47" name="">
             <a:extLst xmlns:a="http://schemas.openxmlformats.org/drawingml/2006/main">
               <a:ext uri="{FF2B5EF4-FFF2-40B4-BE49-F238E27FC236}">
-                <a16:creationId xmlns:a16="http://schemas.microsoft.com/office/drawing/2014/main" id="{B120C1E6-57C8-4408-9873-F9F806B1C19B}"/>
+                <a16:creationId xmlns:a16="http://schemas.microsoft.com/office/drawing/2014/main" id="{08452113-FE9C-4363-B3A3-FE05651A51E4}"/>
               </a:ext>
             </a:extLst>
           </p:cNvPr>
@@ -11233,7 +11233,7 @@
           <p:cNvPr id="48" name="">
             <a:extLst xmlns:a="http://schemas.openxmlformats.org/drawingml/2006/main">
               <a:ext uri="{FF2B5EF4-FFF2-40B4-BE49-F238E27FC236}">
-                <a16:creationId xmlns:a16="http://schemas.microsoft.com/office/drawing/2014/main" id="{4B5AA495-085C-4C0A-B96A-588B144E1DA2}"/>
+                <a16:creationId xmlns:a16="http://schemas.microsoft.com/office/drawing/2014/main" id="{44DE848D-EBA1-4969-B63E-183B3F345E8B}"/>
               </a:ext>
             </a:extLst>
           </p:cNvPr>
@@ -11268,7 +11268,7 @@
           <p:cNvPr id="49" name="">
             <a:extLst xmlns:a="http://schemas.openxmlformats.org/drawingml/2006/main">
               <a:ext uri="{FF2B5EF4-FFF2-40B4-BE49-F238E27FC236}">
-                <a16:creationId xmlns:a16="http://schemas.microsoft.com/office/drawing/2014/main" id="{529FF4EF-5B5B-4432-8DFA-306DE344031D}"/>
+                <a16:creationId xmlns:a16="http://schemas.microsoft.com/office/drawing/2014/main" id="{33D4BDCC-054E-4D46-905B-576D191AD5C6}"/>
               </a:ext>
             </a:extLst>
           </p:cNvPr>
@@ -11332,7 +11332,7 @@
           <p:cNvPr id="50" name="">
             <a:extLst xmlns:a="http://schemas.openxmlformats.org/drawingml/2006/main">
               <a:ext uri="{FF2B5EF4-FFF2-40B4-BE49-F238E27FC236}">
-                <a16:creationId xmlns:a16="http://schemas.microsoft.com/office/drawing/2014/main" id="{D549E8EA-B09E-4FC3-9ACF-DC1F94DA9248}"/>
+                <a16:creationId xmlns:a16="http://schemas.microsoft.com/office/drawing/2014/main" id="{D4B0E8BA-62F3-4402-8503-AEDAAF756BDA}"/>
               </a:ext>
             </a:extLst>
           </p:cNvPr>
@@ -11365,7 +11365,7 @@
           <p:cNvPr id="51" name="">
             <a:extLst xmlns:a="http://schemas.openxmlformats.org/drawingml/2006/main">
               <a:ext uri="{FF2B5EF4-FFF2-40B4-BE49-F238E27FC236}">
-                <a16:creationId xmlns:a16="http://schemas.microsoft.com/office/drawing/2014/main" id="{9034C5E0-375C-47B1-8F7A-5D06D4BDDA8B}"/>
+                <a16:creationId xmlns:a16="http://schemas.microsoft.com/office/drawing/2014/main" id="{F8F9A99A-9B7A-4714-BC63-8D8A01E37D3A}"/>
               </a:ext>
             </a:extLst>
           </p:cNvPr>
@@ -11429,7 +11429,7 @@
           <p:cNvPr id="52" name="">
             <a:extLst xmlns:a="http://schemas.openxmlformats.org/drawingml/2006/main">
               <a:ext uri="{FF2B5EF4-FFF2-40B4-BE49-F238E27FC236}">
-                <a16:creationId xmlns:a16="http://schemas.microsoft.com/office/drawing/2014/main" id="{8EBDEF29-B533-42B2-AF04-25779D61DDC0}"/>
+                <a16:creationId xmlns:a16="http://schemas.microsoft.com/office/drawing/2014/main" id="{31E16851-79FB-4F03-9BE9-7FA63F4A8E7A}"/>
               </a:ext>
             </a:extLst>
           </p:cNvPr>
@@ -11464,7 +11464,7 @@
           <p:cNvPr id="53" name="">
             <a:extLst xmlns:a="http://schemas.openxmlformats.org/drawingml/2006/main">
               <a:ext uri="{FF2B5EF4-FFF2-40B4-BE49-F238E27FC236}">
-                <a16:creationId xmlns:a16="http://schemas.microsoft.com/office/drawing/2014/main" id="{E86864F1-319F-45B6-B697-62C0ADB9885A}"/>
+                <a16:creationId xmlns:a16="http://schemas.microsoft.com/office/drawing/2014/main" id="{8887A782-051E-46A1-816D-F5B6B50FBC43}"/>
               </a:ext>
             </a:extLst>
           </p:cNvPr>
@@ -11528,7 +11528,7 @@
           <p:cNvPr id="54" name="">
             <a:extLst xmlns:a="http://schemas.openxmlformats.org/drawingml/2006/main">
               <a:ext uri="{FF2B5EF4-FFF2-40B4-BE49-F238E27FC236}">
-                <a16:creationId xmlns:a16="http://schemas.microsoft.com/office/drawing/2014/main" id="{EAD21DFA-8A62-4777-A663-5DEFB89D1CB9}"/>
+                <a16:creationId xmlns:a16="http://schemas.microsoft.com/office/drawing/2014/main" id="{DCDFE0C1-DA1C-430B-A02F-117981CA97E9}"/>
               </a:ext>
             </a:extLst>
           </p:cNvPr>
@@ -11563,7 +11563,7 @@
           <p:cNvPr id="55" name="">
             <a:extLst xmlns:a="http://schemas.openxmlformats.org/drawingml/2006/main">
               <a:ext uri="{FF2B5EF4-FFF2-40B4-BE49-F238E27FC236}">
-                <a16:creationId xmlns:a16="http://schemas.microsoft.com/office/drawing/2014/main" id="{0ACFB598-5488-426A-AD20-3E20CA70ED27}"/>
+                <a16:creationId xmlns:a16="http://schemas.microsoft.com/office/drawing/2014/main" id="{0858986D-2CA5-4C98-82DB-25AC6B255542}"/>
               </a:ext>
             </a:extLst>
           </p:cNvPr>
@@ -11627,7 +11627,7 @@
           <p:cNvPr id="56" name="">
             <a:extLst xmlns:a="http://schemas.openxmlformats.org/drawingml/2006/main">
               <a:ext uri="{FF2B5EF4-FFF2-40B4-BE49-F238E27FC236}">
-                <a16:creationId xmlns:a16="http://schemas.microsoft.com/office/drawing/2014/main" id="{47DCC6FD-0773-4B33-9979-930640FED51C}"/>
+                <a16:creationId xmlns:a16="http://schemas.microsoft.com/office/drawing/2014/main" id="{BD07DC1F-025A-4EBC-B0FE-021EBD5F24F8}"/>
               </a:ext>
             </a:extLst>
           </p:cNvPr>
@@ -11662,7 +11662,7 @@
           <p:cNvPr id="57" name="">
             <a:extLst xmlns:a="http://schemas.openxmlformats.org/drawingml/2006/main">
               <a:ext uri="{FF2B5EF4-FFF2-40B4-BE49-F238E27FC236}">
-                <a16:creationId xmlns:a16="http://schemas.microsoft.com/office/drawing/2014/main" id="{9BC918DA-616C-43E0-9381-06799DCA597B}"/>
+                <a16:creationId xmlns:a16="http://schemas.microsoft.com/office/drawing/2014/main" id="{39AC5ADE-1F11-45B5-84DA-4B4E74EDB018}"/>
               </a:ext>
             </a:extLst>
           </p:cNvPr>
@@ -11726,7 +11726,7 @@
           <p:cNvPr id="58" name="">
             <a:extLst xmlns:a="http://schemas.openxmlformats.org/drawingml/2006/main">
               <a:ext uri="{FF2B5EF4-FFF2-40B4-BE49-F238E27FC236}">
-                <a16:creationId xmlns:a16="http://schemas.microsoft.com/office/drawing/2014/main" id="{355D6BAA-FACA-4FC3-AD73-39CB67578065}"/>
+                <a16:creationId xmlns:a16="http://schemas.microsoft.com/office/drawing/2014/main" id="{A055183D-B087-4A48-82E3-CFB4D8D60929}"/>
               </a:ext>
             </a:extLst>
           </p:cNvPr>
@@ -11761,7 +11761,7 @@
           <p:cNvPr id="59" name="">
             <a:extLst xmlns:a="http://schemas.openxmlformats.org/drawingml/2006/main">
               <a:ext uri="{FF2B5EF4-FFF2-40B4-BE49-F238E27FC236}">
-                <a16:creationId xmlns:a16="http://schemas.microsoft.com/office/drawing/2014/main" id="{030629A1-42E3-454E-AC06-F4CEF0A87F76}"/>
+                <a16:creationId xmlns:a16="http://schemas.microsoft.com/office/drawing/2014/main" id="{22770253-8270-46D1-9B0D-948916AB925D}"/>
               </a:ext>
             </a:extLst>
           </p:cNvPr>
@@ -11825,7 +11825,7 @@
           <p:cNvPr id="60" name="">
             <a:extLst xmlns:a="http://schemas.openxmlformats.org/drawingml/2006/main">
               <a:ext uri="{FF2B5EF4-FFF2-40B4-BE49-F238E27FC236}">
-                <a16:creationId xmlns:a16="http://schemas.microsoft.com/office/drawing/2014/main" id="{7C3D4A26-68A2-40E5-A844-E725B7BBEEB2}"/>
+                <a16:creationId xmlns:a16="http://schemas.microsoft.com/office/drawing/2014/main" id="{11335E0D-0B3B-4267-BFB9-8DA2FA1E8310}"/>
               </a:ext>
             </a:extLst>
           </p:cNvPr>
@@ -11858,7 +11858,7 @@
           <p:cNvPr id="61" name="">
             <a:extLst xmlns:a="http://schemas.openxmlformats.org/drawingml/2006/main">
               <a:ext uri="{FF2B5EF4-FFF2-40B4-BE49-F238E27FC236}">
-                <a16:creationId xmlns:a16="http://schemas.microsoft.com/office/drawing/2014/main" id="{48E79FF7-12FC-439B-89CB-AD27EF6CFE55}"/>
+                <a16:creationId xmlns:a16="http://schemas.microsoft.com/office/drawing/2014/main" id="{3B0EACB8-042C-45CC-8474-892A34B65921}"/>
               </a:ext>
             </a:extLst>
           </p:cNvPr>
@@ -11922,7 +11922,7 @@
           <p:cNvPr id="62" name="">
             <a:extLst xmlns:a="http://schemas.openxmlformats.org/drawingml/2006/main">
               <a:ext uri="{FF2B5EF4-FFF2-40B4-BE49-F238E27FC236}">
-                <a16:creationId xmlns:a16="http://schemas.microsoft.com/office/drawing/2014/main" id="{CA989ECF-F056-47DF-946C-F750215D511C}"/>
+                <a16:creationId xmlns:a16="http://schemas.microsoft.com/office/drawing/2014/main" id="{2D38133F-1359-4E85-87FC-74BECCCF907C}"/>
               </a:ext>
             </a:extLst>
           </p:cNvPr>
@@ -11957,7 +11957,7 @@
           <p:cNvPr id="63" name="">
             <a:extLst xmlns:a="http://schemas.openxmlformats.org/drawingml/2006/main">
               <a:ext uri="{FF2B5EF4-FFF2-40B4-BE49-F238E27FC236}">
-                <a16:creationId xmlns:a16="http://schemas.microsoft.com/office/drawing/2014/main" id="{4738473E-62EF-4D4A-A6A6-3FDFD97D8A3B}"/>
+                <a16:creationId xmlns:a16="http://schemas.microsoft.com/office/drawing/2014/main" id="{1BB27CB9-5857-462C-8B01-5196B04FFB77}"/>
               </a:ext>
             </a:extLst>
           </p:cNvPr>
@@ -12021,7 +12021,7 @@
           <p:cNvPr id="64" name="">
             <a:extLst xmlns:a="http://schemas.openxmlformats.org/drawingml/2006/main">
               <a:ext uri="{FF2B5EF4-FFF2-40B4-BE49-F238E27FC236}">
-                <a16:creationId xmlns:a16="http://schemas.microsoft.com/office/drawing/2014/main" id="{F87299F7-EE07-411C-8DEF-DD9B1C77A7F3}"/>
+                <a16:creationId xmlns:a16="http://schemas.microsoft.com/office/drawing/2014/main" id="{44CE7A02-33ED-4059-B179-4ECC00519A17}"/>
               </a:ext>
             </a:extLst>
           </p:cNvPr>
@@ -12056,7 +12056,7 @@
           <p:cNvPr id="65" name="">
             <a:extLst xmlns:a="http://schemas.openxmlformats.org/drawingml/2006/main">
               <a:ext uri="{FF2B5EF4-FFF2-40B4-BE49-F238E27FC236}">
-                <a16:creationId xmlns:a16="http://schemas.microsoft.com/office/drawing/2014/main" id="{23071865-C9D8-49B7-9492-B5ED8E309541}"/>
+                <a16:creationId xmlns:a16="http://schemas.microsoft.com/office/drawing/2014/main" id="{BAF91DD3-A9C5-4F14-BDF3-AFC9D710CF09}"/>
               </a:ext>
             </a:extLst>
           </p:cNvPr>
@@ -12120,7 +12120,7 @@
           <p:cNvPr id="66" name="">
             <a:extLst xmlns:a="http://schemas.openxmlformats.org/drawingml/2006/main">
               <a:ext uri="{FF2B5EF4-FFF2-40B4-BE49-F238E27FC236}">
-                <a16:creationId xmlns:a16="http://schemas.microsoft.com/office/drawing/2014/main" id="{F9421914-64C9-445C-B616-8E47380066EE}"/>
+                <a16:creationId xmlns:a16="http://schemas.microsoft.com/office/drawing/2014/main" id="{5493C284-8ED6-4EA4-8AB6-6F71F21915E0}"/>
               </a:ext>
             </a:extLst>
           </p:cNvPr>
@@ -12155,7 +12155,7 @@
           <p:cNvPr id="67" name="">
             <a:extLst xmlns:a="http://schemas.openxmlformats.org/drawingml/2006/main">
               <a:ext uri="{FF2B5EF4-FFF2-40B4-BE49-F238E27FC236}">
-                <a16:creationId xmlns:a16="http://schemas.microsoft.com/office/drawing/2014/main" id="{00AEAFCD-2DD4-4001-92FF-C6ED49F7700F}"/>
+                <a16:creationId xmlns:a16="http://schemas.microsoft.com/office/drawing/2014/main" id="{AED22E7D-3675-4EB2-890A-C6F67110909F}"/>
               </a:ext>
             </a:extLst>
           </p:cNvPr>
@@ -12219,7 +12219,7 @@
           <p:cNvPr id="68" name="">
             <a:extLst xmlns:a="http://schemas.openxmlformats.org/drawingml/2006/main">
               <a:ext uri="{FF2B5EF4-FFF2-40B4-BE49-F238E27FC236}">
-                <a16:creationId xmlns:a16="http://schemas.microsoft.com/office/drawing/2014/main" id="{870E0566-1BA2-4E58-A378-2F5522614918}"/>
+                <a16:creationId xmlns:a16="http://schemas.microsoft.com/office/drawing/2014/main" id="{95E92647-4836-4138-8024-0C2891E55EBB}"/>
               </a:ext>
             </a:extLst>
           </p:cNvPr>
@@ -12254,7 +12254,7 @@
           <p:cNvPr id="69" name="">
             <a:extLst xmlns:a="http://schemas.openxmlformats.org/drawingml/2006/main">
               <a:ext uri="{FF2B5EF4-FFF2-40B4-BE49-F238E27FC236}">
-                <a16:creationId xmlns:a16="http://schemas.microsoft.com/office/drawing/2014/main" id="{25FF3C14-A001-4337-B939-9F0DB473A46C}"/>
+                <a16:creationId xmlns:a16="http://schemas.microsoft.com/office/drawing/2014/main" id="{CA7FCEC4-DE26-42E8-845B-E24354EA5739}"/>
               </a:ext>
             </a:extLst>
           </p:cNvPr>
@@ -12318,7 +12318,7 @@
           <p:cNvPr id="70" name="">
             <a:extLst xmlns:a="http://schemas.openxmlformats.org/drawingml/2006/main">
               <a:ext uri="{FF2B5EF4-FFF2-40B4-BE49-F238E27FC236}">
-                <a16:creationId xmlns:a16="http://schemas.microsoft.com/office/drawing/2014/main" id="{E3428028-0B03-421A-A843-C6FDB8B6B8D4}"/>
+                <a16:creationId xmlns:a16="http://schemas.microsoft.com/office/drawing/2014/main" id="{2DF49113-47D8-48E7-AA27-D4AF70B2A76C}"/>
               </a:ext>
             </a:extLst>
           </p:cNvPr>
@@ -12351,7 +12351,7 @@
           <p:cNvPr id="71" name="">
             <a:extLst xmlns:a="http://schemas.openxmlformats.org/drawingml/2006/main">
               <a:ext uri="{FF2B5EF4-FFF2-40B4-BE49-F238E27FC236}">
-                <a16:creationId xmlns:a16="http://schemas.microsoft.com/office/drawing/2014/main" id="{C38EFAE4-E310-4B11-88E6-FCA1189D25CF}"/>
+                <a16:creationId xmlns:a16="http://schemas.microsoft.com/office/drawing/2014/main" id="{81A37AB7-01D6-4787-88EE-B57A5B73B6DF}"/>
               </a:ext>
             </a:extLst>
           </p:cNvPr>
@@ -12415,7 +12415,7 @@
           <p:cNvPr id="72" name="">
             <a:extLst xmlns:a="http://schemas.openxmlformats.org/drawingml/2006/main">
               <a:ext uri="{FF2B5EF4-FFF2-40B4-BE49-F238E27FC236}">
-                <a16:creationId xmlns:a16="http://schemas.microsoft.com/office/drawing/2014/main" id="{28900FE8-3D6B-4097-A19F-90A93CCEC581}"/>
+                <a16:creationId xmlns:a16="http://schemas.microsoft.com/office/drawing/2014/main" id="{3537BDB9-B7D3-4291-B427-FEF97036FEB4}"/>
               </a:ext>
             </a:extLst>
           </p:cNvPr>
@@ -12448,7 +12448,7 @@
           <p:cNvPr id="73" name="">
             <a:extLst xmlns:a="http://schemas.openxmlformats.org/drawingml/2006/main">
               <a:ext uri="{FF2B5EF4-FFF2-40B4-BE49-F238E27FC236}">
-                <a16:creationId xmlns:a16="http://schemas.microsoft.com/office/drawing/2014/main" id="{D66FB8E8-FB51-427A-B8AA-34D1B5BB6AC7}"/>
+                <a16:creationId xmlns:a16="http://schemas.microsoft.com/office/drawing/2014/main" id="{BC98D0CF-0A5B-4D22-B646-2B2846BDFFA8}"/>
               </a:ext>
             </a:extLst>
           </p:cNvPr>
@@ -12512,7 +12512,7 @@
           <p:cNvPr id="74" name="">
             <a:extLst xmlns:a="http://schemas.openxmlformats.org/drawingml/2006/main">
               <a:ext uri="{FF2B5EF4-FFF2-40B4-BE49-F238E27FC236}">
-                <a16:creationId xmlns:a16="http://schemas.microsoft.com/office/drawing/2014/main" id="{F4F1AB94-398F-4654-B140-2BB7AF8664EF}"/>
+                <a16:creationId xmlns:a16="http://schemas.microsoft.com/office/drawing/2014/main" id="{10743D2E-ED08-4962-915A-A5D4F379CD60}"/>
               </a:ext>
             </a:extLst>
           </p:cNvPr>
@@ -12547,7 +12547,7 @@
           <p:cNvPr id="75" name="">
             <a:extLst xmlns:a="http://schemas.openxmlformats.org/drawingml/2006/main">
               <a:ext uri="{FF2B5EF4-FFF2-40B4-BE49-F238E27FC236}">
-                <a16:creationId xmlns:a16="http://schemas.microsoft.com/office/drawing/2014/main" id="{ED9754E5-10EB-4F3D-851C-D2D26289445E}"/>
+                <a16:creationId xmlns:a16="http://schemas.microsoft.com/office/drawing/2014/main" id="{D2A7F877-0605-4B6F-8BD0-912866E63B0C}"/>
               </a:ext>
             </a:extLst>
           </p:cNvPr>
@@ -12609,7 +12609,7 @@
     </p:spTree>
     <p:extLst>
       <p:ext uri="{BB962C8B-B14F-4D97-AF65-F5344CB8AC3E}">
-        <p14:creationId xmlns:p14="http://schemas.microsoft.com/office/powerpoint/2010/main" val="612993921"/>
+        <p14:creationId xmlns:p14="http://schemas.microsoft.com/office/powerpoint/2010/main" val="1863614426"/>
       </p:ext>
     </p:extLst>
   </p:cSld>
@@ -12633,7 +12633,7 @@
           <p:cNvPr id="1" name="">
             <a:extLst xmlns:a="http://schemas.openxmlformats.org/drawingml/2006/main">
               <a:ext uri="{FF2B5EF4-FFF2-40B4-BE49-F238E27FC236}">
-                <a16:creationId xmlns:a16="http://schemas.microsoft.com/office/drawing/2014/main" id="{A0427B21-CF8C-4920-BFCE-7931D1B573AC}"/>
+                <a16:creationId xmlns:a16="http://schemas.microsoft.com/office/drawing/2014/main" id="{3405EBDA-C07F-4449-9C02-39548EC2890A}"/>
               </a:ext>
             </a:extLst>
           </p:cNvPr>
@@ -12668,7 +12668,7 @@
           <p:cNvPr id="2" name="">
             <a:extLst xmlns:a="http://schemas.openxmlformats.org/drawingml/2006/main">
               <a:ext uri="{FF2B5EF4-FFF2-40B4-BE49-F238E27FC236}">
-                <a16:creationId xmlns:a16="http://schemas.microsoft.com/office/drawing/2014/main" id="{F9CC901E-41C9-4852-8070-E3E4000AFBFE}"/>
+                <a16:creationId xmlns:a16="http://schemas.microsoft.com/office/drawing/2014/main" id="{6100A0D6-1DE1-4736-B7AF-ADEAA494F695}"/>
               </a:ext>
             </a:extLst>
           </p:cNvPr>
@@ -12703,7 +12703,7 @@
           <p:cNvPr id="3" name="">
             <a:extLst xmlns:a="http://schemas.openxmlformats.org/drawingml/2006/main">
               <a:ext uri="{FF2B5EF4-FFF2-40B4-BE49-F238E27FC236}">
-                <a16:creationId xmlns:a16="http://schemas.microsoft.com/office/drawing/2014/main" id="{4CDD3442-A092-441C-AEDA-490DCC47FD2F}"/>
+                <a16:creationId xmlns:a16="http://schemas.microsoft.com/office/drawing/2014/main" id="{B253B68C-12BF-4187-A47F-8676622F52FA}"/>
               </a:ext>
             </a:extLst>
           </p:cNvPr>
@@ -12738,7 +12738,7 @@
           <p:cNvPr id="4" name="">
             <a:extLst xmlns:a="http://schemas.openxmlformats.org/drawingml/2006/main">
               <a:ext uri="{FF2B5EF4-FFF2-40B4-BE49-F238E27FC236}">
-                <a16:creationId xmlns:a16="http://schemas.microsoft.com/office/drawing/2014/main" id="{B0B71254-30CA-4E23-9CE8-0A790308101F}"/>
+                <a16:creationId xmlns:a16="http://schemas.microsoft.com/office/drawing/2014/main" id="{54E3AE36-6135-465C-AAD1-EA38DD812E90}"/>
               </a:ext>
             </a:extLst>
           </p:cNvPr>
@@ -12802,7 +12802,7 @@
           <p:cNvPr id="5" name="">
             <a:extLst xmlns:a="http://schemas.openxmlformats.org/drawingml/2006/main">
               <a:ext uri="{FF2B5EF4-FFF2-40B4-BE49-F238E27FC236}">
-                <a16:creationId xmlns:a16="http://schemas.microsoft.com/office/drawing/2014/main" id="{04B4C64F-13A5-464A-A335-508F9C27E255}"/>
+                <a16:creationId xmlns:a16="http://schemas.microsoft.com/office/drawing/2014/main" id="{EB49CC2B-39B1-4B74-858D-271C11E8D473}"/>
               </a:ext>
             </a:extLst>
           </p:cNvPr>
@@ -12866,7 +12866,7 @@
           <p:cNvPr id="6" name="">
             <a:extLst xmlns:a="http://schemas.openxmlformats.org/drawingml/2006/main">
               <a:ext uri="{FF2B5EF4-FFF2-40B4-BE49-F238E27FC236}">
-                <a16:creationId xmlns:a16="http://schemas.microsoft.com/office/drawing/2014/main" id="{9A170118-B882-4DDB-BC6C-2DC959BD3857}"/>
+                <a16:creationId xmlns:a16="http://schemas.microsoft.com/office/drawing/2014/main" id="{B5FD8BE5-4FA7-49EC-B290-18FC65C5A466}"/>
               </a:ext>
             </a:extLst>
           </p:cNvPr>
@@ -12902,7 +12902,7 @@
           <a:lstStyle xmlns:a="http://schemas.openxmlformats.org/drawingml/2006/main"/>
           <a:p xmlns:a="http://schemas.openxmlformats.org/drawingml/2006/main">
             <a:pPr algn="l">
-              <a:defRPr sz="2175" b="1">
+              <a:defRPr sz="2100" b="1">
                 <a:solidFill>
                   <a:srgbClr val="111827"/>
                 </a:solidFill>
@@ -12912,7 +12912,7 @@
               </a:defRPr>
             </a:pPr>
             <a:r>
-              <a:rPr sz="2175" b="1">
+              <a:rPr sz="2100" b="1">
                 <a:solidFill>
                   <a:srgbClr val="111827"/>
                 </a:solidFill>
@@ -12920,7 +12920,7 @@
                 <a:ea typeface="Hiragino Mincho ProN"/>
                 <a:cs typeface="Hiragino Mincho ProN"/>
               </a:rPr>
-              <a:t>500KBは、モデルだけでなくvolumeごとの状態まで測る</a:t>
+              <a:t>500 KBの判定では、重みだけでなくvolumeごとの状態も数える</a:t>
             </a:r>
           </a:p>
         </p:txBody>
@@ -12930,7 +12930,7 @@
           <p:cNvPr id="7" name="">
             <a:extLst xmlns:a="http://schemas.openxmlformats.org/drawingml/2006/main">
               <a:ext uri="{FF2B5EF4-FFF2-40B4-BE49-F238E27FC236}">
-                <a16:creationId xmlns:a16="http://schemas.microsoft.com/office/drawing/2014/main" id="{C054D685-8B2C-4878-9645-DAF6CED0AD24}"/>
+                <a16:creationId xmlns:a16="http://schemas.microsoft.com/office/drawing/2014/main" id="{4E305453-4E16-4E50-A7A7-EA581A737D8A}"/>
               </a:ext>
             </a:extLst>
           </p:cNvPr>
@@ -12963,7 +12963,7 @@
           <p:cNvPr id="8" name="">
             <a:extLst xmlns:a="http://schemas.openxmlformats.org/drawingml/2006/main">
               <a:ext uri="{FF2B5EF4-FFF2-40B4-BE49-F238E27FC236}">
-                <a16:creationId xmlns:a16="http://schemas.microsoft.com/office/drawing/2014/main" id="{870F0B10-9C6D-4B01-878A-F20356B3002B}"/>
+                <a16:creationId xmlns:a16="http://schemas.microsoft.com/office/drawing/2014/main" id="{C1EA3A6D-8F80-4990-906A-FBCF6A951EDF}"/>
               </a:ext>
             </a:extLst>
           </p:cNvPr>
@@ -12998,7 +12998,7 @@
           <p:cNvPr id="9" name="">
             <a:extLst xmlns:a="http://schemas.openxmlformats.org/drawingml/2006/main">
               <a:ext uri="{FF2B5EF4-FFF2-40B4-BE49-F238E27FC236}">
-                <a16:creationId xmlns:a16="http://schemas.microsoft.com/office/drawing/2014/main" id="{66F9E1D7-66DA-4EC3-B23C-843F598A804F}"/>
+                <a16:creationId xmlns:a16="http://schemas.microsoft.com/office/drawing/2014/main" id="{34A6A2C6-037F-49C4-96B6-A6ED1376534F}"/>
               </a:ext>
             </a:extLst>
           </p:cNvPr>
@@ -13052,7 +13052,7 @@
                 <a:ea typeface="Hiragino Sans"/>
                 <a:cs typeface="Hiragino Sans"/>
               </a:rPr>
-              <a:t>主張 | per-volume detector-dataには重み、入力列、正規化、threshold、score履歴を含め、共有runtimeとは分けて扱う。</a:t>
+              <a:t>主張 | 測る対象はモデル重みだけではなく、入力列、正規化、threshold、score履歴を含むper-volume detector-dataである。</a:t>
             </a:r>
           </a:p>
         </p:txBody>
@@ -13062,7 +13062,7 @@
           <p:cNvPr id="10" name="">
             <a:extLst xmlns:a="http://schemas.openxmlformats.org/drawingml/2006/main">
               <a:ext uri="{FF2B5EF4-FFF2-40B4-BE49-F238E27FC236}">
-                <a16:creationId xmlns:a16="http://schemas.microsoft.com/office/drawing/2014/main" id="{F2FF564D-EDC0-4606-BFA8-57A3CDFF42A9}"/>
+                <a16:creationId xmlns:a16="http://schemas.microsoft.com/office/drawing/2014/main" id="{9A7035B4-8DD5-4EA9-BDE3-425571A6B463}"/>
               </a:ext>
             </a:extLst>
           </p:cNvPr>
@@ -13095,7 +13095,7 @@
           <p:cNvPr id="11" name="">
             <a:extLst xmlns:a="http://schemas.openxmlformats.org/drawingml/2006/main">
               <a:ext uri="{FF2B5EF4-FFF2-40B4-BE49-F238E27FC236}">
-                <a16:creationId xmlns:a16="http://schemas.microsoft.com/office/drawing/2014/main" id="{E62E1297-B943-493B-9373-7CDE56399C5A}"/>
+                <a16:creationId xmlns:a16="http://schemas.microsoft.com/office/drawing/2014/main" id="{F78C30F2-81BD-400B-8BE8-D1F4C0CDAE17}"/>
               </a:ext>
             </a:extLst>
           </p:cNvPr>
@@ -13130,7 +13130,7 @@
           <p:cNvPr id="12" name="">
             <a:extLst xmlns:a="http://schemas.openxmlformats.org/drawingml/2006/main">
               <a:ext uri="{FF2B5EF4-FFF2-40B4-BE49-F238E27FC236}">
-                <a16:creationId xmlns:a16="http://schemas.microsoft.com/office/drawing/2014/main" id="{618CE497-9C01-4BFD-97FE-7F94E43768F1}"/>
+                <a16:creationId xmlns:a16="http://schemas.microsoft.com/office/drawing/2014/main" id="{5DA9D3E3-7BDD-4033-A7B9-4D18CA495C23}"/>
               </a:ext>
             </a:extLst>
           </p:cNvPr>
@@ -13194,7 +13194,7 @@
           <p:cNvPr id="13" name="">
             <a:extLst xmlns:a="http://schemas.openxmlformats.org/drawingml/2006/main">
               <a:ext uri="{FF2B5EF4-FFF2-40B4-BE49-F238E27FC236}">
-                <a16:creationId xmlns:a16="http://schemas.microsoft.com/office/drawing/2014/main" id="{03E4F3D0-6D62-4583-B327-997329FD5947}"/>
+                <a16:creationId xmlns:a16="http://schemas.microsoft.com/office/drawing/2014/main" id="{0D46CC21-F9BD-4A19-8715-1593B64FADDF}"/>
               </a:ext>
             </a:extLst>
           </p:cNvPr>
@@ -13227,7 +13227,7 @@
           <p:cNvPr id="14" name="">
             <a:extLst xmlns:a="http://schemas.openxmlformats.org/drawingml/2006/main">
               <a:ext uri="{FF2B5EF4-FFF2-40B4-BE49-F238E27FC236}">
-                <a16:creationId xmlns:a16="http://schemas.microsoft.com/office/drawing/2014/main" id="{5D005CE6-0BA6-4829-A317-0B423F5FC161}"/>
+                <a16:creationId xmlns:a16="http://schemas.microsoft.com/office/drawing/2014/main" id="{8B630B6A-221B-401D-AE87-56DBCE4F972B}"/>
               </a:ext>
             </a:extLst>
           </p:cNvPr>
@@ -13291,7 +13291,7 @@
           <p:cNvPr id="15" name="">
             <a:extLst xmlns:a="http://schemas.openxmlformats.org/drawingml/2006/main">
               <a:ext uri="{FF2B5EF4-FFF2-40B4-BE49-F238E27FC236}">
-                <a16:creationId xmlns:a16="http://schemas.microsoft.com/office/drawing/2014/main" id="{AC61A6D5-14BB-4CE2-9AFA-75BB65CB288B}"/>
+                <a16:creationId xmlns:a16="http://schemas.microsoft.com/office/drawing/2014/main" id="{B669A313-01D7-47B6-BCB2-479BEC9CE373}"/>
               </a:ext>
             </a:extLst>
           </p:cNvPr>
@@ -13326,7 +13326,7 @@
           <p:cNvPr id="16" name="">
             <a:extLst xmlns:a="http://schemas.openxmlformats.org/drawingml/2006/main">
               <a:ext uri="{FF2B5EF4-FFF2-40B4-BE49-F238E27FC236}">
-                <a16:creationId xmlns:a16="http://schemas.microsoft.com/office/drawing/2014/main" id="{4B72CD3D-FB29-4D37-A82F-ADECF53945E0}"/>
+                <a16:creationId xmlns:a16="http://schemas.microsoft.com/office/drawing/2014/main" id="{45C0B4B4-AB16-4545-BEBD-6FFFBC3CBAC5}"/>
               </a:ext>
             </a:extLst>
           </p:cNvPr>
@@ -13390,7 +13390,7 @@
           <p:cNvPr id="17" name="">
             <a:extLst xmlns:a="http://schemas.openxmlformats.org/drawingml/2006/main">
               <a:ext uri="{FF2B5EF4-FFF2-40B4-BE49-F238E27FC236}">
-                <a16:creationId xmlns:a16="http://schemas.microsoft.com/office/drawing/2014/main" id="{C651CF0F-174E-436C-B366-23807412A18A}"/>
+                <a16:creationId xmlns:a16="http://schemas.microsoft.com/office/drawing/2014/main" id="{2821EEE7-B1DA-4FBB-8506-E582DDFF61F1}"/>
               </a:ext>
             </a:extLst>
           </p:cNvPr>
@@ -13423,7 +13423,7 @@
           <p:cNvPr id="18" name="">
             <a:extLst xmlns:a="http://schemas.openxmlformats.org/drawingml/2006/main">
               <a:ext uri="{FF2B5EF4-FFF2-40B4-BE49-F238E27FC236}">
-                <a16:creationId xmlns:a16="http://schemas.microsoft.com/office/drawing/2014/main" id="{E6E13A6F-9DCE-456C-B925-74A3F53E7CA8}"/>
+                <a16:creationId xmlns:a16="http://schemas.microsoft.com/office/drawing/2014/main" id="{414CF34C-A873-402A-8A20-7BEF9B0C4A29}"/>
               </a:ext>
             </a:extLst>
           </p:cNvPr>
@@ -13487,7 +13487,7 @@
           <p:cNvPr id="19" name="">
             <a:extLst xmlns:a="http://schemas.openxmlformats.org/drawingml/2006/main">
               <a:ext uri="{FF2B5EF4-FFF2-40B4-BE49-F238E27FC236}">
-                <a16:creationId xmlns:a16="http://schemas.microsoft.com/office/drawing/2014/main" id="{865838A5-03BF-4EB6-854E-0D0B09BB7334}"/>
+                <a16:creationId xmlns:a16="http://schemas.microsoft.com/office/drawing/2014/main" id="{6F51A4E1-1810-4D5C-81AD-A40A95CF202B}"/>
               </a:ext>
             </a:extLst>
           </p:cNvPr>
@@ -13522,7 +13522,7 @@
           <p:cNvPr id="20" name="">
             <a:extLst xmlns:a="http://schemas.openxmlformats.org/drawingml/2006/main">
               <a:ext uri="{FF2B5EF4-FFF2-40B4-BE49-F238E27FC236}">
-                <a16:creationId xmlns:a16="http://schemas.microsoft.com/office/drawing/2014/main" id="{46B5A65B-5767-45BD-8E7D-07FE49D7A94C}"/>
+                <a16:creationId xmlns:a16="http://schemas.microsoft.com/office/drawing/2014/main" id="{C2453CBB-2746-4C35-B169-912AD315259A}"/>
               </a:ext>
             </a:extLst>
           </p:cNvPr>
@@ -13586,7 +13586,7 @@
           <p:cNvPr id="21" name="">
             <a:extLst xmlns:a="http://schemas.openxmlformats.org/drawingml/2006/main">
               <a:ext uri="{FF2B5EF4-FFF2-40B4-BE49-F238E27FC236}">
-                <a16:creationId xmlns:a16="http://schemas.microsoft.com/office/drawing/2014/main" id="{7377D4CB-DAA1-4C81-8356-BD98E07F7C06}"/>
+                <a16:creationId xmlns:a16="http://schemas.microsoft.com/office/drawing/2014/main" id="{183E8182-0D84-4F5C-92F1-ADD6CD9D9EA3}"/>
               </a:ext>
             </a:extLst>
           </p:cNvPr>
@@ -13619,7 +13619,7 @@
           <p:cNvPr id="22" name="">
             <a:extLst xmlns:a="http://schemas.openxmlformats.org/drawingml/2006/main">
               <a:ext uri="{FF2B5EF4-FFF2-40B4-BE49-F238E27FC236}">
-                <a16:creationId xmlns:a16="http://schemas.microsoft.com/office/drawing/2014/main" id="{33B2FF06-4EC9-4F55-8E4D-4B25F98B07A6}"/>
+                <a16:creationId xmlns:a16="http://schemas.microsoft.com/office/drawing/2014/main" id="{DABC9060-D749-4C5A-B3CF-485604704D9C}"/>
               </a:ext>
             </a:extLst>
           </p:cNvPr>
@@ -13683,7 +13683,7 @@
           <p:cNvPr id="23" name="">
             <a:extLst xmlns:a="http://schemas.openxmlformats.org/drawingml/2006/main">
               <a:ext uri="{FF2B5EF4-FFF2-40B4-BE49-F238E27FC236}">
-                <a16:creationId xmlns:a16="http://schemas.microsoft.com/office/drawing/2014/main" id="{756A686D-552E-4EA6-96F7-CD01A393AA1A}"/>
+                <a16:creationId xmlns:a16="http://schemas.microsoft.com/office/drawing/2014/main" id="{E4B0D624-A35D-480B-8531-2B00956C61EA}"/>
               </a:ext>
             </a:extLst>
           </p:cNvPr>
@@ -13718,7 +13718,7 @@
           <p:cNvPr id="24" name="">
             <a:extLst xmlns:a="http://schemas.openxmlformats.org/drawingml/2006/main">
               <a:ext uri="{FF2B5EF4-FFF2-40B4-BE49-F238E27FC236}">
-                <a16:creationId xmlns:a16="http://schemas.microsoft.com/office/drawing/2014/main" id="{942941CC-A002-485C-9BA5-2FC70454D901}"/>
+                <a16:creationId xmlns:a16="http://schemas.microsoft.com/office/drawing/2014/main" id="{F519C4CB-D7DB-40EF-8A4E-866097072E5A}"/>
               </a:ext>
             </a:extLst>
           </p:cNvPr>
@@ -13782,7 +13782,7 @@
           <p:cNvPr id="25" name="">
             <a:extLst xmlns:a="http://schemas.openxmlformats.org/drawingml/2006/main">
               <a:ext uri="{FF2B5EF4-FFF2-40B4-BE49-F238E27FC236}">
-                <a16:creationId xmlns:a16="http://schemas.microsoft.com/office/drawing/2014/main" id="{59C5C174-0C35-4E26-9573-5BDE2ACA3C63}"/>
+                <a16:creationId xmlns:a16="http://schemas.microsoft.com/office/drawing/2014/main" id="{15DF4630-2A80-403C-A760-60D3286428B7}"/>
               </a:ext>
             </a:extLst>
           </p:cNvPr>
@@ -13815,7 +13815,7 @@
           <p:cNvPr id="26" name="">
             <a:extLst xmlns:a="http://schemas.openxmlformats.org/drawingml/2006/main">
               <a:ext uri="{FF2B5EF4-FFF2-40B4-BE49-F238E27FC236}">
-                <a16:creationId xmlns:a16="http://schemas.microsoft.com/office/drawing/2014/main" id="{FC1517A0-0D5A-4ACA-9337-21BFF38F5EDD}"/>
+                <a16:creationId xmlns:a16="http://schemas.microsoft.com/office/drawing/2014/main" id="{12BE3139-F50F-4CE1-A310-3D375372243B}"/>
               </a:ext>
             </a:extLst>
           </p:cNvPr>
@@ -13879,7 +13879,7 @@
           <p:cNvPr id="27" name="">
             <a:extLst xmlns:a="http://schemas.openxmlformats.org/drawingml/2006/main">
               <a:ext uri="{FF2B5EF4-FFF2-40B4-BE49-F238E27FC236}">
-                <a16:creationId xmlns:a16="http://schemas.microsoft.com/office/drawing/2014/main" id="{E3CF2EC5-A3E8-493F-9527-EA3F2DF480C5}"/>
+                <a16:creationId xmlns:a16="http://schemas.microsoft.com/office/drawing/2014/main" id="{2F919FFE-E9F0-47B3-AD60-FA1C82003062}"/>
               </a:ext>
             </a:extLst>
           </p:cNvPr>
@@ -13914,7 +13914,7 @@
           <p:cNvPr id="28" name="">
             <a:extLst xmlns:a="http://schemas.openxmlformats.org/drawingml/2006/main">
               <a:ext uri="{FF2B5EF4-FFF2-40B4-BE49-F238E27FC236}">
-                <a16:creationId xmlns:a16="http://schemas.microsoft.com/office/drawing/2014/main" id="{FF511CFB-A7F1-4C43-8993-676EF08F3D12}"/>
+                <a16:creationId xmlns:a16="http://schemas.microsoft.com/office/drawing/2014/main" id="{3E2E06F8-0980-4486-8972-A97A2F1C7400}"/>
               </a:ext>
             </a:extLst>
           </p:cNvPr>
@@ -13978,7 +13978,7 @@
           <p:cNvPr id="29" name="">
             <a:extLst xmlns:a="http://schemas.openxmlformats.org/drawingml/2006/main">
               <a:ext uri="{FF2B5EF4-FFF2-40B4-BE49-F238E27FC236}">
-                <a16:creationId xmlns:a16="http://schemas.microsoft.com/office/drawing/2014/main" id="{10A547D4-E583-4BDB-B5A8-FB38E860A678}"/>
+                <a16:creationId xmlns:a16="http://schemas.microsoft.com/office/drawing/2014/main" id="{933B9741-5860-493F-9271-58120217EC98}"/>
               </a:ext>
             </a:extLst>
           </p:cNvPr>
@@ -14011,7 +14011,7 @@
           <p:cNvPr id="30" name="">
             <a:extLst xmlns:a="http://schemas.openxmlformats.org/drawingml/2006/main">
               <a:ext uri="{FF2B5EF4-FFF2-40B4-BE49-F238E27FC236}">
-                <a16:creationId xmlns:a16="http://schemas.microsoft.com/office/drawing/2014/main" id="{F02E42A0-9FD3-42E8-B3F7-AB85B7ADCE37}"/>
+                <a16:creationId xmlns:a16="http://schemas.microsoft.com/office/drawing/2014/main" id="{9F5AF5E6-52BC-4E3B-9A2D-B225078F65B6}"/>
               </a:ext>
             </a:extLst>
           </p:cNvPr>
@@ -14075,7 +14075,7 @@
           <p:cNvPr id="31" name="">
             <a:extLst xmlns:a="http://schemas.openxmlformats.org/drawingml/2006/main">
               <a:ext uri="{FF2B5EF4-FFF2-40B4-BE49-F238E27FC236}">
-                <a16:creationId xmlns:a16="http://schemas.microsoft.com/office/drawing/2014/main" id="{77F07B46-D979-4588-BE05-E20BF6BF15E6}"/>
+                <a16:creationId xmlns:a16="http://schemas.microsoft.com/office/drawing/2014/main" id="{DBD540E2-0007-44D8-9E1F-8117A33272BE}"/>
               </a:ext>
             </a:extLst>
           </p:cNvPr>
@@ -14110,7 +14110,7 @@
           <p:cNvPr id="32" name="">
             <a:extLst xmlns:a="http://schemas.openxmlformats.org/drawingml/2006/main">
               <a:ext uri="{FF2B5EF4-FFF2-40B4-BE49-F238E27FC236}">
-                <a16:creationId xmlns:a16="http://schemas.microsoft.com/office/drawing/2014/main" id="{DE290A44-FA50-492C-A74A-C30D3FF4964B}"/>
+                <a16:creationId xmlns:a16="http://schemas.microsoft.com/office/drawing/2014/main" id="{3977B3B2-5A0E-495D-8104-F6AE1973BF9A}"/>
               </a:ext>
             </a:extLst>
           </p:cNvPr>
@@ -14174,7 +14174,7 @@
           <p:cNvPr id="33" name="">
             <a:extLst xmlns:a="http://schemas.openxmlformats.org/drawingml/2006/main">
               <a:ext uri="{FF2B5EF4-FFF2-40B4-BE49-F238E27FC236}">
-                <a16:creationId xmlns:a16="http://schemas.microsoft.com/office/drawing/2014/main" id="{1F491421-35E8-4F65-8EDE-3FEB63BAE13C}"/>
+                <a16:creationId xmlns:a16="http://schemas.microsoft.com/office/drawing/2014/main" id="{7F71719B-65EC-462C-9FF4-349AB248C6F3}"/>
               </a:ext>
             </a:extLst>
           </p:cNvPr>
@@ -14238,7 +14238,7 @@
           <p:cNvPr id="34" name="">
             <a:extLst xmlns:a="http://schemas.openxmlformats.org/drawingml/2006/main">
               <a:ext uri="{FF2B5EF4-FFF2-40B4-BE49-F238E27FC236}">
-                <a16:creationId xmlns:a16="http://schemas.microsoft.com/office/drawing/2014/main" id="{22A15208-E6B7-4C78-B686-493E4B96CF5B}"/>
+                <a16:creationId xmlns:a16="http://schemas.microsoft.com/office/drawing/2014/main" id="{5CA5E63A-1519-44CA-AB3C-32E79DBD0D64}"/>
               </a:ext>
             </a:extLst>
           </p:cNvPr>
@@ -14271,7 +14271,7 @@
           <p:cNvPr id="35" name="">
             <a:extLst xmlns:a="http://schemas.openxmlformats.org/drawingml/2006/main">
               <a:ext uri="{FF2B5EF4-FFF2-40B4-BE49-F238E27FC236}">
-                <a16:creationId xmlns:a16="http://schemas.microsoft.com/office/drawing/2014/main" id="{003EBD7F-56CC-451B-8712-654AA7A2647D}"/>
+                <a16:creationId xmlns:a16="http://schemas.microsoft.com/office/drawing/2014/main" id="{FCEAE34D-B447-4BE0-9407-69CE0E58F38F}"/>
               </a:ext>
             </a:extLst>
           </p:cNvPr>
@@ -14306,7 +14306,7 @@
           <p:cNvPr id="36" name="">
             <a:extLst xmlns:a="http://schemas.openxmlformats.org/drawingml/2006/main">
               <a:ext uri="{FF2B5EF4-FFF2-40B4-BE49-F238E27FC236}">
-                <a16:creationId xmlns:a16="http://schemas.microsoft.com/office/drawing/2014/main" id="{25FC790A-E618-4B64-B8BF-3E90D2236DEA}"/>
+                <a16:creationId xmlns:a16="http://schemas.microsoft.com/office/drawing/2014/main" id="{E24A7684-B9CA-454F-8520-B7F9AC203A63}"/>
               </a:ext>
             </a:extLst>
           </p:cNvPr>
@@ -14370,7 +14370,7 @@
           <p:cNvPr id="37" name="">
             <a:extLst xmlns:a="http://schemas.openxmlformats.org/drawingml/2006/main">
               <a:ext uri="{FF2B5EF4-FFF2-40B4-BE49-F238E27FC236}">
-                <a16:creationId xmlns:a16="http://schemas.microsoft.com/office/drawing/2014/main" id="{A9DBB6B3-E647-4F3F-ADE2-71F5E9314FAA}"/>
+                <a16:creationId xmlns:a16="http://schemas.microsoft.com/office/drawing/2014/main" id="{FCDD5B09-EE13-4BAA-8873-7C862BFC396C}"/>
               </a:ext>
             </a:extLst>
           </p:cNvPr>
@@ -14462,7 +14462,7 @@
           <p:cNvPr id="38" name="">
             <a:extLst xmlns:a="http://schemas.openxmlformats.org/drawingml/2006/main">
               <a:ext uri="{FF2B5EF4-FFF2-40B4-BE49-F238E27FC236}">
-                <a16:creationId xmlns:a16="http://schemas.microsoft.com/office/drawing/2014/main" id="{856F9289-F1B8-4E67-929D-2D404A45220A}"/>
+                <a16:creationId xmlns:a16="http://schemas.microsoft.com/office/drawing/2014/main" id="{0A425B90-103D-4C0E-BE49-8FA906DD37A9}"/>
               </a:ext>
             </a:extLst>
           </p:cNvPr>
@@ -14495,7 +14495,7 @@
           <p:cNvPr id="39" name="">
             <a:extLst xmlns:a="http://schemas.openxmlformats.org/drawingml/2006/main">
               <a:ext uri="{FF2B5EF4-FFF2-40B4-BE49-F238E27FC236}">
-                <a16:creationId xmlns:a16="http://schemas.microsoft.com/office/drawing/2014/main" id="{2EE282F6-9523-4FD2-9B79-E59F714C6F31}"/>
+                <a16:creationId xmlns:a16="http://schemas.microsoft.com/office/drawing/2014/main" id="{AFB29729-4BB1-435F-937A-1A20874ADB8C}"/>
               </a:ext>
             </a:extLst>
           </p:cNvPr>
@@ -14582,7 +14582,7 @@
           <p:cNvPr id="40" name="">
             <a:extLst xmlns:a="http://schemas.openxmlformats.org/drawingml/2006/main">
               <a:ext uri="{FF2B5EF4-FFF2-40B4-BE49-F238E27FC236}">
-                <a16:creationId xmlns:a16="http://schemas.microsoft.com/office/drawing/2014/main" id="{E05F3CDF-16DC-4E38-8DAC-9CF4EF521696}"/>
+                <a16:creationId xmlns:a16="http://schemas.microsoft.com/office/drawing/2014/main" id="{FE3DF9BF-5996-41F1-A227-966B908DEF9B}"/>
               </a:ext>
             </a:extLst>
           </p:cNvPr>
@@ -14615,7 +14615,7 @@
           <p:cNvPr id="41" name="">
             <a:extLst xmlns:a="http://schemas.openxmlformats.org/drawingml/2006/main">
               <a:ext uri="{FF2B5EF4-FFF2-40B4-BE49-F238E27FC236}">
-                <a16:creationId xmlns:a16="http://schemas.microsoft.com/office/drawing/2014/main" id="{4207A309-B985-4348-B4FC-495F84C9BDD6}"/>
+                <a16:creationId xmlns:a16="http://schemas.microsoft.com/office/drawing/2014/main" id="{F7ED05C7-D068-41A2-99AA-1CDB93213CEE}"/>
               </a:ext>
             </a:extLst>
           </p:cNvPr>
@@ -14702,7 +14702,7 @@
           <p:cNvPr id="42" name="">
             <a:extLst xmlns:a="http://schemas.openxmlformats.org/drawingml/2006/main">
               <a:ext uri="{FF2B5EF4-FFF2-40B4-BE49-F238E27FC236}">
-                <a16:creationId xmlns:a16="http://schemas.microsoft.com/office/drawing/2014/main" id="{3F9F5993-1F6A-4875-B6D5-B48130AE7989}"/>
+                <a16:creationId xmlns:a16="http://schemas.microsoft.com/office/drawing/2014/main" id="{DD15F4EB-47C6-487A-99F6-F08D1B10DFBA}"/>
               </a:ext>
             </a:extLst>
           </p:cNvPr>
@@ -14735,7 +14735,7 @@
           <p:cNvPr id="43" name="">
             <a:extLst xmlns:a="http://schemas.openxmlformats.org/drawingml/2006/main">
               <a:ext uri="{FF2B5EF4-FFF2-40B4-BE49-F238E27FC236}">
-                <a16:creationId xmlns:a16="http://schemas.microsoft.com/office/drawing/2014/main" id="{95FFA083-05BC-4C44-98E8-191594648E7F}"/>
+                <a16:creationId xmlns:a16="http://schemas.microsoft.com/office/drawing/2014/main" id="{DD8A4265-43AA-42CC-BA6C-C1E8B6D02C20}"/>
               </a:ext>
             </a:extLst>
           </p:cNvPr>
@@ -14822,7 +14822,7 @@
           <p:cNvPr id="44" name="">
             <a:extLst xmlns:a="http://schemas.openxmlformats.org/drawingml/2006/main">
               <a:ext uri="{FF2B5EF4-FFF2-40B4-BE49-F238E27FC236}">
-                <a16:creationId xmlns:a16="http://schemas.microsoft.com/office/drawing/2014/main" id="{4D12DA9F-331D-4C17-B0DF-DA4747AE68C9}"/>
+                <a16:creationId xmlns:a16="http://schemas.microsoft.com/office/drawing/2014/main" id="{0D4EA5A3-07EA-4912-881A-F445BFC716BB}"/>
               </a:ext>
             </a:extLst>
           </p:cNvPr>
@@ -14857,7 +14857,7 @@
           <p:cNvPr id="45" name="">
             <a:extLst xmlns:a="http://schemas.openxmlformats.org/drawingml/2006/main">
               <a:ext uri="{FF2B5EF4-FFF2-40B4-BE49-F238E27FC236}">
-                <a16:creationId xmlns:a16="http://schemas.microsoft.com/office/drawing/2014/main" id="{FBD7B20E-9E33-4B72-8301-962DBC3519BA}"/>
+                <a16:creationId xmlns:a16="http://schemas.microsoft.com/office/drawing/2014/main" id="{38052FF5-3041-4B19-8D3E-DC9E27F6744F}"/>
               </a:ext>
             </a:extLst>
           </p:cNvPr>
@@ -14919,7 +14919,7 @@
     </p:spTree>
     <p:extLst>
       <p:ext uri="{BB962C8B-B14F-4D97-AF65-F5344CB8AC3E}">
-        <p14:creationId xmlns:p14="http://schemas.microsoft.com/office/powerpoint/2010/main" val="663448164"/>
+        <p14:creationId xmlns:p14="http://schemas.microsoft.com/office/powerpoint/2010/main" val="1578849301"/>
       </p:ext>
     </p:extLst>
   </p:cSld>
@@ -14943,7 +14943,7 @@
           <p:cNvPr id="1" name="">
             <a:extLst xmlns:a="http://schemas.openxmlformats.org/drawingml/2006/main">
               <a:ext uri="{FF2B5EF4-FFF2-40B4-BE49-F238E27FC236}">
-                <a16:creationId xmlns:a16="http://schemas.microsoft.com/office/drawing/2014/main" id="{04055697-AFB9-477A-9C07-DAEBF727B63C}"/>
+                <a16:creationId xmlns:a16="http://schemas.microsoft.com/office/drawing/2014/main" id="{D219D851-C268-4945-822E-3D2ED8452994}"/>
               </a:ext>
             </a:extLst>
           </p:cNvPr>
@@ -14978,7 +14978,7 @@
           <p:cNvPr id="2" name="">
             <a:extLst xmlns:a="http://schemas.openxmlformats.org/drawingml/2006/main">
               <a:ext uri="{FF2B5EF4-FFF2-40B4-BE49-F238E27FC236}">
-                <a16:creationId xmlns:a16="http://schemas.microsoft.com/office/drawing/2014/main" id="{BB3F108A-12BA-4462-B37F-44B88E419EB1}"/>
+                <a16:creationId xmlns:a16="http://schemas.microsoft.com/office/drawing/2014/main" id="{E0D0183F-0135-417C-B18A-C447DD0B8619}"/>
               </a:ext>
             </a:extLst>
           </p:cNvPr>
@@ -15013,7 +15013,7 @@
           <p:cNvPr id="3" name="">
             <a:extLst xmlns:a="http://schemas.openxmlformats.org/drawingml/2006/main">
               <a:ext uri="{FF2B5EF4-FFF2-40B4-BE49-F238E27FC236}">
-                <a16:creationId xmlns:a16="http://schemas.microsoft.com/office/drawing/2014/main" id="{DE2BCA70-1D79-4408-8F5C-DA62ED17B897}"/>
+                <a16:creationId xmlns:a16="http://schemas.microsoft.com/office/drawing/2014/main" id="{B640788A-5C79-4837-96AE-33C2C4CBF322}"/>
               </a:ext>
             </a:extLst>
           </p:cNvPr>
@@ -15048,7 +15048,7 @@
           <p:cNvPr id="4" name="">
             <a:extLst xmlns:a="http://schemas.openxmlformats.org/drawingml/2006/main">
               <a:ext uri="{FF2B5EF4-FFF2-40B4-BE49-F238E27FC236}">
-                <a16:creationId xmlns:a16="http://schemas.microsoft.com/office/drawing/2014/main" id="{941DECA2-5F27-4AD4-A5AD-C7D27019F57A}"/>
+                <a16:creationId xmlns:a16="http://schemas.microsoft.com/office/drawing/2014/main" id="{19721231-963C-447A-A63D-FD21321DE14F}"/>
               </a:ext>
             </a:extLst>
           </p:cNvPr>
@@ -15112,7 +15112,7 @@
           <p:cNvPr id="5" name="">
             <a:extLst xmlns:a="http://schemas.openxmlformats.org/drawingml/2006/main">
               <a:ext uri="{FF2B5EF4-FFF2-40B4-BE49-F238E27FC236}">
-                <a16:creationId xmlns:a16="http://schemas.microsoft.com/office/drawing/2014/main" id="{3B90AB30-7224-4724-8B6E-20255037BAE4}"/>
+                <a16:creationId xmlns:a16="http://schemas.microsoft.com/office/drawing/2014/main" id="{6C8D3DEA-2C43-4FA5-81EC-342FD3A2E6E4}"/>
               </a:ext>
             </a:extLst>
           </p:cNvPr>
@@ -15176,7 +15176,7 @@
           <p:cNvPr id="6" name="">
             <a:extLst xmlns:a="http://schemas.openxmlformats.org/drawingml/2006/main">
               <a:ext uri="{FF2B5EF4-FFF2-40B4-BE49-F238E27FC236}">
-                <a16:creationId xmlns:a16="http://schemas.microsoft.com/office/drawing/2014/main" id="{FB97B980-10F9-4CF0-8845-4CC5672FD6E2}"/>
+                <a16:creationId xmlns:a16="http://schemas.microsoft.com/office/drawing/2014/main" id="{0F613904-D9C0-4631-886C-700E9B64D800}"/>
               </a:ext>
             </a:extLst>
           </p:cNvPr>
@@ -15230,7 +15230,7 @@
                 <a:ea typeface="Hiragino Mincho ProN"/>
                 <a:cs typeface="Hiragino Mincho ProN"/>
               </a:rPr>
-              <a:t>次は四つの証拠で、採用・縮小・棄却を判定する</a:t>
+              <a:t>採用・縮小・棄却は、四つの証拠を見て決める</a:t>
             </a:r>
           </a:p>
         </p:txBody>
@@ -15240,7 +15240,7 @@
           <p:cNvPr id="7" name="">
             <a:extLst xmlns:a="http://schemas.openxmlformats.org/drawingml/2006/main">
               <a:ext uri="{FF2B5EF4-FFF2-40B4-BE49-F238E27FC236}">
-                <a16:creationId xmlns:a16="http://schemas.microsoft.com/office/drawing/2014/main" id="{6D3E89FC-72C8-44B4-B9E0-B38F562DDC6F}"/>
+                <a16:creationId xmlns:a16="http://schemas.microsoft.com/office/drawing/2014/main" id="{33B8F712-479A-4B7C-9C96-97310320E71D}"/>
               </a:ext>
             </a:extLst>
           </p:cNvPr>
@@ -15273,7 +15273,7 @@
           <p:cNvPr id="8" name="">
             <a:extLst xmlns:a="http://schemas.openxmlformats.org/drawingml/2006/main">
               <a:ext uri="{FF2B5EF4-FFF2-40B4-BE49-F238E27FC236}">
-                <a16:creationId xmlns:a16="http://schemas.microsoft.com/office/drawing/2014/main" id="{06B6BF95-9F49-4347-ACA0-D23C7D1C3093}"/>
+                <a16:creationId xmlns:a16="http://schemas.microsoft.com/office/drawing/2014/main" id="{71139D5C-4236-4D25-A593-3F015CFF1355}"/>
               </a:ext>
             </a:extLst>
           </p:cNvPr>
@@ -15308,7 +15308,7 @@
           <p:cNvPr id="9" name="">
             <a:extLst xmlns:a="http://schemas.openxmlformats.org/drawingml/2006/main">
               <a:ext uri="{FF2B5EF4-FFF2-40B4-BE49-F238E27FC236}">
-                <a16:creationId xmlns:a16="http://schemas.microsoft.com/office/drawing/2014/main" id="{962E2F2F-0381-42E9-932C-334B41215A80}"/>
+                <a16:creationId xmlns:a16="http://schemas.microsoft.com/office/drawing/2014/main" id="{0834A9DE-92D1-4388-9890-AB51F4E0F223}"/>
               </a:ext>
             </a:extLst>
           </p:cNvPr>
@@ -15362,7 +15362,7 @@
                 <a:ea typeface="Hiragino Sans"/>
                 <a:cs typeface="Hiragino Sans"/>
               </a:rPr>
-              <a:t>主張 | 検出精度だけで採用せず、offline比較、MNN parity、detector-data、10秒cadenceを同じゲートで見る。</a:t>
+              <a:t>主張 | 精度だけで採用せず、offline比較、MNN parity、detector-data、10秒cadenceを同じゲートで判定する。</a:t>
             </a:r>
           </a:p>
         </p:txBody>
@@ -15372,7 +15372,7 @@
           <p:cNvPr id="10" name="">
             <a:extLst xmlns:a="http://schemas.openxmlformats.org/drawingml/2006/main">
               <a:ext uri="{FF2B5EF4-FFF2-40B4-BE49-F238E27FC236}">
-                <a16:creationId xmlns:a16="http://schemas.microsoft.com/office/drawing/2014/main" id="{C4A1C8DC-E708-4A40-96CA-8BE4391ADB4B}"/>
+                <a16:creationId xmlns:a16="http://schemas.microsoft.com/office/drawing/2014/main" id="{DADB1798-9C82-448F-B0B0-08910D14016E}"/>
               </a:ext>
             </a:extLst>
           </p:cNvPr>
@@ -15405,7 +15405,7 @@
           <p:cNvPr id="11" name="">
             <a:extLst xmlns:a="http://schemas.openxmlformats.org/drawingml/2006/main">
               <a:ext uri="{FF2B5EF4-FFF2-40B4-BE49-F238E27FC236}">
-                <a16:creationId xmlns:a16="http://schemas.microsoft.com/office/drawing/2014/main" id="{0EC48194-5CCD-43AF-AE52-AEEE995F965E}"/>
+                <a16:creationId xmlns:a16="http://schemas.microsoft.com/office/drawing/2014/main" id="{B85A2D8C-AC8C-4D96-93F2-7CDB33C5A01D}"/>
               </a:ext>
             </a:extLst>
           </p:cNvPr>
@@ -15440,7 +15440,7 @@
           <p:cNvPr id="12" name="">
             <a:extLst xmlns:a="http://schemas.openxmlformats.org/drawingml/2006/main">
               <a:ext uri="{FF2B5EF4-FFF2-40B4-BE49-F238E27FC236}">
-                <a16:creationId xmlns:a16="http://schemas.microsoft.com/office/drawing/2014/main" id="{3190D5EE-8762-4CD7-919F-4213A9B10A7C}"/>
+                <a16:creationId xmlns:a16="http://schemas.microsoft.com/office/drawing/2014/main" id="{B4000EC9-EA1A-4534-A3C5-84FC408892DB}"/>
               </a:ext>
             </a:extLst>
           </p:cNvPr>
@@ -15504,7 +15504,7 @@
           <p:cNvPr id="13" name="">
             <a:extLst xmlns:a="http://schemas.openxmlformats.org/drawingml/2006/main">
               <a:ext uri="{FF2B5EF4-FFF2-40B4-BE49-F238E27FC236}">
-                <a16:creationId xmlns:a16="http://schemas.microsoft.com/office/drawing/2014/main" id="{29061DF0-0C50-4682-83C0-9983FB54E051}"/>
+                <a16:creationId xmlns:a16="http://schemas.microsoft.com/office/drawing/2014/main" id="{52C41200-A63F-40CD-AC25-6423AA9E537C}"/>
               </a:ext>
             </a:extLst>
           </p:cNvPr>
@@ -15537,7 +15537,7 @@
           <p:cNvPr id="14" name="">
             <a:extLst xmlns:a="http://schemas.openxmlformats.org/drawingml/2006/main">
               <a:ext uri="{FF2B5EF4-FFF2-40B4-BE49-F238E27FC236}">
-                <a16:creationId xmlns:a16="http://schemas.microsoft.com/office/drawing/2014/main" id="{01C46988-D1B9-48F1-A2F2-B0AEEDF052F6}"/>
+                <a16:creationId xmlns:a16="http://schemas.microsoft.com/office/drawing/2014/main" id="{39407177-0D32-49B5-AC91-54EC55C75726}"/>
               </a:ext>
             </a:extLst>
           </p:cNvPr>
@@ -15572,7 +15572,7 @@
           <p:cNvPr id="15" name="">
             <a:extLst xmlns:a="http://schemas.openxmlformats.org/drawingml/2006/main">
               <a:ext uri="{FF2B5EF4-FFF2-40B4-BE49-F238E27FC236}">
-                <a16:creationId xmlns:a16="http://schemas.microsoft.com/office/drawing/2014/main" id="{6B321F5C-7F4C-4E6D-9330-2C646402C861}"/>
+                <a16:creationId xmlns:a16="http://schemas.microsoft.com/office/drawing/2014/main" id="{8A1304A0-65B3-483D-BF57-DCE5D4E17A43}"/>
               </a:ext>
             </a:extLst>
           </p:cNvPr>
@@ -15636,7 +15636,7 @@
           <p:cNvPr id="16" name="">
             <a:extLst xmlns:a="http://schemas.openxmlformats.org/drawingml/2006/main">
               <a:ext uri="{FF2B5EF4-FFF2-40B4-BE49-F238E27FC236}">
-                <a16:creationId xmlns:a16="http://schemas.microsoft.com/office/drawing/2014/main" id="{FC8F1B17-66C8-4F00-852B-3C93523BBA22}"/>
+                <a16:creationId xmlns:a16="http://schemas.microsoft.com/office/drawing/2014/main" id="{6B3F27DA-8CF0-4B36-B81F-8C33C5EA3DD9}"/>
               </a:ext>
             </a:extLst>
           </p:cNvPr>
@@ -15700,7 +15700,7 @@
           <p:cNvPr id="17" name="">
             <a:extLst xmlns:a="http://schemas.openxmlformats.org/drawingml/2006/main">
               <a:ext uri="{FF2B5EF4-FFF2-40B4-BE49-F238E27FC236}">
-                <a16:creationId xmlns:a16="http://schemas.microsoft.com/office/drawing/2014/main" id="{9639652B-1073-42BE-8C2C-96890126A0CA}"/>
+                <a16:creationId xmlns:a16="http://schemas.microsoft.com/office/drawing/2014/main" id="{B7B5D510-D9BB-476A-9DED-0FA2A948018A}"/>
               </a:ext>
             </a:extLst>
           </p:cNvPr>
@@ -15735,7 +15735,7 @@
           <p:cNvPr id="18" name="">
             <a:extLst xmlns:a="http://schemas.openxmlformats.org/drawingml/2006/main">
               <a:ext uri="{FF2B5EF4-FFF2-40B4-BE49-F238E27FC236}">
-                <a16:creationId xmlns:a16="http://schemas.microsoft.com/office/drawing/2014/main" id="{D7623497-106B-4E97-9F7F-627178142F7A}"/>
+                <a16:creationId xmlns:a16="http://schemas.microsoft.com/office/drawing/2014/main" id="{1ED6AEA1-031A-403B-ADE0-ABF9F41C1311}"/>
               </a:ext>
             </a:extLst>
           </p:cNvPr>
@@ -15799,7 +15799,7 @@
           <p:cNvPr id="19" name="">
             <a:extLst xmlns:a="http://schemas.openxmlformats.org/drawingml/2006/main">
               <a:ext uri="{FF2B5EF4-FFF2-40B4-BE49-F238E27FC236}">
-                <a16:creationId xmlns:a16="http://schemas.microsoft.com/office/drawing/2014/main" id="{E1A209BF-6793-4D39-AAA0-C5F0B6857271}"/>
+                <a16:creationId xmlns:a16="http://schemas.microsoft.com/office/drawing/2014/main" id="{CEBA65B9-5A7A-41CD-ACAD-D41CC80B8A34}"/>
               </a:ext>
             </a:extLst>
           </p:cNvPr>
@@ -15832,7 +15832,7 @@
           <p:cNvPr id="20" name="">
             <a:extLst xmlns:a="http://schemas.openxmlformats.org/drawingml/2006/main">
               <a:ext uri="{FF2B5EF4-FFF2-40B4-BE49-F238E27FC236}">
-                <a16:creationId xmlns:a16="http://schemas.microsoft.com/office/drawing/2014/main" id="{B9BC71AF-8C9F-4F69-AFAF-62AEB8F2AD46}"/>
+                <a16:creationId xmlns:a16="http://schemas.microsoft.com/office/drawing/2014/main" id="{D61EA545-FF90-4C03-9D60-D32758147804}"/>
               </a:ext>
             </a:extLst>
           </p:cNvPr>
@@ -15867,7 +15867,7 @@
           <p:cNvPr id="21" name="">
             <a:extLst xmlns:a="http://schemas.openxmlformats.org/drawingml/2006/main">
               <a:ext uri="{FF2B5EF4-FFF2-40B4-BE49-F238E27FC236}">
-                <a16:creationId xmlns:a16="http://schemas.microsoft.com/office/drawing/2014/main" id="{D46B7954-86A4-4764-958B-83D9BAC62572}"/>
+                <a16:creationId xmlns:a16="http://schemas.microsoft.com/office/drawing/2014/main" id="{51C36C09-86CB-4897-A1A4-CE78DFF0B266}"/>
               </a:ext>
             </a:extLst>
           </p:cNvPr>
@@ -15931,7 +15931,7 @@
           <p:cNvPr id="22" name="">
             <a:extLst xmlns:a="http://schemas.openxmlformats.org/drawingml/2006/main">
               <a:ext uri="{FF2B5EF4-FFF2-40B4-BE49-F238E27FC236}">
-                <a16:creationId xmlns:a16="http://schemas.microsoft.com/office/drawing/2014/main" id="{419B8C2F-74FF-4E43-A0C2-C92B50268809}"/>
+                <a16:creationId xmlns:a16="http://schemas.microsoft.com/office/drawing/2014/main" id="{DA5E7BA7-064E-4F4C-A8DF-E359DABEF936}"/>
               </a:ext>
             </a:extLst>
           </p:cNvPr>
@@ -15995,7 +15995,7 @@
           <p:cNvPr id="23" name="">
             <a:extLst xmlns:a="http://schemas.openxmlformats.org/drawingml/2006/main">
               <a:ext uri="{FF2B5EF4-FFF2-40B4-BE49-F238E27FC236}">
-                <a16:creationId xmlns:a16="http://schemas.microsoft.com/office/drawing/2014/main" id="{32B99BF8-D163-49CE-B0A8-21963069DEE6}"/>
+                <a16:creationId xmlns:a16="http://schemas.microsoft.com/office/drawing/2014/main" id="{C54AEED5-5730-4606-9288-FC8F4ED53852}"/>
               </a:ext>
             </a:extLst>
           </p:cNvPr>
@@ -16030,7 +16030,7 @@
           <p:cNvPr id="24" name="">
             <a:extLst xmlns:a="http://schemas.openxmlformats.org/drawingml/2006/main">
               <a:ext uri="{FF2B5EF4-FFF2-40B4-BE49-F238E27FC236}">
-                <a16:creationId xmlns:a16="http://schemas.microsoft.com/office/drawing/2014/main" id="{C493A2F8-8000-4DAF-A602-56106F75EF85}"/>
+                <a16:creationId xmlns:a16="http://schemas.microsoft.com/office/drawing/2014/main" id="{DB599117-1D37-4198-9749-A2CF6337030F}"/>
               </a:ext>
             </a:extLst>
           </p:cNvPr>
@@ -16094,7 +16094,7 @@
           <p:cNvPr id="25" name="">
             <a:extLst xmlns:a="http://schemas.openxmlformats.org/drawingml/2006/main">
               <a:ext uri="{FF2B5EF4-FFF2-40B4-BE49-F238E27FC236}">
-                <a16:creationId xmlns:a16="http://schemas.microsoft.com/office/drawing/2014/main" id="{82665805-AEB5-46A7-8AFD-D3FE89FBBAF8}"/>
+                <a16:creationId xmlns:a16="http://schemas.microsoft.com/office/drawing/2014/main" id="{FB3F0E0D-72F8-43C0-9976-349E7B6CA4F2}"/>
               </a:ext>
             </a:extLst>
           </p:cNvPr>
@@ -16127,7 +16127,7 @@
           <p:cNvPr id="26" name="">
             <a:extLst xmlns:a="http://schemas.openxmlformats.org/drawingml/2006/main">
               <a:ext uri="{FF2B5EF4-FFF2-40B4-BE49-F238E27FC236}">
-                <a16:creationId xmlns:a16="http://schemas.microsoft.com/office/drawing/2014/main" id="{3CE10F81-96A1-48D3-B6D4-EE8877C88919}"/>
+                <a16:creationId xmlns:a16="http://schemas.microsoft.com/office/drawing/2014/main" id="{A5E9EFF7-B806-4935-BCB5-E0C953A8ED5A}"/>
               </a:ext>
             </a:extLst>
           </p:cNvPr>
@@ -16162,7 +16162,7 @@
           <p:cNvPr id="27" name="">
             <a:extLst xmlns:a="http://schemas.openxmlformats.org/drawingml/2006/main">
               <a:ext uri="{FF2B5EF4-FFF2-40B4-BE49-F238E27FC236}">
-                <a16:creationId xmlns:a16="http://schemas.microsoft.com/office/drawing/2014/main" id="{B1214062-8EAB-4FA3-8209-91AB240A28EB}"/>
+                <a16:creationId xmlns:a16="http://schemas.microsoft.com/office/drawing/2014/main" id="{0D3753B0-A4BF-4350-A483-50DA947699B7}"/>
               </a:ext>
             </a:extLst>
           </p:cNvPr>
@@ -16226,7 +16226,7 @@
           <p:cNvPr id="28" name="">
             <a:extLst xmlns:a="http://schemas.openxmlformats.org/drawingml/2006/main">
               <a:ext uri="{FF2B5EF4-FFF2-40B4-BE49-F238E27FC236}">
-                <a16:creationId xmlns:a16="http://schemas.microsoft.com/office/drawing/2014/main" id="{192B6DA9-9EBF-419D-BFE7-EA3873356190}"/>
+                <a16:creationId xmlns:a16="http://schemas.microsoft.com/office/drawing/2014/main" id="{C2BEEF70-4637-4B67-AD8F-0AA4F4CDDB69}"/>
               </a:ext>
             </a:extLst>
           </p:cNvPr>
@@ -16290,7 +16290,7 @@
           <p:cNvPr id="29" name="">
             <a:extLst xmlns:a="http://schemas.openxmlformats.org/drawingml/2006/main">
               <a:ext uri="{FF2B5EF4-FFF2-40B4-BE49-F238E27FC236}">
-                <a16:creationId xmlns:a16="http://schemas.microsoft.com/office/drawing/2014/main" id="{E88EC443-F49F-46FE-A741-ACB5E6DF1541}"/>
+                <a16:creationId xmlns:a16="http://schemas.microsoft.com/office/drawing/2014/main" id="{57565B24-875E-4F23-AD54-4573DF9D19A9}"/>
               </a:ext>
             </a:extLst>
           </p:cNvPr>
@@ -16325,7 +16325,7 @@
           <p:cNvPr id="30" name="">
             <a:extLst xmlns:a="http://schemas.openxmlformats.org/drawingml/2006/main">
               <a:ext uri="{FF2B5EF4-FFF2-40B4-BE49-F238E27FC236}">
-                <a16:creationId xmlns:a16="http://schemas.microsoft.com/office/drawing/2014/main" id="{C8263A20-CF10-476E-98BF-7998A99F1F36}"/>
+                <a16:creationId xmlns:a16="http://schemas.microsoft.com/office/drawing/2014/main" id="{5355D17A-8858-417F-8384-D42AD02C527F}"/>
               </a:ext>
             </a:extLst>
           </p:cNvPr>
@@ -16389,7 +16389,7 @@
           <p:cNvPr id="31" name="">
             <a:extLst xmlns:a="http://schemas.openxmlformats.org/drawingml/2006/main">
               <a:ext uri="{FF2B5EF4-FFF2-40B4-BE49-F238E27FC236}">
-                <a16:creationId xmlns:a16="http://schemas.microsoft.com/office/drawing/2014/main" id="{D2665343-06F7-4139-AA5F-B5B512696669}"/>
+                <a16:creationId xmlns:a16="http://schemas.microsoft.com/office/drawing/2014/main" id="{3B5321A8-1BFA-45CA-A286-F65D93E8FD71}"/>
               </a:ext>
             </a:extLst>
           </p:cNvPr>
@@ -16422,7 +16422,7 @@
           <p:cNvPr id="32" name="">
             <a:extLst xmlns:a="http://schemas.openxmlformats.org/drawingml/2006/main">
               <a:ext uri="{FF2B5EF4-FFF2-40B4-BE49-F238E27FC236}">
-                <a16:creationId xmlns:a16="http://schemas.microsoft.com/office/drawing/2014/main" id="{A2AFAF0B-02B3-4A86-AC4D-93B2AAF99CE4}"/>
+                <a16:creationId xmlns:a16="http://schemas.microsoft.com/office/drawing/2014/main" id="{89B47CC9-98C7-4A9D-8388-655FCE83E155}"/>
               </a:ext>
             </a:extLst>
           </p:cNvPr>
@@ -16457,7 +16457,7 @@
           <p:cNvPr id="33" name="">
             <a:extLst xmlns:a="http://schemas.openxmlformats.org/drawingml/2006/main">
               <a:ext uri="{FF2B5EF4-FFF2-40B4-BE49-F238E27FC236}">
-                <a16:creationId xmlns:a16="http://schemas.microsoft.com/office/drawing/2014/main" id="{4F051C17-A940-4601-AE9B-BBCF71B213CA}"/>
+                <a16:creationId xmlns:a16="http://schemas.microsoft.com/office/drawing/2014/main" id="{0B2DEF86-E6E6-4A2E-91E3-FA0B987F3136}"/>
               </a:ext>
             </a:extLst>
           </p:cNvPr>
@@ -16521,7 +16521,7 @@
           <p:cNvPr id="34" name="">
             <a:extLst xmlns:a="http://schemas.openxmlformats.org/drawingml/2006/main">
               <a:ext uri="{FF2B5EF4-FFF2-40B4-BE49-F238E27FC236}">
-                <a16:creationId xmlns:a16="http://schemas.microsoft.com/office/drawing/2014/main" id="{99BE0DF1-AFD9-4DFF-8374-997389C11B8E}"/>
+                <a16:creationId xmlns:a16="http://schemas.microsoft.com/office/drawing/2014/main" id="{D6C52683-6214-4F02-B56D-18BE4A5A1C0B}"/>
               </a:ext>
             </a:extLst>
           </p:cNvPr>
@@ -16585,7 +16585,7 @@
           <p:cNvPr id="35" name="">
             <a:extLst xmlns:a="http://schemas.openxmlformats.org/drawingml/2006/main">
               <a:ext uri="{FF2B5EF4-FFF2-40B4-BE49-F238E27FC236}">
-                <a16:creationId xmlns:a16="http://schemas.microsoft.com/office/drawing/2014/main" id="{0AC0D7C9-9931-4381-BBB6-B02086A3D311}"/>
+                <a16:creationId xmlns:a16="http://schemas.microsoft.com/office/drawing/2014/main" id="{923166DE-CE09-4B73-A0F4-BB0875203948}"/>
               </a:ext>
             </a:extLst>
           </p:cNvPr>
@@ -16618,7 +16618,7 @@
           <p:cNvPr id="36" name="">
             <a:extLst xmlns:a="http://schemas.openxmlformats.org/drawingml/2006/main">
               <a:ext uri="{FF2B5EF4-FFF2-40B4-BE49-F238E27FC236}">
-                <a16:creationId xmlns:a16="http://schemas.microsoft.com/office/drawing/2014/main" id="{AE842D23-9F2D-41A6-9366-E5CBEAA22E58}"/>
+                <a16:creationId xmlns:a16="http://schemas.microsoft.com/office/drawing/2014/main" id="{F9EC9212-A8E1-4B12-8594-810E8B94DD41}"/>
               </a:ext>
             </a:extLst>
           </p:cNvPr>
@@ -16653,7 +16653,7 @@
           <p:cNvPr id="37" name="">
             <a:extLst xmlns:a="http://schemas.openxmlformats.org/drawingml/2006/main">
               <a:ext uri="{FF2B5EF4-FFF2-40B4-BE49-F238E27FC236}">
-                <a16:creationId xmlns:a16="http://schemas.microsoft.com/office/drawing/2014/main" id="{E179AFD4-90C4-4F55-9E56-05D7D85C5F7D}"/>
+                <a16:creationId xmlns:a16="http://schemas.microsoft.com/office/drawing/2014/main" id="{EB9B1D21-F13F-4C9F-B9B1-8B8A890C1186}"/>
               </a:ext>
             </a:extLst>
           </p:cNvPr>
@@ -16717,7 +16717,7 @@
           <p:cNvPr id="38" name="">
             <a:extLst xmlns:a="http://schemas.openxmlformats.org/drawingml/2006/main">
               <a:ext uri="{FF2B5EF4-FFF2-40B4-BE49-F238E27FC236}">
-                <a16:creationId xmlns:a16="http://schemas.microsoft.com/office/drawing/2014/main" id="{D618AF41-4425-4985-9EB9-C2DD08682E79}"/>
+                <a16:creationId xmlns:a16="http://schemas.microsoft.com/office/drawing/2014/main" id="{0938DA30-BFE3-49AD-B0EB-C61B02491216}"/>
               </a:ext>
             </a:extLst>
           </p:cNvPr>
@@ -16781,7 +16781,7 @@
           <p:cNvPr id="39" name="">
             <a:extLst xmlns:a="http://schemas.openxmlformats.org/drawingml/2006/main">
               <a:ext uri="{FF2B5EF4-FFF2-40B4-BE49-F238E27FC236}">
-                <a16:creationId xmlns:a16="http://schemas.microsoft.com/office/drawing/2014/main" id="{88A7A107-810D-49AA-A759-40D216D92728}"/>
+                <a16:creationId xmlns:a16="http://schemas.microsoft.com/office/drawing/2014/main" id="{E46EAE50-CFBC-4E51-882D-B9F2D503964A}"/>
               </a:ext>
             </a:extLst>
           </p:cNvPr>
@@ -16814,7 +16814,7 @@
           <p:cNvPr id="40" name="">
             <a:extLst xmlns:a="http://schemas.openxmlformats.org/drawingml/2006/main">
               <a:ext uri="{FF2B5EF4-FFF2-40B4-BE49-F238E27FC236}">
-                <a16:creationId xmlns:a16="http://schemas.microsoft.com/office/drawing/2014/main" id="{D68A1550-3D35-42F4-B147-432919398912}"/>
+                <a16:creationId xmlns:a16="http://schemas.microsoft.com/office/drawing/2014/main" id="{61100B53-3341-4A35-9ED6-3C2D8FD9EDA7}"/>
               </a:ext>
             </a:extLst>
           </p:cNvPr>
@@ -16849,7 +16849,7 @@
           <p:cNvPr id="41" name="">
             <a:extLst xmlns:a="http://schemas.openxmlformats.org/drawingml/2006/main">
               <a:ext uri="{FF2B5EF4-FFF2-40B4-BE49-F238E27FC236}">
-                <a16:creationId xmlns:a16="http://schemas.microsoft.com/office/drawing/2014/main" id="{F947116E-7457-46D4-9A8D-4618B3B5B89D}"/>
+                <a16:creationId xmlns:a16="http://schemas.microsoft.com/office/drawing/2014/main" id="{BA4D3458-46CA-44CC-B341-683B5831161A}"/>
               </a:ext>
             </a:extLst>
           </p:cNvPr>
@@ -16913,7 +16913,7 @@
           <p:cNvPr id="42" name="">
             <a:extLst xmlns:a="http://schemas.openxmlformats.org/drawingml/2006/main">
               <a:ext uri="{FF2B5EF4-FFF2-40B4-BE49-F238E27FC236}">
-                <a16:creationId xmlns:a16="http://schemas.microsoft.com/office/drawing/2014/main" id="{EE72D0FC-1985-44DB-918D-0B94B93516D4}"/>
+                <a16:creationId xmlns:a16="http://schemas.microsoft.com/office/drawing/2014/main" id="{56B36CFE-AC42-4CF3-A725-91F776D189B9}"/>
               </a:ext>
             </a:extLst>
           </p:cNvPr>
@@ -16977,7 +16977,7 @@
           <p:cNvPr id="43" name="">
             <a:extLst xmlns:a="http://schemas.openxmlformats.org/drawingml/2006/main">
               <a:ext uri="{FF2B5EF4-FFF2-40B4-BE49-F238E27FC236}">
-                <a16:creationId xmlns:a16="http://schemas.microsoft.com/office/drawing/2014/main" id="{B74E951B-C661-4619-922D-31813C6B4C27}"/>
+                <a16:creationId xmlns:a16="http://schemas.microsoft.com/office/drawing/2014/main" id="{09A41A10-82C8-4C0A-B654-AE09C3A67229}"/>
               </a:ext>
             </a:extLst>
           </p:cNvPr>
@@ -17010,7 +17010,7 @@
           <p:cNvPr id="44" name="">
             <a:extLst xmlns:a="http://schemas.openxmlformats.org/drawingml/2006/main">
               <a:ext uri="{FF2B5EF4-FFF2-40B4-BE49-F238E27FC236}">
-                <a16:creationId xmlns:a16="http://schemas.microsoft.com/office/drawing/2014/main" id="{C888E931-E8BE-4654-8C63-061A0368E75D}"/>
+                <a16:creationId xmlns:a16="http://schemas.microsoft.com/office/drawing/2014/main" id="{48641F9A-B024-40DE-A7B4-6EB41CF97F79}"/>
               </a:ext>
             </a:extLst>
           </p:cNvPr>
@@ -17074,7 +17074,7 @@
           <p:cNvPr id="45" name="">
             <a:extLst xmlns:a="http://schemas.openxmlformats.org/drawingml/2006/main">
               <a:ext uri="{FF2B5EF4-FFF2-40B4-BE49-F238E27FC236}">
-                <a16:creationId xmlns:a16="http://schemas.microsoft.com/office/drawing/2014/main" id="{0D5C5720-A921-499E-ABD1-E17D5DA5BF2B}"/>
+                <a16:creationId xmlns:a16="http://schemas.microsoft.com/office/drawing/2014/main" id="{AC40A938-2441-4A17-B90B-3E43E777CDFF}"/>
               </a:ext>
             </a:extLst>
           </p:cNvPr>
@@ -17107,7 +17107,7 @@
           <p:cNvPr id="46" name="">
             <a:extLst xmlns:a="http://schemas.openxmlformats.org/drawingml/2006/main">
               <a:ext uri="{FF2B5EF4-FFF2-40B4-BE49-F238E27FC236}">
-                <a16:creationId xmlns:a16="http://schemas.microsoft.com/office/drawing/2014/main" id="{5D5F524C-2D5B-4F7D-B7C9-3AEFCE848570}"/>
+                <a16:creationId xmlns:a16="http://schemas.microsoft.com/office/drawing/2014/main" id="{2C5E4B4C-1396-43C6-BB3E-9E790508C627}"/>
               </a:ext>
             </a:extLst>
           </p:cNvPr>
@@ -17171,7 +17171,7 @@
           <p:cNvPr id="47" name="">
             <a:extLst xmlns:a="http://schemas.openxmlformats.org/drawingml/2006/main">
               <a:ext uri="{FF2B5EF4-FFF2-40B4-BE49-F238E27FC236}">
-                <a16:creationId xmlns:a16="http://schemas.microsoft.com/office/drawing/2014/main" id="{3D380019-F214-4181-AB05-DDCD34013CC7}"/>
+                <a16:creationId xmlns:a16="http://schemas.microsoft.com/office/drawing/2014/main" id="{3F48DAE2-A42E-4B98-949A-55C7896AB9D4}"/>
               </a:ext>
             </a:extLst>
           </p:cNvPr>
@@ -17206,7 +17206,7 @@
           <p:cNvPr id="48" name="">
             <a:extLst xmlns:a="http://schemas.openxmlformats.org/drawingml/2006/main">
               <a:ext uri="{FF2B5EF4-FFF2-40B4-BE49-F238E27FC236}">
-                <a16:creationId xmlns:a16="http://schemas.microsoft.com/office/drawing/2014/main" id="{6E579766-FE3E-4FE1-910F-993B0EB4AAF0}"/>
+                <a16:creationId xmlns:a16="http://schemas.microsoft.com/office/drawing/2014/main" id="{75CA69B1-839F-4177-9616-034C75C17D74}"/>
               </a:ext>
             </a:extLst>
           </p:cNvPr>
@@ -17268,7 +17268,7 @@
     </p:spTree>
     <p:extLst>
       <p:ext uri="{BB962C8B-B14F-4D97-AF65-F5344CB8AC3E}">
-        <p14:creationId xmlns:p14="http://schemas.microsoft.com/office/powerpoint/2010/main" val="1121555075"/>
+        <p14:creationId xmlns:p14="http://schemas.microsoft.com/office/powerpoint/2010/main" val="1159740903"/>
       </p:ext>
     </p:extLst>
   </p:cSld>

</xml_diff>

<commit_message>
Revise sponsor deck copy holistically
</commit_message>
<xml_diff>
--- a/paper/presentations/storage_embedded_ransomware_sponsor_brief.pptx
+++ b/paper/presentations/storage_embedded_ransomware_sponsor_brief.pptx
@@ -2,18 +2,18 @@
 <file path=ppt/presentation.xml><?xml version="1.0" encoding="utf-8"?>
 <p:presentation xmlns:p="http://schemas.openxmlformats.org/presentationml/2006/main">
   <p:sldMasterIdLst>
-    <p:sldMasterId xmlns:r="http://schemas.openxmlformats.org/officeDocument/2006/relationships" id="2147483648" r:id="Rcb2a0d22a58d4f32"/>
+    <p:sldMasterId xmlns:r="http://schemas.openxmlformats.org/officeDocument/2006/relationships" id="2147483648" r:id="Refa5429989e04617"/>
   </p:sldMasterIdLst>
   <p:notesMasterIdLst>
-    <p:notesMasterId xmlns:r="http://schemas.openxmlformats.org/officeDocument/2006/relationships" r:id="R8dd23756957546a0"/>
+    <p:notesMasterId xmlns:r="http://schemas.openxmlformats.org/officeDocument/2006/relationships" r:id="R63c90f5951514f82"/>
   </p:notesMasterIdLst>
   <p:sldIdLst>
-    <p:sldId xmlns:r="http://schemas.openxmlformats.org/officeDocument/2006/relationships" id="256" r:id="Rd6c62c6c98664170"/>
-    <p:sldId xmlns:r="http://schemas.openxmlformats.org/officeDocument/2006/relationships" id="257" r:id="Rbb2331d491024646"/>
-    <p:sldId xmlns:r="http://schemas.openxmlformats.org/officeDocument/2006/relationships" id="258" r:id="R9e0e869f9bcc48dd"/>
-    <p:sldId xmlns:r="http://schemas.openxmlformats.org/officeDocument/2006/relationships" id="259" r:id="R9a8d79fbd2aa4f29"/>
-    <p:sldId xmlns:r="http://schemas.openxmlformats.org/officeDocument/2006/relationships" id="260" r:id="R29dee7d4c15a44c8"/>
-    <p:sldId xmlns:r="http://schemas.openxmlformats.org/officeDocument/2006/relationships" id="261" r:id="R8738d942bfeb4b45"/>
+    <p:sldId xmlns:r="http://schemas.openxmlformats.org/officeDocument/2006/relationships" id="256" r:id="R908d88a1dd3b4890"/>
+    <p:sldId xmlns:r="http://schemas.openxmlformats.org/officeDocument/2006/relationships" id="257" r:id="R0d7b8333f2904b07"/>
+    <p:sldId xmlns:r="http://schemas.openxmlformats.org/officeDocument/2006/relationships" id="258" r:id="Rcf327c50fed94c2b"/>
+    <p:sldId xmlns:r="http://schemas.openxmlformats.org/officeDocument/2006/relationships" id="259" r:id="R5f644d036cac46e8"/>
+    <p:sldId xmlns:r="http://schemas.openxmlformats.org/officeDocument/2006/relationships" id="260" r:id="R6f6444dc432c4573"/>
+    <p:sldId xmlns:r="http://schemas.openxmlformats.org/officeDocument/2006/relationships" id="261" r:id="Re899cf594dea4cfb"/>
   </p:sldIdLst>
   <p:sldSz cx="12192000" cy="6858000"/>
   <p:notesSz cx="6858000" cy="9144000"/>
@@ -890,7 +890,7 @@
   </p:cSld>
   <p:clrMap bg1="lt1" tx1="dk1" bg2="lt2" tx2="dk2" accent1="accent1" accent2="accent2" accent3="accent3" accent4="accent4" accent5="accent5" accent6="accent6" hlink="hlink" folHlink="folHlink"/>
   <p:sldLayoutIdLst>
-    <p:sldLayoutId xmlns:r="http://schemas.openxmlformats.org/officeDocument/2006/relationships" id="2147483649" r:id="R5ecc10da0be948f6"/>
+    <p:sldLayoutId xmlns:r="http://schemas.openxmlformats.org/officeDocument/2006/relationships" id="2147483649" r:id="R6e954dae45284c16"/>
   </p:sldLayoutIdLst>
   <p:txStyles>
     <p:titleStyle>
@@ -1189,7 +1189,7 @@
           <p:cNvPr id="1" name="">
             <a:extLst xmlns:a="http://schemas.openxmlformats.org/drawingml/2006/main">
               <a:ext uri="{FF2B5EF4-FFF2-40B4-BE49-F238E27FC236}">
-                <a16:creationId xmlns:a16="http://schemas.microsoft.com/office/drawing/2014/main" id="{800C9D7C-CA41-4088-833E-1FCFB91EC430}"/>
+                <a16:creationId xmlns:a16="http://schemas.microsoft.com/office/drawing/2014/main" id="{D6226215-32CC-433B-9E9F-1A39AC5DA42A}"/>
               </a:ext>
             </a:extLst>
           </p:cNvPr>
@@ -1224,7 +1224,7 @@
           <p:cNvPr id="2" name="">
             <a:extLst xmlns:a="http://schemas.openxmlformats.org/drawingml/2006/main">
               <a:ext uri="{FF2B5EF4-FFF2-40B4-BE49-F238E27FC236}">
-                <a16:creationId xmlns:a16="http://schemas.microsoft.com/office/drawing/2014/main" id="{D0BCB888-07C8-4E23-BE30-959A2B45F0F5}"/>
+                <a16:creationId xmlns:a16="http://schemas.microsoft.com/office/drawing/2014/main" id="{CECCD30A-05D2-4302-A394-6524FBA6E235}"/>
               </a:ext>
             </a:extLst>
           </p:cNvPr>
@@ -1259,7 +1259,7 @@
           <p:cNvPr id="3" name="">
             <a:extLst xmlns:a="http://schemas.openxmlformats.org/drawingml/2006/main">
               <a:ext uri="{FF2B5EF4-FFF2-40B4-BE49-F238E27FC236}">
-                <a16:creationId xmlns:a16="http://schemas.microsoft.com/office/drawing/2014/main" id="{DFDAB935-DEEF-4BFB-96A7-2A2644B37F4A}"/>
+                <a16:creationId xmlns:a16="http://schemas.microsoft.com/office/drawing/2014/main" id="{A7F3A356-A05E-46C7-BDCE-309565D54F68}"/>
               </a:ext>
             </a:extLst>
           </p:cNvPr>
@@ -1294,7 +1294,7 @@
           <p:cNvPr id="4" name="">
             <a:extLst xmlns:a="http://schemas.openxmlformats.org/drawingml/2006/main">
               <a:ext uri="{FF2B5EF4-FFF2-40B4-BE49-F238E27FC236}">
-                <a16:creationId xmlns:a16="http://schemas.microsoft.com/office/drawing/2014/main" id="{542808FA-0D11-467C-B8DE-3CC4CF155132}"/>
+                <a16:creationId xmlns:a16="http://schemas.microsoft.com/office/drawing/2014/main" id="{7112C3CF-66F3-41A5-AB68-EF3EB3E28BC2}"/>
               </a:ext>
             </a:extLst>
           </p:cNvPr>
@@ -1358,7 +1358,7 @@
           <p:cNvPr id="5" name="">
             <a:extLst xmlns:a="http://schemas.openxmlformats.org/drawingml/2006/main">
               <a:ext uri="{FF2B5EF4-FFF2-40B4-BE49-F238E27FC236}">
-                <a16:creationId xmlns:a16="http://schemas.microsoft.com/office/drawing/2014/main" id="{5F6399FD-F136-4036-8344-91668FF64B6F}"/>
+                <a16:creationId xmlns:a16="http://schemas.microsoft.com/office/drawing/2014/main" id="{7AC6C725-5518-4940-9DC5-6EEB6F92A2BE}"/>
               </a:ext>
             </a:extLst>
           </p:cNvPr>
@@ -1422,7 +1422,7 @@
           <p:cNvPr id="6" name="">
             <a:extLst xmlns:a="http://schemas.openxmlformats.org/drawingml/2006/main">
               <a:ext uri="{FF2B5EF4-FFF2-40B4-BE49-F238E27FC236}">
-                <a16:creationId xmlns:a16="http://schemas.microsoft.com/office/drawing/2014/main" id="{C6FA4DBD-D97D-450A-B4BF-D9A5CC257440}"/>
+                <a16:creationId xmlns:a16="http://schemas.microsoft.com/office/drawing/2014/main" id="{637925B2-6A70-41B2-8AA7-A980B3143D1F}"/>
               </a:ext>
             </a:extLst>
           </p:cNvPr>
@@ -1458,7 +1458,7 @@
           <a:lstStyle xmlns:a="http://schemas.openxmlformats.org/drawingml/2006/main"/>
           <a:p xmlns:a="http://schemas.openxmlformats.org/drawingml/2006/main">
             <a:pPr algn="l">
-              <a:defRPr sz="2175" b="1">
+              <a:defRPr sz="2250" b="1">
                 <a:solidFill>
                   <a:srgbClr val="111827"/>
                 </a:solidFill>
@@ -1468,7 +1468,7 @@
               </a:defRPr>
             </a:pPr>
             <a:r>
-              <a:rPr sz="2175" b="1">
+              <a:rPr sz="2250" b="1">
                 <a:solidFill>
                   <a:srgbClr val="111827"/>
                 </a:solidFill>
@@ -1476,7 +1476,7 @@
                 <a:ea typeface="Hiragino Mincho ProN"/>
                 <a:cs typeface="Hiragino Mincho ProN"/>
               </a:rPr>
-              <a:t>観測範囲をブロックI/Oに絞り、入力として足りるかを測る</a:t>
+              <a:t>ブロックI/Oだけで、異常検知の入力を作れるかを測る</a:t>
             </a:r>
           </a:p>
         </p:txBody>
@@ -1486,7 +1486,7 @@
           <p:cNvPr id="7" name="">
             <a:extLst xmlns:a="http://schemas.openxmlformats.org/drawingml/2006/main">
               <a:ext uri="{FF2B5EF4-FFF2-40B4-BE49-F238E27FC236}">
-                <a16:creationId xmlns:a16="http://schemas.microsoft.com/office/drawing/2014/main" id="{0BE69A05-30D9-4446-9CDD-7674619AA878}"/>
+                <a16:creationId xmlns:a16="http://schemas.microsoft.com/office/drawing/2014/main" id="{FD8857AE-14F5-4967-839E-9D4329945BEE}"/>
               </a:ext>
             </a:extLst>
           </p:cNvPr>
@@ -1519,7 +1519,7 @@
           <p:cNvPr id="8" name="">
             <a:extLst xmlns:a="http://schemas.openxmlformats.org/drawingml/2006/main">
               <a:ext uri="{FF2B5EF4-FFF2-40B4-BE49-F238E27FC236}">
-                <a16:creationId xmlns:a16="http://schemas.microsoft.com/office/drawing/2014/main" id="{93BC5E10-97F5-462D-8B3D-D4B6DDD4C87D}"/>
+                <a16:creationId xmlns:a16="http://schemas.microsoft.com/office/drawing/2014/main" id="{49D44E73-CFE3-4A28-97D1-1492E48C9ADC}"/>
               </a:ext>
             </a:extLst>
           </p:cNvPr>
@@ -1554,7 +1554,7 @@
           <p:cNvPr id="9" name="">
             <a:extLst xmlns:a="http://schemas.openxmlformats.org/drawingml/2006/main">
               <a:ext uri="{FF2B5EF4-FFF2-40B4-BE49-F238E27FC236}">
-                <a16:creationId xmlns:a16="http://schemas.microsoft.com/office/drawing/2014/main" id="{CF7E9209-C83E-4201-97E3-DB26B96F4F63}"/>
+                <a16:creationId xmlns:a16="http://schemas.microsoft.com/office/drawing/2014/main" id="{860A1066-290C-4E2C-897C-8F6C31FA326F}"/>
               </a:ext>
             </a:extLst>
           </p:cNvPr>
@@ -1608,7 +1608,7 @@
                 <a:ea typeface="Hiragino Sans"/>
                 <a:cs typeface="Hiragino Sans"/>
               </a:rPr>
-              <a:t>主張 | プロセス名やファイルパスを使わず、要求メタデータだけでAE候補に渡す統計列を作れるかを検証する。</a:t>
+              <a:t>主張 | ファイルパスやプロセス名を使わず、要求時刻・read/write・LBA・lengthから10秒統計を作る。</a:t>
             </a:r>
           </a:p>
         </p:txBody>
@@ -1618,7 +1618,7 @@
           <p:cNvPr id="10" name="">
             <a:extLst xmlns:a="http://schemas.openxmlformats.org/drawingml/2006/main">
               <a:ext uri="{FF2B5EF4-FFF2-40B4-BE49-F238E27FC236}">
-                <a16:creationId xmlns:a16="http://schemas.microsoft.com/office/drawing/2014/main" id="{2AEA9F35-A8A3-457D-A041-949728628C73}"/>
+                <a16:creationId xmlns:a16="http://schemas.microsoft.com/office/drawing/2014/main" id="{B37D8C54-7FAE-4B9D-B86F-B100CC93E944}"/>
               </a:ext>
             </a:extLst>
           </p:cNvPr>
@@ -1651,7 +1651,7 @@
           <p:cNvPr id="11" name="">
             <a:extLst xmlns:a="http://schemas.openxmlformats.org/drawingml/2006/main">
               <a:ext uri="{FF2B5EF4-FFF2-40B4-BE49-F238E27FC236}">
-                <a16:creationId xmlns:a16="http://schemas.microsoft.com/office/drawing/2014/main" id="{B52520F7-E786-482F-900C-C402B66DC0C8}"/>
+                <a16:creationId xmlns:a16="http://schemas.microsoft.com/office/drawing/2014/main" id="{6B1EEFBF-7AA3-495A-BFE7-3FCB5D45D457}"/>
               </a:ext>
             </a:extLst>
           </p:cNvPr>
@@ -1686,7 +1686,7 @@
           <p:cNvPr id="12" name="">
             <a:extLst xmlns:a="http://schemas.openxmlformats.org/drawingml/2006/main">
               <a:ext uri="{FF2B5EF4-FFF2-40B4-BE49-F238E27FC236}">
-                <a16:creationId xmlns:a16="http://schemas.microsoft.com/office/drawing/2014/main" id="{975338CC-DF6C-4BB2-BF35-04A746661687}"/>
+                <a16:creationId xmlns:a16="http://schemas.microsoft.com/office/drawing/2014/main" id="{3B2AAB60-62C4-4017-8073-F120173D94B3}"/>
               </a:ext>
             </a:extLst>
           </p:cNvPr>
@@ -1721,7 +1721,7 @@
           <p:cNvPr id="13" name="">
             <a:extLst xmlns:a="http://schemas.openxmlformats.org/drawingml/2006/main">
               <a:ext uri="{FF2B5EF4-FFF2-40B4-BE49-F238E27FC236}">
-                <a16:creationId xmlns:a16="http://schemas.microsoft.com/office/drawing/2014/main" id="{2A905709-DEAE-49F5-84B9-38440980D6D5}"/>
+                <a16:creationId xmlns:a16="http://schemas.microsoft.com/office/drawing/2014/main" id="{1D44E384-9AFD-41B7-BAA7-BB91F366903A}"/>
               </a:ext>
             </a:extLst>
           </p:cNvPr>
@@ -1756,7 +1756,7 @@
           <p:cNvPr id="14" name="">
             <a:extLst xmlns:a="http://schemas.openxmlformats.org/drawingml/2006/main">
               <a:ext uri="{FF2B5EF4-FFF2-40B4-BE49-F238E27FC236}">
-                <a16:creationId xmlns:a16="http://schemas.microsoft.com/office/drawing/2014/main" id="{54686577-3B1E-4016-83C4-87516DC10F30}"/>
+                <a16:creationId xmlns:a16="http://schemas.microsoft.com/office/drawing/2014/main" id="{3FF316A9-AD11-4DBC-99B4-5B674F726B0E}"/>
               </a:ext>
             </a:extLst>
           </p:cNvPr>
@@ -1791,7 +1791,7 @@
           <p:cNvPr id="15" name="">
             <a:extLst xmlns:a="http://schemas.openxmlformats.org/drawingml/2006/main">
               <a:ext uri="{FF2B5EF4-FFF2-40B4-BE49-F238E27FC236}">
-                <a16:creationId xmlns:a16="http://schemas.microsoft.com/office/drawing/2014/main" id="{1C75B3E6-EE87-4853-94D5-4B3B7C0AD260}"/>
+                <a16:creationId xmlns:a16="http://schemas.microsoft.com/office/drawing/2014/main" id="{37E7D7C0-7846-46F9-97F2-EF3E33357CAC}"/>
               </a:ext>
             </a:extLst>
           </p:cNvPr>
@@ -1826,7 +1826,7 @@
           <p:cNvPr id="16" name="">
             <a:extLst xmlns:a="http://schemas.openxmlformats.org/drawingml/2006/main">
               <a:ext uri="{FF2B5EF4-FFF2-40B4-BE49-F238E27FC236}">
-                <a16:creationId xmlns:a16="http://schemas.microsoft.com/office/drawing/2014/main" id="{EAA41593-1F9E-4D17-ACF5-FCC2AB098FAB}"/>
+                <a16:creationId xmlns:a16="http://schemas.microsoft.com/office/drawing/2014/main" id="{66B107D3-CDC4-43BE-AD9A-3D0EA1373994}"/>
               </a:ext>
             </a:extLst>
           </p:cNvPr>
@@ -1861,7 +1861,7 @@
           <p:cNvPr id="17" name="">
             <a:extLst xmlns:a="http://schemas.openxmlformats.org/drawingml/2006/main">
               <a:ext uri="{FF2B5EF4-FFF2-40B4-BE49-F238E27FC236}">
-                <a16:creationId xmlns:a16="http://schemas.microsoft.com/office/drawing/2014/main" id="{418B3833-787C-41DF-A76C-BDB21935C9A8}"/>
+                <a16:creationId xmlns:a16="http://schemas.microsoft.com/office/drawing/2014/main" id="{FAA638DE-5271-4309-840B-0F7DF17E50B3}"/>
               </a:ext>
             </a:extLst>
           </p:cNvPr>
@@ -1896,7 +1896,7 @@
           <p:cNvPr id="18" name="">
             <a:extLst xmlns:a="http://schemas.openxmlformats.org/drawingml/2006/main">
               <a:ext uri="{FF2B5EF4-FFF2-40B4-BE49-F238E27FC236}">
-                <a16:creationId xmlns:a16="http://schemas.microsoft.com/office/drawing/2014/main" id="{2A770C9B-375A-4B6F-9E1A-F4EB96F90DB1}"/>
+                <a16:creationId xmlns:a16="http://schemas.microsoft.com/office/drawing/2014/main" id="{BE86B6D7-5D4E-42C8-AD2E-7357FE7022FF}"/>
               </a:ext>
             </a:extLst>
           </p:cNvPr>
@@ -1931,7 +1931,7 @@
           <p:cNvPr id="19" name="">
             <a:extLst xmlns:a="http://schemas.openxmlformats.org/drawingml/2006/main">
               <a:ext uri="{FF2B5EF4-FFF2-40B4-BE49-F238E27FC236}">
-                <a16:creationId xmlns:a16="http://schemas.microsoft.com/office/drawing/2014/main" id="{39098D06-760B-4E1F-B6A1-0645449E9106}"/>
+                <a16:creationId xmlns:a16="http://schemas.microsoft.com/office/drawing/2014/main" id="{128C1CB0-F138-462C-8922-CFDB36524BF9}"/>
               </a:ext>
             </a:extLst>
           </p:cNvPr>
@@ -1966,7 +1966,7 @@
           <p:cNvPr id="20" name="">
             <a:extLst xmlns:a="http://schemas.openxmlformats.org/drawingml/2006/main">
               <a:ext uri="{FF2B5EF4-FFF2-40B4-BE49-F238E27FC236}">
-                <a16:creationId xmlns:a16="http://schemas.microsoft.com/office/drawing/2014/main" id="{18337938-EC15-41E9-B828-B377CC135E1E}"/>
+                <a16:creationId xmlns:a16="http://schemas.microsoft.com/office/drawing/2014/main" id="{0C636E23-E80C-4ABE-94AB-24E3BF3BAE38}"/>
               </a:ext>
             </a:extLst>
           </p:cNvPr>
@@ -2001,7 +2001,7 @@
           <p:cNvPr id="21" name="">
             <a:extLst xmlns:a="http://schemas.openxmlformats.org/drawingml/2006/main">
               <a:ext uri="{FF2B5EF4-FFF2-40B4-BE49-F238E27FC236}">
-                <a16:creationId xmlns:a16="http://schemas.microsoft.com/office/drawing/2014/main" id="{A9797695-55D0-45B6-9991-4B403F694271}"/>
+                <a16:creationId xmlns:a16="http://schemas.microsoft.com/office/drawing/2014/main" id="{D620C7CA-9BCF-4AE8-8F19-858FC224BC02}"/>
               </a:ext>
             </a:extLst>
           </p:cNvPr>
@@ -2036,7 +2036,7 @@
           <p:cNvPr id="22" name="">
             <a:extLst xmlns:a="http://schemas.openxmlformats.org/drawingml/2006/main">
               <a:ext uri="{FF2B5EF4-FFF2-40B4-BE49-F238E27FC236}">
-                <a16:creationId xmlns:a16="http://schemas.microsoft.com/office/drawing/2014/main" id="{4418951B-B29C-4A26-A229-9883CD3E1D70}"/>
+                <a16:creationId xmlns:a16="http://schemas.microsoft.com/office/drawing/2014/main" id="{2E993683-A185-4A45-B469-F811D69012EA}"/>
               </a:ext>
             </a:extLst>
           </p:cNvPr>
@@ -2071,7 +2071,7 @@
           <p:cNvPr id="23" name="">
             <a:extLst xmlns:a="http://schemas.openxmlformats.org/drawingml/2006/main">
               <a:ext uri="{FF2B5EF4-FFF2-40B4-BE49-F238E27FC236}">
-                <a16:creationId xmlns:a16="http://schemas.microsoft.com/office/drawing/2014/main" id="{6C34E2C6-6AE7-47BA-B0A1-AB1ADCB98839}"/>
+                <a16:creationId xmlns:a16="http://schemas.microsoft.com/office/drawing/2014/main" id="{5BB549F0-DDDD-4869-A98A-E611F31336F9}"/>
               </a:ext>
             </a:extLst>
           </p:cNvPr>
@@ -2104,7 +2104,7 @@
           <p:cNvPr id="24" name="">
             <a:extLst xmlns:a="http://schemas.openxmlformats.org/drawingml/2006/main">
               <a:ext uri="{FF2B5EF4-FFF2-40B4-BE49-F238E27FC236}">
-                <a16:creationId xmlns:a16="http://schemas.microsoft.com/office/drawing/2014/main" id="{DF616FDF-2513-4883-8EDF-E3A2AE448536}"/>
+                <a16:creationId xmlns:a16="http://schemas.microsoft.com/office/drawing/2014/main" id="{A32411CA-A0FC-4C70-A7B6-9C89DEB8617B}"/>
               </a:ext>
             </a:extLst>
           </p:cNvPr>
@@ -2139,7 +2139,7 @@
           <p:cNvPr id="25" name="">
             <a:extLst xmlns:a="http://schemas.openxmlformats.org/drawingml/2006/main">
               <a:ext uri="{FF2B5EF4-FFF2-40B4-BE49-F238E27FC236}">
-                <a16:creationId xmlns:a16="http://schemas.microsoft.com/office/drawing/2014/main" id="{74D5DEA3-4136-45FA-814C-B7EC6A4774BA}"/>
+                <a16:creationId xmlns:a16="http://schemas.microsoft.com/office/drawing/2014/main" id="{F58ED037-DD99-4F75-B12E-77FF72798330}"/>
               </a:ext>
             </a:extLst>
           </p:cNvPr>
@@ -2193,7 +2193,7 @@
                 <a:ea typeface="Hiragino Sans"/>
                 <a:cs typeface="Hiragino Sans"/>
               </a:rPr>
-              <a:t>観測は装置境界で安く取れる情報だけ</a:t>
+              <a:t>観測は装置境界で取れる軽量メタデータだけ</a:t>
             </a:r>
           </a:p>
         </p:txBody>
@@ -2203,7 +2203,7 @@
           <p:cNvPr id="26" name="">
             <a:extLst xmlns:a="http://schemas.openxmlformats.org/drawingml/2006/main">
               <a:ext uri="{FF2B5EF4-FFF2-40B4-BE49-F238E27FC236}">
-                <a16:creationId xmlns:a16="http://schemas.microsoft.com/office/drawing/2014/main" id="{BCC026DF-6B68-4613-B7C9-5862D5A5FF6A}"/>
+                <a16:creationId xmlns:a16="http://schemas.microsoft.com/office/drawing/2014/main" id="{72CA17B0-3290-49FF-A861-27896FE79E55}"/>
               </a:ext>
             </a:extLst>
           </p:cNvPr>
@@ -2236,7 +2236,7 @@
           <p:cNvPr id="27" name="">
             <a:extLst xmlns:a="http://schemas.openxmlformats.org/drawingml/2006/main">
               <a:ext uri="{FF2B5EF4-FFF2-40B4-BE49-F238E27FC236}">
-                <a16:creationId xmlns:a16="http://schemas.microsoft.com/office/drawing/2014/main" id="{C04A9E0E-5361-4BB0-AA8A-073C089CB108}"/>
+                <a16:creationId xmlns:a16="http://schemas.microsoft.com/office/drawing/2014/main" id="{D8DA1E66-FA68-4577-B3B0-99CA2ACCF535}"/>
               </a:ext>
             </a:extLst>
           </p:cNvPr>
@@ -2300,7 +2300,7 @@
           <p:cNvPr id="28" name="">
             <a:extLst xmlns:a="http://schemas.openxmlformats.org/drawingml/2006/main">
               <a:ext uri="{FF2B5EF4-FFF2-40B4-BE49-F238E27FC236}">
-                <a16:creationId xmlns:a16="http://schemas.microsoft.com/office/drawing/2014/main" id="{75915CDE-118F-438E-B321-0F497DFC27D2}"/>
+                <a16:creationId xmlns:a16="http://schemas.microsoft.com/office/drawing/2014/main" id="{905CF6BB-CECB-48EC-A481-02EB0380BF42}"/>
               </a:ext>
             </a:extLst>
           </p:cNvPr>
@@ -2354,7 +2354,7 @@
                 <a:ea typeface="Hiragino Sans"/>
                 <a:cs typeface="Hiragino Sans"/>
               </a:rPr>
-              <a:t>アプリやOSの詳細には依存しない</a:t>
+              <a:t>アプリ/OS詳細に依存しない</a:t>
             </a:r>
           </a:p>
         </p:txBody>
@@ -2364,7 +2364,7 @@
           <p:cNvPr id="29" name="">
             <a:extLst xmlns:a="http://schemas.openxmlformats.org/drawingml/2006/main">
               <a:ext uri="{FF2B5EF4-FFF2-40B4-BE49-F238E27FC236}">
-                <a16:creationId xmlns:a16="http://schemas.microsoft.com/office/drawing/2014/main" id="{425BAAA4-4CB3-47C4-A9E0-228E144376FA}"/>
+                <a16:creationId xmlns:a16="http://schemas.microsoft.com/office/drawing/2014/main" id="{71C906A9-70B2-4CD7-983F-6EE7FB21FFAC}"/>
               </a:ext>
             </a:extLst>
           </p:cNvPr>
@@ -2399,7 +2399,7 @@
           <p:cNvPr id="30" name="">
             <a:extLst xmlns:a="http://schemas.openxmlformats.org/drawingml/2006/main">
               <a:ext uri="{FF2B5EF4-FFF2-40B4-BE49-F238E27FC236}">
-                <a16:creationId xmlns:a16="http://schemas.microsoft.com/office/drawing/2014/main" id="{FF0AD81F-0A82-484D-A95C-BCA3A157133A}"/>
+                <a16:creationId xmlns:a16="http://schemas.microsoft.com/office/drawing/2014/main" id="{2B61C876-BDEB-4080-B703-8AEDEE5491FA}"/>
               </a:ext>
             </a:extLst>
           </p:cNvPr>
@@ -2463,7 +2463,7 @@
           <p:cNvPr id="31" name="">
             <a:extLst xmlns:a="http://schemas.openxmlformats.org/drawingml/2006/main">
               <a:ext uri="{FF2B5EF4-FFF2-40B4-BE49-F238E27FC236}">
-                <a16:creationId xmlns:a16="http://schemas.microsoft.com/office/drawing/2014/main" id="{87956898-E625-4950-8050-2A2B11972FC6}"/>
+                <a16:creationId xmlns:a16="http://schemas.microsoft.com/office/drawing/2014/main" id="{A70AC1B5-0B8D-4661-B571-B88A34E9AC63}"/>
               </a:ext>
             </a:extLst>
           </p:cNvPr>
@@ -2496,7 +2496,7 @@
           <p:cNvPr id="32" name="">
             <a:extLst xmlns:a="http://schemas.openxmlformats.org/drawingml/2006/main">
               <a:ext uri="{FF2B5EF4-FFF2-40B4-BE49-F238E27FC236}">
-                <a16:creationId xmlns:a16="http://schemas.microsoft.com/office/drawing/2014/main" id="{9F1D281C-9B03-444C-9A41-5A83E42C0FAB}"/>
+                <a16:creationId xmlns:a16="http://schemas.microsoft.com/office/drawing/2014/main" id="{926E3D9B-FA8E-482E-830A-70C2A945FAFF}"/>
               </a:ext>
             </a:extLst>
           </p:cNvPr>
@@ -2531,7 +2531,7 @@
           <p:cNvPr id="33" name="">
             <a:extLst xmlns:a="http://schemas.openxmlformats.org/drawingml/2006/main">
               <a:ext uri="{FF2B5EF4-FFF2-40B4-BE49-F238E27FC236}">
-                <a16:creationId xmlns:a16="http://schemas.microsoft.com/office/drawing/2014/main" id="{2B64E4D6-0369-42B3-84F5-FD0ECD2E57B9}"/>
+                <a16:creationId xmlns:a16="http://schemas.microsoft.com/office/drawing/2014/main" id="{15011D33-A7E0-4F73-8254-545321056412}"/>
               </a:ext>
             </a:extLst>
           </p:cNvPr>
@@ -2595,7 +2595,7 @@
           <p:cNvPr id="34" name="">
             <a:extLst xmlns:a="http://schemas.openxmlformats.org/drawingml/2006/main">
               <a:ext uri="{FF2B5EF4-FFF2-40B4-BE49-F238E27FC236}">
-                <a16:creationId xmlns:a16="http://schemas.microsoft.com/office/drawing/2014/main" id="{D3F622D2-AB9E-4F9D-99BC-5F4B76396262}"/>
+                <a16:creationId xmlns:a16="http://schemas.microsoft.com/office/drawing/2014/main" id="{28E3DA3E-C9EE-4F66-BACF-FA3988AA25EC}"/>
               </a:ext>
             </a:extLst>
           </p:cNvPr>
@@ -2672,7 +2672,7 @@
                 <a:ea typeface="Hiragino Sans"/>
                 <a:cs typeface="Hiragino Sans"/>
               </a:rPr>
-              <a:t>などを受ける境界</a:t>
+              <a:t>を受ける境界</a:t>
             </a:r>
           </a:p>
         </p:txBody>
@@ -2682,7 +2682,7 @@
           <p:cNvPr id="35" name="">
             <a:extLst xmlns:a="http://schemas.openxmlformats.org/drawingml/2006/main">
               <a:ext uri="{FF2B5EF4-FFF2-40B4-BE49-F238E27FC236}">
-                <a16:creationId xmlns:a16="http://schemas.microsoft.com/office/drawing/2014/main" id="{D153C585-9D7D-4A9A-A365-3A8769E49148}"/>
+                <a16:creationId xmlns:a16="http://schemas.microsoft.com/office/drawing/2014/main" id="{43A335BE-1B70-4729-86E5-2E588E5FA407}"/>
               </a:ext>
             </a:extLst>
           </p:cNvPr>
@@ -2717,7 +2717,7 @@
           <p:cNvPr id="36" name="">
             <a:extLst xmlns:a="http://schemas.openxmlformats.org/drawingml/2006/main">
               <a:ext uri="{FF2B5EF4-FFF2-40B4-BE49-F238E27FC236}">
-                <a16:creationId xmlns:a16="http://schemas.microsoft.com/office/drawing/2014/main" id="{9D844828-8EE2-4007-8B27-5AA1848E6FCF}"/>
+                <a16:creationId xmlns:a16="http://schemas.microsoft.com/office/drawing/2014/main" id="{851D9FBF-C913-4465-8AF0-42CC83ED5E33}"/>
               </a:ext>
             </a:extLst>
           </p:cNvPr>
@@ -2781,7 +2781,7 @@
           <p:cNvPr id="37" name="">
             <a:extLst xmlns:a="http://schemas.openxmlformats.org/drawingml/2006/main">
               <a:ext uri="{FF2B5EF4-FFF2-40B4-BE49-F238E27FC236}">
-                <a16:creationId xmlns:a16="http://schemas.microsoft.com/office/drawing/2014/main" id="{3C4858C5-1376-408A-977E-47D33EFF8CE1}"/>
+                <a16:creationId xmlns:a16="http://schemas.microsoft.com/office/drawing/2014/main" id="{BAFD633B-7CBC-4ED9-A4C0-4987EDF375D9}"/>
               </a:ext>
             </a:extLst>
           </p:cNvPr>
@@ -2814,7 +2814,7 @@
           <p:cNvPr id="38" name="">
             <a:extLst xmlns:a="http://schemas.openxmlformats.org/drawingml/2006/main">
               <a:ext uri="{FF2B5EF4-FFF2-40B4-BE49-F238E27FC236}">
-                <a16:creationId xmlns:a16="http://schemas.microsoft.com/office/drawing/2014/main" id="{7F63C85C-557C-40EA-9F6D-3B4F20C4436C}"/>
+                <a16:creationId xmlns:a16="http://schemas.microsoft.com/office/drawing/2014/main" id="{6D8FAB6D-887A-40CF-8621-3E1B84BA54D4}"/>
               </a:ext>
             </a:extLst>
           </p:cNvPr>
@@ -2878,7 +2878,7 @@
           <p:cNvPr id="39" name="">
             <a:extLst xmlns:a="http://schemas.openxmlformats.org/drawingml/2006/main">
               <a:ext uri="{FF2B5EF4-FFF2-40B4-BE49-F238E27FC236}">
-                <a16:creationId xmlns:a16="http://schemas.microsoft.com/office/drawing/2014/main" id="{0E66A6DE-E480-4BBB-B772-137E72212C43}"/>
+                <a16:creationId xmlns:a16="http://schemas.microsoft.com/office/drawing/2014/main" id="{572C1121-A1E2-4589-A224-E346481ED0E6}"/>
               </a:ext>
             </a:extLst>
           </p:cNvPr>
@@ -2932,7 +2932,7 @@
                 <a:ea typeface="Hiragino Sans"/>
                 <a:cs typeface="Hiragino Sans"/>
               </a:rPr>
-              <a:t>多数volumeを10秒cadenceで見る</a:t>
+              <a:t>多数ボリュームを10秒間隔で見る</a:t>
             </a:r>
           </a:p>
         </p:txBody>
@@ -2942,7 +2942,7 @@
           <p:cNvPr id="40" name="">
             <a:extLst xmlns:a="http://schemas.openxmlformats.org/drawingml/2006/main">
               <a:ext uri="{FF2B5EF4-FFF2-40B4-BE49-F238E27FC236}">
-                <a16:creationId xmlns:a16="http://schemas.microsoft.com/office/drawing/2014/main" id="{3EE0985A-8D36-4497-99C8-55DDDAEE520F}"/>
+                <a16:creationId xmlns:a16="http://schemas.microsoft.com/office/drawing/2014/main" id="{D0D16A06-AB82-4432-AFEB-52AB12A120B0}"/>
               </a:ext>
             </a:extLst>
           </p:cNvPr>
@@ -2975,7 +2975,7 @@
           <p:cNvPr id="41" name="">
             <a:extLst xmlns:a="http://schemas.openxmlformats.org/drawingml/2006/main">
               <a:ext uri="{FF2B5EF4-FFF2-40B4-BE49-F238E27FC236}">
-                <a16:creationId xmlns:a16="http://schemas.microsoft.com/office/drawing/2014/main" id="{7D7786E8-F478-49B1-AA0B-BE54CF7E8E32}"/>
+                <a16:creationId xmlns:a16="http://schemas.microsoft.com/office/drawing/2014/main" id="{7AFD6394-3857-4948-82ED-93A7B79CA918}"/>
               </a:ext>
             </a:extLst>
           </p:cNvPr>
@@ -3010,7 +3010,7 @@
           <p:cNvPr id="42" name="">
             <a:extLst xmlns:a="http://schemas.openxmlformats.org/drawingml/2006/main">
               <a:ext uri="{FF2B5EF4-FFF2-40B4-BE49-F238E27FC236}">
-                <a16:creationId xmlns:a16="http://schemas.microsoft.com/office/drawing/2014/main" id="{716D27DD-073B-4699-968F-B123E39BD44E}"/>
+                <a16:creationId xmlns:a16="http://schemas.microsoft.com/office/drawing/2014/main" id="{53A40553-2714-4EFD-B5EE-241B2D45B75E}"/>
               </a:ext>
             </a:extLst>
           </p:cNvPr>
@@ -3074,7 +3074,7 @@
           <p:cNvPr id="43" name="">
             <a:extLst xmlns:a="http://schemas.openxmlformats.org/drawingml/2006/main">
               <a:ext uri="{FF2B5EF4-FFF2-40B4-BE49-F238E27FC236}">
-                <a16:creationId xmlns:a16="http://schemas.microsoft.com/office/drawing/2014/main" id="{A9F61BF5-63F3-4B63-8C20-9B951CDCF0E2}"/>
+                <a16:creationId xmlns:a16="http://schemas.microsoft.com/office/drawing/2014/main" id="{0C455D0B-F6C4-423F-84FA-ECF9B34CDD7D}"/>
               </a:ext>
             </a:extLst>
           </p:cNvPr>
@@ -3107,7 +3107,7 @@
           <p:cNvPr id="44" name="">
             <a:extLst xmlns:a="http://schemas.openxmlformats.org/drawingml/2006/main">
               <a:ext uri="{FF2B5EF4-FFF2-40B4-BE49-F238E27FC236}">
-                <a16:creationId xmlns:a16="http://schemas.microsoft.com/office/drawing/2014/main" id="{C2CEDD2F-64EB-41EC-AE7B-12E15351A02B}"/>
+                <a16:creationId xmlns:a16="http://schemas.microsoft.com/office/drawing/2014/main" id="{702BDB6E-5668-4193-BCE4-2918120438C7}"/>
               </a:ext>
             </a:extLst>
           </p:cNvPr>
@@ -3184,7 +3184,7 @@
                 <a:ea typeface="Hiragino Sans"/>
                 <a:cs typeface="Hiragino Sans"/>
               </a:rPr>
-              <a:t>安いcounter集計</a:t>
+              <a:t>軽量カウンタ集計</a:t>
             </a:r>
           </a:p>
         </p:txBody>
@@ -3194,7 +3194,7 @@
           <p:cNvPr id="45" name="">
             <a:extLst xmlns:a="http://schemas.openxmlformats.org/drawingml/2006/main">
               <a:ext uri="{FF2B5EF4-FFF2-40B4-BE49-F238E27FC236}">
-                <a16:creationId xmlns:a16="http://schemas.microsoft.com/office/drawing/2014/main" id="{97C08E20-B5C6-416C-ADC1-3AF2C778ECBF}"/>
+                <a16:creationId xmlns:a16="http://schemas.microsoft.com/office/drawing/2014/main" id="{C77B705D-4A38-498E-B083-08B9A43F4A31}"/>
               </a:ext>
             </a:extLst>
           </p:cNvPr>
@@ -3227,7 +3227,7 @@
           <p:cNvPr id="46" name="">
             <a:extLst xmlns:a="http://schemas.openxmlformats.org/drawingml/2006/main">
               <a:ext uri="{FF2B5EF4-FFF2-40B4-BE49-F238E27FC236}">
-                <a16:creationId xmlns:a16="http://schemas.microsoft.com/office/drawing/2014/main" id="{8109466E-DE48-4738-95E2-E54F691BDD9A}"/>
+                <a16:creationId xmlns:a16="http://schemas.microsoft.com/office/drawing/2014/main" id="{656B2FD2-2693-48C4-ABE5-A9126AD5E11B}"/>
               </a:ext>
             </a:extLst>
           </p:cNvPr>
@@ -3304,7 +3304,7 @@
                 <a:ea typeface="Hiragino Sans"/>
                 <a:cs typeface="Hiragino Sans"/>
               </a:rPr>
-              <a:t>N x Dを保持</a:t>
+              <a:t>統計列を保持</a:t>
             </a:r>
           </a:p>
         </p:txBody>
@@ -3314,7 +3314,7 @@
           <p:cNvPr id="47" name="">
             <a:extLst xmlns:a="http://schemas.openxmlformats.org/drawingml/2006/main">
               <a:ext uri="{FF2B5EF4-FFF2-40B4-BE49-F238E27FC236}">
-                <a16:creationId xmlns:a16="http://schemas.microsoft.com/office/drawing/2014/main" id="{1F5DE363-6356-4EC2-A065-C831528DFFC7}"/>
+                <a16:creationId xmlns:a16="http://schemas.microsoft.com/office/drawing/2014/main" id="{B3E0490D-D98A-41D0-9DB3-D9811F35F0C1}"/>
               </a:ext>
             </a:extLst>
           </p:cNvPr>
@@ -3347,7 +3347,7 @@
           <p:cNvPr id="48" name="">
             <a:extLst xmlns:a="http://schemas.openxmlformats.org/drawingml/2006/main">
               <a:ext uri="{FF2B5EF4-FFF2-40B4-BE49-F238E27FC236}">
-                <a16:creationId xmlns:a16="http://schemas.microsoft.com/office/drawing/2014/main" id="{2A1E42E5-507C-4E1B-870D-7896E6F8123D}"/>
+                <a16:creationId xmlns:a16="http://schemas.microsoft.com/office/drawing/2014/main" id="{C73BF4FA-2D64-4C44-BC3D-C04FA5B4E2D5}"/>
               </a:ext>
             </a:extLst>
           </p:cNvPr>
@@ -3424,7 +3424,7 @@
                 <a:ea typeface="Hiragino Sans"/>
                 <a:cs typeface="Hiragino Sans"/>
               </a:rPr>
-              <a:t>再構成誤差を外側で判定</a:t>
+              <a:t>再構成誤差を計算</a:t>
             </a:r>
           </a:p>
         </p:txBody>
@@ -3434,7 +3434,7 @@
           <p:cNvPr id="49" name="">
             <a:extLst xmlns:a="http://schemas.openxmlformats.org/drawingml/2006/main">
               <a:ext uri="{FF2B5EF4-FFF2-40B4-BE49-F238E27FC236}">
-                <a16:creationId xmlns:a16="http://schemas.microsoft.com/office/drawing/2014/main" id="{9BC9CC1E-55DD-4D37-8BE8-053A329C85DA}"/>
+                <a16:creationId xmlns:a16="http://schemas.microsoft.com/office/drawing/2014/main" id="{CD2755B2-E333-487E-BB46-471E7CD90311}"/>
               </a:ext>
             </a:extLst>
           </p:cNvPr>
@@ -3467,7 +3467,7 @@
           <p:cNvPr id="50" name="">
             <a:extLst xmlns:a="http://schemas.openxmlformats.org/drawingml/2006/main">
               <a:ext uri="{FF2B5EF4-FFF2-40B4-BE49-F238E27FC236}">
-                <a16:creationId xmlns:a16="http://schemas.microsoft.com/office/drawing/2014/main" id="{3968304F-EFE4-479A-9F6C-27614F9FD3A0}"/>
+                <a16:creationId xmlns:a16="http://schemas.microsoft.com/office/drawing/2014/main" id="{588B57B1-572B-4F62-A314-51B239C133C6}"/>
               </a:ext>
             </a:extLst>
           </p:cNvPr>
@@ -3502,7 +3502,7 @@
           <p:cNvPr id="51" name="">
             <a:extLst xmlns:a="http://schemas.openxmlformats.org/drawingml/2006/main">
               <a:ext uri="{FF2B5EF4-FFF2-40B4-BE49-F238E27FC236}">
-                <a16:creationId xmlns:a16="http://schemas.microsoft.com/office/drawing/2014/main" id="{298FCCEC-8874-44E8-BD26-144B6281D7BF}"/>
+                <a16:creationId xmlns:a16="http://schemas.microsoft.com/office/drawing/2014/main" id="{590E0573-9094-4AE4-ADD7-D9479EA04D3B}"/>
               </a:ext>
             </a:extLst>
           </p:cNvPr>
@@ -3566,7 +3566,7 @@
           <p:cNvPr id="52" name="">
             <a:extLst xmlns:a="http://schemas.openxmlformats.org/drawingml/2006/main">
               <a:ext uri="{FF2B5EF4-FFF2-40B4-BE49-F238E27FC236}">
-                <a16:creationId xmlns:a16="http://schemas.microsoft.com/office/drawing/2014/main" id="{51F9699E-5385-48A3-BAB3-6871A7FE3678}"/>
+                <a16:creationId xmlns:a16="http://schemas.microsoft.com/office/drawing/2014/main" id="{9C64257C-D1D5-4627-8538-BB68C4FE4803}"/>
               </a:ext>
             </a:extLst>
           </p:cNvPr>
@@ -3599,7 +3599,7 @@
           <p:cNvPr id="53" name="">
             <a:extLst xmlns:a="http://schemas.openxmlformats.org/drawingml/2006/main">
               <a:ext uri="{FF2B5EF4-FFF2-40B4-BE49-F238E27FC236}">
-                <a16:creationId xmlns:a16="http://schemas.microsoft.com/office/drawing/2014/main" id="{623761DB-1195-46E1-8631-A5FE0E23C067}"/>
+                <a16:creationId xmlns:a16="http://schemas.microsoft.com/office/drawing/2014/main" id="{40385589-0084-4BA9-AA86-F4E08122A2A7}"/>
               </a:ext>
             </a:extLst>
           </p:cNvPr>
@@ -3634,7 +3634,7 @@
           <p:cNvPr id="54" name="">
             <a:extLst xmlns:a="http://schemas.openxmlformats.org/drawingml/2006/main">
               <a:ext uri="{FF2B5EF4-FFF2-40B4-BE49-F238E27FC236}">
-                <a16:creationId xmlns:a16="http://schemas.microsoft.com/office/drawing/2014/main" id="{66806566-856A-45C8-9CFB-0BDCAA435CDA}"/>
+                <a16:creationId xmlns:a16="http://schemas.microsoft.com/office/drawing/2014/main" id="{C53C101A-7DA5-41CD-A863-7C0D7455EC82}"/>
               </a:ext>
             </a:extLst>
           </p:cNvPr>
@@ -3698,7 +3698,7 @@
           <p:cNvPr id="55" name="">
             <a:extLst xmlns:a="http://schemas.openxmlformats.org/drawingml/2006/main">
               <a:ext uri="{FF2B5EF4-FFF2-40B4-BE49-F238E27FC236}">
-                <a16:creationId xmlns:a16="http://schemas.microsoft.com/office/drawing/2014/main" id="{15C91474-1D31-4BCC-964C-1716715F56FC}"/>
+                <a16:creationId xmlns:a16="http://schemas.microsoft.com/office/drawing/2014/main" id="{24FDF1D9-9FBD-49EF-B7B5-E21B682EDBDC}"/>
               </a:ext>
             </a:extLst>
           </p:cNvPr>
@@ -3731,7 +3731,7 @@
           <p:cNvPr id="56" name="">
             <a:extLst xmlns:a="http://schemas.openxmlformats.org/drawingml/2006/main">
               <a:ext uri="{FF2B5EF4-FFF2-40B4-BE49-F238E27FC236}">
-                <a16:creationId xmlns:a16="http://schemas.microsoft.com/office/drawing/2014/main" id="{C545111A-A53E-4C4D-A533-05C71079F97E}"/>
+                <a16:creationId xmlns:a16="http://schemas.microsoft.com/office/drawing/2014/main" id="{0E1724FD-5FD1-4EA5-B4C0-6BBCB8CFD27F}"/>
               </a:ext>
             </a:extLst>
           </p:cNvPr>
@@ -3766,7 +3766,7 @@
           <p:cNvPr id="57" name="">
             <a:extLst xmlns:a="http://schemas.openxmlformats.org/drawingml/2006/main">
               <a:ext uri="{FF2B5EF4-FFF2-40B4-BE49-F238E27FC236}">
-                <a16:creationId xmlns:a16="http://schemas.microsoft.com/office/drawing/2014/main" id="{4E0F4CCF-C8B6-4747-912C-69A709C71E4F}"/>
+                <a16:creationId xmlns:a16="http://schemas.microsoft.com/office/drawing/2014/main" id="{EC209E80-B201-4AA5-8DED-1AD17F3EE37C}"/>
               </a:ext>
             </a:extLst>
           </p:cNvPr>
@@ -3830,7 +3830,7 @@
           <p:cNvPr id="58" name="">
             <a:extLst xmlns:a="http://schemas.openxmlformats.org/drawingml/2006/main">
               <a:ext uri="{FF2B5EF4-FFF2-40B4-BE49-F238E27FC236}">
-                <a16:creationId xmlns:a16="http://schemas.microsoft.com/office/drawing/2014/main" id="{5A4CF8FB-7CC5-4D32-921A-4AEFC5D9715B}"/>
+                <a16:creationId xmlns:a16="http://schemas.microsoft.com/office/drawing/2014/main" id="{546963D5-256B-4DDD-A5DB-D064A8C1EC38}"/>
               </a:ext>
             </a:extLst>
           </p:cNvPr>
@@ -3894,7 +3894,7 @@
           <p:cNvPr id="59" name="">
             <a:extLst xmlns:a="http://schemas.openxmlformats.org/drawingml/2006/main">
               <a:ext uri="{FF2B5EF4-FFF2-40B4-BE49-F238E27FC236}">
-                <a16:creationId xmlns:a16="http://schemas.microsoft.com/office/drawing/2014/main" id="{78868278-720F-4121-AB43-630529009873}"/>
+                <a16:creationId xmlns:a16="http://schemas.microsoft.com/office/drawing/2014/main" id="{CCB38749-B10E-46D3-A302-63E623CEBC4A}"/>
               </a:ext>
             </a:extLst>
           </p:cNvPr>
@@ -3948,7 +3948,7 @@
                 <a:ea typeface="Hiragino Sans"/>
                 <a:cs typeface="Hiragino Sans"/>
               </a:rPr>
-              <a:t>軽いMLかを測る</a:t>
+              <a:t>軽量MLの成立性を測る</a:t>
             </a:r>
           </a:p>
         </p:txBody>
@@ -3958,7 +3958,7 @@
           <p:cNvPr id="60" name="">
             <a:extLst xmlns:a="http://schemas.openxmlformats.org/drawingml/2006/main">
               <a:ext uri="{FF2B5EF4-FFF2-40B4-BE49-F238E27FC236}">
-                <a16:creationId xmlns:a16="http://schemas.microsoft.com/office/drawing/2014/main" id="{32CAB53E-4C8C-4AE3-A02D-B8E2A45B7BAB}"/>
+                <a16:creationId xmlns:a16="http://schemas.microsoft.com/office/drawing/2014/main" id="{F95BB2E7-0475-4D18-8DFB-E4F805F38BAA}"/>
               </a:ext>
             </a:extLst>
           </p:cNvPr>
@@ -4022,7 +4022,7 @@
           <p:cNvPr id="61" name="">
             <a:extLst xmlns:a="http://schemas.openxmlformats.org/drawingml/2006/main">
               <a:ext uri="{FF2B5EF4-FFF2-40B4-BE49-F238E27FC236}">
-                <a16:creationId xmlns:a16="http://schemas.microsoft.com/office/drawing/2014/main" id="{B55A99AA-56B7-407E-A88C-862F67A2BBCB}"/>
+                <a16:creationId xmlns:a16="http://schemas.microsoft.com/office/drawing/2014/main" id="{7A4BBF59-6569-486A-AD07-31E6337752C0}"/>
               </a:ext>
             </a:extLst>
           </p:cNvPr>
@@ -4057,7 +4057,7 @@
           <p:cNvPr id="62" name="">
             <a:extLst xmlns:a="http://schemas.openxmlformats.org/drawingml/2006/main">
               <a:ext uri="{FF2B5EF4-FFF2-40B4-BE49-F238E27FC236}">
-                <a16:creationId xmlns:a16="http://schemas.microsoft.com/office/drawing/2014/main" id="{66ECB131-1154-4259-9923-45125C205F86}"/>
+                <a16:creationId xmlns:a16="http://schemas.microsoft.com/office/drawing/2014/main" id="{2D1D8BE1-0EF2-4992-B7CD-692096F64B9C}"/>
               </a:ext>
             </a:extLst>
           </p:cNvPr>
@@ -4119,7 +4119,7 @@
     </p:spTree>
     <p:extLst>
       <p:ext uri="{BB962C8B-B14F-4D97-AF65-F5344CB8AC3E}">
-        <p14:creationId xmlns:p14="http://schemas.microsoft.com/office/powerpoint/2010/main" val="1258848881"/>
+        <p14:creationId xmlns:p14="http://schemas.microsoft.com/office/powerpoint/2010/main" val="49379373"/>
       </p:ext>
     </p:extLst>
   </p:cSld>
@@ -4143,7 +4143,7 @@
           <p:cNvPr id="1" name="">
             <a:extLst xmlns:a="http://schemas.openxmlformats.org/drawingml/2006/main">
               <a:ext uri="{FF2B5EF4-FFF2-40B4-BE49-F238E27FC236}">
-                <a16:creationId xmlns:a16="http://schemas.microsoft.com/office/drawing/2014/main" id="{4B558799-374A-437B-8AB1-F0998CE0AA5A}"/>
+                <a16:creationId xmlns:a16="http://schemas.microsoft.com/office/drawing/2014/main" id="{1EAA61BC-156E-459A-B880-D6E91C99CD0A}"/>
               </a:ext>
             </a:extLst>
           </p:cNvPr>
@@ -4178,7 +4178,7 @@
           <p:cNvPr id="2" name="">
             <a:extLst xmlns:a="http://schemas.openxmlformats.org/drawingml/2006/main">
               <a:ext uri="{FF2B5EF4-FFF2-40B4-BE49-F238E27FC236}">
-                <a16:creationId xmlns:a16="http://schemas.microsoft.com/office/drawing/2014/main" id="{247D86A4-1AC5-4EA2-B29E-2DFAD322C90E}"/>
+                <a16:creationId xmlns:a16="http://schemas.microsoft.com/office/drawing/2014/main" id="{B442C51D-30B3-410C-AE14-D606EB0C1609}"/>
               </a:ext>
             </a:extLst>
           </p:cNvPr>
@@ -4213,7 +4213,7 @@
           <p:cNvPr id="3" name="">
             <a:extLst xmlns:a="http://schemas.openxmlformats.org/drawingml/2006/main">
               <a:ext uri="{FF2B5EF4-FFF2-40B4-BE49-F238E27FC236}">
-                <a16:creationId xmlns:a16="http://schemas.microsoft.com/office/drawing/2014/main" id="{C46FBB90-40D7-488B-8817-17B5C5284AA5}"/>
+                <a16:creationId xmlns:a16="http://schemas.microsoft.com/office/drawing/2014/main" id="{B4E822FC-D3B9-4E0F-8AB7-3CBE6E19F878}"/>
               </a:ext>
             </a:extLst>
           </p:cNvPr>
@@ -4248,7 +4248,7 @@
           <p:cNvPr id="4" name="">
             <a:extLst xmlns:a="http://schemas.openxmlformats.org/drawingml/2006/main">
               <a:ext uri="{FF2B5EF4-FFF2-40B4-BE49-F238E27FC236}">
-                <a16:creationId xmlns:a16="http://schemas.microsoft.com/office/drawing/2014/main" id="{6BCC5FFE-8209-4870-93F0-EBD0F71E26CA}"/>
+                <a16:creationId xmlns:a16="http://schemas.microsoft.com/office/drawing/2014/main" id="{A117E26A-E3D8-4C4B-B08E-62C4E185F3AD}"/>
               </a:ext>
             </a:extLst>
           </p:cNvPr>
@@ -4302,7 +4302,7 @@
                 <a:ea typeface="Hiragino Sans"/>
                 <a:cs typeface="Hiragino Sans"/>
               </a:rPr>
-              <a:t>DECISION FRAME | このプレゼンで決めること</a:t>
+              <a:t>DECISION FRAME | 判定基準</a:t>
             </a:r>
           </a:p>
         </p:txBody>
@@ -4312,7 +4312,7 @@
           <p:cNvPr id="5" name="">
             <a:extLst xmlns:a="http://schemas.openxmlformats.org/drawingml/2006/main">
               <a:ext uri="{FF2B5EF4-FFF2-40B4-BE49-F238E27FC236}">
-                <a16:creationId xmlns:a16="http://schemas.microsoft.com/office/drawing/2014/main" id="{63B9A9E3-8453-4819-9ECD-25CBFBB78EE0}"/>
+                <a16:creationId xmlns:a16="http://schemas.microsoft.com/office/drawing/2014/main" id="{21972CFD-58F9-42D6-A821-3AECE618AA1A}"/>
               </a:ext>
             </a:extLst>
           </p:cNvPr>
@@ -4376,7 +4376,7 @@
           <p:cNvPr id="6" name="">
             <a:extLst xmlns:a="http://schemas.openxmlformats.org/drawingml/2006/main">
               <a:ext uri="{FF2B5EF4-FFF2-40B4-BE49-F238E27FC236}">
-                <a16:creationId xmlns:a16="http://schemas.microsoft.com/office/drawing/2014/main" id="{CD2A98D9-AE1B-406C-92D4-3D8BD3967B1C}"/>
+                <a16:creationId xmlns:a16="http://schemas.microsoft.com/office/drawing/2014/main" id="{31BB3469-9AB0-46CD-BD3B-5A88732E5773}"/>
               </a:ext>
             </a:extLst>
           </p:cNvPr>
@@ -4430,7 +4430,7 @@
                 <a:ea typeface="Hiragino Mincho ProN"/>
                 <a:cs typeface="Hiragino Mincho ProN"/>
               </a:rPr>
-              <a:t>導入判断の前に、候補を落とす条件を決める</a:t>
+              <a:t>導入可否の前に、次実験の判定基準を決める</a:t>
             </a:r>
           </a:p>
         </p:txBody>
@@ -4440,7 +4440,7 @@
           <p:cNvPr id="7" name="">
             <a:extLst xmlns:a="http://schemas.openxmlformats.org/drawingml/2006/main">
               <a:ext uri="{FF2B5EF4-FFF2-40B4-BE49-F238E27FC236}">
-                <a16:creationId xmlns:a16="http://schemas.microsoft.com/office/drawing/2014/main" id="{DDE3F6B7-D2DA-4A00-843B-E4B2F3792800}"/>
+                <a16:creationId xmlns:a16="http://schemas.microsoft.com/office/drawing/2014/main" id="{B3761F53-D652-4A11-913F-4D642B09FC89}"/>
               </a:ext>
             </a:extLst>
           </p:cNvPr>
@@ -4473,7 +4473,7 @@
           <p:cNvPr id="8" name="">
             <a:extLst xmlns:a="http://schemas.openxmlformats.org/drawingml/2006/main">
               <a:ext uri="{FF2B5EF4-FFF2-40B4-BE49-F238E27FC236}">
-                <a16:creationId xmlns:a16="http://schemas.microsoft.com/office/drawing/2014/main" id="{108CD3FF-B24B-4445-B079-51C343142735}"/>
+                <a16:creationId xmlns:a16="http://schemas.microsoft.com/office/drawing/2014/main" id="{67F9A7CF-B3C7-4359-8FCA-849352067B95}"/>
               </a:ext>
             </a:extLst>
           </p:cNvPr>
@@ -4508,7 +4508,7 @@
           <p:cNvPr id="9" name="">
             <a:extLst xmlns:a="http://schemas.openxmlformats.org/drawingml/2006/main">
               <a:ext uri="{FF2B5EF4-FFF2-40B4-BE49-F238E27FC236}">
-                <a16:creationId xmlns:a16="http://schemas.microsoft.com/office/drawing/2014/main" id="{1A93F7D5-D83D-4D5C-BF78-17677DC0AEC0}"/>
+                <a16:creationId xmlns:a16="http://schemas.microsoft.com/office/drawing/2014/main" id="{20A8FE98-8C03-4983-BFE4-F6D9DB67A1AC}"/>
               </a:ext>
             </a:extLst>
           </p:cNvPr>
@@ -4562,7 +4562,7 @@
                 <a:ea typeface="Hiragino Sans"/>
                 <a:cs typeface="Hiragino Sans"/>
               </a:rPr>
-              <a:t>主張 | いま必要なのは採用可否の結論ではなく、次の実験で候補を採用・縮小・棄却する判定条件である。</a:t>
+              <a:t>主張 | 決める対象は採用可否ではなく、単純規則・AE複雑度・装置制約で候補を進めるか止めるかの基準である。</a:t>
             </a:r>
           </a:p>
         </p:txBody>
@@ -4572,7 +4572,7 @@
           <p:cNvPr id="10" name="">
             <a:extLst xmlns:a="http://schemas.openxmlformats.org/drawingml/2006/main">
               <a:ext uri="{FF2B5EF4-FFF2-40B4-BE49-F238E27FC236}">
-                <a16:creationId xmlns:a16="http://schemas.microsoft.com/office/drawing/2014/main" id="{3475EB74-AED9-46DC-A386-84D83BE17408}"/>
+                <a16:creationId xmlns:a16="http://schemas.microsoft.com/office/drawing/2014/main" id="{18928659-D43C-467C-B09D-4B051A104831}"/>
               </a:ext>
             </a:extLst>
           </p:cNvPr>
@@ -4605,7 +4605,7 @@
           <p:cNvPr id="11" name="">
             <a:extLst xmlns:a="http://schemas.openxmlformats.org/drawingml/2006/main">
               <a:ext uri="{FF2B5EF4-FFF2-40B4-BE49-F238E27FC236}">
-                <a16:creationId xmlns:a16="http://schemas.microsoft.com/office/drawing/2014/main" id="{48796FBC-905D-43C1-AF0C-8FB9814623E8}"/>
+                <a16:creationId xmlns:a16="http://schemas.microsoft.com/office/drawing/2014/main" id="{E7B6A0C6-9858-4B14-A18D-9D4407E9D3C5}"/>
               </a:ext>
             </a:extLst>
           </p:cNvPr>
@@ -4640,7 +4640,7 @@
           <p:cNvPr id="12" name="">
             <a:extLst xmlns:a="http://schemas.openxmlformats.org/drawingml/2006/main">
               <a:ext uri="{FF2B5EF4-FFF2-40B4-BE49-F238E27FC236}">
-                <a16:creationId xmlns:a16="http://schemas.microsoft.com/office/drawing/2014/main" id="{D12F5583-40C4-4005-9081-B3BBC317D4CA}"/>
+                <a16:creationId xmlns:a16="http://schemas.microsoft.com/office/drawing/2014/main" id="{E77B43E3-AEE4-4E88-AF2B-6C4F74155F5B}"/>
               </a:ext>
             </a:extLst>
           </p:cNvPr>
@@ -4704,7 +4704,7 @@
           <p:cNvPr id="13" name="">
             <a:extLst xmlns:a="http://schemas.openxmlformats.org/drawingml/2006/main">
               <a:ext uri="{FF2B5EF4-FFF2-40B4-BE49-F238E27FC236}">
-                <a16:creationId xmlns:a16="http://schemas.microsoft.com/office/drawing/2014/main" id="{B9451E6D-3DF4-4F3A-9ACA-68C2D52F2046}"/>
+                <a16:creationId xmlns:a16="http://schemas.microsoft.com/office/drawing/2014/main" id="{8EBBBA63-A71F-4044-88FD-5D7C9B301413}"/>
               </a:ext>
             </a:extLst>
           </p:cNvPr>
@@ -4737,7 +4737,7 @@
           <p:cNvPr id="14" name="">
             <a:extLst xmlns:a="http://schemas.openxmlformats.org/drawingml/2006/main">
               <a:ext uri="{FF2B5EF4-FFF2-40B4-BE49-F238E27FC236}">
-                <a16:creationId xmlns:a16="http://schemas.microsoft.com/office/drawing/2014/main" id="{6C4E1DAB-AB50-4868-AA54-993918E2288A}"/>
+                <a16:creationId xmlns:a16="http://schemas.microsoft.com/office/drawing/2014/main" id="{58E01C25-6034-411B-87BA-27EC2294AF73}"/>
               </a:ext>
             </a:extLst>
           </p:cNvPr>
@@ -4772,7 +4772,7 @@
           <p:cNvPr id="15" name="">
             <a:extLst xmlns:a="http://schemas.openxmlformats.org/drawingml/2006/main">
               <a:ext uri="{FF2B5EF4-FFF2-40B4-BE49-F238E27FC236}">
-                <a16:creationId xmlns:a16="http://schemas.microsoft.com/office/drawing/2014/main" id="{542BAAD8-8B90-4D16-BC2F-66E2AB8FEC15}"/>
+                <a16:creationId xmlns:a16="http://schemas.microsoft.com/office/drawing/2014/main" id="{444246FA-99CF-4B12-B56A-BE094CA12287}"/>
               </a:ext>
             </a:extLst>
           </p:cNvPr>
@@ -4836,7 +4836,7 @@
           <p:cNvPr id="16" name="">
             <a:extLst xmlns:a="http://schemas.openxmlformats.org/drawingml/2006/main">
               <a:ext uri="{FF2B5EF4-FFF2-40B4-BE49-F238E27FC236}">
-                <a16:creationId xmlns:a16="http://schemas.microsoft.com/office/drawing/2014/main" id="{8C26DB6F-198D-4FED-931C-5712278ED822}"/>
+                <a16:creationId xmlns:a16="http://schemas.microsoft.com/office/drawing/2014/main" id="{1B363987-94B8-482E-B7A6-FBE862D0A869}"/>
               </a:ext>
             </a:extLst>
           </p:cNvPr>
@@ -4890,7 +4890,7 @@
                 <a:ea typeface="Hiragino Sans"/>
                 <a:cs typeface="Hiragino Sans"/>
               </a:rPr>
-              <a:t>write ratio、I/O強度、LBA移動だけで説明できるならAEは縮小または棄却する</a:t>
+              <a:t>write ratio、I/O強度、LBA移動で説明できるならAE候補を縮小または棄却する</a:t>
             </a:r>
           </a:p>
         </p:txBody>
@@ -4900,7 +4900,7 @@
           <p:cNvPr id="17" name="">
             <a:extLst xmlns:a="http://schemas.openxmlformats.org/drawingml/2006/main">
               <a:ext uri="{FF2B5EF4-FFF2-40B4-BE49-F238E27FC236}">
-                <a16:creationId xmlns:a16="http://schemas.microsoft.com/office/drawing/2014/main" id="{60550AE4-229C-4BB3-A8A0-EFE63C4DC284}"/>
+                <a16:creationId xmlns:a16="http://schemas.microsoft.com/office/drawing/2014/main" id="{EB732F13-7621-4D56-82E0-4ED1F70B101B}"/>
               </a:ext>
             </a:extLst>
           </p:cNvPr>
@@ -4935,7 +4935,7 @@
           <p:cNvPr id="18" name="">
             <a:extLst xmlns:a="http://schemas.openxmlformats.org/drawingml/2006/main">
               <a:ext uri="{FF2B5EF4-FFF2-40B4-BE49-F238E27FC236}">
-                <a16:creationId xmlns:a16="http://schemas.microsoft.com/office/drawing/2014/main" id="{5C798196-2420-469B-94D1-FA21ACD89255}"/>
+                <a16:creationId xmlns:a16="http://schemas.microsoft.com/office/drawing/2014/main" id="{D5EF9181-CBE5-4696-BE4F-FA4627149252}"/>
               </a:ext>
             </a:extLst>
           </p:cNvPr>
@@ -4999,7 +4999,7 @@
           <p:cNvPr id="19" name="">
             <a:extLst xmlns:a="http://schemas.openxmlformats.org/drawingml/2006/main">
               <a:ext uri="{FF2B5EF4-FFF2-40B4-BE49-F238E27FC236}">
-                <a16:creationId xmlns:a16="http://schemas.microsoft.com/office/drawing/2014/main" id="{15F4E05C-A74A-40E3-83E5-36F4FE451254}"/>
+                <a16:creationId xmlns:a16="http://schemas.microsoft.com/office/drawing/2014/main" id="{57AABC14-585A-4436-ADAD-7B0017692D51}"/>
               </a:ext>
             </a:extLst>
           </p:cNvPr>
@@ -5032,7 +5032,7 @@
           <p:cNvPr id="20" name="">
             <a:extLst xmlns:a="http://schemas.openxmlformats.org/drawingml/2006/main">
               <a:ext uri="{FF2B5EF4-FFF2-40B4-BE49-F238E27FC236}">
-                <a16:creationId xmlns:a16="http://schemas.microsoft.com/office/drawing/2014/main" id="{69928A4D-4AD1-41BF-88F8-CE4CF09DC263}"/>
+                <a16:creationId xmlns:a16="http://schemas.microsoft.com/office/drawing/2014/main" id="{974141C1-5C66-4F9E-A0FB-7E34E402C2D7}"/>
               </a:ext>
             </a:extLst>
           </p:cNvPr>
@@ -5067,7 +5067,7 @@
           <p:cNvPr id="21" name="">
             <a:extLst xmlns:a="http://schemas.openxmlformats.org/drawingml/2006/main">
               <a:ext uri="{FF2B5EF4-FFF2-40B4-BE49-F238E27FC236}">
-                <a16:creationId xmlns:a16="http://schemas.microsoft.com/office/drawing/2014/main" id="{8F1836D2-B01A-4B41-9C67-35C58CCBED0E}"/>
+                <a16:creationId xmlns:a16="http://schemas.microsoft.com/office/drawing/2014/main" id="{337985FE-BEFC-43E7-B378-2848E1FBE361}"/>
               </a:ext>
             </a:extLst>
           </p:cNvPr>
@@ -5121,7 +5121,7 @@
                 <a:ea typeface="Hiragino Sans"/>
                 <a:cs typeface="Hiragino Sans"/>
               </a:rPr>
-              <a:t>2. AEのどこまで必要か</a:t>
+              <a:t>2. どの演算まで必要か</a:t>
             </a:r>
           </a:p>
         </p:txBody>
@@ -5131,7 +5131,7 @@
           <p:cNvPr id="22" name="">
             <a:extLst xmlns:a="http://schemas.openxmlformats.org/drawingml/2006/main">
               <a:ext uri="{FF2B5EF4-FFF2-40B4-BE49-F238E27FC236}">
-                <a16:creationId xmlns:a16="http://schemas.microsoft.com/office/drawing/2014/main" id="{BC1607C9-9660-4EA4-B08E-33AB6E133C2E}"/>
+                <a16:creationId xmlns:a16="http://schemas.microsoft.com/office/drawing/2014/main" id="{24DCDFF0-F9D4-4B96-915B-93E11E6934B6}"/>
               </a:ext>
             </a:extLst>
           </p:cNvPr>
@@ -5185,7 +5185,7 @@
                 <a:ea typeface="Hiragino Sans"/>
                 <a:cs typeface="Hiragino Sans"/>
               </a:rPr>
-              <a:t>Dense、時系列文脈、局所時間特徴、CNN-GRUを同じ入力で順番に比較する</a:t>
+              <a:t>Dense、時系列文脈、局所時間特徴、CNN-GRUを同じ入力で順番に比べる</a:t>
             </a:r>
           </a:p>
         </p:txBody>
@@ -5195,7 +5195,7 @@
           <p:cNvPr id="23" name="">
             <a:extLst xmlns:a="http://schemas.openxmlformats.org/drawingml/2006/main">
               <a:ext uri="{FF2B5EF4-FFF2-40B4-BE49-F238E27FC236}">
-                <a16:creationId xmlns:a16="http://schemas.microsoft.com/office/drawing/2014/main" id="{1DD906AD-F000-4B1E-87E2-F1A7E104ADB0}"/>
+                <a16:creationId xmlns:a16="http://schemas.microsoft.com/office/drawing/2014/main" id="{AC2469B6-690E-4E1B-8A67-DF581FC33104}"/>
               </a:ext>
             </a:extLst>
           </p:cNvPr>
@@ -5230,7 +5230,7 @@
           <p:cNvPr id="24" name="">
             <a:extLst xmlns:a="http://schemas.openxmlformats.org/drawingml/2006/main">
               <a:ext uri="{FF2B5EF4-FFF2-40B4-BE49-F238E27FC236}">
-                <a16:creationId xmlns:a16="http://schemas.microsoft.com/office/drawing/2014/main" id="{BDDEEEDF-400A-4D00-A1F3-C879AC42BA5C}"/>
+                <a16:creationId xmlns:a16="http://schemas.microsoft.com/office/drawing/2014/main" id="{D4CCBB76-C75D-4EDF-BE7E-DF0446569C7A}"/>
               </a:ext>
             </a:extLst>
           </p:cNvPr>
@@ -5294,7 +5294,7 @@
           <p:cNvPr id="25" name="">
             <a:extLst xmlns:a="http://schemas.openxmlformats.org/drawingml/2006/main">
               <a:ext uri="{FF2B5EF4-FFF2-40B4-BE49-F238E27FC236}">
-                <a16:creationId xmlns:a16="http://schemas.microsoft.com/office/drawing/2014/main" id="{E025B094-E27D-48F5-9DB3-93701E9B537A}"/>
+                <a16:creationId xmlns:a16="http://schemas.microsoft.com/office/drawing/2014/main" id="{599B42EF-A273-4695-8F0F-DBA8A27A7163}"/>
               </a:ext>
             </a:extLst>
           </p:cNvPr>
@@ -5327,7 +5327,7 @@
           <p:cNvPr id="26" name="">
             <a:extLst xmlns:a="http://schemas.openxmlformats.org/drawingml/2006/main">
               <a:ext uri="{FF2B5EF4-FFF2-40B4-BE49-F238E27FC236}">
-                <a16:creationId xmlns:a16="http://schemas.microsoft.com/office/drawing/2014/main" id="{DE212E0C-F254-4B96-95D1-BB032EAFF1BA}"/>
+                <a16:creationId xmlns:a16="http://schemas.microsoft.com/office/drawing/2014/main" id="{B54B8B67-F868-4941-A91F-9257F88A496C}"/>
               </a:ext>
             </a:extLst>
           </p:cNvPr>
@@ -5362,7 +5362,7 @@
           <p:cNvPr id="27" name="">
             <a:extLst xmlns:a="http://schemas.openxmlformats.org/drawingml/2006/main">
               <a:ext uri="{FF2B5EF4-FFF2-40B4-BE49-F238E27FC236}">
-                <a16:creationId xmlns:a16="http://schemas.microsoft.com/office/drawing/2014/main" id="{1714C721-EC26-4851-BF60-CBB710069B55}"/>
+                <a16:creationId xmlns:a16="http://schemas.microsoft.com/office/drawing/2014/main" id="{86676ABA-D7D4-4046-B3A4-AED64A4F9577}"/>
               </a:ext>
             </a:extLst>
           </p:cNvPr>
@@ -5416,7 +5416,7 @@
                 <a:ea typeface="Hiragino Sans"/>
                 <a:cs typeface="Hiragino Sans"/>
               </a:rPr>
-              <a:t>3. 装置に載るか</a:t>
+              <a:t>3. 装置制約に収まるか</a:t>
             </a:r>
           </a:p>
         </p:txBody>
@@ -5426,7 +5426,7 @@
           <p:cNvPr id="28" name="">
             <a:extLst xmlns:a="http://schemas.openxmlformats.org/drawingml/2006/main">
               <a:ext uri="{FF2B5EF4-FFF2-40B4-BE49-F238E27FC236}">
-                <a16:creationId xmlns:a16="http://schemas.microsoft.com/office/drawing/2014/main" id="{DFF085FB-A372-4FB7-B997-ED998F9D2712}"/>
+                <a16:creationId xmlns:a16="http://schemas.microsoft.com/office/drawing/2014/main" id="{24FFD6EA-64C0-49A2-8F05-AB2E83DEFAA9}"/>
               </a:ext>
             </a:extLst>
           </p:cNvPr>
@@ -5480,7 +5480,7 @@
                 <a:ea typeface="Hiragino Sans"/>
                 <a:cs typeface="Hiragino Sans"/>
               </a:rPr>
-              <a:t>500 KB detector-data、MNN score parity、10秒cadenceのCPU/slotを分けて測る</a:t>
+              <a:t>500 KB detector-data、MNN score一致、10秒間隔のCPU枠を別々に測る</a:t>
             </a:r>
           </a:p>
         </p:txBody>
@@ -5490,7 +5490,7 @@
           <p:cNvPr id="29" name="">
             <a:extLst xmlns:a="http://schemas.openxmlformats.org/drawingml/2006/main">
               <a:ext uri="{FF2B5EF4-FFF2-40B4-BE49-F238E27FC236}">
-                <a16:creationId xmlns:a16="http://schemas.microsoft.com/office/drawing/2014/main" id="{5DF3BF32-A6B3-4C15-9D45-AC82C78F760A}"/>
+                <a16:creationId xmlns:a16="http://schemas.microsoft.com/office/drawing/2014/main" id="{83616084-4636-4CE6-8739-5816C9A3D0B4}"/>
               </a:ext>
             </a:extLst>
           </p:cNvPr>
@@ -5525,7 +5525,7 @@
           <p:cNvPr id="30" name="">
             <a:extLst xmlns:a="http://schemas.openxmlformats.org/drawingml/2006/main">
               <a:ext uri="{FF2B5EF4-FFF2-40B4-BE49-F238E27FC236}">
-                <a16:creationId xmlns:a16="http://schemas.microsoft.com/office/drawing/2014/main" id="{5B615AFD-B7A2-46C6-A2F2-B5A1E7306F03}"/>
+                <a16:creationId xmlns:a16="http://schemas.microsoft.com/office/drawing/2014/main" id="{F75AA41C-148E-4946-95DC-4E5731853ACC}"/>
               </a:ext>
             </a:extLst>
           </p:cNvPr>
@@ -5589,7 +5589,7 @@
           <p:cNvPr id="31" name="">
             <a:extLst xmlns:a="http://schemas.openxmlformats.org/drawingml/2006/main">
               <a:ext uri="{FF2B5EF4-FFF2-40B4-BE49-F238E27FC236}">
-                <a16:creationId xmlns:a16="http://schemas.microsoft.com/office/drawing/2014/main" id="{55EC90E3-E95A-4D5B-B22E-DE421708C0C3}"/>
+                <a16:creationId xmlns:a16="http://schemas.microsoft.com/office/drawing/2014/main" id="{66B8341F-1357-404A-A114-356C5F5FD0A7}"/>
               </a:ext>
             </a:extLst>
           </p:cNvPr>
@@ -5622,7 +5622,7 @@
           <p:cNvPr id="32" name="">
             <a:extLst xmlns:a="http://schemas.openxmlformats.org/drawingml/2006/main">
               <a:ext uri="{FF2B5EF4-FFF2-40B4-BE49-F238E27FC236}">
-                <a16:creationId xmlns:a16="http://schemas.microsoft.com/office/drawing/2014/main" id="{CBACCF04-1422-4347-9114-0CDBE697BE73}"/>
+                <a16:creationId xmlns:a16="http://schemas.microsoft.com/office/drawing/2014/main" id="{51866A7A-F069-4944-9330-0B764DDA36AD}"/>
               </a:ext>
             </a:extLst>
           </p:cNvPr>
@@ -5657,7 +5657,7 @@
           <p:cNvPr id="33" name="">
             <a:extLst xmlns:a="http://schemas.openxmlformats.org/drawingml/2006/main">
               <a:ext uri="{FF2B5EF4-FFF2-40B4-BE49-F238E27FC236}">
-                <a16:creationId xmlns:a16="http://schemas.microsoft.com/office/drawing/2014/main" id="{9245D2EE-C3A7-4667-A7A6-8EC70AADF3B6}"/>
+                <a16:creationId xmlns:a16="http://schemas.microsoft.com/office/drawing/2014/main" id="{342E375C-3418-4ECF-8D38-33EE8150665F}"/>
               </a:ext>
             </a:extLst>
           </p:cNvPr>
@@ -5711,7 +5711,7 @@
                 <a:ea typeface="Hiragino Sans"/>
                 <a:cs typeface="Hiragino Sans"/>
               </a:rPr>
-              <a:t>4. 次の証拠は何か</a:t>
+              <a:t>4. 次に何を測るか</a:t>
             </a:r>
           </a:p>
         </p:txBody>
@@ -5721,7 +5721,7 @@
           <p:cNvPr id="34" name="">
             <a:extLst xmlns:a="http://schemas.openxmlformats.org/drawingml/2006/main">
               <a:ext uri="{FF2B5EF4-FFF2-40B4-BE49-F238E27FC236}">
-                <a16:creationId xmlns:a16="http://schemas.microsoft.com/office/drawing/2014/main" id="{2A300EFE-A684-4806-A13C-9B8504781078}"/>
+                <a16:creationId xmlns:a16="http://schemas.microsoft.com/office/drawing/2014/main" id="{64DE8BB0-1AD1-4212-ACCE-C2574CEE14E7}"/>
               </a:ext>
             </a:extLst>
           </p:cNvPr>
@@ -5775,7 +5775,7 @@
                 <a:ea typeface="Hiragino Sans"/>
                 <a:cs typeface="Hiragino Sans"/>
               </a:rPr>
-              <a:t>manifest付き実験、MNN変換、memory harnessのどれが意思決定を進めるかを明確にする</a:t>
+              <a:t>manifest付き実験、MNN変換、メモリ測定のどれが判断を進めるかを決める</a:t>
             </a:r>
           </a:p>
         </p:txBody>
@@ -5785,7 +5785,7 @@
           <p:cNvPr id="35" name="">
             <a:extLst xmlns:a="http://schemas.openxmlformats.org/drawingml/2006/main">
               <a:ext uri="{FF2B5EF4-FFF2-40B4-BE49-F238E27FC236}">
-                <a16:creationId xmlns:a16="http://schemas.microsoft.com/office/drawing/2014/main" id="{C0B811CE-8084-4CBC-BB75-DBA10BB9B61E}"/>
+                <a16:creationId xmlns:a16="http://schemas.microsoft.com/office/drawing/2014/main" id="{67A56262-C0F6-490F-ABF5-A7445BE4DF05}"/>
               </a:ext>
             </a:extLst>
           </p:cNvPr>
@@ -5818,7 +5818,7 @@
           <p:cNvPr id="36" name="">
             <a:extLst xmlns:a="http://schemas.openxmlformats.org/drawingml/2006/main">
               <a:ext uri="{FF2B5EF4-FFF2-40B4-BE49-F238E27FC236}">
-                <a16:creationId xmlns:a16="http://schemas.microsoft.com/office/drawing/2014/main" id="{D58D5F3E-CF8B-4771-91C9-D2FD5CDF86AB}"/>
+                <a16:creationId xmlns:a16="http://schemas.microsoft.com/office/drawing/2014/main" id="{177196FF-DAB4-458A-8F49-ACCA3887B9CB}"/>
               </a:ext>
             </a:extLst>
           </p:cNvPr>
@@ -5853,7 +5853,7 @@
           <p:cNvPr id="37" name="">
             <a:extLst xmlns:a="http://schemas.openxmlformats.org/drawingml/2006/main">
               <a:ext uri="{FF2B5EF4-FFF2-40B4-BE49-F238E27FC236}">
-                <a16:creationId xmlns:a16="http://schemas.microsoft.com/office/drawing/2014/main" id="{E80BE486-AABD-4258-8F03-D307A1BC60C3}"/>
+                <a16:creationId xmlns:a16="http://schemas.microsoft.com/office/drawing/2014/main" id="{9A8652E0-E2BB-44EF-A04B-4B2A60F7E936}"/>
               </a:ext>
             </a:extLst>
           </p:cNvPr>
@@ -5917,7 +5917,7 @@
           <p:cNvPr id="38" name="">
             <a:extLst xmlns:a="http://schemas.openxmlformats.org/drawingml/2006/main">
               <a:ext uri="{FF2B5EF4-FFF2-40B4-BE49-F238E27FC236}">
-                <a16:creationId xmlns:a16="http://schemas.microsoft.com/office/drawing/2014/main" id="{2A037E01-8D17-44D9-90DD-4AB9A110FED3}"/>
+                <a16:creationId xmlns:a16="http://schemas.microsoft.com/office/drawing/2014/main" id="{59712E77-26A1-48CC-BD21-87F87BAEE70D}"/>
               </a:ext>
             </a:extLst>
           </p:cNvPr>
@@ -5971,7 +5971,7 @@
                 <a:ea typeface="Hiragino Sans"/>
                 <a:cs typeface="Hiragino Sans"/>
               </a:rPr>
-              <a:t>単純規則を超える説明価値があり、MNN変換後もscoreが一致し、per-volume状態とschedulingが予算内に収まる見込みを測れる。</a:t>
+              <a:t>単純規則を超える説明価値があり、MNN変換後のscore差、per-volume状態量、10秒間隔の見込みを測れる。</a:t>
             </a:r>
           </a:p>
         </p:txBody>
@@ -5981,7 +5981,7 @@
           <p:cNvPr id="39" name="">
             <a:extLst xmlns:a="http://schemas.openxmlformats.org/drawingml/2006/main">
               <a:ext uri="{FF2B5EF4-FFF2-40B4-BE49-F238E27FC236}">
-                <a16:creationId xmlns:a16="http://schemas.microsoft.com/office/drawing/2014/main" id="{098ED56D-8F99-4728-8CF8-5080E9E9269B}"/>
+                <a16:creationId xmlns:a16="http://schemas.microsoft.com/office/drawing/2014/main" id="{2022CB9C-789B-445F-BA00-E752B67C2B5F}"/>
               </a:ext>
             </a:extLst>
           </p:cNvPr>
@@ -6014,7 +6014,7 @@
           <p:cNvPr id="40" name="">
             <a:extLst xmlns:a="http://schemas.openxmlformats.org/drawingml/2006/main">
               <a:ext uri="{FF2B5EF4-FFF2-40B4-BE49-F238E27FC236}">
-                <a16:creationId xmlns:a16="http://schemas.microsoft.com/office/drawing/2014/main" id="{DCB95A29-812A-4D63-A527-3DB215299967}"/>
+                <a16:creationId xmlns:a16="http://schemas.microsoft.com/office/drawing/2014/main" id="{E3D1C584-1BF1-4D44-8C2F-411B76A0E25C}"/>
               </a:ext>
             </a:extLst>
           </p:cNvPr>
@@ -6049,7 +6049,7 @@
           <p:cNvPr id="41" name="">
             <a:extLst xmlns:a="http://schemas.openxmlformats.org/drawingml/2006/main">
               <a:ext uri="{FF2B5EF4-FFF2-40B4-BE49-F238E27FC236}">
-                <a16:creationId xmlns:a16="http://schemas.microsoft.com/office/drawing/2014/main" id="{74F73287-00CD-4C66-9E47-7FB8DDE938E7}"/>
+                <a16:creationId xmlns:a16="http://schemas.microsoft.com/office/drawing/2014/main" id="{BA6723CE-CC87-47E4-B738-9415D2A27723}"/>
               </a:ext>
             </a:extLst>
           </p:cNvPr>
@@ -6113,7 +6113,7 @@
           <p:cNvPr id="42" name="">
             <a:extLst xmlns:a="http://schemas.openxmlformats.org/drawingml/2006/main">
               <a:ext uri="{FF2B5EF4-FFF2-40B4-BE49-F238E27FC236}">
-                <a16:creationId xmlns:a16="http://schemas.microsoft.com/office/drawing/2014/main" id="{C521CF27-DBA3-4746-B6D4-15293EE5AB48}"/>
+                <a16:creationId xmlns:a16="http://schemas.microsoft.com/office/drawing/2014/main" id="{029C98C0-F55B-4127-859E-C8E0A8CCDD42}"/>
               </a:ext>
             </a:extLst>
           </p:cNvPr>
@@ -6167,7 +6167,7 @@
                 <a:ea typeface="Hiragino Sans"/>
                 <a:cs typeface="Hiragino Sans"/>
               </a:rPr>
-              <a:t>単純規則で十分、cheap featureが不足、MNN parityが崩れる、500 KBまたは10秒cadenceのどちらかを満たせない。</a:t>
+              <a:t>単純規則で十分、安価な特徴量が不足、MNN score一致が崩れる、500 KBまたは10秒間隔のどちらかを満たせない。</a:t>
             </a:r>
           </a:p>
         </p:txBody>
@@ -6177,7 +6177,7 @@
           <p:cNvPr id="43" name="">
             <a:extLst xmlns:a="http://schemas.openxmlformats.org/drawingml/2006/main">
               <a:ext uri="{FF2B5EF4-FFF2-40B4-BE49-F238E27FC236}">
-                <a16:creationId xmlns:a16="http://schemas.microsoft.com/office/drawing/2014/main" id="{97724D09-5F31-4358-B81B-BE5B4198F32D}"/>
+                <a16:creationId xmlns:a16="http://schemas.microsoft.com/office/drawing/2014/main" id="{961A168C-10AA-410F-99BB-CA63E2A148B9}"/>
               </a:ext>
             </a:extLst>
           </p:cNvPr>
@@ -6212,7 +6212,7 @@
           <p:cNvPr id="44" name="">
             <a:extLst xmlns:a="http://schemas.openxmlformats.org/drawingml/2006/main">
               <a:ext uri="{FF2B5EF4-FFF2-40B4-BE49-F238E27FC236}">
-                <a16:creationId xmlns:a16="http://schemas.microsoft.com/office/drawing/2014/main" id="{4CBB68E7-E40B-452D-8A27-DB9558ECA71B}"/>
+                <a16:creationId xmlns:a16="http://schemas.microsoft.com/office/drawing/2014/main" id="{ABBF74C6-711D-4078-8B88-3E0EBF885BDB}"/>
               </a:ext>
             </a:extLst>
           </p:cNvPr>
@@ -6274,7 +6274,7 @@
     </p:spTree>
     <p:extLst>
       <p:ext uri="{BB962C8B-B14F-4D97-AF65-F5344CB8AC3E}">
-        <p14:creationId xmlns:p14="http://schemas.microsoft.com/office/powerpoint/2010/main" val="956533939"/>
+        <p14:creationId xmlns:p14="http://schemas.microsoft.com/office/powerpoint/2010/main" val="982810906"/>
       </p:ext>
     </p:extLst>
   </p:cSld>
@@ -6298,7 +6298,7 @@
           <p:cNvPr id="1" name="">
             <a:extLst xmlns:a="http://schemas.openxmlformats.org/drawingml/2006/main">
               <a:ext uri="{FF2B5EF4-FFF2-40B4-BE49-F238E27FC236}">
-                <a16:creationId xmlns:a16="http://schemas.microsoft.com/office/drawing/2014/main" id="{996A11F6-E56A-485C-BE24-26023FDEC7D7}"/>
+                <a16:creationId xmlns:a16="http://schemas.microsoft.com/office/drawing/2014/main" id="{F8BF9EA4-AAFA-41C7-A197-2947C873F512}"/>
               </a:ext>
             </a:extLst>
           </p:cNvPr>
@@ -6333,7 +6333,7 @@
           <p:cNvPr id="2" name="">
             <a:extLst xmlns:a="http://schemas.openxmlformats.org/drawingml/2006/main">
               <a:ext uri="{FF2B5EF4-FFF2-40B4-BE49-F238E27FC236}">
-                <a16:creationId xmlns:a16="http://schemas.microsoft.com/office/drawing/2014/main" id="{6A3A3111-4397-4E24-8B69-3BB21BC6C214}"/>
+                <a16:creationId xmlns:a16="http://schemas.microsoft.com/office/drawing/2014/main" id="{2CFC1834-F8DF-4702-8C2F-F907696B2F8F}"/>
               </a:ext>
             </a:extLst>
           </p:cNvPr>
@@ -6368,7 +6368,7 @@
           <p:cNvPr id="3" name="">
             <a:extLst xmlns:a="http://schemas.openxmlformats.org/drawingml/2006/main">
               <a:ext uri="{FF2B5EF4-FFF2-40B4-BE49-F238E27FC236}">
-                <a16:creationId xmlns:a16="http://schemas.microsoft.com/office/drawing/2014/main" id="{DD472F30-955A-441D-A338-4B7BE9178E3F}"/>
+                <a16:creationId xmlns:a16="http://schemas.microsoft.com/office/drawing/2014/main" id="{20CF4E4F-9E25-4DE9-AA61-B69D0CF57D3C}"/>
               </a:ext>
             </a:extLst>
           </p:cNvPr>
@@ -6403,7 +6403,7 @@
           <p:cNvPr id="4" name="">
             <a:extLst xmlns:a="http://schemas.openxmlformats.org/drawingml/2006/main">
               <a:ext uri="{FF2B5EF4-FFF2-40B4-BE49-F238E27FC236}">
-                <a16:creationId xmlns:a16="http://schemas.microsoft.com/office/drawing/2014/main" id="{726FC2D6-E6B9-426C-9B1B-220A2C5B5D6E}"/>
+                <a16:creationId xmlns:a16="http://schemas.microsoft.com/office/drawing/2014/main" id="{4914FCC4-102F-4663-9AF8-4320A9F4DE0F}"/>
               </a:ext>
             </a:extLst>
           </p:cNvPr>
@@ -6467,7 +6467,7 @@
           <p:cNvPr id="5" name="">
             <a:extLst xmlns:a="http://schemas.openxmlformats.org/drawingml/2006/main">
               <a:ext uri="{FF2B5EF4-FFF2-40B4-BE49-F238E27FC236}">
-                <a16:creationId xmlns:a16="http://schemas.microsoft.com/office/drawing/2014/main" id="{95DF4668-6D66-42AB-829E-C6CA08F8FA0C}"/>
+                <a16:creationId xmlns:a16="http://schemas.microsoft.com/office/drawing/2014/main" id="{5B2EEED2-EE0D-4CA8-B240-9642432CD2FE}"/>
               </a:ext>
             </a:extLst>
           </p:cNvPr>
@@ -6531,7 +6531,7 @@
           <p:cNvPr id="6" name="">
             <a:extLst xmlns:a="http://schemas.openxmlformats.org/drawingml/2006/main">
               <a:ext uri="{FF2B5EF4-FFF2-40B4-BE49-F238E27FC236}">
-                <a16:creationId xmlns:a16="http://schemas.microsoft.com/office/drawing/2014/main" id="{A42E6206-211E-46D3-8B21-61F74C2E2A39}"/>
+                <a16:creationId xmlns:a16="http://schemas.microsoft.com/office/drawing/2014/main" id="{B57A1C5A-ED2A-4262-A4A0-53C920BDBE51}"/>
               </a:ext>
             </a:extLst>
           </p:cNvPr>
@@ -6585,7 +6585,7 @@
                 <a:ea typeface="Hiragino Mincho ProN"/>
                 <a:cs typeface="Hiragino Mincho ProN"/>
               </a:rPr>
-              <a:t>生イベントを残さず、10秒統計だけを残す</a:t>
+              <a:t>生イベントを保存せず、10秒統計を入力にする</a:t>
             </a:r>
           </a:p>
         </p:txBody>
@@ -6595,7 +6595,7 @@
           <p:cNvPr id="7" name="">
             <a:extLst xmlns:a="http://schemas.openxmlformats.org/drawingml/2006/main">
               <a:ext uri="{FF2B5EF4-FFF2-40B4-BE49-F238E27FC236}">
-                <a16:creationId xmlns:a16="http://schemas.microsoft.com/office/drawing/2014/main" id="{38DA55A6-EE1A-4DA0-9C78-D59F8145C414}"/>
+                <a16:creationId xmlns:a16="http://schemas.microsoft.com/office/drawing/2014/main" id="{62037E9B-7A6D-410E-A198-F3D66A54A385}"/>
               </a:ext>
             </a:extLst>
           </p:cNvPr>
@@ -6628,7 +6628,7 @@
           <p:cNvPr id="8" name="">
             <a:extLst xmlns:a="http://schemas.openxmlformats.org/drawingml/2006/main">
               <a:ext uri="{FF2B5EF4-FFF2-40B4-BE49-F238E27FC236}">
-                <a16:creationId xmlns:a16="http://schemas.microsoft.com/office/drawing/2014/main" id="{4F705DE1-9EE9-4C9E-9D6E-E3BB98B67BB1}"/>
+                <a16:creationId xmlns:a16="http://schemas.microsoft.com/office/drawing/2014/main" id="{F17C9426-3539-436A-B2D2-E1DD0E91655A}"/>
               </a:ext>
             </a:extLst>
           </p:cNvPr>
@@ -6663,7 +6663,7 @@
           <p:cNvPr id="9" name="">
             <a:extLst xmlns:a="http://schemas.openxmlformats.org/drawingml/2006/main">
               <a:ext uri="{FF2B5EF4-FFF2-40B4-BE49-F238E27FC236}">
-                <a16:creationId xmlns:a16="http://schemas.microsoft.com/office/drawing/2014/main" id="{6DC4C0C8-99D5-4A62-8DE1-CF540AB4FE2D}"/>
+                <a16:creationId xmlns:a16="http://schemas.microsoft.com/office/drawing/2014/main" id="{834537E4-8C6D-4E32-B514-AF2403B74A47}"/>
               </a:ext>
             </a:extLst>
           </p:cNvPr>
@@ -6717,7 +6717,7 @@
                 <a:ea typeface="Hiragino Sans"/>
                 <a:cs typeface="Hiragino Sans"/>
               </a:rPr>
-              <a:t>主張 | 装置に残すのはraw event列ではなく、10秒ごとに集約した固定長の統計列である。</a:t>
+              <a:t>主張 | MLに渡すのは生イベント列ではなく、装置内で低コストに集計できる固定長の10秒統計列である。</a:t>
             </a:r>
           </a:p>
         </p:txBody>
@@ -6727,7 +6727,7 @@
           <p:cNvPr id="10" name="">
             <a:extLst xmlns:a="http://schemas.openxmlformats.org/drawingml/2006/main">
               <a:ext uri="{FF2B5EF4-FFF2-40B4-BE49-F238E27FC236}">
-                <a16:creationId xmlns:a16="http://schemas.microsoft.com/office/drawing/2014/main" id="{8A84E9D3-1BDD-462E-8A29-910E00CD4A50}"/>
+                <a16:creationId xmlns:a16="http://schemas.microsoft.com/office/drawing/2014/main" id="{85E40A6B-C3C7-485F-B7D5-CC9D0552F887}"/>
               </a:ext>
             </a:extLst>
           </p:cNvPr>
@@ -6760,7 +6760,7 @@
           <p:cNvPr id="11" name="">
             <a:extLst xmlns:a="http://schemas.openxmlformats.org/drawingml/2006/main">
               <a:ext uri="{FF2B5EF4-FFF2-40B4-BE49-F238E27FC236}">
-                <a16:creationId xmlns:a16="http://schemas.microsoft.com/office/drawing/2014/main" id="{DB2A5320-ED0A-499F-BC2E-F7ECA176772F}"/>
+                <a16:creationId xmlns:a16="http://schemas.microsoft.com/office/drawing/2014/main" id="{9F2E4EB8-D8A8-4A6F-9E39-707CBF2396E7}"/>
               </a:ext>
             </a:extLst>
           </p:cNvPr>
@@ -6795,7 +6795,7 @@
           <p:cNvPr id="12" name="">
             <a:extLst xmlns:a="http://schemas.openxmlformats.org/drawingml/2006/main">
               <a:ext uri="{FF2B5EF4-FFF2-40B4-BE49-F238E27FC236}">
-                <a16:creationId xmlns:a16="http://schemas.microsoft.com/office/drawing/2014/main" id="{9B96AA88-EC5A-4DB9-83DB-5B4989571FEF}"/>
+                <a16:creationId xmlns:a16="http://schemas.microsoft.com/office/drawing/2014/main" id="{B1C53FC6-D1D3-41F5-A6B3-E9098600D557}"/>
               </a:ext>
             </a:extLst>
           </p:cNvPr>
@@ -6849,7 +6849,7 @@
                 <a:ea typeface="Hiragino Sans"/>
                 <a:cs typeface="Hiragino Sans"/>
               </a:rPr>
-              <a:t>frame_10s: 装置が安く集計できる候補</a:t>
+              <a:t>frame_10s: 装置で低コストに集計できる候補</a:t>
             </a:r>
           </a:p>
         </p:txBody>
@@ -6859,7 +6859,7 @@
           <p:cNvPr id="13" name="">
             <a:extLst xmlns:a="http://schemas.openxmlformats.org/drawingml/2006/main">
               <a:ext uri="{FF2B5EF4-FFF2-40B4-BE49-F238E27FC236}">
-                <a16:creationId xmlns:a16="http://schemas.microsoft.com/office/drawing/2014/main" id="{5A168818-2AF7-47F4-9A06-61A2031691B5}"/>
+                <a16:creationId xmlns:a16="http://schemas.microsoft.com/office/drawing/2014/main" id="{D7ED7D06-50D0-4921-BC24-F172D72B6833}"/>
               </a:ext>
             </a:extLst>
           </p:cNvPr>
@@ -6892,7 +6892,7 @@
           <p:cNvPr id="14" name="">
             <a:extLst xmlns:a="http://schemas.openxmlformats.org/drawingml/2006/main">
               <a:ext uri="{FF2B5EF4-FFF2-40B4-BE49-F238E27FC236}">
-                <a16:creationId xmlns:a16="http://schemas.microsoft.com/office/drawing/2014/main" id="{859719A6-6CA2-4EBE-8C06-4B15FB4174AF}"/>
+                <a16:creationId xmlns:a16="http://schemas.microsoft.com/office/drawing/2014/main" id="{AFE7176C-A8EB-4AED-8384-EE2C32AB31FD}"/>
               </a:ext>
             </a:extLst>
           </p:cNvPr>
@@ -6956,7 +6956,7 @@
           <p:cNvPr id="15" name="">
             <a:extLst xmlns:a="http://schemas.openxmlformats.org/drawingml/2006/main">
               <a:ext uri="{FF2B5EF4-FFF2-40B4-BE49-F238E27FC236}">
-                <a16:creationId xmlns:a16="http://schemas.microsoft.com/office/drawing/2014/main" id="{5BBA6879-D018-4771-801C-8C981C79E926}"/>
+                <a16:creationId xmlns:a16="http://schemas.microsoft.com/office/drawing/2014/main" id="{FD89F57F-FC27-432C-9F46-5B3225EA8BEC}"/>
               </a:ext>
             </a:extLst>
           </p:cNvPr>
@@ -6991,7 +6991,7 @@
           <p:cNvPr id="16" name="">
             <a:extLst xmlns:a="http://schemas.openxmlformats.org/drawingml/2006/main">
               <a:ext uri="{FF2B5EF4-FFF2-40B4-BE49-F238E27FC236}">
-                <a16:creationId xmlns:a16="http://schemas.microsoft.com/office/drawing/2014/main" id="{9E0B394F-D62C-494B-ABB4-7C3746D1B7A1}"/>
+                <a16:creationId xmlns:a16="http://schemas.microsoft.com/office/drawing/2014/main" id="{883C8BC0-1E38-49B8-A473-D101C45E8644}"/>
               </a:ext>
             </a:extLst>
           </p:cNvPr>
@@ -7055,7 +7055,7 @@
           <p:cNvPr id="17" name="">
             <a:extLst xmlns:a="http://schemas.openxmlformats.org/drawingml/2006/main">
               <a:ext uri="{FF2B5EF4-FFF2-40B4-BE49-F238E27FC236}">
-                <a16:creationId xmlns:a16="http://schemas.microsoft.com/office/drawing/2014/main" id="{F32A91F8-C1F8-4D88-8F1B-B34D2295B223}"/>
+                <a16:creationId xmlns:a16="http://schemas.microsoft.com/office/drawing/2014/main" id="{69D340BC-A6DB-482E-83E4-F739309CEBA4}"/>
               </a:ext>
             </a:extLst>
           </p:cNvPr>
@@ -7088,7 +7088,7 @@
           <p:cNvPr id="18" name="">
             <a:extLst xmlns:a="http://schemas.openxmlformats.org/drawingml/2006/main">
               <a:ext uri="{FF2B5EF4-FFF2-40B4-BE49-F238E27FC236}">
-                <a16:creationId xmlns:a16="http://schemas.microsoft.com/office/drawing/2014/main" id="{8257DC21-237C-4996-B2D7-E64332230F28}"/>
+                <a16:creationId xmlns:a16="http://schemas.microsoft.com/office/drawing/2014/main" id="{B94CA007-B988-4333-B7C4-F1179BAD33C5}"/>
               </a:ext>
             </a:extLst>
           </p:cNvPr>
@@ -7152,7 +7152,7 @@
           <p:cNvPr id="19" name="">
             <a:extLst xmlns:a="http://schemas.openxmlformats.org/drawingml/2006/main">
               <a:ext uri="{FF2B5EF4-FFF2-40B4-BE49-F238E27FC236}">
-                <a16:creationId xmlns:a16="http://schemas.microsoft.com/office/drawing/2014/main" id="{AC1AB28C-66B1-4517-B374-E92B20AEFFEE}"/>
+                <a16:creationId xmlns:a16="http://schemas.microsoft.com/office/drawing/2014/main" id="{80C089E9-8855-43E9-8CD8-962970A8316B}"/>
               </a:ext>
             </a:extLst>
           </p:cNvPr>
@@ -7187,7 +7187,7 @@
           <p:cNvPr id="20" name="">
             <a:extLst xmlns:a="http://schemas.openxmlformats.org/drawingml/2006/main">
               <a:ext uri="{FF2B5EF4-FFF2-40B4-BE49-F238E27FC236}">
-                <a16:creationId xmlns:a16="http://schemas.microsoft.com/office/drawing/2014/main" id="{02EDB78F-658E-4A31-8653-E14FE365BABB}"/>
+                <a16:creationId xmlns:a16="http://schemas.microsoft.com/office/drawing/2014/main" id="{150DC7BA-F206-4B7D-9BCF-A46AEF027FB2}"/>
               </a:ext>
             </a:extLst>
           </p:cNvPr>
@@ -7251,7 +7251,7 @@
           <p:cNvPr id="21" name="">
             <a:extLst xmlns:a="http://schemas.openxmlformats.org/drawingml/2006/main">
               <a:ext uri="{FF2B5EF4-FFF2-40B4-BE49-F238E27FC236}">
-                <a16:creationId xmlns:a16="http://schemas.microsoft.com/office/drawing/2014/main" id="{223B010E-1428-455E-B48A-D7AB289A2AD4}"/>
+                <a16:creationId xmlns:a16="http://schemas.microsoft.com/office/drawing/2014/main" id="{A86415EC-D4AA-449B-8F1B-B23051812AA6}"/>
               </a:ext>
             </a:extLst>
           </p:cNvPr>
@@ -7284,7 +7284,7 @@
           <p:cNvPr id="22" name="">
             <a:extLst xmlns:a="http://schemas.openxmlformats.org/drawingml/2006/main">
               <a:ext uri="{FF2B5EF4-FFF2-40B4-BE49-F238E27FC236}">
-                <a16:creationId xmlns:a16="http://schemas.microsoft.com/office/drawing/2014/main" id="{6AC3F1E7-E9BF-4E27-9741-F9404C9AD85C}"/>
+                <a16:creationId xmlns:a16="http://schemas.microsoft.com/office/drawing/2014/main" id="{D39AD121-9ADE-4A35-A11B-C51C266E0F9B}"/>
               </a:ext>
             </a:extLst>
           </p:cNvPr>
@@ -7348,7 +7348,7 @@
           <p:cNvPr id="23" name="">
             <a:extLst xmlns:a="http://schemas.openxmlformats.org/drawingml/2006/main">
               <a:ext uri="{FF2B5EF4-FFF2-40B4-BE49-F238E27FC236}">
-                <a16:creationId xmlns:a16="http://schemas.microsoft.com/office/drawing/2014/main" id="{C750E8DB-A3AA-479E-9A00-9DE0340756EC}"/>
+                <a16:creationId xmlns:a16="http://schemas.microsoft.com/office/drawing/2014/main" id="{4D9B01D9-E402-466A-BB53-6B2130FF93EC}"/>
               </a:ext>
             </a:extLst>
           </p:cNvPr>
@@ -7383,7 +7383,7 @@
           <p:cNvPr id="24" name="">
             <a:extLst xmlns:a="http://schemas.openxmlformats.org/drawingml/2006/main">
               <a:ext uri="{FF2B5EF4-FFF2-40B4-BE49-F238E27FC236}">
-                <a16:creationId xmlns:a16="http://schemas.microsoft.com/office/drawing/2014/main" id="{5FEE3A4A-F592-4AE7-8D24-9A50BD6D3DCD}"/>
+                <a16:creationId xmlns:a16="http://schemas.microsoft.com/office/drawing/2014/main" id="{F7A424B5-C805-4BDF-9BC6-4FC29B665B92}"/>
               </a:ext>
             </a:extLst>
           </p:cNvPr>
@@ -7447,7 +7447,7 @@
           <p:cNvPr id="25" name="">
             <a:extLst xmlns:a="http://schemas.openxmlformats.org/drawingml/2006/main">
               <a:ext uri="{FF2B5EF4-FFF2-40B4-BE49-F238E27FC236}">
-                <a16:creationId xmlns:a16="http://schemas.microsoft.com/office/drawing/2014/main" id="{D584D574-AF0C-42EA-AEDC-81C459470882}"/>
+                <a16:creationId xmlns:a16="http://schemas.microsoft.com/office/drawing/2014/main" id="{5282DA59-1C06-439A-8640-E4BBA4E8E180}"/>
               </a:ext>
             </a:extLst>
           </p:cNvPr>
@@ -7480,7 +7480,7 @@
           <p:cNvPr id="26" name="">
             <a:extLst xmlns:a="http://schemas.openxmlformats.org/drawingml/2006/main">
               <a:ext uri="{FF2B5EF4-FFF2-40B4-BE49-F238E27FC236}">
-                <a16:creationId xmlns:a16="http://schemas.microsoft.com/office/drawing/2014/main" id="{C2096329-2095-4298-9AF4-49D23851D874}"/>
+                <a16:creationId xmlns:a16="http://schemas.microsoft.com/office/drawing/2014/main" id="{184D34F0-8AEA-4B0B-8559-6A0FC0408BAA}"/>
               </a:ext>
             </a:extLst>
           </p:cNvPr>
@@ -7544,7 +7544,7 @@
           <p:cNvPr id="27" name="">
             <a:extLst xmlns:a="http://schemas.openxmlformats.org/drawingml/2006/main">
               <a:ext uri="{FF2B5EF4-FFF2-40B4-BE49-F238E27FC236}">
-                <a16:creationId xmlns:a16="http://schemas.microsoft.com/office/drawing/2014/main" id="{A428B0C2-1948-4F6C-BC34-23928759EF81}"/>
+                <a16:creationId xmlns:a16="http://schemas.microsoft.com/office/drawing/2014/main" id="{D5FDE7BF-C9ED-4764-9754-0C2313A3FD7B}"/>
               </a:ext>
             </a:extLst>
           </p:cNvPr>
@@ -7579,7 +7579,7 @@
           <p:cNvPr id="28" name="">
             <a:extLst xmlns:a="http://schemas.openxmlformats.org/drawingml/2006/main">
               <a:ext uri="{FF2B5EF4-FFF2-40B4-BE49-F238E27FC236}">
-                <a16:creationId xmlns:a16="http://schemas.microsoft.com/office/drawing/2014/main" id="{A2348508-0069-4B53-92FD-3A4BDE4012AC}"/>
+                <a16:creationId xmlns:a16="http://schemas.microsoft.com/office/drawing/2014/main" id="{0B953DB6-228A-4972-84D5-9A5C19F33601}"/>
               </a:ext>
             </a:extLst>
           </p:cNvPr>
@@ -7643,7 +7643,7 @@
           <p:cNvPr id="29" name="">
             <a:extLst xmlns:a="http://schemas.openxmlformats.org/drawingml/2006/main">
               <a:ext uri="{FF2B5EF4-FFF2-40B4-BE49-F238E27FC236}">
-                <a16:creationId xmlns:a16="http://schemas.microsoft.com/office/drawing/2014/main" id="{F382C06C-2D5D-4E04-AB89-5D5A7558E58F}"/>
+                <a16:creationId xmlns:a16="http://schemas.microsoft.com/office/drawing/2014/main" id="{12595550-80B0-427E-A913-8E04463E7230}"/>
               </a:ext>
             </a:extLst>
           </p:cNvPr>
@@ -7676,7 +7676,7 @@
           <p:cNvPr id="30" name="">
             <a:extLst xmlns:a="http://schemas.openxmlformats.org/drawingml/2006/main">
               <a:ext uri="{FF2B5EF4-FFF2-40B4-BE49-F238E27FC236}">
-                <a16:creationId xmlns:a16="http://schemas.microsoft.com/office/drawing/2014/main" id="{F60AC65D-87BA-48F1-A598-E831309D1F2C}"/>
+                <a16:creationId xmlns:a16="http://schemas.microsoft.com/office/drawing/2014/main" id="{D67E285F-078E-46FB-BE9A-D070A94BEC05}"/>
               </a:ext>
             </a:extLst>
           </p:cNvPr>
@@ -7740,7 +7740,7 @@
           <p:cNvPr id="31" name="">
             <a:extLst xmlns:a="http://schemas.openxmlformats.org/drawingml/2006/main">
               <a:ext uri="{FF2B5EF4-FFF2-40B4-BE49-F238E27FC236}">
-                <a16:creationId xmlns:a16="http://schemas.microsoft.com/office/drawing/2014/main" id="{967245EA-B3EF-4AB0-B932-A3AFD5470F33}"/>
+                <a16:creationId xmlns:a16="http://schemas.microsoft.com/office/drawing/2014/main" id="{D4C511ED-0695-4909-B047-104A28B0C72A}"/>
               </a:ext>
             </a:extLst>
           </p:cNvPr>
@@ -7775,7 +7775,7 @@
           <p:cNvPr id="32" name="">
             <a:extLst xmlns:a="http://schemas.openxmlformats.org/drawingml/2006/main">
               <a:ext uri="{FF2B5EF4-FFF2-40B4-BE49-F238E27FC236}">
-                <a16:creationId xmlns:a16="http://schemas.microsoft.com/office/drawing/2014/main" id="{349993C5-B4CA-4C6C-8247-CEEBFE36EEED}"/>
+                <a16:creationId xmlns:a16="http://schemas.microsoft.com/office/drawing/2014/main" id="{327C7A3E-4AD6-4422-9611-C6809A7CB47E}"/>
               </a:ext>
             </a:extLst>
           </p:cNvPr>
@@ -7839,7 +7839,7 @@
           <p:cNvPr id="33" name="">
             <a:extLst xmlns:a="http://schemas.openxmlformats.org/drawingml/2006/main">
               <a:ext uri="{FF2B5EF4-FFF2-40B4-BE49-F238E27FC236}">
-                <a16:creationId xmlns:a16="http://schemas.microsoft.com/office/drawing/2014/main" id="{D4764C61-285F-4D5C-8D1C-B9E431F48428}"/>
+                <a16:creationId xmlns:a16="http://schemas.microsoft.com/office/drawing/2014/main" id="{C3FE1E94-5DC2-49D7-B2C6-B15B4271EC0A}"/>
               </a:ext>
             </a:extLst>
           </p:cNvPr>
@@ -7872,7 +7872,7 @@
           <p:cNvPr id="34" name="">
             <a:extLst xmlns:a="http://schemas.openxmlformats.org/drawingml/2006/main">
               <a:ext uri="{FF2B5EF4-FFF2-40B4-BE49-F238E27FC236}">
-                <a16:creationId xmlns:a16="http://schemas.microsoft.com/office/drawing/2014/main" id="{FEF44244-9EFB-4FE5-9618-5E12E753808C}"/>
+                <a16:creationId xmlns:a16="http://schemas.microsoft.com/office/drawing/2014/main" id="{DF1BED2C-B48E-447C-B535-85627B9D01F9}"/>
               </a:ext>
             </a:extLst>
           </p:cNvPr>
@@ -7936,7 +7936,7 @@
           <p:cNvPr id="35" name="">
             <a:extLst xmlns:a="http://schemas.openxmlformats.org/drawingml/2006/main">
               <a:ext uri="{FF2B5EF4-FFF2-40B4-BE49-F238E27FC236}">
-                <a16:creationId xmlns:a16="http://schemas.microsoft.com/office/drawing/2014/main" id="{8AB5E9C1-01E8-4D18-ACFE-362743F7BF6E}"/>
+                <a16:creationId xmlns:a16="http://schemas.microsoft.com/office/drawing/2014/main" id="{76E29958-B9E8-4E00-BB08-94C915F4D7B6}"/>
               </a:ext>
             </a:extLst>
           </p:cNvPr>
@@ -7971,7 +7971,7 @@
           <p:cNvPr id="36" name="">
             <a:extLst xmlns:a="http://schemas.openxmlformats.org/drawingml/2006/main">
               <a:ext uri="{FF2B5EF4-FFF2-40B4-BE49-F238E27FC236}">
-                <a16:creationId xmlns:a16="http://schemas.microsoft.com/office/drawing/2014/main" id="{24829FE2-723F-436A-9B91-DB1E4EA515BE}"/>
+                <a16:creationId xmlns:a16="http://schemas.microsoft.com/office/drawing/2014/main" id="{B0A70C34-81CA-409C-AE45-F8834DC99481}"/>
               </a:ext>
             </a:extLst>
           </p:cNvPr>
@@ -8025,7 +8025,7 @@
                 <a:ea typeface="Hiragino Sans"/>
                 <a:cs typeface="Hiragino Sans"/>
               </a:rPr>
-              <a:t>安い圧縮/entropy風カウンタがある時だけ</a:t>
+              <a:t>低コストな圧縮/entropy系カウンタがある場合のみ</a:t>
             </a:r>
           </a:p>
         </p:txBody>
@@ -8035,7 +8035,7 @@
           <p:cNvPr id="37" name="">
             <a:extLst xmlns:a="http://schemas.openxmlformats.org/drawingml/2006/main">
               <a:ext uri="{FF2B5EF4-FFF2-40B4-BE49-F238E27FC236}">
-                <a16:creationId xmlns:a16="http://schemas.microsoft.com/office/drawing/2014/main" id="{922259F5-4461-483F-A6E0-6118237796C6}"/>
+                <a16:creationId xmlns:a16="http://schemas.microsoft.com/office/drawing/2014/main" id="{E28EE6C6-068F-4630-A5EB-F4B5C40BCBEF}"/>
               </a:ext>
             </a:extLst>
           </p:cNvPr>
@@ -8068,7 +8068,7 @@
           <p:cNvPr id="38" name="">
             <a:extLst xmlns:a="http://schemas.openxmlformats.org/drawingml/2006/main">
               <a:ext uri="{FF2B5EF4-FFF2-40B4-BE49-F238E27FC236}">
-                <a16:creationId xmlns:a16="http://schemas.microsoft.com/office/drawing/2014/main" id="{811AE63F-3999-4E48-8BF0-4C94D016CE72}"/>
+                <a16:creationId xmlns:a16="http://schemas.microsoft.com/office/drawing/2014/main" id="{655B5E40-1803-4292-BF72-70553E0FF939}"/>
               </a:ext>
             </a:extLst>
           </p:cNvPr>
@@ -8132,7 +8132,7 @@
           <p:cNvPr id="39" name="">
             <a:extLst xmlns:a="http://schemas.openxmlformats.org/drawingml/2006/main">
               <a:ext uri="{FF2B5EF4-FFF2-40B4-BE49-F238E27FC236}">
-                <a16:creationId xmlns:a16="http://schemas.microsoft.com/office/drawing/2014/main" id="{BF96E35D-D5AE-46E0-90B8-1CE0DD3DDE87}"/>
+                <a16:creationId xmlns:a16="http://schemas.microsoft.com/office/drawing/2014/main" id="{E8D3C71A-0AD0-4005-A874-576EC065AA21}"/>
               </a:ext>
             </a:extLst>
           </p:cNvPr>
@@ -8167,7 +8167,7 @@
           <p:cNvPr id="40" name="">
             <a:extLst xmlns:a="http://schemas.openxmlformats.org/drawingml/2006/main">
               <a:ext uri="{FF2B5EF4-FFF2-40B4-BE49-F238E27FC236}">
-                <a16:creationId xmlns:a16="http://schemas.microsoft.com/office/drawing/2014/main" id="{0CD38D54-93EE-4FA3-AF56-0AAF74296A05}"/>
+                <a16:creationId xmlns:a16="http://schemas.microsoft.com/office/drawing/2014/main" id="{FC952265-81D4-4391-A36F-6245F0B46231}"/>
               </a:ext>
             </a:extLst>
           </p:cNvPr>
@@ -8221,7 +8221,7 @@
                 <a:ea typeface="Hiragino Sans"/>
                 <a:cs typeface="Hiragino Sans"/>
               </a:rPr>
-              <a:t>未提供欄はloss/scoreから外す</a:t>
+              <a:t>未提供の列はloss/scoreから外す</a:t>
             </a:r>
           </a:p>
         </p:txBody>
@@ -8231,7 +8231,7 @@
           <p:cNvPr id="41" name="">
             <a:extLst xmlns:a="http://schemas.openxmlformats.org/drawingml/2006/main">
               <a:ext uri="{FF2B5EF4-FFF2-40B4-BE49-F238E27FC236}">
-                <a16:creationId xmlns:a16="http://schemas.microsoft.com/office/drawing/2014/main" id="{0CBEB4FB-44C4-427A-8CEB-D143A1665D84}"/>
+                <a16:creationId xmlns:a16="http://schemas.microsoft.com/office/drawing/2014/main" id="{0CCDCA94-85C2-4FB3-93CD-C37A3A729396}"/>
               </a:ext>
             </a:extLst>
           </p:cNvPr>
@@ -8264,7 +8264,7 @@
           <p:cNvPr id="42" name="">
             <a:extLst xmlns:a="http://schemas.openxmlformats.org/drawingml/2006/main">
               <a:ext uri="{FF2B5EF4-FFF2-40B4-BE49-F238E27FC236}">
-                <a16:creationId xmlns:a16="http://schemas.microsoft.com/office/drawing/2014/main" id="{8AD70181-A804-4FEC-8736-F6D4A615305F}"/>
+                <a16:creationId xmlns:a16="http://schemas.microsoft.com/office/drawing/2014/main" id="{43D82DA3-00DA-4E89-A5E2-014F6E31E81D}"/>
               </a:ext>
             </a:extLst>
           </p:cNvPr>
@@ -8420,7 +8420,7 @@
           <p:cNvPr id="43" name="">
             <a:extLst xmlns:a="http://schemas.openxmlformats.org/drawingml/2006/main">
               <a:ext uri="{FF2B5EF4-FFF2-40B4-BE49-F238E27FC236}">
-                <a16:creationId xmlns:a16="http://schemas.microsoft.com/office/drawing/2014/main" id="{9AF95847-EFAA-442A-B60C-73A2174007AF}"/>
+                <a16:creationId xmlns:a16="http://schemas.microsoft.com/office/drawing/2014/main" id="{677E9878-722F-4DA9-8C9A-91319D9797F0}"/>
               </a:ext>
             </a:extLst>
           </p:cNvPr>
@@ -8453,7 +8453,7 @@
           <p:cNvPr id="44" name="">
             <a:extLst xmlns:a="http://schemas.openxmlformats.org/drawingml/2006/main">
               <a:ext uri="{FF2B5EF4-FFF2-40B4-BE49-F238E27FC236}">
-                <a16:creationId xmlns:a16="http://schemas.microsoft.com/office/drawing/2014/main" id="{5FB15FD3-A6AE-42F5-80BA-EE18EA5A4F6F}"/>
+                <a16:creationId xmlns:a16="http://schemas.microsoft.com/office/drawing/2014/main" id="{DDABEEE5-E601-4AC5-B4A6-98949B35F315}"/>
               </a:ext>
             </a:extLst>
           </p:cNvPr>
@@ -8488,7 +8488,7 @@
           <p:cNvPr id="45" name="">
             <a:extLst xmlns:a="http://schemas.openxmlformats.org/drawingml/2006/main">
               <a:ext uri="{FF2B5EF4-FFF2-40B4-BE49-F238E27FC236}">
-                <a16:creationId xmlns:a16="http://schemas.microsoft.com/office/drawing/2014/main" id="{191FFCDF-398E-4A0D-95EF-D3D4F8A9EF2A}"/>
+                <a16:creationId xmlns:a16="http://schemas.microsoft.com/office/drawing/2014/main" id="{FA2DCC4C-4155-4316-8A19-28243528F78E}"/>
               </a:ext>
             </a:extLst>
           </p:cNvPr>
@@ -8542,7 +8542,7 @@
                 <a:ea typeface="Hiragino Sans"/>
                 <a:cs typeface="Hiragino Sans"/>
               </a:rPr>
-              <a:t>なぜ固定shapeか</a:t>
+              <a:t>固定長にする理由</a:t>
             </a:r>
           </a:p>
         </p:txBody>
@@ -8552,7 +8552,7 @@
           <p:cNvPr id="46" name="">
             <a:extLst xmlns:a="http://schemas.openxmlformats.org/drawingml/2006/main">
               <a:ext uri="{FF2B5EF4-FFF2-40B4-BE49-F238E27FC236}">
-                <a16:creationId xmlns:a16="http://schemas.microsoft.com/office/drawing/2014/main" id="{396316D9-64ED-4B41-9B6E-505F54C8264A}"/>
+                <a16:creationId xmlns:a16="http://schemas.microsoft.com/office/drawing/2014/main" id="{B871C7FB-941C-40FD-B09E-BDA9B169492C}"/>
               </a:ext>
             </a:extLst>
           </p:cNvPr>
@@ -8616,7 +8616,7 @@
           <p:cNvPr id="47" name="">
             <a:extLst xmlns:a="http://schemas.openxmlformats.org/drawingml/2006/main">
               <a:ext uri="{FF2B5EF4-FFF2-40B4-BE49-F238E27FC236}">
-                <a16:creationId xmlns:a16="http://schemas.microsoft.com/office/drawing/2014/main" id="{A1808295-7B99-4DF5-934D-7843232C76F6}"/>
+                <a16:creationId xmlns:a16="http://schemas.microsoft.com/office/drawing/2014/main" id="{C233E07F-B904-4597-9A77-0ED673D98317}"/>
               </a:ext>
             </a:extLst>
           </p:cNvPr>
@@ -8649,7 +8649,7 @@
           <p:cNvPr id="48" name="">
             <a:extLst xmlns:a="http://schemas.openxmlformats.org/drawingml/2006/main">
               <a:ext uri="{FF2B5EF4-FFF2-40B4-BE49-F238E27FC236}">
-                <a16:creationId xmlns:a16="http://schemas.microsoft.com/office/drawing/2014/main" id="{A429E99A-91B2-4A4A-9433-F3C2562FFBC2}"/>
+                <a16:creationId xmlns:a16="http://schemas.microsoft.com/office/drawing/2014/main" id="{4D387504-C0C9-4118-92DB-90ED0EDC7DC1}"/>
               </a:ext>
             </a:extLst>
           </p:cNvPr>
@@ -8703,7 +8703,7 @@
                 <a:ea typeface="Hiragino Sans"/>
                 <a:cs typeface="Hiragino Sans"/>
               </a:rPr>
-              <a:t>使わない: ファイルパス / プロセス名 / ランサムウェア署名 / ファイル本文scan</a:t>
+              <a:t>使わない: ファイルパス / プロセス名 / ランサムウェア署名 / ファイル本文スキャン</a:t>
             </a:r>
           </a:p>
         </p:txBody>
@@ -8713,7 +8713,7 @@
           <p:cNvPr id="49" name="">
             <a:extLst xmlns:a="http://schemas.openxmlformats.org/drawingml/2006/main">
               <a:ext uri="{FF2B5EF4-FFF2-40B4-BE49-F238E27FC236}">
-                <a16:creationId xmlns:a16="http://schemas.microsoft.com/office/drawing/2014/main" id="{F29A90C0-658E-4D9D-BDA4-42904E4D027E}"/>
+                <a16:creationId xmlns:a16="http://schemas.microsoft.com/office/drawing/2014/main" id="{CBF0ECC9-6CB7-43D0-8762-B88126EB8679}"/>
               </a:ext>
             </a:extLst>
           </p:cNvPr>
@@ -8746,7 +8746,7 @@
           <p:cNvPr id="50" name="">
             <a:extLst xmlns:a="http://schemas.openxmlformats.org/drawingml/2006/main">
               <a:ext uri="{FF2B5EF4-FFF2-40B4-BE49-F238E27FC236}">
-                <a16:creationId xmlns:a16="http://schemas.microsoft.com/office/drawing/2014/main" id="{FC821039-40A7-4601-80E8-FA65C9783CB7}"/>
+                <a16:creationId xmlns:a16="http://schemas.microsoft.com/office/drawing/2014/main" id="{77E195D0-847A-4853-8270-C7AF9ACAB656}"/>
               </a:ext>
             </a:extLst>
           </p:cNvPr>
@@ -8800,7 +8800,7 @@
                 <a:ea typeface="Hiragino Sans"/>
                 <a:cs typeface="Hiragino Sans"/>
               </a:rPr>
-              <a:t>使う: SCSI/NVMe風メタデータ と 安い装置カウンタ</a:t>
+              <a:t>使う: SCSI/NVMe相当のメタデータ と 軽量カウンタ</a:t>
             </a:r>
           </a:p>
         </p:txBody>
@@ -8810,7 +8810,7 @@
           <p:cNvPr id="51" name="">
             <a:extLst xmlns:a="http://schemas.openxmlformats.org/drawingml/2006/main">
               <a:ext uri="{FF2B5EF4-FFF2-40B4-BE49-F238E27FC236}">
-                <a16:creationId xmlns:a16="http://schemas.microsoft.com/office/drawing/2014/main" id="{3136CAE1-75B2-4BE7-8ACE-32770920C0C1}"/>
+                <a16:creationId xmlns:a16="http://schemas.microsoft.com/office/drawing/2014/main" id="{04467D31-AADC-44FE-B677-D2C0BC03DB03}"/>
               </a:ext>
             </a:extLst>
           </p:cNvPr>
@@ -8845,7 +8845,7 @@
           <p:cNvPr id="52" name="">
             <a:extLst xmlns:a="http://schemas.openxmlformats.org/drawingml/2006/main">
               <a:ext uri="{FF2B5EF4-FFF2-40B4-BE49-F238E27FC236}">
-                <a16:creationId xmlns:a16="http://schemas.microsoft.com/office/drawing/2014/main" id="{5875FE6D-7C10-4605-A503-F572BFDFBDCA}"/>
+                <a16:creationId xmlns:a16="http://schemas.microsoft.com/office/drawing/2014/main" id="{0B6A6872-FA9B-4912-957F-332D409AE76D}"/>
               </a:ext>
             </a:extLst>
           </p:cNvPr>
@@ -8907,7 +8907,7 @@
     </p:spTree>
     <p:extLst>
       <p:ext uri="{BB962C8B-B14F-4D97-AF65-F5344CB8AC3E}">
-        <p14:creationId xmlns:p14="http://schemas.microsoft.com/office/powerpoint/2010/main" val="1005806483"/>
+        <p14:creationId xmlns:p14="http://schemas.microsoft.com/office/powerpoint/2010/main" val="2071815301"/>
       </p:ext>
     </p:extLst>
   </p:cSld>
@@ -8931,7 +8931,7 @@
           <p:cNvPr id="1" name="">
             <a:extLst xmlns:a="http://schemas.openxmlformats.org/drawingml/2006/main">
               <a:ext uri="{FF2B5EF4-FFF2-40B4-BE49-F238E27FC236}">
-                <a16:creationId xmlns:a16="http://schemas.microsoft.com/office/drawing/2014/main" id="{8C820FC6-DC63-4E4A-B867-45A55C528A15}"/>
+                <a16:creationId xmlns:a16="http://schemas.microsoft.com/office/drawing/2014/main" id="{A931A857-AAAE-473E-B122-FC60B70AF404}"/>
               </a:ext>
             </a:extLst>
           </p:cNvPr>
@@ -8966,7 +8966,7 @@
           <p:cNvPr id="2" name="">
             <a:extLst xmlns:a="http://schemas.openxmlformats.org/drawingml/2006/main">
               <a:ext uri="{FF2B5EF4-FFF2-40B4-BE49-F238E27FC236}">
-                <a16:creationId xmlns:a16="http://schemas.microsoft.com/office/drawing/2014/main" id="{52EA2C59-6919-43C0-8515-71BF1F0FFB87}"/>
+                <a16:creationId xmlns:a16="http://schemas.microsoft.com/office/drawing/2014/main" id="{FC9719A9-AC3B-4959-A706-467EF1B46A9B}"/>
               </a:ext>
             </a:extLst>
           </p:cNvPr>
@@ -9001,7 +9001,7 @@
           <p:cNvPr id="3" name="">
             <a:extLst xmlns:a="http://schemas.openxmlformats.org/drawingml/2006/main">
               <a:ext uri="{FF2B5EF4-FFF2-40B4-BE49-F238E27FC236}">
-                <a16:creationId xmlns:a16="http://schemas.microsoft.com/office/drawing/2014/main" id="{CC46E333-1581-4998-8C25-00D91662C2C2}"/>
+                <a16:creationId xmlns:a16="http://schemas.microsoft.com/office/drawing/2014/main" id="{FD71BFE9-0C0B-40AF-99A0-7BFD68CFA1A0}"/>
               </a:ext>
             </a:extLst>
           </p:cNvPr>
@@ -9036,7 +9036,7 @@
           <p:cNvPr id="4" name="">
             <a:extLst xmlns:a="http://schemas.openxmlformats.org/drawingml/2006/main">
               <a:ext uri="{FF2B5EF4-FFF2-40B4-BE49-F238E27FC236}">
-                <a16:creationId xmlns:a16="http://schemas.microsoft.com/office/drawing/2014/main" id="{1B421EF9-1A8A-4A46-B987-C0CA86321E55}"/>
+                <a16:creationId xmlns:a16="http://schemas.microsoft.com/office/drawing/2014/main" id="{1EB78EE0-DE0A-473A-950B-02FFF89FDBF8}"/>
               </a:ext>
             </a:extLst>
           </p:cNvPr>
@@ -9100,7 +9100,7 @@
           <p:cNvPr id="5" name="">
             <a:extLst xmlns:a="http://schemas.openxmlformats.org/drawingml/2006/main">
               <a:ext uri="{FF2B5EF4-FFF2-40B4-BE49-F238E27FC236}">
-                <a16:creationId xmlns:a16="http://schemas.microsoft.com/office/drawing/2014/main" id="{16A5FB4A-BBCF-41EF-B083-A532089B7205}"/>
+                <a16:creationId xmlns:a16="http://schemas.microsoft.com/office/drawing/2014/main" id="{6E26B4C5-8BBF-46BC-97B0-AD7FA126C407}"/>
               </a:ext>
             </a:extLst>
           </p:cNvPr>
@@ -9164,7 +9164,7 @@
           <p:cNvPr id="6" name="">
             <a:extLst xmlns:a="http://schemas.openxmlformats.org/drawingml/2006/main">
               <a:ext uri="{FF2B5EF4-FFF2-40B4-BE49-F238E27FC236}">
-                <a16:creationId xmlns:a16="http://schemas.microsoft.com/office/drawing/2014/main" id="{0862320B-2459-4546-B18F-DB3473966F8C}"/>
+                <a16:creationId xmlns:a16="http://schemas.microsoft.com/office/drawing/2014/main" id="{C6B56A14-6C32-4F34-B6C0-700D340542DE}"/>
               </a:ext>
             </a:extLst>
           </p:cNvPr>
@@ -9218,7 +9218,7 @@
                 <a:ea typeface="Hiragino Mincho ProN"/>
                 <a:cs typeface="Hiragino Mincho ProN"/>
               </a:rPr>
-              <a:t>AE候補は、追加演算の必要性を測る階段である</a:t>
+              <a:t>AE-01..05は、追加演算の価値を測る比較順序である</a:t>
             </a:r>
           </a:p>
         </p:txBody>
@@ -9228,7 +9228,7 @@
           <p:cNvPr id="7" name="">
             <a:extLst xmlns:a="http://schemas.openxmlformats.org/drawingml/2006/main">
               <a:ext uri="{FF2B5EF4-FFF2-40B4-BE49-F238E27FC236}">
-                <a16:creationId xmlns:a16="http://schemas.microsoft.com/office/drawing/2014/main" id="{5650D0C0-5CEA-4D16-80FF-5949D7054C46}"/>
+                <a16:creationId xmlns:a16="http://schemas.microsoft.com/office/drawing/2014/main" id="{301ACA27-236F-4C56-B41B-A58690C6A818}"/>
               </a:ext>
             </a:extLst>
           </p:cNvPr>
@@ -9261,7 +9261,7 @@
           <p:cNvPr id="8" name="">
             <a:extLst xmlns:a="http://schemas.openxmlformats.org/drawingml/2006/main">
               <a:ext uri="{FF2B5EF4-FFF2-40B4-BE49-F238E27FC236}">
-                <a16:creationId xmlns:a16="http://schemas.microsoft.com/office/drawing/2014/main" id="{E8F7269D-87E4-4CBB-A288-75B977B04760}"/>
+                <a16:creationId xmlns:a16="http://schemas.microsoft.com/office/drawing/2014/main" id="{00A4D188-959D-4F18-8188-C9C2B89B4419}"/>
               </a:ext>
             </a:extLst>
           </p:cNvPr>
@@ -9296,7 +9296,7 @@
           <p:cNvPr id="9" name="">
             <a:extLst xmlns:a="http://schemas.openxmlformats.org/drawingml/2006/main">
               <a:ext uri="{FF2B5EF4-FFF2-40B4-BE49-F238E27FC236}">
-                <a16:creationId xmlns:a16="http://schemas.microsoft.com/office/drawing/2014/main" id="{B29984AA-7C2F-40F0-901B-10098896A89B}"/>
+                <a16:creationId xmlns:a16="http://schemas.microsoft.com/office/drawing/2014/main" id="{BA3EB420-E84F-435F-9D91-924BCADD738B}"/>
               </a:ext>
             </a:extLst>
           </p:cNvPr>
@@ -9350,7 +9350,7 @@
                 <a:ea typeface="Hiragino Sans"/>
                 <a:cs typeface="Hiragino Sans"/>
               </a:rPr>
-              <a:t>主張 | 単純候補で説明できるなら止め、説明できない差分だけをDense、GRU、Conv1D、CNN-GRUへ渡す。</a:t>
+              <a:t>主張 | 単純なMLPで説明できるなら上位候補へ進まず、残る差分だけをDense、GRU、Conv1D、CNN-GRUで検証する。</a:t>
             </a:r>
           </a:p>
         </p:txBody>
@@ -9360,7 +9360,7 @@
           <p:cNvPr id="10" name="">
             <a:extLst xmlns:a="http://schemas.openxmlformats.org/drawingml/2006/main">
               <a:ext uri="{FF2B5EF4-FFF2-40B4-BE49-F238E27FC236}">
-                <a16:creationId xmlns:a16="http://schemas.microsoft.com/office/drawing/2014/main" id="{7B1D59E5-BF23-4420-AC41-2A86478DB94A}"/>
+                <a16:creationId xmlns:a16="http://schemas.microsoft.com/office/drawing/2014/main" id="{C59F91B7-7342-4CDB-BEE9-57B924AE9D1D}"/>
               </a:ext>
             </a:extLst>
           </p:cNvPr>
@@ -9393,7 +9393,7 @@
           <p:cNvPr id="11" name="">
             <a:extLst xmlns:a="http://schemas.openxmlformats.org/drawingml/2006/main">
               <a:ext uri="{FF2B5EF4-FFF2-40B4-BE49-F238E27FC236}">
-                <a16:creationId xmlns:a16="http://schemas.microsoft.com/office/drawing/2014/main" id="{506E7B6D-4D36-43EA-BAE2-AEE796A3B8B9}"/>
+                <a16:creationId xmlns:a16="http://schemas.microsoft.com/office/drawing/2014/main" id="{F7F1B51C-6AFC-4B37-B8DD-720181D113A7}"/>
               </a:ext>
             </a:extLst>
           </p:cNvPr>
@@ -9457,7 +9457,7 @@
           <p:cNvPr id="12" name="">
             <a:extLst xmlns:a="http://schemas.openxmlformats.org/drawingml/2006/main">
               <a:ext uri="{FF2B5EF4-FFF2-40B4-BE49-F238E27FC236}">
-                <a16:creationId xmlns:a16="http://schemas.microsoft.com/office/drawing/2014/main" id="{024E6DA7-D2ED-4DAB-A117-B83F62010005}"/>
+                <a16:creationId xmlns:a16="http://schemas.microsoft.com/office/drawing/2014/main" id="{570F5246-1BD9-424F-A117-1423BE839EB6}"/>
               </a:ext>
             </a:extLst>
           </p:cNvPr>
@@ -9492,7 +9492,7 @@
           <p:cNvPr id="13" name="">
             <a:extLst xmlns:a="http://schemas.openxmlformats.org/drawingml/2006/main">
               <a:ext uri="{FF2B5EF4-FFF2-40B4-BE49-F238E27FC236}">
-                <a16:creationId xmlns:a16="http://schemas.microsoft.com/office/drawing/2014/main" id="{D422066A-B597-418D-82D8-39D04FB97AFA}"/>
+                <a16:creationId xmlns:a16="http://schemas.microsoft.com/office/drawing/2014/main" id="{C2055169-1920-491C-9F96-CB92D2C60C47}"/>
               </a:ext>
             </a:extLst>
           </p:cNvPr>
@@ -9546,7 +9546,7 @@
                 <a:ea typeface="Hiragino Sans"/>
                 <a:cs typeface="Hiragino Sans"/>
               </a:rPr>
-              <a:t>candidate</a:t>
+              <a:t>候補</a:t>
             </a:r>
           </a:p>
         </p:txBody>
@@ -9556,7 +9556,7 @@
           <p:cNvPr id="14" name="">
             <a:extLst xmlns:a="http://schemas.openxmlformats.org/drawingml/2006/main">
               <a:ext uri="{FF2B5EF4-FFF2-40B4-BE49-F238E27FC236}">
-                <a16:creationId xmlns:a16="http://schemas.microsoft.com/office/drawing/2014/main" id="{4B7C4B5C-CB27-4F93-B576-7FDB33EA8DDE}"/>
+                <a16:creationId xmlns:a16="http://schemas.microsoft.com/office/drawing/2014/main" id="{A2B2186E-EC4B-4944-9271-6D926B1633AD}"/>
               </a:ext>
             </a:extLst>
           </p:cNvPr>
@@ -9591,7 +9591,7 @@
           <p:cNvPr id="15" name="">
             <a:extLst xmlns:a="http://schemas.openxmlformats.org/drawingml/2006/main">
               <a:ext uri="{FF2B5EF4-FFF2-40B4-BE49-F238E27FC236}">
-                <a16:creationId xmlns:a16="http://schemas.microsoft.com/office/drawing/2014/main" id="{72ADCF96-C4A8-4483-AB60-B8A773A43CB9}"/>
+                <a16:creationId xmlns:a16="http://schemas.microsoft.com/office/drawing/2014/main" id="{98E0AA33-B86C-40B7-9602-5B21A76E73FB}"/>
               </a:ext>
             </a:extLst>
           </p:cNvPr>
@@ -9631,9 +9631,9 @@
                 <a:solidFill>
                   <a:srgbClr val="FFFFFF"/>
                 </a:solidFill>
-                <a:latin typeface="Menlo"/>
-                <a:ea typeface="Menlo"/>
-                <a:cs typeface="Menlo"/>
+                <a:latin typeface="Hiragino Sans"/>
+                <a:ea typeface="Hiragino Sans"/>
+                <a:cs typeface="Hiragino Sans"/>
               </a:defRPr>
             </a:pPr>
             <a:r>
@@ -9641,11 +9641,11 @@
                 <a:solidFill>
                   <a:srgbClr val="FFFFFF"/>
                 </a:solidFill>
-                <a:latin typeface="Menlo"/>
-                <a:ea typeface="Menlo"/>
-                <a:cs typeface="Menlo"/>
+                <a:latin typeface="Hiragino Sans"/>
+                <a:ea typeface="Hiragino Sans"/>
+                <a:cs typeface="Hiragino Sans"/>
               </a:rPr>
-              <a:t>operator role</a:t>
+              <a:t>演算の役割</a:t>
             </a:r>
           </a:p>
         </p:txBody>
@@ -9655,7 +9655,7 @@
           <p:cNvPr id="16" name="">
             <a:extLst xmlns:a="http://schemas.openxmlformats.org/drawingml/2006/main">
               <a:ext uri="{FF2B5EF4-FFF2-40B4-BE49-F238E27FC236}">
-                <a16:creationId xmlns:a16="http://schemas.microsoft.com/office/drawing/2014/main" id="{CAFF39DF-76D4-4C91-950F-0AC0D9DC3B8F}"/>
+                <a16:creationId xmlns:a16="http://schemas.microsoft.com/office/drawing/2014/main" id="{05F8F1AE-D880-4BA7-93A6-39D7F4EC9279}"/>
               </a:ext>
             </a:extLst>
           </p:cNvPr>
@@ -9690,7 +9690,7 @@
           <p:cNvPr id="17" name="">
             <a:extLst xmlns:a="http://schemas.openxmlformats.org/drawingml/2006/main">
               <a:ext uri="{FF2B5EF4-FFF2-40B4-BE49-F238E27FC236}">
-                <a16:creationId xmlns:a16="http://schemas.microsoft.com/office/drawing/2014/main" id="{3E99EEDC-3D0C-44B8-A836-F1343E744A54}"/>
+                <a16:creationId xmlns:a16="http://schemas.microsoft.com/office/drawing/2014/main" id="{FB3EF30C-0AD0-49CD-A635-ED6639ABC1F1}"/>
               </a:ext>
             </a:extLst>
           </p:cNvPr>
@@ -9744,7 +9744,7 @@
                 <a:ea typeface="Hiragino Sans"/>
                 <a:cs typeface="Hiragino Sans"/>
               </a:rPr>
-              <a:t>planning size</a:t>
+              <a:t>計画サイズ</a:t>
             </a:r>
           </a:p>
         </p:txBody>
@@ -9754,7 +9754,7 @@
           <p:cNvPr id="18" name="">
             <a:extLst xmlns:a="http://schemas.openxmlformats.org/drawingml/2006/main">
               <a:ext uri="{FF2B5EF4-FFF2-40B4-BE49-F238E27FC236}">
-                <a16:creationId xmlns:a16="http://schemas.microsoft.com/office/drawing/2014/main" id="{F21BC5EF-2ADE-47D9-A864-D9A492C2CAFF}"/>
+                <a16:creationId xmlns:a16="http://schemas.microsoft.com/office/drawing/2014/main" id="{820EA9A0-4DAC-4579-A9DE-96C45ECAC3D7}"/>
               </a:ext>
             </a:extLst>
           </p:cNvPr>
@@ -9789,7 +9789,7 @@
           <p:cNvPr id="19" name="">
             <a:extLst xmlns:a="http://schemas.openxmlformats.org/drawingml/2006/main">
               <a:ext uri="{FF2B5EF4-FFF2-40B4-BE49-F238E27FC236}">
-                <a16:creationId xmlns:a16="http://schemas.microsoft.com/office/drawing/2014/main" id="{D33E7842-47B4-431C-9197-15CF7F3D60EF}"/>
+                <a16:creationId xmlns:a16="http://schemas.microsoft.com/office/drawing/2014/main" id="{6E5340E5-38D3-4E11-843D-46E4AD46D081}"/>
               </a:ext>
             </a:extLst>
           </p:cNvPr>
@@ -9853,7 +9853,7 @@
           <p:cNvPr id="20" name="">
             <a:extLst xmlns:a="http://schemas.openxmlformats.org/drawingml/2006/main">
               <a:ext uri="{FF2B5EF4-FFF2-40B4-BE49-F238E27FC236}">
-                <a16:creationId xmlns:a16="http://schemas.microsoft.com/office/drawing/2014/main" id="{B59C0A66-202F-4D69-B213-FFB63F8A1CFC}"/>
+                <a16:creationId xmlns:a16="http://schemas.microsoft.com/office/drawing/2014/main" id="{076C8B46-3D78-43C5-8F73-6C47AAA21657}"/>
               </a:ext>
             </a:extLst>
           </p:cNvPr>
@@ -9886,7 +9886,7 @@
           <p:cNvPr id="21" name="">
             <a:extLst xmlns:a="http://schemas.openxmlformats.org/drawingml/2006/main">
               <a:ext uri="{FF2B5EF4-FFF2-40B4-BE49-F238E27FC236}">
-                <a16:creationId xmlns:a16="http://schemas.microsoft.com/office/drawing/2014/main" id="{55A5CE80-70F5-44DB-A860-8137E2ED1CD8}"/>
+                <a16:creationId xmlns:a16="http://schemas.microsoft.com/office/drawing/2014/main" id="{A90E1486-5193-47FE-9686-D5E136C8A42B}"/>
               </a:ext>
             </a:extLst>
           </p:cNvPr>
@@ -9950,7 +9950,7 @@
           <p:cNvPr id="22" name="">
             <a:extLst xmlns:a="http://schemas.openxmlformats.org/drawingml/2006/main">
               <a:ext uri="{FF2B5EF4-FFF2-40B4-BE49-F238E27FC236}">
-                <a16:creationId xmlns:a16="http://schemas.microsoft.com/office/drawing/2014/main" id="{E57D1484-1D8A-455C-95A3-1C1D64E4470A}"/>
+                <a16:creationId xmlns:a16="http://schemas.microsoft.com/office/drawing/2014/main" id="{501674CA-03BB-4806-8079-25AFEEB505D2}"/>
               </a:ext>
             </a:extLst>
           </p:cNvPr>
@@ -9985,7 +9985,7 @@
           <p:cNvPr id="23" name="">
             <a:extLst xmlns:a="http://schemas.openxmlformats.org/drawingml/2006/main">
               <a:ext uri="{FF2B5EF4-FFF2-40B4-BE49-F238E27FC236}">
-                <a16:creationId xmlns:a16="http://schemas.microsoft.com/office/drawing/2014/main" id="{866AD5F3-44ED-4484-8837-2A86445C7319}"/>
+                <a16:creationId xmlns:a16="http://schemas.microsoft.com/office/drawing/2014/main" id="{C43CC0ED-5EA7-4C78-87C3-506314D96854}"/>
               </a:ext>
             </a:extLst>
           </p:cNvPr>
@@ -10049,7 +10049,7 @@
           <p:cNvPr id="24" name="">
             <a:extLst xmlns:a="http://schemas.openxmlformats.org/drawingml/2006/main">
               <a:ext uri="{FF2B5EF4-FFF2-40B4-BE49-F238E27FC236}">
-                <a16:creationId xmlns:a16="http://schemas.microsoft.com/office/drawing/2014/main" id="{A6370EA3-CCC8-4C6D-9C4E-347BEA5AD2A0}"/>
+                <a16:creationId xmlns:a16="http://schemas.microsoft.com/office/drawing/2014/main" id="{F20E4045-6755-4BA0-908A-BB701035B71F}"/>
               </a:ext>
             </a:extLst>
           </p:cNvPr>
@@ -10084,7 +10084,7 @@
           <p:cNvPr id="25" name="">
             <a:extLst xmlns:a="http://schemas.openxmlformats.org/drawingml/2006/main">
               <a:ext uri="{FF2B5EF4-FFF2-40B4-BE49-F238E27FC236}">
-                <a16:creationId xmlns:a16="http://schemas.microsoft.com/office/drawing/2014/main" id="{06D420EE-0B6B-414F-B1BD-7D714D7A4DCD}"/>
+                <a16:creationId xmlns:a16="http://schemas.microsoft.com/office/drawing/2014/main" id="{A0BBC3C2-9A66-45FD-836F-22E877F356E6}"/>
               </a:ext>
             </a:extLst>
           </p:cNvPr>
@@ -10124,9 +10124,9 @@
                 <a:solidFill>
                   <a:srgbClr val="111827"/>
                 </a:solidFill>
-                <a:latin typeface="Menlo"/>
-                <a:ea typeface="Menlo"/>
-                <a:cs typeface="Menlo"/>
+                <a:latin typeface="Hiragino Sans"/>
+                <a:ea typeface="Hiragino Sans"/>
+                <a:cs typeface="Hiragino Sans"/>
               </a:defRPr>
             </a:pPr>
             <a:r>
@@ -10134,11 +10134,11 @@
                 <a:solidFill>
                   <a:srgbClr val="111827"/>
                 </a:solidFill>
-                <a:latin typeface="Menlo"/>
-                <a:ea typeface="Menlo"/>
-                <a:cs typeface="Menlo"/>
+                <a:latin typeface="Hiragino Sans"/>
+                <a:ea typeface="Hiragino Sans"/>
+                <a:cs typeface="Hiragino Sans"/>
               </a:rPr>
-              <a:t>flattenした2分窓を圧縮</a:t>
+              <a:t>2分窓をまとめて圧縮</a:t>
             </a:r>
           </a:p>
         </p:txBody>
@@ -10148,7 +10148,7 @@
           <p:cNvPr id="26" name="">
             <a:extLst xmlns:a="http://schemas.openxmlformats.org/drawingml/2006/main">
               <a:ext uri="{FF2B5EF4-FFF2-40B4-BE49-F238E27FC236}">
-                <a16:creationId xmlns:a16="http://schemas.microsoft.com/office/drawing/2014/main" id="{405C1E00-FB9A-43E4-AD2E-099941303DC4}"/>
+                <a16:creationId xmlns:a16="http://schemas.microsoft.com/office/drawing/2014/main" id="{6F7574F2-7D39-471A-B68D-9DBC17DCA8EC}"/>
               </a:ext>
             </a:extLst>
           </p:cNvPr>
@@ -10183,7 +10183,7 @@
           <p:cNvPr id="27" name="">
             <a:extLst xmlns:a="http://schemas.openxmlformats.org/drawingml/2006/main">
               <a:ext uri="{FF2B5EF4-FFF2-40B4-BE49-F238E27FC236}">
-                <a16:creationId xmlns:a16="http://schemas.microsoft.com/office/drawing/2014/main" id="{C76E0DAF-7987-474F-8CD9-7509810CEEB7}"/>
+                <a16:creationId xmlns:a16="http://schemas.microsoft.com/office/drawing/2014/main" id="{BD9F1A99-9833-4518-BF47-B6D7F494BBB5}"/>
               </a:ext>
             </a:extLst>
           </p:cNvPr>
@@ -10247,7 +10247,7 @@
           <p:cNvPr id="28" name="">
             <a:extLst xmlns:a="http://schemas.openxmlformats.org/drawingml/2006/main">
               <a:ext uri="{FF2B5EF4-FFF2-40B4-BE49-F238E27FC236}">
-                <a16:creationId xmlns:a16="http://schemas.microsoft.com/office/drawing/2014/main" id="{A25E5EFE-0180-4B4B-9E8A-F4B51CD1CC04}"/>
+                <a16:creationId xmlns:a16="http://schemas.microsoft.com/office/drawing/2014/main" id="{19AE81CE-F86B-4394-9561-0A4F9B3A84E4}"/>
               </a:ext>
             </a:extLst>
           </p:cNvPr>
@@ -10282,7 +10282,7 @@
           <p:cNvPr id="29" name="">
             <a:extLst xmlns:a="http://schemas.openxmlformats.org/drawingml/2006/main">
               <a:ext uri="{FF2B5EF4-FFF2-40B4-BE49-F238E27FC236}">
-                <a16:creationId xmlns:a16="http://schemas.microsoft.com/office/drawing/2014/main" id="{44E921B2-F658-41AD-A15E-305132D9E0B0}"/>
+                <a16:creationId xmlns:a16="http://schemas.microsoft.com/office/drawing/2014/main" id="{363C3306-C5C0-4978-8D16-DB1F95BEE79E}"/>
               </a:ext>
             </a:extLst>
           </p:cNvPr>
@@ -10336,7 +10336,7 @@
                 <a:ea typeface="Hiragino Sans"/>
                 <a:cs typeface="Hiragino Sans"/>
               </a:rPr>
-              <a:t>粗い統計だけでズレが見えるか</a:t>
+              <a:t>粗い統計だけで差分が見えるか</a:t>
             </a:r>
           </a:p>
         </p:txBody>
@@ -10346,7 +10346,7 @@
           <p:cNvPr id="30" name="">
             <a:extLst xmlns:a="http://schemas.openxmlformats.org/drawingml/2006/main">
               <a:ext uri="{FF2B5EF4-FFF2-40B4-BE49-F238E27FC236}">
-                <a16:creationId xmlns:a16="http://schemas.microsoft.com/office/drawing/2014/main" id="{4CAB004F-4093-415D-9F47-2796CBBF31C5}"/>
+                <a16:creationId xmlns:a16="http://schemas.microsoft.com/office/drawing/2014/main" id="{4C74B386-974E-4A77-AD5F-476F4F213DC9}"/>
               </a:ext>
             </a:extLst>
           </p:cNvPr>
@@ -10379,7 +10379,7 @@
           <p:cNvPr id="31" name="">
             <a:extLst xmlns:a="http://schemas.openxmlformats.org/drawingml/2006/main">
               <a:ext uri="{FF2B5EF4-FFF2-40B4-BE49-F238E27FC236}">
-                <a16:creationId xmlns:a16="http://schemas.microsoft.com/office/drawing/2014/main" id="{659AA732-4A78-4836-866D-A23776DEE569}"/>
+                <a16:creationId xmlns:a16="http://schemas.microsoft.com/office/drawing/2014/main" id="{EFC9BE19-8F67-4428-85D2-7A8F744CFCDC}"/>
               </a:ext>
             </a:extLst>
           </p:cNvPr>
@@ -10443,7 +10443,7 @@
           <p:cNvPr id="32" name="">
             <a:extLst xmlns:a="http://schemas.openxmlformats.org/drawingml/2006/main">
               <a:ext uri="{FF2B5EF4-FFF2-40B4-BE49-F238E27FC236}">
-                <a16:creationId xmlns:a16="http://schemas.microsoft.com/office/drawing/2014/main" id="{83AA0F38-2F86-44AA-9DBB-23950165A54E}"/>
+                <a16:creationId xmlns:a16="http://schemas.microsoft.com/office/drawing/2014/main" id="{7E6A2789-72F4-4B82-981A-24242E77FBB0}"/>
               </a:ext>
             </a:extLst>
           </p:cNvPr>
@@ -10478,7 +10478,7 @@
           <p:cNvPr id="33" name="">
             <a:extLst xmlns:a="http://schemas.openxmlformats.org/drawingml/2006/main">
               <a:ext uri="{FF2B5EF4-FFF2-40B4-BE49-F238E27FC236}">
-                <a16:creationId xmlns:a16="http://schemas.microsoft.com/office/drawing/2014/main" id="{6F14B1A9-644D-40F9-A43D-25DC0B949765}"/>
+                <a16:creationId xmlns:a16="http://schemas.microsoft.com/office/drawing/2014/main" id="{A03A50A1-03F0-403E-BE53-372E60EB76C4}"/>
               </a:ext>
             </a:extLst>
           </p:cNvPr>
@@ -10542,7 +10542,7 @@
           <p:cNvPr id="34" name="">
             <a:extLst xmlns:a="http://schemas.openxmlformats.org/drawingml/2006/main">
               <a:ext uri="{FF2B5EF4-FFF2-40B4-BE49-F238E27FC236}">
-                <a16:creationId xmlns:a16="http://schemas.microsoft.com/office/drawing/2014/main" id="{98282C93-B91D-4A2E-86E9-C5A3D01B1293}"/>
+                <a16:creationId xmlns:a16="http://schemas.microsoft.com/office/drawing/2014/main" id="{DA8D9B93-E189-4C08-943A-1125B7EE5ED1}"/>
               </a:ext>
             </a:extLst>
           </p:cNvPr>
@@ -10577,7 +10577,7 @@
           <p:cNvPr id="35" name="">
             <a:extLst xmlns:a="http://schemas.openxmlformats.org/drawingml/2006/main">
               <a:ext uri="{FF2B5EF4-FFF2-40B4-BE49-F238E27FC236}">
-                <a16:creationId xmlns:a16="http://schemas.microsoft.com/office/drawing/2014/main" id="{04028776-35C0-45F8-95B1-1750AFE7F345}"/>
+                <a16:creationId xmlns:a16="http://schemas.microsoft.com/office/drawing/2014/main" id="{9CB8892B-33F4-4926-9BED-0E8EDA149325}"/>
               </a:ext>
             </a:extLst>
           </p:cNvPr>
@@ -10617,9 +10617,9 @@
                 <a:solidFill>
                   <a:srgbClr val="111827"/>
                 </a:solidFill>
-                <a:latin typeface="Menlo"/>
-                <a:ea typeface="Menlo"/>
-                <a:cs typeface="Menlo"/>
+                <a:latin typeface="Hiragino Sans"/>
+                <a:ea typeface="Hiragino Sans"/>
+                <a:cs typeface="Hiragino Sans"/>
               </a:defRPr>
             </a:pPr>
             <a:r>
@@ -10627,11 +10627,11 @@
                 <a:solidFill>
                   <a:srgbClr val="111827"/>
                 </a:solidFill>
-                <a:latin typeface="Menlo"/>
-                <a:ea typeface="Menlo"/>
-                <a:cs typeface="Menlo"/>
+                <a:latin typeface="Hiragino Sans"/>
+                <a:ea typeface="Hiragino Sans"/>
+                <a:cs typeface="Hiragino Sans"/>
               </a:rPr>
-              <a:t>10秒ごとの圧縮 + 系列圧縮</a:t>
+              <a:t>10秒単位で圧縮し、系列を圧縮</a:t>
             </a:r>
           </a:p>
         </p:txBody>
@@ -10641,7 +10641,7 @@
           <p:cNvPr id="36" name="">
             <a:extLst xmlns:a="http://schemas.openxmlformats.org/drawingml/2006/main">
               <a:ext uri="{FF2B5EF4-FFF2-40B4-BE49-F238E27FC236}">
-                <a16:creationId xmlns:a16="http://schemas.microsoft.com/office/drawing/2014/main" id="{5067013B-4A27-4601-A110-074810703C99}"/>
+                <a16:creationId xmlns:a16="http://schemas.microsoft.com/office/drawing/2014/main" id="{B3109B55-EC04-4389-87D8-0B8A283878BF}"/>
               </a:ext>
             </a:extLst>
           </p:cNvPr>
@@ -10676,7 +10676,7 @@
           <p:cNvPr id="37" name="">
             <a:extLst xmlns:a="http://schemas.openxmlformats.org/drawingml/2006/main">
               <a:ext uri="{FF2B5EF4-FFF2-40B4-BE49-F238E27FC236}">
-                <a16:creationId xmlns:a16="http://schemas.microsoft.com/office/drawing/2014/main" id="{A088C6B0-EDBB-485B-9D2E-17890227EA82}"/>
+                <a16:creationId xmlns:a16="http://schemas.microsoft.com/office/drawing/2014/main" id="{28D61BDC-8975-4F00-9152-0898E476B893}"/>
               </a:ext>
             </a:extLst>
           </p:cNvPr>
@@ -10740,7 +10740,7 @@
           <p:cNvPr id="38" name="">
             <a:extLst xmlns:a="http://schemas.openxmlformats.org/drawingml/2006/main">
               <a:ext uri="{FF2B5EF4-FFF2-40B4-BE49-F238E27FC236}">
-                <a16:creationId xmlns:a16="http://schemas.microsoft.com/office/drawing/2014/main" id="{24413BF0-C826-44E1-BC56-151C416E2695}"/>
+                <a16:creationId xmlns:a16="http://schemas.microsoft.com/office/drawing/2014/main" id="{2A4CB832-8A15-4D1C-ADA3-319D311897EA}"/>
               </a:ext>
             </a:extLst>
           </p:cNvPr>
@@ -10775,7 +10775,7 @@
           <p:cNvPr id="39" name="">
             <a:extLst xmlns:a="http://schemas.openxmlformats.org/drawingml/2006/main">
               <a:ext uri="{FF2B5EF4-FFF2-40B4-BE49-F238E27FC236}">
-                <a16:creationId xmlns:a16="http://schemas.microsoft.com/office/drawing/2014/main" id="{1D962138-7E1E-4061-B378-4135D92E30BB}"/>
+                <a16:creationId xmlns:a16="http://schemas.microsoft.com/office/drawing/2014/main" id="{A3662FCB-02B3-45C6-ACF7-6D5C0DE601EE}"/>
               </a:ext>
             </a:extLst>
           </p:cNvPr>
@@ -10839,7 +10839,7 @@
           <p:cNvPr id="40" name="">
             <a:extLst xmlns:a="http://schemas.openxmlformats.org/drawingml/2006/main">
               <a:ext uri="{FF2B5EF4-FFF2-40B4-BE49-F238E27FC236}">
-                <a16:creationId xmlns:a16="http://schemas.microsoft.com/office/drawing/2014/main" id="{159B46BA-C482-42E0-A74A-B384FFD9FA93}"/>
+                <a16:creationId xmlns:a16="http://schemas.microsoft.com/office/drawing/2014/main" id="{D23CA07B-1E88-47DF-914D-EBE8087BF6C3}"/>
               </a:ext>
             </a:extLst>
           </p:cNvPr>
@@ -10872,7 +10872,7 @@
           <p:cNvPr id="41" name="">
             <a:extLst xmlns:a="http://schemas.openxmlformats.org/drawingml/2006/main">
               <a:ext uri="{FF2B5EF4-FFF2-40B4-BE49-F238E27FC236}">
-                <a16:creationId xmlns:a16="http://schemas.microsoft.com/office/drawing/2014/main" id="{815143A8-9876-43D2-98E5-9D8967328805}"/>
+                <a16:creationId xmlns:a16="http://schemas.microsoft.com/office/drawing/2014/main" id="{17691795-4B67-42C0-A80B-506700780FE3}"/>
               </a:ext>
             </a:extLst>
           </p:cNvPr>
@@ -10936,7 +10936,7 @@
           <p:cNvPr id="42" name="">
             <a:extLst xmlns:a="http://schemas.openxmlformats.org/drawingml/2006/main">
               <a:ext uri="{FF2B5EF4-FFF2-40B4-BE49-F238E27FC236}">
-                <a16:creationId xmlns:a16="http://schemas.microsoft.com/office/drawing/2014/main" id="{C0F0EC58-C03E-40D7-8376-EFE263724400}"/>
+                <a16:creationId xmlns:a16="http://schemas.microsoft.com/office/drawing/2014/main" id="{45F18BD1-E4E3-4A03-AAE6-BF0DC165DCB2}"/>
               </a:ext>
             </a:extLst>
           </p:cNvPr>
@@ -10971,7 +10971,7 @@
           <p:cNvPr id="43" name="">
             <a:extLst xmlns:a="http://schemas.openxmlformats.org/drawingml/2006/main">
               <a:ext uri="{FF2B5EF4-FFF2-40B4-BE49-F238E27FC236}">
-                <a16:creationId xmlns:a16="http://schemas.microsoft.com/office/drawing/2014/main" id="{77E80F56-E7EA-455B-B400-E2B041192490}"/>
+                <a16:creationId xmlns:a16="http://schemas.microsoft.com/office/drawing/2014/main" id="{5DAE75A1-41DA-48A7-A69B-D6C170646B5D}"/>
               </a:ext>
             </a:extLst>
           </p:cNvPr>
@@ -11035,7 +11035,7 @@
           <p:cNvPr id="44" name="">
             <a:extLst xmlns:a="http://schemas.openxmlformats.org/drawingml/2006/main">
               <a:ext uri="{FF2B5EF4-FFF2-40B4-BE49-F238E27FC236}">
-                <a16:creationId xmlns:a16="http://schemas.microsoft.com/office/drawing/2014/main" id="{93283D66-6D2C-47C5-AA92-A6FFF5BDA5A1}"/>
+                <a16:creationId xmlns:a16="http://schemas.microsoft.com/office/drawing/2014/main" id="{912FCC62-A5E4-43E8-907A-32048B83CC5D}"/>
               </a:ext>
             </a:extLst>
           </p:cNvPr>
@@ -11070,7 +11070,7 @@
           <p:cNvPr id="45" name="">
             <a:extLst xmlns:a="http://schemas.openxmlformats.org/drawingml/2006/main">
               <a:ext uri="{FF2B5EF4-FFF2-40B4-BE49-F238E27FC236}">
-                <a16:creationId xmlns:a16="http://schemas.microsoft.com/office/drawing/2014/main" id="{2DEA2D13-2A00-4F5B-A02B-1FF3F763924A}"/>
+                <a16:creationId xmlns:a16="http://schemas.microsoft.com/office/drawing/2014/main" id="{50CE40F6-384B-495E-9E5A-A75926CDE453}"/>
               </a:ext>
             </a:extLst>
           </p:cNvPr>
@@ -11110,9 +11110,9 @@
                 <a:solidFill>
                   <a:srgbClr val="111827"/>
                 </a:solidFill>
-                <a:latin typeface="Menlo"/>
-                <a:ea typeface="Menlo"/>
-                <a:cs typeface="Menlo"/>
+                <a:latin typeface="Hiragino Sans"/>
+                <a:ea typeface="Hiragino Sans"/>
+                <a:cs typeface="Hiragino Sans"/>
               </a:defRPr>
             </a:pPr>
             <a:r>
@@ -11120,11 +11120,11 @@
                 <a:solidFill>
                   <a:srgbClr val="111827"/>
                 </a:solidFill>
-                <a:latin typeface="Menlo"/>
-                <a:ea typeface="Menlo"/>
-                <a:cs typeface="Menlo"/>
+                <a:latin typeface="Hiragino Sans"/>
+                <a:ea typeface="Hiragino Sans"/>
+                <a:cs typeface="Hiragino Sans"/>
               </a:rPr>
-              <a:t>順序と過去文脈を付与</a:t>
+              <a:t>順序と過去文脈を使う</a:t>
             </a:r>
           </a:p>
         </p:txBody>
@@ -11134,7 +11134,7 @@
           <p:cNvPr id="46" name="">
             <a:extLst xmlns:a="http://schemas.openxmlformats.org/drawingml/2006/main">
               <a:ext uri="{FF2B5EF4-FFF2-40B4-BE49-F238E27FC236}">
-                <a16:creationId xmlns:a16="http://schemas.microsoft.com/office/drawing/2014/main" id="{1747CDB4-6A67-4220-832B-B03D6ECAA9CF}"/>
+                <a16:creationId xmlns:a16="http://schemas.microsoft.com/office/drawing/2014/main" id="{0AB2B343-9FDF-4688-B3B2-C4F139882675}"/>
               </a:ext>
             </a:extLst>
           </p:cNvPr>
@@ -11169,7 +11169,7 @@
           <p:cNvPr id="47" name="">
             <a:extLst xmlns:a="http://schemas.openxmlformats.org/drawingml/2006/main">
               <a:ext uri="{FF2B5EF4-FFF2-40B4-BE49-F238E27FC236}">
-                <a16:creationId xmlns:a16="http://schemas.microsoft.com/office/drawing/2014/main" id="{08452113-FE9C-4363-B3A3-FE05651A51E4}"/>
+                <a16:creationId xmlns:a16="http://schemas.microsoft.com/office/drawing/2014/main" id="{9349BE32-BE3B-45D0-874A-901800F0910A}"/>
               </a:ext>
             </a:extLst>
           </p:cNvPr>
@@ -11233,7 +11233,7 @@
           <p:cNvPr id="48" name="">
             <a:extLst xmlns:a="http://schemas.openxmlformats.org/drawingml/2006/main">
               <a:ext uri="{FF2B5EF4-FFF2-40B4-BE49-F238E27FC236}">
-                <a16:creationId xmlns:a16="http://schemas.microsoft.com/office/drawing/2014/main" id="{44DE848D-EBA1-4969-B63E-183B3F345E8B}"/>
+                <a16:creationId xmlns:a16="http://schemas.microsoft.com/office/drawing/2014/main" id="{B2799752-808B-472F-9080-142C03713755}"/>
               </a:ext>
             </a:extLst>
           </p:cNvPr>
@@ -11268,7 +11268,7 @@
           <p:cNvPr id="49" name="">
             <a:extLst xmlns:a="http://schemas.openxmlformats.org/drawingml/2006/main">
               <a:ext uri="{FF2B5EF4-FFF2-40B4-BE49-F238E27FC236}">
-                <a16:creationId xmlns:a16="http://schemas.microsoft.com/office/drawing/2014/main" id="{33D4BDCC-054E-4D46-905B-576D191AD5C6}"/>
+                <a16:creationId xmlns:a16="http://schemas.microsoft.com/office/drawing/2014/main" id="{FB15CF94-8AC8-45B5-BC06-3C2111B46694}"/>
               </a:ext>
             </a:extLst>
           </p:cNvPr>
@@ -11332,7 +11332,7 @@
           <p:cNvPr id="50" name="">
             <a:extLst xmlns:a="http://schemas.openxmlformats.org/drawingml/2006/main">
               <a:ext uri="{FF2B5EF4-FFF2-40B4-BE49-F238E27FC236}">
-                <a16:creationId xmlns:a16="http://schemas.microsoft.com/office/drawing/2014/main" id="{D4B0E8BA-62F3-4402-8503-AEDAAF756BDA}"/>
+                <a16:creationId xmlns:a16="http://schemas.microsoft.com/office/drawing/2014/main" id="{E184CB00-D0D1-4672-8DB6-738EC8E02CD9}"/>
               </a:ext>
             </a:extLst>
           </p:cNvPr>
@@ -11365,7 +11365,7 @@
           <p:cNvPr id="51" name="">
             <a:extLst xmlns:a="http://schemas.openxmlformats.org/drawingml/2006/main">
               <a:ext uri="{FF2B5EF4-FFF2-40B4-BE49-F238E27FC236}">
-                <a16:creationId xmlns:a16="http://schemas.microsoft.com/office/drawing/2014/main" id="{F8F9A99A-9B7A-4714-BC63-8D8A01E37D3A}"/>
+                <a16:creationId xmlns:a16="http://schemas.microsoft.com/office/drawing/2014/main" id="{7BDE00B3-6585-4B12-968D-95A1D62BB87F}"/>
               </a:ext>
             </a:extLst>
           </p:cNvPr>
@@ -11429,7 +11429,7 @@
           <p:cNvPr id="52" name="">
             <a:extLst xmlns:a="http://schemas.openxmlformats.org/drawingml/2006/main">
               <a:ext uri="{FF2B5EF4-FFF2-40B4-BE49-F238E27FC236}">
-                <a16:creationId xmlns:a16="http://schemas.microsoft.com/office/drawing/2014/main" id="{31E16851-79FB-4F03-9BE9-7FA63F4A8E7A}"/>
+                <a16:creationId xmlns:a16="http://schemas.microsoft.com/office/drawing/2014/main" id="{956DDC35-3085-45F2-845F-0EDA5D1EF03D}"/>
               </a:ext>
             </a:extLst>
           </p:cNvPr>
@@ -11464,7 +11464,7 @@
           <p:cNvPr id="53" name="">
             <a:extLst xmlns:a="http://schemas.openxmlformats.org/drawingml/2006/main">
               <a:ext uri="{FF2B5EF4-FFF2-40B4-BE49-F238E27FC236}">
-                <a16:creationId xmlns:a16="http://schemas.microsoft.com/office/drawing/2014/main" id="{8887A782-051E-46A1-816D-F5B6B50FBC43}"/>
+                <a16:creationId xmlns:a16="http://schemas.microsoft.com/office/drawing/2014/main" id="{D1F9DED0-B961-4EAC-9DA3-F28A7CFAEB28}"/>
               </a:ext>
             </a:extLst>
           </p:cNvPr>
@@ -11528,7 +11528,7 @@
           <p:cNvPr id="54" name="">
             <a:extLst xmlns:a="http://schemas.openxmlformats.org/drawingml/2006/main">
               <a:ext uri="{FF2B5EF4-FFF2-40B4-BE49-F238E27FC236}">
-                <a16:creationId xmlns:a16="http://schemas.microsoft.com/office/drawing/2014/main" id="{DCDFE0C1-DA1C-430B-A02F-117981CA97E9}"/>
+                <a16:creationId xmlns:a16="http://schemas.microsoft.com/office/drawing/2014/main" id="{28E04882-54C4-481D-A8AF-45734D510C8D}"/>
               </a:ext>
             </a:extLst>
           </p:cNvPr>
@@ -11563,7 +11563,7 @@
           <p:cNvPr id="55" name="">
             <a:extLst xmlns:a="http://schemas.openxmlformats.org/drawingml/2006/main">
               <a:ext uri="{FF2B5EF4-FFF2-40B4-BE49-F238E27FC236}">
-                <a16:creationId xmlns:a16="http://schemas.microsoft.com/office/drawing/2014/main" id="{0858986D-2CA5-4C98-82DB-25AC6B255542}"/>
+                <a16:creationId xmlns:a16="http://schemas.microsoft.com/office/drawing/2014/main" id="{B0C6B52D-C112-43D9-92C4-10C464ADC29D}"/>
               </a:ext>
             </a:extLst>
           </p:cNvPr>
@@ -11603,9 +11603,9 @@
                 <a:solidFill>
                   <a:srgbClr val="111827"/>
                 </a:solidFill>
-                <a:latin typeface="Menlo"/>
-                <a:ea typeface="Menlo"/>
-                <a:cs typeface="Menlo"/>
+                <a:latin typeface="Hiragino Sans"/>
+                <a:ea typeface="Hiragino Sans"/>
+                <a:cs typeface="Hiragino Sans"/>
               </a:defRPr>
             </a:pPr>
             <a:r>
@@ -11613,9 +11613,9 @@
                 <a:solidFill>
                   <a:srgbClr val="111827"/>
                 </a:solidFill>
-                <a:latin typeface="Menlo"/>
-                <a:ea typeface="Menlo"/>
-                <a:cs typeface="Menlo"/>
+                <a:latin typeface="Hiragino Sans"/>
+                <a:ea typeface="Hiragino Sans"/>
+                <a:cs typeface="Hiragino Sans"/>
               </a:rPr>
               <a:t>近傍時間の局所変化を抽出</a:t>
             </a:r>
@@ -11627,7 +11627,7 @@
           <p:cNvPr id="56" name="">
             <a:extLst xmlns:a="http://schemas.openxmlformats.org/drawingml/2006/main">
               <a:ext uri="{FF2B5EF4-FFF2-40B4-BE49-F238E27FC236}">
-                <a16:creationId xmlns:a16="http://schemas.microsoft.com/office/drawing/2014/main" id="{BD07DC1F-025A-4EBC-B0FE-021EBD5F24F8}"/>
+                <a16:creationId xmlns:a16="http://schemas.microsoft.com/office/drawing/2014/main" id="{AD5F5E95-4E39-413F-9CA8-4B5833D042EC}"/>
               </a:ext>
             </a:extLst>
           </p:cNvPr>
@@ -11662,7 +11662,7 @@
           <p:cNvPr id="57" name="">
             <a:extLst xmlns:a="http://schemas.openxmlformats.org/drawingml/2006/main">
               <a:ext uri="{FF2B5EF4-FFF2-40B4-BE49-F238E27FC236}">
-                <a16:creationId xmlns:a16="http://schemas.microsoft.com/office/drawing/2014/main" id="{39AC5ADE-1F11-45B5-84DA-4B4E74EDB018}"/>
+                <a16:creationId xmlns:a16="http://schemas.microsoft.com/office/drawing/2014/main" id="{2C8E747E-4096-4B6C-8FEA-903BBA83C508}"/>
               </a:ext>
             </a:extLst>
           </p:cNvPr>
@@ -11726,7 +11726,7 @@
           <p:cNvPr id="58" name="">
             <a:extLst xmlns:a="http://schemas.openxmlformats.org/drawingml/2006/main">
               <a:ext uri="{FF2B5EF4-FFF2-40B4-BE49-F238E27FC236}">
-                <a16:creationId xmlns:a16="http://schemas.microsoft.com/office/drawing/2014/main" id="{A055183D-B087-4A48-82E3-CFB4D8D60929}"/>
+                <a16:creationId xmlns:a16="http://schemas.microsoft.com/office/drawing/2014/main" id="{1B5EAC06-6029-4E17-A160-B7A030CF0AA1}"/>
               </a:ext>
             </a:extLst>
           </p:cNvPr>
@@ -11761,7 +11761,7 @@
           <p:cNvPr id="59" name="">
             <a:extLst xmlns:a="http://schemas.openxmlformats.org/drawingml/2006/main">
               <a:ext uri="{FF2B5EF4-FFF2-40B4-BE49-F238E27FC236}">
-                <a16:creationId xmlns:a16="http://schemas.microsoft.com/office/drawing/2014/main" id="{22770253-8270-46D1-9B0D-948916AB925D}"/>
+                <a16:creationId xmlns:a16="http://schemas.microsoft.com/office/drawing/2014/main" id="{E8EC3289-D5BF-44F5-B166-27FA69FBBB1F}"/>
               </a:ext>
             </a:extLst>
           </p:cNvPr>
@@ -11825,7 +11825,7 @@
           <p:cNvPr id="60" name="">
             <a:extLst xmlns:a="http://schemas.openxmlformats.org/drawingml/2006/main">
               <a:ext uri="{FF2B5EF4-FFF2-40B4-BE49-F238E27FC236}">
-                <a16:creationId xmlns:a16="http://schemas.microsoft.com/office/drawing/2014/main" id="{11335E0D-0B3B-4267-BFB9-8DA2FA1E8310}"/>
+                <a16:creationId xmlns:a16="http://schemas.microsoft.com/office/drawing/2014/main" id="{E057ECCE-8C56-4BA0-9152-F95994D9EE20}"/>
               </a:ext>
             </a:extLst>
           </p:cNvPr>
@@ -11858,7 +11858,7 @@
           <p:cNvPr id="61" name="">
             <a:extLst xmlns:a="http://schemas.openxmlformats.org/drawingml/2006/main">
               <a:ext uri="{FF2B5EF4-FFF2-40B4-BE49-F238E27FC236}">
-                <a16:creationId xmlns:a16="http://schemas.microsoft.com/office/drawing/2014/main" id="{3B0EACB8-042C-45CC-8474-892A34B65921}"/>
+                <a16:creationId xmlns:a16="http://schemas.microsoft.com/office/drawing/2014/main" id="{45FDE8CA-58F0-4C80-A5D4-CC3103B85587}"/>
               </a:ext>
             </a:extLst>
           </p:cNvPr>
@@ -11922,7 +11922,7 @@
           <p:cNvPr id="62" name="">
             <a:extLst xmlns:a="http://schemas.openxmlformats.org/drawingml/2006/main">
               <a:ext uri="{FF2B5EF4-FFF2-40B4-BE49-F238E27FC236}">
-                <a16:creationId xmlns:a16="http://schemas.microsoft.com/office/drawing/2014/main" id="{2D38133F-1359-4E85-87FC-74BECCCF907C}"/>
+                <a16:creationId xmlns:a16="http://schemas.microsoft.com/office/drawing/2014/main" id="{9CF6FDCF-E8B8-4670-8A71-909A6C5C8824}"/>
               </a:ext>
             </a:extLst>
           </p:cNvPr>
@@ -11957,7 +11957,7 @@
           <p:cNvPr id="63" name="">
             <a:extLst xmlns:a="http://schemas.openxmlformats.org/drawingml/2006/main">
               <a:ext uri="{FF2B5EF4-FFF2-40B4-BE49-F238E27FC236}">
-                <a16:creationId xmlns:a16="http://schemas.microsoft.com/office/drawing/2014/main" id="{1BB27CB9-5857-462C-8B01-5196B04FFB77}"/>
+                <a16:creationId xmlns:a16="http://schemas.microsoft.com/office/drawing/2014/main" id="{BB69E540-EF63-4061-8EEA-69B6B19AEA26}"/>
               </a:ext>
             </a:extLst>
           </p:cNvPr>
@@ -12021,7 +12021,7 @@
           <p:cNvPr id="64" name="">
             <a:extLst xmlns:a="http://schemas.openxmlformats.org/drawingml/2006/main">
               <a:ext uri="{FF2B5EF4-FFF2-40B4-BE49-F238E27FC236}">
-                <a16:creationId xmlns:a16="http://schemas.microsoft.com/office/drawing/2014/main" id="{44CE7A02-33ED-4059-B179-4ECC00519A17}"/>
+                <a16:creationId xmlns:a16="http://schemas.microsoft.com/office/drawing/2014/main" id="{82B64C33-6BC7-41F0-9DB0-682B7FAE026B}"/>
               </a:ext>
             </a:extLst>
           </p:cNvPr>
@@ -12056,7 +12056,7 @@
           <p:cNvPr id="65" name="">
             <a:extLst xmlns:a="http://schemas.openxmlformats.org/drawingml/2006/main">
               <a:ext uri="{FF2B5EF4-FFF2-40B4-BE49-F238E27FC236}">
-                <a16:creationId xmlns:a16="http://schemas.microsoft.com/office/drawing/2014/main" id="{BAF91DD3-A9C5-4F14-BDF3-AFC9D710CF09}"/>
+                <a16:creationId xmlns:a16="http://schemas.microsoft.com/office/drawing/2014/main" id="{39208974-AF52-45AC-966F-2E04004B2105}"/>
               </a:ext>
             </a:extLst>
           </p:cNvPr>
@@ -12096,9 +12096,9 @@
                 <a:solidFill>
                   <a:srgbClr val="111827"/>
                 </a:solidFill>
-                <a:latin typeface="Menlo"/>
-                <a:ea typeface="Menlo"/>
-                <a:cs typeface="Menlo"/>
+                <a:latin typeface="Hiragino Sans"/>
+                <a:ea typeface="Hiragino Sans"/>
+                <a:cs typeface="Hiragino Sans"/>
               </a:defRPr>
             </a:pPr>
             <a:r>
@@ -12106,11 +12106,11 @@
                 <a:solidFill>
                   <a:srgbClr val="111827"/>
                 </a:solidFill>
-                <a:latin typeface="Menlo"/>
-                <a:ea typeface="Menlo"/>
-                <a:cs typeface="Menlo"/>
+                <a:latin typeface="Hiragino Sans"/>
+                <a:ea typeface="Hiragino Sans"/>
+                <a:cs typeface="Hiragino Sans"/>
               </a:rPr>
-              <a:t>特徴混合 + 文脈 + bottleneck</a:t>
+              <a:t>特徴混合・文脈・ボトルネック</a:t>
             </a:r>
           </a:p>
         </p:txBody>
@@ -12120,7 +12120,7 @@
           <p:cNvPr id="66" name="">
             <a:extLst xmlns:a="http://schemas.openxmlformats.org/drawingml/2006/main">
               <a:ext uri="{FF2B5EF4-FFF2-40B4-BE49-F238E27FC236}">
-                <a16:creationId xmlns:a16="http://schemas.microsoft.com/office/drawing/2014/main" id="{5493C284-8ED6-4EA4-8AB6-6F71F21915E0}"/>
+                <a16:creationId xmlns:a16="http://schemas.microsoft.com/office/drawing/2014/main" id="{FBE454A2-D0F7-4E6F-A945-A547D1CE72DD}"/>
               </a:ext>
             </a:extLst>
           </p:cNvPr>
@@ -12155,7 +12155,7 @@
           <p:cNvPr id="67" name="">
             <a:extLst xmlns:a="http://schemas.openxmlformats.org/drawingml/2006/main">
               <a:ext uri="{FF2B5EF4-FFF2-40B4-BE49-F238E27FC236}">
-                <a16:creationId xmlns:a16="http://schemas.microsoft.com/office/drawing/2014/main" id="{AED22E7D-3675-4EB2-890A-C6F67110909F}"/>
+                <a16:creationId xmlns:a16="http://schemas.microsoft.com/office/drawing/2014/main" id="{EDB7CFB3-1658-4148-A70B-378E079168D3}"/>
               </a:ext>
             </a:extLst>
           </p:cNvPr>
@@ -12219,7 +12219,7 @@
           <p:cNvPr id="68" name="">
             <a:extLst xmlns:a="http://schemas.openxmlformats.org/drawingml/2006/main">
               <a:ext uri="{FF2B5EF4-FFF2-40B4-BE49-F238E27FC236}">
-                <a16:creationId xmlns:a16="http://schemas.microsoft.com/office/drawing/2014/main" id="{95E92647-4836-4138-8024-0C2891E55EBB}"/>
+                <a16:creationId xmlns:a16="http://schemas.microsoft.com/office/drawing/2014/main" id="{E9E65B63-B490-45D8-94E5-4A34E29204BB}"/>
               </a:ext>
             </a:extLst>
           </p:cNvPr>
@@ -12254,7 +12254,7 @@
           <p:cNvPr id="69" name="">
             <a:extLst xmlns:a="http://schemas.openxmlformats.org/drawingml/2006/main">
               <a:ext uri="{FF2B5EF4-FFF2-40B4-BE49-F238E27FC236}">
-                <a16:creationId xmlns:a16="http://schemas.microsoft.com/office/drawing/2014/main" id="{CA7FCEC4-DE26-42E8-845B-E24354EA5739}"/>
+                <a16:creationId xmlns:a16="http://schemas.microsoft.com/office/drawing/2014/main" id="{A28460AD-8BFE-4785-9153-C1175DDB15BA}"/>
               </a:ext>
             </a:extLst>
           </p:cNvPr>
@@ -12318,7 +12318,7 @@
           <p:cNvPr id="70" name="">
             <a:extLst xmlns:a="http://schemas.openxmlformats.org/drawingml/2006/main">
               <a:ext uri="{FF2B5EF4-FFF2-40B4-BE49-F238E27FC236}">
-                <a16:creationId xmlns:a16="http://schemas.microsoft.com/office/drawing/2014/main" id="{2DF49113-47D8-48E7-AA27-D4AF70B2A76C}"/>
+                <a16:creationId xmlns:a16="http://schemas.microsoft.com/office/drawing/2014/main" id="{E7C36560-BE1A-4A90-AB4E-18BBFC67C4B2}"/>
               </a:ext>
             </a:extLst>
           </p:cNvPr>
@@ -12351,7 +12351,7 @@
           <p:cNvPr id="71" name="">
             <a:extLst xmlns:a="http://schemas.openxmlformats.org/drawingml/2006/main">
               <a:ext uri="{FF2B5EF4-FFF2-40B4-BE49-F238E27FC236}">
-                <a16:creationId xmlns:a16="http://schemas.microsoft.com/office/drawing/2014/main" id="{81A37AB7-01D6-4787-88EE-B57A5B73B6DF}"/>
+                <a16:creationId xmlns:a16="http://schemas.microsoft.com/office/drawing/2014/main" id="{D194EAD7-1225-4CDE-8778-9A2668AF3AA6}"/>
               </a:ext>
             </a:extLst>
           </p:cNvPr>
@@ -12405,7 +12405,7 @@
                 <a:ea typeface="Hiragino Sans"/>
                 <a:cs typeface="Hiragino Sans"/>
               </a:rPr>
-              <a:t>選定方針: 簡単な候補で説明できるなら、そこで止める</a:t>
+              <a:t>選定方針: 単純な候補で説明できるなら、上位候補へ進めない</a:t>
             </a:r>
           </a:p>
         </p:txBody>
@@ -12415,7 +12415,7 @@
           <p:cNvPr id="72" name="">
             <a:extLst xmlns:a="http://schemas.openxmlformats.org/drawingml/2006/main">
               <a:ext uri="{FF2B5EF4-FFF2-40B4-BE49-F238E27FC236}">
-                <a16:creationId xmlns:a16="http://schemas.microsoft.com/office/drawing/2014/main" id="{3537BDB9-B7D3-4291-B427-FEF97036FEB4}"/>
+                <a16:creationId xmlns:a16="http://schemas.microsoft.com/office/drawing/2014/main" id="{46BFAFDA-4370-4A4C-9E7C-4DDA4A662902}"/>
               </a:ext>
             </a:extLst>
           </p:cNvPr>
@@ -12448,7 +12448,7 @@
           <p:cNvPr id="73" name="">
             <a:extLst xmlns:a="http://schemas.openxmlformats.org/drawingml/2006/main">
               <a:ext uri="{FF2B5EF4-FFF2-40B4-BE49-F238E27FC236}">
-                <a16:creationId xmlns:a16="http://schemas.microsoft.com/office/drawing/2014/main" id="{BC98D0CF-0A5B-4D22-B646-2B2846BDFFA8}"/>
+                <a16:creationId xmlns:a16="http://schemas.microsoft.com/office/drawing/2014/main" id="{24808D1F-A77F-4474-A55A-4C09FB983789}"/>
               </a:ext>
             </a:extLst>
           </p:cNvPr>
@@ -12502,7 +12502,7 @@
                 <a:ea typeface="Hiragino Sans"/>
                 <a:cs typeface="Hiragino Sans"/>
               </a:rPr>
-              <a:t>未主張: 実測前に性能順位・MNN適合・500KB内に収まった結論を言わない</a:t>
+              <a:t>未主張: 実測前に性能順位・MNN適合・500 KB内に収まった結論を言わない</a:t>
             </a:r>
           </a:p>
         </p:txBody>
@@ -12512,7 +12512,7 @@
           <p:cNvPr id="74" name="">
             <a:extLst xmlns:a="http://schemas.openxmlformats.org/drawingml/2006/main">
               <a:ext uri="{FF2B5EF4-FFF2-40B4-BE49-F238E27FC236}">
-                <a16:creationId xmlns:a16="http://schemas.microsoft.com/office/drawing/2014/main" id="{10743D2E-ED08-4962-915A-A5D4F379CD60}"/>
+                <a16:creationId xmlns:a16="http://schemas.microsoft.com/office/drawing/2014/main" id="{7F04B419-A0EF-49B2-B839-2B36CF234E09}"/>
               </a:ext>
             </a:extLst>
           </p:cNvPr>
@@ -12547,7 +12547,7 @@
           <p:cNvPr id="75" name="">
             <a:extLst xmlns:a="http://schemas.openxmlformats.org/drawingml/2006/main">
               <a:ext uri="{FF2B5EF4-FFF2-40B4-BE49-F238E27FC236}">
-                <a16:creationId xmlns:a16="http://schemas.microsoft.com/office/drawing/2014/main" id="{D2A7F877-0605-4B6F-8BD0-912866E63B0C}"/>
+                <a16:creationId xmlns:a16="http://schemas.microsoft.com/office/drawing/2014/main" id="{06EC8F3F-84D5-4C91-9543-91505B254F44}"/>
               </a:ext>
             </a:extLst>
           </p:cNvPr>
@@ -12609,7 +12609,7 @@
     </p:spTree>
     <p:extLst>
       <p:ext uri="{BB962C8B-B14F-4D97-AF65-F5344CB8AC3E}">
-        <p14:creationId xmlns:p14="http://schemas.microsoft.com/office/powerpoint/2010/main" val="1863614426"/>
+        <p14:creationId xmlns:p14="http://schemas.microsoft.com/office/powerpoint/2010/main" val="1472322859"/>
       </p:ext>
     </p:extLst>
   </p:cSld>
@@ -12633,7 +12633,7 @@
           <p:cNvPr id="1" name="">
             <a:extLst xmlns:a="http://schemas.openxmlformats.org/drawingml/2006/main">
               <a:ext uri="{FF2B5EF4-FFF2-40B4-BE49-F238E27FC236}">
-                <a16:creationId xmlns:a16="http://schemas.microsoft.com/office/drawing/2014/main" id="{3405EBDA-C07F-4449-9C02-39548EC2890A}"/>
+                <a16:creationId xmlns:a16="http://schemas.microsoft.com/office/drawing/2014/main" id="{BE9A472D-9E99-44CA-9BE2-1112E6DBE64D}"/>
               </a:ext>
             </a:extLst>
           </p:cNvPr>
@@ -12668,7 +12668,7 @@
           <p:cNvPr id="2" name="">
             <a:extLst xmlns:a="http://schemas.openxmlformats.org/drawingml/2006/main">
               <a:ext uri="{FF2B5EF4-FFF2-40B4-BE49-F238E27FC236}">
-                <a16:creationId xmlns:a16="http://schemas.microsoft.com/office/drawing/2014/main" id="{6100A0D6-1DE1-4736-B7AF-ADEAA494F695}"/>
+                <a16:creationId xmlns:a16="http://schemas.microsoft.com/office/drawing/2014/main" id="{20A672CC-B23C-4212-8894-21AC9CDB4E85}"/>
               </a:ext>
             </a:extLst>
           </p:cNvPr>
@@ -12703,7 +12703,7 @@
           <p:cNvPr id="3" name="">
             <a:extLst xmlns:a="http://schemas.openxmlformats.org/drawingml/2006/main">
               <a:ext uri="{FF2B5EF4-FFF2-40B4-BE49-F238E27FC236}">
-                <a16:creationId xmlns:a16="http://schemas.microsoft.com/office/drawing/2014/main" id="{B253B68C-12BF-4187-A47F-8676622F52FA}"/>
+                <a16:creationId xmlns:a16="http://schemas.microsoft.com/office/drawing/2014/main" id="{83DD651F-012F-4E11-883D-B9F1D568F2F5}"/>
               </a:ext>
             </a:extLst>
           </p:cNvPr>
@@ -12738,7 +12738,7 @@
           <p:cNvPr id="4" name="">
             <a:extLst xmlns:a="http://schemas.openxmlformats.org/drawingml/2006/main">
               <a:ext uri="{FF2B5EF4-FFF2-40B4-BE49-F238E27FC236}">
-                <a16:creationId xmlns:a16="http://schemas.microsoft.com/office/drawing/2014/main" id="{54E3AE36-6135-465C-AAD1-EA38DD812E90}"/>
+                <a16:creationId xmlns:a16="http://schemas.microsoft.com/office/drawing/2014/main" id="{C020EBED-BC7B-49E2-B4FD-6CA8C7154591}"/>
               </a:ext>
             </a:extLst>
           </p:cNvPr>
@@ -12802,7 +12802,7 @@
           <p:cNvPr id="5" name="">
             <a:extLst xmlns:a="http://schemas.openxmlformats.org/drawingml/2006/main">
               <a:ext uri="{FF2B5EF4-FFF2-40B4-BE49-F238E27FC236}">
-                <a16:creationId xmlns:a16="http://schemas.microsoft.com/office/drawing/2014/main" id="{EB49CC2B-39B1-4B74-858D-271C11E8D473}"/>
+                <a16:creationId xmlns:a16="http://schemas.microsoft.com/office/drawing/2014/main" id="{6E6B824F-E219-426E-B086-EE50F565386C}"/>
               </a:ext>
             </a:extLst>
           </p:cNvPr>
@@ -12866,7 +12866,7 @@
           <p:cNvPr id="6" name="">
             <a:extLst xmlns:a="http://schemas.openxmlformats.org/drawingml/2006/main">
               <a:ext uri="{FF2B5EF4-FFF2-40B4-BE49-F238E27FC236}">
-                <a16:creationId xmlns:a16="http://schemas.microsoft.com/office/drawing/2014/main" id="{B5FD8BE5-4FA7-49EC-B290-18FC65C5A466}"/>
+                <a16:creationId xmlns:a16="http://schemas.microsoft.com/office/drawing/2014/main" id="{3B89A82A-B2F2-4055-9314-B89E73B2AD68}"/>
               </a:ext>
             </a:extLst>
           </p:cNvPr>
@@ -12920,7 +12920,7 @@
                 <a:ea typeface="Hiragino Mincho ProN"/>
                 <a:cs typeface="Hiragino Mincho ProN"/>
               </a:rPr>
-              <a:t>500 KBの判定では、重みだけでなくvolumeごとの状態も数える</a:t>
+              <a:t>500 KBの対象は、重みだけでなくボリュームごとの状態である</a:t>
             </a:r>
           </a:p>
         </p:txBody>
@@ -12930,7 +12930,7 @@
           <p:cNvPr id="7" name="">
             <a:extLst xmlns:a="http://schemas.openxmlformats.org/drawingml/2006/main">
               <a:ext uri="{FF2B5EF4-FFF2-40B4-BE49-F238E27FC236}">
-                <a16:creationId xmlns:a16="http://schemas.microsoft.com/office/drawing/2014/main" id="{4E305453-4E16-4E50-A7A7-EA581A737D8A}"/>
+                <a16:creationId xmlns:a16="http://schemas.microsoft.com/office/drawing/2014/main" id="{D6E01E40-5F6B-4CDB-810A-E5BCE19A0F05}"/>
               </a:ext>
             </a:extLst>
           </p:cNvPr>
@@ -12963,7 +12963,7 @@
           <p:cNvPr id="8" name="">
             <a:extLst xmlns:a="http://schemas.openxmlformats.org/drawingml/2006/main">
               <a:ext uri="{FF2B5EF4-FFF2-40B4-BE49-F238E27FC236}">
-                <a16:creationId xmlns:a16="http://schemas.microsoft.com/office/drawing/2014/main" id="{C1EA3A6D-8F80-4990-906A-FBCF6A951EDF}"/>
+                <a16:creationId xmlns:a16="http://schemas.microsoft.com/office/drawing/2014/main" id="{42132AB7-2D5B-41AC-8BBF-C4FCD93CEB73}"/>
               </a:ext>
             </a:extLst>
           </p:cNvPr>
@@ -12998,7 +12998,7 @@
           <p:cNvPr id="9" name="">
             <a:extLst xmlns:a="http://schemas.openxmlformats.org/drawingml/2006/main">
               <a:ext uri="{FF2B5EF4-FFF2-40B4-BE49-F238E27FC236}">
-                <a16:creationId xmlns:a16="http://schemas.microsoft.com/office/drawing/2014/main" id="{34A6A2C6-037F-49C4-96B6-A6ED1376534F}"/>
+                <a16:creationId xmlns:a16="http://schemas.microsoft.com/office/drawing/2014/main" id="{73673D9B-3320-4D60-B71E-CB466F2ECAB1}"/>
               </a:ext>
             </a:extLst>
           </p:cNvPr>
@@ -13052,7 +13052,7 @@
                 <a:ea typeface="Hiragino Sans"/>
                 <a:cs typeface="Hiragino Sans"/>
               </a:rPr>
-              <a:t>主張 | 測る対象はモデル重みだけではなく、入力列、正規化、threshold、score履歴を含むper-volume detector-dataである。</a:t>
+              <a:t>主張 | 予算に入れるのはモデル重み、入力列、正規化値、しきい値、スコア履歴であり、共有runtimeや一時scratchとは分けて測る。</a:t>
             </a:r>
           </a:p>
         </p:txBody>
@@ -13062,7 +13062,7 @@
           <p:cNvPr id="10" name="">
             <a:extLst xmlns:a="http://schemas.openxmlformats.org/drawingml/2006/main">
               <a:ext uri="{FF2B5EF4-FFF2-40B4-BE49-F238E27FC236}">
-                <a16:creationId xmlns:a16="http://schemas.microsoft.com/office/drawing/2014/main" id="{9A7035B4-8DD5-4EA9-BDE3-425571A6B463}"/>
+                <a16:creationId xmlns:a16="http://schemas.microsoft.com/office/drawing/2014/main" id="{E47AC8FA-E199-42DD-9A66-E3FEF5C30DEA}"/>
               </a:ext>
             </a:extLst>
           </p:cNvPr>
@@ -13095,7 +13095,7 @@
           <p:cNvPr id="11" name="">
             <a:extLst xmlns:a="http://schemas.openxmlformats.org/drawingml/2006/main">
               <a:ext uri="{FF2B5EF4-FFF2-40B4-BE49-F238E27FC236}">
-                <a16:creationId xmlns:a16="http://schemas.microsoft.com/office/drawing/2014/main" id="{F78C30F2-81BD-400B-8BE8-D1F4C0CDAE17}"/>
+                <a16:creationId xmlns:a16="http://schemas.microsoft.com/office/drawing/2014/main" id="{487543CF-A9D0-4A43-8240-CF66F774D4D8}"/>
               </a:ext>
             </a:extLst>
           </p:cNvPr>
@@ -13130,7 +13130,7 @@
           <p:cNvPr id="12" name="">
             <a:extLst xmlns:a="http://schemas.openxmlformats.org/drawingml/2006/main">
               <a:ext uri="{FF2B5EF4-FFF2-40B4-BE49-F238E27FC236}">
-                <a16:creationId xmlns:a16="http://schemas.microsoft.com/office/drawing/2014/main" id="{5DA9D3E3-7BDD-4033-A7B9-4D18CA495C23}"/>
+                <a16:creationId xmlns:a16="http://schemas.microsoft.com/office/drawing/2014/main" id="{1CE64FB8-D8D9-48BA-865B-1EB19780144B}"/>
               </a:ext>
             </a:extLst>
           </p:cNvPr>
@@ -13184,7 +13184,7 @@
                 <a:ea typeface="Hiragino Sans"/>
                 <a:cs typeface="Hiragino Sans"/>
               </a:rPr>
-              <a:t>per-volume detector-data target</a:t>
+              <a:t>ボリュームごとの detector-data 目標</a:t>
             </a:r>
           </a:p>
         </p:txBody>
@@ -13194,7 +13194,7 @@
           <p:cNvPr id="13" name="">
             <a:extLst xmlns:a="http://schemas.openxmlformats.org/drawingml/2006/main">
               <a:ext uri="{FF2B5EF4-FFF2-40B4-BE49-F238E27FC236}">
-                <a16:creationId xmlns:a16="http://schemas.microsoft.com/office/drawing/2014/main" id="{0D46CC21-F9BD-4A19-8715-1593B64FADDF}"/>
+                <a16:creationId xmlns:a16="http://schemas.microsoft.com/office/drawing/2014/main" id="{947FA0FD-140F-4EB8-A3C2-4CA0ED3B56A1}"/>
               </a:ext>
             </a:extLst>
           </p:cNvPr>
@@ -13227,7 +13227,7 @@
           <p:cNvPr id="14" name="">
             <a:extLst xmlns:a="http://schemas.openxmlformats.org/drawingml/2006/main">
               <a:ext uri="{FF2B5EF4-FFF2-40B4-BE49-F238E27FC236}">
-                <a16:creationId xmlns:a16="http://schemas.microsoft.com/office/drawing/2014/main" id="{8B630B6A-221B-401D-AE87-56DBCE4F972B}"/>
+                <a16:creationId xmlns:a16="http://schemas.microsoft.com/office/drawing/2014/main" id="{F9A43D70-7F3B-41AD-8ADA-FC114BD885D0}"/>
               </a:ext>
             </a:extLst>
           </p:cNvPr>
@@ -13291,7 +13291,7 @@
           <p:cNvPr id="15" name="">
             <a:extLst xmlns:a="http://schemas.openxmlformats.org/drawingml/2006/main">
               <a:ext uri="{FF2B5EF4-FFF2-40B4-BE49-F238E27FC236}">
-                <a16:creationId xmlns:a16="http://schemas.microsoft.com/office/drawing/2014/main" id="{B669A313-01D7-47B6-BCB2-479BEC9CE373}"/>
+                <a16:creationId xmlns:a16="http://schemas.microsoft.com/office/drawing/2014/main" id="{B0571308-734C-400A-B414-AF1CA1D68DD3}"/>
               </a:ext>
             </a:extLst>
           </p:cNvPr>
@@ -13326,7 +13326,7 @@
           <p:cNvPr id="16" name="">
             <a:extLst xmlns:a="http://schemas.openxmlformats.org/drawingml/2006/main">
               <a:ext uri="{FF2B5EF4-FFF2-40B4-BE49-F238E27FC236}">
-                <a16:creationId xmlns:a16="http://schemas.microsoft.com/office/drawing/2014/main" id="{45C0B4B4-AB16-4545-BEBD-6FFFBC3CBAC5}"/>
+                <a16:creationId xmlns:a16="http://schemas.microsoft.com/office/drawing/2014/main" id="{C37CA32B-9831-4251-8DEA-38332DFB365B}"/>
               </a:ext>
             </a:extLst>
           </p:cNvPr>
@@ -13390,7 +13390,7 @@
           <p:cNvPr id="17" name="">
             <a:extLst xmlns:a="http://schemas.openxmlformats.org/drawingml/2006/main">
               <a:ext uri="{FF2B5EF4-FFF2-40B4-BE49-F238E27FC236}">
-                <a16:creationId xmlns:a16="http://schemas.microsoft.com/office/drawing/2014/main" id="{2821EEE7-B1DA-4FBB-8506-E582DDFF61F1}"/>
+                <a16:creationId xmlns:a16="http://schemas.microsoft.com/office/drawing/2014/main" id="{9A410456-EE3A-43DE-A504-F3A5EFEDDA5B}"/>
               </a:ext>
             </a:extLst>
           </p:cNvPr>
@@ -13423,7 +13423,7 @@
           <p:cNvPr id="18" name="">
             <a:extLst xmlns:a="http://schemas.openxmlformats.org/drawingml/2006/main">
               <a:ext uri="{FF2B5EF4-FFF2-40B4-BE49-F238E27FC236}">
-                <a16:creationId xmlns:a16="http://schemas.microsoft.com/office/drawing/2014/main" id="{414CF34C-A873-402A-8A20-7BEF9B0C4A29}"/>
+                <a16:creationId xmlns:a16="http://schemas.microsoft.com/office/drawing/2014/main" id="{86AD5EC6-643D-4545-957D-78D2726CF8D7}"/>
               </a:ext>
             </a:extLst>
           </p:cNvPr>
@@ -13487,7 +13487,7 @@
           <p:cNvPr id="19" name="">
             <a:extLst xmlns:a="http://schemas.openxmlformats.org/drawingml/2006/main">
               <a:ext uri="{FF2B5EF4-FFF2-40B4-BE49-F238E27FC236}">
-                <a16:creationId xmlns:a16="http://schemas.microsoft.com/office/drawing/2014/main" id="{6F51A4E1-1810-4D5C-81AD-A40A95CF202B}"/>
+                <a16:creationId xmlns:a16="http://schemas.microsoft.com/office/drawing/2014/main" id="{29ADBDA8-D0A5-4E61-B5A7-584D72416BA3}"/>
               </a:ext>
             </a:extLst>
           </p:cNvPr>
@@ -13522,7 +13522,7 @@
           <p:cNvPr id="20" name="">
             <a:extLst xmlns:a="http://schemas.openxmlformats.org/drawingml/2006/main">
               <a:ext uri="{FF2B5EF4-FFF2-40B4-BE49-F238E27FC236}">
-                <a16:creationId xmlns:a16="http://schemas.microsoft.com/office/drawing/2014/main" id="{C2453CBB-2746-4C35-B169-912AD315259A}"/>
+                <a16:creationId xmlns:a16="http://schemas.microsoft.com/office/drawing/2014/main" id="{E5F6D60A-1D5C-4F31-A422-9D140A8E29D4}"/>
               </a:ext>
             </a:extLst>
           </p:cNvPr>
@@ -13586,7 +13586,7 @@
           <p:cNvPr id="21" name="">
             <a:extLst xmlns:a="http://schemas.openxmlformats.org/drawingml/2006/main">
               <a:ext uri="{FF2B5EF4-FFF2-40B4-BE49-F238E27FC236}">
-                <a16:creationId xmlns:a16="http://schemas.microsoft.com/office/drawing/2014/main" id="{183E8182-0D84-4F5C-92F1-ADD6CD9D9EA3}"/>
+                <a16:creationId xmlns:a16="http://schemas.microsoft.com/office/drawing/2014/main" id="{94977C32-AC75-4A0F-B4CA-18CC62F00853}"/>
               </a:ext>
             </a:extLst>
           </p:cNvPr>
@@ -13619,7 +13619,7 @@
           <p:cNvPr id="22" name="">
             <a:extLst xmlns:a="http://schemas.openxmlformats.org/drawingml/2006/main">
               <a:ext uri="{FF2B5EF4-FFF2-40B4-BE49-F238E27FC236}">
-                <a16:creationId xmlns:a16="http://schemas.microsoft.com/office/drawing/2014/main" id="{DABC9060-D749-4C5A-B3CF-485604704D9C}"/>
+                <a16:creationId xmlns:a16="http://schemas.microsoft.com/office/drawing/2014/main" id="{31D9C891-00A7-4C4F-9B9E-9A9E2E83A8B2}"/>
               </a:ext>
             </a:extLst>
           </p:cNvPr>
@@ -13683,7 +13683,7 @@
           <p:cNvPr id="23" name="">
             <a:extLst xmlns:a="http://schemas.openxmlformats.org/drawingml/2006/main">
               <a:ext uri="{FF2B5EF4-FFF2-40B4-BE49-F238E27FC236}">
-                <a16:creationId xmlns:a16="http://schemas.microsoft.com/office/drawing/2014/main" id="{E4B0D624-A35D-480B-8531-2B00956C61EA}"/>
+                <a16:creationId xmlns:a16="http://schemas.microsoft.com/office/drawing/2014/main" id="{695BB66E-81CB-4C1E-A42A-6193E75CAFE2}"/>
               </a:ext>
             </a:extLst>
           </p:cNvPr>
@@ -13718,7 +13718,7 @@
           <p:cNvPr id="24" name="">
             <a:extLst xmlns:a="http://schemas.openxmlformats.org/drawingml/2006/main">
               <a:ext uri="{FF2B5EF4-FFF2-40B4-BE49-F238E27FC236}">
-                <a16:creationId xmlns:a16="http://schemas.microsoft.com/office/drawing/2014/main" id="{F519C4CB-D7DB-40EF-8A4E-866097072E5A}"/>
+                <a16:creationId xmlns:a16="http://schemas.microsoft.com/office/drawing/2014/main" id="{652EBE7F-2DB6-413F-8186-64F2020FB426}"/>
               </a:ext>
             </a:extLst>
           </p:cNvPr>
@@ -13782,7 +13782,7 @@
           <p:cNvPr id="25" name="">
             <a:extLst xmlns:a="http://schemas.openxmlformats.org/drawingml/2006/main">
               <a:ext uri="{FF2B5EF4-FFF2-40B4-BE49-F238E27FC236}">
-                <a16:creationId xmlns:a16="http://schemas.microsoft.com/office/drawing/2014/main" id="{15DF4630-2A80-403C-A760-60D3286428B7}"/>
+                <a16:creationId xmlns:a16="http://schemas.microsoft.com/office/drawing/2014/main" id="{A6659248-1D1A-45CE-9CAE-6E350E0D6B57}"/>
               </a:ext>
             </a:extLst>
           </p:cNvPr>
@@ -13815,7 +13815,7 @@
           <p:cNvPr id="26" name="">
             <a:extLst xmlns:a="http://schemas.openxmlformats.org/drawingml/2006/main">
               <a:ext uri="{FF2B5EF4-FFF2-40B4-BE49-F238E27FC236}">
-                <a16:creationId xmlns:a16="http://schemas.microsoft.com/office/drawing/2014/main" id="{12BE3139-F50F-4CE1-A310-3D375372243B}"/>
+                <a16:creationId xmlns:a16="http://schemas.microsoft.com/office/drawing/2014/main" id="{73C306FF-F7F7-4010-A597-5E76B930AC50}"/>
               </a:ext>
             </a:extLst>
           </p:cNvPr>
@@ -13879,7 +13879,7 @@
           <p:cNvPr id="27" name="">
             <a:extLst xmlns:a="http://schemas.openxmlformats.org/drawingml/2006/main">
               <a:ext uri="{FF2B5EF4-FFF2-40B4-BE49-F238E27FC236}">
-                <a16:creationId xmlns:a16="http://schemas.microsoft.com/office/drawing/2014/main" id="{2F919FFE-E9F0-47B3-AD60-FA1C82003062}"/>
+                <a16:creationId xmlns:a16="http://schemas.microsoft.com/office/drawing/2014/main" id="{766981AD-D539-4FBA-8945-CBE035DAB115}"/>
               </a:ext>
             </a:extLst>
           </p:cNvPr>
@@ -13914,7 +13914,7 @@
           <p:cNvPr id="28" name="">
             <a:extLst xmlns:a="http://schemas.openxmlformats.org/drawingml/2006/main">
               <a:ext uri="{FF2B5EF4-FFF2-40B4-BE49-F238E27FC236}">
-                <a16:creationId xmlns:a16="http://schemas.microsoft.com/office/drawing/2014/main" id="{3E2E06F8-0980-4486-8972-A97A2F1C7400}"/>
+                <a16:creationId xmlns:a16="http://schemas.microsoft.com/office/drawing/2014/main" id="{79FA41A9-CF5D-41F7-9E34-6B21139C6247}"/>
               </a:ext>
             </a:extLst>
           </p:cNvPr>
@@ -13978,7 +13978,7 @@
           <p:cNvPr id="29" name="">
             <a:extLst xmlns:a="http://schemas.openxmlformats.org/drawingml/2006/main">
               <a:ext uri="{FF2B5EF4-FFF2-40B4-BE49-F238E27FC236}">
-                <a16:creationId xmlns:a16="http://schemas.microsoft.com/office/drawing/2014/main" id="{933B9741-5860-493F-9271-58120217EC98}"/>
+                <a16:creationId xmlns:a16="http://schemas.microsoft.com/office/drawing/2014/main" id="{8B94A0C7-4432-43F9-9A78-12D32B85FEC6}"/>
               </a:ext>
             </a:extLst>
           </p:cNvPr>
@@ -14011,7 +14011,7 @@
           <p:cNvPr id="30" name="">
             <a:extLst xmlns:a="http://schemas.openxmlformats.org/drawingml/2006/main">
               <a:ext uri="{FF2B5EF4-FFF2-40B4-BE49-F238E27FC236}">
-                <a16:creationId xmlns:a16="http://schemas.microsoft.com/office/drawing/2014/main" id="{9F5AF5E6-52BC-4E3B-9A2D-B225078F65B6}"/>
+                <a16:creationId xmlns:a16="http://schemas.microsoft.com/office/drawing/2014/main" id="{72FAAF61-09AB-490E-8B92-2A9E3C0B5010}"/>
               </a:ext>
             </a:extLst>
           </p:cNvPr>
@@ -14075,7 +14075,7 @@
           <p:cNvPr id="31" name="">
             <a:extLst xmlns:a="http://schemas.openxmlformats.org/drawingml/2006/main">
               <a:ext uri="{FF2B5EF4-FFF2-40B4-BE49-F238E27FC236}">
-                <a16:creationId xmlns:a16="http://schemas.microsoft.com/office/drawing/2014/main" id="{DBD540E2-0007-44D8-9E1F-8117A33272BE}"/>
+                <a16:creationId xmlns:a16="http://schemas.microsoft.com/office/drawing/2014/main" id="{75A0399D-2E2D-48B9-8E80-F8CA85B76B3F}"/>
               </a:ext>
             </a:extLst>
           </p:cNvPr>
@@ -14110,7 +14110,7 @@
           <p:cNvPr id="32" name="">
             <a:extLst xmlns:a="http://schemas.openxmlformats.org/drawingml/2006/main">
               <a:ext uri="{FF2B5EF4-FFF2-40B4-BE49-F238E27FC236}">
-                <a16:creationId xmlns:a16="http://schemas.microsoft.com/office/drawing/2014/main" id="{3977B3B2-5A0E-495D-8104-F6AE1973BF9A}"/>
+                <a16:creationId xmlns:a16="http://schemas.microsoft.com/office/drawing/2014/main" id="{8402D027-B74A-4CD5-B047-48211A8E319D}"/>
               </a:ext>
             </a:extLst>
           </p:cNvPr>
@@ -14174,7 +14174,7 @@
           <p:cNvPr id="33" name="">
             <a:extLst xmlns:a="http://schemas.openxmlformats.org/drawingml/2006/main">
               <a:ext uri="{FF2B5EF4-FFF2-40B4-BE49-F238E27FC236}">
-                <a16:creationId xmlns:a16="http://schemas.microsoft.com/office/drawing/2014/main" id="{7F71719B-65EC-462C-9FF4-349AB248C6F3}"/>
+                <a16:creationId xmlns:a16="http://schemas.microsoft.com/office/drawing/2014/main" id="{A8D18386-F0CA-45BB-9280-121702CFE63A}"/>
               </a:ext>
             </a:extLst>
           </p:cNvPr>
@@ -14238,7 +14238,7 @@
           <p:cNvPr id="34" name="">
             <a:extLst xmlns:a="http://schemas.openxmlformats.org/drawingml/2006/main">
               <a:ext uri="{FF2B5EF4-FFF2-40B4-BE49-F238E27FC236}">
-                <a16:creationId xmlns:a16="http://schemas.microsoft.com/office/drawing/2014/main" id="{5CA5E63A-1519-44CA-AB3C-32E79DBD0D64}"/>
+                <a16:creationId xmlns:a16="http://schemas.microsoft.com/office/drawing/2014/main" id="{FEA2DD24-78F8-401D-83E1-9BCC2DD48AF3}"/>
               </a:ext>
             </a:extLst>
           </p:cNvPr>
@@ -14271,7 +14271,7 @@
           <p:cNvPr id="35" name="">
             <a:extLst xmlns:a="http://schemas.openxmlformats.org/drawingml/2006/main">
               <a:ext uri="{FF2B5EF4-FFF2-40B4-BE49-F238E27FC236}">
-                <a16:creationId xmlns:a16="http://schemas.microsoft.com/office/drawing/2014/main" id="{FCEAE34D-B447-4BE0-9407-69CE0E58F38F}"/>
+                <a16:creationId xmlns:a16="http://schemas.microsoft.com/office/drawing/2014/main" id="{6ABD10F6-1683-4756-8076-8B984537DC47}"/>
               </a:ext>
             </a:extLst>
           </p:cNvPr>
@@ -14306,7 +14306,7 @@
           <p:cNvPr id="36" name="">
             <a:extLst xmlns:a="http://schemas.openxmlformats.org/drawingml/2006/main">
               <a:ext uri="{FF2B5EF4-FFF2-40B4-BE49-F238E27FC236}">
-                <a16:creationId xmlns:a16="http://schemas.microsoft.com/office/drawing/2014/main" id="{E24A7684-B9CA-454F-8520-B7F9AC203A63}"/>
+                <a16:creationId xmlns:a16="http://schemas.microsoft.com/office/drawing/2014/main" id="{5A25714E-29E5-42A5-8902-4B91E228FDFE}"/>
               </a:ext>
             </a:extLst>
           </p:cNvPr>
@@ -14370,7 +14370,7 @@
           <p:cNvPr id="37" name="">
             <a:extLst xmlns:a="http://schemas.openxmlformats.org/drawingml/2006/main">
               <a:ext uri="{FF2B5EF4-FFF2-40B4-BE49-F238E27FC236}">
-                <a16:creationId xmlns:a16="http://schemas.microsoft.com/office/drawing/2014/main" id="{FCDD5B09-EE13-4BAA-8873-7C862BFC396C}"/>
+                <a16:creationId xmlns:a16="http://schemas.microsoft.com/office/drawing/2014/main" id="{10407314-2706-4893-976F-2A796589468E}"/>
               </a:ext>
             </a:extLst>
           </p:cNvPr>
@@ -14462,7 +14462,7 @@
           <p:cNvPr id="38" name="">
             <a:extLst xmlns:a="http://schemas.openxmlformats.org/drawingml/2006/main">
               <a:ext uri="{FF2B5EF4-FFF2-40B4-BE49-F238E27FC236}">
-                <a16:creationId xmlns:a16="http://schemas.microsoft.com/office/drawing/2014/main" id="{0A425B90-103D-4C0E-BE49-8FA906DD37A9}"/>
+                <a16:creationId xmlns:a16="http://schemas.microsoft.com/office/drawing/2014/main" id="{5B942B16-0322-4EEE-886E-9993790538F1}"/>
               </a:ext>
             </a:extLst>
           </p:cNvPr>
@@ -14495,7 +14495,7 @@
           <p:cNvPr id="39" name="">
             <a:extLst xmlns:a="http://schemas.openxmlformats.org/drawingml/2006/main">
               <a:ext uri="{FF2B5EF4-FFF2-40B4-BE49-F238E27FC236}">
-                <a16:creationId xmlns:a16="http://schemas.microsoft.com/office/drawing/2014/main" id="{AFB29729-4BB1-435F-937A-1A20874ADB8C}"/>
+                <a16:creationId xmlns:a16="http://schemas.microsoft.com/office/drawing/2014/main" id="{66492FE1-DE1A-4969-92D0-EB5B953FF21B}"/>
               </a:ext>
             </a:extLst>
           </p:cNvPr>
@@ -14572,7 +14572,7 @@
                 <a:ea typeface="Hiragino Sans"/>
                 <a:cs typeface="Hiragino Sans"/>
               </a:rPr>
-              <a:t>多数volumeを同じ10秒cadenceで守る</a:t>
+              <a:t>多数ボリュームを10秒間隔で採点</a:t>
             </a:r>
           </a:p>
         </p:txBody>
@@ -14582,7 +14582,7 @@
           <p:cNvPr id="40" name="">
             <a:extLst xmlns:a="http://schemas.openxmlformats.org/drawingml/2006/main">
               <a:ext uri="{FF2B5EF4-FFF2-40B4-BE49-F238E27FC236}">
-                <a16:creationId xmlns:a16="http://schemas.microsoft.com/office/drawing/2014/main" id="{FE3DF9BF-5996-41F1-A227-966B908DEF9B}"/>
+                <a16:creationId xmlns:a16="http://schemas.microsoft.com/office/drawing/2014/main" id="{64B6A4C3-528A-45AE-81BB-A7B3567703FB}"/>
               </a:ext>
             </a:extLst>
           </p:cNvPr>
@@ -14615,7 +14615,7 @@
           <p:cNvPr id="41" name="">
             <a:extLst xmlns:a="http://schemas.openxmlformats.org/drawingml/2006/main">
               <a:ext uri="{FF2B5EF4-FFF2-40B4-BE49-F238E27FC236}">
-                <a16:creationId xmlns:a16="http://schemas.microsoft.com/office/drawing/2014/main" id="{F7ED05C7-D068-41A2-99AA-1CDB93213CEE}"/>
+                <a16:creationId xmlns:a16="http://schemas.microsoft.com/office/drawing/2014/main" id="{C17FBF80-F0FC-4EAB-B5C7-504D7D148EDB}"/>
               </a:ext>
             </a:extLst>
           </p:cNvPr>
@@ -14692,7 +14692,7 @@
                 <a:ea typeface="Hiragino Sans"/>
                 <a:cs typeface="Hiragino Sans"/>
               </a:rPr>
-              <a:t>同時推論slot数で一時scratchが増える</a:t>
+              <a:t>同時推論slotに応じて一時scratchが増える</a:t>
             </a:r>
           </a:p>
         </p:txBody>
@@ -14702,7 +14702,7 @@
           <p:cNvPr id="42" name="">
             <a:extLst xmlns:a="http://schemas.openxmlformats.org/drawingml/2006/main">
               <a:ext uri="{FF2B5EF4-FFF2-40B4-BE49-F238E27FC236}">
-                <a16:creationId xmlns:a16="http://schemas.microsoft.com/office/drawing/2014/main" id="{DD15F4EB-47C6-487A-99F6-F08D1B10DFBA}"/>
+                <a16:creationId xmlns:a16="http://schemas.microsoft.com/office/drawing/2014/main" id="{7595D06D-CE89-4C6E-A471-9629C4D00609}"/>
               </a:ext>
             </a:extLst>
           </p:cNvPr>
@@ -14735,7 +14735,7 @@
           <p:cNvPr id="43" name="">
             <a:extLst xmlns:a="http://schemas.openxmlformats.org/drawingml/2006/main">
               <a:ext uri="{FF2B5EF4-FFF2-40B4-BE49-F238E27FC236}">
-                <a16:creationId xmlns:a16="http://schemas.microsoft.com/office/drawing/2014/main" id="{DD8A4265-43AA-42CC-BA6C-C1E8B6D02C20}"/>
+                <a16:creationId xmlns:a16="http://schemas.microsoft.com/office/drawing/2014/main" id="{7765A061-D645-499F-972F-2F9766A99C22}"/>
               </a:ext>
             </a:extLst>
           </p:cNvPr>
@@ -14812,7 +14812,7 @@
                 <a:ea typeface="Hiragino Sans"/>
                 <a:cs typeface="Hiragino Sans"/>
               </a:rPr>
-              <a:t>10秒内に全volumeを採点できるか</a:t>
+              <a:t>10秒内に全ボリュームを採点できるか</a:t>
             </a:r>
           </a:p>
         </p:txBody>
@@ -14822,7 +14822,7 @@
           <p:cNvPr id="44" name="">
             <a:extLst xmlns:a="http://schemas.openxmlformats.org/drawingml/2006/main">
               <a:ext uri="{FF2B5EF4-FFF2-40B4-BE49-F238E27FC236}">
-                <a16:creationId xmlns:a16="http://schemas.microsoft.com/office/drawing/2014/main" id="{0D4EA5A3-07EA-4912-881A-F445BFC716BB}"/>
+                <a16:creationId xmlns:a16="http://schemas.microsoft.com/office/drawing/2014/main" id="{91C05159-B251-4DC6-952E-59C01D58A569}"/>
               </a:ext>
             </a:extLst>
           </p:cNvPr>
@@ -14857,7 +14857,7 @@
           <p:cNvPr id="45" name="">
             <a:extLst xmlns:a="http://schemas.openxmlformats.org/drawingml/2006/main">
               <a:ext uri="{FF2B5EF4-FFF2-40B4-BE49-F238E27FC236}">
-                <a16:creationId xmlns:a16="http://schemas.microsoft.com/office/drawing/2014/main" id="{38052FF5-3041-4B19-8D3E-DC9E27F6744F}"/>
+                <a16:creationId xmlns:a16="http://schemas.microsoft.com/office/drawing/2014/main" id="{4EE921BC-0B41-4D4F-8CF8-45EAF84FC928}"/>
               </a:ext>
             </a:extLst>
           </p:cNvPr>
@@ -14919,7 +14919,7 @@
     </p:spTree>
     <p:extLst>
       <p:ext uri="{BB962C8B-B14F-4D97-AF65-F5344CB8AC3E}">
-        <p14:creationId xmlns:p14="http://schemas.microsoft.com/office/powerpoint/2010/main" val="1578849301"/>
+        <p14:creationId xmlns:p14="http://schemas.microsoft.com/office/powerpoint/2010/main" val="1574786530"/>
       </p:ext>
     </p:extLst>
   </p:cSld>
@@ -14943,7 +14943,7 @@
           <p:cNvPr id="1" name="">
             <a:extLst xmlns:a="http://schemas.openxmlformats.org/drawingml/2006/main">
               <a:ext uri="{FF2B5EF4-FFF2-40B4-BE49-F238E27FC236}">
-                <a16:creationId xmlns:a16="http://schemas.microsoft.com/office/drawing/2014/main" id="{D219D851-C268-4945-822E-3D2ED8452994}"/>
+                <a16:creationId xmlns:a16="http://schemas.microsoft.com/office/drawing/2014/main" id="{8390FBFD-CC34-4214-A2B3-3E2B0E596849}"/>
               </a:ext>
             </a:extLst>
           </p:cNvPr>
@@ -14978,7 +14978,7 @@
           <p:cNvPr id="2" name="">
             <a:extLst xmlns:a="http://schemas.openxmlformats.org/drawingml/2006/main">
               <a:ext uri="{FF2B5EF4-FFF2-40B4-BE49-F238E27FC236}">
-                <a16:creationId xmlns:a16="http://schemas.microsoft.com/office/drawing/2014/main" id="{E0D0183F-0135-417C-B18A-C447DD0B8619}"/>
+                <a16:creationId xmlns:a16="http://schemas.microsoft.com/office/drawing/2014/main" id="{313058C1-F055-4E2F-B819-888660C9BD5F}"/>
               </a:ext>
             </a:extLst>
           </p:cNvPr>
@@ -15013,7 +15013,7 @@
           <p:cNvPr id="3" name="">
             <a:extLst xmlns:a="http://schemas.openxmlformats.org/drawingml/2006/main">
               <a:ext uri="{FF2B5EF4-FFF2-40B4-BE49-F238E27FC236}">
-                <a16:creationId xmlns:a16="http://schemas.microsoft.com/office/drawing/2014/main" id="{B640788A-5C79-4837-96AE-33C2C4CBF322}"/>
+                <a16:creationId xmlns:a16="http://schemas.microsoft.com/office/drawing/2014/main" id="{A2169F84-6023-406A-A655-208C5C253B6E}"/>
               </a:ext>
             </a:extLst>
           </p:cNvPr>
@@ -15048,7 +15048,7 @@
           <p:cNvPr id="4" name="">
             <a:extLst xmlns:a="http://schemas.openxmlformats.org/drawingml/2006/main">
               <a:ext uri="{FF2B5EF4-FFF2-40B4-BE49-F238E27FC236}">
-                <a16:creationId xmlns:a16="http://schemas.microsoft.com/office/drawing/2014/main" id="{19721231-963C-447A-A63D-FD21321DE14F}"/>
+                <a16:creationId xmlns:a16="http://schemas.microsoft.com/office/drawing/2014/main" id="{A78BBA6F-AA5C-41B2-95B3-422A68062403}"/>
               </a:ext>
             </a:extLst>
           </p:cNvPr>
@@ -15112,7 +15112,7 @@
           <p:cNvPr id="5" name="">
             <a:extLst xmlns:a="http://schemas.openxmlformats.org/drawingml/2006/main">
               <a:ext uri="{FF2B5EF4-FFF2-40B4-BE49-F238E27FC236}">
-                <a16:creationId xmlns:a16="http://schemas.microsoft.com/office/drawing/2014/main" id="{6C8D3DEA-2C43-4FA5-81EC-342FD3A2E6E4}"/>
+                <a16:creationId xmlns:a16="http://schemas.microsoft.com/office/drawing/2014/main" id="{85058C6A-4F82-48D6-9A12-CF4FEA20F085}"/>
               </a:ext>
             </a:extLst>
           </p:cNvPr>
@@ -15176,7 +15176,7 @@
           <p:cNvPr id="6" name="">
             <a:extLst xmlns:a="http://schemas.openxmlformats.org/drawingml/2006/main">
               <a:ext uri="{FF2B5EF4-FFF2-40B4-BE49-F238E27FC236}">
-                <a16:creationId xmlns:a16="http://schemas.microsoft.com/office/drawing/2014/main" id="{0F613904-D9C0-4631-886C-700E9B64D800}"/>
+                <a16:creationId xmlns:a16="http://schemas.microsoft.com/office/drawing/2014/main" id="{8A2B6A88-AC51-491F-8517-2E8C21EC1CA6}"/>
               </a:ext>
             </a:extLst>
           </p:cNvPr>
@@ -15230,7 +15230,7 @@
                 <a:ea typeface="Hiragino Mincho ProN"/>
                 <a:cs typeface="Hiragino Mincho ProN"/>
               </a:rPr>
-              <a:t>採用・縮小・棄却は、四つの証拠を見て決める</a:t>
+              <a:t>採用・縮小・棄却は、四つの証拠で判断する</a:t>
             </a:r>
           </a:p>
         </p:txBody>
@@ -15240,7 +15240,7 @@
           <p:cNvPr id="7" name="">
             <a:extLst xmlns:a="http://schemas.openxmlformats.org/drawingml/2006/main">
               <a:ext uri="{FF2B5EF4-FFF2-40B4-BE49-F238E27FC236}">
-                <a16:creationId xmlns:a16="http://schemas.microsoft.com/office/drawing/2014/main" id="{33B8F712-479A-4B7C-9C96-97310320E71D}"/>
+                <a16:creationId xmlns:a16="http://schemas.microsoft.com/office/drawing/2014/main" id="{4FCC8CBA-07D8-4EDF-9831-F9FD19A733D7}"/>
               </a:ext>
             </a:extLst>
           </p:cNvPr>
@@ -15273,7 +15273,7 @@
           <p:cNvPr id="8" name="">
             <a:extLst xmlns:a="http://schemas.openxmlformats.org/drawingml/2006/main">
               <a:ext uri="{FF2B5EF4-FFF2-40B4-BE49-F238E27FC236}">
-                <a16:creationId xmlns:a16="http://schemas.microsoft.com/office/drawing/2014/main" id="{71139D5C-4236-4D25-A593-3F015CFF1355}"/>
+                <a16:creationId xmlns:a16="http://schemas.microsoft.com/office/drawing/2014/main" id="{8DE072ED-16B5-42EB-9525-30A876943975}"/>
               </a:ext>
             </a:extLst>
           </p:cNvPr>
@@ -15308,7 +15308,7 @@
           <p:cNvPr id="9" name="">
             <a:extLst xmlns:a="http://schemas.openxmlformats.org/drawingml/2006/main">
               <a:ext uri="{FF2B5EF4-FFF2-40B4-BE49-F238E27FC236}">
-                <a16:creationId xmlns:a16="http://schemas.microsoft.com/office/drawing/2014/main" id="{0834A9DE-92D1-4388-9890-AB51F4E0F223}"/>
+                <a16:creationId xmlns:a16="http://schemas.microsoft.com/office/drawing/2014/main" id="{3B2FA9CD-1374-40DC-8B79-E961BDEFC8FE}"/>
               </a:ext>
             </a:extLst>
           </p:cNvPr>
@@ -15362,7 +15362,7 @@
                 <a:ea typeface="Hiragino Sans"/>
                 <a:cs typeface="Hiragino Sans"/>
               </a:rPr>
-              <a:t>主張 | 精度だけで採用せず、offline比較、MNN parity、detector-data、10秒cadenceを同じゲートで判定する。</a:t>
+              <a:t>主張 | 候補は精度だけで選ばず、offline比較、MNN score一致、detector-data、10秒間隔を同じ判定表で評価する。</a:t>
             </a:r>
           </a:p>
         </p:txBody>
@@ -15372,7 +15372,7 @@
           <p:cNvPr id="10" name="">
             <a:extLst xmlns:a="http://schemas.openxmlformats.org/drawingml/2006/main">
               <a:ext uri="{FF2B5EF4-FFF2-40B4-BE49-F238E27FC236}">
-                <a16:creationId xmlns:a16="http://schemas.microsoft.com/office/drawing/2014/main" id="{DADB1798-9C82-448F-B0B0-08910D14016E}"/>
+                <a16:creationId xmlns:a16="http://schemas.microsoft.com/office/drawing/2014/main" id="{45EDFC7D-6B14-407D-BA6C-64ACAA344571}"/>
               </a:ext>
             </a:extLst>
           </p:cNvPr>
@@ -15405,7 +15405,7 @@
           <p:cNvPr id="11" name="">
             <a:extLst xmlns:a="http://schemas.openxmlformats.org/drawingml/2006/main">
               <a:ext uri="{FF2B5EF4-FFF2-40B4-BE49-F238E27FC236}">
-                <a16:creationId xmlns:a16="http://schemas.microsoft.com/office/drawing/2014/main" id="{B85A2D8C-AC8C-4D96-93F2-7CDB33C5A01D}"/>
+                <a16:creationId xmlns:a16="http://schemas.microsoft.com/office/drawing/2014/main" id="{D22871E5-9E85-4CD0-BB31-4EDB6EBB1291}"/>
               </a:ext>
             </a:extLst>
           </p:cNvPr>
@@ -15440,7 +15440,7 @@
           <p:cNvPr id="12" name="">
             <a:extLst xmlns:a="http://schemas.openxmlformats.org/drawingml/2006/main">
               <a:ext uri="{FF2B5EF4-FFF2-40B4-BE49-F238E27FC236}">
-                <a16:creationId xmlns:a16="http://schemas.microsoft.com/office/drawing/2014/main" id="{B4000EC9-EA1A-4534-A3C5-84FC408892DB}"/>
+                <a16:creationId xmlns:a16="http://schemas.microsoft.com/office/drawing/2014/main" id="{2DAC4809-64F2-43DE-8327-8DBD0DDA6893}"/>
               </a:ext>
             </a:extLst>
           </p:cNvPr>
@@ -15494,7 +15494,7 @@
                 <a:ea typeface="Hiragino Sans"/>
                 <a:cs typeface="Hiragino Sans"/>
               </a:rPr>
-              <a:t>すぐ導入できる、とは言わない</a:t>
+              <a:t>まだ採用とは言わない</a:t>
             </a:r>
           </a:p>
         </p:txBody>
@@ -15504,7 +15504,7 @@
           <p:cNvPr id="13" name="">
             <a:extLst xmlns:a="http://schemas.openxmlformats.org/drawingml/2006/main">
               <a:ext uri="{FF2B5EF4-FFF2-40B4-BE49-F238E27FC236}">
-                <a16:creationId xmlns:a16="http://schemas.microsoft.com/office/drawing/2014/main" id="{52C41200-A63F-40CD-AC25-6423AA9E537C}"/>
+                <a16:creationId xmlns:a16="http://schemas.microsoft.com/office/drawing/2014/main" id="{3B061245-9D53-4E37-897F-49E0F71CB5A8}"/>
               </a:ext>
             </a:extLst>
           </p:cNvPr>
@@ -15537,7 +15537,7 @@
           <p:cNvPr id="14" name="">
             <a:extLst xmlns:a="http://schemas.openxmlformats.org/drawingml/2006/main">
               <a:ext uri="{FF2B5EF4-FFF2-40B4-BE49-F238E27FC236}">
-                <a16:creationId xmlns:a16="http://schemas.microsoft.com/office/drawing/2014/main" id="{39407177-0D32-49B5-AC91-54EC55C75726}"/>
+                <a16:creationId xmlns:a16="http://schemas.microsoft.com/office/drawing/2014/main" id="{F2525CB6-5625-444B-B185-6441094D8986}"/>
               </a:ext>
             </a:extLst>
           </p:cNvPr>
@@ -15572,7 +15572,7 @@
           <p:cNvPr id="15" name="">
             <a:extLst xmlns:a="http://schemas.openxmlformats.org/drawingml/2006/main">
               <a:ext uri="{FF2B5EF4-FFF2-40B4-BE49-F238E27FC236}">
-                <a16:creationId xmlns:a16="http://schemas.microsoft.com/office/drawing/2014/main" id="{8A1304A0-65B3-483D-BF57-DCE5D4E17A43}"/>
+                <a16:creationId xmlns:a16="http://schemas.microsoft.com/office/drawing/2014/main" id="{F234592B-DE3B-4D7A-A1E6-7D0C0D83A32B}"/>
               </a:ext>
             </a:extLst>
           </p:cNvPr>
@@ -15636,7 +15636,7 @@
           <p:cNvPr id="16" name="">
             <a:extLst xmlns:a="http://schemas.openxmlformats.org/drawingml/2006/main">
               <a:ext uri="{FF2B5EF4-FFF2-40B4-BE49-F238E27FC236}">
-                <a16:creationId xmlns:a16="http://schemas.microsoft.com/office/drawing/2014/main" id="{6B3F27DA-8CF0-4B36-B81F-8C33C5EA3DD9}"/>
+                <a16:creationId xmlns:a16="http://schemas.microsoft.com/office/drawing/2014/main" id="{1B6503C0-F8DD-4DDD-B9E0-E78446322976}"/>
               </a:ext>
             </a:extLst>
           </p:cNvPr>
@@ -15690,7 +15690,7 @@
                 <a:ea typeface="Hiragino Sans"/>
                 <a:cs typeface="Hiragino Sans"/>
               </a:rPr>
-              <a:t>benign-only学習、単純規則、AE-01..05、低誤警報で比較</a:t>
+              <a:t>benign-only学習、単純規則、AE-01..05を誤警報を抑えた条件で比較</a:t>
             </a:r>
           </a:p>
         </p:txBody>
@@ -15700,7 +15700,7 @@
           <p:cNvPr id="17" name="">
             <a:extLst xmlns:a="http://schemas.openxmlformats.org/drawingml/2006/main">
               <a:ext uri="{FF2B5EF4-FFF2-40B4-BE49-F238E27FC236}">
-                <a16:creationId xmlns:a16="http://schemas.microsoft.com/office/drawing/2014/main" id="{B7B5D510-D9BB-476A-9DED-0FA2A948018A}"/>
+                <a16:creationId xmlns:a16="http://schemas.microsoft.com/office/drawing/2014/main" id="{71360471-6EE0-494C-9A2E-D0F1946B52DE}"/>
               </a:ext>
             </a:extLst>
           </p:cNvPr>
@@ -15735,7 +15735,7 @@
           <p:cNvPr id="18" name="">
             <a:extLst xmlns:a="http://schemas.openxmlformats.org/drawingml/2006/main">
               <a:ext uri="{FF2B5EF4-FFF2-40B4-BE49-F238E27FC236}">
-                <a16:creationId xmlns:a16="http://schemas.microsoft.com/office/drawing/2014/main" id="{1ED6AEA1-031A-403B-ADE0-ABF9F41C1311}"/>
+                <a16:creationId xmlns:a16="http://schemas.microsoft.com/office/drawing/2014/main" id="{53903BE1-CEE8-440E-AC4A-ABDC406B59BA}"/>
               </a:ext>
             </a:extLst>
           </p:cNvPr>
@@ -15799,7 +15799,7 @@
           <p:cNvPr id="19" name="">
             <a:extLst xmlns:a="http://schemas.openxmlformats.org/drawingml/2006/main">
               <a:ext uri="{FF2B5EF4-FFF2-40B4-BE49-F238E27FC236}">
-                <a16:creationId xmlns:a16="http://schemas.microsoft.com/office/drawing/2014/main" id="{CEBA65B9-5A7A-41CD-ACAD-D41CC80B8A34}"/>
+                <a16:creationId xmlns:a16="http://schemas.microsoft.com/office/drawing/2014/main" id="{86E3B4E9-99C2-45CC-A204-B01332065D4C}"/>
               </a:ext>
             </a:extLst>
           </p:cNvPr>
@@ -15832,7 +15832,7 @@
           <p:cNvPr id="20" name="">
             <a:extLst xmlns:a="http://schemas.openxmlformats.org/drawingml/2006/main">
               <a:ext uri="{FF2B5EF4-FFF2-40B4-BE49-F238E27FC236}">
-                <a16:creationId xmlns:a16="http://schemas.microsoft.com/office/drawing/2014/main" id="{D61EA545-FF90-4C03-9D60-D32758147804}"/>
+                <a16:creationId xmlns:a16="http://schemas.microsoft.com/office/drawing/2014/main" id="{A5D142F7-7F34-4265-BCCB-F1EE39BF9808}"/>
               </a:ext>
             </a:extLst>
           </p:cNvPr>
@@ -15867,7 +15867,7 @@
           <p:cNvPr id="21" name="">
             <a:extLst xmlns:a="http://schemas.openxmlformats.org/drawingml/2006/main">
               <a:ext uri="{FF2B5EF4-FFF2-40B4-BE49-F238E27FC236}">
-                <a16:creationId xmlns:a16="http://schemas.microsoft.com/office/drawing/2014/main" id="{51C36C09-86CB-4897-A1A4-CE78DFF0B266}"/>
+                <a16:creationId xmlns:a16="http://schemas.microsoft.com/office/drawing/2014/main" id="{111BDA2E-91F4-4601-B70D-51E33CDDE923}"/>
               </a:ext>
             </a:extLst>
           </p:cNvPr>
@@ -15921,7 +15921,7 @@
                 <a:ea typeface="Hiragino Sans"/>
                 <a:cs typeface="Hiragino Sans"/>
               </a:rPr>
-              <a:t>2. score parity</a:t>
+              <a:t>2. score一致</a:t>
             </a:r>
           </a:p>
         </p:txBody>
@@ -15931,7 +15931,7 @@
           <p:cNvPr id="22" name="">
             <a:extLst xmlns:a="http://schemas.openxmlformats.org/drawingml/2006/main">
               <a:ext uri="{FF2B5EF4-FFF2-40B4-BE49-F238E27FC236}">
-                <a16:creationId xmlns:a16="http://schemas.microsoft.com/office/drawing/2014/main" id="{DA5E7BA7-064E-4F4C-A8DF-E359DABEF936}"/>
+                <a16:creationId xmlns:a16="http://schemas.microsoft.com/office/drawing/2014/main" id="{717FA388-BFFA-4D82-B42D-64695DBEFB4B}"/>
               </a:ext>
             </a:extLst>
           </p:cNvPr>
@@ -15995,7 +15995,7 @@
           <p:cNvPr id="23" name="">
             <a:extLst xmlns:a="http://schemas.openxmlformats.org/drawingml/2006/main">
               <a:ext uri="{FF2B5EF4-FFF2-40B4-BE49-F238E27FC236}">
-                <a16:creationId xmlns:a16="http://schemas.microsoft.com/office/drawing/2014/main" id="{C54AEED5-5730-4606-9288-FC8F4ED53852}"/>
+                <a16:creationId xmlns:a16="http://schemas.microsoft.com/office/drawing/2014/main" id="{4D06DDC6-0FC0-48D5-B965-19EB071A6EB5}"/>
               </a:ext>
             </a:extLst>
           </p:cNvPr>
@@ -16030,7 +16030,7 @@
           <p:cNvPr id="24" name="">
             <a:extLst xmlns:a="http://schemas.openxmlformats.org/drawingml/2006/main">
               <a:ext uri="{FF2B5EF4-FFF2-40B4-BE49-F238E27FC236}">
-                <a16:creationId xmlns:a16="http://schemas.microsoft.com/office/drawing/2014/main" id="{DB599117-1D37-4198-9749-A2CF6337030F}"/>
+                <a16:creationId xmlns:a16="http://schemas.microsoft.com/office/drawing/2014/main" id="{A1C8F5FA-B801-474C-AE9E-D6361A5F6313}"/>
               </a:ext>
             </a:extLst>
           </p:cNvPr>
@@ -16094,7 +16094,7 @@
           <p:cNvPr id="25" name="">
             <a:extLst xmlns:a="http://schemas.openxmlformats.org/drawingml/2006/main">
               <a:ext uri="{FF2B5EF4-FFF2-40B4-BE49-F238E27FC236}">
-                <a16:creationId xmlns:a16="http://schemas.microsoft.com/office/drawing/2014/main" id="{FB3F0E0D-72F8-43C0-9976-349E7B6CA4F2}"/>
+                <a16:creationId xmlns:a16="http://schemas.microsoft.com/office/drawing/2014/main" id="{1D4D117F-3748-4804-952A-C7E0A1897BD9}"/>
               </a:ext>
             </a:extLst>
           </p:cNvPr>
@@ -16127,7 +16127,7 @@
           <p:cNvPr id="26" name="">
             <a:extLst xmlns:a="http://schemas.openxmlformats.org/drawingml/2006/main">
               <a:ext uri="{FF2B5EF4-FFF2-40B4-BE49-F238E27FC236}">
-                <a16:creationId xmlns:a16="http://schemas.microsoft.com/office/drawing/2014/main" id="{A5E9EFF7-B806-4935-BCB5-E0C953A8ED5A}"/>
+                <a16:creationId xmlns:a16="http://schemas.microsoft.com/office/drawing/2014/main" id="{7D26E4AE-5B7A-4481-95E4-815064642151}"/>
               </a:ext>
             </a:extLst>
           </p:cNvPr>
@@ -16162,7 +16162,7 @@
           <p:cNvPr id="27" name="">
             <a:extLst xmlns:a="http://schemas.openxmlformats.org/drawingml/2006/main">
               <a:ext uri="{FF2B5EF4-FFF2-40B4-BE49-F238E27FC236}">
-                <a16:creationId xmlns:a16="http://schemas.microsoft.com/office/drawing/2014/main" id="{0D3753B0-A4BF-4350-A483-50DA947699B7}"/>
+                <a16:creationId xmlns:a16="http://schemas.microsoft.com/office/drawing/2014/main" id="{CB5D6871-BC71-46AC-915B-CAA4F5D0B843}"/>
               </a:ext>
             </a:extLst>
           </p:cNvPr>
@@ -16226,7 +16226,7 @@
           <p:cNvPr id="28" name="">
             <a:extLst xmlns:a="http://schemas.openxmlformats.org/drawingml/2006/main">
               <a:ext uri="{FF2B5EF4-FFF2-40B4-BE49-F238E27FC236}">
-                <a16:creationId xmlns:a16="http://schemas.microsoft.com/office/drawing/2014/main" id="{C2BEEF70-4637-4B67-AD8F-0AA4F4CDDB69}"/>
+                <a16:creationId xmlns:a16="http://schemas.microsoft.com/office/drawing/2014/main" id="{D7B8CC3C-1A07-4818-8700-7664E20370FE}"/>
               </a:ext>
             </a:extLst>
           </p:cNvPr>
@@ -16290,7 +16290,7 @@
           <p:cNvPr id="29" name="">
             <a:extLst xmlns:a="http://schemas.openxmlformats.org/drawingml/2006/main">
               <a:ext uri="{FF2B5EF4-FFF2-40B4-BE49-F238E27FC236}">
-                <a16:creationId xmlns:a16="http://schemas.microsoft.com/office/drawing/2014/main" id="{57565B24-875E-4F23-AD54-4573DF9D19A9}"/>
+                <a16:creationId xmlns:a16="http://schemas.microsoft.com/office/drawing/2014/main" id="{E3C296E1-EFED-4274-8EE7-5FA13B647FF0}"/>
               </a:ext>
             </a:extLst>
           </p:cNvPr>
@@ -16325,7 +16325,7 @@
           <p:cNvPr id="30" name="">
             <a:extLst xmlns:a="http://schemas.openxmlformats.org/drawingml/2006/main">
               <a:ext uri="{FF2B5EF4-FFF2-40B4-BE49-F238E27FC236}">
-                <a16:creationId xmlns:a16="http://schemas.microsoft.com/office/drawing/2014/main" id="{5355D17A-8858-417F-8384-D42AD02C527F}"/>
+                <a16:creationId xmlns:a16="http://schemas.microsoft.com/office/drawing/2014/main" id="{074F720F-2D21-4AEB-A5D1-89A286A01FB8}"/>
               </a:ext>
             </a:extLst>
           </p:cNvPr>
@@ -16389,7 +16389,7 @@
           <p:cNvPr id="31" name="">
             <a:extLst xmlns:a="http://schemas.openxmlformats.org/drawingml/2006/main">
               <a:ext uri="{FF2B5EF4-FFF2-40B4-BE49-F238E27FC236}">
-                <a16:creationId xmlns:a16="http://schemas.microsoft.com/office/drawing/2014/main" id="{3B5321A8-1BFA-45CA-A286-F65D93E8FD71}"/>
+                <a16:creationId xmlns:a16="http://schemas.microsoft.com/office/drawing/2014/main" id="{37652868-0219-4363-87CB-A028FF6C4749}"/>
               </a:ext>
             </a:extLst>
           </p:cNvPr>
@@ -16422,7 +16422,7 @@
           <p:cNvPr id="32" name="">
             <a:extLst xmlns:a="http://schemas.openxmlformats.org/drawingml/2006/main">
               <a:ext uri="{FF2B5EF4-FFF2-40B4-BE49-F238E27FC236}">
-                <a16:creationId xmlns:a16="http://schemas.microsoft.com/office/drawing/2014/main" id="{89B47CC9-98C7-4A9D-8388-655FCE83E155}"/>
+                <a16:creationId xmlns:a16="http://schemas.microsoft.com/office/drawing/2014/main" id="{6B8C348A-4D55-474C-BAC4-0DD98D806EBB}"/>
               </a:ext>
             </a:extLst>
           </p:cNvPr>
@@ -16457,7 +16457,7 @@
           <p:cNvPr id="33" name="">
             <a:extLst xmlns:a="http://schemas.openxmlformats.org/drawingml/2006/main">
               <a:ext uri="{FF2B5EF4-FFF2-40B4-BE49-F238E27FC236}">
-                <a16:creationId xmlns:a16="http://schemas.microsoft.com/office/drawing/2014/main" id="{0B2DEF86-E6E6-4A2E-91E3-FA0B987F3136}"/>
+                <a16:creationId xmlns:a16="http://schemas.microsoft.com/office/drawing/2014/main" id="{E0F634AE-FF60-4B66-A541-A4C729A4F328}"/>
               </a:ext>
             </a:extLst>
           </p:cNvPr>
@@ -16521,7 +16521,7 @@
           <p:cNvPr id="34" name="">
             <a:extLst xmlns:a="http://schemas.openxmlformats.org/drawingml/2006/main">
               <a:ext uri="{FF2B5EF4-FFF2-40B4-BE49-F238E27FC236}">
-                <a16:creationId xmlns:a16="http://schemas.microsoft.com/office/drawing/2014/main" id="{D6C52683-6214-4F02-B56D-18BE4A5A1C0B}"/>
+                <a16:creationId xmlns:a16="http://schemas.microsoft.com/office/drawing/2014/main" id="{32D7AD06-D885-45F9-9787-314758DD5195}"/>
               </a:ext>
             </a:extLst>
           </p:cNvPr>
@@ -16575,7 +16575,7 @@
                 <a:ea typeface="Hiragino Sans"/>
                 <a:cs typeface="Hiragino Sans"/>
               </a:rPr>
-              <a:t>V volumeとQ inference slotで10秒cadenceを守れるか測る</a:t>
+              <a:t>VボリュームとQ推論slotで10秒間隔を守れるか測る</a:t>
             </a:r>
           </a:p>
         </p:txBody>
@@ -16585,7 +16585,7 @@
           <p:cNvPr id="35" name="">
             <a:extLst xmlns:a="http://schemas.openxmlformats.org/drawingml/2006/main">
               <a:ext uri="{FF2B5EF4-FFF2-40B4-BE49-F238E27FC236}">
-                <a16:creationId xmlns:a16="http://schemas.microsoft.com/office/drawing/2014/main" id="{923166DE-CE09-4B73-A0F4-BB0875203948}"/>
+                <a16:creationId xmlns:a16="http://schemas.microsoft.com/office/drawing/2014/main" id="{3403F213-F8DE-47B0-B418-AB23E47E9B15}"/>
               </a:ext>
             </a:extLst>
           </p:cNvPr>
@@ -16618,7 +16618,7 @@
           <p:cNvPr id="36" name="">
             <a:extLst xmlns:a="http://schemas.openxmlformats.org/drawingml/2006/main">
               <a:ext uri="{FF2B5EF4-FFF2-40B4-BE49-F238E27FC236}">
-                <a16:creationId xmlns:a16="http://schemas.microsoft.com/office/drawing/2014/main" id="{F9EC9212-A8E1-4B12-8594-810E8B94DD41}"/>
+                <a16:creationId xmlns:a16="http://schemas.microsoft.com/office/drawing/2014/main" id="{C7E7369F-2247-4BE1-8F88-F5222E6EDAC1}"/>
               </a:ext>
             </a:extLst>
           </p:cNvPr>
@@ -16653,7 +16653,7 @@
           <p:cNvPr id="37" name="">
             <a:extLst xmlns:a="http://schemas.openxmlformats.org/drawingml/2006/main">
               <a:ext uri="{FF2B5EF4-FFF2-40B4-BE49-F238E27FC236}">
-                <a16:creationId xmlns:a16="http://schemas.microsoft.com/office/drawing/2014/main" id="{EB9B1D21-F13F-4C9F-B9B1-8B8A890C1186}"/>
+                <a16:creationId xmlns:a16="http://schemas.microsoft.com/office/drawing/2014/main" id="{6B6EDD9A-F2FF-40ED-BA25-C255D92A1FC4}"/>
               </a:ext>
             </a:extLst>
           </p:cNvPr>
@@ -16717,7 +16717,7 @@
           <p:cNvPr id="38" name="">
             <a:extLst xmlns:a="http://schemas.openxmlformats.org/drawingml/2006/main">
               <a:ext uri="{FF2B5EF4-FFF2-40B4-BE49-F238E27FC236}">
-                <a16:creationId xmlns:a16="http://schemas.microsoft.com/office/drawing/2014/main" id="{0938DA30-BFE3-49AD-B0EB-C61B02491216}"/>
+                <a16:creationId xmlns:a16="http://schemas.microsoft.com/office/drawing/2014/main" id="{54CCBF51-A91D-4CCA-A42B-764C898BFAA5}"/>
               </a:ext>
             </a:extLst>
           </p:cNvPr>
@@ -16771,7 +16771,7 @@
                 <a:ea typeface="Hiragino Sans"/>
                 <a:cs typeface="Hiragino Sans"/>
               </a:rPr>
-              <a:t>誤警報の少なさ / 警告までの時間 / 警告前の被害量 / どの特徴がズレたか</a:t>
+              <a:t>誤警報の少なさ / 警告までの時間 / 警告前の被害量 / どの特徴量が変化したか</a:t>
             </a:r>
           </a:p>
         </p:txBody>
@@ -16781,7 +16781,7 @@
           <p:cNvPr id="39" name="">
             <a:extLst xmlns:a="http://schemas.openxmlformats.org/drawingml/2006/main">
               <a:ext uri="{FF2B5EF4-FFF2-40B4-BE49-F238E27FC236}">
-                <a16:creationId xmlns:a16="http://schemas.microsoft.com/office/drawing/2014/main" id="{E46EAE50-CFBC-4E51-882D-B9F2D503964A}"/>
+                <a16:creationId xmlns:a16="http://schemas.microsoft.com/office/drawing/2014/main" id="{489ADFD3-CA4A-4E79-84BC-A1B4B0CCE20D}"/>
               </a:ext>
             </a:extLst>
           </p:cNvPr>
@@ -16814,7 +16814,7 @@
           <p:cNvPr id="40" name="">
             <a:extLst xmlns:a="http://schemas.openxmlformats.org/drawingml/2006/main">
               <a:ext uri="{FF2B5EF4-FFF2-40B4-BE49-F238E27FC236}">
-                <a16:creationId xmlns:a16="http://schemas.microsoft.com/office/drawing/2014/main" id="{61100B53-3341-4A35-9ED6-3C2D8FD9EDA7}"/>
+                <a16:creationId xmlns:a16="http://schemas.microsoft.com/office/drawing/2014/main" id="{DD52C0FF-37C8-430B-9F28-D5E1D67C0592}"/>
               </a:ext>
             </a:extLst>
           </p:cNvPr>
@@ -16849,7 +16849,7 @@
           <p:cNvPr id="41" name="">
             <a:extLst xmlns:a="http://schemas.openxmlformats.org/drawingml/2006/main">
               <a:ext uri="{FF2B5EF4-FFF2-40B4-BE49-F238E27FC236}">
-                <a16:creationId xmlns:a16="http://schemas.microsoft.com/office/drawing/2014/main" id="{BA4D3458-46CA-44CC-B341-683B5831161A}"/>
+                <a16:creationId xmlns:a16="http://schemas.microsoft.com/office/drawing/2014/main" id="{A88FE605-2626-4519-AE70-E379E3A25D34}"/>
               </a:ext>
             </a:extLst>
           </p:cNvPr>
@@ -16913,7 +16913,7 @@
           <p:cNvPr id="42" name="">
             <a:extLst xmlns:a="http://schemas.openxmlformats.org/drawingml/2006/main">
               <a:ext uri="{FF2B5EF4-FFF2-40B4-BE49-F238E27FC236}">
-                <a16:creationId xmlns:a16="http://schemas.microsoft.com/office/drawing/2014/main" id="{56B36CFE-AC42-4CF3-A725-91F776D189B9}"/>
+                <a16:creationId xmlns:a16="http://schemas.microsoft.com/office/drawing/2014/main" id="{6BC555CD-A1B2-4505-BE29-FC49CB4920CC}"/>
               </a:ext>
             </a:extLst>
           </p:cNvPr>
@@ -16967,7 +16967,7 @@
                 <a:ea typeface="Hiragino Sans"/>
                 <a:cs typeface="Hiragino Sans"/>
               </a:rPr>
-              <a:t>feature数Dを減らす -&gt; 系列長Nを短くする -&gt; hidden sizeを縮める -&gt; AE-05から単純候補へ戻す</a:t>
+              <a:t>特徴数Dを減らす -&gt; 系列長Nを短くする -&gt; hidden sizeを縮める -&gt; AE-05から単純候補へ戻す</a:t>
             </a:r>
           </a:p>
         </p:txBody>
@@ -16977,7 +16977,7 @@
           <p:cNvPr id="43" name="">
             <a:extLst xmlns:a="http://schemas.openxmlformats.org/drawingml/2006/main">
               <a:ext uri="{FF2B5EF4-FFF2-40B4-BE49-F238E27FC236}">
-                <a16:creationId xmlns:a16="http://schemas.microsoft.com/office/drawing/2014/main" id="{09A41A10-82C8-4C0A-B654-AE09C3A67229}"/>
+                <a16:creationId xmlns:a16="http://schemas.microsoft.com/office/drawing/2014/main" id="{F2293F52-B774-442F-A2A4-C0369C57C3A8}"/>
               </a:ext>
             </a:extLst>
           </p:cNvPr>
@@ -17010,7 +17010,7 @@
           <p:cNvPr id="44" name="">
             <a:extLst xmlns:a="http://schemas.openxmlformats.org/drawingml/2006/main">
               <a:ext uri="{FF2B5EF4-FFF2-40B4-BE49-F238E27FC236}">
-                <a16:creationId xmlns:a16="http://schemas.microsoft.com/office/drawing/2014/main" id="{48641F9A-B024-40DE-A7B4-6EB41CF97F79}"/>
+                <a16:creationId xmlns:a16="http://schemas.microsoft.com/office/drawing/2014/main" id="{4F9F6BAF-D89E-4EFF-90DE-F9B0B504005D}"/>
               </a:ext>
             </a:extLst>
           </p:cNvPr>
@@ -17064,7 +17064,7 @@
                 <a:ea typeface="Hiragino Sans"/>
                 <a:cs typeface="Hiragino Sans"/>
               </a:rPr>
-              <a:t>固定済み: block I/O観測境界、10秒統計、AE候補、device-fit gates</a:t>
+              <a:t>固定済み: block I/O観測境界、10秒統計、AE候補、device-fitゲート</a:t>
             </a:r>
           </a:p>
         </p:txBody>
@@ -17074,7 +17074,7 @@
           <p:cNvPr id="45" name="">
             <a:extLst xmlns:a="http://schemas.openxmlformats.org/drawingml/2006/main">
               <a:ext uri="{FF2B5EF4-FFF2-40B4-BE49-F238E27FC236}">
-                <a16:creationId xmlns:a16="http://schemas.microsoft.com/office/drawing/2014/main" id="{AC40A938-2441-4A17-B90B-3E43E777CDFF}"/>
+                <a16:creationId xmlns:a16="http://schemas.microsoft.com/office/drawing/2014/main" id="{4EB1B388-E276-4B77-9723-6B0D1B2AEA21}"/>
               </a:ext>
             </a:extLst>
           </p:cNvPr>
@@ -17107,7 +17107,7 @@
           <p:cNvPr id="46" name="">
             <a:extLst xmlns:a="http://schemas.openxmlformats.org/drawingml/2006/main">
               <a:ext uri="{FF2B5EF4-FFF2-40B4-BE49-F238E27FC236}">
-                <a16:creationId xmlns:a16="http://schemas.microsoft.com/office/drawing/2014/main" id="{2C5E4B4C-1396-43C6-BB3E-9E790508C627}"/>
+                <a16:creationId xmlns:a16="http://schemas.microsoft.com/office/drawing/2014/main" id="{7DE7032A-2212-4C43-8DFE-FB4C6DB00122}"/>
               </a:ext>
             </a:extLst>
           </p:cNvPr>
@@ -17161,7 +17161,7 @@
                 <a:ea typeface="Hiragino Sans"/>
                 <a:cs typeface="Hiragino Sans"/>
               </a:rPr>
-              <a:t>未主張: 検出性能、MNN readiness、500KB内に収まった結論、実運用早期警告</a:t>
+              <a:t>未主張: 検出性能、MNN readiness、500 KB内に収まった結論、実運用早期警告</a:t>
             </a:r>
           </a:p>
         </p:txBody>
@@ -17171,7 +17171,7 @@
           <p:cNvPr id="47" name="">
             <a:extLst xmlns:a="http://schemas.openxmlformats.org/drawingml/2006/main">
               <a:ext uri="{FF2B5EF4-FFF2-40B4-BE49-F238E27FC236}">
-                <a16:creationId xmlns:a16="http://schemas.microsoft.com/office/drawing/2014/main" id="{3F48DAE2-A42E-4B98-949A-55C7896AB9D4}"/>
+                <a16:creationId xmlns:a16="http://schemas.microsoft.com/office/drawing/2014/main" id="{B980CE3E-4C9D-4110-9AEE-C71392960293}"/>
               </a:ext>
             </a:extLst>
           </p:cNvPr>
@@ -17206,7 +17206,7 @@
           <p:cNvPr id="48" name="">
             <a:extLst xmlns:a="http://schemas.openxmlformats.org/drawingml/2006/main">
               <a:ext uri="{FF2B5EF4-FFF2-40B4-BE49-F238E27FC236}">
-                <a16:creationId xmlns:a16="http://schemas.microsoft.com/office/drawing/2014/main" id="{75CA69B1-839F-4177-9616-034C75C17D74}"/>
+                <a16:creationId xmlns:a16="http://schemas.microsoft.com/office/drawing/2014/main" id="{86C5571B-4C7F-4CFB-8369-BE6368ADF396}"/>
               </a:ext>
             </a:extLst>
           </p:cNvPr>
@@ -17268,7 +17268,7 @@
     </p:spTree>
     <p:extLst>
       <p:ext uri="{BB962C8B-B14F-4D97-AF65-F5344CB8AC3E}">
-        <p14:creationId xmlns:p14="http://schemas.microsoft.com/office/powerpoint/2010/main" val="1159740903"/>
+        <p14:creationId xmlns:p14="http://schemas.microsoft.com/office/powerpoint/2010/main" val="1732931801"/>
       </p:ext>
     </p:extLst>
   </p:cSld>

</xml_diff>